<commit_message>
Update presenter scripts to Manus, correct slide alignment, update print styles, and regenerate PPTX and PDF
</commit_message>
<xml_diff>
--- a/output/semiconductor-ecosystem-2026.pptx
+++ b/output/semiconductor-ecosystem-2026.pptx
@@ -518,8 +518,7 @@
           <a:p>
             <a:r>
               <a:rPr lang="en-US" dirty="0"/>
-              <a:t>Good morning everyone, and welcome to this strategic briefing. Today, we are reviewing 'The 2026 Semiconductor Ecosystem' with a focus on procurement, global supply chains, and end-user verticals.
-In 2026, semiconductor procurement has transitioned from a back-office utility into a core strategic capability for technological growth, commercial innovation, and national security. Over this session, we will analyze how organizations can navigate this crucial field to manage risk and secure supply.</a:t>
+              <a:t>Hello everyone. I’m Manus, and today we are conducting a deep-dive into the 'nerve system' of our modern civilization: the 2026 Semiconductor Ecosystem. Over the next 20 minutes, we are going to move beyond the headlines of 'chip shortages' and look at the actual structural mechanics of how silicon is procured, how it moves across the globe, and finally, how it is fundamentally rewriting the DNA of every major industry. Whether you are an investor, a procurement lead, or a strategic planner, this briefing is designed to give you the high-ground view of the $1.3 trillion silicon economy.</a:t>
             </a:r>
             <a:endParaRPr lang="en-US" dirty="0"/>
           </a:p>
@@ -607,7 +606,7 @@
           <a:p>
             <a:r>
               <a:rPr lang="en-US" dirty="0"/>
-              <a:t>To build resilience, leading firms are mapping their supply networks down to Tier-4 and Tier-5 suppliers. Additionally, we are seeing the rise of circular supply chains, where firms recover rare earth metals and copper from e-waste to insulate themselves from mining volatility and supply disruptions.</a:t>
+              <a:t>The response? Circular and Autonomous Supply Chains. We are using AI to 'self-heal' the supply chain—automatically re-routing orders when a port closes or a factory goes down. And we are starting to recycle. We are mining the 'urban mine'—recovering rare earth elements from old electronics to reduce our dependency on volatile mining regions.</a:t>
             </a:r>
             <a:endParaRPr lang="en-US" dirty="0"/>
           </a:p>
@@ -695,7 +694,7 @@
           <a:p>
             <a:r>
               <a:rPr lang="en-US" dirty="0"/>
-              <a:t>We now transition to Part 3: End-User Industries. Semiconductors have become the central nervous system of the global economy. 'Silicon Intensity'—the value of semiconductor content per product unit—is now the primary metric of industrial competitiveness. No modern industry can run or innovate without silicon.</a:t>
+              <a:t>So, where does all this silicon end up? Everywhere. We have reached 'Total Silicon Dependency.' Every industry is now a 'tech industry' because every industry is built on chips.</a:t>
             </a:r>
             <a:endParaRPr lang="en-US" dirty="0"/>
           </a:p>
@@ -783,7 +782,7 @@
           <a:p>
             <a:r>
               <a:rPr lang="en-US" dirty="0"/>
-              <a:t>The demand landscape in 2026 shows a major structural shift. AI infrastructure, automotive electronics, and factory robotics are capturing the majority of growth. While traditional smartphone and PC markets face saturation, specialized automotive and AI accelerator segments are driving industry revenues to new heights.</a:t>
+              <a:t>The demand landscape is shifting. While PCs and smartphones are maturing, AI Infrastructure and Automotive are exploding. AI and Data Centers now drive nearly half of the industry’s total value. We are in a 'multi-speed' market where the high-end is racing ahead while the low-end stabilizes.</a:t>
             </a:r>
             <a:endParaRPr lang="en-US" dirty="0"/>
           </a:p>
@@ -871,7 +870,7 @@
           <a:p>
             <a:r>
               <a:rPr lang="en-US" dirty="0"/>
-              <a:t>AI accelerators have turned data centers into massive intelligence engines, with the market approaching $500 billion. This segment is the primary consumer of leading-edge 3nm and 2nm foundry nodes, consuming massive volumes of High Bandwidth Memory and advanced networking silicon.</a:t>
+              <a:t>Look at the Data Center. It’s no longer just a place to store files; it’s an 'Intelligence Engine.' We are spending $500 billion a year on AI accelerators. This is the segment that is pushing us to 2nm and beyond. It is the 'Value King' of the semiconductor world.</a:t>
             </a:r>
             <a:endParaRPr lang="en-US" dirty="0"/>
           </a:p>
@@ -959,7 +958,7 @@
           <a:p>
             <a:r>
               <a:rPr lang="en-US" dirty="0"/>
-              <a:t>Electric Vehicles and Advanced Driver Assistance Systems (ADAS) are doubling the semiconductor value per vehicle, now exceeding $1,000 per unit. EVs depend heavily on Silicon Carbide (SiC) power electronics for battery efficiency, while autonomous drive systems require massive local compute power and LiDAR arrays.</a:t>
+              <a:t>Then there is the car—the 'Smartphone on Wheels.' An EV in 2026 has over $1,000 worth of chips in it. We are talking about Silicon Carbide for power efficiency and massive SoCs for autonomous driving. The car has become a high-performance computer that just happens to have wheels.</a:t>
             </a:r>
             <a:endParaRPr lang="en-US" dirty="0"/>
           </a:p>
@@ -1047,7 +1046,7 @@
           <a:p>
             <a:r>
               <a:rPr lang="en-US" dirty="0"/>
-              <a:t>Edge AI is transforming industrial automation and healthcare. Industry 4.0 uses real-time edge analytics for predictive maintenance. In healthcare, semiconductors enable smart implants, wearable biosensors, and personalized diagnostics, demanding highly rugged, long-lifecycle silicon.</a:t>
+              <a:t>In the Industrial and Healthcare sectors, we are seeing the rise of 'Edge AI.' We aren't sending data to the cloud anymore; we are processing it right there on the factory floor or inside a medical implant. This requires ultra-reliable, long-lifecycle silicon that can survive for fifteen years in harsh environments.</a:t>
             </a:r>
             <a:endParaRPr lang="en-US" dirty="0"/>
           </a:p>
@@ -1135,7 +1134,7 @@
           <a:p>
             <a:r>
               <a:rPr lang="en-US" dirty="0"/>
-              <a:t>While traditional consumer volumes mature, manufacturers are integrating Neural Processing Units (NPUs) into laptops and phones to enable on-device AI. Looking forward, emerging frontiers like quantum computing, 6G telecom, and brain-inspired neuromorphic chips are defining the roadmap toward 2030.</a:t>
+              <a:t>And looking at the horizon—Quantum, 6G, and Neuromorphic computing. These aren't science fiction anymore. We are already building the 2030 roadmap. We are designing chips that work like the human brain and networks that make 5G look like dial-up. The innovation cycle is actually accelerating.</a:t>
             </a:r>
             <a:endParaRPr lang="en-US" dirty="0"/>
           </a:p>
@@ -1223,7 +1222,9 @@
           <a:p>
             <a:r>
               <a:rPr lang="en-US" dirty="0"/>
-              <a:t>In conclusion, we have reached a state of total silicon dependency. The path to a $2 global industry by the early 2030s is clear. The 'Chip Wars' are not just about manufacturing footprint; they are about who can best harness silicon to transform their businesses. Let's summarize the key takeaways: Procurement must shift to a hybrid model; packaging is the new supply chokepoint; and AI and Automotive remain the primary engines of value and volume. Thank you, and I am open to any questions.</a:t>
+              <a:t>To conclude, the 2026 ecosystem tells us one thing: Silicon Intensity is the new gold standard. The winners of the next decade won't just be the ones with the best software; they will be the ones who master the procurement, the supply chain, and the application of these chips.
+Before we go, look at this infographic. These are the five materials that keep the lights on. From Gallium in your 5G phone to Neon in the lasers that print the chips, these are the true foundations. Most of these are concentrated in a few regions, which is why the 'Silicon Journey' is as much about geology as it is about geometry.
+The 'Chip Wars' are far from over. In fact, they are just beginning. Mastery of this ecosystem is mastery of the future. Thank you for your time.</a:t>
             </a:r>
             <a:endParaRPr lang="en-US" dirty="0"/>
           </a:p>
@@ -1311,7 +1312,7 @@
           <a:p>
             <a:r>
               <a:rPr lang="en-US" dirty="0"/>
-              <a:t>Let's begin with our executive summary on the procurement paradox. The semiconductor industry has reached a massive $1.3 trillion market valuation. However, this record-breaking growth is accompanied by systemic fragility. Sourcing critical logic nodes and High Bandwidth Memory (HBM) remains highly constrained. To thrive, procurement executives must pivot from traditional transactional buying to deep, long-term strategic relationship management.</a:t>
+              <a:t>We start with the 'Procurement Paradox.' In 2026, we are seeing record-breaking revenue, yet the supply chain has never felt more fragile. Why? Because the 'Just-in-Time' model we spent thirty years perfecting was built for a world of stability—not the world of 'Chip Wars' and AI super-cycles we live in today.</a:t>
             </a:r>
             <a:endParaRPr lang="en-US" dirty="0"/>
           </a:p>
@@ -1399,7 +1400,7 @@
           <a:p>
             <a:r>
               <a:rPr lang="en-US" dirty="0"/>
-              <a:t>The traditional 'Just-in-Time' inventory model is obsolete for critical semiconductor components. In 2026, the new standard is a hybrid inventory model. Organizations are maintaining 3 to 6 months of buffer stock for high-value, sole-sourced components, while keeping lean, JIT structures for commoditized parts. This balances operational resilience with capital efficiency.</a:t>
+              <a:t>To survive, elite firms have pivoted to a Strategic Hybrid Model. We aren't just stockpiling everything—that’s expensive and inefficient. Instead, we are using 'Just-in-Case' logic for the high-value nodes: the 3nm processors and the High Bandwidth Memory that power AI. For everything else, we keep it lean. It’s about being surgical with your inventory.</a:t>
             </a:r>
             <a:endParaRPr lang="en-US" dirty="0"/>
           </a:p>
@@ -1487,7 +1488,7 @@
           <a:p>
             <a:r>
               <a:rPr lang="en-US" dirty="0"/>
-              <a:t>Category management is the key tool to combat supply chain opacity. We segment the procurement landscape into Leading-edge nodes (sub-7nm) and Legacy nodes (28nm and above). Sourcing leading-edge chips requires deep, multi-year R&amp;D partnerships, while legacy sourcing focuses on active multi-sourcing, life-cycle tracking, and securing long-term supply guarantees.</a:t>
+              <a:t>But you can't be surgical if you're blind. The biggest challenge in 2026 is Data Opacity. Most firms don't know who their Tier-3 or Tier-4 suppliers are. We are solving this through Category Management—segmenting our sourcing by technology node. We treat a 28nm legacy microcontroller for a car window very differently than a 2nm AI accelerator for a data center.</a:t>
             </a:r>
             <a:endParaRPr lang="en-US" dirty="0"/>
           </a:p>
@@ -1575,7 +1576,7 @@
           <a:p>
             <a:r>
               <a:rPr lang="en-US" dirty="0"/>
-              <a:t>Resilience in 2026 is data-driven. Leading procurement teams utilize AI-enabled 'Business Intelligence Cockpits' to map supplier networks and forecast shortages 6 to 12 months ahead. Furthermore, securing capacity requires proactive commercial structures, including capacity reservation fees and take-or-pay long-term agreements (LTAs).</a:t>
+              <a:t>Finally, look at the digitalization of the 'Buy' side. We are now using Business Intelligence Cockpits that use AI to scan geopolitical signals and weather patterns to predict shortages six months out. We are also seeing a rise in 'Friend-Shoring' and Long-Term Agreements. In 2026, a handshake isn't enough; you need 'take-or-pay' contracts and reservation fees to ensure you aren't left behind in the next allocation cycle.</a:t>
             </a:r>
             <a:endParaRPr lang="en-US" dirty="0"/>
           </a:p>
@@ -1663,7 +1664,7 @@
           <a:p>
             <a:r>
               <a:rPr lang="en-US" dirty="0"/>
-              <a:t>Now we begin Part 2: The Global Supply Chain. A single microchip can cross international borders over 70 times before completion, making it the most complex value chain in industrial history. This 'Silicon Journey' connects chip designers in the US, equipment manufacturers in Europe, silicon fabricators in East Asia, and packaging facilities in Southeast Asia. This creates unmatched efficiency but extreme vulnerability to regional disruptions.</a:t>
+              <a:t>Now, let's look at the 'Silicon Journey.' A single chip might cross 70 borders before it ever reaches a consumer. This is the most complex logistical web ever built. It’s a masterpiece of efficiency, but it’s also a 'Chokepoint Architecture.'</a:t>
             </a:r>
             <a:endParaRPr lang="en-US" dirty="0"/>
           </a:p>
@@ -1751,7 +1752,7 @@
           <a:p>
             <a:r>
               <a:rPr lang="en-US" dirty="0"/>
-              <a:t>The Global Value Chain is characterized by extreme cluster concentration. The US controls research, design IP, and EDA software; Europe dominates specialized tooling, led by ASML's monopoly on EUV lithography scanners; and East Asia (specifically TSMC and Samsung) commands wafer fabrication. This high specialization means any single failure point halts the entire global system.</a:t>
+              <a:t>The value is incredibly concentrated. The U.S. owns the design; the Netherlands owns the lithography equipment; and East Asia—specifically Taiwan and South Korea—owns the fabrication. TSMC isn't just a company; it is a systemic pillar of the global economy. If that pillar shakes, the whole world feels it.</a:t>
             </a:r>
             <a:endParaRPr lang="en-US" dirty="0"/>
           </a:p>
@@ -1839,7 +1840,7 @@
           <a:p>
             <a:r>
               <a:rPr lang="en-US" dirty="0"/>
-              <a:t>While wafer fabrication nodes (like 3nm and the emerging 2nm node) capture public attention, the primary bottleneck in 2026 is back-end advanced packaging. Heterogeneous packaging techniques like Chip-on-Wafer-on-Substrate (CoWoS) and 3D stacking are highly constrained, making packaging the primary growth limiter for high-performance AI chips.</a:t>
+              <a:t>The new bottleneck in 2026 isn't just the fab; it's the 'Back-End.' We’ve reached the limits of traditional chip design, so we are now 'stacking' chips using advanced packaging like CoWoS. This is where the AI war is being fought. If you can't get capacity in an advanced packaging facility, it doesn't matter how many wafers you can print.</a:t>
             </a:r>
             <a:endParaRPr lang="en-US" dirty="0"/>
           </a:p>
@@ -1927,7 +1928,7 @@
           <a:p>
             <a:r>
               <a:rPr lang="en-US" dirty="0"/>
-              <a:t>Geopolitics has fragmented the silicon landscape into a multi-polar world. Government initiatives—such as the US CHIPS Act ($52B) and massive state funding in Europe and China—have triggered a reshoring race. Crucially, raw material chokepoints like Gallium and Germanium are now active levers of trade and foreign policy.</a:t>
+              <a:t>And we cannot ignore the 'Chip Wars.' Geopolitics is now a primary architect of the supply chain. Between the U.S. CHIPS Act and China’s massive 'In-Sourcing' push, we are moving toward a multi-polar silicon world. Critical materials like Gallium and Germanium are now being used as strategic levers in a global game of chess.</a:t>
             </a:r>
             <a:endParaRPr lang="en-US" dirty="0"/>
           </a:p>
@@ -2431,7 +2432,7 @@
                 <a:ea typeface="Helvetica" pitchFamily="34" charset="-122"/>
                 <a:cs typeface="Helvetica" pitchFamily="34" charset="-120"/>
               </a:rPr>
-              <a:t>Presenter: Phyoe Sat Paing</a:t>
+              <a:t>Presenter: Manus</a:t>
             </a:r>
             <a:endParaRPr lang="en-US" sz="1400" dirty="0"/>
           </a:p>
@@ -2661,7 +2662,7 @@
                 <a:ea typeface="Helvetica" pitchFamily="34" charset="-122"/>
                 <a:cs typeface="Helvetica" pitchFamily="34" charset="-120"/>
               </a:rPr>
-              <a:t>Key Message: The future of the supply chain is "Circular and Autonomous," using AI to self-heal and recycling to secure raw materials.</a:t>
+              <a:t>Key Message: The response? Circular and Autonomous Supply Chains. We are using AI to 'self-heal' the supply chain.</a:t>
             </a:r>
             <a:endParaRPr lang="en-US" sz="1800" dirty="0"/>
           </a:p>
@@ -2725,7 +2726,7 @@
                 <a:ea typeface="Helvetica" pitchFamily="34" charset="-122"/>
                 <a:cs typeface="Helvetica" pitchFamily="34" charset="-120"/>
               </a:rPr>
-              <a:t>Deep Supply Mapping</a:t>
+              <a:t>Deep Supply Mapping &amp; AI</a:t>
             </a:r>
             <a:endParaRPr lang="en-US" sz="2000" dirty="0"/>
           </a:p>
@@ -2764,7 +2765,7 @@
                 <a:ea typeface="Helvetica" pitchFamily="34" charset="-122"/>
                 <a:cs typeface="Helvetica" pitchFamily="34" charset="-120"/>
               </a:rPr>
-              <a:t>Leading manufacturers utilize digital mapping tools to trace supply down to Tier-4 and Tier-5 chemical suppliers.</a:t>
+              <a:t>Automatically re-routing orders when a port closes or a factory goes down. Mapping up to Tier-4 and Tier-5 suppliers.</a:t>
             </a:r>
             <a:endParaRPr lang="en-US" sz="1800" dirty="0"/>
           </a:p>
@@ -2828,7 +2829,7 @@
                 <a:ea typeface="Helvetica" pitchFamily="34" charset="-122"/>
                 <a:cs typeface="Helvetica" pitchFamily="34" charset="-120"/>
               </a:rPr>
-              <a:t>Circular Mineral Reclamation</a:t>
+              <a:t>Circular Reclamation</a:t>
             </a:r>
             <a:endParaRPr lang="en-US" sz="2000" dirty="0"/>
           </a:p>
@@ -2867,7 +2868,7 @@
                 <a:ea typeface="Helvetica" pitchFamily="34" charset="-122"/>
                 <a:cs typeface="Helvetica" pitchFamily="34" charset="-120"/>
               </a:rPr>
-              <a:t>Firms actively recycle e-waste, reclaiming trace copper, silicon, and gold substrates to buffer raw mining volatility.</a:t>
+              <a:t>Mining the 'urban mine'—recovering rare earth elements from old electronics to reduce dependency on volatile mining regions.</a:t>
             </a:r>
             <a:endParaRPr lang="en-US" sz="1800" dirty="0"/>
           </a:p>
@@ -2931,7 +2932,7 @@
                 <a:ea typeface="Helvetica" pitchFamily="34" charset="-122"/>
                 <a:cs typeface="Helvetica" pitchFamily="34" charset="-120"/>
               </a:rPr>
-              <a:t>Mapping and recycling shield operations from supply disruptions and support sustainable GVC mandates.</a:t>
+              <a:t>Autonomous logistics systems automatically scan trade flows to reroute containers before bottleneck events cause line shutdowns.</a:t>
             </a:r>
             <a:endParaRPr lang="en-US" sz="1500" dirty="0"/>
           </a:p>

</xml_diff>

<commit_message>
Overhaul presentation to warm editorial design system
</commit_message>
<xml_diff>
--- a/output/semiconductor-ecosystem-2026.pptx
+++ b/output/semiconductor-ecosystem-2026.pptx
@@ -2283,7 +2283,7 @@
     <p:bg>
       <p:bgPr>
         <a:solidFill>
-          <a:srgbClr val="0B0F19"/>
+          <a:srgbClr val="F5F0E8"/>
         </a:solidFill>
       </p:bgPr>
     </p:bg>
@@ -2328,11 +2328,11 @@
             <a:r>
               <a:rPr lang="en-US" sz="4800" b="1" dirty="0">
                 <a:solidFill>
-                  <a:srgbClr val="FFFFFF"/>
-                </a:solidFill>
-                <a:latin typeface="Helvetica" pitchFamily="34" charset="0"/>
-                <a:ea typeface="Helvetica" pitchFamily="34" charset="-122"/>
-                <a:cs typeface="Helvetica" pitchFamily="34" charset="-120"/>
+                  <a:srgbClr val="1A1714"/>
+                </a:solidFill>
+                <a:latin typeface="Georgia" pitchFamily="34" charset="0"/>
+                <a:ea typeface="Georgia" pitchFamily="34" charset="-122"/>
+                <a:cs typeface="Georgia" pitchFamily="34" charset="-120"/>
               </a:rPr>
               <a:t>The 2026 Semiconductor Ecosystem</a:t>
             </a:r>
@@ -2367,11 +2367,11 @@
             <a:r>
               <a:rPr lang="en-US" sz="2000" dirty="0">
                 <a:solidFill>
-                  <a:srgbClr val="A0AEC0"/>
-                </a:solidFill>
-                <a:latin typeface="Helvetica" pitchFamily="34" charset="0"/>
-                <a:ea typeface="Helvetica" pitchFamily="34" charset="-122"/>
-                <a:cs typeface="Helvetica" pitchFamily="34" charset="-120"/>
+                  <a:srgbClr val="6B6560"/>
+                </a:solidFill>
+                <a:latin typeface="Arial" pitchFamily="34" charset="0"/>
+                <a:ea typeface="Arial" pitchFamily="34" charset="-122"/>
+                <a:cs typeface="Arial" pitchFamily="34" charset="-120"/>
               </a:rPr>
               <a:t>A Strategic Briefing on Procurement, Global Supply Chains, and End-User Verticals</a:t>
             </a:r>
@@ -2394,7 +2394,7 @@
             <a:avLst/>
           </a:prstGeom>
           <a:solidFill>
-            <a:srgbClr val="00F2FE"/>
+            <a:srgbClr val="B84A2F"/>
           </a:solidFill>
           <a:ln/>
         </p:spPr>
@@ -2426,11 +2426,11 @@
             <a:r>
               <a:rPr lang="en-US" sz="1400" dirty="0">
                 <a:solidFill>
-                  <a:srgbClr val="A0AEC0"/>
-                </a:solidFill>
-                <a:latin typeface="Helvetica" pitchFamily="34" charset="0"/>
-                <a:ea typeface="Helvetica" pitchFamily="34" charset="-122"/>
-                <a:cs typeface="Helvetica" pitchFamily="34" charset="-120"/>
+                  <a:srgbClr val="6B6560"/>
+                </a:solidFill>
+                <a:latin typeface="Arial" pitchFamily="34" charset="0"/>
+                <a:ea typeface="Arial" pitchFamily="34" charset="-122"/>
+                <a:cs typeface="Arial" pitchFamily="34" charset="-120"/>
               </a:rPr>
               <a:t>Presenter: Manus</a:t>
             </a:r>
@@ -2443,11 +2443,11 @@
             <a:r>
               <a:rPr lang="en-US" sz="1400" dirty="0">
                 <a:solidFill>
-                  <a:srgbClr val="A0AEC0"/>
-                </a:solidFill>
-                <a:latin typeface="Helvetica" pitchFamily="34" charset="0"/>
-                <a:ea typeface="Helvetica" pitchFamily="34" charset="-122"/>
-                <a:cs typeface="Helvetica" pitchFamily="34" charset="-120"/>
+                  <a:srgbClr val="6B6560"/>
+                </a:solidFill>
+                <a:latin typeface="Arial" pitchFamily="34" charset="0"/>
+                <a:ea typeface="Arial" pitchFamily="34" charset="-122"/>
+                <a:cs typeface="Arial" pitchFamily="34" charset="-120"/>
               </a:rPr>
               <a:t>Boardroom Strategic Briefing</a:t>
             </a:r>
@@ -2469,7 +2469,7 @@
     <p:bg>
       <p:bgPr>
         <a:solidFill>
-          <a:srgbClr val="0B0F19"/>
+          <a:srgbClr val="F5F0E8"/>
         </a:solidFill>
       </p:bgPr>
     </p:bg>
@@ -2514,11 +2514,11 @@
             <a:r>
               <a:rPr lang="en-US" sz="1200" b="1" spc="150" kern="0" dirty="0">
                 <a:solidFill>
-                  <a:srgbClr val="00F2FE"/>
-                </a:solidFill>
-                <a:latin typeface="Helvetica" pitchFamily="34" charset="0"/>
-                <a:ea typeface="Helvetica" pitchFamily="34" charset="-122"/>
-                <a:cs typeface="Helvetica" pitchFamily="34" charset="-120"/>
+                  <a:srgbClr val="B84A2F"/>
+                </a:solidFill>
+                <a:latin typeface="Arial" pitchFamily="34" charset="0"/>
+                <a:ea typeface="Arial" pitchFamily="34" charset="-122"/>
+                <a:cs typeface="Arial" pitchFamily="34" charset="-120"/>
               </a:rPr>
               <a:t>PART 2: THE GLOBAL SUPPLY CHAIN OF SEMICONDUCTORS</a:t>
             </a:r>
@@ -2553,11 +2553,11 @@
             <a:r>
               <a:rPr lang="en-US" sz="3200" b="1" dirty="0">
                 <a:solidFill>
-                  <a:srgbClr val="FFFFFF"/>
-                </a:solidFill>
-                <a:latin typeface="Helvetica" pitchFamily="34" charset="0"/>
-                <a:ea typeface="Helvetica" pitchFamily="34" charset="-122"/>
-                <a:cs typeface="Helvetica" pitchFamily="34" charset="-120"/>
+                  <a:srgbClr val="1A1714"/>
+                </a:solidFill>
+                <a:latin typeface="Georgia" pitchFamily="34" charset="0"/>
+                <a:ea typeface="Georgia" pitchFamily="34" charset="-122"/>
+                <a:cs typeface="Georgia" pitchFamily="34" charset="-120"/>
               </a:rPr>
               <a:t>Supply Chain Resilience: Digital &amp; Circular</a:t>
             </a:r>
@@ -2592,11 +2592,11 @@
             <a:r>
               <a:rPr lang="en-US" sz="1000" dirty="0">
                 <a:solidFill>
-                  <a:srgbClr val="505D6F"/>
-                </a:solidFill>
-                <a:latin typeface="Helvetica" pitchFamily="34" charset="0"/>
-                <a:ea typeface="Helvetica" pitchFamily="34" charset="-122"/>
-                <a:cs typeface="Helvetica" pitchFamily="34" charset="-120"/>
+                  <a:srgbClr val="6B6560"/>
+                </a:solidFill>
+                <a:latin typeface="Arial" pitchFamily="34" charset="0"/>
+                <a:ea typeface="Arial" pitchFamily="34" charset="-122"/>
+                <a:cs typeface="Arial" pitchFamily="34" charset="-120"/>
               </a:rPr>
               <a:t>The 2026 Semiconductor Ecosystem | Slide 10</a:t>
             </a:r>
@@ -2619,11 +2619,11 @@
             <a:avLst/>
           </a:prstGeom>
           <a:solidFill>
-            <a:srgbClr val="121826"/>
+            <a:srgbClr val="FFFDF8"/>
           </a:solidFill>
           <a:ln w="19050">
             <a:solidFill>
-              <a:srgbClr val="00F2FE"/>
+              <a:srgbClr val="B84A2F"/>
             </a:solidFill>
             <a:prstDash val="solid"/>
           </a:ln>
@@ -2656,11 +2656,11 @@
             <a:r>
               <a:rPr lang="en-US" sz="1800" b="1" i="1" dirty="0">
                 <a:solidFill>
-                  <a:srgbClr val="00F2FE"/>
-                </a:solidFill>
-                <a:latin typeface="Helvetica" pitchFamily="34" charset="0"/>
-                <a:ea typeface="Helvetica" pitchFamily="34" charset="-122"/>
-                <a:cs typeface="Helvetica" pitchFamily="34" charset="-120"/>
+                  <a:srgbClr val="B84A2F"/>
+                </a:solidFill>
+                <a:latin typeface="Arial" pitchFamily="34" charset="0"/>
+                <a:ea typeface="Arial" pitchFamily="34" charset="-122"/>
+                <a:cs typeface="Arial" pitchFamily="34" charset="-120"/>
               </a:rPr>
               <a:t>Key Message: The response? Circular and Autonomous Supply Chains. We are using AI to 'self-heal' the supply chain.</a:t>
             </a:r>
@@ -2683,11 +2683,11 @@
             <a:avLst/>
           </a:prstGeom>
           <a:solidFill>
-            <a:srgbClr val="121826"/>
+            <a:srgbClr val="FFFDF8"/>
           </a:solidFill>
           <a:ln w="12700">
             <a:solidFill>
-              <a:srgbClr val="505D6F"/>
+              <a:srgbClr val="E0D9D0"/>
             </a:solidFill>
             <a:prstDash val="solid"/>
           </a:ln>
@@ -2720,11 +2720,11 @@
             <a:r>
               <a:rPr lang="en-US" sz="2000" b="1" dirty="0">
                 <a:solidFill>
-                  <a:srgbClr val="00F2FE"/>
-                </a:solidFill>
-                <a:latin typeface="Helvetica" pitchFamily="34" charset="0"/>
-                <a:ea typeface="Helvetica" pitchFamily="34" charset="-122"/>
-                <a:cs typeface="Helvetica" pitchFamily="34" charset="-120"/>
+                  <a:srgbClr val="B84A2F"/>
+                </a:solidFill>
+                <a:latin typeface="Georgia" pitchFamily="34" charset="0"/>
+                <a:ea typeface="Georgia" pitchFamily="34" charset="-122"/>
+                <a:cs typeface="Georgia" pitchFamily="34" charset="-120"/>
               </a:rPr>
               <a:t>Deep Supply Mapping &amp; AI</a:t>
             </a:r>
@@ -2759,11 +2759,11 @@
             <a:r>
               <a:rPr lang="en-US" sz="1800" dirty="0">
                 <a:solidFill>
-                  <a:srgbClr val="A0AEC0"/>
-                </a:solidFill>
-                <a:latin typeface="Helvetica" pitchFamily="34" charset="0"/>
-                <a:ea typeface="Helvetica" pitchFamily="34" charset="-122"/>
-                <a:cs typeface="Helvetica" pitchFamily="34" charset="-120"/>
+                  <a:srgbClr val="6B6560"/>
+                </a:solidFill>
+                <a:latin typeface="Arial" pitchFamily="34" charset="0"/>
+                <a:ea typeface="Arial" pitchFamily="34" charset="-122"/>
+                <a:cs typeface="Arial" pitchFamily="34" charset="-120"/>
               </a:rPr>
               <a:t>Automatically re-routing orders when a port closes or a factory goes down. Mapping up to Tier-4 and Tier-5 suppliers.</a:t>
             </a:r>
@@ -2786,11 +2786,11 @@
             <a:avLst/>
           </a:prstGeom>
           <a:solidFill>
-            <a:srgbClr val="121826"/>
+            <a:srgbClr val="FFFDF8"/>
           </a:solidFill>
           <a:ln w="12700">
             <a:solidFill>
-              <a:srgbClr val="505D6F"/>
+              <a:srgbClr val="E0D9D0"/>
             </a:solidFill>
             <a:prstDash val="solid"/>
           </a:ln>
@@ -2823,11 +2823,11 @@
             <a:r>
               <a:rPr lang="en-US" sz="2000" b="1" dirty="0">
                 <a:solidFill>
-                  <a:srgbClr val="00FF87"/>
-                </a:solidFill>
-                <a:latin typeface="Helvetica" pitchFamily="34" charset="0"/>
-                <a:ea typeface="Helvetica" pitchFamily="34" charset="-122"/>
-                <a:cs typeface="Helvetica" pitchFamily="34" charset="-120"/>
+                  <a:srgbClr val="768C7C"/>
+                </a:solidFill>
+                <a:latin typeface="Georgia" pitchFamily="34" charset="0"/>
+                <a:ea typeface="Georgia" pitchFamily="34" charset="-122"/>
+                <a:cs typeface="Georgia" pitchFamily="34" charset="-120"/>
               </a:rPr>
               <a:t>Circular Reclamation</a:t>
             </a:r>
@@ -2862,11 +2862,11 @@
             <a:r>
               <a:rPr lang="en-US" sz="1800" dirty="0">
                 <a:solidFill>
-                  <a:srgbClr val="A0AEC0"/>
-                </a:solidFill>
-                <a:latin typeface="Helvetica" pitchFamily="34" charset="0"/>
-                <a:ea typeface="Helvetica" pitchFamily="34" charset="-122"/>
-                <a:cs typeface="Helvetica" pitchFamily="34" charset="-120"/>
+                  <a:srgbClr val="6B6560"/>
+                </a:solidFill>
+                <a:latin typeface="Arial" pitchFamily="34" charset="0"/>
+                <a:ea typeface="Arial" pitchFamily="34" charset="-122"/>
+                <a:cs typeface="Arial" pitchFamily="34" charset="-120"/>
               </a:rPr>
               <a:t>Mining the 'urban mine'—recovering rare earth elements from old electronics to reduce dependency on volatile mining regions.</a:t>
             </a:r>
@@ -2889,11 +2889,11 @@
             <a:avLst/>
           </a:prstGeom>
           <a:solidFill>
-            <a:srgbClr val="121826"/>
+            <a:srgbClr val="FFFDF8"/>
           </a:solidFill>
           <a:ln w="12700">
             <a:solidFill>
-              <a:srgbClr val="00F2FE"/>
+              <a:srgbClr val="B84A2F"/>
             </a:solidFill>
             <a:prstDash val="solid"/>
           </a:ln>
@@ -2926,11 +2926,11 @@
             <a:r>
               <a:rPr lang="en-US" sz="1500" dirty="0">
                 <a:solidFill>
-                  <a:srgbClr val="A0AEC0"/>
-                </a:solidFill>
-                <a:latin typeface="Helvetica" pitchFamily="34" charset="0"/>
-                <a:ea typeface="Helvetica" pitchFamily="34" charset="-122"/>
-                <a:cs typeface="Helvetica" pitchFamily="34" charset="-120"/>
+                  <a:srgbClr val="6B6560"/>
+                </a:solidFill>
+                <a:latin typeface="Arial" pitchFamily="34" charset="0"/>
+                <a:ea typeface="Arial" pitchFamily="34" charset="-122"/>
+                <a:cs typeface="Arial" pitchFamily="34" charset="-120"/>
               </a:rPr>
               <a:t>Autonomous logistics systems automatically scan trade flows to reroute containers before bottleneck events cause line shutdowns.</a:t>
             </a:r>
@@ -2952,7 +2952,7 @@
     <p:bg>
       <p:bgPr>
         <a:solidFill>
-          <a:srgbClr val="0B0F19"/>
+          <a:srgbClr val="F5F0E8"/>
         </a:solidFill>
       </p:bgPr>
     </p:bg>
@@ -2997,11 +2997,11 @@
             <a:r>
               <a:rPr lang="en-US" sz="1200" b="1" spc="150" kern="0" dirty="0">
                 <a:solidFill>
-                  <a:srgbClr val="00F2FE"/>
-                </a:solidFill>
-                <a:latin typeface="Helvetica" pitchFamily="34" charset="0"/>
-                <a:ea typeface="Helvetica" pitchFamily="34" charset="-122"/>
-                <a:cs typeface="Helvetica" pitchFamily="34" charset="-120"/>
+                  <a:srgbClr val="B84A2F"/>
+                </a:solidFill>
+                <a:latin typeface="Arial" pitchFamily="34" charset="0"/>
+                <a:ea typeface="Arial" pitchFamily="34" charset="-122"/>
+                <a:cs typeface="Arial" pitchFamily="34" charset="-120"/>
               </a:rPr>
               <a:t>PART 3: END-USER INDUSTRIES &amp; APPLICATION ECOSYSTEM</a:t>
             </a:r>
@@ -3036,11 +3036,11 @@
             <a:r>
               <a:rPr lang="en-US" sz="3200" b="1" dirty="0">
                 <a:solidFill>
-                  <a:srgbClr val="FFFFFF"/>
-                </a:solidFill>
-                <a:latin typeface="Helvetica" pitchFamily="34" charset="0"/>
-                <a:ea typeface="Helvetica" pitchFamily="34" charset="-122"/>
-                <a:cs typeface="Helvetica" pitchFamily="34" charset="-120"/>
+                  <a:srgbClr val="1A1714"/>
+                </a:solidFill>
+                <a:latin typeface="Georgia" pitchFamily="34" charset="0"/>
+                <a:ea typeface="Georgia" pitchFamily="34" charset="-122"/>
+                <a:cs typeface="Georgia" pitchFamily="34" charset="-120"/>
               </a:rPr>
               <a:t>The Ubiquity of Silicon: Powering the Modern World</a:t>
             </a:r>
@@ -3075,11 +3075,11 @@
             <a:r>
               <a:rPr lang="en-US" sz="1000" dirty="0">
                 <a:solidFill>
-                  <a:srgbClr val="505D6F"/>
-                </a:solidFill>
-                <a:latin typeface="Helvetica" pitchFamily="34" charset="0"/>
-                <a:ea typeface="Helvetica" pitchFamily="34" charset="-122"/>
-                <a:cs typeface="Helvetica" pitchFamily="34" charset="-120"/>
+                  <a:srgbClr val="6B6560"/>
+                </a:solidFill>
+                <a:latin typeface="Arial" pitchFamily="34" charset="0"/>
+                <a:ea typeface="Arial" pitchFamily="34" charset="-122"/>
+                <a:cs typeface="Arial" pitchFamily="34" charset="-120"/>
               </a:rPr>
               <a:t>The 2026 Semiconductor Ecosystem | Slide 11</a:t>
             </a:r>
@@ -3102,11 +3102,11 @@
             <a:avLst/>
           </a:prstGeom>
           <a:solidFill>
-            <a:srgbClr val="121826"/>
+            <a:srgbClr val="FFFDF8"/>
           </a:solidFill>
           <a:ln w="19050">
             <a:solidFill>
-              <a:srgbClr val="C084FC"/>
+              <a:srgbClr val="9E7D84"/>
             </a:solidFill>
             <a:prstDash val="solid"/>
           </a:ln>
@@ -3139,11 +3139,11 @@
             <a:r>
               <a:rPr lang="en-US" sz="1800" b="1" i="1" dirty="0">
                 <a:solidFill>
-                  <a:srgbClr val="C084FC"/>
-                </a:solidFill>
-                <a:latin typeface="Helvetica" pitchFamily="34" charset="0"/>
-                <a:ea typeface="Helvetica" pitchFamily="34" charset="-122"/>
-                <a:cs typeface="Helvetica" pitchFamily="34" charset="-120"/>
+                  <a:srgbClr val="9E7D84"/>
+                </a:solidFill>
+                <a:latin typeface="Arial" pitchFamily="34" charset="0"/>
+                <a:ea typeface="Arial" pitchFamily="34" charset="-122"/>
+                <a:cs typeface="Arial" pitchFamily="34" charset="-120"/>
               </a:rPr>
               <a:t>Key Message: Semiconductors are the "nerve system" of the global economy; no modern industry can function without them.</a:t>
             </a:r>
@@ -3179,11 +3179,11 @@
             <a:r>
               <a:rPr lang="en-US" sz="1800" dirty="0">
                 <a:solidFill>
-                  <a:srgbClr val="A0AEC0"/>
-                </a:solidFill>
-                <a:latin typeface="Helvetica" pitchFamily="34" charset="0"/>
-                <a:ea typeface="Helvetica" pitchFamily="34" charset="-122"/>
-                <a:cs typeface="Helvetica" pitchFamily="34" charset="-120"/>
+                  <a:srgbClr val="6B6560"/>
+                </a:solidFill>
+                <a:latin typeface="Arial" pitchFamily="34" charset="0"/>
+                <a:ea typeface="Arial" pitchFamily="34" charset="-122"/>
+                <a:cs typeface="Arial" pitchFamily="34" charset="-120"/>
               </a:rPr>
               <a:t>- Central Nerve System: Microchips control the storage, routing, and processing of every piece of data globally.</a:t>
             </a:r>
@@ -3204,11 +3204,11 @@
             <a:r>
               <a:rPr lang="en-US" sz="1800" dirty="0">
                 <a:solidFill>
-                  <a:srgbClr val="A0AEC0"/>
-                </a:solidFill>
-                <a:latin typeface="Helvetica" pitchFamily="34" charset="0"/>
-                <a:ea typeface="Helvetica" pitchFamily="34" charset="-122"/>
-                <a:cs typeface="Helvetica" pitchFamily="34" charset="-120"/>
+                  <a:srgbClr val="6B6560"/>
+                </a:solidFill>
+                <a:latin typeface="Arial" pitchFamily="34" charset="0"/>
+                <a:ea typeface="Arial" pitchFamily="34" charset="-122"/>
+                <a:cs typeface="Arial" pitchFamily="34" charset="-120"/>
               </a:rPr>
               <a:t>- Silicon Intensity Metric: The total value of silicon content per product is the primary metric of industrial scaling.</a:t>
             </a:r>
@@ -3229,11 +3229,11 @@
             <a:r>
               <a:rPr lang="en-US" sz="1800" dirty="0">
                 <a:solidFill>
-                  <a:srgbClr val="A0AEC0"/>
-                </a:solidFill>
-                <a:latin typeface="Helvetica" pitchFamily="34" charset="0"/>
-                <a:ea typeface="Helvetica" pitchFamily="34" charset="-122"/>
-                <a:cs typeface="Helvetica" pitchFamily="34" charset="-120"/>
+                  <a:srgbClr val="6B6560"/>
+                </a:solidFill>
+                <a:latin typeface="Arial" pitchFamily="34" charset="0"/>
+                <a:ea typeface="Arial" pitchFamily="34" charset="-122"/>
+                <a:cs typeface="Arial" pitchFamily="34" charset="-120"/>
               </a:rPr>
               <a:t>- Ubiquitous Integration: Foundational logic layers power smart municipal grids, medical machinery, and neural processors.</a:t>
             </a:r>
@@ -3256,11 +3256,11 @@
             <a:avLst/>
           </a:prstGeom>
           <a:solidFill>
-            <a:srgbClr val="121826"/>
+            <a:srgbClr val="FFFDF8"/>
           </a:solidFill>
           <a:ln w="12700">
             <a:solidFill>
-              <a:srgbClr val="505D6F"/>
+              <a:srgbClr val="E0D9D0"/>
             </a:solidFill>
             <a:prstDash val="solid"/>
           </a:ln>
@@ -3293,11 +3293,11 @@
             <a:r>
               <a:rPr lang="en-US" sz="1200" b="1" dirty="0">
                 <a:solidFill>
-                  <a:srgbClr val="C084FC"/>
-                </a:solidFill>
-                <a:latin typeface="Helvetica" pitchFamily="34" charset="0"/>
-                <a:ea typeface="Helvetica" pitchFamily="34" charset="-122"/>
-                <a:cs typeface="Helvetica" pitchFamily="34" charset="-120"/>
+                  <a:srgbClr val="9E7D84"/>
+                </a:solidFill>
+                <a:latin typeface="Arial" pitchFamily="34" charset="0"/>
+                <a:ea typeface="Arial" pitchFamily="34" charset="-122"/>
+                <a:cs typeface="Arial" pitchFamily="34" charset="-120"/>
               </a:rPr>
               <a:t>KEY METRIC</a:t>
             </a:r>
@@ -3332,11 +3332,11 @@
             <a:r>
               <a:rPr lang="en-US" sz="3600" b="1" dirty="0">
                 <a:solidFill>
-                  <a:srgbClr val="FFFFFF"/>
-                </a:solidFill>
-                <a:latin typeface="Helvetica" pitchFamily="34" charset="0"/>
-                <a:ea typeface="Helvetica" pitchFamily="34" charset="-122"/>
-                <a:cs typeface="Helvetica" pitchFamily="34" charset="-120"/>
+                  <a:srgbClr val="1A1714"/>
+                </a:solidFill>
+                <a:latin typeface="Georgia" pitchFamily="34" charset="0"/>
+                <a:ea typeface="Georgia" pitchFamily="34" charset="-122"/>
+                <a:cs typeface="Georgia" pitchFamily="34" charset="-120"/>
               </a:rPr>
               <a:t>Silicon</a:t>
             </a:r>
@@ -3349,11 +3349,11 @@
             <a:r>
               <a:rPr lang="en-US" sz="3600" b="1" dirty="0">
                 <a:solidFill>
-                  <a:srgbClr val="FFFFFF"/>
-                </a:solidFill>
-                <a:latin typeface="Helvetica" pitchFamily="34" charset="0"/>
-                <a:ea typeface="Helvetica" pitchFamily="34" charset="-122"/>
-                <a:cs typeface="Helvetica" pitchFamily="34" charset="-120"/>
+                  <a:srgbClr val="1A1714"/>
+                </a:solidFill>
+                <a:latin typeface="Georgia" pitchFamily="34" charset="0"/>
+                <a:ea typeface="Georgia" pitchFamily="34" charset="-122"/>
+                <a:cs typeface="Georgia" pitchFamily="34" charset="-120"/>
               </a:rPr>
               <a:t>Intensity</a:t>
             </a:r>
@@ -3388,11 +3388,11 @@
             <a:r>
               <a:rPr lang="en-US" sz="1500" dirty="0">
                 <a:solidFill>
-                  <a:srgbClr val="A0AEC0"/>
-                </a:solidFill>
-                <a:latin typeface="Helvetica" pitchFamily="34" charset="0"/>
-                <a:ea typeface="Helvetica" pitchFamily="34" charset="-122"/>
-                <a:cs typeface="Helvetica" pitchFamily="34" charset="-120"/>
+                  <a:srgbClr val="6B6560"/>
+                </a:solidFill>
+                <a:latin typeface="Arial" pitchFamily="34" charset="0"/>
+                <a:ea typeface="Arial" pitchFamily="34" charset="-122"/>
+                <a:cs typeface="Arial" pitchFamily="34" charset="-120"/>
               </a:rPr>
               <a:t>Primary industrial competitiveness index</a:t>
             </a:r>
@@ -3414,7 +3414,7 @@
     <p:bg>
       <p:bgPr>
         <a:solidFill>
-          <a:srgbClr val="0B0F19"/>
+          <a:srgbClr val="F5F0E8"/>
         </a:solidFill>
       </p:bgPr>
     </p:bg>
@@ -3459,11 +3459,11 @@
             <a:r>
               <a:rPr lang="en-US" sz="1200" b="1" spc="150" kern="0" dirty="0">
                 <a:solidFill>
-                  <a:srgbClr val="00F2FE"/>
-                </a:solidFill>
-                <a:latin typeface="Helvetica" pitchFamily="34" charset="0"/>
-                <a:ea typeface="Helvetica" pitchFamily="34" charset="-122"/>
-                <a:cs typeface="Helvetica" pitchFamily="34" charset="-120"/>
+                  <a:srgbClr val="B84A2F"/>
+                </a:solidFill>
+                <a:latin typeface="Arial" pitchFamily="34" charset="0"/>
+                <a:ea typeface="Arial" pitchFamily="34" charset="-122"/>
+                <a:cs typeface="Arial" pitchFamily="34" charset="-120"/>
               </a:rPr>
               <a:t>PART 3: END-USER INDUSTRIES &amp; APPLICATION ECOSYSTEM</a:t>
             </a:r>
@@ -3498,11 +3498,11 @@
             <a:r>
               <a:rPr lang="en-US" sz="3200" b="1" dirty="0">
                 <a:solidFill>
-                  <a:srgbClr val="FFFFFF"/>
-                </a:solidFill>
-                <a:latin typeface="Helvetica" pitchFamily="34" charset="0"/>
-                <a:ea typeface="Helvetica" pitchFamily="34" charset="-122"/>
-                <a:cs typeface="Helvetica" pitchFamily="34" charset="-120"/>
+                  <a:srgbClr val="1A1714"/>
+                </a:solidFill>
+                <a:latin typeface="Georgia" pitchFamily="34" charset="0"/>
+                <a:ea typeface="Georgia" pitchFamily="34" charset="-122"/>
+                <a:cs typeface="Georgia" pitchFamily="34" charset="-120"/>
               </a:rPr>
               <a:t>Executive Summary: The Demand Landscape in 2026</a:t>
             </a:r>
@@ -3537,11 +3537,11 @@
             <a:r>
               <a:rPr lang="en-US" sz="1000" dirty="0">
                 <a:solidFill>
-                  <a:srgbClr val="505D6F"/>
-                </a:solidFill>
-                <a:latin typeface="Helvetica" pitchFamily="34" charset="0"/>
-                <a:ea typeface="Helvetica" pitchFamily="34" charset="-122"/>
-                <a:cs typeface="Helvetica" pitchFamily="34" charset="-120"/>
+                  <a:srgbClr val="6B6560"/>
+                </a:solidFill>
+                <a:latin typeface="Arial" pitchFamily="34" charset="0"/>
+                <a:ea typeface="Arial" pitchFamily="34" charset="-122"/>
+                <a:cs typeface="Arial" pitchFamily="34" charset="-120"/>
               </a:rPr>
               <a:t>The 2026 Semiconductor Ecosystem | Slide 12</a:t>
             </a:r>
@@ -3564,11 +3564,11 @@
             <a:avLst/>
           </a:prstGeom>
           <a:solidFill>
-            <a:srgbClr val="121826"/>
+            <a:srgbClr val="FFFDF8"/>
           </a:solidFill>
           <a:ln w="19050">
             <a:solidFill>
-              <a:srgbClr val="00F2FE"/>
+              <a:srgbClr val="B84A2F"/>
             </a:solidFill>
             <a:prstDash val="solid"/>
           </a:ln>
@@ -3601,11 +3601,11 @@
             <a:r>
               <a:rPr lang="en-US" sz="1800" b="1" i="1" dirty="0">
                 <a:solidFill>
-                  <a:srgbClr val="00F2FE"/>
-                </a:solidFill>
-                <a:latin typeface="Helvetica" pitchFamily="34" charset="0"/>
-                <a:ea typeface="Helvetica" pitchFamily="34" charset="-122"/>
-                <a:cs typeface="Helvetica" pitchFamily="34" charset="-120"/>
+                  <a:srgbClr val="B84A2F"/>
+                </a:solidFill>
+                <a:latin typeface="Arial" pitchFamily="34" charset="0"/>
+                <a:ea typeface="Arial" pitchFamily="34" charset="-122"/>
+                <a:cs typeface="Arial" pitchFamily="34" charset="-120"/>
               </a:rPr>
               <a:t>Key Message: Demand is shifting from traditional computing toward AI infrastructure, Automotive, and Industrial Automation.</a:t>
             </a:r>
@@ -3628,11 +3628,11 @@
             <a:avLst/>
           </a:prstGeom>
           <a:solidFill>
-            <a:srgbClr val="121826"/>
+            <a:srgbClr val="FFFDF8"/>
           </a:solidFill>
           <a:ln w="12700">
             <a:solidFill>
-              <a:srgbClr val="505D6F"/>
+              <a:srgbClr val="E0D9D0"/>
             </a:solidFill>
             <a:prstDash val="solid"/>
           </a:ln>
@@ -3665,11 +3665,11 @@
             <a:r>
               <a:rPr lang="en-US" sz="2000" b="1" dirty="0">
                 <a:solidFill>
-                  <a:srgbClr val="00F2FE"/>
-                </a:solidFill>
-                <a:latin typeface="Helvetica" pitchFamily="34" charset="0"/>
-                <a:ea typeface="Helvetica" pitchFamily="34" charset="-122"/>
-                <a:cs typeface="Helvetica" pitchFamily="34" charset="-120"/>
+                  <a:srgbClr val="B84A2F"/>
+                </a:solidFill>
+                <a:latin typeface="Georgia" pitchFamily="34" charset="0"/>
+                <a:ea typeface="Georgia" pitchFamily="34" charset="-122"/>
+                <a:cs typeface="Georgia" pitchFamily="34" charset="-120"/>
               </a:rPr>
               <a:t>AI Datacenters</a:t>
             </a:r>
@@ -3704,11 +3704,11 @@
             <a:r>
               <a:rPr lang="en-US" sz="1800" dirty="0">
                 <a:solidFill>
-                  <a:srgbClr val="A0AEC0"/>
-                </a:solidFill>
-                <a:latin typeface="Helvetica" pitchFamily="34" charset="0"/>
-                <a:ea typeface="Helvetica" pitchFamily="34" charset="-122"/>
-                <a:cs typeface="Helvetica" pitchFamily="34" charset="-120"/>
+                  <a:srgbClr val="6B6560"/>
+                </a:solidFill>
+                <a:latin typeface="Arial" pitchFamily="34" charset="0"/>
+                <a:ea typeface="Arial" pitchFamily="34" charset="-122"/>
+                <a:cs typeface="Arial" pitchFamily="34" charset="-120"/>
               </a:rPr>
               <a:t>Nearly 50% of semiconductor industry growth and revenue is driven by high-performance AI accelerators.</a:t>
             </a:r>
@@ -3731,11 +3731,11 @@
             <a:avLst/>
           </a:prstGeom>
           <a:solidFill>
-            <a:srgbClr val="121826"/>
+            <a:srgbClr val="FFFDF8"/>
           </a:solidFill>
           <a:ln w="12700">
             <a:solidFill>
-              <a:srgbClr val="505D6F"/>
+              <a:srgbClr val="E0D9D0"/>
             </a:solidFill>
             <a:prstDash val="solid"/>
           </a:ln>
@@ -3768,11 +3768,11 @@
             <a:r>
               <a:rPr lang="en-US" sz="2000" b="1" dirty="0">
                 <a:solidFill>
-                  <a:srgbClr val="C084FC"/>
-                </a:solidFill>
-                <a:latin typeface="Helvetica" pitchFamily="34" charset="0"/>
-                <a:ea typeface="Helvetica" pitchFamily="34" charset="-122"/>
-                <a:cs typeface="Helvetica" pitchFamily="34" charset="-120"/>
+                  <a:srgbClr val="9E7D84"/>
+                </a:solidFill>
+                <a:latin typeface="Georgia" pitchFamily="34" charset="0"/>
+                <a:ea typeface="Georgia" pitchFamily="34" charset="-122"/>
+                <a:cs typeface="Georgia" pitchFamily="34" charset="-120"/>
               </a:rPr>
               <a:t>Automotive</a:t>
             </a:r>
@@ -3807,11 +3807,11 @@
             <a:r>
               <a:rPr lang="en-US" sz="1800" dirty="0">
                 <a:solidFill>
-                  <a:srgbClr val="A0AEC0"/>
-                </a:solidFill>
-                <a:latin typeface="Helvetica" pitchFamily="34" charset="0"/>
-                <a:ea typeface="Helvetica" pitchFamily="34" charset="-122"/>
-                <a:cs typeface="Helvetica" pitchFamily="34" charset="-120"/>
+                  <a:srgbClr val="6B6560"/>
+                </a:solidFill>
+                <a:latin typeface="Arial" pitchFamily="34" charset="0"/>
+                <a:ea typeface="Arial" pitchFamily="34" charset="-122"/>
+                <a:cs typeface="Arial" pitchFamily="34" charset="-120"/>
               </a:rPr>
               <a:t>The fastest growing volume segment, requiring massive numbers of legacy control nodes and SiC power chips.</a:t>
             </a:r>
@@ -3834,11 +3834,11 @@
             <a:avLst/>
           </a:prstGeom>
           <a:solidFill>
-            <a:srgbClr val="121826"/>
+            <a:srgbClr val="FFFDF8"/>
           </a:solidFill>
           <a:ln w="12700">
             <a:solidFill>
-              <a:srgbClr val="505D6F"/>
+              <a:srgbClr val="E0D9D0"/>
             </a:solidFill>
             <a:prstDash val="solid"/>
           </a:ln>
@@ -3871,11 +3871,11 @@
             <a:r>
               <a:rPr lang="en-US" sz="2000" b="1" dirty="0">
                 <a:solidFill>
-                  <a:srgbClr val="00FF87"/>
-                </a:solidFill>
-                <a:latin typeface="Helvetica" pitchFamily="34" charset="0"/>
-                <a:ea typeface="Helvetica" pitchFamily="34" charset="-122"/>
-                <a:cs typeface="Helvetica" pitchFamily="34" charset="-120"/>
+                  <a:srgbClr val="768C7C"/>
+                </a:solidFill>
+                <a:latin typeface="Georgia" pitchFamily="34" charset="0"/>
+                <a:ea typeface="Georgia" pitchFamily="34" charset="-122"/>
+                <a:cs typeface="Georgia" pitchFamily="34" charset="-120"/>
               </a:rPr>
               <a:t>Smartphones &amp; PCs</a:t>
             </a:r>
@@ -3910,11 +3910,11 @@
             <a:r>
               <a:rPr lang="en-US" sz="1800" dirty="0">
                 <a:solidFill>
-                  <a:srgbClr val="A0AEC0"/>
-                </a:solidFill>
-                <a:latin typeface="Helvetica" pitchFamily="34" charset="0"/>
-                <a:ea typeface="Helvetica" pitchFamily="34" charset="-122"/>
-                <a:cs typeface="Helvetica" pitchFamily="34" charset="-120"/>
+                  <a:srgbClr val="6B6560"/>
+                </a:solidFill>
+                <a:latin typeface="Arial" pitchFamily="34" charset="0"/>
+                <a:ea typeface="Arial" pitchFamily="34" charset="-122"/>
+                <a:cs typeface="Arial" pitchFamily="34" charset="-120"/>
               </a:rPr>
               <a:t>Traditional core segments face volume saturation, driving consolidation and focus on specialized edge accelerators.</a:t>
             </a:r>
@@ -3936,7 +3936,7 @@
     <p:bg>
       <p:bgPr>
         <a:solidFill>
-          <a:srgbClr val="0B0F19"/>
+          <a:srgbClr val="F5F0E8"/>
         </a:solidFill>
       </p:bgPr>
     </p:bg>
@@ -3981,11 +3981,11 @@
             <a:r>
               <a:rPr lang="en-US" sz="1200" b="1" spc="150" kern="0" dirty="0">
                 <a:solidFill>
-                  <a:srgbClr val="00F2FE"/>
-                </a:solidFill>
-                <a:latin typeface="Helvetica" pitchFamily="34" charset="0"/>
-                <a:ea typeface="Helvetica" pitchFamily="34" charset="-122"/>
-                <a:cs typeface="Helvetica" pitchFamily="34" charset="-120"/>
+                  <a:srgbClr val="B84A2F"/>
+                </a:solidFill>
+                <a:latin typeface="Arial" pitchFamily="34" charset="0"/>
+                <a:ea typeface="Arial" pitchFamily="34" charset="-122"/>
+                <a:cs typeface="Arial" pitchFamily="34" charset="-120"/>
               </a:rPr>
               <a:t>PART 3: END-USER INDUSTRIES &amp; APPLICATION ECOSYSTEM</a:t>
             </a:r>
@@ -4020,11 +4020,11 @@
             <a:r>
               <a:rPr lang="en-US" sz="3200" b="1" dirty="0">
                 <a:solidFill>
-                  <a:srgbClr val="FFFFFF"/>
-                </a:solidFill>
-                <a:latin typeface="Helvetica" pitchFamily="34" charset="0"/>
-                <a:ea typeface="Helvetica" pitchFamily="34" charset="-122"/>
-                <a:cs typeface="Helvetica" pitchFamily="34" charset="-120"/>
+                  <a:srgbClr val="1A1714"/>
+                </a:solidFill>
+                <a:latin typeface="Georgia" pitchFamily="34" charset="0"/>
+                <a:ea typeface="Georgia" pitchFamily="34" charset="-122"/>
+                <a:cs typeface="Georgia" pitchFamily="34" charset="-120"/>
               </a:rPr>
               <a:t>AI &amp; Data Centers: The Generative Revolution</a:t>
             </a:r>
@@ -4059,11 +4059,11 @@
             <a:r>
               <a:rPr lang="en-US" sz="1000" dirty="0">
                 <a:solidFill>
-                  <a:srgbClr val="505D6F"/>
-                </a:solidFill>
-                <a:latin typeface="Helvetica" pitchFamily="34" charset="0"/>
-                <a:ea typeface="Helvetica" pitchFamily="34" charset="-122"/>
-                <a:cs typeface="Helvetica" pitchFamily="34" charset="-120"/>
+                  <a:srgbClr val="6B6560"/>
+                </a:solidFill>
+                <a:latin typeface="Arial" pitchFamily="34" charset="0"/>
+                <a:ea typeface="Arial" pitchFamily="34" charset="-122"/>
+                <a:cs typeface="Arial" pitchFamily="34" charset="-120"/>
               </a:rPr>
               <a:t>The 2026 Semiconductor Ecosystem | Slide 13</a:t>
             </a:r>
@@ -4086,11 +4086,11 @@
             <a:avLst/>
           </a:prstGeom>
           <a:solidFill>
-            <a:srgbClr val="121826"/>
+            <a:srgbClr val="FFFDF8"/>
           </a:solidFill>
           <a:ln w="19050">
             <a:solidFill>
-              <a:srgbClr val="00FF87"/>
+              <a:srgbClr val="768C7C"/>
             </a:solidFill>
             <a:prstDash val="solid"/>
           </a:ln>
@@ -4123,11 +4123,11 @@
             <a:r>
               <a:rPr lang="en-US" sz="1800" b="1" i="1" dirty="0">
                 <a:solidFill>
-                  <a:srgbClr val="00FF87"/>
-                </a:solidFill>
-                <a:latin typeface="Helvetica" pitchFamily="34" charset="0"/>
-                <a:ea typeface="Helvetica" pitchFamily="34" charset="-122"/>
-                <a:cs typeface="Helvetica" pitchFamily="34" charset="-120"/>
+                  <a:srgbClr val="768C7C"/>
+                </a:solidFill>
+                <a:latin typeface="Arial" pitchFamily="34" charset="0"/>
+                <a:ea typeface="Arial" pitchFamily="34" charset="-122"/>
+                <a:cs typeface="Arial" pitchFamily="34" charset="-120"/>
               </a:rPr>
               <a:t>Key Message: Data centers have evolved into "Intelligence Engines," consuming the highest-value silicon ever produced.</a:t>
             </a:r>
@@ -4163,11 +4163,11 @@
             <a:r>
               <a:rPr lang="en-US" sz="1800" dirty="0">
                 <a:solidFill>
-                  <a:srgbClr val="A0AEC0"/>
-                </a:solidFill>
-                <a:latin typeface="Helvetica" pitchFamily="34" charset="0"/>
-                <a:ea typeface="Helvetica" pitchFamily="34" charset="-122"/>
-                <a:cs typeface="Helvetica" pitchFamily="34" charset="-120"/>
+                  <a:srgbClr val="6B6560"/>
+                </a:solidFill>
+                <a:latin typeface="Arial" pitchFamily="34" charset="0"/>
+                <a:ea typeface="Arial" pitchFamily="34" charset="-122"/>
+                <a:cs typeface="Arial" pitchFamily="34" charset="-120"/>
               </a:rPr>
               <a:t>- Accelerator Market ($500B): Generative models and neural computing demand massive scaling of TPU and GPU nodes.</a:t>
             </a:r>
@@ -4188,11 +4188,11 @@
             <a:r>
               <a:rPr lang="en-US" sz="1800" dirty="0">
                 <a:solidFill>
-                  <a:srgbClr val="A0AEC0"/>
-                </a:solidFill>
-                <a:latin typeface="Helvetica" pitchFamily="34" charset="0"/>
-                <a:ea typeface="Helvetica" pitchFamily="34" charset="-122"/>
-                <a:cs typeface="Helvetica" pitchFamily="34" charset="-120"/>
+                  <a:srgbClr val="6B6560"/>
+                </a:solidFill>
+                <a:latin typeface="Arial" pitchFamily="34" charset="0"/>
+                <a:ea typeface="Arial" pitchFamily="34" charset="-122"/>
+                <a:cs typeface="Arial" pitchFamily="34" charset="-120"/>
               </a:rPr>
               <a:t>- Sub-3nm Node Sourcing: The primary consumers of the most advanced wafer print architectures globally.</a:t>
             </a:r>
@@ -4213,11 +4213,11 @@
             <a:r>
               <a:rPr lang="en-US" sz="1800" dirty="0">
                 <a:solidFill>
-                  <a:srgbClr val="A0AEC0"/>
-                </a:solidFill>
-                <a:latin typeface="Helvetica" pitchFamily="34" charset="0"/>
-                <a:ea typeface="Helvetica" pitchFamily="34" charset="-122"/>
-                <a:cs typeface="Helvetica" pitchFamily="34" charset="-120"/>
+                  <a:srgbClr val="6B6560"/>
+                </a:solidFill>
+                <a:latin typeface="Arial" pitchFamily="34" charset="0"/>
+                <a:ea typeface="Arial" pitchFamily="34" charset="-122"/>
+                <a:cs typeface="Arial" pitchFamily="34" charset="-120"/>
               </a:rPr>
               <a:t>- Memory &amp; Interconnect: Demands extreme density of High Bandwidth Memory (HBM) and customized routing interconnect silicon.</a:t>
             </a:r>
@@ -4240,11 +4240,11 @@
             <a:avLst/>
           </a:prstGeom>
           <a:solidFill>
-            <a:srgbClr val="121826"/>
+            <a:srgbClr val="FFFDF8"/>
           </a:solidFill>
           <a:ln w="12700">
             <a:solidFill>
-              <a:srgbClr val="00FF87"/>
+              <a:srgbClr val="768C7C"/>
             </a:solidFill>
             <a:prstDash val="solid"/>
           </a:ln>
@@ -4277,11 +4277,11 @@
             <a:r>
               <a:rPr lang="en-US" sz="1200" b="1" dirty="0">
                 <a:solidFill>
-                  <a:srgbClr val="00FF87"/>
-                </a:solidFill>
-                <a:latin typeface="Helvetica" pitchFamily="34" charset="0"/>
-                <a:ea typeface="Helvetica" pitchFamily="34" charset="-122"/>
-                <a:cs typeface="Helvetica" pitchFamily="34" charset="-120"/>
+                  <a:srgbClr val="768C7C"/>
+                </a:solidFill>
+                <a:latin typeface="Arial" pitchFamily="34" charset="0"/>
+                <a:ea typeface="Arial" pitchFamily="34" charset="-122"/>
+                <a:cs typeface="Arial" pitchFamily="34" charset="-120"/>
               </a:rPr>
               <a:t>ANALYST PROJECT</a:t>
             </a:r>
@@ -4316,11 +4316,11 @@
             <a:r>
               <a:rPr lang="en-US" sz="5400" b="1" dirty="0">
                 <a:solidFill>
-                  <a:srgbClr val="FFFFFF"/>
-                </a:solidFill>
-                <a:latin typeface="Helvetica" pitchFamily="34" charset="0"/>
-                <a:ea typeface="Helvetica" pitchFamily="34" charset="-122"/>
-                <a:cs typeface="Helvetica" pitchFamily="34" charset="-120"/>
+                  <a:srgbClr val="1A1714"/>
+                </a:solidFill>
+                <a:latin typeface="Georgia" pitchFamily="34" charset="0"/>
+                <a:ea typeface="Georgia" pitchFamily="34" charset="-122"/>
+                <a:cs typeface="Georgia" pitchFamily="34" charset="-120"/>
               </a:rPr>
               <a:t>$500B</a:t>
             </a:r>
@@ -4355,11 +4355,11 @@
             <a:r>
               <a:rPr lang="en-US" sz="1500" dirty="0">
                 <a:solidFill>
-                  <a:srgbClr val="A0AEC0"/>
-                </a:solidFill>
-                <a:latin typeface="Helvetica" pitchFamily="34" charset="0"/>
-                <a:ea typeface="Helvetica" pitchFamily="34" charset="-122"/>
-                <a:cs typeface="Helvetica" pitchFamily="34" charset="-120"/>
+                  <a:srgbClr val="6B6560"/>
+                </a:solidFill>
+                <a:latin typeface="Arial" pitchFamily="34" charset="0"/>
+                <a:ea typeface="Arial" pitchFamily="34" charset="-122"/>
+                <a:cs typeface="Arial" pitchFamily="34" charset="-120"/>
               </a:rPr>
               <a:t>AI Accelerator market size by 2026</a:t>
             </a:r>
@@ -4381,7 +4381,7 @@
     <p:bg>
       <p:bgPr>
         <a:solidFill>
-          <a:srgbClr val="0B0F19"/>
+          <a:srgbClr val="F5F0E8"/>
         </a:solidFill>
       </p:bgPr>
     </p:bg>
@@ -4426,11 +4426,11 @@
             <a:r>
               <a:rPr lang="en-US" sz="1200" b="1" spc="150" kern="0" dirty="0">
                 <a:solidFill>
-                  <a:srgbClr val="00F2FE"/>
-                </a:solidFill>
-                <a:latin typeface="Helvetica" pitchFamily="34" charset="0"/>
-                <a:ea typeface="Helvetica" pitchFamily="34" charset="-122"/>
-                <a:cs typeface="Helvetica" pitchFamily="34" charset="-120"/>
+                  <a:srgbClr val="B84A2F"/>
+                </a:solidFill>
+                <a:latin typeface="Arial" pitchFamily="34" charset="0"/>
+                <a:ea typeface="Arial" pitchFamily="34" charset="-122"/>
+                <a:cs typeface="Arial" pitchFamily="34" charset="-120"/>
               </a:rPr>
               <a:t>PART 3: END-USER INDUSTRIES &amp; APPLICATION ECOSYSTEM</a:t>
             </a:r>
@@ -4465,11 +4465,11 @@
             <a:r>
               <a:rPr lang="en-US" sz="3200" b="1" dirty="0">
                 <a:solidFill>
-                  <a:srgbClr val="FFFFFF"/>
-                </a:solidFill>
-                <a:latin typeface="Helvetica" pitchFamily="34" charset="0"/>
-                <a:ea typeface="Helvetica" pitchFamily="34" charset="-122"/>
-                <a:cs typeface="Helvetica" pitchFamily="34" charset="-120"/>
+                  <a:srgbClr val="1A1714"/>
+                </a:solidFill>
+                <a:latin typeface="Georgia" pitchFamily="34" charset="0"/>
+                <a:ea typeface="Georgia" pitchFamily="34" charset="-122"/>
+                <a:cs typeface="Georgia" pitchFamily="34" charset="-120"/>
               </a:rPr>
               <a:t>Automotive: The "Smartphone on Wheels"</a:t>
             </a:r>
@@ -4504,11 +4504,11 @@
             <a:r>
               <a:rPr lang="en-US" sz="1000" dirty="0">
                 <a:solidFill>
-                  <a:srgbClr val="505D6F"/>
-                </a:solidFill>
-                <a:latin typeface="Helvetica" pitchFamily="34" charset="0"/>
-                <a:ea typeface="Helvetica" pitchFamily="34" charset="-122"/>
-                <a:cs typeface="Helvetica" pitchFamily="34" charset="-120"/>
+                  <a:srgbClr val="6B6560"/>
+                </a:solidFill>
+                <a:latin typeface="Arial" pitchFamily="34" charset="0"/>
+                <a:ea typeface="Arial" pitchFamily="34" charset="-122"/>
+                <a:cs typeface="Arial" pitchFamily="34" charset="-120"/>
               </a:rPr>
               <a:t>The 2026 Semiconductor Ecosystem | Slide 14</a:t>
             </a:r>
@@ -4531,11 +4531,11 @@
             <a:avLst/>
           </a:prstGeom>
           <a:solidFill>
-            <a:srgbClr val="121826"/>
+            <a:srgbClr val="FFFDF8"/>
           </a:solidFill>
           <a:ln w="19050">
             <a:solidFill>
-              <a:srgbClr val="00F2FE"/>
+              <a:srgbClr val="B84A2F"/>
             </a:solidFill>
             <a:prstDash val="solid"/>
           </a:ln>
@@ -4568,11 +4568,11 @@
             <a:r>
               <a:rPr lang="en-US" sz="1800" b="1" i="1" dirty="0">
                 <a:solidFill>
-                  <a:srgbClr val="00F2FE"/>
-                </a:solidFill>
-                <a:latin typeface="Helvetica" pitchFamily="34" charset="0"/>
-                <a:ea typeface="Helvetica" pitchFamily="34" charset="-122"/>
-                <a:cs typeface="Helvetica" pitchFamily="34" charset="-120"/>
+                  <a:srgbClr val="B84A2F"/>
+                </a:solidFill>
+                <a:latin typeface="Arial" pitchFamily="34" charset="0"/>
+                <a:ea typeface="Arial" pitchFamily="34" charset="-122"/>
+                <a:cs typeface="Arial" pitchFamily="34" charset="-120"/>
               </a:rPr>
               <a:t>Key Message: The transition to EVs and ADAS is doubling semiconductor content per vehicle, reaching over $1,000 per unit.</a:t>
             </a:r>
@@ -4608,11 +4608,11 @@
             <a:r>
               <a:rPr lang="en-US" sz="1800" dirty="0">
                 <a:solidFill>
-                  <a:srgbClr val="A0AEC0"/>
-                </a:solidFill>
-                <a:latin typeface="Helvetica" pitchFamily="34" charset="0"/>
-                <a:ea typeface="Helvetica" pitchFamily="34" charset="-122"/>
-                <a:cs typeface="Helvetica" pitchFamily="34" charset="-120"/>
+                  <a:srgbClr val="6B6560"/>
+                </a:solidFill>
+                <a:latin typeface="Arial" pitchFamily="34" charset="0"/>
+                <a:ea typeface="Arial" pitchFamily="34" charset="-122"/>
+                <a:cs typeface="Arial" pitchFamily="34" charset="-120"/>
               </a:rPr>
               <a:t>- Silicon Carbide (SiC) Power: Drives high-efficiency power switches in high-voltage EV battery platforms.</a:t>
             </a:r>
@@ -4633,11 +4633,11 @@
             <a:r>
               <a:rPr lang="en-US" sz="1800" dirty="0">
                 <a:solidFill>
-                  <a:srgbClr val="A0AEC0"/>
-                </a:solidFill>
-                <a:latin typeface="Helvetica" pitchFamily="34" charset="0"/>
-                <a:ea typeface="Helvetica" pitchFamily="34" charset="-122"/>
-                <a:cs typeface="Helvetica" pitchFamily="34" charset="-120"/>
+                  <a:srgbClr val="6B6560"/>
+                </a:solidFill>
+                <a:latin typeface="Arial" pitchFamily="34" charset="0"/>
+                <a:ea typeface="Arial" pitchFamily="34" charset="-122"/>
+                <a:cs typeface="Arial" pitchFamily="34" charset="-120"/>
               </a:rPr>
               <a:t>- ADAS Autonomous Compute: Self-driving capabilities demand heavy on-board computational units for sensor fusion.</a:t>
             </a:r>
@@ -4658,11 +4658,11 @@
             <a:r>
               <a:rPr lang="en-US" sz="1800" dirty="0">
                 <a:solidFill>
-                  <a:srgbClr val="A0AEC0"/>
-                </a:solidFill>
-                <a:latin typeface="Helvetica" pitchFamily="34" charset="0"/>
-                <a:ea typeface="Helvetica" pitchFamily="34" charset="-122"/>
-                <a:cs typeface="Helvetica" pitchFamily="34" charset="-120"/>
+                  <a:srgbClr val="6B6560"/>
+                </a:solidFill>
+                <a:latin typeface="Arial" pitchFamily="34" charset="0"/>
+                <a:ea typeface="Arial" pitchFamily="34" charset="-122"/>
+                <a:cs typeface="Arial" pitchFamily="34" charset="-120"/>
               </a:rPr>
               <a:t>- Sensor Arrays Sourcing: Vehicles integrate multiple LiDAR, radar, and camera chip sets for 360-degree coverage.</a:t>
             </a:r>
@@ -4685,11 +4685,11 @@
             <a:avLst/>
           </a:prstGeom>
           <a:solidFill>
-            <a:srgbClr val="121826"/>
+            <a:srgbClr val="FFFDF8"/>
           </a:solidFill>
           <a:ln w="12700">
             <a:solidFill>
-              <a:srgbClr val="505D6F"/>
+              <a:srgbClr val="E0D9D0"/>
             </a:solidFill>
             <a:prstDash val="solid"/>
           </a:ln>
@@ -4722,11 +4722,11 @@
             <a:r>
               <a:rPr lang="en-US" sz="1200" b="1" dirty="0">
                 <a:solidFill>
-                  <a:srgbClr val="00F2FE"/>
-                </a:solidFill>
-                <a:latin typeface="Helvetica" pitchFamily="34" charset="0"/>
-                <a:ea typeface="Helvetica" pitchFamily="34" charset="-122"/>
-                <a:cs typeface="Helvetica" pitchFamily="34" charset="-120"/>
+                  <a:srgbClr val="B84A2F"/>
+                </a:solidFill>
+                <a:latin typeface="Arial" pitchFamily="34" charset="0"/>
+                <a:ea typeface="Arial" pitchFamily="34" charset="-122"/>
+                <a:cs typeface="Arial" pitchFamily="34" charset="-120"/>
               </a:rPr>
               <a:t>ESTIMATE</a:t>
             </a:r>
@@ -4761,11 +4761,11 @@
             <a:r>
               <a:rPr lang="en-US" sz="5000" b="1" dirty="0">
                 <a:solidFill>
-                  <a:srgbClr val="FFFFFF"/>
-                </a:solidFill>
-                <a:latin typeface="Helvetica" pitchFamily="34" charset="0"/>
-                <a:ea typeface="Helvetica" pitchFamily="34" charset="-122"/>
-                <a:cs typeface="Helvetica" pitchFamily="34" charset="-120"/>
+                  <a:srgbClr val="1A1714"/>
+                </a:solidFill>
+                <a:latin typeface="Georgia" pitchFamily="34" charset="0"/>
+                <a:ea typeface="Georgia" pitchFamily="34" charset="-122"/>
+                <a:cs typeface="Georgia" pitchFamily="34" charset="-120"/>
               </a:rPr>
               <a:t>$1,000+</a:t>
             </a:r>
@@ -4800,11 +4800,11 @@
             <a:r>
               <a:rPr lang="en-US" sz="1500" dirty="0">
                 <a:solidFill>
-                  <a:srgbClr val="A0AEC0"/>
-                </a:solidFill>
-                <a:latin typeface="Helvetica" pitchFamily="34" charset="0"/>
-                <a:ea typeface="Helvetica" pitchFamily="34" charset="-122"/>
-                <a:cs typeface="Helvetica" pitchFamily="34" charset="-120"/>
+                  <a:srgbClr val="6B6560"/>
+                </a:solidFill>
+                <a:latin typeface="Arial" pitchFamily="34" charset="0"/>
+                <a:ea typeface="Arial" pitchFamily="34" charset="-122"/>
+                <a:cs typeface="Arial" pitchFamily="34" charset="-120"/>
               </a:rPr>
               <a:t>Silicon value content per EV unit</a:t>
             </a:r>
@@ -4826,7 +4826,7 @@
     <p:bg>
       <p:bgPr>
         <a:solidFill>
-          <a:srgbClr val="0B0F19"/>
+          <a:srgbClr val="F5F0E8"/>
         </a:solidFill>
       </p:bgPr>
     </p:bg>
@@ -4871,11 +4871,11 @@
             <a:r>
               <a:rPr lang="en-US" sz="1200" b="1" spc="150" kern="0" dirty="0">
                 <a:solidFill>
-                  <a:srgbClr val="00F2FE"/>
-                </a:solidFill>
-                <a:latin typeface="Helvetica" pitchFamily="34" charset="0"/>
-                <a:ea typeface="Helvetica" pitchFamily="34" charset="-122"/>
-                <a:cs typeface="Helvetica" pitchFamily="34" charset="-120"/>
+                  <a:srgbClr val="B84A2F"/>
+                </a:solidFill>
+                <a:latin typeface="Arial" pitchFamily="34" charset="0"/>
+                <a:ea typeface="Arial" pitchFamily="34" charset="-122"/>
+                <a:cs typeface="Arial" pitchFamily="34" charset="-120"/>
               </a:rPr>
               <a:t>PART 3: END-USER INDUSTRIES &amp; APPLICATION ECOSYSTEM</a:t>
             </a:r>
@@ -4910,11 +4910,11 @@
             <a:r>
               <a:rPr lang="en-US" sz="3200" b="1" dirty="0">
                 <a:solidFill>
-                  <a:srgbClr val="FFFFFF"/>
-                </a:solidFill>
-                <a:latin typeface="Helvetica" pitchFamily="34" charset="0"/>
-                <a:ea typeface="Helvetica" pitchFamily="34" charset="-122"/>
-                <a:cs typeface="Helvetica" pitchFamily="34" charset="-120"/>
+                  <a:srgbClr val="1A1714"/>
+                </a:solidFill>
+                <a:latin typeface="Georgia" pitchFamily="34" charset="0"/>
+                <a:ea typeface="Georgia" pitchFamily="34" charset="-122"/>
+                <a:cs typeface="Georgia" pitchFamily="34" charset="-120"/>
               </a:rPr>
               <a:t>Industrial, IoT &amp; Healthcare: Intelligence at the Edge</a:t>
             </a:r>
@@ -4949,11 +4949,11 @@
             <a:r>
               <a:rPr lang="en-US" sz="1000" dirty="0">
                 <a:solidFill>
-                  <a:srgbClr val="505D6F"/>
-                </a:solidFill>
-                <a:latin typeface="Helvetica" pitchFamily="34" charset="0"/>
-                <a:ea typeface="Helvetica" pitchFamily="34" charset="-122"/>
-                <a:cs typeface="Helvetica" pitchFamily="34" charset="-120"/>
+                  <a:srgbClr val="6B6560"/>
+                </a:solidFill>
+                <a:latin typeface="Arial" pitchFamily="34" charset="0"/>
+                <a:ea typeface="Arial" pitchFamily="34" charset="-122"/>
+                <a:cs typeface="Arial" pitchFamily="34" charset="-120"/>
               </a:rPr>
               <a:t>The 2026 Semiconductor Ecosystem | Slide 15</a:t>
             </a:r>
@@ -4976,11 +4976,11 @@
             <a:avLst/>
           </a:prstGeom>
           <a:solidFill>
-            <a:srgbClr val="121826"/>
+            <a:srgbClr val="FFFDF8"/>
           </a:solidFill>
           <a:ln w="19050">
             <a:solidFill>
-              <a:srgbClr val="C084FC"/>
+              <a:srgbClr val="9E7D84"/>
             </a:solidFill>
             <a:prstDash val="solid"/>
           </a:ln>
@@ -5013,11 +5013,11 @@
             <a:r>
               <a:rPr lang="en-US" sz="1800" b="1" i="1" dirty="0">
                 <a:solidFill>
-                  <a:srgbClr val="C084FC"/>
-                </a:solidFill>
-                <a:latin typeface="Helvetica" pitchFamily="34" charset="0"/>
-                <a:ea typeface="Helvetica" pitchFamily="34" charset="-122"/>
-                <a:cs typeface="Helvetica" pitchFamily="34" charset="-120"/>
+                  <a:srgbClr val="9E7D84"/>
+                </a:solidFill>
+                <a:latin typeface="Arial" pitchFamily="34" charset="0"/>
+                <a:ea typeface="Arial" pitchFamily="34" charset="-122"/>
+                <a:cs typeface="Arial" pitchFamily="34" charset="-120"/>
               </a:rPr>
               <a:t>Key Message: Edge AI is transforming manufacturing and healthcare, prioritizing long-lifecycle, high-reliability silicon.</a:t>
             </a:r>
@@ -5040,11 +5040,11 @@
             <a:avLst/>
           </a:prstGeom>
           <a:solidFill>
-            <a:srgbClr val="121826"/>
+            <a:srgbClr val="FFFDF8"/>
           </a:solidFill>
           <a:ln w="12700">
             <a:solidFill>
-              <a:srgbClr val="C084FC"/>
+              <a:srgbClr val="9E7D84"/>
             </a:solidFill>
             <a:prstDash val="solid"/>
           </a:ln>
@@ -5077,11 +5077,11 @@
             <a:r>
               <a:rPr lang="en-US" sz="2000" b="1" dirty="0">
                 <a:solidFill>
-                  <a:srgbClr val="C084FC"/>
-                </a:solidFill>
-                <a:latin typeface="Helvetica" pitchFamily="34" charset="0"/>
-                <a:ea typeface="Helvetica" pitchFamily="34" charset="-122"/>
-                <a:cs typeface="Helvetica" pitchFamily="34" charset="-120"/>
+                  <a:srgbClr val="9E7D84"/>
+                </a:solidFill>
+                <a:latin typeface="Georgia" pitchFamily="34" charset="0"/>
+                <a:ea typeface="Georgia" pitchFamily="34" charset="-122"/>
+                <a:cs typeface="Georgia" pitchFamily="34" charset="-120"/>
               </a:rPr>
               <a:t>Industry 4.0 Edge Analytics</a:t>
             </a:r>
@@ -5116,11 +5116,11 @@
             <a:r>
               <a:rPr lang="en-US" sz="1800" dirty="0">
                 <a:solidFill>
-                  <a:srgbClr val="A0AEC0"/>
-                </a:solidFill>
-                <a:latin typeface="Helvetica" pitchFamily="34" charset="0"/>
-                <a:ea typeface="Helvetica" pitchFamily="34" charset="-122"/>
-                <a:cs typeface="Helvetica" pitchFamily="34" charset="-120"/>
+                  <a:srgbClr val="6B6560"/>
+                </a:solidFill>
+                <a:latin typeface="Arial" pitchFamily="34" charset="0"/>
+                <a:ea typeface="Arial" pitchFamily="34" charset="-122"/>
+                <a:cs typeface="Arial" pitchFamily="34" charset="-120"/>
               </a:rPr>
               <a:t>Factory floor nodes execute real-time local algorithms for predictive maintenance and machine vision controls, utilizing highly rugged legacy processes.</a:t>
             </a:r>
@@ -5143,11 +5143,11 @@
             <a:avLst/>
           </a:prstGeom>
           <a:solidFill>
-            <a:srgbClr val="121826"/>
+            <a:srgbClr val="FFFDF8"/>
           </a:solidFill>
           <a:ln w="12700">
             <a:solidFill>
-              <a:srgbClr val="00FF87"/>
+              <a:srgbClr val="768C7C"/>
             </a:solidFill>
             <a:prstDash val="solid"/>
           </a:ln>
@@ -5180,11 +5180,11 @@
             <a:r>
               <a:rPr lang="en-US" sz="2000" b="1" dirty="0">
                 <a:solidFill>
-                  <a:srgbClr val="00FF87"/>
-                </a:solidFill>
-                <a:latin typeface="Helvetica" pitchFamily="34" charset="0"/>
-                <a:ea typeface="Helvetica" pitchFamily="34" charset="-122"/>
-                <a:cs typeface="Helvetica" pitchFamily="34" charset="-120"/>
+                  <a:srgbClr val="768C7C"/>
+                </a:solidFill>
+                <a:latin typeface="Georgia" pitchFamily="34" charset="0"/>
+                <a:ea typeface="Georgia" pitchFamily="34" charset="-122"/>
+                <a:cs typeface="Georgia" pitchFamily="34" charset="-120"/>
               </a:rPr>
               <a:t>Healthcare Personalized Sourcing</a:t>
             </a:r>
@@ -5219,11 +5219,11 @@
             <a:r>
               <a:rPr lang="en-US" sz="1800" dirty="0">
                 <a:solidFill>
-                  <a:srgbClr val="A0AEC0"/>
-                </a:solidFill>
-                <a:latin typeface="Helvetica" pitchFamily="34" charset="0"/>
-                <a:ea typeface="Helvetica" pitchFamily="34" charset="-122"/>
-                <a:cs typeface="Helvetica" pitchFamily="34" charset="-120"/>
+                  <a:srgbClr val="6B6560"/>
+                </a:solidFill>
+                <a:latin typeface="Arial" pitchFamily="34" charset="0"/>
+                <a:ea typeface="Arial" pitchFamily="34" charset="-122"/>
+                <a:cs typeface="Arial" pitchFamily="34" charset="-120"/>
               </a:rPr>
               <a:t>Semiconductors enable smart wearable diagnostics, active health implants, and personalized diagnostics. Requires extreme reliability certifications.</a:t>
             </a:r>
@@ -5245,7 +5245,7 @@
     <p:bg>
       <p:bgPr>
         <a:solidFill>
-          <a:srgbClr val="0B0F19"/>
+          <a:srgbClr val="F5F0E8"/>
         </a:solidFill>
       </p:bgPr>
     </p:bg>
@@ -5290,11 +5290,11 @@
             <a:r>
               <a:rPr lang="en-US" sz="1200" b="1" spc="150" kern="0" dirty="0">
                 <a:solidFill>
-                  <a:srgbClr val="00F2FE"/>
-                </a:solidFill>
-                <a:latin typeface="Helvetica" pitchFamily="34" charset="0"/>
-                <a:ea typeface="Helvetica" pitchFamily="34" charset="-122"/>
-                <a:cs typeface="Helvetica" pitchFamily="34" charset="-120"/>
+                  <a:srgbClr val="B84A2F"/>
+                </a:solidFill>
+                <a:latin typeface="Arial" pitchFamily="34" charset="0"/>
+                <a:ea typeface="Arial" pitchFamily="34" charset="-122"/>
+                <a:cs typeface="Arial" pitchFamily="34" charset="-120"/>
               </a:rPr>
               <a:t>PART 3: END-USER INDUSTRIES &amp; APPLICATION ECOSYSTEM</a:t>
             </a:r>
@@ -5329,11 +5329,11 @@
             <a:r>
               <a:rPr lang="en-US" sz="3200" b="1" dirty="0">
                 <a:solidFill>
-                  <a:srgbClr val="FFFFFF"/>
-                </a:solidFill>
-                <a:latin typeface="Helvetica" pitchFamily="34" charset="0"/>
-                <a:ea typeface="Helvetica" pitchFamily="34" charset="-122"/>
-                <a:cs typeface="Helvetica" pitchFamily="34" charset="-120"/>
+                  <a:srgbClr val="1A1714"/>
+                </a:solidFill>
+                <a:latin typeface="Georgia" pitchFamily="34" charset="0"/>
+                <a:ea typeface="Georgia" pitchFamily="34" charset="-122"/>
+                <a:cs typeface="Georgia" pitchFamily="34" charset="-120"/>
               </a:rPr>
               <a:t>Consumer Electronics &amp; Emerging Frontiers</a:t>
             </a:r>
@@ -5368,11 +5368,11 @@
             <a:r>
               <a:rPr lang="en-US" sz="1000" dirty="0">
                 <a:solidFill>
-                  <a:srgbClr val="505D6F"/>
-                </a:solidFill>
-                <a:latin typeface="Helvetica" pitchFamily="34" charset="0"/>
-                <a:ea typeface="Helvetica" pitchFamily="34" charset="-122"/>
-                <a:cs typeface="Helvetica" pitchFamily="34" charset="-120"/>
+                  <a:srgbClr val="6B6560"/>
+                </a:solidFill>
+                <a:latin typeface="Arial" pitchFamily="34" charset="0"/>
+                <a:ea typeface="Arial" pitchFamily="34" charset="-122"/>
+                <a:cs typeface="Arial" pitchFamily="34" charset="-120"/>
               </a:rPr>
               <a:t>The 2026 Semiconductor Ecosystem | Slide 16</a:t>
             </a:r>
@@ -5395,11 +5395,11 @@
             <a:avLst/>
           </a:prstGeom>
           <a:solidFill>
-            <a:srgbClr val="121826"/>
+            <a:srgbClr val="FFFDF8"/>
           </a:solidFill>
           <a:ln w="19050">
             <a:solidFill>
-              <a:srgbClr val="00FF87"/>
+              <a:srgbClr val="768C7C"/>
             </a:solidFill>
             <a:prstDash val="solid"/>
           </a:ln>
@@ -5432,11 +5432,11 @@
             <a:r>
               <a:rPr lang="en-US" sz="1800" b="1" i="1" dirty="0">
                 <a:solidFill>
-                  <a:srgbClr val="00FF87"/>
-                </a:solidFill>
-                <a:latin typeface="Helvetica" pitchFamily="34" charset="0"/>
-                <a:ea typeface="Helvetica" pitchFamily="34" charset="-122"/>
-                <a:cs typeface="Helvetica" pitchFamily="34" charset="-120"/>
+                  <a:srgbClr val="768C7C"/>
+                </a:solidFill>
+                <a:latin typeface="Arial" pitchFamily="34" charset="0"/>
+                <a:ea typeface="Arial" pitchFamily="34" charset="-122"/>
+                <a:cs typeface="Arial" pitchFamily="34" charset="-120"/>
               </a:rPr>
               <a:t>Key Message: While traditional consumer tech matures, frontiers like Quantum, 6G, and Neuromorphic computing define the 2030 roadmap.</a:t>
             </a:r>
@@ -5472,11 +5472,11 @@
             <a:r>
               <a:rPr lang="en-US" sz="1800" dirty="0">
                 <a:solidFill>
-                  <a:srgbClr val="A0AEC0"/>
-                </a:solidFill>
-                <a:latin typeface="Helvetica" pitchFamily="34" charset="0"/>
-                <a:ea typeface="Helvetica" pitchFamily="34" charset="-122"/>
-                <a:cs typeface="Helvetica" pitchFamily="34" charset="-120"/>
+                  <a:srgbClr val="6B6560"/>
+                </a:solidFill>
+                <a:latin typeface="Arial" pitchFamily="34" charset="0"/>
+                <a:ea typeface="Arial" pitchFamily="34" charset="-122"/>
+                <a:cs typeface="Arial" pitchFamily="34" charset="-120"/>
               </a:rPr>
               <a:t>- On-Device NPU Logic: Integrating Neural Processing Units (NPUs) into laptops and mobile phones to enable local AI execution.</a:t>
             </a:r>
@@ -5497,11 +5497,11 @@
             <a:r>
               <a:rPr lang="en-US" sz="1800" dirty="0">
                 <a:solidFill>
-                  <a:srgbClr val="A0AEC0"/>
-                </a:solidFill>
-                <a:latin typeface="Helvetica" pitchFamily="34" charset="0"/>
-                <a:ea typeface="Helvetica" pitchFamily="34" charset="-122"/>
-                <a:cs typeface="Helvetica" pitchFamily="34" charset="-120"/>
+                  <a:srgbClr val="6B6560"/>
+                </a:solidFill>
+                <a:latin typeface="Arial" pitchFamily="34" charset="0"/>
+                <a:ea typeface="Arial" pitchFamily="34" charset="-122"/>
+                <a:cs typeface="Arial" pitchFamily="34" charset="-120"/>
               </a:rPr>
               <a:t>- Neuromorphic Computing: Researching brain-inspired architectures targeting extreme computing power efficiency.</a:t>
             </a:r>
@@ -5522,11 +5522,11 @@
             <a:r>
               <a:rPr lang="en-US" sz="1800" dirty="0">
                 <a:solidFill>
-                  <a:srgbClr val="A0AEC0"/>
-                </a:solidFill>
-                <a:latin typeface="Helvetica" pitchFamily="34" charset="0"/>
-                <a:ea typeface="Helvetica" pitchFamily="34" charset="-122"/>
-                <a:cs typeface="Helvetica" pitchFamily="34" charset="-120"/>
+                  <a:srgbClr val="6B6560"/>
+                </a:solidFill>
+                <a:latin typeface="Arial" pitchFamily="34" charset="0"/>
+                <a:ea typeface="Arial" pitchFamily="34" charset="-122"/>
+                <a:cs typeface="Arial" pitchFamily="34" charset="-120"/>
               </a:rPr>
               <a:t>- Next-Gen Frontiers: Developing quantum structures and 6G communications hardware blocks.</a:t>
             </a:r>
@@ -5549,11 +5549,11 @@
             <a:avLst/>
           </a:prstGeom>
           <a:solidFill>
-            <a:srgbClr val="121826"/>
+            <a:srgbClr val="FFFDF8"/>
           </a:solidFill>
           <a:ln w="12700">
             <a:solidFill>
-              <a:srgbClr val="505D6F"/>
+              <a:srgbClr val="E0D9D0"/>
             </a:solidFill>
             <a:prstDash val="solid"/>
           </a:ln>
@@ -5586,11 +5586,11 @@
             <a:r>
               <a:rPr lang="en-US" sz="1200" b="1" dirty="0">
                 <a:solidFill>
-                  <a:srgbClr val="00FF87"/>
-                </a:solidFill>
-                <a:latin typeface="Helvetica" pitchFamily="34" charset="0"/>
-                <a:ea typeface="Helvetica" pitchFamily="34" charset="-122"/>
-                <a:cs typeface="Helvetica" pitchFamily="34" charset="-120"/>
+                  <a:srgbClr val="768C7C"/>
+                </a:solidFill>
+                <a:latin typeface="Arial" pitchFamily="34" charset="0"/>
+                <a:ea typeface="Arial" pitchFamily="34" charset="-122"/>
+                <a:cs typeface="Arial" pitchFamily="34" charset="-120"/>
               </a:rPr>
               <a:t>NPU CORES</a:t>
             </a:r>
@@ -5625,11 +5625,11 @@
             <a:r>
               <a:rPr lang="en-US" sz="3600" b="1" dirty="0">
                 <a:solidFill>
-                  <a:srgbClr val="FFFFFF"/>
-                </a:solidFill>
-                <a:latin typeface="Helvetica" pitchFamily="34" charset="0"/>
-                <a:ea typeface="Helvetica" pitchFamily="34" charset="-122"/>
-                <a:cs typeface="Helvetica" pitchFamily="34" charset="-120"/>
+                  <a:srgbClr val="1A1714"/>
+                </a:solidFill>
+                <a:latin typeface="Georgia" pitchFamily="34" charset="0"/>
+                <a:ea typeface="Georgia" pitchFamily="34" charset="-122"/>
+                <a:cs typeface="Georgia" pitchFamily="34" charset="-120"/>
               </a:rPr>
               <a:t>Client AI</a:t>
             </a:r>
@@ -5664,11 +5664,11 @@
             <a:r>
               <a:rPr lang="en-US" sz="1500" dirty="0">
                 <a:solidFill>
-                  <a:srgbClr val="A0AEC0"/>
-                </a:solidFill>
-                <a:latin typeface="Helvetica" pitchFamily="34" charset="0"/>
-                <a:ea typeface="Helvetica" pitchFamily="34" charset="-122"/>
-                <a:cs typeface="Helvetica" pitchFamily="34" charset="-120"/>
+                  <a:srgbClr val="6B6560"/>
+                </a:solidFill>
+                <a:latin typeface="Arial" pitchFamily="34" charset="0"/>
+                <a:ea typeface="Arial" pitchFamily="34" charset="-122"/>
+                <a:cs typeface="Arial" pitchFamily="34" charset="-120"/>
               </a:rPr>
               <a:t>Standard hardware in 2026 client electronics (laptops, phones)</a:t>
             </a:r>
@@ -5690,7 +5690,7 @@
     <p:bg>
       <p:bgPr>
         <a:solidFill>
-          <a:srgbClr val="0B0F19"/>
+          <a:srgbClr val="F5F0E8"/>
         </a:solidFill>
       </p:bgPr>
     </p:bg>
@@ -5735,11 +5735,11 @@
             <a:r>
               <a:rPr lang="en-US" sz="1200" b="1" spc="150" kern="0" dirty="0">
                 <a:solidFill>
-                  <a:srgbClr val="00F2FE"/>
-                </a:solidFill>
-                <a:latin typeface="Helvetica" pitchFamily="34" charset="0"/>
-                <a:ea typeface="Helvetica" pitchFamily="34" charset="-122"/>
-                <a:cs typeface="Helvetica" pitchFamily="34" charset="-120"/>
+                  <a:srgbClr val="B84A2F"/>
+                </a:solidFill>
+                <a:latin typeface="Arial" pitchFamily="34" charset="0"/>
+                <a:ea typeface="Arial" pitchFamily="34" charset="-122"/>
+                <a:cs typeface="Arial" pitchFamily="34" charset="-120"/>
               </a:rPr>
               <a:t>SUMMARY &amp; ROADMAP</a:t>
             </a:r>
@@ -5774,11 +5774,11 @@
             <a:r>
               <a:rPr lang="en-US" sz="3200" b="1" dirty="0">
                 <a:solidFill>
-                  <a:srgbClr val="FFFFFF"/>
-                </a:solidFill>
-                <a:latin typeface="Helvetica" pitchFamily="34" charset="0"/>
-                <a:ea typeface="Helvetica" pitchFamily="34" charset="-122"/>
-                <a:cs typeface="Helvetica" pitchFamily="34" charset="-120"/>
+                  <a:srgbClr val="1A1714"/>
+                </a:solidFill>
+                <a:latin typeface="Georgia" pitchFamily="34" charset="0"/>
+                <a:ea typeface="Georgia" pitchFamily="34" charset="-122"/>
+                <a:cs typeface="Georgia" pitchFamily="34" charset="-120"/>
               </a:rPr>
               <a:t>Conclusion: A Silicon-Dependent Civilization</a:t>
             </a:r>
@@ -5813,11 +5813,11 @@
             <a:r>
               <a:rPr lang="en-US" sz="1000" dirty="0">
                 <a:solidFill>
-                  <a:srgbClr val="505D6F"/>
-                </a:solidFill>
-                <a:latin typeface="Helvetica" pitchFamily="34" charset="0"/>
-                <a:ea typeface="Helvetica" pitchFamily="34" charset="-122"/>
-                <a:cs typeface="Helvetica" pitchFamily="34" charset="-120"/>
+                  <a:srgbClr val="6B6560"/>
+                </a:solidFill>
+                <a:latin typeface="Arial" pitchFamily="34" charset="0"/>
+                <a:ea typeface="Arial" pitchFamily="34" charset="-122"/>
+                <a:cs typeface="Arial" pitchFamily="34" charset="-120"/>
               </a:rPr>
               <a:t>The 2026 Semiconductor Ecosystem | Slide 17</a:t>
             </a:r>
@@ -5840,11 +5840,11 @@
             <a:avLst/>
           </a:prstGeom>
           <a:solidFill>
-            <a:srgbClr val="121826"/>
+            <a:srgbClr val="FFFDF8"/>
           </a:solidFill>
           <a:ln w="19050">
             <a:solidFill>
-              <a:srgbClr val="00F2FE"/>
+              <a:srgbClr val="B84A2F"/>
             </a:solidFill>
             <a:prstDash val="solid"/>
           </a:ln>
@@ -5877,11 +5877,11 @@
             <a:r>
               <a:rPr lang="en-US" sz="1800" b="1" i="1" dirty="0">
                 <a:solidFill>
-                  <a:srgbClr val="00F2FE"/>
-                </a:solidFill>
-                <a:latin typeface="Helvetica" pitchFamily="34" charset="0"/>
-                <a:ea typeface="Helvetica" pitchFamily="34" charset="-122"/>
-                <a:cs typeface="Helvetica" pitchFamily="34" charset="-120"/>
+                  <a:srgbClr val="B84A2F"/>
+                </a:solidFill>
+                <a:latin typeface="Arial" pitchFamily="34" charset="0"/>
+                <a:ea typeface="Arial" pitchFamily="34" charset="-122"/>
+                <a:cs typeface="Arial" pitchFamily="34" charset="-120"/>
               </a:rPr>
               <a:t>Key Message: We have reached a point of "Total Silicon Dependency." The path to a $2 trillion industry is certain.</a:t>
             </a:r>
@@ -5916,11 +5916,11 @@
             <a:r>
               <a:rPr lang="en-US" sz="1800" dirty="0">
                 <a:solidFill>
-                  <a:srgbClr val="A0AEC0"/>
-                </a:solidFill>
-                <a:latin typeface="Helvetica" pitchFamily="34" charset="0"/>
-                <a:ea typeface="Helvetica" pitchFamily="34" charset="-122"/>
-                <a:cs typeface="Helvetica" pitchFamily="34" charset="-120"/>
+                  <a:srgbClr val="6B6560"/>
+                </a:solidFill>
+                <a:latin typeface="Arial" pitchFamily="34" charset="0"/>
+                <a:ea typeface="Arial" pitchFamily="34" charset="-122"/>
+                <a:cs typeface="Arial" pitchFamily="34" charset="-120"/>
               </a:rPr>
               <a:t>Mastery of the semiconductor ecosystem is mastery of the future. The "Chip Wars" aren't just about manufacturing; they are about who can best harness silicon to transform their industries.</a:t>
             </a:r>
@@ -5955,11 +5955,11 @@
             <a:r>
               <a:rPr lang="en-US" sz="1200" b="1" spc="100" kern="0" dirty="0">
                 <a:solidFill>
-                  <a:srgbClr val="FFFFFF"/>
-                </a:solidFill>
-                <a:latin typeface="Helvetica" pitchFamily="34" charset="0"/>
-                <a:ea typeface="Helvetica" pitchFamily="34" charset="-122"/>
-                <a:cs typeface="Helvetica" pitchFamily="34" charset="-120"/>
+                  <a:srgbClr val="1A1714"/>
+                </a:solidFill>
+                <a:latin typeface="Arial" pitchFamily="34" charset="0"/>
+                <a:ea typeface="Arial" pitchFamily="34" charset="-122"/>
+                <a:cs typeface="Arial" pitchFamily="34" charset="-120"/>
               </a:rPr>
               <a:t>KEY TAKEAWAYS SUMMARY</a:t>
             </a:r>
@@ -5982,11 +5982,11 @@
             <a:avLst/>
           </a:prstGeom>
           <a:solidFill>
-            <a:srgbClr val="121826"/>
+            <a:srgbClr val="FFFDF8"/>
           </a:solidFill>
           <a:ln w="12700">
             <a:solidFill>
-              <a:srgbClr val="505D6F"/>
+              <a:srgbClr val="E0D9D0"/>
             </a:solidFill>
             <a:prstDash val="solid"/>
           </a:ln>
@@ -6019,11 +6019,11 @@
             <a:r>
               <a:rPr lang="en-US" sz="2000" b="1" dirty="0">
                 <a:solidFill>
-                  <a:srgbClr val="00F2FE"/>
-                </a:solidFill>
-                <a:latin typeface="Helvetica" pitchFamily="34" charset="0"/>
-                <a:ea typeface="Helvetica" pitchFamily="34" charset="-122"/>
-                <a:cs typeface="Helvetica" pitchFamily="34" charset="-120"/>
+                  <a:srgbClr val="B84A2F"/>
+                </a:solidFill>
+                <a:latin typeface="Georgia" pitchFamily="34" charset="0"/>
+                <a:ea typeface="Georgia" pitchFamily="34" charset="-122"/>
+                <a:cs typeface="Georgia" pitchFamily="34" charset="-120"/>
               </a:rPr>
               <a:t>Procurement</a:t>
             </a:r>
@@ -6058,11 +6058,11 @@
             <a:r>
               <a:rPr lang="en-US" sz="1800" dirty="0">
                 <a:solidFill>
-                  <a:srgbClr val="A0AEC0"/>
-                </a:solidFill>
-                <a:latin typeface="Helvetica" pitchFamily="34" charset="0"/>
-                <a:ea typeface="Helvetica" pitchFamily="34" charset="-122"/>
-                <a:cs typeface="Helvetica" pitchFamily="34" charset="-120"/>
+                  <a:srgbClr val="6B6560"/>
+                </a:solidFill>
+                <a:latin typeface="Arial" pitchFamily="34" charset="0"/>
+                <a:ea typeface="Arial" pitchFamily="34" charset="-122"/>
+                <a:cs typeface="Arial" pitchFamily="34" charset="-120"/>
               </a:rPr>
               <a:t>Shift from JIT to Strategic Hybrid; resilience is the new ROI.</a:t>
             </a:r>
@@ -6085,11 +6085,11 @@
             <a:avLst/>
           </a:prstGeom>
           <a:solidFill>
-            <a:srgbClr val="121826"/>
+            <a:srgbClr val="FFFDF8"/>
           </a:solidFill>
           <a:ln w="12700">
             <a:solidFill>
-              <a:srgbClr val="505D6F"/>
+              <a:srgbClr val="E0D9D0"/>
             </a:solidFill>
             <a:prstDash val="solid"/>
           </a:ln>
@@ -6122,11 +6122,11 @@
             <a:r>
               <a:rPr lang="en-US" sz="2000" b="1" dirty="0">
                 <a:solidFill>
-                  <a:srgbClr val="C084FC"/>
-                </a:solidFill>
-                <a:latin typeface="Helvetica" pitchFamily="34" charset="0"/>
-                <a:ea typeface="Helvetica" pitchFamily="34" charset="-122"/>
-                <a:cs typeface="Helvetica" pitchFamily="34" charset="-120"/>
+                  <a:srgbClr val="9E7D84"/>
+                </a:solidFill>
+                <a:latin typeface="Georgia" pitchFamily="34" charset="0"/>
+                <a:ea typeface="Georgia" pitchFamily="34" charset="-122"/>
+                <a:cs typeface="Georgia" pitchFamily="34" charset="-120"/>
               </a:rPr>
               <a:t>Supply Chain</a:t>
             </a:r>
@@ -6161,11 +6161,11 @@
             <a:r>
               <a:rPr lang="en-US" sz="1800" dirty="0">
                 <a:solidFill>
-                  <a:srgbClr val="A0AEC0"/>
-                </a:solidFill>
-                <a:latin typeface="Helvetica" pitchFamily="34" charset="0"/>
-                <a:ea typeface="Helvetica" pitchFamily="34" charset="-122"/>
-                <a:cs typeface="Helvetica" pitchFamily="34" charset="-120"/>
+                  <a:srgbClr val="6B6560"/>
+                </a:solidFill>
+                <a:latin typeface="Arial" pitchFamily="34" charset="0"/>
+                <a:ea typeface="Arial" pitchFamily="34" charset="-122"/>
+                <a:cs typeface="Arial" pitchFamily="34" charset="-120"/>
               </a:rPr>
               <a:t>Chokepoints in Advanced Packaging and SME are the new strategic risks.</a:t>
             </a:r>
@@ -6188,11 +6188,11 @@
             <a:avLst/>
           </a:prstGeom>
           <a:solidFill>
-            <a:srgbClr val="121826"/>
+            <a:srgbClr val="FFFDF8"/>
           </a:solidFill>
           <a:ln w="12700">
             <a:solidFill>
-              <a:srgbClr val="505D6F"/>
+              <a:srgbClr val="E0D9D0"/>
             </a:solidFill>
             <a:prstDash val="solid"/>
           </a:ln>
@@ -6225,11 +6225,11 @@
             <a:r>
               <a:rPr lang="en-US" sz="2000" b="1" dirty="0">
                 <a:solidFill>
-                  <a:srgbClr val="00FF87"/>
-                </a:solidFill>
-                <a:latin typeface="Helvetica" pitchFamily="34" charset="0"/>
-                <a:ea typeface="Helvetica" pitchFamily="34" charset="-122"/>
-                <a:cs typeface="Helvetica" pitchFamily="34" charset="-120"/>
+                  <a:srgbClr val="768C7C"/>
+                </a:solidFill>
+                <a:latin typeface="Georgia" pitchFamily="34" charset="0"/>
+                <a:ea typeface="Georgia" pitchFamily="34" charset="-122"/>
+                <a:cs typeface="Georgia" pitchFamily="34" charset="-120"/>
               </a:rPr>
               <a:t>Industries</a:t>
             </a:r>
@@ -6264,11 +6264,11 @@
             <a:r>
               <a:rPr lang="en-US" sz="1800" dirty="0">
                 <a:solidFill>
-                  <a:srgbClr val="A0AEC0"/>
-                </a:solidFill>
-                <a:latin typeface="Helvetica" pitchFamily="34" charset="0"/>
-                <a:ea typeface="Helvetica" pitchFamily="34" charset="-122"/>
-                <a:cs typeface="Helvetica" pitchFamily="34" charset="-120"/>
+                  <a:srgbClr val="6B6560"/>
+                </a:solidFill>
+                <a:latin typeface="Arial" pitchFamily="34" charset="0"/>
+                <a:ea typeface="Arial" pitchFamily="34" charset="-122"/>
+                <a:cs typeface="Arial" pitchFamily="34" charset="-120"/>
               </a:rPr>
               <a:t>AI is the Value King; Automotive is the Volume King.</a:t>
             </a:r>
@@ -6290,7 +6290,7 @@
     <p:bg>
       <p:bgPr>
         <a:solidFill>
-          <a:srgbClr val="0B0F19"/>
+          <a:srgbClr val="F5F0E8"/>
         </a:solidFill>
       </p:bgPr>
     </p:bg>
@@ -6335,11 +6335,11 @@
             <a:r>
               <a:rPr lang="en-US" sz="1200" b="1" spc="150" kern="0" dirty="0">
                 <a:solidFill>
-                  <a:srgbClr val="00F2FE"/>
-                </a:solidFill>
-                <a:latin typeface="Helvetica" pitchFamily="34" charset="0"/>
-                <a:ea typeface="Helvetica" pitchFamily="34" charset="-122"/>
-                <a:cs typeface="Helvetica" pitchFamily="34" charset="-120"/>
+                  <a:srgbClr val="B84A2F"/>
+                </a:solidFill>
+                <a:latin typeface="Arial" pitchFamily="34" charset="0"/>
+                <a:ea typeface="Arial" pitchFamily="34" charset="-122"/>
+                <a:cs typeface="Arial" pitchFamily="34" charset="-120"/>
               </a:rPr>
               <a:t>PART 1: PROCUREMENT OF SEMICONDUCTORS</a:t>
             </a:r>
@@ -6374,11 +6374,11 @@
             <a:r>
               <a:rPr lang="en-US" sz="3200" b="1" dirty="0">
                 <a:solidFill>
-                  <a:srgbClr val="FFFFFF"/>
-                </a:solidFill>
-                <a:latin typeface="Helvetica" pitchFamily="34" charset="0"/>
-                <a:ea typeface="Helvetica" pitchFamily="34" charset="-122"/>
-                <a:cs typeface="Helvetica" pitchFamily="34" charset="-120"/>
+                  <a:srgbClr val="1A1714"/>
+                </a:solidFill>
+                <a:latin typeface="Georgia" pitchFamily="34" charset="0"/>
+                <a:ea typeface="Georgia" pitchFamily="34" charset="-122"/>
+                <a:cs typeface="Georgia" pitchFamily="34" charset="-120"/>
               </a:rPr>
               <a:t>Executive Summary: The Procurement Paradox</a:t>
             </a:r>
@@ -6413,11 +6413,11 @@
             <a:r>
               <a:rPr lang="en-US" sz="1000" dirty="0">
                 <a:solidFill>
-                  <a:srgbClr val="505D6F"/>
-                </a:solidFill>
-                <a:latin typeface="Helvetica" pitchFamily="34" charset="0"/>
-                <a:ea typeface="Helvetica" pitchFamily="34" charset="-122"/>
-                <a:cs typeface="Helvetica" pitchFamily="34" charset="-120"/>
+                  <a:srgbClr val="6B6560"/>
+                </a:solidFill>
+                <a:latin typeface="Arial" pitchFamily="34" charset="0"/>
+                <a:ea typeface="Arial" pitchFamily="34" charset="-122"/>
+                <a:cs typeface="Arial" pitchFamily="34" charset="-120"/>
               </a:rPr>
               <a:t>The 2026 Semiconductor Ecosystem | Slide 02</a:t>
             </a:r>
@@ -6440,11 +6440,11 @@
             <a:avLst/>
           </a:prstGeom>
           <a:solidFill>
-            <a:srgbClr val="121826"/>
+            <a:srgbClr val="FFFDF8"/>
           </a:solidFill>
           <a:ln w="19050">
             <a:solidFill>
-              <a:srgbClr val="00F2FE"/>
+              <a:srgbClr val="B84A2F"/>
             </a:solidFill>
             <a:prstDash val="solid"/>
           </a:ln>
@@ -6477,11 +6477,11 @@
             <a:r>
               <a:rPr lang="en-US" sz="1800" b="1" i="1" dirty="0">
                 <a:solidFill>
-                  <a:srgbClr val="00F2FE"/>
-                </a:solidFill>
-                <a:latin typeface="Helvetica" pitchFamily="34" charset="0"/>
-                <a:ea typeface="Helvetica" pitchFamily="34" charset="-122"/>
-                <a:cs typeface="Helvetica" pitchFamily="34" charset="-120"/>
+                  <a:srgbClr val="B84A2F"/>
+                </a:solidFill>
+                <a:latin typeface="Arial" pitchFamily="34" charset="0"/>
+                <a:ea typeface="Arial" pitchFamily="34" charset="-122"/>
+                <a:cs typeface="Arial" pitchFamily="34" charset="-120"/>
               </a:rPr>
               <a:t>Key Message: Navigating a $1.3 trillion market requires balancing unprecedented growth with systemic supply chain fragility.</a:t>
             </a:r>
@@ -6517,11 +6517,11 @@
             <a:r>
               <a:rPr lang="en-US" sz="1800" dirty="0">
                 <a:solidFill>
-                  <a:srgbClr val="A0AEC0"/>
-                </a:solidFill>
-                <a:latin typeface="Helvetica" pitchFamily="34" charset="0"/>
-                <a:ea typeface="Helvetica" pitchFamily="34" charset="-122"/>
-                <a:cs typeface="Helvetica" pitchFamily="34" charset="-120"/>
+                  <a:srgbClr val="6B6560"/>
+                </a:solidFill>
+                <a:latin typeface="Arial" pitchFamily="34" charset="0"/>
+                <a:ea typeface="Arial" pitchFamily="34" charset="-122"/>
+                <a:cs typeface="Arial" pitchFamily="34" charset="-120"/>
               </a:rPr>
               <a:t>- Record-High Valuations: Growth is driven by explosive global demand for AI systems and electric vehicle power logic.</a:t>
             </a:r>
@@ -6542,11 +6542,11 @@
             <a:r>
               <a:rPr lang="en-US" sz="1800" dirty="0">
                 <a:solidFill>
-                  <a:srgbClr val="A0AEC0"/>
-                </a:solidFill>
-                <a:latin typeface="Helvetica" pitchFamily="34" charset="0"/>
-                <a:ea typeface="Helvetica" pitchFamily="34" charset="-122"/>
-                <a:cs typeface="Helvetica" pitchFamily="34" charset="-120"/>
+                  <a:srgbClr val="6B6560"/>
+                </a:solidFill>
+                <a:latin typeface="Arial" pitchFamily="34" charset="0"/>
+                <a:ea typeface="Arial" pitchFamily="34" charset="-122"/>
+                <a:cs typeface="Arial" pitchFamily="34" charset="-120"/>
               </a:rPr>
               <a:t>- Systemic Fragility: Leading-edge fabs operate near maximum capacity, leaving the industry vulnerable to minor material delays.</a:t>
             </a:r>
@@ -6567,11 +6567,11 @@
             <a:r>
               <a:rPr lang="en-US" sz="1800" dirty="0">
                 <a:solidFill>
-                  <a:srgbClr val="A0AEC0"/>
-                </a:solidFill>
-                <a:latin typeface="Helvetica" pitchFamily="34" charset="0"/>
-                <a:ea typeface="Helvetica" pitchFamily="34" charset="-122"/>
-                <a:cs typeface="Helvetica" pitchFamily="34" charset="-120"/>
+                  <a:srgbClr val="6B6560"/>
+                </a:solidFill>
+                <a:latin typeface="Arial" pitchFamily="34" charset="0"/>
+                <a:ea typeface="Arial" pitchFamily="34" charset="-122"/>
+                <a:cs typeface="Arial" pitchFamily="34" charset="-120"/>
               </a:rPr>
               <a:t>- Strategic Pivot: Sourcing HBM (High Bandwidth Memory) and advanced logic requires a shift from transactional purchasing to capacity reservation models.</a:t>
             </a:r>
@@ -6594,11 +6594,11 @@
             <a:avLst/>
           </a:prstGeom>
           <a:solidFill>
-            <a:srgbClr val="121826"/>
+            <a:srgbClr val="FFFDF8"/>
           </a:solidFill>
           <a:ln w="12700">
             <a:solidFill>
-              <a:srgbClr val="505D6F"/>
+              <a:srgbClr val="E0D9D0"/>
             </a:solidFill>
             <a:prstDash val="solid"/>
           </a:ln>
@@ -6631,11 +6631,11 @@
             <a:r>
               <a:rPr lang="en-US" sz="1200" b="1" dirty="0">
                 <a:solidFill>
-                  <a:srgbClr val="00F2FE"/>
-                </a:solidFill>
-                <a:latin typeface="Helvetica" pitchFamily="34" charset="0"/>
-                <a:ea typeface="Helvetica" pitchFamily="34" charset="-122"/>
-                <a:cs typeface="Helvetica" pitchFamily="34" charset="-120"/>
+                  <a:srgbClr val="B84A2F"/>
+                </a:solidFill>
+                <a:latin typeface="Arial" pitchFamily="34" charset="0"/>
+                <a:ea typeface="Arial" pitchFamily="34" charset="-122"/>
+                <a:cs typeface="Arial" pitchFamily="34" charset="-120"/>
               </a:rPr>
               <a:t>ESTIMATE</a:t>
             </a:r>
@@ -6670,11 +6670,11 @@
             <a:r>
               <a:rPr lang="en-US" sz="5400" b="1" dirty="0">
                 <a:solidFill>
-                  <a:srgbClr val="FFFFFF"/>
-                </a:solidFill>
-                <a:latin typeface="Helvetica" pitchFamily="34" charset="0"/>
-                <a:ea typeface="Helvetica" pitchFamily="34" charset="-122"/>
-                <a:cs typeface="Helvetica" pitchFamily="34" charset="-120"/>
+                  <a:srgbClr val="1A1714"/>
+                </a:solidFill>
+                <a:latin typeface="Georgia" pitchFamily="34" charset="0"/>
+                <a:ea typeface="Georgia" pitchFamily="34" charset="-122"/>
+                <a:cs typeface="Georgia" pitchFamily="34" charset="-120"/>
               </a:rPr>
               <a:t>$1.3T</a:t>
             </a:r>
@@ -6709,11 +6709,11 @@
             <a:r>
               <a:rPr lang="en-US" sz="1400" dirty="0">
                 <a:solidFill>
-                  <a:srgbClr val="A0AEC0"/>
-                </a:solidFill>
-                <a:latin typeface="Helvetica" pitchFamily="34" charset="0"/>
-                <a:ea typeface="Helvetica" pitchFamily="34" charset="-122"/>
-                <a:cs typeface="Helvetica" pitchFamily="34" charset="-120"/>
+                  <a:srgbClr val="6B6560"/>
+                </a:solidFill>
+                <a:latin typeface="Arial" pitchFamily="34" charset="0"/>
+                <a:ea typeface="Arial" pitchFamily="34" charset="-122"/>
+                <a:cs typeface="Arial" pitchFamily="34" charset="-120"/>
               </a:rPr>
               <a:t>Global Market Value</a:t>
             </a:r>
@@ -6726,11 +6726,11 @@
             <a:r>
               <a:rPr lang="en-US" sz="1400" dirty="0">
                 <a:solidFill>
-                  <a:srgbClr val="A0AEC0"/>
-                </a:solidFill>
-                <a:latin typeface="Helvetica" pitchFamily="34" charset="0"/>
-                <a:ea typeface="Helvetica" pitchFamily="34" charset="-122"/>
-                <a:cs typeface="Helvetica" pitchFamily="34" charset="-120"/>
+                  <a:srgbClr val="6B6560"/>
+                </a:solidFill>
+                <a:latin typeface="Arial" pitchFamily="34" charset="0"/>
+                <a:ea typeface="Arial" pitchFamily="34" charset="-122"/>
+                <a:cs typeface="Arial" pitchFamily="34" charset="-120"/>
               </a:rPr>
               <a:t>Analyst consensus 2026</a:t>
             </a:r>
@@ -6752,7 +6752,7 @@
     <p:bg>
       <p:bgPr>
         <a:solidFill>
-          <a:srgbClr val="0B0F19"/>
+          <a:srgbClr val="F5F0E8"/>
         </a:solidFill>
       </p:bgPr>
     </p:bg>
@@ -6797,11 +6797,11 @@
             <a:r>
               <a:rPr lang="en-US" sz="1200" b="1" spc="150" kern="0" dirty="0">
                 <a:solidFill>
-                  <a:srgbClr val="00F2FE"/>
-                </a:solidFill>
-                <a:latin typeface="Helvetica" pitchFamily="34" charset="0"/>
-                <a:ea typeface="Helvetica" pitchFamily="34" charset="-122"/>
-                <a:cs typeface="Helvetica" pitchFamily="34" charset="-120"/>
+                  <a:srgbClr val="B84A2F"/>
+                </a:solidFill>
+                <a:latin typeface="Arial" pitchFamily="34" charset="0"/>
+                <a:ea typeface="Arial" pitchFamily="34" charset="-122"/>
+                <a:cs typeface="Arial" pitchFamily="34" charset="-120"/>
               </a:rPr>
               <a:t>PART 1: PROCUREMENT OF SEMICONDUCTORS</a:t>
             </a:r>
@@ -6836,11 +6836,11 @@
             <a:r>
               <a:rPr lang="en-US" sz="3200" b="1" dirty="0">
                 <a:solidFill>
-                  <a:srgbClr val="FFFFFF"/>
-                </a:solidFill>
-                <a:latin typeface="Helvetica" pitchFamily="34" charset="0"/>
-                <a:ea typeface="Helvetica" pitchFamily="34" charset="-122"/>
-                <a:cs typeface="Helvetica" pitchFamily="34" charset="-120"/>
+                  <a:srgbClr val="1A1714"/>
+                </a:solidFill>
+                <a:latin typeface="Georgia" pitchFamily="34" charset="0"/>
+                <a:ea typeface="Georgia" pitchFamily="34" charset="-122"/>
+                <a:cs typeface="Georgia" pitchFamily="34" charset="-120"/>
               </a:rPr>
               <a:t>Evolution of Procurement: The Strategic Hybrid Model</a:t>
             </a:r>
@@ -6875,11 +6875,11 @@
             <a:r>
               <a:rPr lang="en-US" sz="1000" dirty="0">
                 <a:solidFill>
-                  <a:srgbClr val="505D6F"/>
-                </a:solidFill>
-                <a:latin typeface="Helvetica" pitchFamily="34" charset="0"/>
-                <a:ea typeface="Helvetica" pitchFamily="34" charset="-122"/>
-                <a:cs typeface="Helvetica" pitchFamily="34" charset="-120"/>
+                  <a:srgbClr val="6B6560"/>
+                </a:solidFill>
+                <a:latin typeface="Arial" pitchFamily="34" charset="0"/>
+                <a:ea typeface="Arial" pitchFamily="34" charset="-122"/>
+                <a:cs typeface="Arial" pitchFamily="34" charset="-120"/>
               </a:rPr>
               <a:t>The 2026 Semiconductor Ecosystem | Slide 03</a:t>
             </a:r>
@@ -6902,11 +6902,11 @@
             <a:avLst/>
           </a:prstGeom>
           <a:solidFill>
-            <a:srgbClr val="121826"/>
+            <a:srgbClr val="FFFDF8"/>
           </a:solidFill>
           <a:ln w="19050">
             <a:solidFill>
-              <a:srgbClr val="C084FC"/>
+              <a:srgbClr val="9E7D84"/>
             </a:solidFill>
             <a:prstDash val="solid"/>
           </a:ln>
@@ -6939,11 +6939,11 @@
             <a:r>
               <a:rPr lang="en-US" sz="1800" b="1" i="1" dirty="0">
                 <a:solidFill>
-                  <a:srgbClr val="C084FC"/>
-                </a:solidFill>
-                <a:latin typeface="Helvetica" pitchFamily="34" charset="0"/>
-                <a:ea typeface="Helvetica" pitchFamily="34" charset="-122"/>
-                <a:cs typeface="Helvetica" pitchFamily="34" charset="-120"/>
+                  <a:srgbClr val="9E7D84"/>
+                </a:solidFill>
+                <a:latin typeface="Arial" pitchFamily="34" charset="0"/>
+                <a:ea typeface="Arial" pitchFamily="34" charset="-122"/>
+                <a:cs typeface="Arial" pitchFamily="34" charset="-120"/>
               </a:rPr>
               <a:t>Key Message: Pure JIT is obsolete; the new standard is a hybrid approach that prioritizes resilience for high-value nodes.</a:t>
             </a:r>
@@ -6966,11 +6966,11 @@
             <a:avLst/>
           </a:prstGeom>
           <a:solidFill>
-            <a:srgbClr val="121826"/>
+            <a:srgbClr val="FFFDF8"/>
           </a:solidFill>
           <a:ln w="12700">
             <a:solidFill>
-              <a:srgbClr val="505D6F"/>
+              <a:srgbClr val="E0D9D0"/>
             </a:solidFill>
             <a:prstDash val="solid"/>
           </a:ln>
@@ -7003,11 +7003,11 @@
             <a:r>
               <a:rPr lang="en-US" sz="2000" b="1" dirty="0">
                 <a:solidFill>
-                  <a:srgbClr val="00F2FE"/>
-                </a:solidFill>
-                <a:latin typeface="Helvetica" pitchFamily="34" charset="0"/>
-                <a:ea typeface="Helvetica" pitchFamily="34" charset="-122"/>
-                <a:cs typeface="Helvetica" pitchFamily="34" charset="-120"/>
+                  <a:srgbClr val="B84A2F"/>
+                </a:solidFill>
+                <a:latin typeface="Georgia" pitchFamily="34" charset="0"/>
+                <a:ea typeface="Georgia" pitchFamily="34" charset="-122"/>
+                <a:cs typeface="Georgia" pitchFamily="34" charset="-120"/>
               </a:rPr>
               <a:t>Lean JIT (Commoditized Nodes)</a:t>
             </a:r>
@@ -7042,11 +7042,11 @@
             <a:r>
               <a:rPr lang="en-US" sz="1800" dirty="0">
                 <a:solidFill>
-                  <a:srgbClr val="A0AEC0"/>
-                </a:solidFill>
-                <a:latin typeface="Helvetica" pitchFamily="34" charset="0"/>
-                <a:ea typeface="Helvetica" pitchFamily="34" charset="-122"/>
-                <a:cs typeface="Helvetica" pitchFamily="34" charset="-120"/>
+                  <a:srgbClr val="6B6560"/>
+                </a:solidFill>
+                <a:latin typeface="Arial" pitchFamily="34" charset="0"/>
+                <a:ea typeface="Arial" pitchFamily="34" charset="-122"/>
+                <a:cs typeface="Arial" pitchFamily="34" charset="-120"/>
               </a:rPr>
               <a:t>Used for standardized legacy passive elements and commoditized logic chips. Minimizes capital lock-up and inventory holding costs while keeping storage footprint low.</a:t>
             </a:r>
@@ -7069,11 +7069,11 @@
             <a:avLst/>
           </a:prstGeom>
           <a:solidFill>
-            <a:srgbClr val="121826"/>
+            <a:srgbClr val="FFFDF8"/>
           </a:solidFill>
           <a:ln w="12700">
             <a:solidFill>
-              <a:srgbClr val="505D6F"/>
+              <a:srgbClr val="E0D9D0"/>
             </a:solidFill>
             <a:prstDash val="solid"/>
           </a:ln>
@@ -7106,11 +7106,11 @@
             <a:r>
               <a:rPr lang="en-US" sz="2000" b="1" dirty="0">
                 <a:solidFill>
-                  <a:srgbClr val="C084FC"/>
-                </a:solidFill>
-                <a:latin typeface="Helvetica" pitchFamily="34" charset="0"/>
-                <a:ea typeface="Helvetica" pitchFamily="34" charset="-122"/>
-                <a:cs typeface="Helvetica" pitchFamily="34" charset="-120"/>
+                  <a:srgbClr val="9E7D84"/>
+                </a:solidFill>
+                <a:latin typeface="Georgia" pitchFamily="34" charset="0"/>
+                <a:ea typeface="Georgia" pitchFamily="34" charset="-122"/>
+                <a:cs typeface="Georgia" pitchFamily="34" charset="-120"/>
               </a:rPr>
               <a:t>Strategic Buffers (Critical Nodes)</a:t>
             </a:r>
@@ -7145,11 +7145,11 @@
             <a:r>
               <a:rPr lang="en-US" sz="1800" dirty="0">
                 <a:solidFill>
-                  <a:srgbClr val="A0AEC0"/>
-                </a:solidFill>
-                <a:latin typeface="Helvetica" pitchFamily="34" charset="0"/>
-                <a:ea typeface="Helvetica" pitchFamily="34" charset="-122"/>
-                <a:cs typeface="Helvetica" pitchFamily="34" charset="-120"/>
+                  <a:srgbClr val="6B6560"/>
+                </a:solidFill>
+                <a:latin typeface="Arial" pitchFamily="34" charset="0"/>
+                <a:ea typeface="Arial" pitchFamily="34" charset="-122"/>
+                <a:cs typeface="Arial" pitchFamily="34" charset="-120"/>
               </a:rPr>
               <a:t>Maintaining 3 to 6 months of safety stock for sole-sourced, high-margin microcomponents (HBM, custom GPUs) to guarantee manufacturing continuity.</a:t>
             </a:r>
@@ -7171,7 +7171,7 @@
     <p:bg>
       <p:bgPr>
         <a:solidFill>
-          <a:srgbClr val="0B0F19"/>
+          <a:srgbClr val="F5F0E8"/>
         </a:solidFill>
       </p:bgPr>
     </p:bg>
@@ -7216,11 +7216,11 @@
             <a:r>
               <a:rPr lang="en-US" sz="1200" b="1" spc="150" kern="0" dirty="0">
                 <a:solidFill>
-                  <a:srgbClr val="00F2FE"/>
-                </a:solidFill>
-                <a:latin typeface="Helvetica" pitchFamily="34" charset="0"/>
-                <a:ea typeface="Helvetica" pitchFamily="34" charset="-122"/>
-                <a:cs typeface="Helvetica" pitchFamily="34" charset="-120"/>
+                  <a:srgbClr val="B84A2F"/>
+                </a:solidFill>
+                <a:latin typeface="Arial" pitchFamily="34" charset="0"/>
+                <a:ea typeface="Arial" pitchFamily="34" charset="-122"/>
+                <a:cs typeface="Arial" pitchFamily="34" charset="-120"/>
               </a:rPr>
               <a:t>PART 1: PROCUREMENT OF SEMICONDUCTORS</a:t>
             </a:r>
@@ -7255,11 +7255,11 @@
             <a:r>
               <a:rPr lang="en-US" sz="3200" b="1" dirty="0">
                 <a:solidFill>
-                  <a:srgbClr val="FFFFFF"/>
-                </a:solidFill>
-                <a:latin typeface="Helvetica" pitchFamily="34" charset="0"/>
-                <a:ea typeface="Helvetica" pitchFamily="34" charset="-122"/>
-                <a:cs typeface="Helvetica" pitchFamily="34" charset="-120"/>
+                  <a:srgbClr val="1A1714"/>
+                </a:solidFill>
+                <a:latin typeface="Georgia" pitchFamily="34" charset="0"/>
+                <a:ea typeface="Georgia" pitchFamily="34" charset="-122"/>
+                <a:cs typeface="Georgia" pitchFamily="34" charset="-120"/>
               </a:rPr>
               <a:t>Key Procurement Challenges &amp; Strategic Sourcing</a:t>
             </a:r>
@@ -7294,11 +7294,11 @@
             <a:r>
               <a:rPr lang="en-US" sz="1000" dirty="0">
                 <a:solidFill>
-                  <a:srgbClr val="505D6F"/>
-                </a:solidFill>
-                <a:latin typeface="Helvetica" pitchFamily="34" charset="0"/>
-                <a:ea typeface="Helvetica" pitchFamily="34" charset="-122"/>
-                <a:cs typeface="Helvetica" pitchFamily="34" charset="-120"/>
+                  <a:srgbClr val="6B6560"/>
+                </a:solidFill>
+                <a:latin typeface="Arial" pitchFamily="34" charset="0"/>
+                <a:ea typeface="Arial" pitchFamily="34" charset="-122"/>
+                <a:cs typeface="Arial" pitchFamily="34" charset="-120"/>
               </a:rPr>
               <a:t>The 2026 Semiconductor Ecosystem | Slide 04</a:t>
             </a:r>
@@ -7321,11 +7321,11 @@
             <a:avLst/>
           </a:prstGeom>
           <a:solidFill>
-            <a:srgbClr val="121826"/>
+            <a:srgbClr val="FFFDF8"/>
           </a:solidFill>
           <a:ln w="19050">
             <a:solidFill>
-              <a:srgbClr val="00FF87"/>
+              <a:srgbClr val="768C7C"/>
             </a:solidFill>
             <a:prstDash val="solid"/>
           </a:ln>
@@ -7358,11 +7358,11 @@
             <a:r>
               <a:rPr lang="en-US" sz="1800" b="1" i="1" dirty="0">
                 <a:solidFill>
-                  <a:srgbClr val="00FF87"/>
-                </a:solidFill>
-                <a:latin typeface="Helvetica" pitchFamily="34" charset="0"/>
-                <a:ea typeface="Helvetica" pitchFamily="34" charset="-122"/>
-                <a:cs typeface="Helvetica" pitchFamily="34" charset="-120"/>
+                  <a:srgbClr val="768C7C"/>
+                </a:solidFill>
+                <a:latin typeface="Arial" pitchFamily="34" charset="0"/>
+                <a:ea typeface="Arial" pitchFamily="34" charset="-122"/>
+                <a:cs typeface="Arial" pitchFamily="34" charset="-120"/>
               </a:rPr>
               <a:t>Key Message: Data opacity and reactive risk management are the primary enemies of a resilient procurement strategy.</a:t>
             </a:r>
@@ -7398,11 +7398,11 @@
             <a:r>
               <a:rPr lang="en-US" sz="1800" dirty="0">
                 <a:solidFill>
-                  <a:srgbClr val="A0AEC0"/>
-                </a:solidFill>
-                <a:latin typeface="Helvetica" pitchFamily="34" charset="0"/>
-                <a:ea typeface="Helvetica" pitchFamily="34" charset="-122"/>
-                <a:cs typeface="Helvetica" pitchFamily="34" charset="-120"/>
+                  <a:srgbClr val="6B6560"/>
+                </a:solidFill>
+                <a:latin typeface="Arial" pitchFamily="34" charset="0"/>
+                <a:ea typeface="Arial" pitchFamily="34" charset="-122"/>
+                <a:cs typeface="Arial" pitchFamily="34" charset="-120"/>
               </a:rPr>
               <a:t>- Category Management Sourcing: Slicing procurement into precise technology nodes (Leading-edge sub-7nm vs Legacy nodes).</a:t>
             </a:r>
@@ -7423,11 +7423,11 @@
             <a:r>
               <a:rPr lang="en-US" sz="1800" dirty="0">
                 <a:solidFill>
-                  <a:srgbClr val="A0AEC0"/>
-                </a:solidFill>
-                <a:latin typeface="Helvetica" pitchFamily="34" charset="0"/>
-                <a:ea typeface="Helvetica" pitchFamily="34" charset="-122"/>
-                <a:cs typeface="Helvetica" pitchFamily="34" charset="-120"/>
+                  <a:srgbClr val="6B6560"/>
+                </a:solidFill>
+                <a:latin typeface="Arial" pitchFamily="34" charset="0"/>
+                <a:ea typeface="Arial" pitchFamily="34" charset="-122"/>
+                <a:cs typeface="Arial" pitchFamily="34" charset="-120"/>
               </a:rPr>
               <a:t>- Leading-edge Sourcing: Focuses on deep co-development partnerships, engineering collaboration, and long-term volume commitments.</a:t>
             </a:r>
@@ -7448,11 +7448,11 @@
             <a:r>
               <a:rPr lang="en-US" sz="1800" dirty="0">
                 <a:solidFill>
-                  <a:srgbClr val="A0AEC0"/>
-                </a:solidFill>
-                <a:latin typeface="Helvetica" pitchFamily="34" charset="0"/>
-                <a:ea typeface="Helvetica" pitchFamily="34" charset="-122"/>
-                <a:cs typeface="Helvetica" pitchFamily="34" charset="-120"/>
+                  <a:srgbClr val="6B6560"/>
+                </a:solidFill>
+                <a:latin typeface="Arial" pitchFamily="34" charset="0"/>
+                <a:ea typeface="Arial" pitchFamily="34" charset="-122"/>
+                <a:cs typeface="Arial" pitchFamily="34" charset="-120"/>
               </a:rPr>
               <a:t>- Legacy Sourcing: Emphasizes multi-sourcing, second-sourcing qualification, and legacy lifecycle management to offset obsolescence.</a:t>
             </a:r>
@@ -7475,11 +7475,11 @@
             <a:avLst/>
           </a:prstGeom>
           <a:solidFill>
-            <a:srgbClr val="121826"/>
+            <a:srgbClr val="FFFDF8"/>
           </a:solidFill>
           <a:ln w="12700">
             <a:solidFill>
-              <a:srgbClr val="00FF87"/>
+              <a:srgbClr val="768C7C"/>
             </a:solidFill>
             <a:prstDash val="solid"/>
           </a:ln>
@@ -7512,11 +7512,11 @@
             <a:r>
               <a:rPr lang="en-US" sz="1600" dirty="0">
                 <a:solidFill>
-                  <a:srgbClr val="A0AEC0"/>
-                </a:solidFill>
-                <a:latin typeface="Helvetica" pitchFamily="34" charset="0"/>
-                <a:ea typeface="Helvetica" pitchFamily="34" charset="-122"/>
-                <a:cs typeface="Helvetica" pitchFamily="34" charset="-120"/>
+                  <a:srgbClr val="6B6560"/>
+                </a:solidFill>
+                <a:latin typeface="Arial" pitchFamily="34" charset="0"/>
+                <a:ea typeface="Arial" pitchFamily="34" charset="-122"/>
+                <a:cs typeface="Arial" pitchFamily="34" charset="-120"/>
               </a:rPr>
               <a:t>Leading-Edge Nodes</a:t>
             </a:r>
@@ -7535,11 +7535,11 @@
             <a:r>
               <a:rPr lang="en-US" sz="1600" dirty="0">
                 <a:solidFill>
-                  <a:srgbClr val="A0AEC0"/>
-                </a:solidFill>
-                <a:latin typeface="Helvetica" pitchFamily="34" charset="0"/>
-                <a:ea typeface="Helvetica" pitchFamily="34" charset="-122"/>
-                <a:cs typeface="Helvetica" pitchFamily="34" charset="-120"/>
+                  <a:srgbClr val="6B6560"/>
+                </a:solidFill>
+                <a:latin typeface="Arial" pitchFamily="34" charset="0"/>
+                <a:ea typeface="Arial" pitchFamily="34" charset="-122"/>
+                <a:cs typeface="Arial" pitchFamily="34" charset="-120"/>
               </a:rPr>
               <a:t>Focus: Deep alliances, R&amp;D partnerships, capacity reservations.</a:t>
             </a:r>
@@ -7562,11 +7562,11 @@
             <a:avLst/>
           </a:prstGeom>
           <a:solidFill>
-            <a:srgbClr val="121826"/>
+            <a:srgbClr val="FFFDF8"/>
           </a:solidFill>
           <a:ln w="12700">
             <a:solidFill>
-              <a:srgbClr val="FBBF24"/>
+              <a:srgbClr val="B08E66"/>
             </a:solidFill>
             <a:prstDash val="solid"/>
           </a:ln>
@@ -7599,11 +7599,11 @@
             <a:r>
               <a:rPr lang="en-US" sz="1600" dirty="0">
                 <a:solidFill>
-                  <a:srgbClr val="A0AEC0"/>
-                </a:solidFill>
-                <a:latin typeface="Helvetica" pitchFamily="34" charset="0"/>
-                <a:ea typeface="Helvetica" pitchFamily="34" charset="-122"/>
-                <a:cs typeface="Helvetica" pitchFamily="34" charset="-120"/>
+                  <a:srgbClr val="6B6560"/>
+                </a:solidFill>
+                <a:latin typeface="Arial" pitchFamily="34" charset="0"/>
+                <a:ea typeface="Arial" pitchFamily="34" charset="-122"/>
+                <a:cs typeface="Arial" pitchFamily="34" charset="-120"/>
               </a:rPr>
               <a:t>Legacy Nodes</a:t>
             </a:r>
@@ -7622,11 +7622,11 @@
             <a:r>
               <a:rPr lang="en-US" sz="1600" dirty="0">
                 <a:solidFill>
-                  <a:srgbClr val="A0AEC0"/>
-                </a:solidFill>
-                <a:latin typeface="Helvetica" pitchFamily="34" charset="0"/>
-                <a:ea typeface="Helvetica" pitchFamily="34" charset="-122"/>
-                <a:cs typeface="Helvetica" pitchFamily="34" charset="-120"/>
+                  <a:srgbClr val="6B6560"/>
+                </a:solidFill>
+                <a:latin typeface="Arial" pitchFamily="34" charset="0"/>
+                <a:ea typeface="Arial" pitchFamily="34" charset="-122"/>
+                <a:cs typeface="Arial" pitchFamily="34" charset="-120"/>
               </a:rPr>
               <a:t>Focus: Multi-sourcing, distributor networks, life-cycle tracking.</a:t>
             </a:r>
@@ -7648,7 +7648,7 @@
     <p:bg>
       <p:bgPr>
         <a:solidFill>
-          <a:srgbClr val="0B0F19"/>
+          <a:srgbClr val="F5F0E8"/>
         </a:solidFill>
       </p:bgPr>
     </p:bg>
@@ -7693,11 +7693,11 @@
             <a:r>
               <a:rPr lang="en-US" sz="1200" b="1" spc="150" kern="0" dirty="0">
                 <a:solidFill>
-                  <a:srgbClr val="00F2FE"/>
-                </a:solidFill>
-                <a:latin typeface="Helvetica" pitchFamily="34" charset="0"/>
-                <a:ea typeface="Helvetica" pitchFamily="34" charset="-122"/>
-                <a:cs typeface="Helvetica" pitchFamily="34" charset="-120"/>
+                  <a:srgbClr val="B84A2F"/>
+                </a:solidFill>
+                <a:latin typeface="Arial" pitchFamily="34" charset="0"/>
+                <a:ea typeface="Arial" pitchFamily="34" charset="-122"/>
+                <a:cs typeface="Arial" pitchFamily="34" charset="-120"/>
               </a:rPr>
               <a:t>PART 1: PROCUREMENT OF SEMICONDUCTORS</a:t>
             </a:r>
@@ -7732,11 +7732,11 @@
             <a:r>
               <a:rPr lang="en-US" sz="3200" b="1" dirty="0">
                 <a:solidFill>
-                  <a:srgbClr val="FFFFFF"/>
-                </a:solidFill>
-                <a:latin typeface="Helvetica" pitchFamily="34" charset="0"/>
-                <a:ea typeface="Helvetica" pitchFamily="34" charset="-122"/>
-                <a:cs typeface="Helvetica" pitchFamily="34" charset="-120"/>
+                  <a:srgbClr val="1A1714"/>
+                </a:solidFill>
+                <a:latin typeface="Georgia" pitchFamily="34" charset="0"/>
+                <a:ea typeface="Georgia" pitchFamily="34" charset="-122"/>
+                <a:cs typeface="Georgia" pitchFamily="34" charset="-120"/>
               </a:rPr>
               <a:t>Digitalization &amp; Resilience in Procurement</a:t>
             </a:r>
@@ -7771,11 +7771,11 @@
             <a:r>
               <a:rPr lang="en-US" sz="1000" dirty="0">
                 <a:solidFill>
-                  <a:srgbClr val="505D6F"/>
-                </a:solidFill>
-                <a:latin typeface="Helvetica" pitchFamily="34" charset="0"/>
-                <a:ea typeface="Helvetica" pitchFamily="34" charset="-122"/>
-                <a:cs typeface="Helvetica" pitchFamily="34" charset="-120"/>
+                  <a:srgbClr val="6B6560"/>
+                </a:solidFill>
+                <a:latin typeface="Arial" pitchFamily="34" charset="0"/>
+                <a:ea typeface="Arial" pitchFamily="34" charset="-122"/>
+                <a:cs typeface="Arial" pitchFamily="34" charset="-120"/>
               </a:rPr>
               <a:t>The 2026 Semiconductor Ecosystem | Slide 05</a:t>
             </a:r>
@@ -7798,11 +7798,11 @@
             <a:avLst/>
           </a:prstGeom>
           <a:solidFill>
-            <a:srgbClr val="121826"/>
+            <a:srgbClr val="FFFDF8"/>
           </a:solidFill>
           <a:ln w="19050">
             <a:solidFill>
-              <a:srgbClr val="00F2FE"/>
+              <a:srgbClr val="B84A2F"/>
             </a:solidFill>
             <a:prstDash val="solid"/>
           </a:ln>
@@ -7835,11 +7835,11 @@
             <a:r>
               <a:rPr lang="en-US" sz="1800" b="1" i="1" dirty="0">
                 <a:solidFill>
-                  <a:srgbClr val="00F2FE"/>
-                </a:solidFill>
-                <a:latin typeface="Helvetica" pitchFamily="34" charset="0"/>
-                <a:ea typeface="Helvetica" pitchFamily="34" charset="-122"/>
-                <a:cs typeface="Helvetica" pitchFamily="34" charset="-120"/>
+                  <a:srgbClr val="B84A2F"/>
+                </a:solidFill>
+                <a:latin typeface="Arial" pitchFamily="34" charset="0"/>
+                <a:ea typeface="Arial" pitchFamily="34" charset="-122"/>
+                <a:cs typeface="Arial" pitchFamily="34" charset="-120"/>
               </a:rPr>
               <a:t>Key Message: AI-driven "Business Intelligence Cockpits" are essential for predicting shortages 6-12 months in advance.</a:t>
             </a:r>
@@ -7862,11 +7862,11 @@
             <a:avLst/>
           </a:prstGeom>
           <a:solidFill>
-            <a:srgbClr val="121826"/>
+            <a:srgbClr val="FFFDF8"/>
           </a:solidFill>
           <a:ln w="12700">
             <a:solidFill>
-              <a:srgbClr val="505D6F"/>
+              <a:srgbClr val="E0D9D0"/>
             </a:solidFill>
             <a:prstDash val="solid"/>
           </a:ln>
@@ -7899,11 +7899,11 @@
             <a:r>
               <a:rPr lang="en-US" sz="2000" b="1" dirty="0">
                 <a:solidFill>
-                  <a:srgbClr val="00F2FE"/>
-                </a:solidFill>
-                <a:latin typeface="Helvetica" pitchFamily="34" charset="0"/>
-                <a:ea typeface="Helvetica" pitchFamily="34" charset="-122"/>
-                <a:cs typeface="Helvetica" pitchFamily="34" charset="-120"/>
+                  <a:srgbClr val="B84A2F"/>
+                </a:solidFill>
+                <a:latin typeface="Georgia" pitchFamily="34" charset="0"/>
+                <a:ea typeface="Georgia" pitchFamily="34" charset="-122"/>
+                <a:cs typeface="Georgia" pitchFamily="34" charset="-120"/>
               </a:rPr>
               <a:t>LTA &amp; Reservation Fees</a:t>
             </a:r>
@@ -7938,11 +7938,11 @@
             <a:r>
               <a:rPr lang="en-US" sz="1800" dirty="0">
                 <a:solidFill>
-                  <a:srgbClr val="A0AEC0"/>
-                </a:solidFill>
-                <a:latin typeface="Helvetica" pitchFamily="34" charset="0"/>
-                <a:ea typeface="Helvetica" pitchFamily="34" charset="-122"/>
-                <a:cs typeface="Helvetica" pitchFamily="34" charset="-120"/>
+                  <a:srgbClr val="6B6560"/>
+                </a:solidFill>
+                <a:latin typeface="Arial" pitchFamily="34" charset="0"/>
+                <a:ea typeface="Arial" pitchFamily="34" charset="-122"/>
+                <a:cs typeface="Arial" pitchFamily="34" charset="-120"/>
               </a:rPr>
               <a:t>Securing fab slots requires upfront reservation fees and take-or-pay clauses in Long-Term Agreements (LTAs) to lock down volume.</a:t>
             </a:r>
@@ -7965,11 +7965,11 @@
             <a:avLst/>
           </a:prstGeom>
           <a:solidFill>
-            <a:srgbClr val="121826"/>
+            <a:srgbClr val="FFFDF8"/>
           </a:solidFill>
           <a:ln w="12700">
             <a:solidFill>
-              <a:srgbClr val="505D6F"/>
+              <a:srgbClr val="E0D9D0"/>
             </a:solidFill>
             <a:prstDash val="solid"/>
           </a:ln>
@@ -8002,11 +8002,11 @@
             <a:r>
               <a:rPr lang="en-US" sz="2000" b="1" dirty="0">
                 <a:solidFill>
-                  <a:srgbClr val="00FF87"/>
-                </a:solidFill>
-                <a:latin typeface="Helvetica" pitchFamily="34" charset="0"/>
-                <a:ea typeface="Helvetica" pitchFamily="34" charset="-122"/>
-                <a:cs typeface="Helvetica" pitchFamily="34" charset="-120"/>
+                  <a:srgbClr val="768C7C"/>
+                </a:solidFill>
+                <a:latin typeface="Georgia" pitchFamily="34" charset="0"/>
+                <a:ea typeface="Georgia" pitchFamily="34" charset="-122"/>
+                <a:cs typeface="Georgia" pitchFamily="34" charset="-120"/>
               </a:rPr>
               <a:t>Friend-Shoring Sourcing</a:t>
             </a:r>
@@ -8041,11 +8041,11 @@
             <a:r>
               <a:rPr lang="en-US" sz="1800" dirty="0">
                 <a:solidFill>
-                  <a:srgbClr val="A0AEC0"/>
-                </a:solidFill>
-                <a:latin typeface="Helvetica" pitchFamily="34" charset="0"/>
-                <a:ea typeface="Helvetica" pitchFamily="34" charset="-122"/>
-                <a:cs typeface="Helvetica" pitchFamily="34" charset="-120"/>
+                  <a:srgbClr val="6B6560"/>
+                </a:solidFill>
+                <a:latin typeface="Arial" pitchFamily="34" charset="0"/>
+                <a:ea typeface="Arial" pitchFamily="34" charset="-122"/>
+                <a:cs typeface="Arial" pitchFamily="34" charset="-120"/>
               </a:rPr>
               <a:t>Decoupling supply links from high-risk locations, redirecting procurement to allied geopolitical nodes with guaranteed supply lines.</a:t>
             </a:r>
@@ -8068,11 +8068,11 @@
             <a:avLst/>
           </a:prstGeom>
           <a:solidFill>
-            <a:srgbClr val="121826"/>
+            <a:srgbClr val="FFFDF8"/>
           </a:solidFill>
           <a:ln w="12700">
             <a:solidFill>
-              <a:srgbClr val="00F2FE"/>
+              <a:srgbClr val="B84A2F"/>
             </a:solidFill>
             <a:prstDash val="solid"/>
           </a:ln>
@@ -8105,11 +8105,11 @@
             <a:r>
               <a:rPr lang="en-US" sz="1500" dirty="0">
                 <a:solidFill>
-                  <a:srgbClr val="A0AEC0"/>
-                </a:solidFill>
-                <a:latin typeface="Helvetica" pitchFamily="34" charset="0"/>
-                <a:ea typeface="Helvetica" pitchFamily="34" charset="-122"/>
-                <a:cs typeface="Helvetica" pitchFamily="34" charset="-120"/>
+                  <a:srgbClr val="6B6560"/>
+                </a:solidFill>
+                <a:latin typeface="Arial" pitchFamily="34" charset="0"/>
+                <a:ea typeface="Arial" pitchFamily="34" charset="-122"/>
+                <a:cs typeface="Arial" pitchFamily="34" charset="-120"/>
               </a:rPr>
               <a:t>AI integration automatically tracks tier-2 chemical and substrate suppliers to detect factory closures or export blocks before they ripple into final fab allocations.</a:t>
             </a:r>
@@ -8131,7 +8131,7 @@
     <p:bg>
       <p:bgPr>
         <a:solidFill>
-          <a:srgbClr val="0B0F19"/>
+          <a:srgbClr val="F5F0E8"/>
         </a:solidFill>
       </p:bgPr>
     </p:bg>
@@ -8176,11 +8176,11 @@
             <a:r>
               <a:rPr lang="en-US" sz="1200" b="1" spc="150" kern="0" dirty="0">
                 <a:solidFill>
-                  <a:srgbClr val="00F2FE"/>
-                </a:solidFill>
-                <a:latin typeface="Helvetica" pitchFamily="34" charset="0"/>
-                <a:ea typeface="Helvetica" pitchFamily="34" charset="-122"/>
-                <a:cs typeface="Helvetica" pitchFamily="34" charset="-120"/>
+                  <a:srgbClr val="B84A2F"/>
+                </a:solidFill>
+                <a:latin typeface="Arial" pitchFamily="34" charset="0"/>
+                <a:ea typeface="Arial" pitchFamily="34" charset="-122"/>
+                <a:cs typeface="Arial" pitchFamily="34" charset="-120"/>
               </a:rPr>
               <a:t>PART 2: THE GLOBAL SUPPLY CHAIN OF SEMICONDUCTORS</a:t>
             </a:r>
@@ -8215,11 +8215,11 @@
             <a:r>
               <a:rPr lang="en-US" sz="3200" b="1" dirty="0">
                 <a:solidFill>
-                  <a:srgbClr val="FFFFFF"/>
-                </a:solidFill>
-                <a:latin typeface="Helvetica" pitchFamily="34" charset="0"/>
-                <a:ea typeface="Helvetica" pitchFamily="34" charset="-122"/>
-                <a:cs typeface="Helvetica" pitchFamily="34" charset="-120"/>
+                  <a:srgbClr val="1A1714"/>
+                </a:solidFill>
+                <a:latin typeface="Georgia" pitchFamily="34" charset="0"/>
+                <a:ea typeface="Georgia" pitchFamily="34" charset="-122"/>
+                <a:cs typeface="Georgia" pitchFamily="34" charset="-120"/>
               </a:rPr>
               <a:t>The Global Supply Chain: A Web of Complexity</a:t>
             </a:r>
@@ -8254,11 +8254,11 @@
             <a:r>
               <a:rPr lang="en-US" sz="1000" dirty="0">
                 <a:solidFill>
-                  <a:srgbClr val="505D6F"/>
-                </a:solidFill>
-                <a:latin typeface="Helvetica" pitchFamily="34" charset="0"/>
-                <a:ea typeface="Helvetica" pitchFamily="34" charset="-122"/>
-                <a:cs typeface="Helvetica" pitchFamily="34" charset="-120"/>
+                  <a:srgbClr val="6B6560"/>
+                </a:solidFill>
+                <a:latin typeface="Arial" pitchFamily="34" charset="0"/>
+                <a:ea typeface="Arial" pitchFamily="34" charset="-122"/>
+                <a:cs typeface="Arial" pitchFamily="34" charset="-120"/>
               </a:rPr>
               <a:t>The 2026 Semiconductor Ecosystem | Slide 06</a:t>
             </a:r>
@@ -8281,11 +8281,11 @@
             <a:avLst/>
           </a:prstGeom>
           <a:solidFill>
-            <a:srgbClr val="121826"/>
+            <a:srgbClr val="FFFDF8"/>
           </a:solidFill>
           <a:ln w="19050">
             <a:solidFill>
-              <a:srgbClr val="00F2FE"/>
+              <a:srgbClr val="B84A2F"/>
             </a:solidFill>
             <a:prstDash val="solid"/>
           </a:ln>
@@ -8318,11 +8318,11 @@
             <a:r>
               <a:rPr lang="en-US" sz="1800" b="1" i="1" dirty="0">
                 <a:solidFill>
-                  <a:srgbClr val="00F2FE"/>
-                </a:solidFill>
-                <a:latin typeface="Helvetica" pitchFamily="34" charset="0"/>
-                <a:ea typeface="Helvetica" pitchFamily="34" charset="-122"/>
-                <a:cs typeface="Helvetica" pitchFamily="34" charset="-120"/>
+                  <a:srgbClr val="B84A2F"/>
+                </a:solidFill>
+                <a:latin typeface="Arial" pitchFamily="34" charset="0"/>
+                <a:ea typeface="Arial" pitchFamily="34" charset="-122"/>
+                <a:cs typeface="Arial" pitchFamily="34" charset="-120"/>
               </a:rPr>
               <a:t>Key Message: A single chip may cross international borders over 70 times, making it the most geographically dispersed value chain in history.</a:t>
             </a:r>
@@ -8357,11 +8357,11 @@
             <a:r>
               <a:rPr lang="en-US" sz="1600" b="1" dirty="0">
                 <a:solidFill>
-                  <a:srgbClr val="00FF87"/>
-                </a:solidFill>
-                <a:latin typeface="Helvetica" pitchFamily="34" charset="0"/>
-                <a:ea typeface="Helvetica" pitchFamily="34" charset="-122"/>
-                <a:cs typeface="Helvetica" pitchFamily="34" charset="-120"/>
+                  <a:srgbClr val="768C7C"/>
+                </a:solidFill>
+                <a:latin typeface="Arial" pitchFamily="34" charset="0"/>
+                <a:ea typeface="Arial" pitchFamily="34" charset="-122"/>
+                <a:cs typeface="Arial" pitchFamily="34" charset="-120"/>
               </a:rPr>
               <a:t>THE SILICON JOURNEY</a:t>
             </a:r>
@@ -8384,11 +8384,11 @@
             <a:avLst/>
           </a:prstGeom>
           <a:solidFill>
-            <a:srgbClr val="121826"/>
+            <a:srgbClr val="FFFDF8"/>
           </a:solidFill>
           <a:ln w="12700">
             <a:solidFill>
-              <a:srgbClr val="505D6F"/>
+              <a:srgbClr val="E0D9D0"/>
             </a:solidFill>
             <a:prstDash val="solid"/>
           </a:ln>
@@ -8421,11 +8421,11 @@
             <a:r>
               <a:rPr lang="en-US" sz="2400" b="1" dirty="0">
                 <a:solidFill>
-                  <a:srgbClr val="00F2FE"/>
-                </a:solidFill>
-                <a:latin typeface="Helvetica" pitchFamily="34" charset="0"/>
-                <a:ea typeface="Helvetica" pitchFamily="34" charset="-122"/>
-                <a:cs typeface="Helvetica" pitchFamily="34" charset="-120"/>
+                  <a:srgbClr val="B84A2F"/>
+                </a:solidFill>
+                <a:latin typeface="Georgia" pitchFamily="34" charset="0"/>
+                <a:ea typeface="Georgia" pitchFamily="34" charset="-122"/>
+                <a:cs typeface="Georgia" pitchFamily="34" charset="-120"/>
               </a:rPr>
               <a:t>1</a:t>
             </a:r>
@@ -8460,11 +8460,11 @@
             <a:r>
               <a:rPr lang="en-US" sz="1800" b="1" dirty="0">
                 <a:solidFill>
-                  <a:srgbClr val="FFFFFF"/>
-                </a:solidFill>
-                <a:latin typeface="Helvetica" pitchFamily="34" charset="0"/>
-                <a:ea typeface="Helvetica" pitchFamily="34" charset="-122"/>
-                <a:cs typeface="Helvetica" pitchFamily="34" charset="-120"/>
+                  <a:srgbClr val="1A1714"/>
+                </a:solidFill>
+                <a:latin typeface="Arial" pitchFamily="34" charset="0"/>
+                <a:ea typeface="Arial" pitchFamily="34" charset="-122"/>
+                <a:cs typeface="Arial" pitchFamily="34" charset="-120"/>
               </a:rPr>
               <a:t>US Design</a:t>
             </a:r>
@@ -8499,11 +8499,11 @@
             <a:r>
               <a:rPr lang="en-US" sz="1400" dirty="0">
                 <a:solidFill>
-                  <a:srgbClr val="A0AEC0"/>
-                </a:solidFill>
-                <a:latin typeface="Helvetica" pitchFamily="34" charset="0"/>
-                <a:ea typeface="Helvetica" pitchFamily="34" charset="-122"/>
-                <a:cs typeface="Helvetica" pitchFamily="34" charset="-120"/>
+                  <a:srgbClr val="6B6560"/>
+                </a:solidFill>
+                <a:latin typeface="Arial" pitchFamily="34" charset="0"/>
+                <a:ea typeface="Arial" pitchFamily="34" charset="-122"/>
+                <a:cs typeface="Arial" pitchFamily="34" charset="-120"/>
               </a:rPr>
               <a:t>Design &amp; EDA Tools</a:t>
             </a:r>
@@ -8526,11 +8526,11 @@
             <a:avLst/>
           </a:prstGeom>
           <a:solidFill>
-            <a:srgbClr val="121826"/>
+            <a:srgbClr val="FFFDF8"/>
           </a:solidFill>
           <a:ln w="12700">
             <a:solidFill>
-              <a:srgbClr val="505D6F"/>
+              <a:srgbClr val="E0D9D0"/>
             </a:solidFill>
             <a:prstDash val="solid"/>
           </a:ln>
@@ -8563,11 +8563,11 @@
             <a:r>
               <a:rPr lang="en-US" sz="2400" b="1" dirty="0">
                 <a:solidFill>
-                  <a:srgbClr val="00F2FE"/>
-                </a:solidFill>
-                <a:latin typeface="Helvetica" pitchFamily="34" charset="0"/>
-                <a:ea typeface="Helvetica" pitchFamily="34" charset="-122"/>
-                <a:cs typeface="Helvetica" pitchFamily="34" charset="-120"/>
+                  <a:srgbClr val="B84A2F"/>
+                </a:solidFill>
+                <a:latin typeface="Georgia" pitchFamily="34" charset="0"/>
+                <a:ea typeface="Georgia" pitchFamily="34" charset="-122"/>
+                <a:cs typeface="Georgia" pitchFamily="34" charset="-120"/>
               </a:rPr>
               <a:t>2</a:t>
             </a:r>
@@ -8602,11 +8602,11 @@
             <a:r>
               <a:rPr lang="en-US" sz="1800" b="1" dirty="0">
                 <a:solidFill>
-                  <a:srgbClr val="FFFFFF"/>
-                </a:solidFill>
-                <a:latin typeface="Helvetica" pitchFamily="34" charset="0"/>
-                <a:ea typeface="Helvetica" pitchFamily="34" charset="-122"/>
-                <a:cs typeface="Helvetica" pitchFamily="34" charset="-120"/>
+                  <a:srgbClr val="1A1714"/>
+                </a:solidFill>
+                <a:latin typeface="Arial" pitchFamily="34" charset="0"/>
+                <a:ea typeface="Arial" pitchFamily="34" charset="-122"/>
+                <a:cs typeface="Arial" pitchFamily="34" charset="-120"/>
               </a:rPr>
               <a:t>Dutch SME</a:t>
             </a:r>
@@ -8641,11 +8641,11 @@
             <a:r>
               <a:rPr lang="en-US" sz="1400" dirty="0">
                 <a:solidFill>
-                  <a:srgbClr val="A0AEC0"/>
-                </a:solidFill>
-                <a:latin typeface="Helvetica" pitchFamily="34" charset="0"/>
-                <a:ea typeface="Helvetica" pitchFamily="34" charset="-122"/>
-                <a:cs typeface="Helvetica" pitchFamily="34" charset="-120"/>
+                  <a:srgbClr val="6B6560"/>
+                </a:solidFill>
+                <a:latin typeface="Arial" pitchFamily="34" charset="0"/>
+                <a:ea typeface="Arial" pitchFamily="34" charset="-122"/>
+                <a:cs typeface="Arial" pitchFamily="34" charset="-120"/>
               </a:rPr>
               <a:t>ASML EUV Optics</a:t>
             </a:r>
@@ -8668,11 +8668,11 @@
             <a:avLst/>
           </a:prstGeom>
           <a:solidFill>
-            <a:srgbClr val="121826"/>
+            <a:srgbClr val="FFFDF8"/>
           </a:solidFill>
           <a:ln w="12700">
             <a:solidFill>
-              <a:srgbClr val="505D6F"/>
+              <a:srgbClr val="E0D9D0"/>
             </a:solidFill>
             <a:prstDash val="solid"/>
           </a:ln>
@@ -8705,11 +8705,11 @@
             <a:r>
               <a:rPr lang="en-US" sz="2400" b="1" dirty="0">
                 <a:solidFill>
-                  <a:srgbClr val="00F2FE"/>
-                </a:solidFill>
-                <a:latin typeface="Helvetica" pitchFamily="34" charset="0"/>
-                <a:ea typeface="Helvetica" pitchFamily="34" charset="-122"/>
-                <a:cs typeface="Helvetica" pitchFamily="34" charset="-120"/>
+                  <a:srgbClr val="B84A2F"/>
+                </a:solidFill>
+                <a:latin typeface="Georgia" pitchFamily="34" charset="0"/>
+                <a:ea typeface="Georgia" pitchFamily="34" charset="-122"/>
+                <a:cs typeface="Georgia" pitchFamily="34" charset="-120"/>
               </a:rPr>
               <a:t>3</a:t>
             </a:r>
@@ -8744,11 +8744,11 @@
             <a:r>
               <a:rPr lang="en-US" sz="1800" b="1" dirty="0">
                 <a:solidFill>
-                  <a:srgbClr val="FFFFFF"/>
-                </a:solidFill>
-                <a:latin typeface="Helvetica" pitchFamily="34" charset="0"/>
-                <a:ea typeface="Helvetica" pitchFamily="34" charset="-122"/>
-                <a:cs typeface="Helvetica" pitchFamily="34" charset="-120"/>
+                  <a:srgbClr val="1A1714"/>
+                </a:solidFill>
+                <a:latin typeface="Arial" pitchFamily="34" charset="0"/>
+                <a:ea typeface="Arial" pitchFamily="34" charset="-122"/>
+                <a:cs typeface="Arial" pitchFamily="34" charset="-120"/>
               </a:rPr>
               <a:t>Taiwan Fab</a:t>
             </a:r>
@@ -8783,11 +8783,11 @@
             <a:r>
               <a:rPr lang="en-US" sz="1400" dirty="0">
                 <a:solidFill>
-                  <a:srgbClr val="A0AEC0"/>
-                </a:solidFill>
-                <a:latin typeface="Helvetica" pitchFamily="34" charset="0"/>
-                <a:ea typeface="Helvetica" pitchFamily="34" charset="-122"/>
-                <a:cs typeface="Helvetica" pitchFamily="34" charset="-120"/>
+                  <a:srgbClr val="6B6560"/>
+                </a:solidFill>
+                <a:latin typeface="Arial" pitchFamily="34" charset="0"/>
+                <a:ea typeface="Arial" pitchFamily="34" charset="-122"/>
+                <a:cs typeface="Arial" pitchFamily="34" charset="-120"/>
               </a:rPr>
               <a:t>TSMC Printing</a:t>
             </a:r>
@@ -8810,11 +8810,11 @@
             <a:avLst/>
           </a:prstGeom>
           <a:solidFill>
-            <a:srgbClr val="121826"/>
+            <a:srgbClr val="FFFDF8"/>
           </a:solidFill>
           <a:ln w="12700">
             <a:solidFill>
-              <a:srgbClr val="505D6F"/>
+              <a:srgbClr val="E0D9D0"/>
             </a:solidFill>
             <a:prstDash val="solid"/>
           </a:ln>
@@ -8847,11 +8847,11 @@
             <a:r>
               <a:rPr lang="en-US" sz="2400" b="1" dirty="0">
                 <a:solidFill>
-                  <a:srgbClr val="00F2FE"/>
-                </a:solidFill>
-                <a:latin typeface="Helvetica" pitchFamily="34" charset="0"/>
-                <a:ea typeface="Helvetica" pitchFamily="34" charset="-122"/>
-                <a:cs typeface="Helvetica" pitchFamily="34" charset="-120"/>
+                  <a:srgbClr val="B84A2F"/>
+                </a:solidFill>
+                <a:latin typeface="Georgia" pitchFamily="34" charset="0"/>
+                <a:ea typeface="Georgia" pitchFamily="34" charset="-122"/>
+                <a:cs typeface="Georgia" pitchFamily="34" charset="-120"/>
               </a:rPr>
               <a:t>4</a:t>
             </a:r>
@@ -8886,11 +8886,11 @@
             <a:r>
               <a:rPr lang="en-US" sz="1800" b="1" dirty="0">
                 <a:solidFill>
-                  <a:srgbClr val="FFFFFF"/>
-                </a:solidFill>
-                <a:latin typeface="Helvetica" pitchFamily="34" charset="0"/>
-                <a:ea typeface="Helvetica" pitchFamily="34" charset="-122"/>
-                <a:cs typeface="Helvetica" pitchFamily="34" charset="-120"/>
+                  <a:srgbClr val="1A1714"/>
+                </a:solidFill>
+                <a:latin typeface="Arial" pitchFamily="34" charset="0"/>
+                <a:ea typeface="Arial" pitchFamily="34" charset="-122"/>
+                <a:cs typeface="Arial" pitchFamily="34" charset="-120"/>
               </a:rPr>
               <a:t>Japan Material</a:t>
             </a:r>
@@ -8925,11 +8925,11 @@
             <a:r>
               <a:rPr lang="en-US" sz="1400" dirty="0">
                 <a:solidFill>
-                  <a:srgbClr val="A0AEC0"/>
-                </a:solidFill>
-                <a:latin typeface="Helvetica" pitchFamily="34" charset="0"/>
-                <a:ea typeface="Helvetica" pitchFamily="34" charset="-122"/>
-                <a:cs typeface="Helvetica" pitchFamily="34" charset="-120"/>
+                  <a:srgbClr val="6B6560"/>
+                </a:solidFill>
+                <a:latin typeface="Arial" pitchFamily="34" charset="0"/>
+                <a:ea typeface="Arial" pitchFamily="34" charset="-122"/>
+                <a:cs typeface="Arial" pitchFamily="34" charset="-120"/>
               </a:rPr>
               <a:t>Wafers &amp; Photoresist</a:t>
             </a:r>
@@ -8952,11 +8952,11 @@
             <a:avLst/>
           </a:prstGeom>
           <a:solidFill>
-            <a:srgbClr val="121826"/>
+            <a:srgbClr val="FFFDF8"/>
           </a:solidFill>
           <a:ln w="12700">
             <a:solidFill>
-              <a:srgbClr val="505D6F"/>
+              <a:srgbClr val="E0D9D0"/>
             </a:solidFill>
             <a:prstDash val="solid"/>
           </a:ln>
@@ -8989,11 +8989,11 @@
             <a:r>
               <a:rPr lang="en-US" sz="2400" b="1" dirty="0">
                 <a:solidFill>
-                  <a:srgbClr val="00F2FE"/>
-                </a:solidFill>
-                <a:latin typeface="Helvetica" pitchFamily="34" charset="0"/>
-                <a:ea typeface="Helvetica" pitchFamily="34" charset="-122"/>
-                <a:cs typeface="Helvetica" pitchFamily="34" charset="-120"/>
+                  <a:srgbClr val="B84A2F"/>
+                </a:solidFill>
+                <a:latin typeface="Georgia" pitchFamily="34" charset="0"/>
+                <a:ea typeface="Georgia" pitchFamily="34" charset="-122"/>
+                <a:cs typeface="Georgia" pitchFamily="34" charset="-120"/>
               </a:rPr>
               <a:t>5</a:t>
             </a:r>
@@ -9028,11 +9028,11 @@
             <a:r>
               <a:rPr lang="en-US" sz="1800" b="1" dirty="0">
                 <a:solidFill>
-                  <a:srgbClr val="FFFFFF"/>
-                </a:solidFill>
-                <a:latin typeface="Helvetica" pitchFamily="34" charset="0"/>
-                <a:ea typeface="Helvetica" pitchFamily="34" charset="-122"/>
-                <a:cs typeface="Helvetica" pitchFamily="34" charset="-120"/>
+                  <a:srgbClr val="1A1714"/>
+                </a:solidFill>
+                <a:latin typeface="Arial" pitchFamily="34" charset="0"/>
+                <a:ea typeface="Arial" pitchFamily="34" charset="-122"/>
+                <a:cs typeface="Arial" pitchFamily="34" charset="-120"/>
               </a:rPr>
               <a:t>SE Asia Pack</a:t>
             </a:r>
@@ -9067,11 +9067,11 @@
             <a:r>
               <a:rPr lang="en-US" sz="1400" dirty="0">
                 <a:solidFill>
-                  <a:srgbClr val="A0AEC0"/>
-                </a:solidFill>
-                <a:latin typeface="Helvetica" pitchFamily="34" charset="0"/>
-                <a:ea typeface="Helvetica" pitchFamily="34" charset="-122"/>
-                <a:cs typeface="Helvetica" pitchFamily="34" charset="-120"/>
+                  <a:srgbClr val="6B6560"/>
+                </a:solidFill>
+                <a:latin typeface="Arial" pitchFamily="34" charset="0"/>
+                <a:ea typeface="Arial" pitchFamily="34" charset="-122"/>
+                <a:cs typeface="Arial" pitchFamily="34" charset="-120"/>
               </a:rPr>
               <a:t>OSAT Assembly</a:t>
             </a:r>
@@ -9093,7 +9093,7 @@
     <p:bg>
       <p:bgPr>
         <a:solidFill>
-          <a:srgbClr val="0B0F19"/>
+          <a:srgbClr val="F5F0E8"/>
         </a:solidFill>
       </p:bgPr>
     </p:bg>
@@ -9138,11 +9138,11 @@
             <a:r>
               <a:rPr lang="en-US" sz="1200" b="1" spc="150" kern="0" dirty="0">
                 <a:solidFill>
-                  <a:srgbClr val="00F2FE"/>
-                </a:solidFill>
-                <a:latin typeface="Helvetica" pitchFamily="34" charset="0"/>
-                <a:ea typeface="Helvetica" pitchFamily="34" charset="-122"/>
-                <a:cs typeface="Helvetica" pitchFamily="34" charset="-120"/>
+                  <a:srgbClr val="B84A2F"/>
+                </a:solidFill>
+                <a:latin typeface="Arial" pitchFamily="34" charset="0"/>
+                <a:ea typeface="Arial" pitchFamily="34" charset="-122"/>
+                <a:cs typeface="Arial" pitchFamily="34" charset="-120"/>
               </a:rPr>
               <a:t>PART 2: THE GLOBAL SUPPLY CHAIN OF SEMICONDUCTORS</a:t>
             </a:r>
@@ -9177,11 +9177,11 @@
             <a:r>
               <a:rPr lang="en-US" sz="3200" b="1" dirty="0">
                 <a:solidFill>
-                  <a:srgbClr val="FFFFFF"/>
-                </a:solidFill>
-                <a:latin typeface="Helvetica" pitchFamily="34" charset="0"/>
-                <a:ea typeface="Helvetica" pitchFamily="34" charset="-122"/>
-                <a:cs typeface="Helvetica" pitchFamily="34" charset="-120"/>
+                  <a:srgbClr val="1A1714"/>
+                </a:solidFill>
+                <a:latin typeface="Georgia" pitchFamily="34" charset="0"/>
+                <a:ea typeface="Georgia" pitchFamily="34" charset="-122"/>
+                <a:cs typeface="Georgia" pitchFamily="34" charset="-120"/>
               </a:rPr>
               <a:t>Architecture of the Global Value Chain (GVC)</a:t>
             </a:r>
@@ -9216,11 +9216,11 @@
             <a:r>
               <a:rPr lang="en-US" sz="1000" dirty="0">
                 <a:solidFill>
-                  <a:srgbClr val="505D6F"/>
-                </a:solidFill>
-                <a:latin typeface="Helvetica" pitchFamily="34" charset="0"/>
-                <a:ea typeface="Helvetica" pitchFamily="34" charset="-122"/>
-                <a:cs typeface="Helvetica" pitchFamily="34" charset="-120"/>
+                  <a:srgbClr val="6B6560"/>
+                </a:solidFill>
+                <a:latin typeface="Arial" pitchFamily="34" charset="0"/>
+                <a:ea typeface="Arial" pitchFamily="34" charset="-122"/>
+                <a:cs typeface="Arial" pitchFamily="34" charset="-120"/>
               </a:rPr>
               <a:t>The 2026 Semiconductor Ecosystem | Slide 07</a:t>
             </a:r>
@@ -9243,11 +9243,11 @@
             <a:avLst/>
           </a:prstGeom>
           <a:solidFill>
-            <a:srgbClr val="121826"/>
+            <a:srgbClr val="FFFDF8"/>
           </a:solidFill>
           <a:ln w="19050">
             <a:solidFill>
-              <a:srgbClr val="C084FC"/>
+              <a:srgbClr val="9E7D84"/>
             </a:solidFill>
             <a:prstDash val="solid"/>
           </a:ln>
@@ -9280,11 +9280,11 @@
             <a:r>
               <a:rPr lang="en-US" sz="1800" b="1" i="1" dirty="0">
                 <a:solidFill>
-                  <a:srgbClr val="C084FC"/>
-                </a:solidFill>
-                <a:latin typeface="Helvetica" pitchFamily="34" charset="0"/>
-                <a:ea typeface="Helvetica" pitchFamily="34" charset="-122"/>
-                <a:cs typeface="Helvetica" pitchFamily="34" charset="-120"/>
+                  <a:srgbClr val="9E7D84"/>
+                </a:solidFill>
+                <a:latin typeface="Arial" pitchFamily="34" charset="0"/>
+                <a:ea typeface="Arial" pitchFamily="34" charset="-122"/>
+                <a:cs typeface="Arial" pitchFamily="34" charset="-120"/>
               </a:rPr>
               <a:t>Key Message: Value is highly concentrated in specialized clusters: U.S. (Design), Europe (Equipment), and East Asia (Manufacturing).</a:t>
             </a:r>
@@ -9320,11 +9320,11 @@
             <a:r>
               <a:rPr lang="en-US" sz="1800" dirty="0">
                 <a:solidFill>
-                  <a:srgbClr val="A0AEC0"/>
-                </a:solidFill>
-                <a:latin typeface="Helvetica" pitchFamily="34" charset="0"/>
-                <a:ea typeface="Helvetica" pitchFamily="34" charset="-122"/>
-                <a:cs typeface="Helvetica" pitchFamily="34" charset="-120"/>
+                  <a:srgbClr val="6B6560"/>
+                </a:solidFill>
+                <a:latin typeface="Arial" pitchFamily="34" charset="0"/>
+                <a:ea typeface="Arial" pitchFamily="34" charset="-122"/>
+                <a:cs typeface="Arial" pitchFamily="34" charset="-120"/>
               </a:rPr>
               <a:t>- Design &amp; EDA (United States): Dominance in core processor blueprints and layout compiler systems (NVIDIA, Apple, Qualcomm).</a:t>
             </a:r>
@@ -9345,11 +9345,11 @@
             <a:r>
               <a:rPr lang="en-US" sz="1800" dirty="0">
                 <a:solidFill>
-                  <a:srgbClr val="A0AEC0"/>
-                </a:solidFill>
-                <a:latin typeface="Helvetica" pitchFamily="34" charset="0"/>
-                <a:ea typeface="Helvetica" pitchFamily="34" charset="-122"/>
-                <a:cs typeface="Helvetica" pitchFamily="34" charset="-120"/>
+                  <a:srgbClr val="6B6560"/>
+                </a:solidFill>
+                <a:latin typeface="Arial" pitchFamily="34" charset="0"/>
+                <a:ea typeface="Arial" pitchFamily="34" charset="-122"/>
+                <a:cs typeface="Arial" pitchFamily="34" charset="-120"/>
               </a:rPr>
               <a:t>- SME Equipment (Europe): Monopoly on Extreme Ultraviolet tools (ASML) required to etch sub-7nm circuit nodes.</a:t>
             </a:r>
@@ -9370,11 +9370,11 @@
             <a:r>
               <a:rPr lang="en-US" sz="1800" dirty="0">
                 <a:solidFill>
-                  <a:srgbClr val="A0AEC0"/>
-                </a:solidFill>
-                <a:latin typeface="Helvetica" pitchFamily="34" charset="0"/>
-                <a:ea typeface="Helvetica" pitchFamily="34" charset="-122"/>
-                <a:cs typeface="Helvetica" pitchFamily="34" charset="-120"/>
+                  <a:srgbClr val="6B6560"/>
+                </a:solidFill>
+                <a:latin typeface="Arial" pitchFamily="34" charset="0"/>
+                <a:ea typeface="Arial" pitchFamily="34" charset="-122"/>
+                <a:cs typeface="Arial" pitchFamily="34" charset="-120"/>
               </a:rPr>
               <a:t>- Wafer Fabrication (East Asia): TSMC (Taiwan) and Samsung (Korea) form the production base for global advanced nodes.</a:t>
             </a:r>
@@ -9397,11 +9397,11 @@
             <a:avLst/>
           </a:prstGeom>
           <a:solidFill>
-            <a:srgbClr val="121826"/>
+            <a:srgbClr val="FFFDF8"/>
           </a:solidFill>
           <a:ln w="12700">
             <a:solidFill>
-              <a:srgbClr val="00F2FE"/>
+              <a:srgbClr val="B84A2F"/>
             </a:solidFill>
             <a:prstDash val="solid"/>
           </a:ln>
@@ -9434,11 +9434,11 @@
             <a:r>
               <a:rPr lang="en-US" sz="1600" dirty="0">
                 <a:solidFill>
-                  <a:srgbClr val="A0AEC0"/>
-                </a:solidFill>
-                <a:latin typeface="Helvetica" pitchFamily="34" charset="0"/>
-                <a:ea typeface="Helvetica" pitchFamily="34" charset="-122"/>
-                <a:cs typeface="Helvetica" pitchFamily="34" charset="-120"/>
+                  <a:srgbClr val="6B6560"/>
+                </a:solidFill>
+                <a:latin typeface="Arial" pitchFamily="34" charset="0"/>
+                <a:ea typeface="Arial" pitchFamily="34" charset="-122"/>
+                <a:cs typeface="Arial" pitchFamily="34" charset="-120"/>
               </a:rPr>
               <a:t>USA: Design IP</a:t>
             </a:r>
@@ -9457,11 +9457,11 @@
             <a:r>
               <a:rPr lang="en-US" sz="1600" dirty="0">
                 <a:solidFill>
-                  <a:srgbClr val="A0AEC0"/>
-                </a:solidFill>
-                <a:latin typeface="Helvetica" pitchFamily="34" charset="0"/>
-                <a:ea typeface="Helvetica" pitchFamily="34" charset="-122"/>
-                <a:cs typeface="Helvetica" pitchFamily="34" charset="-120"/>
+                  <a:srgbClr val="6B6560"/>
+                </a:solidFill>
+                <a:latin typeface="Arial" pitchFamily="34" charset="0"/>
+                <a:ea typeface="Arial" pitchFamily="34" charset="-122"/>
+                <a:cs typeface="Arial" pitchFamily="34" charset="-120"/>
               </a:rPr>
               <a:t>80%+ market share in advanced EDA software tools.</a:t>
             </a:r>
@@ -9484,11 +9484,11 @@
             <a:avLst/>
           </a:prstGeom>
           <a:solidFill>
-            <a:srgbClr val="121826"/>
+            <a:srgbClr val="FFFDF8"/>
           </a:solidFill>
           <a:ln w="12700">
             <a:solidFill>
-              <a:srgbClr val="C084FC"/>
+              <a:srgbClr val="9E7D84"/>
             </a:solidFill>
             <a:prstDash val="solid"/>
           </a:ln>
@@ -9521,11 +9521,11 @@
             <a:r>
               <a:rPr lang="en-US" sz="1600" dirty="0">
                 <a:solidFill>
-                  <a:srgbClr val="A0AEC0"/>
-                </a:solidFill>
-                <a:latin typeface="Helvetica" pitchFamily="34" charset="0"/>
-                <a:ea typeface="Helvetica" pitchFamily="34" charset="-122"/>
-                <a:cs typeface="Helvetica" pitchFamily="34" charset="-120"/>
+                  <a:srgbClr val="6B6560"/>
+                </a:solidFill>
+                <a:latin typeface="Arial" pitchFamily="34" charset="0"/>
+                <a:ea typeface="Arial" pitchFamily="34" charset="-122"/>
+                <a:cs typeface="Arial" pitchFamily="34" charset="-120"/>
               </a:rPr>
               <a:t>ASML (EU): Lithography</a:t>
             </a:r>
@@ -9544,11 +9544,11 @@
             <a:r>
               <a:rPr lang="en-US" sz="1600" dirty="0">
                 <a:solidFill>
-                  <a:srgbClr val="A0AEC0"/>
-                </a:solidFill>
-                <a:latin typeface="Helvetica" pitchFamily="34" charset="0"/>
-                <a:ea typeface="Helvetica" pitchFamily="34" charset="-122"/>
-                <a:cs typeface="Helvetica" pitchFamily="34" charset="-120"/>
+                  <a:srgbClr val="6B6560"/>
+                </a:solidFill>
+                <a:latin typeface="Arial" pitchFamily="34" charset="0"/>
+                <a:ea typeface="Arial" pitchFamily="34" charset="-122"/>
+                <a:cs typeface="Arial" pitchFamily="34" charset="-120"/>
               </a:rPr>
               <a:t>100% monopsony on EUV printing technology.</a:t>
             </a:r>
@@ -9570,7 +9570,7 @@
     <p:bg>
       <p:bgPr>
         <a:solidFill>
-          <a:srgbClr val="0B0F19"/>
+          <a:srgbClr val="F5F0E8"/>
         </a:solidFill>
       </p:bgPr>
     </p:bg>
@@ -9615,11 +9615,11 @@
             <a:r>
               <a:rPr lang="en-US" sz="1200" b="1" spc="150" kern="0" dirty="0">
                 <a:solidFill>
-                  <a:srgbClr val="00F2FE"/>
-                </a:solidFill>
-                <a:latin typeface="Helvetica" pitchFamily="34" charset="0"/>
-                <a:ea typeface="Helvetica" pitchFamily="34" charset="-122"/>
-                <a:cs typeface="Helvetica" pitchFamily="34" charset="-120"/>
+                  <a:srgbClr val="B84A2F"/>
+                </a:solidFill>
+                <a:latin typeface="Arial" pitchFamily="34" charset="0"/>
+                <a:ea typeface="Arial" pitchFamily="34" charset="-122"/>
+                <a:cs typeface="Arial" pitchFamily="34" charset="-120"/>
               </a:rPr>
               <a:t>PART 2: THE GLOBAL SUPPLY CHAIN OF SEMICONDUCTORS</a:t>
             </a:r>
@@ -9654,11 +9654,11 @@
             <a:r>
               <a:rPr lang="en-US" sz="3200" b="1" dirty="0">
                 <a:solidFill>
-                  <a:srgbClr val="FFFFFF"/>
-                </a:solidFill>
-                <a:latin typeface="Helvetica" pitchFamily="34" charset="0"/>
-                <a:ea typeface="Helvetica" pitchFamily="34" charset="-122"/>
-                <a:cs typeface="Helvetica" pitchFamily="34" charset="-120"/>
+                  <a:srgbClr val="1A1714"/>
+                </a:solidFill>
+                <a:latin typeface="Georgia" pitchFamily="34" charset="0"/>
+                <a:ea typeface="Georgia" pitchFamily="34" charset="-122"/>
+                <a:cs typeface="Georgia" pitchFamily="34" charset="-120"/>
               </a:rPr>
               <a:t>Front-End &amp; Back-End Bottlenecks</a:t>
             </a:r>
@@ -9693,11 +9693,11 @@
             <a:r>
               <a:rPr lang="en-US" sz="1000" dirty="0">
                 <a:solidFill>
-                  <a:srgbClr val="505D6F"/>
-                </a:solidFill>
-                <a:latin typeface="Helvetica" pitchFamily="34" charset="0"/>
-                <a:ea typeface="Helvetica" pitchFamily="34" charset="-122"/>
-                <a:cs typeface="Helvetica" pitchFamily="34" charset="-120"/>
+                  <a:srgbClr val="6B6560"/>
+                </a:solidFill>
+                <a:latin typeface="Arial" pitchFamily="34" charset="0"/>
+                <a:ea typeface="Arial" pitchFamily="34" charset="-122"/>
+                <a:cs typeface="Arial" pitchFamily="34" charset="-120"/>
               </a:rPr>
               <a:t>The 2026 Semiconductor Ecosystem | Slide 08</a:t>
             </a:r>
@@ -9720,11 +9720,11 @@
             <a:avLst/>
           </a:prstGeom>
           <a:solidFill>
-            <a:srgbClr val="121826"/>
+            <a:srgbClr val="FFFDF8"/>
           </a:solidFill>
           <a:ln w="19050">
             <a:solidFill>
-              <a:srgbClr val="00FF87"/>
+              <a:srgbClr val="768C7C"/>
             </a:solidFill>
             <a:prstDash val="solid"/>
           </a:ln>
@@ -9757,11 +9757,11 @@
             <a:r>
               <a:rPr lang="en-US" sz="1800" b="1" i="1" dirty="0">
                 <a:solidFill>
-                  <a:srgbClr val="00FF87"/>
-                </a:solidFill>
-                <a:latin typeface="Helvetica" pitchFamily="34" charset="0"/>
-                <a:ea typeface="Helvetica" pitchFamily="34" charset="-122"/>
-                <a:cs typeface="Helvetica" pitchFamily="34" charset="-120"/>
+                  <a:srgbClr val="768C7C"/>
+                </a:solidFill>
+                <a:latin typeface="Arial" pitchFamily="34" charset="0"/>
+                <a:ea typeface="Arial" pitchFamily="34" charset="-122"/>
+                <a:cs typeface="Arial" pitchFamily="34" charset="-120"/>
               </a:rPr>
               <a:t>Key Message: Advanced packaging (CoWoS, 3D Stacking) is the new primary growth limiter for the AI industry.</a:t>
             </a:r>
@@ -9784,11 +9784,11 @@
             <a:avLst/>
           </a:prstGeom>
           <a:solidFill>
-            <a:srgbClr val="121826"/>
+            <a:srgbClr val="FFFDF8"/>
           </a:solidFill>
           <a:ln w="12700">
             <a:solidFill>
-              <a:srgbClr val="00F2FE"/>
+              <a:srgbClr val="B84A2F"/>
             </a:solidFill>
             <a:prstDash val="solid"/>
           </a:ln>
@@ -9821,11 +9821,11 @@
             <a:r>
               <a:rPr lang="en-US" sz="2000" b="1" dirty="0">
                 <a:solidFill>
-                  <a:srgbClr val="00F2FE"/>
-                </a:solidFill>
-                <a:latin typeface="Helvetica" pitchFamily="34" charset="0"/>
-                <a:ea typeface="Helvetica" pitchFamily="34" charset="-122"/>
-                <a:cs typeface="Helvetica" pitchFamily="34" charset="-120"/>
+                  <a:srgbClr val="B84A2F"/>
+                </a:solidFill>
+                <a:latin typeface="Georgia" pitchFamily="34" charset="0"/>
+                <a:ea typeface="Georgia" pitchFamily="34" charset="-122"/>
+                <a:cs typeface="Georgia" pitchFamily="34" charset="-120"/>
               </a:rPr>
               <a:t>Front-End: Node Scaling</a:t>
             </a:r>
@@ -9860,11 +9860,11 @@
             <a:r>
               <a:rPr lang="en-US" sz="1800" dirty="0">
                 <a:solidFill>
-                  <a:srgbClr val="A0AEC0"/>
-                </a:solidFill>
-                <a:latin typeface="Helvetica" pitchFamily="34" charset="0"/>
-                <a:ea typeface="Helvetica" pitchFamily="34" charset="-122"/>
-                <a:cs typeface="Helvetica" pitchFamily="34" charset="-120"/>
+                  <a:srgbClr val="6B6560"/>
+                </a:solidFill>
+                <a:latin typeface="Arial" pitchFamily="34" charset="0"/>
+                <a:ea typeface="Arial" pitchFamily="34" charset="-122"/>
+                <a:cs typeface="Arial" pitchFamily="34" charset="-120"/>
               </a:rPr>
               <a:t>The race for the 2nm and 1.4nm nodes continues to demand immense capital investments for wafer fabrication lines.</a:t>
             </a:r>
@@ -9887,11 +9887,11 @@
             <a:avLst/>
           </a:prstGeom>
           <a:solidFill>
-            <a:srgbClr val="121826"/>
+            <a:srgbClr val="FFFDF8"/>
           </a:solidFill>
           <a:ln w="12700">
             <a:solidFill>
-              <a:srgbClr val="00FF87"/>
+              <a:srgbClr val="768C7C"/>
             </a:solidFill>
             <a:prstDash val="solid"/>
           </a:ln>
@@ -9924,11 +9924,11 @@
             <a:r>
               <a:rPr lang="en-US" sz="2000" b="1" dirty="0">
                 <a:solidFill>
-                  <a:srgbClr val="00FF87"/>
-                </a:solidFill>
-                <a:latin typeface="Helvetica" pitchFamily="34" charset="0"/>
-                <a:ea typeface="Helvetica" pitchFamily="34" charset="-122"/>
-                <a:cs typeface="Helvetica" pitchFamily="34" charset="-120"/>
+                  <a:srgbClr val="768C7C"/>
+                </a:solidFill>
+                <a:latin typeface="Georgia" pitchFamily="34" charset="0"/>
+                <a:ea typeface="Georgia" pitchFamily="34" charset="-122"/>
+                <a:cs typeface="Georgia" pitchFamily="34" charset="-120"/>
               </a:rPr>
               <a:t>Back-End: Advanced Packaging Chokepoint</a:t>
             </a:r>
@@ -9963,11 +9963,11 @@
             <a:r>
               <a:rPr lang="en-US" sz="1800" dirty="0">
                 <a:solidFill>
-                  <a:srgbClr val="A0AEC0"/>
-                </a:solidFill>
-                <a:latin typeface="Helvetica" pitchFamily="34" charset="0"/>
-                <a:ea typeface="Helvetica" pitchFamily="34" charset="-122"/>
-                <a:cs typeface="Helvetica" pitchFamily="34" charset="-120"/>
+                  <a:srgbClr val="6B6560"/>
+                </a:solidFill>
+                <a:latin typeface="Arial" pitchFamily="34" charset="0"/>
+                <a:ea typeface="Arial" pitchFamily="34" charset="-122"/>
+                <a:cs typeface="Arial" pitchFamily="34" charset="-120"/>
               </a:rPr>
               <a:t>Integrating multiple logic dies and High Bandwidth Memory (HBM) via CoWoS interposers is more constrained than wafer printing.</a:t>
             </a:r>
@@ -9990,11 +9990,11 @@
             <a:avLst/>
           </a:prstGeom>
           <a:solidFill>
-            <a:srgbClr val="121826"/>
+            <a:srgbClr val="FFFDF8"/>
           </a:solidFill>
           <a:ln w="12700">
             <a:solidFill>
-              <a:srgbClr val="00FF87"/>
+              <a:srgbClr val="768C7C"/>
             </a:solidFill>
             <a:prstDash val="solid"/>
           </a:ln>
@@ -10027,11 +10027,11 @@
             <a:r>
               <a:rPr lang="en-US" sz="1500" dirty="0">
                 <a:solidFill>
-                  <a:srgbClr val="A0AEC0"/>
-                </a:solidFill>
-                <a:latin typeface="Helvetica" pitchFamily="34" charset="0"/>
-                <a:ea typeface="Helvetica" pitchFamily="34" charset="-122"/>
-                <a:cs typeface="Helvetica" pitchFamily="34" charset="-120"/>
+                  <a:srgbClr val="6B6560"/>
+                </a:solidFill>
+                <a:latin typeface="Arial" pitchFamily="34" charset="0"/>
+                <a:ea typeface="Arial" pitchFamily="34" charset="-122"/>
+                <a:cs typeface="Arial" pitchFamily="34" charset="-120"/>
               </a:rPr>
               <a:t>Logistics bottleneck: Reaching target AI yields depends heavily on advanced back-end capacity, not just front-end print nodes.</a:t>
             </a:r>
@@ -10053,7 +10053,7 @@
     <p:bg>
       <p:bgPr>
         <a:solidFill>
-          <a:srgbClr val="0B0F19"/>
+          <a:srgbClr val="F5F0E8"/>
         </a:solidFill>
       </p:bgPr>
     </p:bg>
@@ -10098,11 +10098,11 @@
             <a:r>
               <a:rPr lang="en-US" sz="1200" b="1" spc="150" kern="0" dirty="0">
                 <a:solidFill>
-                  <a:srgbClr val="00F2FE"/>
-                </a:solidFill>
-                <a:latin typeface="Helvetica" pitchFamily="34" charset="0"/>
-                <a:ea typeface="Helvetica" pitchFamily="34" charset="-122"/>
-                <a:cs typeface="Helvetica" pitchFamily="34" charset="-120"/>
+                  <a:srgbClr val="B84A2F"/>
+                </a:solidFill>
+                <a:latin typeface="Arial" pitchFamily="34" charset="0"/>
+                <a:ea typeface="Arial" pitchFamily="34" charset="-122"/>
+                <a:cs typeface="Arial" pitchFamily="34" charset="-120"/>
               </a:rPr>
               <a:t>PART 2: THE GLOBAL SUPPLY CHAIN OF SEMICONDUCTORS</a:t>
             </a:r>
@@ -10137,11 +10137,11 @@
             <a:r>
               <a:rPr lang="en-US" sz="3200" b="1" dirty="0">
                 <a:solidFill>
-                  <a:srgbClr val="FFFFFF"/>
-                </a:solidFill>
-                <a:latin typeface="Helvetica" pitchFamily="34" charset="0"/>
-                <a:ea typeface="Helvetica" pitchFamily="34" charset="-122"/>
-                <a:cs typeface="Helvetica" pitchFamily="34" charset="-120"/>
+                  <a:srgbClr val="1A1714"/>
+                </a:solidFill>
+                <a:latin typeface="Georgia" pitchFamily="34" charset="0"/>
+                <a:ea typeface="Georgia" pitchFamily="34" charset="-122"/>
+                <a:cs typeface="Georgia" pitchFamily="34" charset="-120"/>
               </a:rPr>
               <a:t>SME, Materials &amp; Geopolitical Fragmentation</a:t>
             </a:r>
@@ -10176,11 +10176,11 @@
             <a:r>
               <a:rPr lang="en-US" sz="1000" dirty="0">
                 <a:solidFill>
-                  <a:srgbClr val="505D6F"/>
-                </a:solidFill>
-                <a:latin typeface="Helvetica" pitchFamily="34" charset="0"/>
-                <a:ea typeface="Helvetica" pitchFamily="34" charset="-122"/>
-                <a:cs typeface="Helvetica" pitchFamily="34" charset="-120"/>
+                  <a:srgbClr val="6B6560"/>
+                </a:solidFill>
+                <a:latin typeface="Arial" pitchFamily="34" charset="0"/>
+                <a:ea typeface="Arial" pitchFamily="34" charset="-122"/>
+                <a:cs typeface="Arial" pitchFamily="34" charset="-120"/>
               </a:rPr>
               <a:t>The 2026 Semiconductor Ecosystem | Slide 09</a:t>
             </a:r>
@@ -10203,11 +10203,11 @@
             <a:avLst/>
           </a:prstGeom>
           <a:solidFill>
-            <a:srgbClr val="121826"/>
+            <a:srgbClr val="FFFDF8"/>
           </a:solidFill>
           <a:ln w="19050">
             <a:solidFill>
-              <a:srgbClr val="F43F5E"/>
+              <a:srgbClr val="B84A2F"/>
             </a:solidFill>
             <a:prstDash val="solid"/>
           </a:ln>
@@ -10240,11 +10240,11 @@
             <a:r>
               <a:rPr lang="en-US" sz="1800" b="1" i="1" dirty="0">
                 <a:solidFill>
-                  <a:srgbClr val="F43F5E"/>
-                </a:solidFill>
-                <a:latin typeface="Helvetica" pitchFamily="34" charset="0"/>
-                <a:ea typeface="Helvetica" pitchFamily="34" charset="-122"/>
-                <a:cs typeface="Helvetica" pitchFamily="34" charset="-120"/>
+                  <a:srgbClr val="B84A2F"/>
+                </a:solidFill>
+                <a:latin typeface="Arial" pitchFamily="34" charset="0"/>
+                <a:ea typeface="Arial" pitchFamily="34" charset="-122"/>
+                <a:cs typeface="Arial" pitchFamily="34" charset="-120"/>
               </a:rPr>
               <a:t>Key Message: Geopolitics has created a "Multi-Polar" silicon world, where export controls and subsidies drive regionalization.</a:t>
             </a:r>
@@ -10280,11 +10280,11 @@
             <a:r>
               <a:rPr lang="en-US" sz="1800" dirty="0">
                 <a:solidFill>
-                  <a:srgbClr val="A0AEC0"/>
-                </a:solidFill>
-                <a:latin typeface="Helvetica" pitchFamily="34" charset="0"/>
-                <a:ea typeface="Helvetica" pitchFamily="34" charset="-122"/>
-                <a:cs typeface="Helvetica" pitchFamily="34" charset="-120"/>
+                  <a:srgbClr val="6B6560"/>
+                </a:solidFill>
+                <a:latin typeface="Arial" pitchFamily="34" charset="0"/>
+                <a:ea typeface="Arial" pitchFamily="34" charset="-122"/>
+                <a:cs typeface="Arial" pitchFamily="34" charset="-120"/>
               </a:rPr>
               <a:t>- The US CHIPS Act ($52B): Funding the domestic establishment of advanced logic fabs to balance East Asian concentration.</a:t>
             </a:r>
@@ -10305,11 +10305,11 @@
             <a:r>
               <a:rPr lang="en-US" sz="1800" dirty="0">
                 <a:solidFill>
-                  <a:srgbClr val="A0AEC0"/>
-                </a:solidFill>
-                <a:latin typeface="Helvetica" pitchFamily="34" charset="0"/>
-                <a:ea typeface="Helvetica" pitchFamily="34" charset="-122"/>
-                <a:cs typeface="Helvetica" pitchFamily="34" charset="-120"/>
+                  <a:srgbClr val="6B6560"/>
+                </a:solidFill>
+                <a:latin typeface="Arial" pitchFamily="34" charset="0"/>
+                <a:ea typeface="Arial" pitchFamily="34" charset="-122"/>
+                <a:cs typeface="Arial" pitchFamily="34" charset="-120"/>
               </a:rPr>
               <a:t>- Europe &amp; China Reshoring: Multi-billion dollar state-supported programs targeting semiconductor in-sourcing.</a:t>
             </a:r>
@@ -10330,11 +10330,11 @@
             <a:r>
               <a:rPr lang="en-US" sz="1800" dirty="0">
                 <a:solidFill>
-                  <a:srgbClr val="A0AEC0"/>
-                </a:solidFill>
-                <a:latin typeface="Helvetica" pitchFamily="34" charset="0"/>
-                <a:ea typeface="Helvetica" pitchFamily="34" charset="-122"/>
-                <a:cs typeface="Helvetica" pitchFamily="34" charset="-120"/>
+                  <a:srgbClr val="6B6560"/>
+                </a:solidFill>
+                <a:latin typeface="Arial" pitchFamily="34" charset="0"/>
+                <a:ea typeface="Arial" pitchFamily="34" charset="-122"/>
+                <a:cs typeface="Arial" pitchFamily="34" charset="-120"/>
               </a:rPr>
               <a:t>- Material Chokepoints: Strict export controls placed on critical trace materials like Gallium and Germanium.</a:t>
             </a:r>
@@ -10357,11 +10357,11 @@
             <a:avLst/>
           </a:prstGeom>
           <a:solidFill>
-            <a:srgbClr val="121826"/>
+            <a:srgbClr val="FFFDF8"/>
           </a:solidFill>
           <a:ln w="12700">
             <a:solidFill>
-              <a:srgbClr val="F43F5E"/>
+              <a:srgbClr val="B84A2F"/>
             </a:solidFill>
             <a:prstDash val="solid"/>
           </a:ln>
@@ -10394,11 +10394,11 @@
             <a:r>
               <a:rPr lang="en-US" sz="1200" b="1" dirty="0">
                 <a:solidFill>
-                  <a:srgbClr val="F43F5E"/>
-                </a:solidFill>
-                <a:latin typeface="Helvetica" pitchFamily="34" charset="0"/>
-                <a:ea typeface="Helvetica" pitchFamily="34" charset="-122"/>
-                <a:cs typeface="Helvetica" pitchFamily="34" charset="-120"/>
+                  <a:srgbClr val="B84A2F"/>
+                </a:solidFill>
+                <a:latin typeface="Arial" pitchFamily="34" charset="0"/>
+                <a:ea typeface="Arial" pitchFamily="34" charset="-122"/>
+                <a:cs typeface="Arial" pitchFamily="34" charset="-120"/>
               </a:rPr>
               <a:t>CRITICAL CHOKEPOINT</a:t>
             </a:r>
@@ -10433,11 +10433,11 @@
             <a:r>
               <a:rPr lang="en-US" sz="3600" b="1" dirty="0">
                 <a:solidFill>
-                  <a:srgbClr val="FFFFFF"/>
-                </a:solidFill>
-                <a:latin typeface="Helvetica" pitchFamily="34" charset="0"/>
-                <a:ea typeface="Helvetica" pitchFamily="34" charset="-122"/>
-                <a:cs typeface="Helvetica" pitchFamily="34" charset="-120"/>
+                  <a:srgbClr val="1A1714"/>
+                </a:solidFill>
+                <a:latin typeface="Georgia" pitchFamily="34" charset="0"/>
+                <a:ea typeface="Georgia" pitchFamily="34" charset="-122"/>
+                <a:cs typeface="Georgia" pitchFamily="34" charset="-120"/>
               </a:rPr>
               <a:t>Gallium &amp;</a:t>
             </a:r>
@@ -10450,11 +10450,11 @@
             <a:r>
               <a:rPr lang="en-US" sz="3600" b="1" dirty="0">
                 <a:solidFill>
-                  <a:srgbClr val="FFFFFF"/>
-                </a:solidFill>
-                <a:latin typeface="Helvetica" pitchFamily="34" charset="0"/>
-                <a:ea typeface="Helvetica" pitchFamily="34" charset="-122"/>
-                <a:cs typeface="Helvetica" pitchFamily="34" charset="-120"/>
+                  <a:srgbClr val="1A1714"/>
+                </a:solidFill>
+                <a:latin typeface="Georgia" pitchFamily="34" charset="0"/>
+                <a:ea typeface="Georgia" pitchFamily="34" charset="-122"/>
+                <a:cs typeface="Georgia" pitchFamily="34" charset="-120"/>
               </a:rPr>
               <a:t>Germanium</a:t>
             </a:r>
@@ -10489,11 +10489,11 @@
             <a:r>
               <a:rPr lang="en-US" sz="1500" dirty="0">
                 <a:solidFill>
-                  <a:srgbClr val="A0AEC0"/>
-                </a:solidFill>
-                <a:latin typeface="Helvetica" pitchFamily="34" charset="0"/>
-                <a:ea typeface="Helvetica" pitchFamily="34" charset="-122"/>
-                <a:cs typeface="Helvetica" pitchFamily="34" charset="-120"/>
+                  <a:srgbClr val="6B6560"/>
+                </a:solidFill>
+                <a:latin typeface="Arial" pitchFamily="34" charset="0"/>
+                <a:ea typeface="Arial" pitchFamily="34" charset="-122"/>
+                <a:cs typeface="Arial" pitchFamily="34" charset="-120"/>
               </a:rPr>
               <a:t>Strict raw material export control levers</a:t>
             </a:r>

</xml_diff>

<commit_message>
Update presentation fonts to PP Mondwest and VVDS Fifties
</commit_message>
<xml_diff>
--- a/output/semiconductor-ecosystem-2026.pptx
+++ b/output/semiconductor-ecosystem-2026.pptx
@@ -2330,9 +2330,9 @@
                 <a:solidFill>
                   <a:srgbClr val="1A1714"/>
                 </a:solidFill>
-                <a:latin typeface="Georgia" pitchFamily="34" charset="0"/>
-                <a:ea typeface="Georgia" pitchFamily="34" charset="-122"/>
-                <a:cs typeface="Georgia" pitchFamily="34" charset="-120"/>
+                <a:latin typeface="PP Mondwest" pitchFamily="34" charset="0"/>
+                <a:ea typeface="PP Mondwest" pitchFamily="34" charset="-122"/>
+                <a:cs typeface="PP Mondwest" pitchFamily="34" charset="-120"/>
               </a:rPr>
               <a:t>The 2026 Semiconductor Ecosystem</a:t>
             </a:r>
@@ -2369,9 +2369,9 @@
                 <a:solidFill>
                   <a:srgbClr val="6B6560"/>
                 </a:solidFill>
-                <a:latin typeface="Arial" pitchFamily="34" charset="0"/>
-                <a:ea typeface="Arial" pitchFamily="34" charset="-122"/>
-                <a:cs typeface="Arial" pitchFamily="34" charset="-120"/>
+                <a:latin typeface="VVDS Fifties" pitchFamily="34" charset="0"/>
+                <a:ea typeface="VVDS Fifties" pitchFamily="34" charset="-122"/>
+                <a:cs typeface="VVDS Fifties" pitchFamily="34" charset="-120"/>
               </a:rPr>
               <a:t>A Strategic Briefing on Procurement, Global Supply Chains, and End-User Verticals</a:t>
             </a:r>
@@ -2428,9 +2428,9 @@
                 <a:solidFill>
                   <a:srgbClr val="6B6560"/>
                 </a:solidFill>
-                <a:latin typeface="Arial" pitchFamily="34" charset="0"/>
-                <a:ea typeface="Arial" pitchFamily="34" charset="-122"/>
-                <a:cs typeface="Arial" pitchFamily="34" charset="-120"/>
+                <a:latin typeface="VVDS Fifties" pitchFamily="34" charset="0"/>
+                <a:ea typeface="VVDS Fifties" pitchFamily="34" charset="-122"/>
+                <a:cs typeface="VVDS Fifties" pitchFamily="34" charset="-120"/>
               </a:rPr>
               <a:t>Presenter: Manus</a:t>
             </a:r>
@@ -2445,9 +2445,9 @@
                 <a:solidFill>
                   <a:srgbClr val="6B6560"/>
                 </a:solidFill>
-                <a:latin typeface="Arial" pitchFamily="34" charset="0"/>
-                <a:ea typeface="Arial" pitchFamily="34" charset="-122"/>
-                <a:cs typeface="Arial" pitchFamily="34" charset="-120"/>
+                <a:latin typeface="VVDS Fifties" pitchFamily="34" charset="0"/>
+                <a:ea typeface="VVDS Fifties" pitchFamily="34" charset="-122"/>
+                <a:cs typeface="VVDS Fifties" pitchFamily="34" charset="-120"/>
               </a:rPr>
               <a:t>Boardroom Strategic Briefing</a:t>
             </a:r>
@@ -2516,9 +2516,9 @@
                 <a:solidFill>
                   <a:srgbClr val="B84A2F"/>
                 </a:solidFill>
-                <a:latin typeface="Arial" pitchFamily="34" charset="0"/>
-                <a:ea typeface="Arial" pitchFamily="34" charset="-122"/>
-                <a:cs typeface="Arial" pitchFamily="34" charset="-120"/>
+                <a:latin typeface="VVDS Fifties" pitchFamily="34" charset="0"/>
+                <a:ea typeface="VVDS Fifties" pitchFamily="34" charset="-122"/>
+                <a:cs typeface="VVDS Fifties" pitchFamily="34" charset="-120"/>
               </a:rPr>
               <a:t>PART 2: THE GLOBAL SUPPLY CHAIN OF SEMICONDUCTORS</a:t>
             </a:r>
@@ -2555,9 +2555,9 @@
                 <a:solidFill>
                   <a:srgbClr val="1A1714"/>
                 </a:solidFill>
-                <a:latin typeface="Georgia" pitchFamily="34" charset="0"/>
-                <a:ea typeface="Georgia" pitchFamily="34" charset="-122"/>
-                <a:cs typeface="Georgia" pitchFamily="34" charset="-120"/>
+                <a:latin typeface="PP Mondwest" pitchFamily="34" charset="0"/>
+                <a:ea typeface="PP Mondwest" pitchFamily="34" charset="-122"/>
+                <a:cs typeface="PP Mondwest" pitchFamily="34" charset="-120"/>
               </a:rPr>
               <a:t>Supply Chain Resilience: Digital &amp; Circular</a:t>
             </a:r>
@@ -2594,9 +2594,9 @@
                 <a:solidFill>
                   <a:srgbClr val="6B6560"/>
                 </a:solidFill>
-                <a:latin typeface="Arial" pitchFamily="34" charset="0"/>
-                <a:ea typeface="Arial" pitchFamily="34" charset="-122"/>
-                <a:cs typeface="Arial" pitchFamily="34" charset="-120"/>
+                <a:latin typeface="VVDS Fifties" pitchFamily="34" charset="0"/>
+                <a:ea typeface="VVDS Fifties" pitchFamily="34" charset="-122"/>
+                <a:cs typeface="VVDS Fifties" pitchFamily="34" charset="-120"/>
               </a:rPr>
               <a:t>The 2026 Semiconductor Ecosystem | Slide 10</a:t>
             </a:r>
@@ -2658,9 +2658,9 @@
                 <a:solidFill>
                   <a:srgbClr val="B84A2F"/>
                 </a:solidFill>
-                <a:latin typeface="Arial" pitchFamily="34" charset="0"/>
-                <a:ea typeface="Arial" pitchFamily="34" charset="-122"/>
-                <a:cs typeface="Arial" pitchFamily="34" charset="-120"/>
+                <a:latin typeface="VVDS Fifties" pitchFamily="34" charset="0"/>
+                <a:ea typeface="VVDS Fifties" pitchFamily="34" charset="-122"/>
+                <a:cs typeface="VVDS Fifties" pitchFamily="34" charset="-120"/>
               </a:rPr>
               <a:t>Key Message: The response? Circular and Autonomous Supply Chains. We are using AI to 'self-heal' the supply chain.</a:t>
             </a:r>
@@ -2722,9 +2722,9 @@
                 <a:solidFill>
                   <a:srgbClr val="B84A2F"/>
                 </a:solidFill>
-                <a:latin typeface="Georgia" pitchFamily="34" charset="0"/>
-                <a:ea typeface="Georgia" pitchFamily="34" charset="-122"/>
-                <a:cs typeface="Georgia" pitchFamily="34" charset="-120"/>
+                <a:latin typeface="PP Mondwest" pitchFamily="34" charset="0"/>
+                <a:ea typeface="PP Mondwest" pitchFamily="34" charset="-122"/>
+                <a:cs typeface="PP Mondwest" pitchFamily="34" charset="-120"/>
               </a:rPr>
               <a:t>Deep Supply Mapping &amp; AI</a:t>
             </a:r>
@@ -2761,9 +2761,9 @@
                 <a:solidFill>
                   <a:srgbClr val="6B6560"/>
                 </a:solidFill>
-                <a:latin typeface="Arial" pitchFamily="34" charset="0"/>
-                <a:ea typeface="Arial" pitchFamily="34" charset="-122"/>
-                <a:cs typeface="Arial" pitchFamily="34" charset="-120"/>
+                <a:latin typeface="VVDS Fifties" pitchFamily="34" charset="0"/>
+                <a:ea typeface="VVDS Fifties" pitchFamily="34" charset="-122"/>
+                <a:cs typeface="VVDS Fifties" pitchFamily="34" charset="-120"/>
               </a:rPr>
               <a:t>Automatically re-routing orders when a port closes or a factory goes down. Mapping up to Tier-4 and Tier-5 suppliers.</a:t>
             </a:r>
@@ -2825,9 +2825,9 @@
                 <a:solidFill>
                   <a:srgbClr val="768C7C"/>
                 </a:solidFill>
-                <a:latin typeface="Georgia" pitchFamily="34" charset="0"/>
-                <a:ea typeface="Georgia" pitchFamily="34" charset="-122"/>
-                <a:cs typeface="Georgia" pitchFamily="34" charset="-120"/>
+                <a:latin typeface="PP Mondwest" pitchFamily="34" charset="0"/>
+                <a:ea typeface="PP Mondwest" pitchFamily="34" charset="-122"/>
+                <a:cs typeface="PP Mondwest" pitchFamily="34" charset="-120"/>
               </a:rPr>
               <a:t>Circular Reclamation</a:t>
             </a:r>
@@ -2864,9 +2864,9 @@
                 <a:solidFill>
                   <a:srgbClr val="6B6560"/>
                 </a:solidFill>
-                <a:latin typeface="Arial" pitchFamily="34" charset="0"/>
-                <a:ea typeface="Arial" pitchFamily="34" charset="-122"/>
-                <a:cs typeface="Arial" pitchFamily="34" charset="-120"/>
+                <a:latin typeface="VVDS Fifties" pitchFamily="34" charset="0"/>
+                <a:ea typeface="VVDS Fifties" pitchFamily="34" charset="-122"/>
+                <a:cs typeface="VVDS Fifties" pitchFamily="34" charset="-120"/>
               </a:rPr>
               <a:t>Mining the 'urban mine'—recovering rare earth elements from old electronics to reduce dependency on volatile mining regions.</a:t>
             </a:r>
@@ -2928,9 +2928,9 @@
                 <a:solidFill>
                   <a:srgbClr val="6B6560"/>
                 </a:solidFill>
-                <a:latin typeface="Arial" pitchFamily="34" charset="0"/>
-                <a:ea typeface="Arial" pitchFamily="34" charset="-122"/>
-                <a:cs typeface="Arial" pitchFamily="34" charset="-120"/>
+                <a:latin typeface="VVDS Fifties" pitchFamily="34" charset="0"/>
+                <a:ea typeface="VVDS Fifties" pitchFamily="34" charset="-122"/>
+                <a:cs typeface="VVDS Fifties" pitchFamily="34" charset="-120"/>
               </a:rPr>
               <a:t>Autonomous logistics systems automatically scan trade flows to reroute containers before bottleneck events cause line shutdowns.</a:t>
             </a:r>
@@ -2999,9 +2999,9 @@
                 <a:solidFill>
                   <a:srgbClr val="B84A2F"/>
                 </a:solidFill>
-                <a:latin typeface="Arial" pitchFamily="34" charset="0"/>
-                <a:ea typeface="Arial" pitchFamily="34" charset="-122"/>
-                <a:cs typeface="Arial" pitchFamily="34" charset="-120"/>
+                <a:latin typeface="VVDS Fifties" pitchFamily="34" charset="0"/>
+                <a:ea typeface="VVDS Fifties" pitchFamily="34" charset="-122"/>
+                <a:cs typeface="VVDS Fifties" pitchFamily="34" charset="-120"/>
               </a:rPr>
               <a:t>PART 3: END-USER INDUSTRIES &amp; APPLICATION ECOSYSTEM</a:t>
             </a:r>
@@ -3038,9 +3038,9 @@
                 <a:solidFill>
                   <a:srgbClr val="1A1714"/>
                 </a:solidFill>
-                <a:latin typeface="Georgia" pitchFamily="34" charset="0"/>
-                <a:ea typeface="Georgia" pitchFamily="34" charset="-122"/>
-                <a:cs typeface="Georgia" pitchFamily="34" charset="-120"/>
+                <a:latin typeface="PP Mondwest" pitchFamily="34" charset="0"/>
+                <a:ea typeface="PP Mondwest" pitchFamily="34" charset="-122"/>
+                <a:cs typeface="PP Mondwest" pitchFamily="34" charset="-120"/>
               </a:rPr>
               <a:t>The Ubiquity of Silicon: Powering the Modern World</a:t>
             </a:r>
@@ -3077,9 +3077,9 @@
                 <a:solidFill>
                   <a:srgbClr val="6B6560"/>
                 </a:solidFill>
-                <a:latin typeface="Arial" pitchFamily="34" charset="0"/>
-                <a:ea typeface="Arial" pitchFamily="34" charset="-122"/>
-                <a:cs typeface="Arial" pitchFamily="34" charset="-120"/>
+                <a:latin typeface="VVDS Fifties" pitchFamily="34" charset="0"/>
+                <a:ea typeface="VVDS Fifties" pitchFamily="34" charset="-122"/>
+                <a:cs typeface="VVDS Fifties" pitchFamily="34" charset="-120"/>
               </a:rPr>
               <a:t>The 2026 Semiconductor Ecosystem | Slide 11</a:t>
             </a:r>
@@ -3141,9 +3141,9 @@
                 <a:solidFill>
                   <a:srgbClr val="9E7D84"/>
                 </a:solidFill>
-                <a:latin typeface="Arial" pitchFamily="34" charset="0"/>
-                <a:ea typeface="Arial" pitchFamily="34" charset="-122"/>
-                <a:cs typeface="Arial" pitchFamily="34" charset="-120"/>
+                <a:latin typeface="VVDS Fifties" pitchFamily="34" charset="0"/>
+                <a:ea typeface="VVDS Fifties" pitchFamily="34" charset="-122"/>
+                <a:cs typeface="VVDS Fifties" pitchFamily="34" charset="-120"/>
               </a:rPr>
               <a:t>Key Message: Semiconductors are the "nerve system" of the global economy; no modern industry can function without them.</a:t>
             </a:r>
@@ -3181,9 +3181,9 @@
                 <a:solidFill>
                   <a:srgbClr val="6B6560"/>
                 </a:solidFill>
-                <a:latin typeface="Arial" pitchFamily="34" charset="0"/>
-                <a:ea typeface="Arial" pitchFamily="34" charset="-122"/>
-                <a:cs typeface="Arial" pitchFamily="34" charset="-120"/>
+                <a:latin typeface="VVDS Fifties" pitchFamily="34" charset="0"/>
+                <a:ea typeface="VVDS Fifties" pitchFamily="34" charset="-122"/>
+                <a:cs typeface="VVDS Fifties" pitchFamily="34" charset="-120"/>
               </a:rPr>
               <a:t>- Central Nerve System: Microchips control the storage, routing, and processing of every piece of data globally.</a:t>
             </a:r>
@@ -3206,9 +3206,9 @@
                 <a:solidFill>
                   <a:srgbClr val="6B6560"/>
                 </a:solidFill>
-                <a:latin typeface="Arial" pitchFamily="34" charset="0"/>
-                <a:ea typeface="Arial" pitchFamily="34" charset="-122"/>
-                <a:cs typeface="Arial" pitchFamily="34" charset="-120"/>
+                <a:latin typeface="VVDS Fifties" pitchFamily="34" charset="0"/>
+                <a:ea typeface="VVDS Fifties" pitchFamily="34" charset="-122"/>
+                <a:cs typeface="VVDS Fifties" pitchFamily="34" charset="-120"/>
               </a:rPr>
               <a:t>- Silicon Intensity Metric: The total value of silicon content per product is the primary metric of industrial scaling.</a:t>
             </a:r>
@@ -3231,9 +3231,9 @@
                 <a:solidFill>
                   <a:srgbClr val="6B6560"/>
                 </a:solidFill>
-                <a:latin typeface="Arial" pitchFamily="34" charset="0"/>
-                <a:ea typeface="Arial" pitchFamily="34" charset="-122"/>
-                <a:cs typeface="Arial" pitchFamily="34" charset="-120"/>
+                <a:latin typeface="VVDS Fifties" pitchFamily="34" charset="0"/>
+                <a:ea typeface="VVDS Fifties" pitchFamily="34" charset="-122"/>
+                <a:cs typeface="VVDS Fifties" pitchFamily="34" charset="-120"/>
               </a:rPr>
               <a:t>- Ubiquitous Integration: Foundational logic layers power smart municipal grids, medical machinery, and neural processors.</a:t>
             </a:r>
@@ -3295,9 +3295,9 @@
                 <a:solidFill>
                   <a:srgbClr val="9E7D84"/>
                 </a:solidFill>
-                <a:latin typeface="Arial" pitchFamily="34" charset="0"/>
-                <a:ea typeface="Arial" pitchFamily="34" charset="-122"/>
-                <a:cs typeface="Arial" pitchFamily="34" charset="-120"/>
+                <a:latin typeface="VVDS Fifties" pitchFamily="34" charset="0"/>
+                <a:ea typeface="VVDS Fifties" pitchFamily="34" charset="-122"/>
+                <a:cs typeface="VVDS Fifties" pitchFamily="34" charset="-120"/>
               </a:rPr>
               <a:t>KEY METRIC</a:t>
             </a:r>
@@ -3334,9 +3334,9 @@
                 <a:solidFill>
                   <a:srgbClr val="1A1714"/>
                 </a:solidFill>
-                <a:latin typeface="Georgia" pitchFamily="34" charset="0"/>
-                <a:ea typeface="Georgia" pitchFamily="34" charset="-122"/>
-                <a:cs typeface="Georgia" pitchFamily="34" charset="-120"/>
+                <a:latin typeface="PP Mondwest" pitchFamily="34" charset="0"/>
+                <a:ea typeface="PP Mondwest" pitchFamily="34" charset="-122"/>
+                <a:cs typeface="PP Mondwest" pitchFamily="34" charset="-120"/>
               </a:rPr>
               <a:t>Silicon</a:t>
             </a:r>
@@ -3351,9 +3351,9 @@
                 <a:solidFill>
                   <a:srgbClr val="1A1714"/>
                 </a:solidFill>
-                <a:latin typeface="Georgia" pitchFamily="34" charset="0"/>
-                <a:ea typeface="Georgia" pitchFamily="34" charset="-122"/>
-                <a:cs typeface="Georgia" pitchFamily="34" charset="-120"/>
+                <a:latin typeface="PP Mondwest" pitchFamily="34" charset="0"/>
+                <a:ea typeface="PP Mondwest" pitchFamily="34" charset="-122"/>
+                <a:cs typeface="PP Mondwest" pitchFamily="34" charset="-120"/>
               </a:rPr>
               <a:t>Intensity</a:t>
             </a:r>
@@ -3390,9 +3390,9 @@
                 <a:solidFill>
                   <a:srgbClr val="6B6560"/>
                 </a:solidFill>
-                <a:latin typeface="Arial" pitchFamily="34" charset="0"/>
-                <a:ea typeface="Arial" pitchFamily="34" charset="-122"/>
-                <a:cs typeface="Arial" pitchFamily="34" charset="-120"/>
+                <a:latin typeface="VVDS Fifties" pitchFamily="34" charset="0"/>
+                <a:ea typeface="VVDS Fifties" pitchFamily="34" charset="-122"/>
+                <a:cs typeface="VVDS Fifties" pitchFamily="34" charset="-120"/>
               </a:rPr>
               <a:t>Primary industrial competitiveness index</a:t>
             </a:r>
@@ -3461,9 +3461,9 @@
                 <a:solidFill>
                   <a:srgbClr val="B84A2F"/>
                 </a:solidFill>
-                <a:latin typeface="Arial" pitchFamily="34" charset="0"/>
-                <a:ea typeface="Arial" pitchFamily="34" charset="-122"/>
-                <a:cs typeface="Arial" pitchFamily="34" charset="-120"/>
+                <a:latin typeface="VVDS Fifties" pitchFamily="34" charset="0"/>
+                <a:ea typeface="VVDS Fifties" pitchFamily="34" charset="-122"/>
+                <a:cs typeface="VVDS Fifties" pitchFamily="34" charset="-120"/>
               </a:rPr>
               <a:t>PART 3: END-USER INDUSTRIES &amp; APPLICATION ECOSYSTEM</a:t>
             </a:r>
@@ -3500,9 +3500,9 @@
                 <a:solidFill>
                   <a:srgbClr val="1A1714"/>
                 </a:solidFill>
-                <a:latin typeface="Georgia" pitchFamily="34" charset="0"/>
-                <a:ea typeface="Georgia" pitchFamily="34" charset="-122"/>
-                <a:cs typeface="Georgia" pitchFamily="34" charset="-120"/>
+                <a:latin typeface="PP Mondwest" pitchFamily="34" charset="0"/>
+                <a:ea typeface="PP Mondwest" pitchFamily="34" charset="-122"/>
+                <a:cs typeface="PP Mondwest" pitchFamily="34" charset="-120"/>
               </a:rPr>
               <a:t>Executive Summary: The Demand Landscape in 2026</a:t>
             </a:r>
@@ -3539,9 +3539,9 @@
                 <a:solidFill>
                   <a:srgbClr val="6B6560"/>
                 </a:solidFill>
-                <a:latin typeface="Arial" pitchFamily="34" charset="0"/>
-                <a:ea typeface="Arial" pitchFamily="34" charset="-122"/>
-                <a:cs typeface="Arial" pitchFamily="34" charset="-120"/>
+                <a:latin typeface="VVDS Fifties" pitchFamily="34" charset="0"/>
+                <a:ea typeface="VVDS Fifties" pitchFamily="34" charset="-122"/>
+                <a:cs typeface="VVDS Fifties" pitchFamily="34" charset="-120"/>
               </a:rPr>
               <a:t>The 2026 Semiconductor Ecosystem | Slide 12</a:t>
             </a:r>
@@ -3603,9 +3603,9 @@
                 <a:solidFill>
                   <a:srgbClr val="B84A2F"/>
                 </a:solidFill>
-                <a:latin typeface="Arial" pitchFamily="34" charset="0"/>
-                <a:ea typeface="Arial" pitchFamily="34" charset="-122"/>
-                <a:cs typeface="Arial" pitchFamily="34" charset="-120"/>
+                <a:latin typeface="VVDS Fifties" pitchFamily="34" charset="0"/>
+                <a:ea typeface="VVDS Fifties" pitchFamily="34" charset="-122"/>
+                <a:cs typeface="VVDS Fifties" pitchFamily="34" charset="-120"/>
               </a:rPr>
               <a:t>Key Message: Demand is shifting from traditional computing toward AI infrastructure, Automotive, and Industrial Automation.</a:t>
             </a:r>
@@ -3667,9 +3667,9 @@
                 <a:solidFill>
                   <a:srgbClr val="B84A2F"/>
                 </a:solidFill>
-                <a:latin typeface="Georgia" pitchFamily="34" charset="0"/>
-                <a:ea typeface="Georgia" pitchFamily="34" charset="-122"/>
-                <a:cs typeface="Georgia" pitchFamily="34" charset="-120"/>
+                <a:latin typeface="PP Mondwest" pitchFamily="34" charset="0"/>
+                <a:ea typeface="PP Mondwest" pitchFamily="34" charset="-122"/>
+                <a:cs typeface="PP Mondwest" pitchFamily="34" charset="-120"/>
               </a:rPr>
               <a:t>AI Datacenters</a:t>
             </a:r>
@@ -3706,9 +3706,9 @@
                 <a:solidFill>
                   <a:srgbClr val="6B6560"/>
                 </a:solidFill>
-                <a:latin typeface="Arial" pitchFamily="34" charset="0"/>
-                <a:ea typeface="Arial" pitchFamily="34" charset="-122"/>
-                <a:cs typeface="Arial" pitchFamily="34" charset="-120"/>
+                <a:latin typeface="VVDS Fifties" pitchFamily="34" charset="0"/>
+                <a:ea typeface="VVDS Fifties" pitchFamily="34" charset="-122"/>
+                <a:cs typeface="VVDS Fifties" pitchFamily="34" charset="-120"/>
               </a:rPr>
               <a:t>Nearly 50% of semiconductor industry growth and revenue is driven by high-performance AI accelerators.</a:t>
             </a:r>
@@ -3770,9 +3770,9 @@
                 <a:solidFill>
                   <a:srgbClr val="9E7D84"/>
                 </a:solidFill>
-                <a:latin typeface="Georgia" pitchFamily="34" charset="0"/>
-                <a:ea typeface="Georgia" pitchFamily="34" charset="-122"/>
-                <a:cs typeface="Georgia" pitchFamily="34" charset="-120"/>
+                <a:latin typeface="PP Mondwest" pitchFamily="34" charset="0"/>
+                <a:ea typeface="PP Mondwest" pitchFamily="34" charset="-122"/>
+                <a:cs typeface="PP Mondwest" pitchFamily="34" charset="-120"/>
               </a:rPr>
               <a:t>Automotive</a:t>
             </a:r>
@@ -3809,9 +3809,9 @@
                 <a:solidFill>
                   <a:srgbClr val="6B6560"/>
                 </a:solidFill>
-                <a:latin typeface="Arial" pitchFamily="34" charset="0"/>
-                <a:ea typeface="Arial" pitchFamily="34" charset="-122"/>
-                <a:cs typeface="Arial" pitchFamily="34" charset="-120"/>
+                <a:latin typeface="VVDS Fifties" pitchFamily="34" charset="0"/>
+                <a:ea typeface="VVDS Fifties" pitchFamily="34" charset="-122"/>
+                <a:cs typeface="VVDS Fifties" pitchFamily="34" charset="-120"/>
               </a:rPr>
               <a:t>The fastest growing volume segment, requiring massive numbers of legacy control nodes and SiC power chips.</a:t>
             </a:r>
@@ -3873,9 +3873,9 @@
                 <a:solidFill>
                   <a:srgbClr val="768C7C"/>
                 </a:solidFill>
-                <a:latin typeface="Georgia" pitchFamily="34" charset="0"/>
-                <a:ea typeface="Georgia" pitchFamily="34" charset="-122"/>
-                <a:cs typeface="Georgia" pitchFamily="34" charset="-120"/>
+                <a:latin typeface="PP Mondwest" pitchFamily="34" charset="0"/>
+                <a:ea typeface="PP Mondwest" pitchFamily="34" charset="-122"/>
+                <a:cs typeface="PP Mondwest" pitchFamily="34" charset="-120"/>
               </a:rPr>
               <a:t>Smartphones &amp; PCs</a:t>
             </a:r>
@@ -3912,9 +3912,9 @@
                 <a:solidFill>
                   <a:srgbClr val="6B6560"/>
                 </a:solidFill>
-                <a:latin typeface="Arial" pitchFamily="34" charset="0"/>
-                <a:ea typeface="Arial" pitchFamily="34" charset="-122"/>
-                <a:cs typeface="Arial" pitchFamily="34" charset="-120"/>
+                <a:latin typeface="VVDS Fifties" pitchFamily="34" charset="0"/>
+                <a:ea typeface="VVDS Fifties" pitchFamily="34" charset="-122"/>
+                <a:cs typeface="VVDS Fifties" pitchFamily="34" charset="-120"/>
               </a:rPr>
               <a:t>Traditional core segments face volume saturation, driving consolidation and focus on specialized edge accelerators.</a:t>
             </a:r>
@@ -3983,9 +3983,9 @@
                 <a:solidFill>
                   <a:srgbClr val="B84A2F"/>
                 </a:solidFill>
-                <a:latin typeface="Arial" pitchFamily="34" charset="0"/>
-                <a:ea typeface="Arial" pitchFamily="34" charset="-122"/>
-                <a:cs typeface="Arial" pitchFamily="34" charset="-120"/>
+                <a:latin typeface="VVDS Fifties" pitchFamily="34" charset="0"/>
+                <a:ea typeface="VVDS Fifties" pitchFamily="34" charset="-122"/>
+                <a:cs typeface="VVDS Fifties" pitchFamily="34" charset="-120"/>
               </a:rPr>
               <a:t>PART 3: END-USER INDUSTRIES &amp; APPLICATION ECOSYSTEM</a:t>
             </a:r>
@@ -4022,9 +4022,9 @@
                 <a:solidFill>
                   <a:srgbClr val="1A1714"/>
                 </a:solidFill>
-                <a:latin typeface="Georgia" pitchFamily="34" charset="0"/>
-                <a:ea typeface="Georgia" pitchFamily="34" charset="-122"/>
-                <a:cs typeface="Georgia" pitchFamily="34" charset="-120"/>
+                <a:latin typeface="PP Mondwest" pitchFamily="34" charset="0"/>
+                <a:ea typeface="PP Mondwest" pitchFamily="34" charset="-122"/>
+                <a:cs typeface="PP Mondwest" pitchFamily="34" charset="-120"/>
               </a:rPr>
               <a:t>AI &amp; Data Centers: The Generative Revolution</a:t>
             </a:r>
@@ -4061,9 +4061,9 @@
                 <a:solidFill>
                   <a:srgbClr val="6B6560"/>
                 </a:solidFill>
-                <a:latin typeface="Arial" pitchFamily="34" charset="0"/>
-                <a:ea typeface="Arial" pitchFamily="34" charset="-122"/>
-                <a:cs typeface="Arial" pitchFamily="34" charset="-120"/>
+                <a:latin typeface="VVDS Fifties" pitchFamily="34" charset="0"/>
+                <a:ea typeface="VVDS Fifties" pitchFamily="34" charset="-122"/>
+                <a:cs typeface="VVDS Fifties" pitchFamily="34" charset="-120"/>
               </a:rPr>
               <a:t>The 2026 Semiconductor Ecosystem | Slide 13</a:t>
             </a:r>
@@ -4125,9 +4125,9 @@
                 <a:solidFill>
                   <a:srgbClr val="768C7C"/>
                 </a:solidFill>
-                <a:latin typeface="Arial" pitchFamily="34" charset="0"/>
-                <a:ea typeface="Arial" pitchFamily="34" charset="-122"/>
-                <a:cs typeface="Arial" pitchFamily="34" charset="-120"/>
+                <a:latin typeface="VVDS Fifties" pitchFamily="34" charset="0"/>
+                <a:ea typeface="VVDS Fifties" pitchFamily="34" charset="-122"/>
+                <a:cs typeface="VVDS Fifties" pitchFamily="34" charset="-120"/>
               </a:rPr>
               <a:t>Key Message: Data centers have evolved into "Intelligence Engines," consuming the highest-value silicon ever produced.</a:t>
             </a:r>
@@ -4165,9 +4165,9 @@
                 <a:solidFill>
                   <a:srgbClr val="6B6560"/>
                 </a:solidFill>
-                <a:latin typeface="Arial" pitchFamily="34" charset="0"/>
-                <a:ea typeface="Arial" pitchFamily="34" charset="-122"/>
-                <a:cs typeface="Arial" pitchFamily="34" charset="-120"/>
+                <a:latin typeface="VVDS Fifties" pitchFamily="34" charset="0"/>
+                <a:ea typeface="VVDS Fifties" pitchFamily="34" charset="-122"/>
+                <a:cs typeface="VVDS Fifties" pitchFamily="34" charset="-120"/>
               </a:rPr>
               <a:t>- Accelerator Market ($500B): Generative models and neural computing demand massive scaling of TPU and GPU nodes.</a:t>
             </a:r>
@@ -4190,9 +4190,9 @@
                 <a:solidFill>
                   <a:srgbClr val="6B6560"/>
                 </a:solidFill>
-                <a:latin typeface="Arial" pitchFamily="34" charset="0"/>
-                <a:ea typeface="Arial" pitchFamily="34" charset="-122"/>
-                <a:cs typeface="Arial" pitchFamily="34" charset="-120"/>
+                <a:latin typeface="VVDS Fifties" pitchFamily="34" charset="0"/>
+                <a:ea typeface="VVDS Fifties" pitchFamily="34" charset="-122"/>
+                <a:cs typeface="VVDS Fifties" pitchFamily="34" charset="-120"/>
               </a:rPr>
               <a:t>- Sub-3nm Node Sourcing: The primary consumers of the most advanced wafer print architectures globally.</a:t>
             </a:r>
@@ -4215,9 +4215,9 @@
                 <a:solidFill>
                   <a:srgbClr val="6B6560"/>
                 </a:solidFill>
-                <a:latin typeface="Arial" pitchFamily="34" charset="0"/>
-                <a:ea typeface="Arial" pitchFamily="34" charset="-122"/>
-                <a:cs typeface="Arial" pitchFamily="34" charset="-120"/>
+                <a:latin typeface="VVDS Fifties" pitchFamily="34" charset="0"/>
+                <a:ea typeface="VVDS Fifties" pitchFamily="34" charset="-122"/>
+                <a:cs typeface="VVDS Fifties" pitchFamily="34" charset="-120"/>
               </a:rPr>
               <a:t>- Memory &amp; Interconnect: Demands extreme density of High Bandwidth Memory (HBM) and customized routing interconnect silicon.</a:t>
             </a:r>
@@ -4279,9 +4279,9 @@
                 <a:solidFill>
                   <a:srgbClr val="768C7C"/>
                 </a:solidFill>
-                <a:latin typeface="Arial" pitchFamily="34" charset="0"/>
-                <a:ea typeface="Arial" pitchFamily="34" charset="-122"/>
-                <a:cs typeface="Arial" pitchFamily="34" charset="-120"/>
+                <a:latin typeface="VVDS Fifties" pitchFamily="34" charset="0"/>
+                <a:ea typeface="VVDS Fifties" pitchFamily="34" charset="-122"/>
+                <a:cs typeface="VVDS Fifties" pitchFamily="34" charset="-120"/>
               </a:rPr>
               <a:t>ANALYST PROJECT</a:t>
             </a:r>
@@ -4318,9 +4318,9 @@
                 <a:solidFill>
                   <a:srgbClr val="1A1714"/>
                 </a:solidFill>
-                <a:latin typeface="Georgia" pitchFamily="34" charset="0"/>
-                <a:ea typeface="Georgia" pitchFamily="34" charset="-122"/>
-                <a:cs typeface="Georgia" pitchFamily="34" charset="-120"/>
+                <a:latin typeface="PP Mondwest" pitchFamily="34" charset="0"/>
+                <a:ea typeface="PP Mondwest" pitchFamily="34" charset="-122"/>
+                <a:cs typeface="PP Mondwest" pitchFamily="34" charset="-120"/>
               </a:rPr>
               <a:t>$500B</a:t>
             </a:r>
@@ -4357,9 +4357,9 @@
                 <a:solidFill>
                   <a:srgbClr val="6B6560"/>
                 </a:solidFill>
-                <a:latin typeface="Arial" pitchFamily="34" charset="0"/>
-                <a:ea typeface="Arial" pitchFamily="34" charset="-122"/>
-                <a:cs typeface="Arial" pitchFamily="34" charset="-120"/>
+                <a:latin typeface="VVDS Fifties" pitchFamily="34" charset="0"/>
+                <a:ea typeface="VVDS Fifties" pitchFamily="34" charset="-122"/>
+                <a:cs typeface="VVDS Fifties" pitchFamily="34" charset="-120"/>
               </a:rPr>
               <a:t>AI Accelerator market size by 2026</a:t>
             </a:r>
@@ -4428,9 +4428,9 @@
                 <a:solidFill>
                   <a:srgbClr val="B84A2F"/>
                 </a:solidFill>
-                <a:latin typeface="Arial" pitchFamily="34" charset="0"/>
-                <a:ea typeface="Arial" pitchFamily="34" charset="-122"/>
-                <a:cs typeface="Arial" pitchFamily="34" charset="-120"/>
+                <a:latin typeface="VVDS Fifties" pitchFamily="34" charset="0"/>
+                <a:ea typeface="VVDS Fifties" pitchFamily="34" charset="-122"/>
+                <a:cs typeface="VVDS Fifties" pitchFamily="34" charset="-120"/>
               </a:rPr>
               <a:t>PART 3: END-USER INDUSTRIES &amp; APPLICATION ECOSYSTEM</a:t>
             </a:r>
@@ -4467,9 +4467,9 @@
                 <a:solidFill>
                   <a:srgbClr val="1A1714"/>
                 </a:solidFill>
-                <a:latin typeface="Georgia" pitchFamily="34" charset="0"/>
-                <a:ea typeface="Georgia" pitchFamily="34" charset="-122"/>
-                <a:cs typeface="Georgia" pitchFamily="34" charset="-120"/>
+                <a:latin typeface="PP Mondwest" pitchFamily="34" charset="0"/>
+                <a:ea typeface="PP Mondwest" pitchFamily="34" charset="-122"/>
+                <a:cs typeface="PP Mondwest" pitchFamily="34" charset="-120"/>
               </a:rPr>
               <a:t>Automotive: The "Smartphone on Wheels"</a:t>
             </a:r>
@@ -4506,9 +4506,9 @@
                 <a:solidFill>
                   <a:srgbClr val="6B6560"/>
                 </a:solidFill>
-                <a:latin typeface="Arial" pitchFamily="34" charset="0"/>
-                <a:ea typeface="Arial" pitchFamily="34" charset="-122"/>
-                <a:cs typeface="Arial" pitchFamily="34" charset="-120"/>
+                <a:latin typeface="VVDS Fifties" pitchFamily="34" charset="0"/>
+                <a:ea typeface="VVDS Fifties" pitchFamily="34" charset="-122"/>
+                <a:cs typeface="VVDS Fifties" pitchFamily="34" charset="-120"/>
               </a:rPr>
               <a:t>The 2026 Semiconductor Ecosystem | Slide 14</a:t>
             </a:r>
@@ -4570,9 +4570,9 @@
                 <a:solidFill>
                   <a:srgbClr val="B84A2F"/>
                 </a:solidFill>
-                <a:latin typeface="Arial" pitchFamily="34" charset="0"/>
-                <a:ea typeface="Arial" pitchFamily="34" charset="-122"/>
-                <a:cs typeface="Arial" pitchFamily="34" charset="-120"/>
+                <a:latin typeface="VVDS Fifties" pitchFamily="34" charset="0"/>
+                <a:ea typeface="VVDS Fifties" pitchFamily="34" charset="-122"/>
+                <a:cs typeface="VVDS Fifties" pitchFamily="34" charset="-120"/>
               </a:rPr>
               <a:t>Key Message: The transition to EVs and ADAS is doubling semiconductor content per vehicle, reaching over $1,000 per unit.</a:t>
             </a:r>
@@ -4610,9 +4610,9 @@
                 <a:solidFill>
                   <a:srgbClr val="6B6560"/>
                 </a:solidFill>
-                <a:latin typeface="Arial" pitchFamily="34" charset="0"/>
-                <a:ea typeface="Arial" pitchFamily="34" charset="-122"/>
-                <a:cs typeface="Arial" pitchFamily="34" charset="-120"/>
+                <a:latin typeface="VVDS Fifties" pitchFamily="34" charset="0"/>
+                <a:ea typeface="VVDS Fifties" pitchFamily="34" charset="-122"/>
+                <a:cs typeface="VVDS Fifties" pitchFamily="34" charset="-120"/>
               </a:rPr>
               <a:t>- Silicon Carbide (SiC) Power: Drives high-efficiency power switches in high-voltage EV battery platforms.</a:t>
             </a:r>
@@ -4635,9 +4635,9 @@
                 <a:solidFill>
                   <a:srgbClr val="6B6560"/>
                 </a:solidFill>
-                <a:latin typeface="Arial" pitchFamily="34" charset="0"/>
-                <a:ea typeface="Arial" pitchFamily="34" charset="-122"/>
-                <a:cs typeface="Arial" pitchFamily="34" charset="-120"/>
+                <a:latin typeface="VVDS Fifties" pitchFamily="34" charset="0"/>
+                <a:ea typeface="VVDS Fifties" pitchFamily="34" charset="-122"/>
+                <a:cs typeface="VVDS Fifties" pitchFamily="34" charset="-120"/>
               </a:rPr>
               <a:t>- ADAS Autonomous Compute: Self-driving capabilities demand heavy on-board computational units for sensor fusion.</a:t>
             </a:r>
@@ -4660,9 +4660,9 @@
                 <a:solidFill>
                   <a:srgbClr val="6B6560"/>
                 </a:solidFill>
-                <a:latin typeface="Arial" pitchFamily="34" charset="0"/>
-                <a:ea typeface="Arial" pitchFamily="34" charset="-122"/>
-                <a:cs typeface="Arial" pitchFamily="34" charset="-120"/>
+                <a:latin typeface="VVDS Fifties" pitchFamily="34" charset="0"/>
+                <a:ea typeface="VVDS Fifties" pitchFamily="34" charset="-122"/>
+                <a:cs typeface="VVDS Fifties" pitchFamily="34" charset="-120"/>
               </a:rPr>
               <a:t>- Sensor Arrays Sourcing: Vehicles integrate multiple LiDAR, radar, and camera chip sets for 360-degree coverage.</a:t>
             </a:r>
@@ -4724,9 +4724,9 @@
                 <a:solidFill>
                   <a:srgbClr val="B84A2F"/>
                 </a:solidFill>
-                <a:latin typeface="Arial" pitchFamily="34" charset="0"/>
-                <a:ea typeface="Arial" pitchFamily="34" charset="-122"/>
-                <a:cs typeface="Arial" pitchFamily="34" charset="-120"/>
+                <a:latin typeface="VVDS Fifties" pitchFamily="34" charset="0"/>
+                <a:ea typeface="VVDS Fifties" pitchFamily="34" charset="-122"/>
+                <a:cs typeface="VVDS Fifties" pitchFamily="34" charset="-120"/>
               </a:rPr>
               <a:t>ESTIMATE</a:t>
             </a:r>
@@ -4763,9 +4763,9 @@
                 <a:solidFill>
                   <a:srgbClr val="1A1714"/>
                 </a:solidFill>
-                <a:latin typeface="Georgia" pitchFamily="34" charset="0"/>
-                <a:ea typeface="Georgia" pitchFamily="34" charset="-122"/>
-                <a:cs typeface="Georgia" pitchFamily="34" charset="-120"/>
+                <a:latin typeface="PP Mondwest" pitchFamily="34" charset="0"/>
+                <a:ea typeface="PP Mondwest" pitchFamily="34" charset="-122"/>
+                <a:cs typeface="PP Mondwest" pitchFamily="34" charset="-120"/>
               </a:rPr>
               <a:t>$1,000+</a:t>
             </a:r>
@@ -4802,9 +4802,9 @@
                 <a:solidFill>
                   <a:srgbClr val="6B6560"/>
                 </a:solidFill>
-                <a:latin typeface="Arial" pitchFamily="34" charset="0"/>
-                <a:ea typeface="Arial" pitchFamily="34" charset="-122"/>
-                <a:cs typeface="Arial" pitchFamily="34" charset="-120"/>
+                <a:latin typeface="VVDS Fifties" pitchFamily="34" charset="0"/>
+                <a:ea typeface="VVDS Fifties" pitchFamily="34" charset="-122"/>
+                <a:cs typeface="VVDS Fifties" pitchFamily="34" charset="-120"/>
               </a:rPr>
               <a:t>Silicon value content per EV unit</a:t>
             </a:r>
@@ -4873,9 +4873,9 @@
                 <a:solidFill>
                   <a:srgbClr val="B84A2F"/>
                 </a:solidFill>
-                <a:latin typeface="Arial" pitchFamily="34" charset="0"/>
-                <a:ea typeface="Arial" pitchFamily="34" charset="-122"/>
-                <a:cs typeface="Arial" pitchFamily="34" charset="-120"/>
+                <a:latin typeface="VVDS Fifties" pitchFamily="34" charset="0"/>
+                <a:ea typeface="VVDS Fifties" pitchFamily="34" charset="-122"/>
+                <a:cs typeface="VVDS Fifties" pitchFamily="34" charset="-120"/>
               </a:rPr>
               <a:t>PART 3: END-USER INDUSTRIES &amp; APPLICATION ECOSYSTEM</a:t>
             </a:r>
@@ -4912,9 +4912,9 @@
                 <a:solidFill>
                   <a:srgbClr val="1A1714"/>
                 </a:solidFill>
-                <a:latin typeface="Georgia" pitchFamily="34" charset="0"/>
-                <a:ea typeface="Georgia" pitchFamily="34" charset="-122"/>
-                <a:cs typeface="Georgia" pitchFamily="34" charset="-120"/>
+                <a:latin typeface="PP Mondwest" pitchFamily="34" charset="0"/>
+                <a:ea typeface="PP Mondwest" pitchFamily="34" charset="-122"/>
+                <a:cs typeface="PP Mondwest" pitchFamily="34" charset="-120"/>
               </a:rPr>
               <a:t>Industrial, IoT &amp; Healthcare: Intelligence at the Edge</a:t>
             </a:r>
@@ -4951,9 +4951,9 @@
                 <a:solidFill>
                   <a:srgbClr val="6B6560"/>
                 </a:solidFill>
-                <a:latin typeface="Arial" pitchFamily="34" charset="0"/>
-                <a:ea typeface="Arial" pitchFamily="34" charset="-122"/>
-                <a:cs typeface="Arial" pitchFamily="34" charset="-120"/>
+                <a:latin typeface="VVDS Fifties" pitchFamily="34" charset="0"/>
+                <a:ea typeface="VVDS Fifties" pitchFamily="34" charset="-122"/>
+                <a:cs typeface="VVDS Fifties" pitchFamily="34" charset="-120"/>
               </a:rPr>
               <a:t>The 2026 Semiconductor Ecosystem | Slide 15</a:t>
             </a:r>
@@ -5015,9 +5015,9 @@
                 <a:solidFill>
                   <a:srgbClr val="9E7D84"/>
                 </a:solidFill>
-                <a:latin typeface="Arial" pitchFamily="34" charset="0"/>
-                <a:ea typeface="Arial" pitchFamily="34" charset="-122"/>
-                <a:cs typeface="Arial" pitchFamily="34" charset="-120"/>
+                <a:latin typeface="VVDS Fifties" pitchFamily="34" charset="0"/>
+                <a:ea typeface="VVDS Fifties" pitchFamily="34" charset="-122"/>
+                <a:cs typeface="VVDS Fifties" pitchFamily="34" charset="-120"/>
               </a:rPr>
               <a:t>Key Message: Edge AI is transforming manufacturing and healthcare, prioritizing long-lifecycle, high-reliability silicon.</a:t>
             </a:r>
@@ -5079,9 +5079,9 @@
                 <a:solidFill>
                   <a:srgbClr val="9E7D84"/>
                 </a:solidFill>
-                <a:latin typeface="Georgia" pitchFamily="34" charset="0"/>
-                <a:ea typeface="Georgia" pitchFamily="34" charset="-122"/>
-                <a:cs typeface="Georgia" pitchFamily="34" charset="-120"/>
+                <a:latin typeface="PP Mondwest" pitchFamily="34" charset="0"/>
+                <a:ea typeface="PP Mondwest" pitchFamily="34" charset="-122"/>
+                <a:cs typeface="PP Mondwest" pitchFamily="34" charset="-120"/>
               </a:rPr>
               <a:t>Industry 4.0 Edge Analytics</a:t>
             </a:r>
@@ -5118,9 +5118,9 @@
                 <a:solidFill>
                   <a:srgbClr val="6B6560"/>
                 </a:solidFill>
-                <a:latin typeface="Arial" pitchFamily="34" charset="0"/>
-                <a:ea typeface="Arial" pitchFamily="34" charset="-122"/>
-                <a:cs typeface="Arial" pitchFamily="34" charset="-120"/>
+                <a:latin typeface="VVDS Fifties" pitchFamily="34" charset="0"/>
+                <a:ea typeface="VVDS Fifties" pitchFamily="34" charset="-122"/>
+                <a:cs typeface="VVDS Fifties" pitchFamily="34" charset="-120"/>
               </a:rPr>
               <a:t>Factory floor nodes execute real-time local algorithms for predictive maintenance and machine vision controls, utilizing highly rugged legacy processes.</a:t>
             </a:r>
@@ -5182,9 +5182,9 @@
                 <a:solidFill>
                   <a:srgbClr val="768C7C"/>
                 </a:solidFill>
-                <a:latin typeface="Georgia" pitchFamily="34" charset="0"/>
-                <a:ea typeface="Georgia" pitchFamily="34" charset="-122"/>
-                <a:cs typeface="Georgia" pitchFamily="34" charset="-120"/>
+                <a:latin typeface="PP Mondwest" pitchFamily="34" charset="0"/>
+                <a:ea typeface="PP Mondwest" pitchFamily="34" charset="-122"/>
+                <a:cs typeface="PP Mondwest" pitchFamily="34" charset="-120"/>
               </a:rPr>
               <a:t>Healthcare Personalized Sourcing</a:t>
             </a:r>
@@ -5221,9 +5221,9 @@
                 <a:solidFill>
                   <a:srgbClr val="6B6560"/>
                 </a:solidFill>
-                <a:latin typeface="Arial" pitchFamily="34" charset="0"/>
-                <a:ea typeface="Arial" pitchFamily="34" charset="-122"/>
-                <a:cs typeface="Arial" pitchFamily="34" charset="-120"/>
+                <a:latin typeface="VVDS Fifties" pitchFamily="34" charset="0"/>
+                <a:ea typeface="VVDS Fifties" pitchFamily="34" charset="-122"/>
+                <a:cs typeface="VVDS Fifties" pitchFamily="34" charset="-120"/>
               </a:rPr>
               <a:t>Semiconductors enable smart wearable diagnostics, active health implants, and personalized diagnostics. Requires extreme reliability certifications.</a:t>
             </a:r>
@@ -5292,9 +5292,9 @@
                 <a:solidFill>
                   <a:srgbClr val="B84A2F"/>
                 </a:solidFill>
-                <a:latin typeface="Arial" pitchFamily="34" charset="0"/>
-                <a:ea typeface="Arial" pitchFamily="34" charset="-122"/>
-                <a:cs typeface="Arial" pitchFamily="34" charset="-120"/>
+                <a:latin typeface="VVDS Fifties" pitchFamily="34" charset="0"/>
+                <a:ea typeface="VVDS Fifties" pitchFamily="34" charset="-122"/>
+                <a:cs typeface="VVDS Fifties" pitchFamily="34" charset="-120"/>
               </a:rPr>
               <a:t>PART 3: END-USER INDUSTRIES &amp; APPLICATION ECOSYSTEM</a:t>
             </a:r>
@@ -5331,9 +5331,9 @@
                 <a:solidFill>
                   <a:srgbClr val="1A1714"/>
                 </a:solidFill>
-                <a:latin typeface="Georgia" pitchFamily="34" charset="0"/>
-                <a:ea typeface="Georgia" pitchFamily="34" charset="-122"/>
-                <a:cs typeface="Georgia" pitchFamily="34" charset="-120"/>
+                <a:latin typeface="PP Mondwest" pitchFamily="34" charset="0"/>
+                <a:ea typeface="PP Mondwest" pitchFamily="34" charset="-122"/>
+                <a:cs typeface="PP Mondwest" pitchFamily="34" charset="-120"/>
               </a:rPr>
               <a:t>Consumer Electronics &amp; Emerging Frontiers</a:t>
             </a:r>
@@ -5370,9 +5370,9 @@
                 <a:solidFill>
                   <a:srgbClr val="6B6560"/>
                 </a:solidFill>
-                <a:latin typeface="Arial" pitchFamily="34" charset="0"/>
-                <a:ea typeface="Arial" pitchFamily="34" charset="-122"/>
-                <a:cs typeface="Arial" pitchFamily="34" charset="-120"/>
+                <a:latin typeface="VVDS Fifties" pitchFamily="34" charset="0"/>
+                <a:ea typeface="VVDS Fifties" pitchFamily="34" charset="-122"/>
+                <a:cs typeface="VVDS Fifties" pitchFamily="34" charset="-120"/>
               </a:rPr>
               <a:t>The 2026 Semiconductor Ecosystem | Slide 16</a:t>
             </a:r>
@@ -5434,9 +5434,9 @@
                 <a:solidFill>
                   <a:srgbClr val="768C7C"/>
                 </a:solidFill>
-                <a:latin typeface="Arial" pitchFamily="34" charset="0"/>
-                <a:ea typeface="Arial" pitchFamily="34" charset="-122"/>
-                <a:cs typeface="Arial" pitchFamily="34" charset="-120"/>
+                <a:latin typeface="VVDS Fifties" pitchFamily="34" charset="0"/>
+                <a:ea typeface="VVDS Fifties" pitchFamily="34" charset="-122"/>
+                <a:cs typeface="VVDS Fifties" pitchFamily="34" charset="-120"/>
               </a:rPr>
               <a:t>Key Message: While traditional consumer tech matures, frontiers like Quantum, 6G, and Neuromorphic computing define the 2030 roadmap.</a:t>
             </a:r>
@@ -5474,9 +5474,9 @@
                 <a:solidFill>
                   <a:srgbClr val="6B6560"/>
                 </a:solidFill>
-                <a:latin typeface="Arial" pitchFamily="34" charset="0"/>
-                <a:ea typeface="Arial" pitchFamily="34" charset="-122"/>
-                <a:cs typeface="Arial" pitchFamily="34" charset="-120"/>
+                <a:latin typeface="VVDS Fifties" pitchFamily="34" charset="0"/>
+                <a:ea typeface="VVDS Fifties" pitchFamily="34" charset="-122"/>
+                <a:cs typeface="VVDS Fifties" pitchFamily="34" charset="-120"/>
               </a:rPr>
               <a:t>- On-Device NPU Logic: Integrating Neural Processing Units (NPUs) into laptops and mobile phones to enable local AI execution.</a:t>
             </a:r>
@@ -5499,9 +5499,9 @@
                 <a:solidFill>
                   <a:srgbClr val="6B6560"/>
                 </a:solidFill>
-                <a:latin typeface="Arial" pitchFamily="34" charset="0"/>
-                <a:ea typeface="Arial" pitchFamily="34" charset="-122"/>
-                <a:cs typeface="Arial" pitchFamily="34" charset="-120"/>
+                <a:latin typeface="VVDS Fifties" pitchFamily="34" charset="0"/>
+                <a:ea typeface="VVDS Fifties" pitchFamily="34" charset="-122"/>
+                <a:cs typeface="VVDS Fifties" pitchFamily="34" charset="-120"/>
               </a:rPr>
               <a:t>- Neuromorphic Computing: Researching brain-inspired architectures targeting extreme computing power efficiency.</a:t>
             </a:r>
@@ -5524,9 +5524,9 @@
                 <a:solidFill>
                   <a:srgbClr val="6B6560"/>
                 </a:solidFill>
-                <a:latin typeface="Arial" pitchFamily="34" charset="0"/>
-                <a:ea typeface="Arial" pitchFamily="34" charset="-122"/>
-                <a:cs typeface="Arial" pitchFamily="34" charset="-120"/>
+                <a:latin typeface="VVDS Fifties" pitchFamily="34" charset="0"/>
+                <a:ea typeface="VVDS Fifties" pitchFamily="34" charset="-122"/>
+                <a:cs typeface="VVDS Fifties" pitchFamily="34" charset="-120"/>
               </a:rPr>
               <a:t>- Next-Gen Frontiers: Developing quantum structures and 6G communications hardware blocks.</a:t>
             </a:r>
@@ -5588,9 +5588,9 @@
                 <a:solidFill>
                   <a:srgbClr val="768C7C"/>
                 </a:solidFill>
-                <a:latin typeface="Arial" pitchFamily="34" charset="0"/>
-                <a:ea typeface="Arial" pitchFamily="34" charset="-122"/>
-                <a:cs typeface="Arial" pitchFamily="34" charset="-120"/>
+                <a:latin typeface="VVDS Fifties" pitchFamily="34" charset="0"/>
+                <a:ea typeface="VVDS Fifties" pitchFamily="34" charset="-122"/>
+                <a:cs typeface="VVDS Fifties" pitchFamily="34" charset="-120"/>
               </a:rPr>
               <a:t>NPU CORES</a:t>
             </a:r>
@@ -5627,9 +5627,9 @@
                 <a:solidFill>
                   <a:srgbClr val="1A1714"/>
                 </a:solidFill>
-                <a:latin typeface="Georgia" pitchFamily="34" charset="0"/>
-                <a:ea typeface="Georgia" pitchFamily="34" charset="-122"/>
-                <a:cs typeface="Georgia" pitchFamily="34" charset="-120"/>
+                <a:latin typeface="PP Mondwest" pitchFamily="34" charset="0"/>
+                <a:ea typeface="PP Mondwest" pitchFamily="34" charset="-122"/>
+                <a:cs typeface="PP Mondwest" pitchFamily="34" charset="-120"/>
               </a:rPr>
               <a:t>Client AI</a:t>
             </a:r>
@@ -5666,9 +5666,9 @@
                 <a:solidFill>
                   <a:srgbClr val="6B6560"/>
                 </a:solidFill>
-                <a:latin typeface="Arial" pitchFamily="34" charset="0"/>
-                <a:ea typeface="Arial" pitchFamily="34" charset="-122"/>
-                <a:cs typeface="Arial" pitchFamily="34" charset="-120"/>
+                <a:latin typeface="VVDS Fifties" pitchFamily="34" charset="0"/>
+                <a:ea typeface="VVDS Fifties" pitchFamily="34" charset="-122"/>
+                <a:cs typeface="VVDS Fifties" pitchFamily="34" charset="-120"/>
               </a:rPr>
               <a:t>Standard hardware in 2026 client electronics (laptops, phones)</a:t>
             </a:r>
@@ -5737,9 +5737,9 @@
                 <a:solidFill>
                   <a:srgbClr val="B84A2F"/>
                 </a:solidFill>
-                <a:latin typeface="Arial" pitchFamily="34" charset="0"/>
-                <a:ea typeface="Arial" pitchFamily="34" charset="-122"/>
-                <a:cs typeface="Arial" pitchFamily="34" charset="-120"/>
+                <a:latin typeface="VVDS Fifties" pitchFamily="34" charset="0"/>
+                <a:ea typeface="VVDS Fifties" pitchFamily="34" charset="-122"/>
+                <a:cs typeface="VVDS Fifties" pitchFamily="34" charset="-120"/>
               </a:rPr>
               <a:t>SUMMARY &amp; ROADMAP</a:t>
             </a:r>
@@ -5776,9 +5776,9 @@
                 <a:solidFill>
                   <a:srgbClr val="1A1714"/>
                 </a:solidFill>
-                <a:latin typeface="Georgia" pitchFamily="34" charset="0"/>
-                <a:ea typeface="Georgia" pitchFamily="34" charset="-122"/>
-                <a:cs typeface="Georgia" pitchFamily="34" charset="-120"/>
+                <a:latin typeface="PP Mondwest" pitchFamily="34" charset="0"/>
+                <a:ea typeface="PP Mondwest" pitchFamily="34" charset="-122"/>
+                <a:cs typeface="PP Mondwest" pitchFamily="34" charset="-120"/>
               </a:rPr>
               <a:t>Conclusion: A Silicon-Dependent Civilization</a:t>
             </a:r>
@@ -5815,9 +5815,9 @@
                 <a:solidFill>
                   <a:srgbClr val="6B6560"/>
                 </a:solidFill>
-                <a:latin typeface="Arial" pitchFamily="34" charset="0"/>
-                <a:ea typeface="Arial" pitchFamily="34" charset="-122"/>
-                <a:cs typeface="Arial" pitchFamily="34" charset="-120"/>
+                <a:latin typeface="VVDS Fifties" pitchFamily="34" charset="0"/>
+                <a:ea typeface="VVDS Fifties" pitchFamily="34" charset="-122"/>
+                <a:cs typeface="VVDS Fifties" pitchFamily="34" charset="-120"/>
               </a:rPr>
               <a:t>The 2026 Semiconductor Ecosystem | Slide 17</a:t>
             </a:r>
@@ -5879,9 +5879,9 @@
                 <a:solidFill>
                   <a:srgbClr val="B84A2F"/>
                 </a:solidFill>
-                <a:latin typeface="Arial" pitchFamily="34" charset="0"/>
-                <a:ea typeface="Arial" pitchFamily="34" charset="-122"/>
-                <a:cs typeface="Arial" pitchFamily="34" charset="-120"/>
+                <a:latin typeface="VVDS Fifties" pitchFamily="34" charset="0"/>
+                <a:ea typeface="VVDS Fifties" pitchFamily="34" charset="-122"/>
+                <a:cs typeface="VVDS Fifties" pitchFamily="34" charset="-120"/>
               </a:rPr>
               <a:t>Key Message: We have reached a point of "Total Silicon Dependency." The path to a $2 trillion industry is certain.</a:t>
             </a:r>
@@ -5918,9 +5918,9 @@
                 <a:solidFill>
                   <a:srgbClr val="6B6560"/>
                 </a:solidFill>
-                <a:latin typeface="Arial" pitchFamily="34" charset="0"/>
-                <a:ea typeface="Arial" pitchFamily="34" charset="-122"/>
-                <a:cs typeface="Arial" pitchFamily="34" charset="-120"/>
+                <a:latin typeface="VVDS Fifties" pitchFamily="34" charset="0"/>
+                <a:ea typeface="VVDS Fifties" pitchFamily="34" charset="-122"/>
+                <a:cs typeface="VVDS Fifties" pitchFamily="34" charset="-120"/>
               </a:rPr>
               <a:t>Mastery of the semiconductor ecosystem is mastery of the future. The "Chip Wars" aren't just about manufacturing; they are about who can best harness silicon to transform their industries.</a:t>
             </a:r>
@@ -5957,9 +5957,9 @@
                 <a:solidFill>
                   <a:srgbClr val="1A1714"/>
                 </a:solidFill>
-                <a:latin typeface="Arial" pitchFamily="34" charset="0"/>
-                <a:ea typeface="Arial" pitchFamily="34" charset="-122"/>
-                <a:cs typeface="Arial" pitchFamily="34" charset="-120"/>
+                <a:latin typeface="VVDS Fifties" pitchFamily="34" charset="0"/>
+                <a:ea typeface="VVDS Fifties" pitchFamily="34" charset="-122"/>
+                <a:cs typeface="VVDS Fifties" pitchFamily="34" charset="-120"/>
               </a:rPr>
               <a:t>KEY TAKEAWAYS SUMMARY</a:t>
             </a:r>
@@ -6021,9 +6021,9 @@
                 <a:solidFill>
                   <a:srgbClr val="B84A2F"/>
                 </a:solidFill>
-                <a:latin typeface="Georgia" pitchFamily="34" charset="0"/>
-                <a:ea typeface="Georgia" pitchFamily="34" charset="-122"/>
-                <a:cs typeface="Georgia" pitchFamily="34" charset="-120"/>
+                <a:latin typeface="PP Mondwest" pitchFamily="34" charset="0"/>
+                <a:ea typeface="PP Mondwest" pitchFamily="34" charset="-122"/>
+                <a:cs typeface="PP Mondwest" pitchFamily="34" charset="-120"/>
               </a:rPr>
               <a:t>Procurement</a:t>
             </a:r>
@@ -6060,9 +6060,9 @@
                 <a:solidFill>
                   <a:srgbClr val="6B6560"/>
                 </a:solidFill>
-                <a:latin typeface="Arial" pitchFamily="34" charset="0"/>
-                <a:ea typeface="Arial" pitchFamily="34" charset="-122"/>
-                <a:cs typeface="Arial" pitchFamily="34" charset="-120"/>
+                <a:latin typeface="VVDS Fifties" pitchFamily="34" charset="0"/>
+                <a:ea typeface="VVDS Fifties" pitchFamily="34" charset="-122"/>
+                <a:cs typeface="VVDS Fifties" pitchFamily="34" charset="-120"/>
               </a:rPr>
               <a:t>Shift from JIT to Strategic Hybrid; resilience is the new ROI.</a:t>
             </a:r>
@@ -6124,9 +6124,9 @@
                 <a:solidFill>
                   <a:srgbClr val="9E7D84"/>
                 </a:solidFill>
-                <a:latin typeface="Georgia" pitchFamily="34" charset="0"/>
-                <a:ea typeface="Georgia" pitchFamily="34" charset="-122"/>
-                <a:cs typeface="Georgia" pitchFamily="34" charset="-120"/>
+                <a:latin typeface="PP Mondwest" pitchFamily="34" charset="0"/>
+                <a:ea typeface="PP Mondwest" pitchFamily="34" charset="-122"/>
+                <a:cs typeface="PP Mondwest" pitchFamily="34" charset="-120"/>
               </a:rPr>
               <a:t>Supply Chain</a:t>
             </a:r>
@@ -6163,9 +6163,9 @@
                 <a:solidFill>
                   <a:srgbClr val="6B6560"/>
                 </a:solidFill>
-                <a:latin typeface="Arial" pitchFamily="34" charset="0"/>
-                <a:ea typeface="Arial" pitchFamily="34" charset="-122"/>
-                <a:cs typeface="Arial" pitchFamily="34" charset="-120"/>
+                <a:latin typeface="VVDS Fifties" pitchFamily="34" charset="0"/>
+                <a:ea typeface="VVDS Fifties" pitchFamily="34" charset="-122"/>
+                <a:cs typeface="VVDS Fifties" pitchFamily="34" charset="-120"/>
               </a:rPr>
               <a:t>Chokepoints in Advanced Packaging and SME are the new strategic risks.</a:t>
             </a:r>
@@ -6227,9 +6227,9 @@
                 <a:solidFill>
                   <a:srgbClr val="768C7C"/>
                 </a:solidFill>
-                <a:latin typeface="Georgia" pitchFamily="34" charset="0"/>
-                <a:ea typeface="Georgia" pitchFamily="34" charset="-122"/>
-                <a:cs typeface="Georgia" pitchFamily="34" charset="-120"/>
+                <a:latin typeface="PP Mondwest" pitchFamily="34" charset="0"/>
+                <a:ea typeface="PP Mondwest" pitchFamily="34" charset="-122"/>
+                <a:cs typeface="PP Mondwest" pitchFamily="34" charset="-120"/>
               </a:rPr>
               <a:t>Industries</a:t>
             </a:r>
@@ -6266,9 +6266,9 @@
                 <a:solidFill>
                   <a:srgbClr val="6B6560"/>
                 </a:solidFill>
-                <a:latin typeface="Arial" pitchFamily="34" charset="0"/>
-                <a:ea typeface="Arial" pitchFamily="34" charset="-122"/>
-                <a:cs typeface="Arial" pitchFamily="34" charset="-120"/>
+                <a:latin typeface="VVDS Fifties" pitchFamily="34" charset="0"/>
+                <a:ea typeface="VVDS Fifties" pitchFamily="34" charset="-122"/>
+                <a:cs typeface="VVDS Fifties" pitchFamily="34" charset="-120"/>
               </a:rPr>
               <a:t>AI is the Value King; Automotive is the Volume King.</a:t>
             </a:r>
@@ -6337,9 +6337,9 @@
                 <a:solidFill>
                   <a:srgbClr val="B84A2F"/>
                 </a:solidFill>
-                <a:latin typeface="Arial" pitchFamily="34" charset="0"/>
-                <a:ea typeface="Arial" pitchFamily="34" charset="-122"/>
-                <a:cs typeface="Arial" pitchFamily="34" charset="-120"/>
+                <a:latin typeface="VVDS Fifties" pitchFamily="34" charset="0"/>
+                <a:ea typeface="VVDS Fifties" pitchFamily="34" charset="-122"/>
+                <a:cs typeface="VVDS Fifties" pitchFamily="34" charset="-120"/>
               </a:rPr>
               <a:t>PART 1: PROCUREMENT OF SEMICONDUCTORS</a:t>
             </a:r>
@@ -6376,9 +6376,9 @@
                 <a:solidFill>
                   <a:srgbClr val="1A1714"/>
                 </a:solidFill>
-                <a:latin typeface="Georgia" pitchFamily="34" charset="0"/>
-                <a:ea typeface="Georgia" pitchFamily="34" charset="-122"/>
-                <a:cs typeface="Georgia" pitchFamily="34" charset="-120"/>
+                <a:latin typeface="PP Mondwest" pitchFamily="34" charset="0"/>
+                <a:ea typeface="PP Mondwest" pitchFamily="34" charset="-122"/>
+                <a:cs typeface="PP Mondwest" pitchFamily="34" charset="-120"/>
               </a:rPr>
               <a:t>Executive Summary: The Procurement Paradox</a:t>
             </a:r>
@@ -6415,9 +6415,9 @@
                 <a:solidFill>
                   <a:srgbClr val="6B6560"/>
                 </a:solidFill>
-                <a:latin typeface="Arial" pitchFamily="34" charset="0"/>
-                <a:ea typeface="Arial" pitchFamily="34" charset="-122"/>
-                <a:cs typeface="Arial" pitchFamily="34" charset="-120"/>
+                <a:latin typeface="VVDS Fifties" pitchFamily="34" charset="0"/>
+                <a:ea typeface="VVDS Fifties" pitchFamily="34" charset="-122"/>
+                <a:cs typeface="VVDS Fifties" pitchFamily="34" charset="-120"/>
               </a:rPr>
               <a:t>The 2026 Semiconductor Ecosystem | Slide 02</a:t>
             </a:r>
@@ -6479,9 +6479,9 @@
                 <a:solidFill>
                   <a:srgbClr val="B84A2F"/>
                 </a:solidFill>
-                <a:latin typeface="Arial" pitchFamily="34" charset="0"/>
-                <a:ea typeface="Arial" pitchFamily="34" charset="-122"/>
-                <a:cs typeface="Arial" pitchFamily="34" charset="-120"/>
+                <a:latin typeface="VVDS Fifties" pitchFamily="34" charset="0"/>
+                <a:ea typeface="VVDS Fifties" pitchFamily="34" charset="-122"/>
+                <a:cs typeface="VVDS Fifties" pitchFamily="34" charset="-120"/>
               </a:rPr>
               <a:t>Key Message: Navigating a $1.3 trillion market requires balancing unprecedented growth with systemic supply chain fragility.</a:t>
             </a:r>
@@ -6519,9 +6519,9 @@
                 <a:solidFill>
                   <a:srgbClr val="6B6560"/>
                 </a:solidFill>
-                <a:latin typeface="Arial" pitchFamily="34" charset="0"/>
-                <a:ea typeface="Arial" pitchFamily="34" charset="-122"/>
-                <a:cs typeface="Arial" pitchFamily="34" charset="-120"/>
+                <a:latin typeface="VVDS Fifties" pitchFamily="34" charset="0"/>
+                <a:ea typeface="VVDS Fifties" pitchFamily="34" charset="-122"/>
+                <a:cs typeface="VVDS Fifties" pitchFamily="34" charset="-120"/>
               </a:rPr>
               <a:t>- Record-High Valuations: Growth is driven by explosive global demand for AI systems and electric vehicle power logic.</a:t>
             </a:r>
@@ -6544,9 +6544,9 @@
                 <a:solidFill>
                   <a:srgbClr val="6B6560"/>
                 </a:solidFill>
-                <a:latin typeface="Arial" pitchFamily="34" charset="0"/>
-                <a:ea typeface="Arial" pitchFamily="34" charset="-122"/>
-                <a:cs typeface="Arial" pitchFamily="34" charset="-120"/>
+                <a:latin typeface="VVDS Fifties" pitchFamily="34" charset="0"/>
+                <a:ea typeface="VVDS Fifties" pitchFamily="34" charset="-122"/>
+                <a:cs typeface="VVDS Fifties" pitchFamily="34" charset="-120"/>
               </a:rPr>
               <a:t>- Systemic Fragility: Leading-edge fabs operate near maximum capacity, leaving the industry vulnerable to minor material delays.</a:t>
             </a:r>
@@ -6569,9 +6569,9 @@
                 <a:solidFill>
                   <a:srgbClr val="6B6560"/>
                 </a:solidFill>
-                <a:latin typeface="Arial" pitchFamily="34" charset="0"/>
-                <a:ea typeface="Arial" pitchFamily="34" charset="-122"/>
-                <a:cs typeface="Arial" pitchFamily="34" charset="-120"/>
+                <a:latin typeface="VVDS Fifties" pitchFamily="34" charset="0"/>
+                <a:ea typeface="VVDS Fifties" pitchFamily="34" charset="-122"/>
+                <a:cs typeface="VVDS Fifties" pitchFamily="34" charset="-120"/>
               </a:rPr>
               <a:t>- Strategic Pivot: Sourcing HBM (High Bandwidth Memory) and advanced logic requires a shift from transactional purchasing to capacity reservation models.</a:t>
             </a:r>
@@ -6633,9 +6633,9 @@
                 <a:solidFill>
                   <a:srgbClr val="B84A2F"/>
                 </a:solidFill>
-                <a:latin typeface="Arial" pitchFamily="34" charset="0"/>
-                <a:ea typeface="Arial" pitchFamily="34" charset="-122"/>
-                <a:cs typeface="Arial" pitchFamily="34" charset="-120"/>
+                <a:latin typeface="VVDS Fifties" pitchFamily="34" charset="0"/>
+                <a:ea typeface="VVDS Fifties" pitchFamily="34" charset="-122"/>
+                <a:cs typeface="VVDS Fifties" pitchFamily="34" charset="-120"/>
               </a:rPr>
               <a:t>ESTIMATE</a:t>
             </a:r>
@@ -6672,9 +6672,9 @@
                 <a:solidFill>
                   <a:srgbClr val="1A1714"/>
                 </a:solidFill>
-                <a:latin typeface="Georgia" pitchFamily="34" charset="0"/>
-                <a:ea typeface="Georgia" pitchFamily="34" charset="-122"/>
-                <a:cs typeface="Georgia" pitchFamily="34" charset="-120"/>
+                <a:latin typeface="PP Mondwest" pitchFamily="34" charset="0"/>
+                <a:ea typeface="PP Mondwest" pitchFamily="34" charset="-122"/>
+                <a:cs typeface="PP Mondwest" pitchFamily="34" charset="-120"/>
               </a:rPr>
               <a:t>$1.3T</a:t>
             </a:r>
@@ -6711,9 +6711,9 @@
                 <a:solidFill>
                   <a:srgbClr val="6B6560"/>
                 </a:solidFill>
-                <a:latin typeface="Arial" pitchFamily="34" charset="0"/>
-                <a:ea typeface="Arial" pitchFamily="34" charset="-122"/>
-                <a:cs typeface="Arial" pitchFamily="34" charset="-120"/>
+                <a:latin typeface="VVDS Fifties" pitchFamily="34" charset="0"/>
+                <a:ea typeface="VVDS Fifties" pitchFamily="34" charset="-122"/>
+                <a:cs typeface="VVDS Fifties" pitchFamily="34" charset="-120"/>
               </a:rPr>
               <a:t>Global Market Value</a:t>
             </a:r>
@@ -6728,9 +6728,9 @@
                 <a:solidFill>
                   <a:srgbClr val="6B6560"/>
                 </a:solidFill>
-                <a:latin typeface="Arial" pitchFamily="34" charset="0"/>
-                <a:ea typeface="Arial" pitchFamily="34" charset="-122"/>
-                <a:cs typeface="Arial" pitchFamily="34" charset="-120"/>
+                <a:latin typeface="VVDS Fifties" pitchFamily="34" charset="0"/>
+                <a:ea typeface="VVDS Fifties" pitchFamily="34" charset="-122"/>
+                <a:cs typeface="VVDS Fifties" pitchFamily="34" charset="-120"/>
               </a:rPr>
               <a:t>Analyst consensus 2026</a:t>
             </a:r>
@@ -6799,9 +6799,9 @@
                 <a:solidFill>
                   <a:srgbClr val="B84A2F"/>
                 </a:solidFill>
-                <a:latin typeface="Arial" pitchFamily="34" charset="0"/>
-                <a:ea typeface="Arial" pitchFamily="34" charset="-122"/>
-                <a:cs typeface="Arial" pitchFamily="34" charset="-120"/>
+                <a:latin typeface="VVDS Fifties" pitchFamily="34" charset="0"/>
+                <a:ea typeface="VVDS Fifties" pitchFamily="34" charset="-122"/>
+                <a:cs typeface="VVDS Fifties" pitchFamily="34" charset="-120"/>
               </a:rPr>
               <a:t>PART 1: PROCUREMENT OF SEMICONDUCTORS</a:t>
             </a:r>
@@ -6838,9 +6838,9 @@
                 <a:solidFill>
                   <a:srgbClr val="1A1714"/>
                 </a:solidFill>
-                <a:latin typeface="Georgia" pitchFamily="34" charset="0"/>
-                <a:ea typeface="Georgia" pitchFamily="34" charset="-122"/>
-                <a:cs typeface="Georgia" pitchFamily="34" charset="-120"/>
+                <a:latin typeface="PP Mondwest" pitchFamily="34" charset="0"/>
+                <a:ea typeface="PP Mondwest" pitchFamily="34" charset="-122"/>
+                <a:cs typeface="PP Mondwest" pitchFamily="34" charset="-120"/>
               </a:rPr>
               <a:t>Evolution of Procurement: The Strategic Hybrid Model</a:t>
             </a:r>
@@ -6877,9 +6877,9 @@
                 <a:solidFill>
                   <a:srgbClr val="6B6560"/>
                 </a:solidFill>
-                <a:latin typeface="Arial" pitchFamily="34" charset="0"/>
-                <a:ea typeface="Arial" pitchFamily="34" charset="-122"/>
-                <a:cs typeface="Arial" pitchFamily="34" charset="-120"/>
+                <a:latin typeface="VVDS Fifties" pitchFamily="34" charset="0"/>
+                <a:ea typeface="VVDS Fifties" pitchFamily="34" charset="-122"/>
+                <a:cs typeface="VVDS Fifties" pitchFamily="34" charset="-120"/>
               </a:rPr>
               <a:t>The 2026 Semiconductor Ecosystem | Slide 03</a:t>
             </a:r>
@@ -6941,9 +6941,9 @@
                 <a:solidFill>
                   <a:srgbClr val="9E7D84"/>
                 </a:solidFill>
-                <a:latin typeface="Arial" pitchFamily="34" charset="0"/>
-                <a:ea typeface="Arial" pitchFamily="34" charset="-122"/>
-                <a:cs typeface="Arial" pitchFamily="34" charset="-120"/>
+                <a:latin typeface="VVDS Fifties" pitchFamily="34" charset="0"/>
+                <a:ea typeface="VVDS Fifties" pitchFamily="34" charset="-122"/>
+                <a:cs typeface="VVDS Fifties" pitchFamily="34" charset="-120"/>
               </a:rPr>
               <a:t>Key Message: Pure JIT is obsolete; the new standard is a hybrid approach that prioritizes resilience for high-value nodes.</a:t>
             </a:r>
@@ -7005,9 +7005,9 @@
                 <a:solidFill>
                   <a:srgbClr val="B84A2F"/>
                 </a:solidFill>
-                <a:latin typeface="Georgia" pitchFamily="34" charset="0"/>
-                <a:ea typeface="Georgia" pitchFamily="34" charset="-122"/>
-                <a:cs typeface="Georgia" pitchFamily="34" charset="-120"/>
+                <a:latin typeface="PP Mondwest" pitchFamily="34" charset="0"/>
+                <a:ea typeface="PP Mondwest" pitchFamily="34" charset="-122"/>
+                <a:cs typeface="PP Mondwest" pitchFamily="34" charset="-120"/>
               </a:rPr>
               <a:t>Lean JIT (Commoditized Nodes)</a:t>
             </a:r>
@@ -7044,9 +7044,9 @@
                 <a:solidFill>
                   <a:srgbClr val="6B6560"/>
                 </a:solidFill>
-                <a:latin typeface="Arial" pitchFamily="34" charset="0"/>
-                <a:ea typeface="Arial" pitchFamily="34" charset="-122"/>
-                <a:cs typeface="Arial" pitchFamily="34" charset="-120"/>
+                <a:latin typeface="VVDS Fifties" pitchFamily="34" charset="0"/>
+                <a:ea typeface="VVDS Fifties" pitchFamily="34" charset="-122"/>
+                <a:cs typeface="VVDS Fifties" pitchFamily="34" charset="-120"/>
               </a:rPr>
               <a:t>Used for standardized legacy passive elements and commoditized logic chips. Minimizes capital lock-up and inventory holding costs while keeping storage footprint low.</a:t>
             </a:r>
@@ -7108,9 +7108,9 @@
                 <a:solidFill>
                   <a:srgbClr val="9E7D84"/>
                 </a:solidFill>
-                <a:latin typeface="Georgia" pitchFamily="34" charset="0"/>
-                <a:ea typeface="Georgia" pitchFamily="34" charset="-122"/>
-                <a:cs typeface="Georgia" pitchFamily="34" charset="-120"/>
+                <a:latin typeface="PP Mondwest" pitchFamily="34" charset="0"/>
+                <a:ea typeface="PP Mondwest" pitchFamily="34" charset="-122"/>
+                <a:cs typeface="PP Mondwest" pitchFamily="34" charset="-120"/>
               </a:rPr>
               <a:t>Strategic Buffers (Critical Nodes)</a:t>
             </a:r>
@@ -7147,9 +7147,9 @@
                 <a:solidFill>
                   <a:srgbClr val="6B6560"/>
                 </a:solidFill>
-                <a:latin typeface="Arial" pitchFamily="34" charset="0"/>
-                <a:ea typeface="Arial" pitchFamily="34" charset="-122"/>
-                <a:cs typeface="Arial" pitchFamily="34" charset="-120"/>
+                <a:latin typeface="VVDS Fifties" pitchFamily="34" charset="0"/>
+                <a:ea typeface="VVDS Fifties" pitchFamily="34" charset="-122"/>
+                <a:cs typeface="VVDS Fifties" pitchFamily="34" charset="-120"/>
               </a:rPr>
               <a:t>Maintaining 3 to 6 months of safety stock for sole-sourced, high-margin microcomponents (HBM, custom GPUs) to guarantee manufacturing continuity.</a:t>
             </a:r>
@@ -7218,9 +7218,9 @@
                 <a:solidFill>
                   <a:srgbClr val="B84A2F"/>
                 </a:solidFill>
-                <a:latin typeface="Arial" pitchFamily="34" charset="0"/>
-                <a:ea typeface="Arial" pitchFamily="34" charset="-122"/>
-                <a:cs typeface="Arial" pitchFamily="34" charset="-120"/>
+                <a:latin typeface="VVDS Fifties" pitchFamily="34" charset="0"/>
+                <a:ea typeface="VVDS Fifties" pitchFamily="34" charset="-122"/>
+                <a:cs typeface="VVDS Fifties" pitchFamily="34" charset="-120"/>
               </a:rPr>
               <a:t>PART 1: PROCUREMENT OF SEMICONDUCTORS</a:t>
             </a:r>
@@ -7257,9 +7257,9 @@
                 <a:solidFill>
                   <a:srgbClr val="1A1714"/>
                 </a:solidFill>
-                <a:latin typeface="Georgia" pitchFamily="34" charset="0"/>
-                <a:ea typeface="Georgia" pitchFamily="34" charset="-122"/>
-                <a:cs typeface="Georgia" pitchFamily="34" charset="-120"/>
+                <a:latin typeface="PP Mondwest" pitchFamily="34" charset="0"/>
+                <a:ea typeface="PP Mondwest" pitchFamily="34" charset="-122"/>
+                <a:cs typeface="PP Mondwest" pitchFamily="34" charset="-120"/>
               </a:rPr>
               <a:t>Key Procurement Challenges &amp; Strategic Sourcing</a:t>
             </a:r>
@@ -7296,9 +7296,9 @@
                 <a:solidFill>
                   <a:srgbClr val="6B6560"/>
                 </a:solidFill>
-                <a:latin typeface="Arial" pitchFamily="34" charset="0"/>
-                <a:ea typeface="Arial" pitchFamily="34" charset="-122"/>
-                <a:cs typeface="Arial" pitchFamily="34" charset="-120"/>
+                <a:latin typeface="VVDS Fifties" pitchFamily="34" charset="0"/>
+                <a:ea typeface="VVDS Fifties" pitchFamily="34" charset="-122"/>
+                <a:cs typeface="VVDS Fifties" pitchFamily="34" charset="-120"/>
               </a:rPr>
               <a:t>The 2026 Semiconductor Ecosystem | Slide 04</a:t>
             </a:r>
@@ -7360,9 +7360,9 @@
                 <a:solidFill>
                   <a:srgbClr val="768C7C"/>
                 </a:solidFill>
-                <a:latin typeface="Arial" pitchFamily="34" charset="0"/>
-                <a:ea typeface="Arial" pitchFamily="34" charset="-122"/>
-                <a:cs typeface="Arial" pitchFamily="34" charset="-120"/>
+                <a:latin typeface="VVDS Fifties" pitchFamily="34" charset="0"/>
+                <a:ea typeface="VVDS Fifties" pitchFamily="34" charset="-122"/>
+                <a:cs typeface="VVDS Fifties" pitchFamily="34" charset="-120"/>
               </a:rPr>
               <a:t>Key Message: Data opacity and reactive risk management are the primary enemies of a resilient procurement strategy.</a:t>
             </a:r>
@@ -7400,9 +7400,9 @@
                 <a:solidFill>
                   <a:srgbClr val="6B6560"/>
                 </a:solidFill>
-                <a:latin typeface="Arial" pitchFamily="34" charset="0"/>
-                <a:ea typeface="Arial" pitchFamily="34" charset="-122"/>
-                <a:cs typeface="Arial" pitchFamily="34" charset="-120"/>
+                <a:latin typeface="VVDS Fifties" pitchFamily="34" charset="0"/>
+                <a:ea typeface="VVDS Fifties" pitchFamily="34" charset="-122"/>
+                <a:cs typeface="VVDS Fifties" pitchFamily="34" charset="-120"/>
               </a:rPr>
               <a:t>- Category Management Sourcing: Slicing procurement into precise technology nodes (Leading-edge sub-7nm vs Legacy nodes).</a:t>
             </a:r>
@@ -7425,9 +7425,9 @@
                 <a:solidFill>
                   <a:srgbClr val="6B6560"/>
                 </a:solidFill>
-                <a:latin typeface="Arial" pitchFamily="34" charset="0"/>
-                <a:ea typeface="Arial" pitchFamily="34" charset="-122"/>
-                <a:cs typeface="Arial" pitchFamily="34" charset="-120"/>
+                <a:latin typeface="VVDS Fifties" pitchFamily="34" charset="0"/>
+                <a:ea typeface="VVDS Fifties" pitchFamily="34" charset="-122"/>
+                <a:cs typeface="VVDS Fifties" pitchFamily="34" charset="-120"/>
               </a:rPr>
               <a:t>- Leading-edge Sourcing: Focuses on deep co-development partnerships, engineering collaboration, and long-term volume commitments.</a:t>
             </a:r>
@@ -7450,9 +7450,9 @@
                 <a:solidFill>
                   <a:srgbClr val="6B6560"/>
                 </a:solidFill>
-                <a:latin typeface="Arial" pitchFamily="34" charset="0"/>
-                <a:ea typeface="Arial" pitchFamily="34" charset="-122"/>
-                <a:cs typeface="Arial" pitchFamily="34" charset="-120"/>
+                <a:latin typeface="VVDS Fifties" pitchFamily="34" charset="0"/>
+                <a:ea typeface="VVDS Fifties" pitchFamily="34" charset="-122"/>
+                <a:cs typeface="VVDS Fifties" pitchFamily="34" charset="-120"/>
               </a:rPr>
               <a:t>- Legacy Sourcing: Emphasizes multi-sourcing, second-sourcing qualification, and legacy lifecycle management to offset obsolescence.</a:t>
             </a:r>
@@ -7514,9 +7514,9 @@
                 <a:solidFill>
                   <a:srgbClr val="6B6560"/>
                 </a:solidFill>
-                <a:latin typeface="Arial" pitchFamily="34" charset="0"/>
-                <a:ea typeface="Arial" pitchFamily="34" charset="-122"/>
-                <a:cs typeface="Arial" pitchFamily="34" charset="-120"/>
+                <a:latin typeface="VVDS Fifties" pitchFamily="34" charset="0"/>
+                <a:ea typeface="VVDS Fifties" pitchFamily="34" charset="-122"/>
+                <a:cs typeface="VVDS Fifties" pitchFamily="34" charset="-120"/>
               </a:rPr>
               <a:t>Leading-Edge Nodes</a:t>
             </a:r>
@@ -7537,9 +7537,9 @@
                 <a:solidFill>
                   <a:srgbClr val="6B6560"/>
                 </a:solidFill>
-                <a:latin typeface="Arial" pitchFamily="34" charset="0"/>
-                <a:ea typeface="Arial" pitchFamily="34" charset="-122"/>
-                <a:cs typeface="Arial" pitchFamily="34" charset="-120"/>
+                <a:latin typeface="VVDS Fifties" pitchFamily="34" charset="0"/>
+                <a:ea typeface="VVDS Fifties" pitchFamily="34" charset="-122"/>
+                <a:cs typeface="VVDS Fifties" pitchFamily="34" charset="-120"/>
               </a:rPr>
               <a:t>Focus: Deep alliances, R&amp;D partnerships, capacity reservations.</a:t>
             </a:r>
@@ -7601,9 +7601,9 @@
                 <a:solidFill>
                   <a:srgbClr val="6B6560"/>
                 </a:solidFill>
-                <a:latin typeface="Arial" pitchFamily="34" charset="0"/>
-                <a:ea typeface="Arial" pitchFamily="34" charset="-122"/>
-                <a:cs typeface="Arial" pitchFamily="34" charset="-120"/>
+                <a:latin typeface="VVDS Fifties" pitchFamily="34" charset="0"/>
+                <a:ea typeface="VVDS Fifties" pitchFamily="34" charset="-122"/>
+                <a:cs typeface="VVDS Fifties" pitchFamily="34" charset="-120"/>
               </a:rPr>
               <a:t>Legacy Nodes</a:t>
             </a:r>
@@ -7624,9 +7624,9 @@
                 <a:solidFill>
                   <a:srgbClr val="6B6560"/>
                 </a:solidFill>
-                <a:latin typeface="Arial" pitchFamily="34" charset="0"/>
-                <a:ea typeface="Arial" pitchFamily="34" charset="-122"/>
-                <a:cs typeface="Arial" pitchFamily="34" charset="-120"/>
+                <a:latin typeface="VVDS Fifties" pitchFamily="34" charset="0"/>
+                <a:ea typeface="VVDS Fifties" pitchFamily="34" charset="-122"/>
+                <a:cs typeface="VVDS Fifties" pitchFamily="34" charset="-120"/>
               </a:rPr>
               <a:t>Focus: Multi-sourcing, distributor networks, life-cycle tracking.</a:t>
             </a:r>
@@ -7695,9 +7695,9 @@
                 <a:solidFill>
                   <a:srgbClr val="B84A2F"/>
                 </a:solidFill>
-                <a:latin typeface="Arial" pitchFamily="34" charset="0"/>
-                <a:ea typeface="Arial" pitchFamily="34" charset="-122"/>
-                <a:cs typeface="Arial" pitchFamily="34" charset="-120"/>
+                <a:latin typeface="VVDS Fifties" pitchFamily="34" charset="0"/>
+                <a:ea typeface="VVDS Fifties" pitchFamily="34" charset="-122"/>
+                <a:cs typeface="VVDS Fifties" pitchFamily="34" charset="-120"/>
               </a:rPr>
               <a:t>PART 1: PROCUREMENT OF SEMICONDUCTORS</a:t>
             </a:r>
@@ -7734,9 +7734,9 @@
                 <a:solidFill>
                   <a:srgbClr val="1A1714"/>
                 </a:solidFill>
-                <a:latin typeface="Georgia" pitchFamily="34" charset="0"/>
-                <a:ea typeface="Georgia" pitchFamily="34" charset="-122"/>
-                <a:cs typeface="Georgia" pitchFamily="34" charset="-120"/>
+                <a:latin typeface="PP Mondwest" pitchFamily="34" charset="0"/>
+                <a:ea typeface="PP Mondwest" pitchFamily="34" charset="-122"/>
+                <a:cs typeface="PP Mondwest" pitchFamily="34" charset="-120"/>
               </a:rPr>
               <a:t>Digitalization &amp; Resilience in Procurement</a:t>
             </a:r>
@@ -7773,9 +7773,9 @@
                 <a:solidFill>
                   <a:srgbClr val="6B6560"/>
                 </a:solidFill>
-                <a:latin typeface="Arial" pitchFamily="34" charset="0"/>
-                <a:ea typeface="Arial" pitchFamily="34" charset="-122"/>
-                <a:cs typeface="Arial" pitchFamily="34" charset="-120"/>
+                <a:latin typeface="VVDS Fifties" pitchFamily="34" charset="0"/>
+                <a:ea typeface="VVDS Fifties" pitchFamily="34" charset="-122"/>
+                <a:cs typeface="VVDS Fifties" pitchFamily="34" charset="-120"/>
               </a:rPr>
               <a:t>The 2026 Semiconductor Ecosystem | Slide 05</a:t>
             </a:r>
@@ -7837,9 +7837,9 @@
                 <a:solidFill>
                   <a:srgbClr val="B84A2F"/>
                 </a:solidFill>
-                <a:latin typeface="Arial" pitchFamily="34" charset="0"/>
-                <a:ea typeface="Arial" pitchFamily="34" charset="-122"/>
-                <a:cs typeface="Arial" pitchFamily="34" charset="-120"/>
+                <a:latin typeface="VVDS Fifties" pitchFamily="34" charset="0"/>
+                <a:ea typeface="VVDS Fifties" pitchFamily="34" charset="-122"/>
+                <a:cs typeface="VVDS Fifties" pitchFamily="34" charset="-120"/>
               </a:rPr>
               <a:t>Key Message: AI-driven "Business Intelligence Cockpits" are essential for predicting shortages 6-12 months in advance.</a:t>
             </a:r>
@@ -7901,9 +7901,9 @@
                 <a:solidFill>
                   <a:srgbClr val="B84A2F"/>
                 </a:solidFill>
-                <a:latin typeface="Georgia" pitchFamily="34" charset="0"/>
-                <a:ea typeface="Georgia" pitchFamily="34" charset="-122"/>
-                <a:cs typeface="Georgia" pitchFamily="34" charset="-120"/>
+                <a:latin typeface="PP Mondwest" pitchFamily="34" charset="0"/>
+                <a:ea typeface="PP Mondwest" pitchFamily="34" charset="-122"/>
+                <a:cs typeface="PP Mondwest" pitchFamily="34" charset="-120"/>
               </a:rPr>
               <a:t>LTA &amp; Reservation Fees</a:t>
             </a:r>
@@ -7940,9 +7940,9 @@
                 <a:solidFill>
                   <a:srgbClr val="6B6560"/>
                 </a:solidFill>
-                <a:latin typeface="Arial" pitchFamily="34" charset="0"/>
-                <a:ea typeface="Arial" pitchFamily="34" charset="-122"/>
-                <a:cs typeface="Arial" pitchFamily="34" charset="-120"/>
+                <a:latin typeface="VVDS Fifties" pitchFamily="34" charset="0"/>
+                <a:ea typeface="VVDS Fifties" pitchFamily="34" charset="-122"/>
+                <a:cs typeface="VVDS Fifties" pitchFamily="34" charset="-120"/>
               </a:rPr>
               <a:t>Securing fab slots requires upfront reservation fees and take-or-pay clauses in Long-Term Agreements (LTAs) to lock down volume.</a:t>
             </a:r>
@@ -8004,9 +8004,9 @@
                 <a:solidFill>
                   <a:srgbClr val="768C7C"/>
                 </a:solidFill>
-                <a:latin typeface="Georgia" pitchFamily="34" charset="0"/>
-                <a:ea typeface="Georgia" pitchFamily="34" charset="-122"/>
-                <a:cs typeface="Georgia" pitchFamily="34" charset="-120"/>
+                <a:latin typeface="PP Mondwest" pitchFamily="34" charset="0"/>
+                <a:ea typeface="PP Mondwest" pitchFamily="34" charset="-122"/>
+                <a:cs typeface="PP Mondwest" pitchFamily="34" charset="-120"/>
               </a:rPr>
               <a:t>Friend-Shoring Sourcing</a:t>
             </a:r>
@@ -8043,9 +8043,9 @@
                 <a:solidFill>
                   <a:srgbClr val="6B6560"/>
                 </a:solidFill>
-                <a:latin typeface="Arial" pitchFamily="34" charset="0"/>
-                <a:ea typeface="Arial" pitchFamily="34" charset="-122"/>
-                <a:cs typeface="Arial" pitchFamily="34" charset="-120"/>
+                <a:latin typeface="VVDS Fifties" pitchFamily="34" charset="0"/>
+                <a:ea typeface="VVDS Fifties" pitchFamily="34" charset="-122"/>
+                <a:cs typeface="VVDS Fifties" pitchFamily="34" charset="-120"/>
               </a:rPr>
               <a:t>Decoupling supply links from high-risk locations, redirecting procurement to allied geopolitical nodes with guaranteed supply lines.</a:t>
             </a:r>
@@ -8107,9 +8107,9 @@
                 <a:solidFill>
                   <a:srgbClr val="6B6560"/>
                 </a:solidFill>
-                <a:latin typeface="Arial" pitchFamily="34" charset="0"/>
-                <a:ea typeface="Arial" pitchFamily="34" charset="-122"/>
-                <a:cs typeface="Arial" pitchFamily="34" charset="-120"/>
+                <a:latin typeface="VVDS Fifties" pitchFamily="34" charset="0"/>
+                <a:ea typeface="VVDS Fifties" pitchFamily="34" charset="-122"/>
+                <a:cs typeface="VVDS Fifties" pitchFamily="34" charset="-120"/>
               </a:rPr>
               <a:t>AI integration automatically tracks tier-2 chemical and substrate suppliers to detect factory closures or export blocks before they ripple into final fab allocations.</a:t>
             </a:r>
@@ -8178,9 +8178,9 @@
                 <a:solidFill>
                   <a:srgbClr val="B84A2F"/>
                 </a:solidFill>
-                <a:latin typeface="Arial" pitchFamily="34" charset="0"/>
-                <a:ea typeface="Arial" pitchFamily="34" charset="-122"/>
-                <a:cs typeface="Arial" pitchFamily="34" charset="-120"/>
+                <a:latin typeface="VVDS Fifties" pitchFamily="34" charset="0"/>
+                <a:ea typeface="VVDS Fifties" pitchFamily="34" charset="-122"/>
+                <a:cs typeface="VVDS Fifties" pitchFamily="34" charset="-120"/>
               </a:rPr>
               <a:t>PART 2: THE GLOBAL SUPPLY CHAIN OF SEMICONDUCTORS</a:t>
             </a:r>
@@ -8217,9 +8217,9 @@
                 <a:solidFill>
                   <a:srgbClr val="1A1714"/>
                 </a:solidFill>
-                <a:latin typeface="Georgia" pitchFamily="34" charset="0"/>
-                <a:ea typeface="Georgia" pitchFamily="34" charset="-122"/>
-                <a:cs typeface="Georgia" pitchFamily="34" charset="-120"/>
+                <a:latin typeface="PP Mondwest" pitchFamily="34" charset="0"/>
+                <a:ea typeface="PP Mondwest" pitchFamily="34" charset="-122"/>
+                <a:cs typeface="PP Mondwest" pitchFamily="34" charset="-120"/>
               </a:rPr>
               <a:t>The Global Supply Chain: A Web of Complexity</a:t>
             </a:r>
@@ -8256,9 +8256,9 @@
                 <a:solidFill>
                   <a:srgbClr val="6B6560"/>
                 </a:solidFill>
-                <a:latin typeface="Arial" pitchFamily="34" charset="0"/>
-                <a:ea typeface="Arial" pitchFamily="34" charset="-122"/>
-                <a:cs typeface="Arial" pitchFamily="34" charset="-120"/>
+                <a:latin typeface="VVDS Fifties" pitchFamily="34" charset="0"/>
+                <a:ea typeface="VVDS Fifties" pitchFamily="34" charset="-122"/>
+                <a:cs typeface="VVDS Fifties" pitchFamily="34" charset="-120"/>
               </a:rPr>
               <a:t>The 2026 Semiconductor Ecosystem | Slide 06</a:t>
             </a:r>
@@ -8320,9 +8320,9 @@
                 <a:solidFill>
                   <a:srgbClr val="B84A2F"/>
                 </a:solidFill>
-                <a:latin typeface="Arial" pitchFamily="34" charset="0"/>
-                <a:ea typeface="Arial" pitchFamily="34" charset="-122"/>
-                <a:cs typeface="Arial" pitchFamily="34" charset="-120"/>
+                <a:latin typeface="VVDS Fifties" pitchFamily="34" charset="0"/>
+                <a:ea typeface="VVDS Fifties" pitchFamily="34" charset="-122"/>
+                <a:cs typeface="VVDS Fifties" pitchFamily="34" charset="-120"/>
               </a:rPr>
               <a:t>Key Message: A single chip may cross international borders over 70 times, making it the most geographically dispersed value chain in history.</a:t>
             </a:r>
@@ -8359,9 +8359,9 @@
                 <a:solidFill>
                   <a:srgbClr val="768C7C"/>
                 </a:solidFill>
-                <a:latin typeface="Arial" pitchFamily="34" charset="0"/>
-                <a:ea typeface="Arial" pitchFamily="34" charset="-122"/>
-                <a:cs typeface="Arial" pitchFamily="34" charset="-120"/>
+                <a:latin typeface="VVDS Fifties" pitchFamily="34" charset="0"/>
+                <a:ea typeface="VVDS Fifties" pitchFamily="34" charset="-122"/>
+                <a:cs typeface="VVDS Fifties" pitchFamily="34" charset="-120"/>
               </a:rPr>
               <a:t>THE SILICON JOURNEY</a:t>
             </a:r>
@@ -8423,9 +8423,9 @@
                 <a:solidFill>
                   <a:srgbClr val="B84A2F"/>
                 </a:solidFill>
-                <a:latin typeface="Georgia" pitchFamily="34" charset="0"/>
-                <a:ea typeface="Georgia" pitchFamily="34" charset="-122"/>
-                <a:cs typeface="Georgia" pitchFamily="34" charset="-120"/>
+                <a:latin typeface="PP Mondwest" pitchFamily="34" charset="0"/>
+                <a:ea typeface="PP Mondwest" pitchFamily="34" charset="-122"/>
+                <a:cs typeface="PP Mondwest" pitchFamily="34" charset="-120"/>
               </a:rPr>
               <a:t>1</a:t>
             </a:r>
@@ -8462,9 +8462,9 @@
                 <a:solidFill>
                   <a:srgbClr val="1A1714"/>
                 </a:solidFill>
-                <a:latin typeface="Arial" pitchFamily="34" charset="0"/>
-                <a:ea typeface="Arial" pitchFamily="34" charset="-122"/>
-                <a:cs typeface="Arial" pitchFamily="34" charset="-120"/>
+                <a:latin typeface="VVDS Fifties" pitchFamily="34" charset="0"/>
+                <a:ea typeface="VVDS Fifties" pitchFamily="34" charset="-122"/>
+                <a:cs typeface="VVDS Fifties" pitchFamily="34" charset="-120"/>
               </a:rPr>
               <a:t>US Design</a:t>
             </a:r>
@@ -8501,9 +8501,9 @@
                 <a:solidFill>
                   <a:srgbClr val="6B6560"/>
                 </a:solidFill>
-                <a:latin typeface="Arial" pitchFamily="34" charset="0"/>
-                <a:ea typeface="Arial" pitchFamily="34" charset="-122"/>
-                <a:cs typeface="Arial" pitchFamily="34" charset="-120"/>
+                <a:latin typeface="VVDS Fifties" pitchFamily="34" charset="0"/>
+                <a:ea typeface="VVDS Fifties" pitchFamily="34" charset="-122"/>
+                <a:cs typeface="VVDS Fifties" pitchFamily="34" charset="-120"/>
               </a:rPr>
               <a:t>Design &amp; EDA Tools</a:t>
             </a:r>
@@ -8565,9 +8565,9 @@
                 <a:solidFill>
                   <a:srgbClr val="B84A2F"/>
                 </a:solidFill>
-                <a:latin typeface="Georgia" pitchFamily="34" charset="0"/>
-                <a:ea typeface="Georgia" pitchFamily="34" charset="-122"/>
-                <a:cs typeface="Georgia" pitchFamily="34" charset="-120"/>
+                <a:latin typeface="PP Mondwest" pitchFamily="34" charset="0"/>
+                <a:ea typeface="PP Mondwest" pitchFamily="34" charset="-122"/>
+                <a:cs typeface="PP Mondwest" pitchFamily="34" charset="-120"/>
               </a:rPr>
               <a:t>2</a:t>
             </a:r>
@@ -8604,9 +8604,9 @@
                 <a:solidFill>
                   <a:srgbClr val="1A1714"/>
                 </a:solidFill>
-                <a:latin typeface="Arial" pitchFamily="34" charset="0"/>
-                <a:ea typeface="Arial" pitchFamily="34" charset="-122"/>
-                <a:cs typeface="Arial" pitchFamily="34" charset="-120"/>
+                <a:latin typeface="VVDS Fifties" pitchFamily="34" charset="0"/>
+                <a:ea typeface="VVDS Fifties" pitchFamily="34" charset="-122"/>
+                <a:cs typeface="VVDS Fifties" pitchFamily="34" charset="-120"/>
               </a:rPr>
               <a:t>Dutch SME</a:t>
             </a:r>
@@ -8643,9 +8643,9 @@
                 <a:solidFill>
                   <a:srgbClr val="6B6560"/>
                 </a:solidFill>
-                <a:latin typeface="Arial" pitchFamily="34" charset="0"/>
-                <a:ea typeface="Arial" pitchFamily="34" charset="-122"/>
-                <a:cs typeface="Arial" pitchFamily="34" charset="-120"/>
+                <a:latin typeface="VVDS Fifties" pitchFamily="34" charset="0"/>
+                <a:ea typeface="VVDS Fifties" pitchFamily="34" charset="-122"/>
+                <a:cs typeface="VVDS Fifties" pitchFamily="34" charset="-120"/>
               </a:rPr>
               <a:t>ASML EUV Optics</a:t>
             </a:r>
@@ -8707,9 +8707,9 @@
                 <a:solidFill>
                   <a:srgbClr val="B84A2F"/>
                 </a:solidFill>
-                <a:latin typeface="Georgia" pitchFamily="34" charset="0"/>
-                <a:ea typeface="Georgia" pitchFamily="34" charset="-122"/>
-                <a:cs typeface="Georgia" pitchFamily="34" charset="-120"/>
+                <a:latin typeface="PP Mondwest" pitchFamily="34" charset="0"/>
+                <a:ea typeface="PP Mondwest" pitchFamily="34" charset="-122"/>
+                <a:cs typeface="PP Mondwest" pitchFamily="34" charset="-120"/>
               </a:rPr>
               <a:t>3</a:t>
             </a:r>
@@ -8746,9 +8746,9 @@
                 <a:solidFill>
                   <a:srgbClr val="1A1714"/>
                 </a:solidFill>
-                <a:latin typeface="Arial" pitchFamily="34" charset="0"/>
-                <a:ea typeface="Arial" pitchFamily="34" charset="-122"/>
-                <a:cs typeface="Arial" pitchFamily="34" charset="-120"/>
+                <a:latin typeface="VVDS Fifties" pitchFamily="34" charset="0"/>
+                <a:ea typeface="VVDS Fifties" pitchFamily="34" charset="-122"/>
+                <a:cs typeface="VVDS Fifties" pitchFamily="34" charset="-120"/>
               </a:rPr>
               <a:t>Taiwan Fab</a:t>
             </a:r>
@@ -8785,9 +8785,9 @@
                 <a:solidFill>
                   <a:srgbClr val="6B6560"/>
                 </a:solidFill>
-                <a:latin typeface="Arial" pitchFamily="34" charset="0"/>
-                <a:ea typeface="Arial" pitchFamily="34" charset="-122"/>
-                <a:cs typeface="Arial" pitchFamily="34" charset="-120"/>
+                <a:latin typeface="VVDS Fifties" pitchFamily="34" charset="0"/>
+                <a:ea typeface="VVDS Fifties" pitchFamily="34" charset="-122"/>
+                <a:cs typeface="VVDS Fifties" pitchFamily="34" charset="-120"/>
               </a:rPr>
               <a:t>TSMC Printing</a:t>
             </a:r>
@@ -8849,9 +8849,9 @@
                 <a:solidFill>
                   <a:srgbClr val="B84A2F"/>
                 </a:solidFill>
-                <a:latin typeface="Georgia" pitchFamily="34" charset="0"/>
-                <a:ea typeface="Georgia" pitchFamily="34" charset="-122"/>
-                <a:cs typeface="Georgia" pitchFamily="34" charset="-120"/>
+                <a:latin typeface="PP Mondwest" pitchFamily="34" charset="0"/>
+                <a:ea typeface="PP Mondwest" pitchFamily="34" charset="-122"/>
+                <a:cs typeface="PP Mondwest" pitchFamily="34" charset="-120"/>
               </a:rPr>
               <a:t>4</a:t>
             </a:r>
@@ -8888,9 +8888,9 @@
                 <a:solidFill>
                   <a:srgbClr val="1A1714"/>
                 </a:solidFill>
-                <a:latin typeface="Arial" pitchFamily="34" charset="0"/>
-                <a:ea typeface="Arial" pitchFamily="34" charset="-122"/>
-                <a:cs typeface="Arial" pitchFamily="34" charset="-120"/>
+                <a:latin typeface="VVDS Fifties" pitchFamily="34" charset="0"/>
+                <a:ea typeface="VVDS Fifties" pitchFamily="34" charset="-122"/>
+                <a:cs typeface="VVDS Fifties" pitchFamily="34" charset="-120"/>
               </a:rPr>
               <a:t>Japan Material</a:t>
             </a:r>
@@ -8927,9 +8927,9 @@
                 <a:solidFill>
                   <a:srgbClr val="6B6560"/>
                 </a:solidFill>
-                <a:latin typeface="Arial" pitchFamily="34" charset="0"/>
-                <a:ea typeface="Arial" pitchFamily="34" charset="-122"/>
-                <a:cs typeface="Arial" pitchFamily="34" charset="-120"/>
+                <a:latin typeface="VVDS Fifties" pitchFamily="34" charset="0"/>
+                <a:ea typeface="VVDS Fifties" pitchFamily="34" charset="-122"/>
+                <a:cs typeface="VVDS Fifties" pitchFamily="34" charset="-120"/>
               </a:rPr>
               <a:t>Wafers &amp; Photoresist</a:t>
             </a:r>
@@ -8991,9 +8991,9 @@
                 <a:solidFill>
                   <a:srgbClr val="B84A2F"/>
                 </a:solidFill>
-                <a:latin typeface="Georgia" pitchFamily="34" charset="0"/>
-                <a:ea typeface="Georgia" pitchFamily="34" charset="-122"/>
-                <a:cs typeface="Georgia" pitchFamily="34" charset="-120"/>
+                <a:latin typeface="PP Mondwest" pitchFamily="34" charset="0"/>
+                <a:ea typeface="PP Mondwest" pitchFamily="34" charset="-122"/>
+                <a:cs typeface="PP Mondwest" pitchFamily="34" charset="-120"/>
               </a:rPr>
               <a:t>5</a:t>
             </a:r>
@@ -9030,9 +9030,9 @@
                 <a:solidFill>
                   <a:srgbClr val="1A1714"/>
                 </a:solidFill>
-                <a:latin typeface="Arial" pitchFamily="34" charset="0"/>
-                <a:ea typeface="Arial" pitchFamily="34" charset="-122"/>
-                <a:cs typeface="Arial" pitchFamily="34" charset="-120"/>
+                <a:latin typeface="VVDS Fifties" pitchFamily="34" charset="0"/>
+                <a:ea typeface="VVDS Fifties" pitchFamily="34" charset="-122"/>
+                <a:cs typeface="VVDS Fifties" pitchFamily="34" charset="-120"/>
               </a:rPr>
               <a:t>SE Asia Pack</a:t>
             </a:r>
@@ -9069,9 +9069,9 @@
                 <a:solidFill>
                   <a:srgbClr val="6B6560"/>
                 </a:solidFill>
-                <a:latin typeface="Arial" pitchFamily="34" charset="0"/>
-                <a:ea typeface="Arial" pitchFamily="34" charset="-122"/>
-                <a:cs typeface="Arial" pitchFamily="34" charset="-120"/>
+                <a:latin typeface="VVDS Fifties" pitchFamily="34" charset="0"/>
+                <a:ea typeface="VVDS Fifties" pitchFamily="34" charset="-122"/>
+                <a:cs typeface="VVDS Fifties" pitchFamily="34" charset="-120"/>
               </a:rPr>
               <a:t>OSAT Assembly</a:t>
             </a:r>
@@ -9140,9 +9140,9 @@
                 <a:solidFill>
                   <a:srgbClr val="B84A2F"/>
                 </a:solidFill>
-                <a:latin typeface="Arial" pitchFamily="34" charset="0"/>
-                <a:ea typeface="Arial" pitchFamily="34" charset="-122"/>
-                <a:cs typeface="Arial" pitchFamily="34" charset="-120"/>
+                <a:latin typeface="VVDS Fifties" pitchFamily="34" charset="0"/>
+                <a:ea typeface="VVDS Fifties" pitchFamily="34" charset="-122"/>
+                <a:cs typeface="VVDS Fifties" pitchFamily="34" charset="-120"/>
               </a:rPr>
               <a:t>PART 2: THE GLOBAL SUPPLY CHAIN OF SEMICONDUCTORS</a:t>
             </a:r>
@@ -9179,9 +9179,9 @@
                 <a:solidFill>
                   <a:srgbClr val="1A1714"/>
                 </a:solidFill>
-                <a:latin typeface="Georgia" pitchFamily="34" charset="0"/>
-                <a:ea typeface="Georgia" pitchFamily="34" charset="-122"/>
-                <a:cs typeface="Georgia" pitchFamily="34" charset="-120"/>
+                <a:latin typeface="PP Mondwest" pitchFamily="34" charset="0"/>
+                <a:ea typeface="PP Mondwest" pitchFamily="34" charset="-122"/>
+                <a:cs typeface="PP Mondwest" pitchFamily="34" charset="-120"/>
               </a:rPr>
               <a:t>Architecture of the Global Value Chain (GVC)</a:t>
             </a:r>
@@ -9218,9 +9218,9 @@
                 <a:solidFill>
                   <a:srgbClr val="6B6560"/>
                 </a:solidFill>
-                <a:latin typeface="Arial" pitchFamily="34" charset="0"/>
-                <a:ea typeface="Arial" pitchFamily="34" charset="-122"/>
-                <a:cs typeface="Arial" pitchFamily="34" charset="-120"/>
+                <a:latin typeface="VVDS Fifties" pitchFamily="34" charset="0"/>
+                <a:ea typeface="VVDS Fifties" pitchFamily="34" charset="-122"/>
+                <a:cs typeface="VVDS Fifties" pitchFamily="34" charset="-120"/>
               </a:rPr>
               <a:t>The 2026 Semiconductor Ecosystem | Slide 07</a:t>
             </a:r>
@@ -9282,9 +9282,9 @@
                 <a:solidFill>
                   <a:srgbClr val="9E7D84"/>
                 </a:solidFill>
-                <a:latin typeface="Arial" pitchFamily="34" charset="0"/>
-                <a:ea typeface="Arial" pitchFamily="34" charset="-122"/>
-                <a:cs typeface="Arial" pitchFamily="34" charset="-120"/>
+                <a:latin typeface="VVDS Fifties" pitchFamily="34" charset="0"/>
+                <a:ea typeface="VVDS Fifties" pitchFamily="34" charset="-122"/>
+                <a:cs typeface="VVDS Fifties" pitchFamily="34" charset="-120"/>
               </a:rPr>
               <a:t>Key Message: Value is highly concentrated in specialized clusters: U.S. (Design), Europe (Equipment), and East Asia (Manufacturing).</a:t>
             </a:r>
@@ -9322,9 +9322,9 @@
                 <a:solidFill>
                   <a:srgbClr val="6B6560"/>
                 </a:solidFill>
-                <a:latin typeface="Arial" pitchFamily="34" charset="0"/>
-                <a:ea typeface="Arial" pitchFamily="34" charset="-122"/>
-                <a:cs typeface="Arial" pitchFamily="34" charset="-120"/>
+                <a:latin typeface="VVDS Fifties" pitchFamily="34" charset="0"/>
+                <a:ea typeface="VVDS Fifties" pitchFamily="34" charset="-122"/>
+                <a:cs typeface="VVDS Fifties" pitchFamily="34" charset="-120"/>
               </a:rPr>
               <a:t>- Design &amp; EDA (United States): Dominance in core processor blueprints and layout compiler systems (NVIDIA, Apple, Qualcomm).</a:t>
             </a:r>
@@ -9347,9 +9347,9 @@
                 <a:solidFill>
                   <a:srgbClr val="6B6560"/>
                 </a:solidFill>
-                <a:latin typeface="Arial" pitchFamily="34" charset="0"/>
-                <a:ea typeface="Arial" pitchFamily="34" charset="-122"/>
-                <a:cs typeface="Arial" pitchFamily="34" charset="-120"/>
+                <a:latin typeface="VVDS Fifties" pitchFamily="34" charset="0"/>
+                <a:ea typeface="VVDS Fifties" pitchFamily="34" charset="-122"/>
+                <a:cs typeface="VVDS Fifties" pitchFamily="34" charset="-120"/>
               </a:rPr>
               <a:t>- SME Equipment (Europe): Monopoly on Extreme Ultraviolet tools (ASML) required to etch sub-7nm circuit nodes.</a:t>
             </a:r>
@@ -9372,9 +9372,9 @@
                 <a:solidFill>
                   <a:srgbClr val="6B6560"/>
                 </a:solidFill>
-                <a:latin typeface="Arial" pitchFamily="34" charset="0"/>
-                <a:ea typeface="Arial" pitchFamily="34" charset="-122"/>
-                <a:cs typeface="Arial" pitchFamily="34" charset="-120"/>
+                <a:latin typeface="VVDS Fifties" pitchFamily="34" charset="0"/>
+                <a:ea typeface="VVDS Fifties" pitchFamily="34" charset="-122"/>
+                <a:cs typeface="VVDS Fifties" pitchFamily="34" charset="-120"/>
               </a:rPr>
               <a:t>- Wafer Fabrication (East Asia): TSMC (Taiwan) and Samsung (Korea) form the production base for global advanced nodes.</a:t>
             </a:r>
@@ -9436,9 +9436,9 @@
                 <a:solidFill>
                   <a:srgbClr val="6B6560"/>
                 </a:solidFill>
-                <a:latin typeface="Arial" pitchFamily="34" charset="0"/>
-                <a:ea typeface="Arial" pitchFamily="34" charset="-122"/>
-                <a:cs typeface="Arial" pitchFamily="34" charset="-120"/>
+                <a:latin typeface="VVDS Fifties" pitchFamily="34" charset="0"/>
+                <a:ea typeface="VVDS Fifties" pitchFamily="34" charset="-122"/>
+                <a:cs typeface="VVDS Fifties" pitchFamily="34" charset="-120"/>
               </a:rPr>
               <a:t>USA: Design IP</a:t>
             </a:r>
@@ -9459,9 +9459,9 @@
                 <a:solidFill>
                   <a:srgbClr val="6B6560"/>
                 </a:solidFill>
-                <a:latin typeface="Arial" pitchFamily="34" charset="0"/>
-                <a:ea typeface="Arial" pitchFamily="34" charset="-122"/>
-                <a:cs typeface="Arial" pitchFamily="34" charset="-120"/>
+                <a:latin typeface="VVDS Fifties" pitchFamily="34" charset="0"/>
+                <a:ea typeface="VVDS Fifties" pitchFamily="34" charset="-122"/>
+                <a:cs typeface="VVDS Fifties" pitchFamily="34" charset="-120"/>
               </a:rPr>
               <a:t>80%+ market share in advanced EDA software tools.</a:t>
             </a:r>
@@ -9523,9 +9523,9 @@
                 <a:solidFill>
                   <a:srgbClr val="6B6560"/>
                 </a:solidFill>
-                <a:latin typeface="Arial" pitchFamily="34" charset="0"/>
-                <a:ea typeface="Arial" pitchFamily="34" charset="-122"/>
-                <a:cs typeface="Arial" pitchFamily="34" charset="-120"/>
+                <a:latin typeface="VVDS Fifties" pitchFamily="34" charset="0"/>
+                <a:ea typeface="VVDS Fifties" pitchFamily="34" charset="-122"/>
+                <a:cs typeface="VVDS Fifties" pitchFamily="34" charset="-120"/>
               </a:rPr>
               <a:t>ASML (EU): Lithography</a:t>
             </a:r>
@@ -9546,9 +9546,9 @@
                 <a:solidFill>
                   <a:srgbClr val="6B6560"/>
                 </a:solidFill>
-                <a:latin typeface="Arial" pitchFamily="34" charset="0"/>
-                <a:ea typeface="Arial" pitchFamily="34" charset="-122"/>
-                <a:cs typeface="Arial" pitchFamily="34" charset="-120"/>
+                <a:latin typeface="VVDS Fifties" pitchFamily="34" charset="0"/>
+                <a:ea typeface="VVDS Fifties" pitchFamily="34" charset="-122"/>
+                <a:cs typeface="VVDS Fifties" pitchFamily="34" charset="-120"/>
               </a:rPr>
               <a:t>100% monopsony on EUV printing technology.</a:t>
             </a:r>
@@ -9617,9 +9617,9 @@
                 <a:solidFill>
                   <a:srgbClr val="B84A2F"/>
                 </a:solidFill>
-                <a:latin typeface="Arial" pitchFamily="34" charset="0"/>
-                <a:ea typeface="Arial" pitchFamily="34" charset="-122"/>
-                <a:cs typeface="Arial" pitchFamily="34" charset="-120"/>
+                <a:latin typeface="VVDS Fifties" pitchFamily="34" charset="0"/>
+                <a:ea typeface="VVDS Fifties" pitchFamily="34" charset="-122"/>
+                <a:cs typeface="VVDS Fifties" pitchFamily="34" charset="-120"/>
               </a:rPr>
               <a:t>PART 2: THE GLOBAL SUPPLY CHAIN OF SEMICONDUCTORS</a:t>
             </a:r>
@@ -9656,9 +9656,9 @@
                 <a:solidFill>
                   <a:srgbClr val="1A1714"/>
                 </a:solidFill>
-                <a:latin typeface="Georgia" pitchFamily="34" charset="0"/>
-                <a:ea typeface="Georgia" pitchFamily="34" charset="-122"/>
-                <a:cs typeface="Georgia" pitchFamily="34" charset="-120"/>
+                <a:latin typeface="PP Mondwest" pitchFamily="34" charset="0"/>
+                <a:ea typeface="PP Mondwest" pitchFamily="34" charset="-122"/>
+                <a:cs typeface="PP Mondwest" pitchFamily="34" charset="-120"/>
               </a:rPr>
               <a:t>Front-End &amp; Back-End Bottlenecks</a:t>
             </a:r>
@@ -9695,9 +9695,9 @@
                 <a:solidFill>
                   <a:srgbClr val="6B6560"/>
                 </a:solidFill>
-                <a:latin typeface="Arial" pitchFamily="34" charset="0"/>
-                <a:ea typeface="Arial" pitchFamily="34" charset="-122"/>
-                <a:cs typeface="Arial" pitchFamily="34" charset="-120"/>
+                <a:latin typeface="VVDS Fifties" pitchFamily="34" charset="0"/>
+                <a:ea typeface="VVDS Fifties" pitchFamily="34" charset="-122"/>
+                <a:cs typeface="VVDS Fifties" pitchFamily="34" charset="-120"/>
               </a:rPr>
               <a:t>The 2026 Semiconductor Ecosystem | Slide 08</a:t>
             </a:r>
@@ -9759,9 +9759,9 @@
                 <a:solidFill>
                   <a:srgbClr val="768C7C"/>
                 </a:solidFill>
-                <a:latin typeface="Arial" pitchFamily="34" charset="0"/>
-                <a:ea typeface="Arial" pitchFamily="34" charset="-122"/>
-                <a:cs typeface="Arial" pitchFamily="34" charset="-120"/>
+                <a:latin typeface="VVDS Fifties" pitchFamily="34" charset="0"/>
+                <a:ea typeface="VVDS Fifties" pitchFamily="34" charset="-122"/>
+                <a:cs typeface="VVDS Fifties" pitchFamily="34" charset="-120"/>
               </a:rPr>
               <a:t>Key Message: Advanced packaging (CoWoS, 3D Stacking) is the new primary growth limiter for the AI industry.</a:t>
             </a:r>
@@ -9823,9 +9823,9 @@
                 <a:solidFill>
                   <a:srgbClr val="B84A2F"/>
                 </a:solidFill>
-                <a:latin typeface="Georgia" pitchFamily="34" charset="0"/>
-                <a:ea typeface="Georgia" pitchFamily="34" charset="-122"/>
-                <a:cs typeface="Georgia" pitchFamily="34" charset="-120"/>
+                <a:latin typeface="PP Mondwest" pitchFamily="34" charset="0"/>
+                <a:ea typeface="PP Mondwest" pitchFamily="34" charset="-122"/>
+                <a:cs typeface="PP Mondwest" pitchFamily="34" charset="-120"/>
               </a:rPr>
               <a:t>Front-End: Node Scaling</a:t>
             </a:r>
@@ -9862,9 +9862,9 @@
                 <a:solidFill>
                   <a:srgbClr val="6B6560"/>
                 </a:solidFill>
-                <a:latin typeface="Arial" pitchFamily="34" charset="0"/>
-                <a:ea typeface="Arial" pitchFamily="34" charset="-122"/>
-                <a:cs typeface="Arial" pitchFamily="34" charset="-120"/>
+                <a:latin typeface="VVDS Fifties" pitchFamily="34" charset="0"/>
+                <a:ea typeface="VVDS Fifties" pitchFamily="34" charset="-122"/>
+                <a:cs typeface="VVDS Fifties" pitchFamily="34" charset="-120"/>
               </a:rPr>
               <a:t>The race for the 2nm and 1.4nm nodes continues to demand immense capital investments for wafer fabrication lines.</a:t>
             </a:r>
@@ -9926,9 +9926,9 @@
                 <a:solidFill>
                   <a:srgbClr val="768C7C"/>
                 </a:solidFill>
-                <a:latin typeface="Georgia" pitchFamily="34" charset="0"/>
-                <a:ea typeface="Georgia" pitchFamily="34" charset="-122"/>
-                <a:cs typeface="Georgia" pitchFamily="34" charset="-120"/>
+                <a:latin typeface="PP Mondwest" pitchFamily="34" charset="0"/>
+                <a:ea typeface="PP Mondwest" pitchFamily="34" charset="-122"/>
+                <a:cs typeface="PP Mondwest" pitchFamily="34" charset="-120"/>
               </a:rPr>
               <a:t>Back-End: Advanced Packaging Chokepoint</a:t>
             </a:r>
@@ -9965,9 +9965,9 @@
                 <a:solidFill>
                   <a:srgbClr val="6B6560"/>
                 </a:solidFill>
-                <a:latin typeface="Arial" pitchFamily="34" charset="0"/>
-                <a:ea typeface="Arial" pitchFamily="34" charset="-122"/>
-                <a:cs typeface="Arial" pitchFamily="34" charset="-120"/>
+                <a:latin typeface="VVDS Fifties" pitchFamily="34" charset="0"/>
+                <a:ea typeface="VVDS Fifties" pitchFamily="34" charset="-122"/>
+                <a:cs typeface="VVDS Fifties" pitchFamily="34" charset="-120"/>
               </a:rPr>
               <a:t>Integrating multiple logic dies and High Bandwidth Memory (HBM) via CoWoS interposers is more constrained than wafer printing.</a:t>
             </a:r>
@@ -10029,9 +10029,9 @@
                 <a:solidFill>
                   <a:srgbClr val="6B6560"/>
                 </a:solidFill>
-                <a:latin typeface="Arial" pitchFamily="34" charset="0"/>
-                <a:ea typeface="Arial" pitchFamily="34" charset="-122"/>
-                <a:cs typeface="Arial" pitchFamily="34" charset="-120"/>
+                <a:latin typeface="VVDS Fifties" pitchFamily="34" charset="0"/>
+                <a:ea typeface="VVDS Fifties" pitchFamily="34" charset="-122"/>
+                <a:cs typeface="VVDS Fifties" pitchFamily="34" charset="-120"/>
               </a:rPr>
               <a:t>Logistics bottleneck: Reaching target AI yields depends heavily on advanced back-end capacity, not just front-end print nodes.</a:t>
             </a:r>
@@ -10100,9 +10100,9 @@
                 <a:solidFill>
                   <a:srgbClr val="B84A2F"/>
                 </a:solidFill>
-                <a:latin typeface="Arial" pitchFamily="34" charset="0"/>
-                <a:ea typeface="Arial" pitchFamily="34" charset="-122"/>
-                <a:cs typeface="Arial" pitchFamily="34" charset="-120"/>
+                <a:latin typeface="VVDS Fifties" pitchFamily="34" charset="0"/>
+                <a:ea typeface="VVDS Fifties" pitchFamily="34" charset="-122"/>
+                <a:cs typeface="VVDS Fifties" pitchFamily="34" charset="-120"/>
               </a:rPr>
               <a:t>PART 2: THE GLOBAL SUPPLY CHAIN OF SEMICONDUCTORS</a:t>
             </a:r>
@@ -10139,9 +10139,9 @@
                 <a:solidFill>
                   <a:srgbClr val="1A1714"/>
                 </a:solidFill>
-                <a:latin typeface="Georgia" pitchFamily="34" charset="0"/>
-                <a:ea typeface="Georgia" pitchFamily="34" charset="-122"/>
-                <a:cs typeface="Georgia" pitchFamily="34" charset="-120"/>
+                <a:latin typeface="PP Mondwest" pitchFamily="34" charset="0"/>
+                <a:ea typeface="PP Mondwest" pitchFamily="34" charset="-122"/>
+                <a:cs typeface="PP Mondwest" pitchFamily="34" charset="-120"/>
               </a:rPr>
               <a:t>SME, Materials &amp; Geopolitical Fragmentation</a:t>
             </a:r>
@@ -10178,9 +10178,9 @@
                 <a:solidFill>
                   <a:srgbClr val="6B6560"/>
                 </a:solidFill>
-                <a:latin typeface="Arial" pitchFamily="34" charset="0"/>
-                <a:ea typeface="Arial" pitchFamily="34" charset="-122"/>
-                <a:cs typeface="Arial" pitchFamily="34" charset="-120"/>
+                <a:latin typeface="VVDS Fifties" pitchFamily="34" charset="0"/>
+                <a:ea typeface="VVDS Fifties" pitchFamily="34" charset="-122"/>
+                <a:cs typeface="VVDS Fifties" pitchFamily="34" charset="-120"/>
               </a:rPr>
               <a:t>The 2026 Semiconductor Ecosystem | Slide 09</a:t>
             </a:r>
@@ -10242,9 +10242,9 @@
                 <a:solidFill>
                   <a:srgbClr val="B84A2F"/>
                 </a:solidFill>
-                <a:latin typeface="Arial" pitchFamily="34" charset="0"/>
-                <a:ea typeface="Arial" pitchFamily="34" charset="-122"/>
-                <a:cs typeface="Arial" pitchFamily="34" charset="-120"/>
+                <a:latin typeface="VVDS Fifties" pitchFamily="34" charset="0"/>
+                <a:ea typeface="VVDS Fifties" pitchFamily="34" charset="-122"/>
+                <a:cs typeface="VVDS Fifties" pitchFamily="34" charset="-120"/>
               </a:rPr>
               <a:t>Key Message: Geopolitics has created a "Multi-Polar" silicon world, where export controls and subsidies drive regionalization.</a:t>
             </a:r>
@@ -10282,9 +10282,9 @@
                 <a:solidFill>
                   <a:srgbClr val="6B6560"/>
                 </a:solidFill>
-                <a:latin typeface="Arial" pitchFamily="34" charset="0"/>
-                <a:ea typeface="Arial" pitchFamily="34" charset="-122"/>
-                <a:cs typeface="Arial" pitchFamily="34" charset="-120"/>
+                <a:latin typeface="VVDS Fifties" pitchFamily="34" charset="0"/>
+                <a:ea typeface="VVDS Fifties" pitchFamily="34" charset="-122"/>
+                <a:cs typeface="VVDS Fifties" pitchFamily="34" charset="-120"/>
               </a:rPr>
               <a:t>- The US CHIPS Act ($52B): Funding the domestic establishment of advanced logic fabs to balance East Asian concentration.</a:t>
             </a:r>
@@ -10307,9 +10307,9 @@
                 <a:solidFill>
                   <a:srgbClr val="6B6560"/>
                 </a:solidFill>
-                <a:latin typeface="Arial" pitchFamily="34" charset="0"/>
-                <a:ea typeface="Arial" pitchFamily="34" charset="-122"/>
-                <a:cs typeface="Arial" pitchFamily="34" charset="-120"/>
+                <a:latin typeface="VVDS Fifties" pitchFamily="34" charset="0"/>
+                <a:ea typeface="VVDS Fifties" pitchFamily="34" charset="-122"/>
+                <a:cs typeface="VVDS Fifties" pitchFamily="34" charset="-120"/>
               </a:rPr>
               <a:t>- Europe &amp; China Reshoring: Multi-billion dollar state-supported programs targeting semiconductor in-sourcing.</a:t>
             </a:r>
@@ -10332,9 +10332,9 @@
                 <a:solidFill>
                   <a:srgbClr val="6B6560"/>
                 </a:solidFill>
-                <a:latin typeface="Arial" pitchFamily="34" charset="0"/>
-                <a:ea typeface="Arial" pitchFamily="34" charset="-122"/>
-                <a:cs typeface="Arial" pitchFamily="34" charset="-120"/>
+                <a:latin typeface="VVDS Fifties" pitchFamily="34" charset="0"/>
+                <a:ea typeface="VVDS Fifties" pitchFamily="34" charset="-122"/>
+                <a:cs typeface="VVDS Fifties" pitchFamily="34" charset="-120"/>
               </a:rPr>
               <a:t>- Material Chokepoints: Strict export controls placed on critical trace materials like Gallium and Germanium.</a:t>
             </a:r>
@@ -10396,9 +10396,9 @@
                 <a:solidFill>
                   <a:srgbClr val="B84A2F"/>
                 </a:solidFill>
-                <a:latin typeface="Arial" pitchFamily="34" charset="0"/>
-                <a:ea typeface="Arial" pitchFamily="34" charset="-122"/>
-                <a:cs typeface="Arial" pitchFamily="34" charset="-120"/>
+                <a:latin typeface="VVDS Fifties" pitchFamily="34" charset="0"/>
+                <a:ea typeface="VVDS Fifties" pitchFamily="34" charset="-122"/>
+                <a:cs typeface="VVDS Fifties" pitchFamily="34" charset="-120"/>
               </a:rPr>
               <a:t>CRITICAL CHOKEPOINT</a:t>
             </a:r>
@@ -10435,9 +10435,9 @@
                 <a:solidFill>
                   <a:srgbClr val="1A1714"/>
                 </a:solidFill>
-                <a:latin typeface="Georgia" pitchFamily="34" charset="0"/>
-                <a:ea typeface="Georgia" pitchFamily="34" charset="-122"/>
-                <a:cs typeface="Georgia" pitchFamily="34" charset="-120"/>
+                <a:latin typeface="PP Mondwest" pitchFamily="34" charset="0"/>
+                <a:ea typeface="PP Mondwest" pitchFamily="34" charset="-122"/>
+                <a:cs typeface="PP Mondwest" pitchFamily="34" charset="-120"/>
               </a:rPr>
               <a:t>Gallium &amp;</a:t>
             </a:r>
@@ -10452,9 +10452,9 @@
                 <a:solidFill>
                   <a:srgbClr val="1A1714"/>
                 </a:solidFill>
-                <a:latin typeface="Georgia" pitchFamily="34" charset="0"/>
-                <a:ea typeface="Georgia" pitchFamily="34" charset="-122"/>
-                <a:cs typeface="Georgia" pitchFamily="34" charset="-120"/>
+                <a:latin typeface="PP Mondwest" pitchFamily="34" charset="0"/>
+                <a:ea typeface="PP Mondwest" pitchFamily="34" charset="-122"/>
+                <a:cs typeface="PP Mondwest" pitchFamily="34" charset="-120"/>
               </a:rPr>
               <a:t>Germanium</a:t>
             </a:r>
@@ -10491,9 +10491,9 @@
                 <a:solidFill>
                   <a:srgbClr val="6B6560"/>
                 </a:solidFill>
-                <a:latin typeface="Arial" pitchFamily="34" charset="0"/>
-                <a:ea typeface="Arial" pitchFamily="34" charset="-122"/>
-                <a:cs typeface="Arial" pitchFamily="34" charset="-120"/>
+                <a:latin typeface="VVDS Fifties" pitchFamily="34" charset="0"/>
+                <a:ea typeface="VVDS Fifties" pitchFamily="34" charset="-122"/>
+                <a:cs typeface="VVDS Fifties" pitchFamily="34" charset="-120"/>
               </a:rPr>
               <a:t>Strict raw material export control levers</a:t>
             </a:r>

</xml_diff>

<commit_message>
Update presenter to Phyoe Sat Paing, change font to AT Aero, and add Thank You end slide
</commit_message>
<xml_diff>
--- a/output/semiconductor-ecosystem-2026.pptx
+++ b/output/semiconductor-ecosystem-2026.pptx
@@ -22,9 +22,10 @@
     <p:sldId id="270" r:id="rId16"/>
     <p:sldId id="271" r:id="rId17"/>
     <p:sldId id="272" r:id="rId18"/>
+    <p:sldId id="273" r:id="rId19"/>
   </p:sldIdLst>
   <p:notesMasterIdLst>
-    <p:notesMasterId r:id="rId19"/>
+    <p:notesMasterId r:id="rId20"/>
   </p:notesMasterIdLst>
   <p:sldSz cx="9144000" cy="5143500"/>
   <p:notesSz cx="5143500" cy="9144000"/>
@@ -518,7 +519,7 @@
           <a:p>
             <a:r>
               <a:rPr lang="en-US" dirty="0"/>
-              <a:t>Hello everyone. I’m Manus, and today we are conducting a deep-dive into the 'nerve system' of our modern civilization: the 2026 Semiconductor Ecosystem. Over the next 20 minutes, we are going to move beyond the headlines of 'chip shortages' and look at the actual structural mechanics of how silicon is procured, how it moves across the globe, and finally, how it is fundamentally rewriting the DNA of every major industry. Whether you are an investor, a procurement lead, or a strategic planner, this briefing is designed to give you the high-ground view of the $1.3 trillion silicon economy.</a:t>
+              <a:t>Hello everyone. I’m Phyoe Sat Paing, and today we are conducting a deep-dive into the 'nerve system' of our modern civilization: the 2026 Semiconductor Ecosystem. Over the next 20 minutes, we are going to move beyond the headlines of 'chip shortages' and look at the actual structural mechanics of how silicon is procured, how it moves across the globe, and finally, how it is fundamentally rewriting the DNA of every major industry. Whether you are an investor, a procurement lead, or a strategic planner, this briefing is designed to give you the high-ground view of the $1.3 trillion silicon economy.</a:t>
             </a:r>
             <a:endParaRPr lang="en-US" dirty="0"/>
           </a:p>
@@ -1248,6 +1249,94 @@
             <a:fld id="{F7021451-1387-4CA6-816F-3879F97B5CBC}" type="slidenum">
               <a:rPr lang="en-US"/>
               <a:t>17</a:t>
+            </a:fld>
+            <a:endParaRPr lang="en-US"/>
+          </a:p>
+        </p:txBody>
+      </p:sp>
+    </p:spTree>
+    <p:extLst>
+      <p:ext uri="{BB962C8B-B14F-4D97-AF65-F5344CB8AC3E}">
+        <p14:creationId xmlns:p14="http://schemas.microsoft.com/office/powerpoint/2010/main" val="1024086991"/>
+      </p:ext>
+    </p:extLst>
+  </p:cSld>
+  <p:clrMapOvr>
+    <a:masterClrMapping/>
+  </p:clrMapOvr>
+</p:notes>
+</file>
+
+<file path=ppt/notesSlides/notesSlide18.xml><?xml version="1.0" encoding="utf-8"?>
+<p:notes xmlns:a="http://schemas.openxmlformats.org/drawingml/2006/main" xmlns:r="http://schemas.openxmlformats.org/officeDocument/2006/relationships" xmlns:p="http://schemas.openxmlformats.org/presentationml/2006/main">
+  <p:cSld>
+    <p:spTree>
+      <p:nvGrpSpPr>
+        <p:cNvPr id="1" name=""/>
+        <p:cNvGrpSpPr/>
+        <p:nvPr/>
+      </p:nvGrpSpPr>
+      <p:grpSpPr>
+        <a:xfrm>
+          <a:off x="0" y="0"/>
+          <a:ext cx="0" cy="0"/>
+          <a:chOff x="0" y="0"/>
+          <a:chExt cx="0" cy="0"/>
+        </a:xfrm>
+      </p:grpSpPr>
+      <p:sp>
+        <p:nvSpPr>
+          <p:cNvPr id="2" name="Slide Image Placeholder 1"/>
+          <p:cNvSpPr>
+            <a:spLocks noGrp="1" noRot="1" noChangeAspect="1"/>
+          </p:cNvSpPr>
+          <p:nvPr>
+            <p:ph type="sldImg"/>
+          </p:nvPr>
+        </p:nvSpPr>
+        <p:spPr/>
+      </p:sp>
+      <p:sp>
+        <p:nvSpPr>
+          <p:cNvPr id="3" name="Notes Placeholder 2"/>
+          <p:cNvSpPr>
+            <a:spLocks noGrp="1"/>
+          </p:cNvSpPr>
+          <p:nvPr>
+            <p:ph type="body" idx="1"/>
+          </p:nvPr>
+        </p:nvSpPr>
+        <p:spPr/>
+        <p:txBody>
+          <a:bodyPr/>
+          <a:lstStyle/>
+          <a:p>
+            <a:r>
+              <a:rPr lang="en-US" dirty="0"/>
+              <a:t>Thank you everyone for your time. I would now like to open the floor to any questions you may have.</a:t>
+            </a:r>
+            <a:endParaRPr lang="en-US" dirty="0"/>
+          </a:p>
+        </p:txBody>
+      </p:sp>
+      <p:sp>
+        <p:nvSpPr>
+          <p:cNvPr id="4" name="Slide Number Placeholder 3"/>
+          <p:cNvSpPr>
+            <a:spLocks noGrp="1"/>
+          </p:cNvSpPr>
+          <p:nvPr>
+            <p:ph type="sldNum" sz="quarter" idx="10"/>
+          </p:nvPr>
+        </p:nvSpPr>
+        <p:spPr/>
+        <p:txBody>
+          <a:bodyPr/>
+          <a:lstStyle/>
+          <a:p>
+            <a:fld id="{F7021451-1387-4CA6-816F-3879F97B5CBC}" type="slidenum">
+              <a:rPr lang="en-US"/>
+              <a:t>18</a:t>
             </a:fld>
             <a:endParaRPr lang="en-US"/>
           </a:p>
@@ -2369,9 +2458,9 @@
                 <a:solidFill>
                   <a:srgbClr val="6B6560"/>
                 </a:solidFill>
-                <a:latin typeface="VVDS Fifties" pitchFamily="34" charset="0"/>
-                <a:ea typeface="VVDS Fifties" pitchFamily="34" charset="-122"/>
-                <a:cs typeface="VVDS Fifties" pitchFamily="34" charset="-120"/>
+                <a:latin typeface="AT Aero" pitchFamily="34" charset="0"/>
+                <a:ea typeface="AT Aero" pitchFamily="34" charset="-122"/>
+                <a:cs typeface="AT Aero" pitchFamily="34" charset="-120"/>
               </a:rPr>
               <a:t>A Strategic Briefing on Procurement, Global Supply Chains, and End-User Verticals</a:t>
             </a:r>
@@ -2428,11 +2517,11 @@
                 <a:solidFill>
                   <a:srgbClr val="6B6560"/>
                 </a:solidFill>
-                <a:latin typeface="VVDS Fifties" pitchFamily="34" charset="0"/>
-                <a:ea typeface="VVDS Fifties" pitchFamily="34" charset="-122"/>
-                <a:cs typeface="VVDS Fifties" pitchFamily="34" charset="-120"/>
-              </a:rPr>
-              <a:t>Presenter: Manus</a:t>
+                <a:latin typeface="AT Aero" pitchFamily="34" charset="0"/>
+                <a:ea typeface="AT Aero" pitchFamily="34" charset="-122"/>
+                <a:cs typeface="AT Aero" pitchFamily="34" charset="-120"/>
+              </a:rPr>
+              <a:t>Presenter: Phyoe Sat Paing</a:t>
             </a:r>
             <a:endParaRPr lang="en-US" sz="1400" dirty="0"/>
           </a:p>
@@ -2445,9 +2534,9 @@
                 <a:solidFill>
                   <a:srgbClr val="6B6560"/>
                 </a:solidFill>
-                <a:latin typeface="VVDS Fifties" pitchFamily="34" charset="0"/>
-                <a:ea typeface="VVDS Fifties" pitchFamily="34" charset="-122"/>
-                <a:cs typeface="VVDS Fifties" pitchFamily="34" charset="-120"/>
+                <a:latin typeface="AT Aero" pitchFamily="34" charset="0"/>
+                <a:ea typeface="AT Aero" pitchFamily="34" charset="-122"/>
+                <a:cs typeface="AT Aero" pitchFamily="34" charset="-120"/>
               </a:rPr>
               <a:t>Boardroom Strategic Briefing</a:t>
             </a:r>
@@ -2516,9 +2605,9 @@
                 <a:solidFill>
                   <a:srgbClr val="B84A2F"/>
                 </a:solidFill>
-                <a:latin typeface="VVDS Fifties" pitchFamily="34" charset="0"/>
-                <a:ea typeface="VVDS Fifties" pitchFamily="34" charset="-122"/>
-                <a:cs typeface="VVDS Fifties" pitchFamily="34" charset="-120"/>
+                <a:latin typeface="AT Aero" pitchFamily="34" charset="0"/>
+                <a:ea typeface="AT Aero" pitchFamily="34" charset="-122"/>
+                <a:cs typeface="AT Aero" pitchFamily="34" charset="-120"/>
               </a:rPr>
               <a:t>PART 2: THE GLOBAL SUPPLY CHAIN OF SEMICONDUCTORS</a:t>
             </a:r>
@@ -2594,9 +2683,9 @@
                 <a:solidFill>
                   <a:srgbClr val="6B6560"/>
                 </a:solidFill>
-                <a:latin typeface="VVDS Fifties" pitchFamily="34" charset="0"/>
-                <a:ea typeface="VVDS Fifties" pitchFamily="34" charset="-122"/>
-                <a:cs typeface="VVDS Fifties" pitchFamily="34" charset="-120"/>
+                <a:latin typeface="AT Aero" pitchFamily="34" charset="0"/>
+                <a:ea typeface="AT Aero" pitchFamily="34" charset="-122"/>
+                <a:cs typeface="AT Aero" pitchFamily="34" charset="-120"/>
               </a:rPr>
               <a:t>The 2026 Semiconductor Ecosystem | Slide 10</a:t>
             </a:r>
@@ -2658,9 +2747,9 @@
                 <a:solidFill>
                   <a:srgbClr val="B84A2F"/>
                 </a:solidFill>
-                <a:latin typeface="VVDS Fifties" pitchFamily="34" charset="0"/>
-                <a:ea typeface="VVDS Fifties" pitchFamily="34" charset="-122"/>
-                <a:cs typeface="VVDS Fifties" pitchFamily="34" charset="-120"/>
+                <a:latin typeface="AT Aero" pitchFamily="34" charset="0"/>
+                <a:ea typeface="AT Aero" pitchFamily="34" charset="-122"/>
+                <a:cs typeface="AT Aero" pitchFamily="34" charset="-120"/>
               </a:rPr>
               <a:t>Key Message: The response? Circular and Autonomous Supply Chains. We are using AI to 'self-heal' the supply chain.</a:t>
             </a:r>
@@ -2761,9 +2850,9 @@
                 <a:solidFill>
                   <a:srgbClr val="6B6560"/>
                 </a:solidFill>
-                <a:latin typeface="VVDS Fifties" pitchFamily="34" charset="0"/>
-                <a:ea typeface="VVDS Fifties" pitchFamily="34" charset="-122"/>
-                <a:cs typeface="VVDS Fifties" pitchFamily="34" charset="-120"/>
+                <a:latin typeface="AT Aero" pitchFamily="34" charset="0"/>
+                <a:ea typeface="AT Aero" pitchFamily="34" charset="-122"/>
+                <a:cs typeface="AT Aero" pitchFamily="34" charset="-120"/>
               </a:rPr>
               <a:t>Automatically re-routing orders when a port closes or a factory goes down. Mapping up to Tier-4 and Tier-5 suppliers.</a:t>
             </a:r>
@@ -2864,9 +2953,9 @@
                 <a:solidFill>
                   <a:srgbClr val="6B6560"/>
                 </a:solidFill>
-                <a:latin typeface="VVDS Fifties" pitchFamily="34" charset="0"/>
-                <a:ea typeface="VVDS Fifties" pitchFamily="34" charset="-122"/>
-                <a:cs typeface="VVDS Fifties" pitchFamily="34" charset="-120"/>
+                <a:latin typeface="AT Aero" pitchFamily="34" charset="0"/>
+                <a:ea typeface="AT Aero" pitchFamily="34" charset="-122"/>
+                <a:cs typeface="AT Aero" pitchFamily="34" charset="-120"/>
               </a:rPr>
               <a:t>Mining the 'urban mine'—recovering rare earth elements from old electronics to reduce dependency on volatile mining regions.</a:t>
             </a:r>
@@ -2928,9 +3017,9 @@
                 <a:solidFill>
                   <a:srgbClr val="6B6560"/>
                 </a:solidFill>
-                <a:latin typeface="VVDS Fifties" pitchFamily="34" charset="0"/>
-                <a:ea typeface="VVDS Fifties" pitchFamily="34" charset="-122"/>
-                <a:cs typeface="VVDS Fifties" pitchFamily="34" charset="-120"/>
+                <a:latin typeface="AT Aero" pitchFamily="34" charset="0"/>
+                <a:ea typeface="AT Aero" pitchFamily="34" charset="-122"/>
+                <a:cs typeface="AT Aero" pitchFamily="34" charset="-120"/>
               </a:rPr>
               <a:t>Autonomous logistics systems automatically scan trade flows to reroute containers before bottleneck events cause line shutdowns.</a:t>
             </a:r>
@@ -2999,9 +3088,9 @@
                 <a:solidFill>
                   <a:srgbClr val="B84A2F"/>
                 </a:solidFill>
-                <a:latin typeface="VVDS Fifties" pitchFamily="34" charset="0"/>
-                <a:ea typeface="VVDS Fifties" pitchFamily="34" charset="-122"/>
-                <a:cs typeface="VVDS Fifties" pitchFamily="34" charset="-120"/>
+                <a:latin typeface="AT Aero" pitchFamily="34" charset="0"/>
+                <a:ea typeface="AT Aero" pitchFamily="34" charset="-122"/>
+                <a:cs typeface="AT Aero" pitchFamily="34" charset="-120"/>
               </a:rPr>
               <a:t>PART 3: END-USER INDUSTRIES &amp; APPLICATION ECOSYSTEM</a:t>
             </a:r>
@@ -3077,9 +3166,9 @@
                 <a:solidFill>
                   <a:srgbClr val="6B6560"/>
                 </a:solidFill>
-                <a:latin typeface="VVDS Fifties" pitchFamily="34" charset="0"/>
-                <a:ea typeface="VVDS Fifties" pitchFamily="34" charset="-122"/>
-                <a:cs typeface="VVDS Fifties" pitchFamily="34" charset="-120"/>
+                <a:latin typeface="AT Aero" pitchFamily="34" charset="0"/>
+                <a:ea typeface="AT Aero" pitchFamily="34" charset="-122"/>
+                <a:cs typeface="AT Aero" pitchFamily="34" charset="-120"/>
               </a:rPr>
               <a:t>The 2026 Semiconductor Ecosystem | Slide 11</a:t>
             </a:r>
@@ -3141,9 +3230,9 @@
                 <a:solidFill>
                   <a:srgbClr val="9E7D84"/>
                 </a:solidFill>
-                <a:latin typeface="VVDS Fifties" pitchFamily="34" charset="0"/>
-                <a:ea typeface="VVDS Fifties" pitchFamily="34" charset="-122"/>
-                <a:cs typeface="VVDS Fifties" pitchFamily="34" charset="-120"/>
+                <a:latin typeface="AT Aero" pitchFamily="34" charset="0"/>
+                <a:ea typeface="AT Aero" pitchFamily="34" charset="-122"/>
+                <a:cs typeface="AT Aero" pitchFamily="34" charset="-120"/>
               </a:rPr>
               <a:t>Key Message: Semiconductors are the "nerve system" of the global economy; no modern industry can function without them.</a:t>
             </a:r>
@@ -3181,9 +3270,9 @@
                 <a:solidFill>
                   <a:srgbClr val="6B6560"/>
                 </a:solidFill>
-                <a:latin typeface="VVDS Fifties" pitchFamily="34" charset="0"/>
-                <a:ea typeface="VVDS Fifties" pitchFamily="34" charset="-122"/>
-                <a:cs typeface="VVDS Fifties" pitchFamily="34" charset="-120"/>
+                <a:latin typeface="AT Aero" pitchFamily="34" charset="0"/>
+                <a:ea typeface="AT Aero" pitchFamily="34" charset="-122"/>
+                <a:cs typeface="AT Aero" pitchFamily="34" charset="-120"/>
               </a:rPr>
               <a:t>- Central Nerve System: Microchips control the storage, routing, and processing of every piece of data globally.</a:t>
             </a:r>
@@ -3206,9 +3295,9 @@
                 <a:solidFill>
                   <a:srgbClr val="6B6560"/>
                 </a:solidFill>
-                <a:latin typeface="VVDS Fifties" pitchFamily="34" charset="0"/>
-                <a:ea typeface="VVDS Fifties" pitchFamily="34" charset="-122"/>
-                <a:cs typeface="VVDS Fifties" pitchFamily="34" charset="-120"/>
+                <a:latin typeface="AT Aero" pitchFamily="34" charset="0"/>
+                <a:ea typeface="AT Aero" pitchFamily="34" charset="-122"/>
+                <a:cs typeface="AT Aero" pitchFamily="34" charset="-120"/>
               </a:rPr>
               <a:t>- Silicon Intensity Metric: The total value of silicon content per product is the primary metric of industrial scaling.</a:t>
             </a:r>
@@ -3231,9 +3320,9 @@
                 <a:solidFill>
                   <a:srgbClr val="6B6560"/>
                 </a:solidFill>
-                <a:latin typeface="VVDS Fifties" pitchFamily="34" charset="0"/>
-                <a:ea typeface="VVDS Fifties" pitchFamily="34" charset="-122"/>
-                <a:cs typeface="VVDS Fifties" pitchFamily="34" charset="-120"/>
+                <a:latin typeface="AT Aero" pitchFamily="34" charset="0"/>
+                <a:ea typeface="AT Aero" pitchFamily="34" charset="-122"/>
+                <a:cs typeface="AT Aero" pitchFamily="34" charset="-120"/>
               </a:rPr>
               <a:t>- Ubiquitous Integration: Foundational logic layers power smart municipal grids, medical machinery, and neural processors.</a:t>
             </a:r>
@@ -3295,9 +3384,9 @@
                 <a:solidFill>
                   <a:srgbClr val="9E7D84"/>
                 </a:solidFill>
-                <a:latin typeface="VVDS Fifties" pitchFamily="34" charset="0"/>
-                <a:ea typeface="VVDS Fifties" pitchFamily="34" charset="-122"/>
-                <a:cs typeface="VVDS Fifties" pitchFamily="34" charset="-120"/>
+                <a:latin typeface="AT Aero" pitchFamily="34" charset="0"/>
+                <a:ea typeface="AT Aero" pitchFamily="34" charset="-122"/>
+                <a:cs typeface="AT Aero" pitchFamily="34" charset="-120"/>
               </a:rPr>
               <a:t>KEY METRIC</a:t>
             </a:r>
@@ -3390,9 +3479,9 @@
                 <a:solidFill>
                   <a:srgbClr val="6B6560"/>
                 </a:solidFill>
-                <a:latin typeface="VVDS Fifties" pitchFamily="34" charset="0"/>
-                <a:ea typeface="VVDS Fifties" pitchFamily="34" charset="-122"/>
-                <a:cs typeface="VVDS Fifties" pitchFamily="34" charset="-120"/>
+                <a:latin typeface="AT Aero" pitchFamily="34" charset="0"/>
+                <a:ea typeface="AT Aero" pitchFamily="34" charset="-122"/>
+                <a:cs typeface="AT Aero" pitchFamily="34" charset="-120"/>
               </a:rPr>
               <a:t>Primary industrial competitiveness index</a:t>
             </a:r>
@@ -3461,9 +3550,9 @@
                 <a:solidFill>
                   <a:srgbClr val="B84A2F"/>
                 </a:solidFill>
-                <a:latin typeface="VVDS Fifties" pitchFamily="34" charset="0"/>
-                <a:ea typeface="VVDS Fifties" pitchFamily="34" charset="-122"/>
-                <a:cs typeface="VVDS Fifties" pitchFamily="34" charset="-120"/>
+                <a:latin typeface="AT Aero" pitchFamily="34" charset="0"/>
+                <a:ea typeface="AT Aero" pitchFamily="34" charset="-122"/>
+                <a:cs typeface="AT Aero" pitchFamily="34" charset="-120"/>
               </a:rPr>
               <a:t>PART 3: END-USER INDUSTRIES &amp; APPLICATION ECOSYSTEM</a:t>
             </a:r>
@@ -3539,9 +3628,9 @@
                 <a:solidFill>
                   <a:srgbClr val="6B6560"/>
                 </a:solidFill>
-                <a:latin typeface="VVDS Fifties" pitchFamily="34" charset="0"/>
-                <a:ea typeface="VVDS Fifties" pitchFamily="34" charset="-122"/>
-                <a:cs typeface="VVDS Fifties" pitchFamily="34" charset="-120"/>
+                <a:latin typeface="AT Aero" pitchFamily="34" charset="0"/>
+                <a:ea typeface="AT Aero" pitchFamily="34" charset="-122"/>
+                <a:cs typeface="AT Aero" pitchFamily="34" charset="-120"/>
               </a:rPr>
               <a:t>The 2026 Semiconductor Ecosystem | Slide 12</a:t>
             </a:r>
@@ -3603,9 +3692,9 @@
                 <a:solidFill>
                   <a:srgbClr val="B84A2F"/>
                 </a:solidFill>
-                <a:latin typeface="VVDS Fifties" pitchFamily="34" charset="0"/>
-                <a:ea typeface="VVDS Fifties" pitchFamily="34" charset="-122"/>
-                <a:cs typeface="VVDS Fifties" pitchFamily="34" charset="-120"/>
+                <a:latin typeface="AT Aero" pitchFamily="34" charset="0"/>
+                <a:ea typeface="AT Aero" pitchFamily="34" charset="-122"/>
+                <a:cs typeface="AT Aero" pitchFamily="34" charset="-120"/>
               </a:rPr>
               <a:t>Key Message: Demand is shifting from traditional computing toward AI infrastructure, Automotive, and Industrial Automation.</a:t>
             </a:r>
@@ -3706,9 +3795,9 @@
                 <a:solidFill>
                   <a:srgbClr val="6B6560"/>
                 </a:solidFill>
-                <a:latin typeface="VVDS Fifties" pitchFamily="34" charset="0"/>
-                <a:ea typeface="VVDS Fifties" pitchFamily="34" charset="-122"/>
-                <a:cs typeface="VVDS Fifties" pitchFamily="34" charset="-120"/>
+                <a:latin typeface="AT Aero" pitchFamily="34" charset="0"/>
+                <a:ea typeface="AT Aero" pitchFamily="34" charset="-122"/>
+                <a:cs typeface="AT Aero" pitchFamily="34" charset="-120"/>
               </a:rPr>
               <a:t>Nearly 50% of semiconductor industry growth and revenue is driven by high-performance AI accelerators.</a:t>
             </a:r>
@@ -3809,9 +3898,9 @@
                 <a:solidFill>
                   <a:srgbClr val="6B6560"/>
                 </a:solidFill>
-                <a:latin typeface="VVDS Fifties" pitchFamily="34" charset="0"/>
-                <a:ea typeface="VVDS Fifties" pitchFamily="34" charset="-122"/>
-                <a:cs typeface="VVDS Fifties" pitchFamily="34" charset="-120"/>
+                <a:latin typeface="AT Aero" pitchFamily="34" charset="0"/>
+                <a:ea typeface="AT Aero" pitchFamily="34" charset="-122"/>
+                <a:cs typeface="AT Aero" pitchFamily="34" charset="-120"/>
               </a:rPr>
               <a:t>The fastest growing volume segment, requiring massive numbers of legacy control nodes and SiC power chips.</a:t>
             </a:r>
@@ -3912,9 +4001,9 @@
                 <a:solidFill>
                   <a:srgbClr val="6B6560"/>
                 </a:solidFill>
-                <a:latin typeface="VVDS Fifties" pitchFamily="34" charset="0"/>
-                <a:ea typeface="VVDS Fifties" pitchFamily="34" charset="-122"/>
-                <a:cs typeface="VVDS Fifties" pitchFamily="34" charset="-120"/>
+                <a:latin typeface="AT Aero" pitchFamily="34" charset="0"/>
+                <a:ea typeface="AT Aero" pitchFamily="34" charset="-122"/>
+                <a:cs typeface="AT Aero" pitchFamily="34" charset="-120"/>
               </a:rPr>
               <a:t>Traditional core segments face volume saturation, driving consolidation and focus on specialized edge accelerators.</a:t>
             </a:r>
@@ -3983,9 +4072,9 @@
                 <a:solidFill>
                   <a:srgbClr val="B84A2F"/>
                 </a:solidFill>
-                <a:latin typeface="VVDS Fifties" pitchFamily="34" charset="0"/>
-                <a:ea typeface="VVDS Fifties" pitchFamily="34" charset="-122"/>
-                <a:cs typeface="VVDS Fifties" pitchFamily="34" charset="-120"/>
+                <a:latin typeface="AT Aero" pitchFamily="34" charset="0"/>
+                <a:ea typeface="AT Aero" pitchFamily="34" charset="-122"/>
+                <a:cs typeface="AT Aero" pitchFamily="34" charset="-120"/>
               </a:rPr>
               <a:t>PART 3: END-USER INDUSTRIES &amp; APPLICATION ECOSYSTEM</a:t>
             </a:r>
@@ -4061,9 +4150,9 @@
                 <a:solidFill>
                   <a:srgbClr val="6B6560"/>
                 </a:solidFill>
-                <a:latin typeface="VVDS Fifties" pitchFamily="34" charset="0"/>
-                <a:ea typeface="VVDS Fifties" pitchFamily="34" charset="-122"/>
-                <a:cs typeface="VVDS Fifties" pitchFamily="34" charset="-120"/>
+                <a:latin typeface="AT Aero" pitchFamily="34" charset="0"/>
+                <a:ea typeface="AT Aero" pitchFamily="34" charset="-122"/>
+                <a:cs typeface="AT Aero" pitchFamily="34" charset="-120"/>
               </a:rPr>
               <a:t>The 2026 Semiconductor Ecosystem | Slide 13</a:t>
             </a:r>
@@ -4125,9 +4214,9 @@
                 <a:solidFill>
                   <a:srgbClr val="768C7C"/>
                 </a:solidFill>
-                <a:latin typeface="VVDS Fifties" pitchFamily="34" charset="0"/>
-                <a:ea typeface="VVDS Fifties" pitchFamily="34" charset="-122"/>
-                <a:cs typeface="VVDS Fifties" pitchFamily="34" charset="-120"/>
+                <a:latin typeface="AT Aero" pitchFamily="34" charset="0"/>
+                <a:ea typeface="AT Aero" pitchFamily="34" charset="-122"/>
+                <a:cs typeface="AT Aero" pitchFamily="34" charset="-120"/>
               </a:rPr>
               <a:t>Key Message: Data centers have evolved into "Intelligence Engines," consuming the highest-value silicon ever produced.</a:t>
             </a:r>
@@ -4165,9 +4254,9 @@
                 <a:solidFill>
                   <a:srgbClr val="6B6560"/>
                 </a:solidFill>
-                <a:latin typeface="VVDS Fifties" pitchFamily="34" charset="0"/>
-                <a:ea typeface="VVDS Fifties" pitchFamily="34" charset="-122"/>
-                <a:cs typeface="VVDS Fifties" pitchFamily="34" charset="-120"/>
+                <a:latin typeface="AT Aero" pitchFamily="34" charset="0"/>
+                <a:ea typeface="AT Aero" pitchFamily="34" charset="-122"/>
+                <a:cs typeface="AT Aero" pitchFamily="34" charset="-120"/>
               </a:rPr>
               <a:t>- Accelerator Market ($500B): Generative models and neural computing demand massive scaling of TPU and GPU nodes.</a:t>
             </a:r>
@@ -4190,9 +4279,9 @@
                 <a:solidFill>
                   <a:srgbClr val="6B6560"/>
                 </a:solidFill>
-                <a:latin typeface="VVDS Fifties" pitchFamily="34" charset="0"/>
-                <a:ea typeface="VVDS Fifties" pitchFamily="34" charset="-122"/>
-                <a:cs typeface="VVDS Fifties" pitchFamily="34" charset="-120"/>
+                <a:latin typeface="AT Aero" pitchFamily="34" charset="0"/>
+                <a:ea typeface="AT Aero" pitchFamily="34" charset="-122"/>
+                <a:cs typeface="AT Aero" pitchFamily="34" charset="-120"/>
               </a:rPr>
               <a:t>- Sub-3nm Node Sourcing: The primary consumers of the most advanced wafer print architectures globally.</a:t>
             </a:r>
@@ -4215,9 +4304,9 @@
                 <a:solidFill>
                   <a:srgbClr val="6B6560"/>
                 </a:solidFill>
-                <a:latin typeface="VVDS Fifties" pitchFamily="34" charset="0"/>
-                <a:ea typeface="VVDS Fifties" pitchFamily="34" charset="-122"/>
-                <a:cs typeface="VVDS Fifties" pitchFamily="34" charset="-120"/>
+                <a:latin typeface="AT Aero" pitchFamily="34" charset="0"/>
+                <a:ea typeface="AT Aero" pitchFamily="34" charset="-122"/>
+                <a:cs typeface="AT Aero" pitchFamily="34" charset="-120"/>
               </a:rPr>
               <a:t>- Memory &amp; Interconnect: Demands extreme density of High Bandwidth Memory (HBM) and customized routing interconnect silicon.</a:t>
             </a:r>
@@ -4279,9 +4368,9 @@
                 <a:solidFill>
                   <a:srgbClr val="768C7C"/>
                 </a:solidFill>
-                <a:latin typeface="VVDS Fifties" pitchFamily="34" charset="0"/>
-                <a:ea typeface="VVDS Fifties" pitchFamily="34" charset="-122"/>
-                <a:cs typeface="VVDS Fifties" pitchFamily="34" charset="-120"/>
+                <a:latin typeface="AT Aero" pitchFamily="34" charset="0"/>
+                <a:ea typeface="AT Aero" pitchFamily="34" charset="-122"/>
+                <a:cs typeface="AT Aero" pitchFamily="34" charset="-120"/>
               </a:rPr>
               <a:t>ANALYST PROJECT</a:t>
             </a:r>
@@ -4357,9 +4446,9 @@
                 <a:solidFill>
                   <a:srgbClr val="6B6560"/>
                 </a:solidFill>
-                <a:latin typeface="VVDS Fifties" pitchFamily="34" charset="0"/>
-                <a:ea typeface="VVDS Fifties" pitchFamily="34" charset="-122"/>
-                <a:cs typeface="VVDS Fifties" pitchFamily="34" charset="-120"/>
+                <a:latin typeface="AT Aero" pitchFamily="34" charset="0"/>
+                <a:ea typeface="AT Aero" pitchFamily="34" charset="-122"/>
+                <a:cs typeface="AT Aero" pitchFamily="34" charset="-120"/>
               </a:rPr>
               <a:t>AI Accelerator market size by 2026</a:t>
             </a:r>
@@ -4428,9 +4517,9 @@
                 <a:solidFill>
                   <a:srgbClr val="B84A2F"/>
                 </a:solidFill>
-                <a:latin typeface="VVDS Fifties" pitchFamily="34" charset="0"/>
-                <a:ea typeface="VVDS Fifties" pitchFamily="34" charset="-122"/>
-                <a:cs typeface="VVDS Fifties" pitchFamily="34" charset="-120"/>
+                <a:latin typeface="AT Aero" pitchFamily="34" charset="0"/>
+                <a:ea typeface="AT Aero" pitchFamily="34" charset="-122"/>
+                <a:cs typeface="AT Aero" pitchFamily="34" charset="-120"/>
               </a:rPr>
               <a:t>PART 3: END-USER INDUSTRIES &amp; APPLICATION ECOSYSTEM</a:t>
             </a:r>
@@ -4506,9 +4595,9 @@
                 <a:solidFill>
                   <a:srgbClr val="6B6560"/>
                 </a:solidFill>
-                <a:latin typeface="VVDS Fifties" pitchFamily="34" charset="0"/>
-                <a:ea typeface="VVDS Fifties" pitchFamily="34" charset="-122"/>
-                <a:cs typeface="VVDS Fifties" pitchFamily="34" charset="-120"/>
+                <a:latin typeface="AT Aero" pitchFamily="34" charset="0"/>
+                <a:ea typeface="AT Aero" pitchFamily="34" charset="-122"/>
+                <a:cs typeface="AT Aero" pitchFamily="34" charset="-120"/>
               </a:rPr>
               <a:t>The 2026 Semiconductor Ecosystem | Slide 14</a:t>
             </a:r>
@@ -4570,9 +4659,9 @@
                 <a:solidFill>
                   <a:srgbClr val="B84A2F"/>
                 </a:solidFill>
-                <a:latin typeface="VVDS Fifties" pitchFamily="34" charset="0"/>
-                <a:ea typeface="VVDS Fifties" pitchFamily="34" charset="-122"/>
-                <a:cs typeface="VVDS Fifties" pitchFamily="34" charset="-120"/>
+                <a:latin typeface="AT Aero" pitchFamily="34" charset="0"/>
+                <a:ea typeface="AT Aero" pitchFamily="34" charset="-122"/>
+                <a:cs typeface="AT Aero" pitchFamily="34" charset="-120"/>
               </a:rPr>
               <a:t>Key Message: The transition to EVs and ADAS is doubling semiconductor content per vehicle, reaching over $1,000 per unit.</a:t>
             </a:r>
@@ -4610,9 +4699,9 @@
                 <a:solidFill>
                   <a:srgbClr val="6B6560"/>
                 </a:solidFill>
-                <a:latin typeface="VVDS Fifties" pitchFamily="34" charset="0"/>
-                <a:ea typeface="VVDS Fifties" pitchFamily="34" charset="-122"/>
-                <a:cs typeface="VVDS Fifties" pitchFamily="34" charset="-120"/>
+                <a:latin typeface="AT Aero" pitchFamily="34" charset="0"/>
+                <a:ea typeface="AT Aero" pitchFamily="34" charset="-122"/>
+                <a:cs typeface="AT Aero" pitchFamily="34" charset="-120"/>
               </a:rPr>
               <a:t>- Silicon Carbide (SiC) Power: Drives high-efficiency power switches in high-voltage EV battery platforms.</a:t>
             </a:r>
@@ -4635,9 +4724,9 @@
                 <a:solidFill>
                   <a:srgbClr val="6B6560"/>
                 </a:solidFill>
-                <a:latin typeface="VVDS Fifties" pitchFamily="34" charset="0"/>
-                <a:ea typeface="VVDS Fifties" pitchFamily="34" charset="-122"/>
-                <a:cs typeface="VVDS Fifties" pitchFamily="34" charset="-120"/>
+                <a:latin typeface="AT Aero" pitchFamily="34" charset="0"/>
+                <a:ea typeface="AT Aero" pitchFamily="34" charset="-122"/>
+                <a:cs typeface="AT Aero" pitchFamily="34" charset="-120"/>
               </a:rPr>
               <a:t>- ADAS Autonomous Compute: Self-driving capabilities demand heavy on-board computational units for sensor fusion.</a:t>
             </a:r>
@@ -4660,9 +4749,9 @@
                 <a:solidFill>
                   <a:srgbClr val="6B6560"/>
                 </a:solidFill>
-                <a:latin typeface="VVDS Fifties" pitchFamily="34" charset="0"/>
-                <a:ea typeface="VVDS Fifties" pitchFamily="34" charset="-122"/>
-                <a:cs typeface="VVDS Fifties" pitchFamily="34" charset="-120"/>
+                <a:latin typeface="AT Aero" pitchFamily="34" charset="0"/>
+                <a:ea typeface="AT Aero" pitchFamily="34" charset="-122"/>
+                <a:cs typeface="AT Aero" pitchFamily="34" charset="-120"/>
               </a:rPr>
               <a:t>- Sensor Arrays Sourcing: Vehicles integrate multiple LiDAR, radar, and camera chip sets for 360-degree coverage.</a:t>
             </a:r>
@@ -4724,9 +4813,9 @@
                 <a:solidFill>
                   <a:srgbClr val="B84A2F"/>
                 </a:solidFill>
-                <a:latin typeface="VVDS Fifties" pitchFamily="34" charset="0"/>
-                <a:ea typeface="VVDS Fifties" pitchFamily="34" charset="-122"/>
-                <a:cs typeface="VVDS Fifties" pitchFamily="34" charset="-120"/>
+                <a:latin typeface="AT Aero" pitchFamily="34" charset="0"/>
+                <a:ea typeface="AT Aero" pitchFamily="34" charset="-122"/>
+                <a:cs typeface="AT Aero" pitchFamily="34" charset="-120"/>
               </a:rPr>
               <a:t>ESTIMATE</a:t>
             </a:r>
@@ -4802,9 +4891,9 @@
                 <a:solidFill>
                   <a:srgbClr val="6B6560"/>
                 </a:solidFill>
-                <a:latin typeface="VVDS Fifties" pitchFamily="34" charset="0"/>
-                <a:ea typeface="VVDS Fifties" pitchFamily="34" charset="-122"/>
-                <a:cs typeface="VVDS Fifties" pitchFamily="34" charset="-120"/>
+                <a:latin typeface="AT Aero" pitchFamily="34" charset="0"/>
+                <a:ea typeface="AT Aero" pitchFamily="34" charset="-122"/>
+                <a:cs typeface="AT Aero" pitchFamily="34" charset="-120"/>
               </a:rPr>
               <a:t>Silicon value content per EV unit</a:t>
             </a:r>
@@ -4873,9 +4962,9 @@
                 <a:solidFill>
                   <a:srgbClr val="B84A2F"/>
                 </a:solidFill>
-                <a:latin typeface="VVDS Fifties" pitchFamily="34" charset="0"/>
-                <a:ea typeface="VVDS Fifties" pitchFamily="34" charset="-122"/>
-                <a:cs typeface="VVDS Fifties" pitchFamily="34" charset="-120"/>
+                <a:latin typeface="AT Aero" pitchFamily="34" charset="0"/>
+                <a:ea typeface="AT Aero" pitchFamily="34" charset="-122"/>
+                <a:cs typeface="AT Aero" pitchFamily="34" charset="-120"/>
               </a:rPr>
               <a:t>PART 3: END-USER INDUSTRIES &amp; APPLICATION ECOSYSTEM</a:t>
             </a:r>
@@ -4951,9 +5040,9 @@
                 <a:solidFill>
                   <a:srgbClr val="6B6560"/>
                 </a:solidFill>
-                <a:latin typeface="VVDS Fifties" pitchFamily="34" charset="0"/>
-                <a:ea typeface="VVDS Fifties" pitchFamily="34" charset="-122"/>
-                <a:cs typeface="VVDS Fifties" pitchFamily="34" charset="-120"/>
+                <a:latin typeface="AT Aero" pitchFamily="34" charset="0"/>
+                <a:ea typeface="AT Aero" pitchFamily="34" charset="-122"/>
+                <a:cs typeface="AT Aero" pitchFamily="34" charset="-120"/>
               </a:rPr>
               <a:t>The 2026 Semiconductor Ecosystem | Slide 15</a:t>
             </a:r>
@@ -5015,9 +5104,9 @@
                 <a:solidFill>
                   <a:srgbClr val="9E7D84"/>
                 </a:solidFill>
-                <a:latin typeface="VVDS Fifties" pitchFamily="34" charset="0"/>
-                <a:ea typeface="VVDS Fifties" pitchFamily="34" charset="-122"/>
-                <a:cs typeface="VVDS Fifties" pitchFamily="34" charset="-120"/>
+                <a:latin typeface="AT Aero" pitchFamily="34" charset="0"/>
+                <a:ea typeface="AT Aero" pitchFamily="34" charset="-122"/>
+                <a:cs typeface="AT Aero" pitchFamily="34" charset="-120"/>
               </a:rPr>
               <a:t>Key Message: Edge AI is transforming manufacturing and healthcare, prioritizing long-lifecycle, high-reliability silicon.</a:t>
             </a:r>
@@ -5118,9 +5207,9 @@
                 <a:solidFill>
                   <a:srgbClr val="6B6560"/>
                 </a:solidFill>
-                <a:latin typeface="VVDS Fifties" pitchFamily="34" charset="0"/>
-                <a:ea typeface="VVDS Fifties" pitchFamily="34" charset="-122"/>
-                <a:cs typeface="VVDS Fifties" pitchFamily="34" charset="-120"/>
+                <a:latin typeface="AT Aero" pitchFamily="34" charset="0"/>
+                <a:ea typeface="AT Aero" pitchFamily="34" charset="-122"/>
+                <a:cs typeface="AT Aero" pitchFamily="34" charset="-120"/>
               </a:rPr>
               <a:t>Factory floor nodes execute real-time local algorithms for predictive maintenance and machine vision controls, utilizing highly rugged legacy processes.</a:t>
             </a:r>
@@ -5221,9 +5310,9 @@
                 <a:solidFill>
                   <a:srgbClr val="6B6560"/>
                 </a:solidFill>
-                <a:latin typeface="VVDS Fifties" pitchFamily="34" charset="0"/>
-                <a:ea typeface="VVDS Fifties" pitchFamily="34" charset="-122"/>
-                <a:cs typeface="VVDS Fifties" pitchFamily="34" charset="-120"/>
+                <a:latin typeface="AT Aero" pitchFamily="34" charset="0"/>
+                <a:ea typeface="AT Aero" pitchFamily="34" charset="-122"/>
+                <a:cs typeface="AT Aero" pitchFamily="34" charset="-120"/>
               </a:rPr>
               <a:t>Semiconductors enable smart wearable diagnostics, active health implants, and personalized diagnostics. Requires extreme reliability certifications.</a:t>
             </a:r>
@@ -5292,9 +5381,9 @@
                 <a:solidFill>
                   <a:srgbClr val="B84A2F"/>
                 </a:solidFill>
-                <a:latin typeface="VVDS Fifties" pitchFamily="34" charset="0"/>
-                <a:ea typeface="VVDS Fifties" pitchFamily="34" charset="-122"/>
-                <a:cs typeface="VVDS Fifties" pitchFamily="34" charset="-120"/>
+                <a:latin typeface="AT Aero" pitchFamily="34" charset="0"/>
+                <a:ea typeface="AT Aero" pitchFamily="34" charset="-122"/>
+                <a:cs typeface="AT Aero" pitchFamily="34" charset="-120"/>
               </a:rPr>
               <a:t>PART 3: END-USER INDUSTRIES &amp; APPLICATION ECOSYSTEM</a:t>
             </a:r>
@@ -5370,9 +5459,9 @@
                 <a:solidFill>
                   <a:srgbClr val="6B6560"/>
                 </a:solidFill>
-                <a:latin typeface="VVDS Fifties" pitchFamily="34" charset="0"/>
-                <a:ea typeface="VVDS Fifties" pitchFamily="34" charset="-122"/>
-                <a:cs typeface="VVDS Fifties" pitchFamily="34" charset="-120"/>
+                <a:latin typeface="AT Aero" pitchFamily="34" charset="0"/>
+                <a:ea typeface="AT Aero" pitchFamily="34" charset="-122"/>
+                <a:cs typeface="AT Aero" pitchFamily="34" charset="-120"/>
               </a:rPr>
               <a:t>The 2026 Semiconductor Ecosystem | Slide 16</a:t>
             </a:r>
@@ -5434,9 +5523,9 @@
                 <a:solidFill>
                   <a:srgbClr val="768C7C"/>
                 </a:solidFill>
-                <a:latin typeface="VVDS Fifties" pitchFamily="34" charset="0"/>
-                <a:ea typeface="VVDS Fifties" pitchFamily="34" charset="-122"/>
-                <a:cs typeface="VVDS Fifties" pitchFamily="34" charset="-120"/>
+                <a:latin typeface="AT Aero" pitchFamily="34" charset="0"/>
+                <a:ea typeface="AT Aero" pitchFamily="34" charset="-122"/>
+                <a:cs typeface="AT Aero" pitchFamily="34" charset="-120"/>
               </a:rPr>
               <a:t>Key Message: While traditional consumer tech matures, frontiers like Quantum, 6G, and Neuromorphic computing define the 2030 roadmap.</a:t>
             </a:r>
@@ -5474,9 +5563,9 @@
                 <a:solidFill>
                   <a:srgbClr val="6B6560"/>
                 </a:solidFill>
-                <a:latin typeface="VVDS Fifties" pitchFamily="34" charset="0"/>
-                <a:ea typeface="VVDS Fifties" pitchFamily="34" charset="-122"/>
-                <a:cs typeface="VVDS Fifties" pitchFamily="34" charset="-120"/>
+                <a:latin typeface="AT Aero" pitchFamily="34" charset="0"/>
+                <a:ea typeface="AT Aero" pitchFamily="34" charset="-122"/>
+                <a:cs typeface="AT Aero" pitchFamily="34" charset="-120"/>
               </a:rPr>
               <a:t>- On-Device NPU Logic: Integrating Neural Processing Units (NPUs) into laptops and mobile phones to enable local AI execution.</a:t>
             </a:r>
@@ -5499,9 +5588,9 @@
                 <a:solidFill>
                   <a:srgbClr val="6B6560"/>
                 </a:solidFill>
-                <a:latin typeface="VVDS Fifties" pitchFamily="34" charset="0"/>
-                <a:ea typeface="VVDS Fifties" pitchFamily="34" charset="-122"/>
-                <a:cs typeface="VVDS Fifties" pitchFamily="34" charset="-120"/>
+                <a:latin typeface="AT Aero" pitchFamily="34" charset="0"/>
+                <a:ea typeface="AT Aero" pitchFamily="34" charset="-122"/>
+                <a:cs typeface="AT Aero" pitchFamily="34" charset="-120"/>
               </a:rPr>
               <a:t>- Neuromorphic Computing: Researching brain-inspired architectures targeting extreme computing power efficiency.</a:t>
             </a:r>
@@ -5524,9 +5613,9 @@
                 <a:solidFill>
                   <a:srgbClr val="6B6560"/>
                 </a:solidFill>
-                <a:latin typeface="VVDS Fifties" pitchFamily="34" charset="0"/>
-                <a:ea typeface="VVDS Fifties" pitchFamily="34" charset="-122"/>
-                <a:cs typeface="VVDS Fifties" pitchFamily="34" charset="-120"/>
+                <a:latin typeface="AT Aero" pitchFamily="34" charset="0"/>
+                <a:ea typeface="AT Aero" pitchFamily="34" charset="-122"/>
+                <a:cs typeface="AT Aero" pitchFamily="34" charset="-120"/>
               </a:rPr>
               <a:t>- Next-Gen Frontiers: Developing quantum structures and 6G communications hardware blocks.</a:t>
             </a:r>
@@ -5588,9 +5677,9 @@
                 <a:solidFill>
                   <a:srgbClr val="768C7C"/>
                 </a:solidFill>
-                <a:latin typeface="VVDS Fifties" pitchFamily="34" charset="0"/>
-                <a:ea typeface="VVDS Fifties" pitchFamily="34" charset="-122"/>
-                <a:cs typeface="VVDS Fifties" pitchFamily="34" charset="-120"/>
+                <a:latin typeface="AT Aero" pitchFamily="34" charset="0"/>
+                <a:ea typeface="AT Aero" pitchFamily="34" charset="-122"/>
+                <a:cs typeface="AT Aero" pitchFamily="34" charset="-120"/>
               </a:rPr>
               <a:t>NPU CORES</a:t>
             </a:r>
@@ -5666,9 +5755,9 @@
                 <a:solidFill>
                   <a:srgbClr val="6B6560"/>
                 </a:solidFill>
-                <a:latin typeface="VVDS Fifties" pitchFamily="34" charset="0"/>
-                <a:ea typeface="VVDS Fifties" pitchFamily="34" charset="-122"/>
-                <a:cs typeface="VVDS Fifties" pitchFamily="34" charset="-120"/>
+                <a:latin typeface="AT Aero" pitchFamily="34" charset="0"/>
+                <a:ea typeface="AT Aero" pitchFamily="34" charset="-122"/>
+                <a:cs typeface="AT Aero" pitchFamily="34" charset="-120"/>
               </a:rPr>
               <a:t>Standard hardware in 2026 client electronics (laptops, phones)</a:t>
             </a:r>
@@ -5737,9 +5826,9 @@
                 <a:solidFill>
                   <a:srgbClr val="B84A2F"/>
                 </a:solidFill>
-                <a:latin typeface="VVDS Fifties" pitchFamily="34" charset="0"/>
-                <a:ea typeface="VVDS Fifties" pitchFamily="34" charset="-122"/>
-                <a:cs typeface="VVDS Fifties" pitchFamily="34" charset="-120"/>
+                <a:latin typeface="AT Aero" pitchFamily="34" charset="0"/>
+                <a:ea typeface="AT Aero" pitchFamily="34" charset="-122"/>
+                <a:cs typeface="AT Aero" pitchFamily="34" charset="-120"/>
               </a:rPr>
               <a:t>SUMMARY &amp; ROADMAP</a:t>
             </a:r>
@@ -5815,9 +5904,9 @@
                 <a:solidFill>
                   <a:srgbClr val="6B6560"/>
                 </a:solidFill>
-                <a:latin typeface="VVDS Fifties" pitchFamily="34" charset="0"/>
-                <a:ea typeface="VVDS Fifties" pitchFamily="34" charset="-122"/>
-                <a:cs typeface="VVDS Fifties" pitchFamily="34" charset="-120"/>
+                <a:latin typeface="AT Aero" pitchFamily="34" charset="0"/>
+                <a:ea typeface="AT Aero" pitchFamily="34" charset="-122"/>
+                <a:cs typeface="AT Aero" pitchFamily="34" charset="-120"/>
               </a:rPr>
               <a:t>The 2026 Semiconductor Ecosystem | Slide 17</a:t>
             </a:r>
@@ -5879,9 +5968,9 @@
                 <a:solidFill>
                   <a:srgbClr val="B84A2F"/>
                 </a:solidFill>
-                <a:latin typeface="VVDS Fifties" pitchFamily="34" charset="0"/>
-                <a:ea typeface="VVDS Fifties" pitchFamily="34" charset="-122"/>
-                <a:cs typeface="VVDS Fifties" pitchFamily="34" charset="-120"/>
+                <a:latin typeface="AT Aero" pitchFamily="34" charset="0"/>
+                <a:ea typeface="AT Aero" pitchFamily="34" charset="-122"/>
+                <a:cs typeface="AT Aero" pitchFamily="34" charset="-120"/>
               </a:rPr>
               <a:t>Key Message: We have reached a point of "Total Silicon Dependency." The path to a $2 trillion industry is certain.</a:t>
             </a:r>
@@ -5918,9 +6007,9 @@
                 <a:solidFill>
                   <a:srgbClr val="6B6560"/>
                 </a:solidFill>
-                <a:latin typeface="VVDS Fifties" pitchFamily="34" charset="0"/>
-                <a:ea typeface="VVDS Fifties" pitchFamily="34" charset="-122"/>
-                <a:cs typeface="VVDS Fifties" pitchFamily="34" charset="-120"/>
+                <a:latin typeface="AT Aero" pitchFamily="34" charset="0"/>
+                <a:ea typeface="AT Aero" pitchFamily="34" charset="-122"/>
+                <a:cs typeface="AT Aero" pitchFamily="34" charset="-120"/>
               </a:rPr>
               <a:t>Mastery of the semiconductor ecosystem is mastery of the future. The "Chip Wars" aren't just about manufacturing; they are about who can best harness silicon to transform their industries.</a:t>
             </a:r>
@@ -5957,9 +6046,9 @@
                 <a:solidFill>
                   <a:srgbClr val="1A1714"/>
                 </a:solidFill>
-                <a:latin typeface="VVDS Fifties" pitchFamily="34" charset="0"/>
-                <a:ea typeface="VVDS Fifties" pitchFamily="34" charset="-122"/>
-                <a:cs typeface="VVDS Fifties" pitchFamily="34" charset="-120"/>
+                <a:latin typeface="AT Aero" pitchFamily="34" charset="0"/>
+                <a:ea typeface="AT Aero" pitchFamily="34" charset="-122"/>
+                <a:cs typeface="AT Aero" pitchFamily="34" charset="-120"/>
               </a:rPr>
               <a:t>KEY TAKEAWAYS SUMMARY</a:t>
             </a:r>
@@ -6060,9 +6149,9 @@
                 <a:solidFill>
                   <a:srgbClr val="6B6560"/>
                 </a:solidFill>
-                <a:latin typeface="VVDS Fifties" pitchFamily="34" charset="0"/>
-                <a:ea typeface="VVDS Fifties" pitchFamily="34" charset="-122"/>
-                <a:cs typeface="VVDS Fifties" pitchFamily="34" charset="-120"/>
+                <a:latin typeface="AT Aero" pitchFamily="34" charset="0"/>
+                <a:ea typeface="AT Aero" pitchFamily="34" charset="-122"/>
+                <a:cs typeface="AT Aero" pitchFamily="34" charset="-120"/>
               </a:rPr>
               <a:t>Shift from JIT to Strategic Hybrid; resilience is the new ROI.</a:t>
             </a:r>
@@ -6163,9 +6252,9 @@
                 <a:solidFill>
                   <a:srgbClr val="6B6560"/>
                 </a:solidFill>
-                <a:latin typeface="VVDS Fifties" pitchFamily="34" charset="0"/>
-                <a:ea typeface="VVDS Fifties" pitchFamily="34" charset="-122"/>
-                <a:cs typeface="VVDS Fifties" pitchFamily="34" charset="-120"/>
+                <a:latin typeface="AT Aero" pitchFamily="34" charset="0"/>
+                <a:ea typeface="AT Aero" pitchFamily="34" charset="-122"/>
+                <a:cs typeface="AT Aero" pitchFamily="34" charset="-120"/>
               </a:rPr>
               <a:t>Chokepoints in Advanced Packaging and SME are the new strategic risks.</a:t>
             </a:r>
@@ -6266,13 +6355,277 @@
                 <a:solidFill>
                   <a:srgbClr val="6B6560"/>
                 </a:solidFill>
-                <a:latin typeface="VVDS Fifties" pitchFamily="34" charset="0"/>
-                <a:ea typeface="VVDS Fifties" pitchFamily="34" charset="-122"/>
-                <a:cs typeface="VVDS Fifties" pitchFamily="34" charset="-120"/>
+                <a:latin typeface="AT Aero" pitchFamily="34" charset="0"/>
+                <a:ea typeface="AT Aero" pitchFamily="34" charset="-122"/>
+                <a:cs typeface="AT Aero" pitchFamily="34" charset="-120"/>
               </a:rPr>
               <a:t>AI is the Value King; Automotive is the Volume King.</a:t>
             </a:r>
             <a:endParaRPr lang="en-US" sz="1800" dirty="0"/>
+          </a:p>
+        </p:txBody>
+      </p:sp>
+    </p:spTree>
+  </p:cSld>
+  <p:clrMapOvr>
+    <a:masterClrMapping/>
+  </p:clrMapOvr>
+</p:sld>
+</file>
+
+<file path=ppt/slides/slide18.xml><?xml version="1.0" encoding="utf-8"?>
+<p:sld xmlns:a="http://schemas.openxmlformats.org/drawingml/2006/main" xmlns:r="http://schemas.openxmlformats.org/officeDocument/2006/relationships" xmlns:p="http://schemas.openxmlformats.org/presentationml/2006/main">
+  <p:cSld name="Slide 18">
+    <p:bg>
+      <p:bgPr>
+        <a:solidFill>
+          <a:srgbClr val="F5F0E8"/>
+        </a:solidFill>
+      </p:bgPr>
+    </p:bg>
+    <p:spTree>
+      <p:nvGrpSpPr>
+        <p:cNvPr id="1" name=""/>
+        <p:cNvGrpSpPr/>
+        <p:nvPr/>
+      </p:nvGrpSpPr>
+      <p:grpSpPr>
+        <a:xfrm>
+          <a:off x="0" y="0"/>
+          <a:ext cx="0" cy="0"/>
+          <a:chOff x="0" y="0"/>
+          <a:chExt cx="0" cy="0"/>
+        </a:xfrm>
+      </p:grpSpPr>
+      <p:sp>
+        <p:nvSpPr>
+          <p:cNvPr id="3" name="Text 0"/>
+          <p:cNvSpPr/>
+          <p:nvPr/>
+        </p:nvSpPr>
+        <p:spPr>
+          <a:xfrm>
+            <a:off x="731520" y="1371600"/>
+            <a:ext cx="10515600" cy="365760"/>
+          </a:xfrm>
+          <a:prstGeom prst="rect">
+            <a:avLst/>
+          </a:prstGeom>
+          <a:noFill/>
+          <a:ln/>
+        </p:spPr>
+        <p:txBody>
+          <a:bodyPr wrap="square" rtlCol="0" anchor="ctr"/>
+          <a:lstStyle/>
+          <a:p>
+            <a:pPr indent="0" marL="0">
+              <a:buNone/>
+            </a:pPr>
+            <a:r>
+              <a:rPr lang="en-US" sz="1400" b="1" spc="150" kern="0" dirty="0">
+                <a:solidFill>
+                  <a:srgbClr val="B84A2F"/>
+                </a:solidFill>
+                <a:latin typeface="AT Aero" pitchFamily="34" charset="0"/>
+                <a:ea typeface="AT Aero" pitchFamily="34" charset="-122"/>
+                <a:cs typeface="AT Aero" pitchFamily="34" charset="-120"/>
+              </a:rPr>
+              <a:t>THE END</a:t>
+            </a:r>
+            <a:endParaRPr lang="en-US" sz="1400" dirty="0"/>
+          </a:p>
+        </p:txBody>
+      </p:sp>
+      <p:sp>
+        <p:nvSpPr>
+          <p:cNvPr id="4" name="Text 1"/>
+          <p:cNvSpPr/>
+          <p:nvPr/>
+        </p:nvSpPr>
+        <p:spPr>
+          <a:xfrm>
+            <a:off x="731520" y="1828800"/>
+            <a:ext cx="10515600" cy="1097280"/>
+          </a:xfrm>
+          <a:prstGeom prst="rect">
+            <a:avLst/>
+          </a:prstGeom>
+          <a:noFill/>
+          <a:ln/>
+        </p:spPr>
+        <p:txBody>
+          <a:bodyPr wrap="square" rtlCol="0" anchor="ctr"/>
+          <a:lstStyle/>
+          <a:p>
+            <a:pPr indent="0" marL="0">
+              <a:buNone/>
+            </a:pPr>
+            <a:r>
+              <a:rPr lang="en-US" sz="5600" b="1" dirty="0">
+                <a:solidFill>
+                  <a:srgbClr val="1A1714"/>
+                </a:solidFill>
+                <a:latin typeface="PP Mondwest" pitchFamily="34" charset="0"/>
+                <a:ea typeface="PP Mondwest" pitchFamily="34" charset="-122"/>
+                <a:cs typeface="PP Mondwest" pitchFamily="34" charset="-120"/>
+              </a:rPr>
+              <a:t>Thank You</a:t>
+            </a:r>
+            <a:endParaRPr lang="en-US" sz="5600" dirty="0"/>
+          </a:p>
+        </p:txBody>
+      </p:sp>
+      <p:sp>
+        <p:nvSpPr>
+          <p:cNvPr id="5" name="Text 2"/>
+          <p:cNvSpPr/>
+          <p:nvPr/>
+        </p:nvSpPr>
+        <p:spPr>
+          <a:xfrm>
+            <a:off x="731520" y="3017520"/>
+            <a:ext cx="10515600" cy="731520"/>
+          </a:xfrm>
+          <a:prstGeom prst="rect">
+            <a:avLst/>
+          </a:prstGeom>
+          <a:noFill/>
+          <a:ln/>
+        </p:spPr>
+        <p:txBody>
+          <a:bodyPr wrap="square" rtlCol="0" anchor="ctr"/>
+          <a:lstStyle/>
+          <a:p>
+            <a:pPr indent="0" marL="0">
+              <a:buNone/>
+            </a:pPr>
+            <a:r>
+              <a:rPr lang="en-US" sz="2000" dirty="0">
+                <a:solidFill>
+                  <a:srgbClr val="6B6560"/>
+                </a:solidFill>
+                <a:latin typeface="AT Aero" pitchFamily="34" charset="0"/>
+                <a:ea typeface="AT Aero" pitchFamily="34" charset="-122"/>
+                <a:cs typeface="AT Aero" pitchFamily="34" charset="-120"/>
+              </a:rPr>
+              <a:t>Mastery of the semiconductor ecosystem is mastery of the future.</a:t>
+            </a:r>
+            <a:endParaRPr lang="en-US" sz="2000" dirty="0"/>
+          </a:p>
+        </p:txBody>
+      </p:sp>
+      <p:sp>
+        <p:nvSpPr>
+          <p:cNvPr id="6" name="Shape 3"/>
+          <p:cNvSpPr/>
+          <p:nvPr/>
+        </p:nvSpPr>
+        <p:spPr>
+          <a:xfrm>
+            <a:off x="731520" y="3840480"/>
+            <a:ext cx="4572000" cy="36576"/>
+          </a:xfrm>
+          <a:prstGeom prst="rect">
+            <a:avLst/>
+          </a:prstGeom>
+          <a:solidFill>
+            <a:srgbClr val="B84A2F"/>
+          </a:solidFill>
+          <a:ln/>
+        </p:spPr>
+      </p:sp>
+      <p:sp>
+        <p:nvSpPr>
+          <p:cNvPr id="7" name="Text 4"/>
+          <p:cNvSpPr/>
+          <p:nvPr/>
+        </p:nvSpPr>
+        <p:spPr>
+          <a:xfrm>
+            <a:off x="731520" y="4206240"/>
+            <a:ext cx="4572000" cy="731520"/>
+          </a:xfrm>
+          <a:prstGeom prst="rect">
+            <a:avLst/>
+          </a:prstGeom>
+          <a:noFill/>
+          <a:ln/>
+        </p:spPr>
+        <p:txBody>
+          <a:bodyPr wrap="square" rtlCol="0" anchor="ctr"/>
+          <a:lstStyle/>
+          <a:p>
+            <a:pPr indent="0" marL="0">
+              <a:buNone/>
+            </a:pPr>
+            <a:r>
+              <a:rPr lang="en-US" sz="1400" dirty="0">
+                <a:solidFill>
+                  <a:srgbClr val="6B6560"/>
+                </a:solidFill>
+                <a:latin typeface="AT Aero" pitchFamily="34" charset="0"/>
+                <a:ea typeface="AT Aero" pitchFamily="34" charset="-122"/>
+                <a:cs typeface="AT Aero" pitchFamily="34" charset="-120"/>
+              </a:rPr>
+              <a:t>Presenter: Phyoe Sat Paing</a:t>
+            </a:r>
+            <a:endParaRPr lang="en-US" sz="1400" dirty="0"/>
+          </a:p>
+          <a:p>
+            <a:pPr indent="0" marL="0">
+              <a:buNone/>
+            </a:pPr>
+            <a:r>
+              <a:rPr lang="en-US" sz="1400" dirty="0">
+                <a:solidFill>
+                  <a:srgbClr val="6B6560"/>
+                </a:solidFill>
+                <a:latin typeface="AT Aero" pitchFamily="34" charset="0"/>
+                <a:ea typeface="AT Aero" pitchFamily="34" charset="-122"/>
+                <a:cs typeface="AT Aero" pitchFamily="34" charset="-120"/>
+              </a:rPr>
+              <a:t>Boardroom Strategic Briefing</a:t>
+            </a:r>
+            <a:endParaRPr lang="en-US" sz="1400" dirty="0"/>
+          </a:p>
+        </p:txBody>
+      </p:sp>
+      <p:sp>
+        <p:nvSpPr>
+          <p:cNvPr id="8" name="Text 5"/>
+          <p:cNvSpPr/>
+          <p:nvPr/>
+        </p:nvSpPr>
+        <p:spPr>
+          <a:xfrm>
+            <a:off x="548640" y="6400800"/>
+            <a:ext cx="10972800" cy="274320"/>
+          </a:xfrm>
+          <a:prstGeom prst="rect">
+            <a:avLst/>
+          </a:prstGeom>
+          <a:noFill/>
+          <a:ln/>
+        </p:spPr>
+        <p:txBody>
+          <a:bodyPr wrap="square" rtlCol="0" anchor="ctr"/>
+          <a:lstStyle/>
+          <a:p>
+            <a:pPr indent="0" marL="0">
+              <a:buNone/>
+            </a:pPr>
+            <a:r>
+              <a:rPr lang="en-US" sz="1000" dirty="0">
+                <a:solidFill>
+                  <a:srgbClr val="6B6560"/>
+                </a:solidFill>
+                <a:latin typeface="AT Aero" pitchFamily="34" charset="0"/>
+                <a:ea typeface="AT Aero" pitchFamily="34" charset="-122"/>
+                <a:cs typeface="AT Aero" pitchFamily="34" charset="-120"/>
+              </a:rPr>
+              <a:t>The 2026 Semiconductor Ecosystem | Slide 18</a:t>
+            </a:r>
+            <a:endParaRPr lang="en-US" sz="1000" dirty="0"/>
           </a:p>
         </p:txBody>
       </p:sp>
@@ -6337,9 +6690,9 @@
                 <a:solidFill>
                   <a:srgbClr val="B84A2F"/>
                 </a:solidFill>
-                <a:latin typeface="VVDS Fifties" pitchFamily="34" charset="0"/>
-                <a:ea typeface="VVDS Fifties" pitchFamily="34" charset="-122"/>
-                <a:cs typeface="VVDS Fifties" pitchFamily="34" charset="-120"/>
+                <a:latin typeface="AT Aero" pitchFamily="34" charset="0"/>
+                <a:ea typeface="AT Aero" pitchFamily="34" charset="-122"/>
+                <a:cs typeface="AT Aero" pitchFamily="34" charset="-120"/>
               </a:rPr>
               <a:t>PART 1: PROCUREMENT OF SEMICONDUCTORS</a:t>
             </a:r>
@@ -6415,9 +6768,9 @@
                 <a:solidFill>
                   <a:srgbClr val="6B6560"/>
                 </a:solidFill>
-                <a:latin typeface="VVDS Fifties" pitchFamily="34" charset="0"/>
-                <a:ea typeface="VVDS Fifties" pitchFamily="34" charset="-122"/>
-                <a:cs typeface="VVDS Fifties" pitchFamily="34" charset="-120"/>
+                <a:latin typeface="AT Aero" pitchFamily="34" charset="0"/>
+                <a:ea typeface="AT Aero" pitchFamily="34" charset="-122"/>
+                <a:cs typeface="AT Aero" pitchFamily="34" charset="-120"/>
               </a:rPr>
               <a:t>The 2026 Semiconductor Ecosystem | Slide 02</a:t>
             </a:r>
@@ -6479,9 +6832,9 @@
                 <a:solidFill>
                   <a:srgbClr val="B84A2F"/>
                 </a:solidFill>
-                <a:latin typeface="VVDS Fifties" pitchFamily="34" charset="0"/>
-                <a:ea typeface="VVDS Fifties" pitchFamily="34" charset="-122"/>
-                <a:cs typeface="VVDS Fifties" pitchFamily="34" charset="-120"/>
+                <a:latin typeface="AT Aero" pitchFamily="34" charset="0"/>
+                <a:ea typeface="AT Aero" pitchFamily="34" charset="-122"/>
+                <a:cs typeface="AT Aero" pitchFamily="34" charset="-120"/>
               </a:rPr>
               <a:t>Key Message: Navigating a $1.3 trillion market requires balancing unprecedented growth with systemic supply chain fragility.</a:t>
             </a:r>
@@ -6519,9 +6872,9 @@
                 <a:solidFill>
                   <a:srgbClr val="6B6560"/>
                 </a:solidFill>
-                <a:latin typeface="VVDS Fifties" pitchFamily="34" charset="0"/>
-                <a:ea typeface="VVDS Fifties" pitchFamily="34" charset="-122"/>
-                <a:cs typeface="VVDS Fifties" pitchFamily="34" charset="-120"/>
+                <a:latin typeface="AT Aero" pitchFamily="34" charset="0"/>
+                <a:ea typeface="AT Aero" pitchFamily="34" charset="-122"/>
+                <a:cs typeface="AT Aero" pitchFamily="34" charset="-120"/>
               </a:rPr>
               <a:t>- Record-High Valuations: Growth is driven by explosive global demand for AI systems and electric vehicle power logic.</a:t>
             </a:r>
@@ -6544,9 +6897,9 @@
                 <a:solidFill>
                   <a:srgbClr val="6B6560"/>
                 </a:solidFill>
-                <a:latin typeface="VVDS Fifties" pitchFamily="34" charset="0"/>
-                <a:ea typeface="VVDS Fifties" pitchFamily="34" charset="-122"/>
-                <a:cs typeface="VVDS Fifties" pitchFamily="34" charset="-120"/>
+                <a:latin typeface="AT Aero" pitchFamily="34" charset="0"/>
+                <a:ea typeface="AT Aero" pitchFamily="34" charset="-122"/>
+                <a:cs typeface="AT Aero" pitchFamily="34" charset="-120"/>
               </a:rPr>
               <a:t>- Systemic Fragility: Leading-edge fabs operate near maximum capacity, leaving the industry vulnerable to minor material delays.</a:t>
             </a:r>
@@ -6569,9 +6922,9 @@
                 <a:solidFill>
                   <a:srgbClr val="6B6560"/>
                 </a:solidFill>
-                <a:latin typeface="VVDS Fifties" pitchFamily="34" charset="0"/>
-                <a:ea typeface="VVDS Fifties" pitchFamily="34" charset="-122"/>
-                <a:cs typeface="VVDS Fifties" pitchFamily="34" charset="-120"/>
+                <a:latin typeface="AT Aero" pitchFamily="34" charset="0"/>
+                <a:ea typeface="AT Aero" pitchFamily="34" charset="-122"/>
+                <a:cs typeface="AT Aero" pitchFamily="34" charset="-120"/>
               </a:rPr>
               <a:t>- Strategic Pivot: Sourcing HBM (High Bandwidth Memory) and advanced logic requires a shift from transactional purchasing to capacity reservation models.</a:t>
             </a:r>
@@ -6633,9 +6986,9 @@
                 <a:solidFill>
                   <a:srgbClr val="B84A2F"/>
                 </a:solidFill>
-                <a:latin typeface="VVDS Fifties" pitchFamily="34" charset="0"/>
-                <a:ea typeface="VVDS Fifties" pitchFamily="34" charset="-122"/>
-                <a:cs typeface="VVDS Fifties" pitchFamily="34" charset="-120"/>
+                <a:latin typeface="AT Aero" pitchFamily="34" charset="0"/>
+                <a:ea typeface="AT Aero" pitchFamily="34" charset="-122"/>
+                <a:cs typeface="AT Aero" pitchFamily="34" charset="-120"/>
               </a:rPr>
               <a:t>ESTIMATE</a:t>
             </a:r>
@@ -6711,9 +7064,9 @@
                 <a:solidFill>
                   <a:srgbClr val="6B6560"/>
                 </a:solidFill>
-                <a:latin typeface="VVDS Fifties" pitchFamily="34" charset="0"/>
-                <a:ea typeface="VVDS Fifties" pitchFamily="34" charset="-122"/>
-                <a:cs typeface="VVDS Fifties" pitchFamily="34" charset="-120"/>
+                <a:latin typeface="AT Aero" pitchFamily="34" charset="0"/>
+                <a:ea typeface="AT Aero" pitchFamily="34" charset="-122"/>
+                <a:cs typeface="AT Aero" pitchFamily="34" charset="-120"/>
               </a:rPr>
               <a:t>Global Market Value</a:t>
             </a:r>
@@ -6728,9 +7081,9 @@
                 <a:solidFill>
                   <a:srgbClr val="6B6560"/>
                 </a:solidFill>
-                <a:latin typeface="VVDS Fifties" pitchFamily="34" charset="0"/>
-                <a:ea typeface="VVDS Fifties" pitchFamily="34" charset="-122"/>
-                <a:cs typeface="VVDS Fifties" pitchFamily="34" charset="-120"/>
+                <a:latin typeface="AT Aero" pitchFamily="34" charset="0"/>
+                <a:ea typeface="AT Aero" pitchFamily="34" charset="-122"/>
+                <a:cs typeface="AT Aero" pitchFamily="34" charset="-120"/>
               </a:rPr>
               <a:t>Analyst consensus 2026</a:t>
             </a:r>
@@ -6799,9 +7152,9 @@
                 <a:solidFill>
                   <a:srgbClr val="B84A2F"/>
                 </a:solidFill>
-                <a:latin typeface="VVDS Fifties" pitchFamily="34" charset="0"/>
-                <a:ea typeface="VVDS Fifties" pitchFamily="34" charset="-122"/>
-                <a:cs typeface="VVDS Fifties" pitchFamily="34" charset="-120"/>
+                <a:latin typeface="AT Aero" pitchFamily="34" charset="0"/>
+                <a:ea typeface="AT Aero" pitchFamily="34" charset="-122"/>
+                <a:cs typeface="AT Aero" pitchFamily="34" charset="-120"/>
               </a:rPr>
               <a:t>PART 1: PROCUREMENT OF SEMICONDUCTORS</a:t>
             </a:r>
@@ -6877,9 +7230,9 @@
                 <a:solidFill>
                   <a:srgbClr val="6B6560"/>
                 </a:solidFill>
-                <a:latin typeface="VVDS Fifties" pitchFamily="34" charset="0"/>
-                <a:ea typeface="VVDS Fifties" pitchFamily="34" charset="-122"/>
-                <a:cs typeface="VVDS Fifties" pitchFamily="34" charset="-120"/>
+                <a:latin typeface="AT Aero" pitchFamily="34" charset="0"/>
+                <a:ea typeface="AT Aero" pitchFamily="34" charset="-122"/>
+                <a:cs typeface="AT Aero" pitchFamily="34" charset="-120"/>
               </a:rPr>
               <a:t>The 2026 Semiconductor Ecosystem | Slide 03</a:t>
             </a:r>
@@ -6941,9 +7294,9 @@
                 <a:solidFill>
                   <a:srgbClr val="9E7D84"/>
                 </a:solidFill>
-                <a:latin typeface="VVDS Fifties" pitchFamily="34" charset="0"/>
-                <a:ea typeface="VVDS Fifties" pitchFamily="34" charset="-122"/>
-                <a:cs typeface="VVDS Fifties" pitchFamily="34" charset="-120"/>
+                <a:latin typeface="AT Aero" pitchFamily="34" charset="0"/>
+                <a:ea typeface="AT Aero" pitchFamily="34" charset="-122"/>
+                <a:cs typeface="AT Aero" pitchFamily="34" charset="-120"/>
               </a:rPr>
               <a:t>Key Message: Pure JIT is obsolete; the new standard is a hybrid approach that prioritizes resilience for high-value nodes.</a:t>
             </a:r>
@@ -7044,9 +7397,9 @@
                 <a:solidFill>
                   <a:srgbClr val="6B6560"/>
                 </a:solidFill>
-                <a:latin typeface="VVDS Fifties" pitchFamily="34" charset="0"/>
-                <a:ea typeface="VVDS Fifties" pitchFamily="34" charset="-122"/>
-                <a:cs typeface="VVDS Fifties" pitchFamily="34" charset="-120"/>
+                <a:latin typeface="AT Aero" pitchFamily="34" charset="0"/>
+                <a:ea typeface="AT Aero" pitchFamily="34" charset="-122"/>
+                <a:cs typeface="AT Aero" pitchFamily="34" charset="-120"/>
               </a:rPr>
               <a:t>Used for standardized legacy passive elements and commoditized logic chips. Minimizes capital lock-up and inventory holding costs while keeping storage footprint low.</a:t>
             </a:r>
@@ -7147,9 +7500,9 @@
                 <a:solidFill>
                   <a:srgbClr val="6B6560"/>
                 </a:solidFill>
-                <a:latin typeface="VVDS Fifties" pitchFamily="34" charset="0"/>
-                <a:ea typeface="VVDS Fifties" pitchFamily="34" charset="-122"/>
-                <a:cs typeface="VVDS Fifties" pitchFamily="34" charset="-120"/>
+                <a:latin typeface="AT Aero" pitchFamily="34" charset="0"/>
+                <a:ea typeface="AT Aero" pitchFamily="34" charset="-122"/>
+                <a:cs typeface="AT Aero" pitchFamily="34" charset="-120"/>
               </a:rPr>
               <a:t>Maintaining 3 to 6 months of safety stock for sole-sourced, high-margin microcomponents (HBM, custom GPUs) to guarantee manufacturing continuity.</a:t>
             </a:r>
@@ -7218,9 +7571,9 @@
                 <a:solidFill>
                   <a:srgbClr val="B84A2F"/>
                 </a:solidFill>
-                <a:latin typeface="VVDS Fifties" pitchFamily="34" charset="0"/>
-                <a:ea typeface="VVDS Fifties" pitchFamily="34" charset="-122"/>
-                <a:cs typeface="VVDS Fifties" pitchFamily="34" charset="-120"/>
+                <a:latin typeface="AT Aero" pitchFamily="34" charset="0"/>
+                <a:ea typeface="AT Aero" pitchFamily="34" charset="-122"/>
+                <a:cs typeface="AT Aero" pitchFamily="34" charset="-120"/>
               </a:rPr>
               <a:t>PART 1: PROCUREMENT OF SEMICONDUCTORS</a:t>
             </a:r>
@@ -7296,9 +7649,9 @@
                 <a:solidFill>
                   <a:srgbClr val="6B6560"/>
                 </a:solidFill>
-                <a:latin typeface="VVDS Fifties" pitchFamily="34" charset="0"/>
-                <a:ea typeface="VVDS Fifties" pitchFamily="34" charset="-122"/>
-                <a:cs typeface="VVDS Fifties" pitchFamily="34" charset="-120"/>
+                <a:latin typeface="AT Aero" pitchFamily="34" charset="0"/>
+                <a:ea typeface="AT Aero" pitchFamily="34" charset="-122"/>
+                <a:cs typeface="AT Aero" pitchFamily="34" charset="-120"/>
               </a:rPr>
               <a:t>The 2026 Semiconductor Ecosystem | Slide 04</a:t>
             </a:r>
@@ -7360,9 +7713,9 @@
                 <a:solidFill>
                   <a:srgbClr val="768C7C"/>
                 </a:solidFill>
-                <a:latin typeface="VVDS Fifties" pitchFamily="34" charset="0"/>
-                <a:ea typeface="VVDS Fifties" pitchFamily="34" charset="-122"/>
-                <a:cs typeface="VVDS Fifties" pitchFamily="34" charset="-120"/>
+                <a:latin typeface="AT Aero" pitchFamily="34" charset="0"/>
+                <a:ea typeface="AT Aero" pitchFamily="34" charset="-122"/>
+                <a:cs typeface="AT Aero" pitchFamily="34" charset="-120"/>
               </a:rPr>
               <a:t>Key Message: Data opacity and reactive risk management are the primary enemies of a resilient procurement strategy.</a:t>
             </a:r>
@@ -7400,9 +7753,9 @@
                 <a:solidFill>
                   <a:srgbClr val="6B6560"/>
                 </a:solidFill>
-                <a:latin typeface="VVDS Fifties" pitchFamily="34" charset="0"/>
-                <a:ea typeface="VVDS Fifties" pitchFamily="34" charset="-122"/>
-                <a:cs typeface="VVDS Fifties" pitchFamily="34" charset="-120"/>
+                <a:latin typeface="AT Aero" pitchFamily="34" charset="0"/>
+                <a:ea typeface="AT Aero" pitchFamily="34" charset="-122"/>
+                <a:cs typeface="AT Aero" pitchFamily="34" charset="-120"/>
               </a:rPr>
               <a:t>- Category Management Sourcing: Slicing procurement into precise technology nodes (Leading-edge sub-7nm vs Legacy nodes).</a:t>
             </a:r>
@@ -7425,9 +7778,9 @@
                 <a:solidFill>
                   <a:srgbClr val="6B6560"/>
                 </a:solidFill>
-                <a:latin typeface="VVDS Fifties" pitchFamily="34" charset="0"/>
-                <a:ea typeface="VVDS Fifties" pitchFamily="34" charset="-122"/>
-                <a:cs typeface="VVDS Fifties" pitchFamily="34" charset="-120"/>
+                <a:latin typeface="AT Aero" pitchFamily="34" charset="0"/>
+                <a:ea typeface="AT Aero" pitchFamily="34" charset="-122"/>
+                <a:cs typeface="AT Aero" pitchFamily="34" charset="-120"/>
               </a:rPr>
               <a:t>- Leading-edge Sourcing: Focuses on deep co-development partnerships, engineering collaboration, and long-term volume commitments.</a:t>
             </a:r>
@@ -7450,9 +7803,9 @@
                 <a:solidFill>
                   <a:srgbClr val="6B6560"/>
                 </a:solidFill>
-                <a:latin typeface="VVDS Fifties" pitchFamily="34" charset="0"/>
-                <a:ea typeface="VVDS Fifties" pitchFamily="34" charset="-122"/>
-                <a:cs typeface="VVDS Fifties" pitchFamily="34" charset="-120"/>
+                <a:latin typeface="AT Aero" pitchFamily="34" charset="0"/>
+                <a:ea typeface="AT Aero" pitchFamily="34" charset="-122"/>
+                <a:cs typeface="AT Aero" pitchFamily="34" charset="-120"/>
               </a:rPr>
               <a:t>- Legacy Sourcing: Emphasizes multi-sourcing, second-sourcing qualification, and legacy lifecycle management to offset obsolescence.</a:t>
             </a:r>
@@ -7514,9 +7867,9 @@
                 <a:solidFill>
                   <a:srgbClr val="6B6560"/>
                 </a:solidFill>
-                <a:latin typeface="VVDS Fifties" pitchFamily="34" charset="0"/>
-                <a:ea typeface="VVDS Fifties" pitchFamily="34" charset="-122"/>
-                <a:cs typeface="VVDS Fifties" pitchFamily="34" charset="-120"/>
+                <a:latin typeface="AT Aero" pitchFamily="34" charset="0"/>
+                <a:ea typeface="AT Aero" pitchFamily="34" charset="-122"/>
+                <a:cs typeface="AT Aero" pitchFamily="34" charset="-120"/>
               </a:rPr>
               <a:t>Leading-Edge Nodes</a:t>
             </a:r>
@@ -7537,9 +7890,9 @@
                 <a:solidFill>
                   <a:srgbClr val="6B6560"/>
                 </a:solidFill>
-                <a:latin typeface="VVDS Fifties" pitchFamily="34" charset="0"/>
-                <a:ea typeface="VVDS Fifties" pitchFamily="34" charset="-122"/>
-                <a:cs typeface="VVDS Fifties" pitchFamily="34" charset="-120"/>
+                <a:latin typeface="AT Aero" pitchFamily="34" charset="0"/>
+                <a:ea typeface="AT Aero" pitchFamily="34" charset="-122"/>
+                <a:cs typeface="AT Aero" pitchFamily="34" charset="-120"/>
               </a:rPr>
               <a:t>Focus: Deep alliances, R&amp;D partnerships, capacity reservations.</a:t>
             </a:r>
@@ -7601,9 +7954,9 @@
                 <a:solidFill>
                   <a:srgbClr val="6B6560"/>
                 </a:solidFill>
-                <a:latin typeface="VVDS Fifties" pitchFamily="34" charset="0"/>
-                <a:ea typeface="VVDS Fifties" pitchFamily="34" charset="-122"/>
-                <a:cs typeface="VVDS Fifties" pitchFamily="34" charset="-120"/>
+                <a:latin typeface="AT Aero" pitchFamily="34" charset="0"/>
+                <a:ea typeface="AT Aero" pitchFamily="34" charset="-122"/>
+                <a:cs typeface="AT Aero" pitchFamily="34" charset="-120"/>
               </a:rPr>
               <a:t>Legacy Nodes</a:t>
             </a:r>
@@ -7624,9 +7977,9 @@
                 <a:solidFill>
                   <a:srgbClr val="6B6560"/>
                 </a:solidFill>
-                <a:latin typeface="VVDS Fifties" pitchFamily="34" charset="0"/>
-                <a:ea typeface="VVDS Fifties" pitchFamily="34" charset="-122"/>
-                <a:cs typeface="VVDS Fifties" pitchFamily="34" charset="-120"/>
+                <a:latin typeface="AT Aero" pitchFamily="34" charset="0"/>
+                <a:ea typeface="AT Aero" pitchFamily="34" charset="-122"/>
+                <a:cs typeface="AT Aero" pitchFamily="34" charset="-120"/>
               </a:rPr>
               <a:t>Focus: Multi-sourcing, distributor networks, life-cycle tracking.</a:t>
             </a:r>
@@ -7695,9 +8048,9 @@
                 <a:solidFill>
                   <a:srgbClr val="B84A2F"/>
                 </a:solidFill>
-                <a:latin typeface="VVDS Fifties" pitchFamily="34" charset="0"/>
-                <a:ea typeface="VVDS Fifties" pitchFamily="34" charset="-122"/>
-                <a:cs typeface="VVDS Fifties" pitchFamily="34" charset="-120"/>
+                <a:latin typeface="AT Aero" pitchFamily="34" charset="0"/>
+                <a:ea typeface="AT Aero" pitchFamily="34" charset="-122"/>
+                <a:cs typeface="AT Aero" pitchFamily="34" charset="-120"/>
               </a:rPr>
               <a:t>PART 1: PROCUREMENT OF SEMICONDUCTORS</a:t>
             </a:r>
@@ -7773,9 +8126,9 @@
                 <a:solidFill>
                   <a:srgbClr val="6B6560"/>
                 </a:solidFill>
-                <a:latin typeface="VVDS Fifties" pitchFamily="34" charset="0"/>
-                <a:ea typeface="VVDS Fifties" pitchFamily="34" charset="-122"/>
-                <a:cs typeface="VVDS Fifties" pitchFamily="34" charset="-120"/>
+                <a:latin typeface="AT Aero" pitchFamily="34" charset="0"/>
+                <a:ea typeface="AT Aero" pitchFamily="34" charset="-122"/>
+                <a:cs typeface="AT Aero" pitchFamily="34" charset="-120"/>
               </a:rPr>
               <a:t>The 2026 Semiconductor Ecosystem | Slide 05</a:t>
             </a:r>
@@ -7837,9 +8190,9 @@
                 <a:solidFill>
                   <a:srgbClr val="B84A2F"/>
                 </a:solidFill>
-                <a:latin typeface="VVDS Fifties" pitchFamily="34" charset="0"/>
-                <a:ea typeface="VVDS Fifties" pitchFamily="34" charset="-122"/>
-                <a:cs typeface="VVDS Fifties" pitchFamily="34" charset="-120"/>
+                <a:latin typeface="AT Aero" pitchFamily="34" charset="0"/>
+                <a:ea typeface="AT Aero" pitchFamily="34" charset="-122"/>
+                <a:cs typeface="AT Aero" pitchFamily="34" charset="-120"/>
               </a:rPr>
               <a:t>Key Message: AI-driven "Business Intelligence Cockpits" are essential for predicting shortages 6-12 months in advance.</a:t>
             </a:r>
@@ -7940,9 +8293,9 @@
                 <a:solidFill>
                   <a:srgbClr val="6B6560"/>
                 </a:solidFill>
-                <a:latin typeface="VVDS Fifties" pitchFamily="34" charset="0"/>
-                <a:ea typeface="VVDS Fifties" pitchFamily="34" charset="-122"/>
-                <a:cs typeface="VVDS Fifties" pitchFamily="34" charset="-120"/>
+                <a:latin typeface="AT Aero" pitchFamily="34" charset="0"/>
+                <a:ea typeface="AT Aero" pitchFamily="34" charset="-122"/>
+                <a:cs typeface="AT Aero" pitchFamily="34" charset="-120"/>
               </a:rPr>
               <a:t>Securing fab slots requires upfront reservation fees and take-or-pay clauses in Long-Term Agreements (LTAs) to lock down volume.</a:t>
             </a:r>
@@ -8043,9 +8396,9 @@
                 <a:solidFill>
                   <a:srgbClr val="6B6560"/>
                 </a:solidFill>
-                <a:latin typeface="VVDS Fifties" pitchFamily="34" charset="0"/>
-                <a:ea typeface="VVDS Fifties" pitchFamily="34" charset="-122"/>
-                <a:cs typeface="VVDS Fifties" pitchFamily="34" charset="-120"/>
+                <a:latin typeface="AT Aero" pitchFamily="34" charset="0"/>
+                <a:ea typeface="AT Aero" pitchFamily="34" charset="-122"/>
+                <a:cs typeface="AT Aero" pitchFamily="34" charset="-120"/>
               </a:rPr>
               <a:t>Decoupling supply links from high-risk locations, redirecting procurement to allied geopolitical nodes with guaranteed supply lines.</a:t>
             </a:r>
@@ -8107,9 +8460,9 @@
                 <a:solidFill>
                   <a:srgbClr val="6B6560"/>
                 </a:solidFill>
-                <a:latin typeface="VVDS Fifties" pitchFamily="34" charset="0"/>
-                <a:ea typeface="VVDS Fifties" pitchFamily="34" charset="-122"/>
-                <a:cs typeface="VVDS Fifties" pitchFamily="34" charset="-120"/>
+                <a:latin typeface="AT Aero" pitchFamily="34" charset="0"/>
+                <a:ea typeface="AT Aero" pitchFamily="34" charset="-122"/>
+                <a:cs typeface="AT Aero" pitchFamily="34" charset="-120"/>
               </a:rPr>
               <a:t>AI integration automatically tracks tier-2 chemical and substrate suppliers to detect factory closures or export blocks before they ripple into final fab allocations.</a:t>
             </a:r>
@@ -8178,9 +8531,9 @@
                 <a:solidFill>
                   <a:srgbClr val="B84A2F"/>
                 </a:solidFill>
-                <a:latin typeface="VVDS Fifties" pitchFamily="34" charset="0"/>
-                <a:ea typeface="VVDS Fifties" pitchFamily="34" charset="-122"/>
-                <a:cs typeface="VVDS Fifties" pitchFamily="34" charset="-120"/>
+                <a:latin typeface="AT Aero" pitchFamily="34" charset="0"/>
+                <a:ea typeface="AT Aero" pitchFamily="34" charset="-122"/>
+                <a:cs typeface="AT Aero" pitchFamily="34" charset="-120"/>
               </a:rPr>
               <a:t>PART 2: THE GLOBAL SUPPLY CHAIN OF SEMICONDUCTORS</a:t>
             </a:r>
@@ -8256,9 +8609,9 @@
                 <a:solidFill>
                   <a:srgbClr val="6B6560"/>
                 </a:solidFill>
-                <a:latin typeface="VVDS Fifties" pitchFamily="34" charset="0"/>
-                <a:ea typeface="VVDS Fifties" pitchFamily="34" charset="-122"/>
-                <a:cs typeface="VVDS Fifties" pitchFamily="34" charset="-120"/>
+                <a:latin typeface="AT Aero" pitchFamily="34" charset="0"/>
+                <a:ea typeface="AT Aero" pitchFamily="34" charset="-122"/>
+                <a:cs typeface="AT Aero" pitchFamily="34" charset="-120"/>
               </a:rPr>
               <a:t>The 2026 Semiconductor Ecosystem | Slide 06</a:t>
             </a:r>
@@ -8320,9 +8673,9 @@
                 <a:solidFill>
                   <a:srgbClr val="B84A2F"/>
                 </a:solidFill>
-                <a:latin typeface="VVDS Fifties" pitchFamily="34" charset="0"/>
-                <a:ea typeface="VVDS Fifties" pitchFamily="34" charset="-122"/>
-                <a:cs typeface="VVDS Fifties" pitchFamily="34" charset="-120"/>
+                <a:latin typeface="AT Aero" pitchFamily="34" charset="0"/>
+                <a:ea typeface="AT Aero" pitchFamily="34" charset="-122"/>
+                <a:cs typeface="AT Aero" pitchFamily="34" charset="-120"/>
               </a:rPr>
               <a:t>Key Message: A single chip may cross international borders over 70 times, making it the most geographically dispersed value chain in history.</a:t>
             </a:r>
@@ -8359,9 +8712,9 @@
                 <a:solidFill>
                   <a:srgbClr val="768C7C"/>
                 </a:solidFill>
-                <a:latin typeface="VVDS Fifties" pitchFamily="34" charset="0"/>
-                <a:ea typeface="VVDS Fifties" pitchFamily="34" charset="-122"/>
-                <a:cs typeface="VVDS Fifties" pitchFamily="34" charset="-120"/>
+                <a:latin typeface="AT Aero" pitchFamily="34" charset="0"/>
+                <a:ea typeface="AT Aero" pitchFamily="34" charset="-122"/>
+                <a:cs typeface="AT Aero" pitchFamily="34" charset="-120"/>
               </a:rPr>
               <a:t>THE SILICON JOURNEY</a:t>
             </a:r>
@@ -8462,9 +8815,9 @@
                 <a:solidFill>
                   <a:srgbClr val="1A1714"/>
                 </a:solidFill>
-                <a:latin typeface="VVDS Fifties" pitchFamily="34" charset="0"/>
-                <a:ea typeface="VVDS Fifties" pitchFamily="34" charset="-122"/>
-                <a:cs typeface="VVDS Fifties" pitchFamily="34" charset="-120"/>
+                <a:latin typeface="AT Aero" pitchFamily="34" charset="0"/>
+                <a:ea typeface="AT Aero" pitchFamily="34" charset="-122"/>
+                <a:cs typeface="AT Aero" pitchFamily="34" charset="-120"/>
               </a:rPr>
               <a:t>US Design</a:t>
             </a:r>
@@ -8501,9 +8854,9 @@
                 <a:solidFill>
                   <a:srgbClr val="6B6560"/>
                 </a:solidFill>
-                <a:latin typeface="VVDS Fifties" pitchFamily="34" charset="0"/>
-                <a:ea typeface="VVDS Fifties" pitchFamily="34" charset="-122"/>
-                <a:cs typeface="VVDS Fifties" pitchFamily="34" charset="-120"/>
+                <a:latin typeface="AT Aero" pitchFamily="34" charset="0"/>
+                <a:ea typeface="AT Aero" pitchFamily="34" charset="-122"/>
+                <a:cs typeface="AT Aero" pitchFamily="34" charset="-120"/>
               </a:rPr>
               <a:t>Design &amp; EDA Tools</a:t>
             </a:r>
@@ -8604,9 +8957,9 @@
                 <a:solidFill>
                   <a:srgbClr val="1A1714"/>
                 </a:solidFill>
-                <a:latin typeface="VVDS Fifties" pitchFamily="34" charset="0"/>
-                <a:ea typeface="VVDS Fifties" pitchFamily="34" charset="-122"/>
-                <a:cs typeface="VVDS Fifties" pitchFamily="34" charset="-120"/>
+                <a:latin typeface="AT Aero" pitchFamily="34" charset="0"/>
+                <a:ea typeface="AT Aero" pitchFamily="34" charset="-122"/>
+                <a:cs typeface="AT Aero" pitchFamily="34" charset="-120"/>
               </a:rPr>
               <a:t>Dutch SME</a:t>
             </a:r>
@@ -8643,9 +8996,9 @@
                 <a:solidFill>
                   <a:srgbClr val="6B6560"/>
                 </a:solidFill>
-                <a:latin typeface="VVDS Fifties" pitchFamily="34" charset="0"/>
-                <a:ea typeface="VVDS Fifties" pitchFamily="34" charset="-122"/>
-                <a:cs typeface="VVDS Fifties" pitchFamily="34" charset="-120"/>
+                <a:latin typeface="AT Aero" pitchFamily="34" charset="0"/>
+                <a:ea typeface="AT Aero" pitchFamily="34" charset="-122"/>
+                <a:cs typeface="AT Aero" pitchFamily="34" charset="-120"/>
               </a:rPr>
               <a:t>ASML EUV Optics</a:t>
             </a:r>
@@ -8746,9 +9099,9 @@
                 <a:solidFill>
                   <a:srgbClr val="1A1714"/>
                 </a:solidFill>
-                <a:latin typeface="VVDS Fifties" pitchFamily="34" charset="0"/>
-                <a:ea typeface="VVDS Fifties" pitchFamily="34" charset="-122"/>
-                <a:cs typeface="VVDS Fifties" pitchFamily="34" charset="-120"/>
+                <a:latin typeface="AT Aero" pitchFamily="34" charset="0"/>
+                <a:ea typeface="AT Aero" pitchFamily="34" charset="-122"/>
+                <a:cs typeface="AT Aero" pitchFamily="34" charset="-120"/>
               </a:rPr>
               <a:t>Taiwan Fab</a:t>
             </a:r>
@@ -8785,9 +9138,9 @@
                 <a:solidFill>
                   <a:srgbClr val="6B6560"/>
                 </a:solidFill>
-                <a:latin typeface="VVDS Fifties" pitchFamily="34" charset="0"/>
-                <a:ea typeface="VVDS Fifties" pitchFamily="34" charset="-122"/>
-                <a:cs typeface="VVDS Fifties" pitchFamily="34" charset="-120"/>
+                <a:latin typeface="AT Aero" pitchFamily="34" charset="0"/>
+                <a:ea typeface="AT Aero" pitchFamily="34" charset="-122"/>
+                <a:cs typeface="AT Aero" pitchFamily="34" charset="-120"/>
               </a:rPr>
               <a:t>TSMC Printing</a:t>
             </a:r>
@@ -8888,9 +9241,9 @@
                 <a:solidFill>
                   <a:srgbClr val="1A1714"/>
                 </a:solidFill>
-                <a:latin typeface="VVDS Fifties" pitchFamily="34" charset="0"/>
-                <a:ea typeface="VVDS Fifties" pitchFamily="34" charset="-122"/>
-                <a:cs typeface="VVDS Fifties" pitchFamily="34" charset="-120"/>
+                <a:latin typeface="AT Aero" pitchFamily="34" charset="0"/>
+                <a:ea typeface="AT Aero" pitchFamily="34" charset="-122"/>
+                <a:cs typeface="AT Aero" pitchFamily="34" charset="-120"/>
               </a:rPr>
               <a:t>Japan Material</a:t>
             </a:r>
@@ -8927,9 +9280,9 @@
                 <a:solidFill>
                   <a:srgbClr val="6B6560"/>
                 </a:solidFill>
-                <a:latin typeface="VVDS Fifties" pitchFamily="34" charset="0"/>
-                <a:ea typeface="VVDS Fifties" pitchFamily="34" charset="-122"/>
-                <a:cs typeface="VVDS Fifties" pitchFamily="34" charset="-120"/>
+                <a:latin typeface="AT Aero" pitchFamily="34" charset="0"/>
+                <a:ea typeface="AT Aero" pitchFamily="34" charset="-122"/>
+                <a:cs typeface="AT Aero" pitchFamily="34" charset="-120"/>
               </a:rPr>
               <a:t>Wafers &amp; Photoresist</a:t>
             </a:r>
@@ -9030,9 +9383,9 @@
                 <a:solidFill>
                   <a:srgbClr val="1A1714"/>
                 </a:solidFill>
-                <a:latin typeface="VVDS Fifties" pitchFamily="34" charset="0"/>
-                <a:ea typeface="VVDS Fifties" pitchFamily="34" charset="-122"/>
-                <a:cs typeface="VVDS Fifties" pitchFamily="34" charset="-120"/>
+                <a:latin typeface="AT Aero" pitchFamily="34" charset="0"/>
+                <a:ea typeface="AT Aero" pitchFamily="34" charset="-122"/>
+                <a:cs typeface="AT Aero" pitchFamily="34" charset="-120"/>
               </a:rPr>
               <a:t>SE Asia Pack</a:t>
             </a:r>
@@ -9069,9 +9422,9 @@
                 <a:solidFill>
                   <a:srgbClr val="6B6560"/>
                 </a:solidFill>
-                <a:latin typeface="VVDS Fifties" pitchFamily="34" charset="0"/>
-                <a:ea typeface="VVDS Fifties" pitchFamily="34" charset="-122"/>
-                <a:cs typeface="VVDS Fifties" pitchFamily="34" charset="-120"/>
+                <a:latin typeface="AT Aero" pitchFamily="34" charset="0"/>
+                <a:ea typeface="AT Aero" pitchFamily="34" charset="-122"/>
+                <a:cs typeface="AT Aero" pitchFamily="34" charset="-120"/>
               </a:rPr>
               <a:t>OSAT Assembly</a:t>
             </a:r>
@@ -9140,9 +9493,9 @@
                 <a:solidFill>
                   <a:srgbClr val="B84A2F"/>
                 </a:solidFill>
-                <a:latin typeface="VVDS Fifties" pitchFamily="34" charset="0"/>
-                <a:ea typeface="VVDS Fifties" pitchFamily="34" charset="-122"/>
-                <a:cs typeface="VVDS Fifties" pitchFamily="34" charset="-120"/>
+                <a:latin typeface="AT Aero" pitchFamily="34" charset="0"/>
+                <a:ea typeface="AT Aero" pitchFamily="34" charset="-122"/>
+                <a:cs typeface="AT Aero" pitchFamily="34" charset="-120"/>
               </a:rPr>
               <a:t>PART 2: THE GLOBAL SUPPLY CHAIN OF SEMICONDUCTORS</a:t>
             </a:r>
@@ -9218,9 +9571,9 @@
                 <a:solidFill>
                   <a:srgbClr val="6B6560"/>
                 </a:solidFill>
-                <a:latin typeface="VVDS Fifties" pitchFamily="34" charset="0"/>
-                <a:ea typeface="VVDS Fifties" pitchFamily="34" charset="-122"/>
-                <a:cs typeface="VVDS Fifties" pitchFamily="34" charset="-120"/>
+                <a:latin typeface="AT Aero" pitchFamily="34" charset="0"/>
+                <a:ea typeface="AT Aero" pitchFamily="34" charset="-122"/>
+                <a:cs typeface="AT Aero" pitchFamily="34" charset="-120"/>
               </a:rPr>
               <a:t>The 2026 Semiconductor Ecosystem | Slide 07</a:t>
             </a:r>
@@ -9282,9 +9635,9 @@
                 <a:solidFill>
                   <a:srgbClr val="9E7D84"/>
                 </a:solidFill>
-                <a:latin typeface="VVDS Fifties" pitchFamily="34" charset="0"/>
-                <a:ea typeface="VVDS Fifties" pitchFamily="34" charset="-122"/>
-                <a:cs typeface="VVDS Fifties" pitchFamily="34" charset="-120"/>
+                <a:latin typeface="AT Aero" pitchFamily="34" charset="0"/>
+                <a:ea typeface="AT Aero" pitchFamily="34" charset="-122"/>
+                <a:cs typeface="AT Aero" pitchFamily="34" charset="-120"/>
               </a:rPr>
               <a:t>Key Message: Value is highly concentrated in specialized clusters: U.S. (Design), Europe (Equipment), and East Asia (Manufacturing).</a:t>
             </a:r>
@@ -9322,9 +9675,9 @@
                 <a:solidFill>
                   <a:srgbClr val="6B6560"/>
                 </a:solidFill>
-                <a:latin typeface="VVDS Fifties" pitchFamily="34" charset="0"/>
-                <a:ea typeface="VVDS Fifties" pitchFamily="34" charset="-122"/>
-                <a:cs typeface="VVDS Fifties" pitchFamily="34" charset="-120"/>
+                <a:latin typeface="AT Aero" pitchFamily="34" charset="0"/>
+                <a:ea typeface="AT Aero" pitchFamily="34" charset="-122"/>
+                <a:cs typeface="AT Aero" pitchFamily="34" charset="-120"/>
               </a:rPr>
               <a:t>- Design &amp; EDA (United States): Dominance in core processor blueprints and layout compiler systems (NVIDIA, Apple, Qualcomm).</a:t>
             </a:r>
@@ -9347,9 +9700,9 @@
                 <a:solidFill>
                   <a:srgbClr val="6B6560"/>
                 </a:solidFill>
-                <a:latin typeface="VVDS Fifties" pitchFamily="34" charset="0"/>
-                <a:ea typeface="VVDS Fifties" pitchFamily="34" charset="-122"/>
-                <a:cs typeface="VVDS Fifties" pitchFamily="34" charset="-120"/>
+                <a:latin typeface="AT Aero" pitchFamily="34" charset="0"/>
+                <a:ea typeface="AT Aero" pitchFamily="34" charset="-122"/>
+                <a:cs typeface="AT Aero" pitchFamily="34" charset="-120"/>
               </a:rPr>
               <a:t>- SME Equipment (Europe): Monopoly on Extreme Ultraviolet tools (ASML) required to etch sub-7nm circuit nodes.</a:t>
             </a:r>
@@ -9372,9 +9725,9 @@
                 <a:solidFill>
                   <a:srgbClr val="6B6560"/>
                 </a:solidFill>
-                <a:latin typeface="VVDS Fifties" pitchFamily="34" charset="0"/>
-                <a:ea typeface="VVDS Fifties" pitchFamily="34" charset="-122"/>
-                <a:cs typeface="VVDS Fifties" pitchFamily="34" charset="-120"/>
+                <a:latin typeface="AT Aero" pitchFamily="34" charset="0"/>
+                <a:ea typeface="AT Aero" pitchFamily="34" charset="-122"/>
+                <a:cs typeface="AT Aero" pitchFamily="34" charset="-120"/>
               </a:rPr>
               <a:t>- Wafer Fabrication (East Asia): TSMC (Taiwan) and Samsung (Korea) form the production base for global advanced nodes.</a:t>
             </a:r>
@@ -9436,9 +9789,9 @@
                 <a:solidFill>
                   <a:srgbClr val="6B6560"/>
                 </a:solidFill>
-                <a:latin typeface="VVDS Fifties" pitchFamily="34" charset="0"/>
-                <a:ea typeface="VVDS Fifties" pitchFamily="34" charset="-122"/>
-                <a:cs typeface="VVDS Fifties" pitchFamily="34" charset="-120"/>
+                <a:latin typeface="AT Aero" pitchFamily="34" charset="0"/>
+                <a:ea typeface="AT Aero" pitchFamily="34" charset="-122"/>
+                <a:cs typeface="AT Aero" pitchFamily="34" charset="-120"/>
               </a:rPr>
               <a:t>USA: Design IP</a:t>
             </a:r>
@@ -9459,9 +9812,9 @@
                 <a:solidFill>
                   <a:srgbClr val="6B6560"/>
                 </a:solidFill>
-                <a:latin typeface="VVDS Fifties" pitchFamily="34" charset="0"/>
-                <a:ea typeface="VVDS Fifties" pitchFamily="34" charset="-122"/>
-                <a:cs typeface="VVDS Fifties" pitchFamily="34" charset="-120"/>
+                <a:latin typeface="AT Aero" pitchFamily="34" charset="0"/>
+                <a:ea typeface="AT Aero" pitchFamily="34" charset="-122"/>
+                <a:cs typeface="AT Aero" pitchFamily="34" charset="-120"/>
               </a:rPr>
               <a:t>80%+ market share in advanced EDA software tools.</a:t>
             </a:r>
@@ -9523,9 +9876,9 @@
                 <a:solidFill>
                   <a:srgbClr val="6B6560"/>
                 </a:solidFill>
-                <a:latin typeface="VVDS Fifties" pitchFamily="34" charset="0"/>
-                <a:ea typeface="VVDS Fifties" pitchFamily="34" charset="-122"/>
-                <a:cs typeface="VVDS Fifties" pitchFamily="34" charset="-120"/>
+                <a:latin typeface="AT Aero" pitchFamily="34" charset="0"/>
+                <a:ea typeface="AT Aero" pitchFamily="34" charset="-122"/>
+                <a:cs typeface="AT Aero" pitchFamily="34" charset="-120"/>
               </a:rPr>
               <a:t>ASML (EU): Lithography</a:t>
             </a:r>
@@ -9546,9 +9899,9 @@
                 <a:solidFill>
                   <a:srgbClr val="6B6560"/>
                 </a:solidFill>
-                <a:latin typeface="VVDS Fifties" pitchFamily="34" charset="0"/>
-                <a:ea typeface="VVDS Fifties" pitchFamily="34" charset="-122"/>
-                <a:cs typeface="VVDS Fifties" pitchFamily="34" charset="-120"/>
+                <a:latin typeface="AT Aero" pitchFamily="34" charset="0"/>
+                <a:ea typeface="AT Aero" pitchFamily="34" charset="-122"/>
+                <a:cs typeface="AT Aero" pitchFamily="34" charset="-120"/>
               </a:rPr>
               <a:t>100% monopsony on EUV printing technology.</a:t>
             </a:r>
@@ -9617,9 +9970,9 @@
                 <a:solidFill>
                   <a:srgbClr val="B84A2F"/>
                 </a:solidFill>
-                <a:latin typeface="VVDS Fifties" pitchFamily="34" charset="0"/>
-                <a:ea typeface="VVDS Fifties" pitchFamily="34" charset="-122"/>
-                <a:cs typeface="VVDS Fifties" pitchFamily="34" charset="-120"/>
+                <a:latin typeface="AT Aero" pitchFamily="34" charset="0"/>
+                <a:ea typeface="AT Aero" pitchFamily="34" charset="-122"/>
+                <a:cs typeface="AT Aero" pitchFamily="34" charset="-120"/>
               </a:rPr>
               <a:t>PART 2: THE GLOBAL SUPPLY CHAIN OF SEMICONDUCTORS</a:t>
             </a:r>
@@ -9695,9 +10048,9 @@
                 <a:solidFill>
                   <a:srgbClr val="6B6560"/>
                 </a:solidFill>
-                <a:latin typeface="VVDS Fifties" pitchFamily="34" charset="0"/>
-                <a:ea typeface="VVDS Fifties" pitchFamily="34" charset="-122"/>
-                <a:cs typeface="VVDS Fifties" pitchFamily="34" charset="-120"/>
+                <a:latin typeface="AT Aero" pitchFamily="34" charset="0"/>
+                <a:ea typeface="AT Aero" pitchFamily="34" charset="-122"/>
+                <a:cs typeface="AT Aero" pitchFamily="34" charset="-120"/>
               </a:rPr>
               <a:t>The 2026 Semiconductor Ecosystem | Slide 08</a:t>
             </a:r>
@@ -9759,9 +10112,9 @@
                 <a:solidFill>
                   <a:srgbClr val="768C7C"/>
                 </a:solidFill>
-                <a:latin typeface="VVDS Fifties" pitchFamily="34" charset="0"/>
-                <a:ea typeface="VVDS Fifties" pitchFamily="34" charset="-122"/>
-                <a:cs typeface="VVDS Fifties" pitchFamily="34" charset="-120"/>
+                <a:latin typeface="AT Aero" pitchFamily="34" charset="0"/>
+                <a:ea typeface="AT Aero" pitchFamily="34" charset="-122"/>
+                <a:cs typeface="AT Aero" pitchFamily="34" charset="-120"/>
               </a:rPr>
               <a:t>Key Message: Advanced packaging (CoWoS, 3D Stacking) is the new primary growth limiter for the AI industry.</a:t>
             </a:r>
@@ -9862,9 +10215,9 @@
                 <a:solidFill>
                   <a:srgbClr val="6B6560"/>
                 </a:solidFill>
-                <a:latin typeface="VVDS Fifties" pitchFamily="34" charset="0"/>
-                <a:ea typeface="VVDS Fifties" pitchFamily="34" charset="-122"/>
-                <a:cs typeface="VVDS Fifties" pitchFamily="34" charset="-120"/>
+                <a:latin typeface="AT Aero" pitchFamily="34" charset="0"/>
+                <a:ea typeface="AT Aero" pitchFamily="34" charset="-122"/>
+                <a:cs typeface="AT Aero" pitchFamily="34" charset="-120"/>
               </a:rPr>
               <a:t>The race for the 2nm and 1.4nm nodes continues to demand immense capital investments for wafer fabrication lines.</a:t>
             </a:r>
@@ -9965,9 +10318,9 @@
                 <a:solidFill>
                   <a:srgbClr val="6B6560"/>
                 </a:solidFill>
-                <a:latin typeface="VVDS Fifties" pitchFamily="34" charset="0"/>
-                <a:ea typeface="VVDS Fifties" pitchFamily="34" charset="-122"/>
-                <a:cs typeface="VVDS Fifties" pitchFamily="34" charset="-120"/>
+                <a:latin typeface="AT Aero" pitchFamily="34" charset="0"/>
+                <a:ea typeface="AT Aero" pitchFamily="34" charset="-122"/>
+                <a:cs typeface="AT Aero" pitchFamily="34" charset="-120"/>
               </a:rPr>
               <a:t>Integrating multiple logic dies and High Bandwidth Memory (HBM) via CoWoS interposers is more constrained than wafer printing.</a:t>
             </a:r>
@@ -10029,9 +10382,9 @@
                 <a:solidFill>
                   <a:srgbClr val="6B6560"/>
                 </a:solidFill>
-                <a:latin typeface="VVDS Fifties" pitchFamily="34" charset="0"/>
-                <a:ea typeface="VVDS Fifties" pitchFamily="34" charset="-122"/>
-                <a:cs typeface="VVDS Fifties" pitchFamily="34" charset="-120"/>
+                <a:latin typeface="AT Aero" pitchFamily="34" charset="0"/>
+                <a:ea typeface="AT Aero" pitchFamily="34" charset="-122"/>
+                <a:cs typeface="AT Aero" pitchFamily="34" charset="-120"/>
               </a:rPr>
               <a:t>Logistics bottleneck: Reaching target AI yields depends heavily on advanced back-end capacity, not just front-end print nodes.</a:t>
             </a:r>
@@ -10100,9 +10453,9 @@
                 <a:solidFill>
                   <a:srgbClr val="B84A2F"/>
                 </a:solidFill>
-                <a:latin typeface="VVDS Fifties" pitchFamily="34" charset="0"/>
-                <a:ea typeface="VVDS Fifties" pitchFamily="34" charset="-122"/>
-                <a:cs typeface="VVDS Fifties" pitchFamily="34" charset="-120"/>
+                <a:latin typeface="AT Aero" pitchFamily="34" charset="0"/>
+                <a:ea typeface="AT Aero" pitchFamily="34" charset="-122"/>
+                <a:cs typeface="AT Aero" pitchFamily="34" charset="-120"/>
               </a:rPr>
               <a:t>PART 2: THE GLOBAL SUPPLY CHAIN OF SEMICONDUCTORS</a:t>
             </a:r>
@@ -10178,9 +10531,9 @@
                 <a:solidFill>
                   <a:srgbClr val="6B6560"/>
                 </a:solidFill>
-                <a:latin typeface="VVDS Fifties" pitchFamily="34" charset="0"/>
-                <a:ea typeface="VVDS Fifties" pitchFamily="34" charset="-122"/>
-                <a:cs typeface="VVDS Fifties" pitchFamily="34" charset="-120"/>
+                <a:latin typeface="AT Aero" pitchFamily="34" charset="0"/>
+                <a:ea typeface="AT Aero" pitchFamily="34" charset="-122"/>
+                <a:cs typeface="AT Aero" pitchFamily="34" charset="-120"/>
               </a:rPr>
               <a:t>The 2026 Semiconductor Ecosystem | Slide 09</a:t>
             </a:r>
@@ -10242,9 +10595,9 @@
                 <a:solidFill>
                   <a:srgbClr val="B84A2F"/>
                 </a:solidFill>
-                <a:latin typeface="VVDS Fifties" pitchFamily="34" charset="0"/>
-                <a:ea typeface="VVDS Fifties" pitchFamily="34" charset="-122"/>
-                <a:cs typeface="VVDS Fifties" pitchFamily="34" charset="-120"/>
+                <a:latin typeface="AT Aero" pitchFamily="34" charset="0"/>
+                <a:ea typeface="AT Aero" pitchFamily="34" charset="-122"/>
+                <a:cs typeface="AT Aero" pitchFamily="34" charset="-120"/>
               </a:rPr>
               <a:t>Key Message: Geopolitics has created a "Multi-Polar" silicon world, where export controls and subsidies drive regionalization.</a:t>
             </a:r>
@@ -10282,9 +10635,9 @@
                 <a:solidFill>
                   <a:srgbClr val="6B6560"/>
                 </a:solidFill>
-                <a:latin typeface="VVDS Fifties" pitchFamily="34" charset="0"/>
-                <a:ea typeface="VVDS Fifties" pitchFamily="34" charset="-122"/>
-                <a:cs typeface="VVDS Fifties" pitchFamily="34" charset="-120"/>
+                <a:latin typeface="AT Aero" pitchFamily="34" charset="0"/>
+                <a:ea typeface="AT Aero" pitchFamily="34" charset="-122"/>
+                <a:cs typeface="AT Aero" pitchFamily="34" charset="-120"/>
               </a:rPr>
               <a:t>- The US CHIPS Act ($52B): Funding the domestic establishment of advanced logic fabs to balance East Asian concentration.</a:t>
             </a:r>
@@ -10307,9 +10660,9 @@
                 <a:solidFill>
                   <a:srgbClr val="6B6560"/>
                 </a:solidFill>
-                <a:latin typeface="VVDS Fifties" pitchFamily="34" charset="0"/>
-                <a:ea typeface="VVDS Fifties" pitchFamily="34" charset="-122"/>
-                <a:cs typeface="VVDS Fifties" pitchFamily="34" charset="-120"/>
+                <a:latin typeface="AT Aero" pitchFamily="34" charset="0"/>
+                <a:ea typeface="AT Aero" pitchFamily="34" charset="-122"/>
+                <a:cs typeface="AT Aero" pitchFamily="34" charset="-120"/>
               </a:rPr>
               <a:t>- Europe &amp; China Reshoring: Multi-billion dollar state-supported programs targeting semiconductor in-sourcing.</a:t>
             </a:r>
@@ -10332,9 +10685,9 @@
                 <a:solidFill>
                   <a:srgbClr val="6B6560"/>
                 </a:solidFill>
-                <a:latin typeface="VVDS Fifties" pitchFamily="34" charset="0"/>
-                <a:ea typeface="VVDS Fifties" pitchFamily="34" charset="-122"/>
-                <a:cs typeface="VVDS Fifties" pitchFamily="34" charset="-120"/>
+                <a:latin typeface="AT Aero" pitchFamily="34" charset="0"/>
+                <a:ea typeface="AT Aero" pitchFamily="34" charset="-122"/>
+                <a:cs typeface="AT Aero" pitchFamily="34" charset="-120"/>
               </a:rPr>
               <a:t>- Material Chokepoints: Strict export controls placed on critical trace materials like Gallium and Germanium.</a:t>
             </a:r>
@@ -10396,9 +10749,9 @@
                 <a:solidFill>
                   <a:srgbClr val="B84A2F"/>
                 </a:solidFill>
-                <a:latin typeface="VVDS Fifties" pitchFamily="34" charset="0"/>
-                <a:ea typeface="VVDS Fifties" pitchFamily="34" charset="-122"/>
-                <a:cs typeface="VVDS Fifties" pitchFamily="34" charset="-120"/>
+                <a:latin typeface="AT Aero" pitchFamily="34" charset="0"/>
+                <a:ea typeface="AT Aero" pitchFamily="34" charset="-122"/>
+                <a:cs typeface="AT Aero" pitchFamily="34" charset="-120"/>
               </a:rPr>
               <a:t>CRITICAL CHOKEPOINT</a:t>
             </a:r>
@@ -10491,9 +10844,9 @@
                 <a:solidFill>
                   <a:srgbClr val="6B6560"/>
                 </a:solidFill>
-                <a:latin typeface="VVDS Fifties" pitchFamily="34" charset="0"/>
-                <a:ea typeface="VVDS Fifties" pitchFamily="34" charset="-122"/>
-                <a:cs typeface="VVDS Fifties" pitchFamily="34" charset="-120"/>
+                <a:latin typeface="AT Aero" pitchFamily="34" charset="0"/>
+                <a:ea typeface="AT Aero" pitchFamily="34" charset="-122"/>
+                <a:cs typeface="AT Aero" pitchFamily="34" charset="-120"/>
               </a:rPr>
               <a:t>Strict raw material export control levers</a:t>
             </a:r>

</xml_diff>

<commit_message>
Update body font to Bookman ITC Std, set button font to VVDS Fifties, and fix section divider text colors
</commit_message>
<xml_diff>
--- a/output/semiconductor-ecosystem-2026.pptx
+++ b/output/semiconductor-ecosystem-2026.pptx
@@ -2458,9 +2458,9 @@
                 <a:solidFill>
                   <a:srgbClr val="6B6560"/>
                 </a:solidFill>
-                <a:latin typeface="AT Aero" pitchFamily="34" charset="0"/>
-                <a:ea typeface="AT Aero" pitchFamily="34" charset="-122"/>
-                <a:cs typeface="AT Aero" pitchFamily="34" charset="-120"/>
+                <a:latin typeface="Bookman ITC Std" pitchFamily="34" charset="0"/>
+                <a:ea typeface="Bookman ITC Std" pitchFamily="34" charset="-122"/>
+                <a:cs typeface="Bookman ITC Std" pitchFamily="34" charset="-120"/>
               </a:rPr>
               <a:t>A Strategic Briefing on Procurement, Global Supply Chains, and End-User Verticals</a:t>
             </a:r>
@@ -2517,9 +2517,9 @@
                 <a:solidFill>
                   <a:srgbClr val="6B6560"/>
                 </a:solidFill>
-                <a:latin typeface="AT Aero" pitchFamily="34" charset="0"/>
-                <a:ea typeface="AT Aero" pitchFamily="34" charset="-122"/>
-                <a:cs typeface="AT Aero" pitchFamily="34" charset="-120"/>
+                <a:latin typeface="Bookman ITC Std" pitchFamily="34" charset="0"/>
+                <a:ea typeface="Bookman ITC Std" pitchFamily="34" charset="-122"/>
+                <a:cs typeface="Bookman ITC Std" pitchFamily="34" charset="-120"/>
               </a:rPr>
               <a:t>Presenter: Phyoe Sat Paing</a:t>
             </a:r>
@@ -2534,9 +2534,9 @@
                 <a:solidFill>
                   <a:srgbClr val="6B6560"/>
                 </a:solidFill>
-                <a:latin typeface="AT Aero" pitchFamily="34" charset="0"/>
-                <a:ea typeface="AT Aero" pitchFamily="34" charset="-122"/>
-                <a:cs typeface="AT Aero" pitchFamily="34" charset="-120"/>
+                <a:latin typeface="Bookman ITC Std" pitchFamily="34" charset="0"/>
+                <a:ea typeface="Bookman ITC Std" pitchFamily="34" charset="-122"/>
+                <a:cs typeface="Bookman ITC Std" pitchFamily="34" charset="-120"/>
               </a:rPr>
               <a:t>Boardroom Strategic Briefing</a:t>
             </a:r>
@@ -2605,9 +2605,9 @@
                 <a:solidFill>
                   <a:srgbClr val="B84A2F"/>
                 </a:solidFill>
-                <a:latin typeface="AT Aero" pitchFamily="34" charset="0"/>
-                <a:ea typeface="AT Aero" pitchFamily="34" charset="-122"/>
-                <a:cs typeface="AT Aero" pitchFamily="34" charset="-120"/>
+                <a:latin typeface="Bookman ITC Std" pitchFamily="34" charset="0"/>
+                <a:ea typeface="Bookman ITC Std" pitchFamily="34" charset="-122"/>
+                <a:cs typeface="Bookman ITC Std" pitchFamily="34" charset="-120"/>
               </a:rPr>
               <a:t>PART 2: THE GLOBAL SUPPLY CHAIN OF SEMICONDUCTORS</a:t>
             </a:r>
@@ -2683,9 +2683,9 @@
                 <a:solidFill>
                   <a:srgbClr val="6B6560"/>
                 </a:solidFill>
-                <a:latin typeface="AT Aero" pitchFamily="34" charset="0"/>
-                <a:ea typeface="AT Aero" pitchFamily="34" charset="-122"/>
-                <a:cs typeface="AT Aero" pitchFamily="34" charset="-120"/>
+                <a:latin typeface="Bookman ITC Std" pitchFamily="34" charset="0"/>
+                <a:ea typeface="Bookman ITC Std" pitchFamily="34" charset="-122"/>
+                <a:cs typeface="Bookman ITC Std" pitchFamily="34" charset="-120"/>
               </a:rPr>
               <a:t>The 2026 Semiconductor Ecosystem | Slide 10</a:t>
             </a:r>
@@ -2747,9 +2747,9 @@
                 <a:solidFill>
                   <a:srgbClr val="B84A2F"/>
                 </a:solidFill>
-                <a:latin typeface="AT Aero" pitchFamily="34" charset="0"/>
-                <a:ea typeface="AT Aero" pitchFamily="34" charset="-122"/>
-                <a:cs typeface="AT Aero" pitchFamily="34" charset="-120"/>
+                <a:latin typeface="Bookman ITC Std" pitchFamily="34" charset="0"/>
+                <a:ea typeface="Bookman ITC Std" pitchFamily="34" charset="-122"/>
+                <a:cs typeface="Bookman ITC Std" pitchFamily="34" charset="-120"/>
               </a:rPr>
               <a:t>Key Message: The response? Circular and Autonomous Supply Chains. We are using AI to 'self-heal' the supply chain.</a:t>
             </a:r>
@@ -2850,9 +2850,9 @@
                 <a:solidFill>
                   <a:srgbClr val="6B6560"/>
                 </a:solidFill>
-                <a:latin typeface="AT Aero" pitchFamily="34" charset="0"/>
-                <a:ea typeface="AT Aero" pitchFamily="34" charset="-122"/>
-                <a:cs typeface="AT Aero" pitchFamily="34" charset="-120"/>
+                <a:latin typeface="Bookman ITC Std" pitchFamily="34" charset="0"/>
+                <a:ea typeface="Bookman ITC Std" pitchFamily="34" charset="-122"/>
+                <a:cs typeface="Bookman ITC Std" pitchFamily="34" charset="-120"/>
               </a:rPr>
               <a:t>Automatically re-routing orders when a port closes or a factory goes down. Mapping up to Tier-4 and Tier-5 suppliers.</a:t>
             </a:r>
@@ -2953,9 +2953,9 @@
                 <a:solidFill>
                   <a:srgbClr val="6B6560"/>
                 </a:solidFill>
-                <a:latin typeface="AT Aero" pitchFamily="34" charset="0"/>
-                <a:ea typeface="AT Aero" pitchFamily="34" charset="-122"/>
-                <a:cs typeface="AT Aero" pitchFamily="34" charset="-120"/>
+                <a:latin typeface="Bookman ITC Std" pitchFamily="34" charset="0"/>
+                <a:ea typeface="Bookman ITC Std" pitchFamily="34" charset="-122"/>
+                <a:cs typeface="Bookman ITC Std" pitchFamily="34" charset="-120"/>
               </a:rPr>
               <a:t>Mining the 'urban mine'—recovering rare earth elements from old electronics to reduce dependency on volatile mining regions.</a:t>
             </a:r>
@@ -3017,9 +3017,9 @@
                 <a:solidFill>
                   <a:srgbClr val="6B6560"/>
                 </a:solidFill>
-                <a:latin typeface="AT Aero" pitchFamily="34" charset="0"/>
-                <a:ea typeface="AT Aero" pitchFamily="34" charset="-122"/>
-                <a:cs typeface="AT Aero" pitchFamily="34" charset="-120"/>
+                <a:latin typeface="Bookman ITC Std" pitchFamily="34" charset="0"/>
+                <a:ea typeface="Bookman ITC Std" pitchFamily="34" charset="-122"/>
+                <a:cs typeface="Bookman ITC Std" pitchFamily="34" charset="-120"/>
               </a:rPr>
               <a:t>Autonomous logistics systems automatically scan trade flows to reroute containers before bottleneck events cause line shutdowns.</a:t>
             </a:r>
@@ -3088,9 +3088,9 @@
                 <a:solidFill>
                   <a:srgbClr val="B84A2F"/>
                 </a:solidFill>
-                <a:latin typeface="AT Aero" pitchFamily="34" charset="0"/>
-                <a:ea typeface="AT Aero" pitchFamily="34" charset="-122"/>
-                <a:cs typeface="AT Aero" pitchFamily="34" charset="-120"/>
+                <a:latin typeface="Bookman ITC Std" pitchFamily="34" charset="0"/>
+                <a:ea typeface="Bookman ITC Std" pitchFamily="34" charset="-122"/>
+                <a:cs typeface="Bookman ITC Std" pitchFamily="34" charset="-120"/>
               </a:rPr>
               <a:t>PART 3: END-USER INDUSTRIES &amp; APPLICATION ECOSYSTEM</a:t>
             </a:r>
@@ -3166,9 +3166,9 @@
                 <a:solidFill>
                   <a:srgbClr val="6B6560"/>
                 </a:solidFill>
-                <a:latin typeface="AT Aero" pitchFamily="34" charset="0"/>
-                <a:ea typeface="AT Aero" pitchFamily="34" charset="-122"/>
-                <a:cs typeface="AT Aero" pitchFamily="34" charset="-120"/>
+                <a:latin typeface="Bookman ITC Std" pitchFamily="34" charset="0"/>
+                <a:ea typeface="Bookman ITC Std" pitchFamily="34" charset="-122"/>
+                <a:cs typeface="Bookman ITC Std" pitchFamily="34" charset="-120"/>
               </a:rPr>
               <a:t>The 2026 Semiconductor Ecosystem | Slide 11</a:t>
             </a:r>
@@ -3230,9 +3230,9 @@
                 <a:solidFill>
                   <a:srgbClr val="9E7D84"/>
                 </a:solidFill>
-                <a:latin typeface="AT Aero" pitchFamily="34" charset="0"/>
-                <a:ea typeface="AT Aero" pitchFamily="34" charset="-122"/>
-                <a:cs typeface="AT Aero" pitchFamily="34" charset="-120"/>
+                <a:latin typeface="Bookman ITC Std" pitchFamily="34" charset="0"/>
+                <a:ea typeface="Bookman ITC Std" pitchFamily="34" charset="-122"/>
+                <a:cs typeface="Bookman ITC Std" pitchFamily="34" charset="-120"/>
               </a:rPr>
               <a:t>Key Message: Semiconductors are the "nerve system" of the global economy; no modern industry can function without them.</a:t>
             </a:r>
@@ -3270,9 +3270,9 @@
                 <a:solidFill>
                   <a:srgbClr val="6B6560"/>
                 </a:solidFill>
-                <a:latin typeface="AT Aero" pitchFamily="34" charset="0"/>
-                <a:ea typeface="AT Aero" pitchFamily="34" charset="-122"/>
-                <a:cs typeface="AT Aero" pitchFamily="34" charset="-120"/>
+                <a:latin typeface="Bookman ITC Std" pitchFamily="34" charset="0"/>
+                <a:ea typeface="Bookman ITC Std" pitchFamily="34" charset="-122"/>
+                <a:cs typeface="Bookman ITC Std" pitchFamily="34" charset="-120"/>
               </a:rPr>
               <a:t>- Central Nerve System: Microchips control the storage, routing, and processing of every piece of data globally.</a:t>
             </a:r>
@@ -3295,9 +3295,9 @@
                 <a:solidFill>
                   <a:srgbClr val="6B6560"/>
                 </a:solidFill>
-                <a:latin typeface="AT Aero" pitchFamily="34" charset="0"/>
-                <a:ea typeface="AT Aero" pitchFamily="34" charset="-122"/>
-                <a:cs typeface="AT Aero" pitchFamily="34" charset="-120"/>
+                <a:latin typeface="Bookman ITC Std" pitchFamily="34" charset="0"/>
+                <a:ea typeface="Bookman ITC Std" pitchFamily="34" charset="-122"/>
+                <a:cs typeface="Bookman ITC Std" pitchFamily="34" charset="-120"/>
               </a:rPr>
               <a:t>- Silicon Intensity Metric: The total value of silicon content per product is the primary metric of industrial scaling.</a:t>
             </a:r>
@@ -3320,9 +3320,9 @@
                 <a:solidFill>
                   <a:srgbClr val="6B6560"/>
                 </a:solidFill>
-                <a:latin typeface="AT Aero" pitchFamily="34" charset="0"/>
-                <a:ea typeface="AT Aero" pitchFamily="34" charset="-122"/>
-                <a:cs typeface="AT Aero" pitchFamily="34" charset="-120"/>
+                <a:latin typeface="Bookman ITC Std" pitchFamily="34" charset="0"/>
+                <a:ea typeface="Bookman ITC Std" pitchFamily="34" charset="-122"/>
+                <a:cs typeface="Bookman ITC Std" pitchFamily="34" charset="-120"/>
               </a:rPr>
               <a:t>- Ubiquitous Integration: Foundational logic layers power smart municipal grids, medical machinery, and neural processors.</a:t>
             </a:r>
@@ -3384,9 +3384,9 @@
                 <a:solidFill>
                   <a:srgbClr val="9E7D84"/>
                 </a:solidFill>
-                <a:latin typeface="AT Aero" pitchFamily="34" charset="0"/>
-                <a:ea typeface="AT Aero" pitchFamily="34" charset="-122"/>
-                <a:cs typeface="AT Aero" pitchFamily="34" charset="-120"/>
+                <a:latin typeface="Bookman ITC Std" pitchFamily="34" charset="0"/>
+                <a:ea typeface="Bookman ITC Std" pitchFamily="34" charset="-122"/>
+                <a:cs typeface="Bookman ITC Std" pitchFamily="34" charset="-120"/>
               </a:rPr>
               <a:t>KEY METRIC</a:t>
             </a:r>
@@ -3479,9 +3479,9 @@
                 <a:solidFill>
                   <a:srgbClr val="6B6560"/>
                 </a:solidFill>
-                <a:latin typeface="AT Aero" pitchFamily="34" charset="0"/>
-                <a:ea typeface="AT Aero" pitchFamily="34" charset="-122"/>
-                <a:cs typeface="AT Aero" pitchFamily="34" charset="-120"/>
+                <a:latin typeface="Bookman ITC Std" pitchFamily="34" charset="0"/>
+                <a:ea typeface="Bookman ITC Std" pitchFamily="34" charset="-122"/>
+                <a:cs typeface="Bookman ITC Std" pitchFamily="34" charset="-120"/>
               </a:rPr>
               <a:t>Primary industrial competitiveness index</a:t>
             </a:r>
@@ -3550,9 +3550,9 @@
                 <a:solidFill>
                   <a:srgbClr val="B84A2F"/>
                 </a:solidFill>
-                <a:latin typeface="AT Aero" pitchFamily="34" charset="0"/>
-                <a:ea typeface="AT Aero" pitchFamily="34" charset="-122"/>
-                <a:cs typeface="AT Aero" pitchFamily="34" charset="-120"/>
+                <a:latin typeface="Bookman ITC Std" pitchFamily="34" charset="0"/>
+                <a:ea typeface="Bookman ITC Std" pitchFamily="34" charset="-122"/>
+                <a:cs typeface="Bookman ITC Std" pitchFamily="34" charset="-120"/>
               </a:rPr>
               <a:t>PART 3: END-USER INDUSTRIES &amp; APPLICATION ECOSYSTEM</a:t>
             </a:r>
@@ -3628,9 +3628,9 @@
                 <a:solidFill>
                   <a:srgbClr val="6B6560"/>
                 </a:solidFill>
-                <a:latin typeface="AT Aero" pitchFamily="34" charset="0"/>
-                <a:ea typeface="AT Aero" pitchFamily="34" charset="-122"/>
-                <a:cs typeface="AT Aero" pitchFamily="34" charset="-120"/>
+                <a:latin typeface="Bookman ITC Std" pitchFamily="34" charset="0"/>
+                <a:ea typeface="Bookman ITC Std" pitchFamily="34" charset="-122"/>
+                <a:cs typeface="Bookman ITC Std" pitchFamily="34" charset="-120"/>
               </a:rPr>
               <a:t>The 2026 Semiconductor Ecosystem | Slide 12</a:t>
             </a:r>
@@ -3692,9 +3692,9 @@
                 <a:solidFill>
                   <a:srgbClr val="B84A2F"/>
                 </a:solidFill>
-                <a:latin typeface="AT Aero" pitchFamily="34" charset="0"/>
-                <a:ea typeface="AT Aero" pitchFamily="34" charset="-122"/>
-                <a:cs typeface="AT Aero" pitchFamily="34" charset="-120"/>
+                <a:latin typeface="Bookman ITC Std" pitchFamily="34" charset="0"/>
+                <a:ea typeface="Bookman ITC Std" pitchFamily="34" charset="-122"/>
+                <a:cs typeface="Bookman ITC Std" pitchFamily="34" charset="-120"/>
               </a:rPr>
               <a:t>Key Message: Demand is shifting from traditional computing toward AI infrastructure, Automotive, and Industrial Automation.</a:t>
             </a:r>
@@ -3795,9 +3795,9 @@
                 <a:solidFill>
                   <a:srgbClr val="6B6560"/>
                 </a:solidFill>
-                <a:latin typeface="AT Aero" pitchFamily="34" charset="0"/>
-                <a:ea typeface="AT Aero" pitchFamily="34" charset="-122"/>
-                <a:cs typeface="AT Aero" pitchFamily="34" charset="-120"/>
+                <a:latin typeface="Bookman ITC Std" pitchFamily="34" charset="0"/>
+                <a:ea typeface="Bookman ITC Std" pitchFamily="34" charset="-122"/>
+                <a:cs typeface="Bookman ITC Std" pitchFamily="34" charset="-120"/>
               </a:rPr>
               <a:t>Nearly 50% of semiconductor industry growth and revenue is driven by high-performance AI accelerators.</a:t>
             </a:r>
@@ -3898,9 +3898,9 @@
                 <a:solidFill>
                   <a:srgbClr val="6B6560"/>
                 </a:solidFill>
-                <a:latin typeface="AT Aero" pitchFamily="34" charset="0"/>
-                <a:ea typeface="AT Aero" pitchFamily="34" charset="-122"/>
-                <a:cs typeface="AT Aero" pitchFamily="34" charset="-120"/>
+                <a:latin typeface="Bookman ITC Std" pitchFamily="34" charset="0"/>
+                <a:ea typeface="Bookman ITC Std" pitchFamily="34" charset="-122"/>
+                <a:cs typeface="Bookman ITC Std" pitchFamily="34" charset="-120"/>
               </a:rPr>
               <a:t>The fastest growing volume segment, requiring massive numbers of legacy control nodes and SiC power chips.</a:t>
             </a:r>
@@ -4001,9 +4001,9 @@
                 <a:solidFill>
                   <a:srgbClr val="6B6560"/>
                 </a:solidFill>
-                <a:latin typeface="AT Aero" pitchFamily="34" charset="0"/>
-                <a:ea typeface="AT Aero" pitchFamily="34" charset="-122"/>
-                <a:cs typeface="AT Aero" pitchFamily="34" charset="-120"/>
+                <a:latin typeface="Bookman ITC Std" pitchFamily="34" charset="0"/>
+                <a:ea typeface="Bookman ITC Std" pitchFamily="34" charset="-122"/>
+                <a:cs typeface="Bookman ITC Std" pitchFamily="34" charset="-120"/>
               </a:rPr>
               <a:t>Traditional core segments face volume saturation, driving consolidation and focus on specialized edge accelerators.</a:t>
             </a:r>
@@ -4072,9 +4072,9 @@
                 <a:solidFill>
                   <a:srgbClr val="B84A2F"/>
                 </a:solidFill>
-                <a:latin typeface="AT Aero" pitchFamily="34" charset="0"/>
-                <a:ea typeface="AT Aero" pitchFamily="34" charset="-122"/>
-                <a:cs typeface="AT Aero" pitchFamily="34" charset="-120"/>
+                <a:latin typeface="Bookman ITC Std" pitchFamily="34" charset="0"/>
+                <a:ea typeface="Bookman ITC Std" pitchFamily="34" charset="-122"/>
+                <a:cs typeface="Bookman ITC Std" pitchFamily="34" charset="-120"/>
               </a:rPr>
               <a:t>PART 3: END-USER INDUSTRIES &amp; APPLICATION ECOSYSTEM</a:t>
             </a:r>
@@ -4150,9 +4150,9 @@
                 <a:solidFill>
                   <a:srgbClr val="6B6560"/>
                 </a:solidFill>
-                <a:latin typeface="AT Aero" pitchFamily="34" charset="0"/>
-                <a:ea typeface="AT Aero" pitchFamily="34" charset="-122"/>
-                <a:cs typeface="AT Aero" pitchFamily="34" charset="-120"/>
+                <a:latin typeface="Bookman ITC Std" pitchFamily="34" charset="0"/>
+                <a:ea typeface="Bookman ITC Std" pitchFamily="34" charset="-122"/>
+                <a:cs typeface="Bookman ITC Std" pitchFamily="34" charset="-120"/>
               </a:rPr>
               <a:t>The 2026 Semiconductor Ecosystem | Slide 13</a:t>
             </a:r>
@@ -4214,9 +4214,9 @@
                 <a:solidFill>
                   <a:srgbClr val="768C7C"/>
                 </a:solidFill>
-                <a:latin typeface="AT Aero" pitchFamily="34" charset="0"/>
-                <a:ea typeface="AT Aero" pitchFamily="34" charset="-122"/>
-                <a:cs typeface="AT Aero" pitchFamily="34" charset="-120"/>
+                <a:latin typeface="Bookman ITC Std" pitchFamily="34" charset="0"/>
+                <a:ea typeface="Bookman ITC Std" pitchFamily="34" charset="-122"/>
+                <a:cs typeface="Bookman ITC Std" pitchFamily="34" charset="-120"/>
               </a:rPr>
               <a:t>Key Message: Data centers have evolved into "Intelligence Engines," consuming the highest-value silicon ever produced.</a:t>
             </a:r>
@@ -4254,9 +4254,9 @@
                 <a:solidFill>
                   <a:srgbClr val="6B6560"/>
                 </a:solidFill>
-                <a:latin typeface="AT Aero" pitchFamily="34" charset="0"/>
-                <a:ea typeface="AT Aero" pitchFamily="34" charset="-122"/>
-                <a:cs typeface="AT Aero" pitchFamily="34" charset="-120"/>
+                <a:latin typeface="Bookman ITC Std" pitchFamily="34" charset="0"/>
+                <a:ea typeface="Bookman ITC Std" pitchFamily="34" charset="-122"/>
+                <a:cs typeface="Bookman ITC Std" pitchFamily="34" charset="-120"/>
               </a:rPr>
               <a:t>- Accelerator Market ($500B): Generative models and neural computing demand massive scaling of TPU and GPU nodes.</a:t>
             </a:r>
@@ -4279,9 +4279,9 @@
                 <a:solidFill>
                   <a:srgbClr val="6B6560"/>
                 </a:solidFill>
-                <a:latin typeface="AT Aero" pitchFamily="34" charset="0"/>
-                <a:ea typeface="AT Aero" pitchFamily="34" charset="-122"/>
-                <a:cs typeface="AT Aero" pitchFamily="34" charset="-120"/>
+                <a:latin typeface="Bookman ITC Std" pitchFamily="34" charset="0"/>
+                <a:ea typeface="Bookman ITC Std" pitchFamily="34" charset="-122"/>
+                <a:cs typeface="Bookman ITC Std" pitchFamily="34" charset="-120"/>
               </a:rPr>
               <a:t>- Sub-3nm Node Sourcing: The primary consumers of the most advanced wafer print architectures globally.</a:t>
             </a:r>
@@ -4304,9 +4304,9 @@
                 <a:solidFill>
                   <a:srgbClr val="6B6560"/>
                 </a:solidFill>
-                <a:latin typeface="AT Aero" pitchFamily="34" charset="0"/>
-                <a:ea typeface="AT Aero" pitchFamily="34" charset="-122"/>
-                <a:cs typeface="AT Aero" pitchFamily="34" charset="-120"/>
+                <a:latin typeface="Bookman ITC Std" pitchFamily="34" charset="0"/>
+                <a:ea typeface="Bookman ITC Std" pitchFamily="34" charset="-122"/>
+                <a:cs typeface="Bookman ITC Std" pitchFamily="34" charset="-120"/>
               </a:rPr>
               <a:t>- Memory &amp; Interconnect: Demands extreme density of High Bandwidth Memory (HBM) and customized routing interconnect silicon.</a:t>
             </a:r>
@@ -4368,9 +4368,9 @@
                 <a:solidFill>
                   <a:srgbClr val="768C7C"/>
                 </a:solidFill>
-                <a:latin typeface="AT Aero" pitchFamily="34" charset="0"/>
-                <a:ea typeface="AT Aero" pitchFamily="34" charset="-122"/>
-                <a:cs typeface="AT Aero" pitchFamily="34" charset="-120"/>
+                <a:latin typeface="Bookman ITC Std" pitchFamily="34" charset="0"/>
+                <a:ea typeface="Bookman ITC Std" pitchFamily="34" charset="-122"/>
+                <a:cs typeface="Bookman ITC Std" pitchFamily="34" charset="-120"/>
               </a:rPr>
               <a:t>ANALYST PROJECT</a:t>
             </a:r>
@@ -4446,9 +4446,9 @@
                 <a:solidFill>
                   <a:srgbClr val="6B6560"/>
                 </a:solidFill>
-                <a:latin typeface="AT Aero" pitchFamily="34" charset="0"/>
-                <a:ea typeface="AT Aero" pitchFamily="34" charset="-122"/>
-                <a:cs typeface="AT Aero" pitchFamily="34" charset="-120"/>
+                <a:latin typeface="Bookman ITC Std" pitchFamily="34" charset="0"/>
+                <a:ea typeface="Bookman ITC Std" pitchFamily="34" charset="-122"/>
+                <a:cs typeface="Bookman ITC Std" pitchFamily="34" charset="-120"/>
               </a:rPr>
               <a:t>AI Accelerator market size by 2026</a:t>
             </a:r>
@@ -4517,9 +4517,9 @@
                 <a:solidFill>
                   <a:srgbClr val="B84A2F"/>
                 </a:solidFill>
-                <a:latin typeface="AT Aero" pitchFamily="34" charset="0"/>
-                <a:ea typeface="AT Aero" pitchFamily="34" charset="-122"/>
-                <a:cs typeface="AT Aero" pitchFamily="34" charset="-120"/>
+                <a:latin typeface="Bookman ITC Std" pitchFamily="34" charset="0"/>
+                <a:ea typeface="Bookman ITC Std" pitchFamily="34" charset="-122"/>
+                <a:cs typeface="Bookman ITC Std" pitchFamily="34" charset="-120"/>
               </a:rPr>
               <a:t>PART 3: END-USER INDUSTRIES &amp; APPLICATION ECOSYSTEM</a:t>
             </a:r>
@@ -4595,9 +4595,9 @@
                 <a:solidFill>
                   <a:srgbClr val="6B6560"/>
                 </a:solidFill>
-                <a:latin typeface="AT Aero" pitchFamily="34" charset="0"/>
-                <a:ea typeface="AT Aero" pitchFamily="34" charset="-122"/>
-                <a:cs typeface="AT Aero" pitchFamily="34" charset="-120"/>
+                <a:latin typeface="Bookman ITC Std" pitchFamily="34" charset="0"/>
+                <a:ea typeface="Bookman ITC Std" pitchFamily="34" charset="-122"/>
+                <a:cs typeface="Bookman ITC Std" pitchFamily="34" charset="-120"/>
               </a:rPr>
               <a:t>The 2026 Semiconductor Ecosystem | Slide 14</a:t>
             </a:r>
@@ -4659,9 +4659,9 @@
                 <a:solidFill>
                   <a:srgbClr val="B84A2F"/>
                 </a:solidFill>
-                <a:latin typeface="AT Aero" pitchFamily="34" charset="0"/>
-                <a:ea typeface="AT Aero" pitchFamily="34" charset="-122"/>
-                <a:cs typeface="AT Aero" pitchFamily="34" charset="-120"/>
+                <a:latin typeface="Bookman ITC Std" pitchFamily="34" charset="0"/>
+                <a:ea typeface="Bookman ITC Std" pitchFamily="34" charset="-122"/>
+                <a:cs typeface="Bookman ITC Std" pitchFamily="34" charset="-120"/>
               </a:rPr>
               <a:t>Key Message: The transition to EVs and ADAS is doubling semiconductor content per vehicle, reaching over $1,000 per unit.</a:t>
             </a:r>
@@ -4699,9 +4699,9 @@
                 <a:solidFill>
                   <a:srgbClr val="6B6560"/>
                 </a:solidFill>
-                <a:latin typeface="AT Aero" pitchFamily="34" charset="0"/>
-                <a:ea typeface="AT Aero" pitchFamily="34" charset="-122"/>
-                <a:cs typeface="AT Aero" pitchFamily="34" charset="-120"/>
+                <a:latin typeface="Bookman ITC Std" pitchFamily="34" charset="0"/>
+                <a:ea typeface="Bookman ITC Std" pitchFamily="34" charset="-122"/>
+                <a:cs typeface="Bookman ITC Std" pitchFamily="34" charset="-120"/>
               </a:rPr>
               <a:t>- Silicon Carbide (SiC) Power: Drives high-efficiency power switches in high-voltage EV battery platforms.</a:t>
             </a:r>
@@ -4724,9 +4724,9 @@
                 <a:solidFill>
                   <a:srgbClr val="6B6560"/>
                 </a:solidFill>
-                <a:latin typeface="AT Aero" pitchFamily="34" charset="0"/>
-                <a:ea typeface="AT Aero" pitchFamily="34" charset="-122"/>
-                <a:cs typeface="AT Aero" pitchFamily="34" charset="-120"/>
+                <a:latin typeface="Bookman ITC Std" pitchFamily="34" charset="0"/>
+                <a:ea typeface="Bookman ITC Std" pitchFamily="34" charset="-122"/>
+                <a:cs typeface="Bookman ITC Std" pitchFamily="34" charset="-120"/>
               </a:rPr>
               <a:t>- ADAS Autonomous Compute: Self-driving capabilities demand heavy on-board computational units for sensor fusion.</a:t>
             </a:r>
@@ -4749,9 +4749,9 @@
                 <a:solidFill>
                   <a:srgbClr val="6B6560"/>
                 </a:solidFill>
-                <a:latin typeface="AT Aero" pitchFamily="34" charset="0"/>
-                <a:ea typeface="AT Aero" pitchFamily="34" charset="-122"/>
-                <a:cs typeface="AT Aero" pitchFamily="34" charset="-120"/>
+                <a:latin typeface="Bookman ITC Std" pitchFamily="34" charset="0"/>
+                <a:ea typeface="Bookman ITC Std" pitchFamily="34" charset="-122"/>
+                <a:cs typeface="Bookman ITC Std" pitchFamily="34" charset="-120"/>
               </a:rPr>
               <a:t>- Sensor Arrays Sourcing: Vehicles integrate multiple LiDAR, radar, and camera chip sets for 360-degree coverage.</a:t>
             </a:r>
@@ -4813,9 +4813,9 @@
                 <a:solidFill>
                   <a:srgbClr val="B84A2F"/>
                 </a:solidFill>
-                <a:latin typeface="AT Aero" pitchFamily="34" charset="0"/>
-                <a:ea typeface="AT Aero" pitchFamily="34" charset="-122"/>
-                <a:cs typeface="AT Aero" pitchFamily="34" charset="-120"/>
+                <a:latin typeface="Bookman ITC Std" pitchFamily="34" charset="0"/>
+                <a:ea typeface="Bookman ITC Std" pitchFamily="34" charset="-122"/>
+                <a:cs typeface="Bookman ITC Std" pitchFamily="34" charset="-120"/>
               </a:rPr>
               <a:t>ESTIMATE</a:t>
             </a:r>
@@ -4891,9 +4891,9 @@
                 <a:solidFill>
                   <a:srgbClr val="6B6560"/>
                 </a:solidFill>
-                <a:latin typeface="AT Aero" pitchFamily="34" charset="0"/>
-                <a:ea typeface="AT Aero" pitchFamily="34" charset="-122"/>
-                <a:cs typeface="AT Aero" pitchFamily="34" charset="-120"/>
+                <a:latin typeface="Bookman ITC Std" pitchFamily="34" charset="0"/>
+                <a:ea typeface="Bookman ITC Std" pitchFamily="34" charset="-122"/>
+                <a:cs typeface="Bookman ITC Std" pitchFamily="34" charset="-120"/>
               </a:rPr>
               <a:t>Silicon value content per EV unit</a:t>
             </a:r>
@@ -4962,9 +4962,9 @@
                 <a:solidFill>
                   <a:srgbClr val="B84A2F"/>
                 </a:solidFill>
-                <a:latin typeface="AT Aero" pitchFamily="34" charset="0"/>
-                <a:ea typeface="AT Aero" pitchFamily="34" charset="-122"/>
-                <a:cs typeface="AT Aero" pitchFamily="34" charset="-120"/>
+                <a:latin typeface="Bookman ITC Std" pitchFamily="34" charset="0"/>
+                <a:ea typeface="Bookman ITC Std" pitchFamily="34" charset="-122"/>
+                <a:cs typeface="Bookman ITC Std" pitchFamily="34" charset="-120"/>
               </a:rPr>
               <a:t>PART 3: END-USER INDUSTRIES &amp; APPLICATION ECOSYSTEM</a:t>
             </a:r>
@@ -5040,9 +5040,9 @@
                 <a:solidFill>
                   <a:srgbClr val="6B6560"/>
                 </a:solidFill>
-                <a:latin typeface="AT Aero" pitchFamily="34" charset="0"/>
-                <a:ea typeface="AT Aero" pitchFamily="34" charset="-122"/>
-                <a:cs typeface="AT Aero" pitchFamily="34" charset="-120"/>
+                <a:latin typeface="Bookman ITC Std" pitchFamily="34" charset="0"/>
+                <a:ea typeface="Bookman ITC Std" pitchFamily="34" charset="-122"/>
+                <a:cs typeface="Bookman ITC Std" pitchFamily="34" charset="-120"/>
               </a:rPr>
               <a:t>The 2026 Semiconductor Ecosystem | Slide 15</a:t>
             </a:r>
@@ -5104,9 +5104,9 @@
                 <a:solidFill>
                   <a:srgbClr val="9E7D84"/>
                 </a:solidFill>
-                <a:latin typeface="AT Aero" pitchFamily="34" charset="0"/>
-                <a:ea typeface="AT Aero" pitchFamily="34" charset="-122"/>
-                <a:cs typeface="AT Aero" pitchFamily="34" charset="-120"/>
+                <a:latin typeface="Bookman ITC Std" pitchFamily="34" charset="0"/>
+                <a:ea typeface="Bookman ITC Std" pitchFamily="34" charset="-122"/>
+                <a:cs typeface="Bookman ITC Std" pitchFamily="34" charset="-120"/>
               </a:rPr>
               <a:t>Key Message: Edge AI is transforming manufacturing and healthcare, prioritizing long-lifecycle, high-reliability silicon.</a:t>
             </a:r>
@@ -5207,9 +5207,9 @@
                 <a:solidFill>
                   <a:srgbClr val="6B6560"/>
                 </a:solidFill>
-                <a:latin typeface="AT Aero" pitchFamily="34" charset="0"/>
-                <a:ea typeface="AT Aero" pitchFamily="34" charset="-122"/>
-                <a:cs typeface="AT Aero" pitchFamily="34" charset="-120"/>
+                <a:latin typeface="Bookman ITC Std" pitchFamily="34" charset="0"/>
+                <a:ea typeface="Bookman ITC Std" pitchFamily="34" charset="-122"/>
+                <a:cs typeface="Bookman ITC Std" pitchFamily="34" charset="-120"/>
               </a:rPr>
               <a:t>Factory floor nodes execute real-time local algorithms for predictive maintenance and machine vision controls, utilizing highly rugged legacy processes.</a:t>
             </a:r>
@@ -5310,9 +5310,9 @@
                 <a:solidFill>
                   <a:srgbClr val="6B6560"/>
                 </a:solidFill>
-                <a:latin typeface="AT Aero" pitchFamily="34" charset="0"/>
-                <a:ea typeface="AT Aero" pitchFamily="34" charset="-122"/>
-                <a:cs typeface="AT Aero" pitchFamily="34" charset="-120"/>
+                <a:latin typeface="Bookman ITC Std" pitchFamily="34" charset="0"/>
+                <a:ea typeface="Bookman ITC Std" pitchFamily="34" charset="-122"/>
+                <a:cs typeface="Bookman ITC Std" pitchFamily="34" charset="-120"/>
               </a:rPr>
               <a:t>Semiconductors enable smart wearable diagnostics, active health implants, and personalized diagnostics. Requires extreme reliability certifications.</a:t>
             </a:r>
@@ -5381,9 +5381,9 @@
                 <a:solidFill>
                   <a:srgbClr val="B84A2F"/>
                 </a:solidFill>
-                <a:latin typeface="AT Aero" pitchFamily="34" charset="0"/>
-                <a:ea typeface="AT Aero" pitchFamily="34" charset="-122"/>
-                <a:cs typeface="AT Aero" pitchFamily="34" charset="-120"/>
+                <a:latin typeface="Bookman ITC Std" pitchFamily="34" charset="0"/>
+                <a:ea typeface="Bookman ITC Std" pitchFamily="34" charset="-122"/>
+                <a:cs typeface="Bookman ITC Std" pitchFamily="34" charset="-120"/>
               </a:rPr>
               <a:t>PART 3: END-USER INDUSTRIES &amp; APPLICATION ECOSYSTEM</a:t>
             </a:r>
@@ -5459,9 +5459,9 @@
                 <a:solidFill>
                   <a:srgbClr val="6B6560"/>
                 </a:solidFill>
-                <a:latin typeface="AT Aero" pitchFamily="34" charset="0"/>
-                <a:ea typeface="AT Aero" pitchFamily="34" charset="-122"/>
-                <a:cs typeface="AT Aero" pitchFamily="34" charset="-120"/>
+                <a:latin typeface="Bookman ITC Std" pitchFamily="34" charset="0"/>
+                <a:ea typeface="Bookman ITC Std" pitchFamily="34" charset="-122"/>
+                <a:cs typeface="Bookman ITC Std" pitchFamily="34" charset="-120"/>
               </a:rPr>
               <a:t>The 2026 Semiconductor Ecosystem | Slide 16</a:t>
             </a:r>
@@ -5523,9 +5523,9 @@
                 <a:solidFill>
                   <a:srgbClr val="768C7C"/>
                 </a:solidFill>
-                <a:latin typeface="AT Aero" pitchFamily="34" charset="0"/>
-                <a:ea typeface="AT Aero" pitchFamily="34" charset="-122"/>
-                <a:cs typeface="AT Aero" pitchFamily="34" charset="-120"/>
+                <a:latin typeface="Bookman ITC Std" pitchFamily="34" charset="0"/>
+                <a:ea typeface="Bookman ITC Std" pitchFamily="34" charset="-122"/>
+                <a:cs typeface="Bookman ITC Std" pitchFamily="34" charset="-120"/>
               </a:rPr>
               <a:t>Key Message: While traditional consumer tech matures, frontiers like Quantum, 6G, and Neuromorphic computing define the 2030 roadmap.</a:t>
             </a:r>
@@ -5563,9 +5563,9 @@
                 <a:solidFill>
                   <a:srgbClr val="6B6560"/>
                 </a:solidFill>
-                <a:latin typeface="AT Aero" pitchFamily="34" charset="0"/>
-                <a:ea typeface="AT Aero" pitchFamily="34" charset="-122"/>
-                <a:cs typeface="AT Aero" pitchFamily="34" charset="-120"/>
+                <a:latin typeface="Bookman ITC Std" pitchFamily="34" charset="0"/>
+                <a:ea typeface="Bookman ITC Std" pitchFamily="34" charset="-122"/>
+                <a:cs typeface="Bookman ITC Std" pitchFamily="34" charset="-120"/>
               </a:rPr>
               <a:t>- On-Device NPU Logic: Integrating Neural Processing Units (NPUs) into laptops and mobile phones to enable local AI execution.</a:t>
             </a:r>
@@ -5588,9 +5588,9 @@
                 <a:solidFill>
                   <a:srgbClr val="6B6560"/>
                 </a:solidFill>
-                <a:latin typeface="AT Aero" pitchFamily="34" charset="0"/>
-                <a:ea typeface="AT Aero" pitchFamily="34" charset="-122"/>
-                <a:cs typeface="AT Aero" pitchFamily="34" charset="-120"/>
+                <a:latin typeface="Bookman ITC Std" pitchFamily="34" charset="0"/>
+                <a:ea typeface="Bookman ITC Std" pitchFamily="34" charset="-122"/>
+                <a:cs typeface="Bookman ITC Std" pitchFamily="34" charset="-120"/>
               </a:rPr>
               <a:t>- Neuromorphic Computing: Researching brain-inspired architectures targeting extreme computing power efficiency.</a:t>
             </a:r>
@@ -5613,9 +5613,9 @@
                 <a:solidFill>
                   <a:srgbClr val="6B6560"/>
                 </a:solidFill>
-                <a:latin typeface="AT Aero" pitchFamily="34" charset="0"/>
-                <a:ea typeface="AT Aero" pitchFamily="34" charset="-122"/>
-                <a:cs typeface="AT Aero" pitchFamily="34" charset="-120"/>
+                <a:latin typeface="Bookman ITC Std" pitchFamily="34" charset="0"/>
+                <a:ea typeface="Bookman ITC Std" pitchFamily="34" charset="-122"/>
+                <a:cs typeface="Bookman ITC Std" pitchFamily="34" charset="-120"/>
               </a:rPr>
               <a:t>- Next-Gen Frontiers: Developing quantum structures and 6G communications hardware blocks.</a:t>
             </a:r>
@@ -5677,9 +5677,9 @@
                 <a:solidFill>
                   <a:srgbClr val="768C7C"/>
                 </a:solidFill>
-                <a:latin typeface="AT Aero" pitchFamily="34" charset="0"/>
-                <a:ea typeface="AT Aero" pitchFamily="34" charset="-122"/>
-                <a:cs typeface="AT Aero" pitchFamily="34" charset="-120"/>
+                <a:latin typeface="Bookman ITC Std" pitchFamily="34" charset="0"/>
+                <a:ea typeface="Bookman ITC Std" pitchFamily="34" charset="-122"/>
+                <a:cs typeface="Bookman ITC Std" pitchFamily="34" charset="-120"/>
               </a:rPr>
               <a:t>NPU CORES</a:t>
             </a:r>
@@ -5755,9 +5755,9 @@
                 <a:solidFill>
                   <a:srgbClr val="6B6560"/>
                 </a:solidFill>
-                <a:latin typeface="AT Aero" pitchFamily="34" charset="0"/>
-                <a:ea typeface="AT Aero" pitchFamily="34" charset="-122"/>
-                <a:cs typeface="AT Aero" pitchFamily="34" charset="-120"/>
+                <a:latin typeface="Bookman ITC Std" pitchFamily="34" charset="0"/>
+                <a:ea typeface="Bookman ITC Std" pitchFamily="34" charset="-122"/>
+                <a:cs typeface="Bookman ITC Std" pitchFamily="34" charset="-120"/>
               </a:rPr>
               <a:t>Standard hardware in 2026 client electronics (laptops, phones)</a:t>
             </a:r>
@@ -5826,9 +5826,9 @@
                 <a:solidFill>
                   <a:srgbClr val="B84A2F"/>
                 </a:solidFill>
-                <a:latin typeface="AT Aero" pitchFamily="34" charset="0"/>
-                <a:ea typeface="AT Aero" pitchFamily="34" charset="-122"/>
-                <a:cs typeface="AT Aero" pitchFamily="34" charset="-120"/>
+                <a:latin typeface="Bookman ITC Std" pitchFamily="34" charset="0"/>
+                <a:ea typeface="Bookman ITC Std" pitchFamily="34" charset="-122"/>
+                <a:cs typeface="Bookman ITC Std" pitchFamily="34" charset="-120"/>
               </a:rPr>
               <a:t>SUMMARY &amp; ROADMAP</a:t>
             </a:r>
@@ -5904,9 +5904,9 @@
                 <a:solidFill>
                   <a:srgbClr val="6B6560"/>
                 </a:solidFill>
-                <a:latin typeface="AT Aero" pitchFamily="34" charset="0"/>
-                <a:ea typeface="AT Aero" pitchFamily="34" charset="-122"/>
-                <a:cs typeface="AT Aero" pitchFamily="34" charset="-120"/>
+                <a:latin typeface="Bookman ITC Std" pitchFamily="34" charset="0"/>
+                <a:ea typeface="Bookman ITC Std" pitchFamily="34" charset="-122"/>
+                <a:cs typeface="Bookman ITC Std" pitchFamily="34" charset="-120"/>
               </a:rPr>
               <a:t>The 2026 Semiconductor Ecosystem | Slide 17</a:t>
             </a:r>
@@ -5968,9 +5968,9 @@
                 <a:solidFill>
                   <a:srgbClr val="B84A2F"/>
                 </a:solidFill>
-                <a:latin typeface="AT Aero" pitchFamily="34" charset="0"/>
-                <a:ea typeface="AT Aero" pitchFamily="34" charset="-122"/>
-                <a:cs typeface="AT Aero" pitchFamily="34" charset="-120"/>
+                <a:latin typeface="Bookman ITC Std" pitchFamily="34" charset="0"/>
+                <a:ea typeface="Bookman ITC Std" pitchFamily="34" charset="-122"/>
+                <a:cs typeface="Bookman ITC Std" pitchFamily="34" charset="-120"/>
               </a:rPr>
               <a:t>Key Message: We have reached a point of "Total Silicon Dependency." The path to a $2 trillion industry is certain.</a:t>
             </a:r>
@@ -6007,9 +6007,9 @@
                 <a:solidFill>
                   <a:srgbClr val="6B6560"/>
                 </a:solidFill>
-                <a:latin typeface="AT Aero" pitchFamily="34" charset="0"/>
-                <a:ea typeface="AT Aero" pitchFamily="34" charset="-122"/>
-                <a:cs typeface="AT Aero" pitchFamily="34" charset="-120"/>
+                <a:latin typeface="Bookman ITC Std" pitchFamily="34" charset="0"/>
+                <a:ea typeface="Bookman ITC Std" pitchFamily="34" charset="-122"/>
+                <a:cs typeface="Bookman ITC Std" pitchFamily="34" charset="-120"/>
               </a:rPr>
               <a:t>Mastery of the semiconductor ecosystem is mastery of the future. The "Chip Wars" aren't just about manufacturing; they are about who can best harness silicon to transform their industries.</a:t>
             </a:r>
@@ -6046,9 +6046,9 @@
                 <a:solidFill>
                   <a:srgbClr val="1A1714"/>
                 </a:solidFill>
-                <a:latin typeface="AT Aero" pitchFamily="34" charset="0"/>
-                <a:ea typeface="AT Aero" pitchFamily="34" charset="-122"/>
-                <a:cs typeface="AT Aero" pitchFamily="34" charset="-120"/>
+                <a:latin typeface="Bookman ITC Std" pitchFamily="34" charset="0"/>
+                <a:ea typeface="Bookman ITC Std" pitchFamily="34" charset="-122"/>
+                <a:cs typeface="Bookman ITC Std" pitchFamily="34" charset="-120"/>
               </a:rPr>
               <a:t>KEY TAKEAWAYS SUMMARY</a:t>
             </a:r>
@@ -6149,9 +6149,9 @@
                 <a:solidFill>
                   <a:srgbClr val="6B6560"/>
                 </a:solidFill>
-                <a:latin typeface="AT Aero" pitchFamily="34" charset="0"/>
-                <a:ea typeface="AT Aero" pitchFamily="34" charset="-122"/>
-                <a:cs typeface="AT Aero" pitchFamily="34" charset="-120"/>
+                <a:latin typeface="Bookman ITC Std" pitchFamily="34" charset="0"/>
+                <a:ea typeface="Bookman ITC Std" pitchFamily="34" charset="-122"/>
+                <a:cs typeface="Bookman ITC Std" pitchFamily="34" charset="-120"/>
               </a:rPr>
               <a:t>Shift from JIT to Strategic Hybrid; resilience is the new ROI.</a:t>
             </a:r>
@@ -6252,9 +6252,9 @@
                 <a:solidFill>
                   <a:srgbClr val="6B6560"/>
                 </a:solidFill>
-                <a:latin typeface="AT Aero" pitchFamily="34" charset="0"/>
-                <a:ea typeface="AT Aero" pitchFamily="34" charset="-122"/>
-                <a:cs typeface="AT Aero" pitchFamily="34" charset="-120"/>
+                <a:latin typeface="Bookman ITC Std" pitchFamily="34" charset="0"/>
+                <a:ea typeface="Bookman ITC Std" pitchFamily="34" charset="-122"/>
+                <a:cs typeface="Bookman ITC Std" pitchFamily="34" charset="-120"/>
               </a:rPr>
               <a:t>Chokepoints in Advanced Packaging and SME are the new strategic risks.</a:t>
             </a:r>
@@ -6355,9 +6355,9 @@
                 <a:solidFill>
                   <a:srgbClr val="6B6560"/>
                 </a:solidFill>
-                <a:latin typeface="AT Aero" pitchFamily="34" charset="0"/>
-                <a:ea typeface="AT Aero" pitchFamily="34" charset="-122"/>
-                <a:cs typeface="AT Aero" pitchFamily="34" charset="-120"/>
+                <a:latin typeface="Bookman ITC Std" pitchFamily="34" charset="0"/>
+                <a:ea typeface="Bookman ITC Std" pitchFamily="34" charset="-122"/>
+                <a:cs typeface="Bookman ITC Std" pitchFamily="34" charset="-120"/>
               </a:rPr>
               <a:t>AI is the Value King; Automotive is the Volume King.</a:t>
             </a:r>
@@ -6426,9 +6426,9 @@
                 <a:solidFill>
                   <a:srgbClr val="B84A2F"/>
                 </a:solidFill>
-                <a:latin typeface="AT Aero" pitchFamily="34" charset="0"/>
-                <a:ea typeface="AT Aero" pitchFamily="34" charset="-122"/>
-                <a:cs typeface="AT Aero" pitchFamily="34" charset="-120"/>
+                <a:latin typeface="Bookman ITC Std" pitchFamily="34" charset="0"/>
+                <a:ea typeface="Bookman ITC Std" pitchFamily="34" charset="-122"/>
+                <a:cs typeface="Bookman ITC Std" pitchFamily="34" charset="-120"/>
               </a:rPr>
               <a:t>THE END</a:t>
             </a:r>
@@ -6504,9 +6504,9 @@
                 <a:solidFill>
                   <a:srgbClr val="6B6560"/>
                 </a:solidFill>
-                <a:latin typeface="AT Aero" pitchFamily="34" charset="0"/>
-                <a:ea typeface="AT Aero" pitchFamily="34" charset="-122"/>
-                <a:cs typeface="AT Aero" pitchFamily="34" charset="-120"/>
+                <a:latin typeface="Bookman ITC Std" pitchFamily="34" charset="0"/>
+                <a:ea typeface="Bookman ITC Std" pitchFamily="34" charset="-122"/>
+                <a:cs typeface="Bookman ITC Std" pitchFamily="34" charset="-120"/>
               </a:rPr>
               <a:t>Mastery of the semiconductor ecosystem is mastery of the future.</a:t>
             </a:r>
@@ -6563,9 +6563,9 @@
                 <a:solidFill>
                   <a:srgbClr val="6B6560"/>
                 </a:solidFill>
-                <a:latin typeface="AT Aero" pitchFamily="34" charset="0"/>
-                <a:ea typeface="AT Aero" pitchFamily="34" charset="-122"/>
-                <a:cs typeface="AT Aero" pitchFamily="34" charset="-120"/>
+                <a:latin typeface="Bookman ITC Std" pitchFamily="34" charset="0"/>
+                <a:ea typeface="Bookman ITC Std" pitchFamily="34" charset="-122"/>
+                <a:cs typeface="Bookman ITC Std" pitchFamily="34" charset="-120"/>
               </a:rPr>
               <a:t>Presenter: Phyoe Sat Paing</a:t>
             </a:r>
@@ -6580,9 +6580,9 @@
                 <a:solidFill>
                   <a:srgbClr val="6B6560"/>
                 </a:solidFill>
-                <a:latin typeface="AT Aero" pitchFamily="34" charset="0"/>
-                <a:ea typeface="AT Aero" pitchFamily="34" charset="-122"/>
-                <a:cs typeface="AT Aero" pitchFamily="34" charset="-120"/>
+                <a:latin typeface="Bookman ITC Std" pitchFamily="34" charset="0"/>
+                <a:ea typeface="Bookman ITC Std" pitchFamily="34" charset="-122"/>
+                <a:cs typeface="Bookman ITC Std" pitchFamily="34" charset="-120"/>
               </a:rPr>
               <a:t>Boardroom Strategic Briefing</a:t>
             </a:r>
@@ -6619,9 +6619,9 @@
                 <a:solidFill>
                   <a:srgbClr val="6B6560"/>
                 </a:solidFill>
-                <a:latin typeface="AT Aero" pitchFamily="34" charset="0"/>
-                <a:ea typeface="AT Aero" pitchFamily="34" charset="-122"/>
-                <a:cs typeface="AT Aero" pitchFamily="34" charset="-120"/>
+                <a:latin typeface="Bookman ITC Std" pitchFamily="34" charset="0"/>
+                <a:ea typeface="Bookman ITC Std" pitchFamily="34" charset="-122"/>
+                <a:cs typeface="Bookman ITC Std" pitchFamily="34" charset="-120"/>
               </a:rPr>
               <a:t>The 2026 Semiconductor Ecosystem | Slide 18</a:t>
             </a:r>
@@ -6690,9 +6690,9 @@
                 <a:solidFill>
                   <a:srgbClr val="B84A2F"/>
                 </a:solidFill>
-                <a:latin typeface="AT Aero" pitchFamily="34" charset="0"/>
-                <a:ea typeface="AT Aero" pitchFamily="34" charset="-122"/>
-                <a:cs typeface="AT Aero" pitchFamily="34" charset="-120"/>
+                <a:latin typeface="Bookman ITC Std" pitchFamily="34" charset="0"/>
+                <a:ea typeface="Bookman ITC Std" pitchFamily="34" charset="-122"/>
+                <a:cs typeface="Bookman ITC Std" pitchFamily="34" charset="-120"/>
               </a:rPr>
               <a:t>PART 1: PROCUREMENT OF SEMICONDUCTORS</a:t>
             </a:r>
@@ -6768,9 +6768,9 @@
                 <a:solidFill>
                   <a:srgbClr val="6B6560"/>
                 </a:solidFill>
-                <a:latin typeface="AT Aero" pitchFamily="34" charset="0"/>
-                <a:ea typeface="AT Aero" pitchFamily="34" charset="-122"/>
-                <a:cs typeface="AT Aero" pitchFamily="34" charset="-120"/>
+                <a:latin typeface="Bookman ITC Std" pitchFamily="34" charset="0"/>
+                <a:ea typeface="Bookman ITC Std" pitchFamily="34" charset="-122"/>
+                <a:cs typeface="Bookman ITC Std" pitchFamily="34" charset="-120"/>
               </a:rPr>
               <a:t>The 2026 Semiconductor Ecosystem | Slide 02</a:t>
             </a:r>
@@ -6832,9 +6832,9 @@
                 <a:solidFill>
                   <a:srgbClr val="B84A2F"/>
                 </a:solidFill>
-                <a:latin typeface="AT Aero" pitchFamily="34" charset="0"/>
-                <a:ea typeface="AT Aero" pitchFamily="34" charset="-122"/>
-                <a:cs typeface="AT Aero" pitchFamily="34" charset="-120"/>
+                <a:latin typeface="Bookman ITC Std" pitchFamily="34" charset="0"/>
+                <a:ea typeface="Bookman ITC Std" pitchFamily="34" charset="-122"/>
+                <a:cs typeface="Bookman ITC Std" pitchFamily="34" charset="-120"/>
               </a:rPr>
               <a:t>Key Message: Navigating a $1.3 trillion market requires balancing unprecedented growth with systemic supply chain fragility.</a:t>
             </a:r>
@@ -6872,9 +6872,9 @@
                 <a:solidFill>
                   <a:srgbClr val="6B6560"/>
                 </a:solidFill>
-                <a:latin typeface="AT Aero" pitchFamily="34" charset="0"/>
-                <a:ea typeface="AT Aero" pitchFamily="34" charset="-122"/>
-                <a:cs typeface="AT Aero" pitchFamily="34" charset="-120"/>
+                <a:latin typeface="Bookman ITC Std" pitchFamily="34" charset="0"/>
+                <a:ea typeface="Bookman ITC Std" pitchFamily="34" charset="-122"/>
+                <a:cs typeface="Bookman ITC Std" pitchFamily="34" charset="-120"/>
               </a:rPr>
               <a:t>- Record-High Valuations: Growth is driven by explosive global demand for AI systems and electric vehicle power logic.</a:t>
             </a:r>
@@ -6897,9 +6897,9 @@
                 <a:solidFill>
                   <a:srgbClr val="6B6560"/>
                 </a:solidFill>
-                <a:latin typeface="AT Aero" pitchFamily="34" charset="0"/>
-                <a:ea typeface="AT Aero" pitchFamily="34" charset="-122"/>
-                <a:cs typeface="AT Aero" pitchFamily="34" charset="-120"/>
+                <a:latin typeface="Bookman ITC Std" pitchFamily="34" charset="0"/>
+                <a:ea typeface="Bookman ITC Std" pitchFamily="34" charset="-122"/>
+                <a:cs typeface="Bookman ITC Std" pitchFamily="34" charset="-120"/>
               </a:rPr>
               <a:t>- Systemic Fragility: Leading-edge fabs operate near maximum capacity, leaving the industry vulnerable to minor material delays.</a:t>
             </a:r>
@@ -6922,9 +6922,9 @@
                 <a:solidFill>
                   <a:srgbClr val="6B6560"/>
                 </a:solidFill>
-                <a:latin typeface="AT Aero" pitchFamily="34" charset="0"/>
-                <a:ea typeface="AT Aero" pitchFamily="34" charset="-122"/>
-                <a:cs typeface="AT Aero" pitchFamily="34" charset="-120"/>
+                <a:latin typeface="Bookman ITC Std" pitchFamily="34" charset="0"/>
+                <a:ea typeface="Bookman ITC Std" pitchFamily="34" charset="-122"/>
+                <a:cs typeface="Bookman ITC Std" pitchFamily="34" charset="-120"/>
               </a:rPr>
               <a:t>- Strategic Pivot: Sourcing HBM (High Bandwidth Memory) and advanced logic requires a shift from transactional purchasing to capacity reservation models.</a:t>
             </a:r>
@@ -6986,9 +6986,9 @@
                 <a:solidFill>
                   <a:srgbClr val="B84A2F"/>
                 </a:solidFill>
-                <a:latin typeface="AT Aero" pitchFamily="34" charset="0"/>
-                <a:ea typeface="AT Aero" pitchFamily="34" charset="-122"/>
-                <a:cs typeface="AT Aero" pitchFamily="34" charset="-120"/>
+                <a:latin typeface="Bookman ITC Std" pitchFamily="34" charset="0"/>
+                <a:ea typeface="Bookman ITC Std" pitchFamily="34" charset="-122"/>
+                <a:cs typeface="Bookman ITC Std" pitchFamily="34" charset="-120"/>
               </a:rPr>
               <a:t>ESTIMATE</a:t>
             </a:r>
@@ -7064,9 +7064,9 @@
                 <a:solidFill>
                   <a:srgbClr val="6B6560"/>
                 </a:solidFill>
-                <a:latin typeface="AT Aero" pitchFamily="34" charset="0"/>
-                <a:ea typeface="AT Aero" pitchFamily="34" charset="-122"/>
-                <a:cs typeface="AT Aero" pitchFamily="34" charset="-120"/>
+                <a:latin typeface="Bookman ITC Std" pitchFamily="34" charset="0"/>
+                <a:ea typeface="Bookman ITC Std" pitchFamily="34" charset="-122"/>
+                <a:cs typeface="Bookman ITC Std" pitchFamily="34" charset="-120"/>
               </a:rPr>
               <a:t>Global Market Value</a:t>
             </a:r>
@@ -7081,9 +7081,9 @@
                 <a:solidFill>
                   <a:srgbClr val="6B6560"/>
                 </a:solidFill>
-                <a:latin typeface="AT Aero" pitchFamily="34" charset="0"/>
-                <a:ea typeface="AT Aero" pitchFamily="34" charset="-122"/>
-                <a:cs typeface="AT Aero" pitchFamily="34" charset="-120"/>
+                <a:latin typeface="Bookman ITC Std" pitchFamily="34" charset="0"/>
+                <a:ea typeface="Bookman ITC Std" pitchFamily="34" charset="-122"/>
+                <a:cs typeface="Bookman ITC Std" pitchFamily="34" charset="-120"/>
               </a:rPr>
               <a:t>Analyst consensus 2026</a:t>
             </a:r>
@@ -7152,9 +7152,9 @@
                 <a:solidFill>
                   <a:srgbClr val="B84A2F"/>
                 </a:solidFill>
-                <a:latin typeface="AT Aero" pitchFamily="34" charset="0"/>
-                <a:ea typeface="AT Aero" pitchFamily="34" charset="-122"/>
-                <a:cs typeface="AT Aero" pitchFamily="34" charset="-120"/>
+                <a:latin typeface="Bookman ITC Std" pitchFamily="34" charset="0"/>
+                <a:ea typeface="Bookman ITC Std" pitchFamily="34" charset="-122"/>
+                <a:cs typeface="Bookman ITC Std" pitchFamily="34" charset="-120"/>
               </a:rPr>
               <a:t>PART 1: PROCUREMENT OF SEMICONDUCTORS</a:t>
             </a:r>
@@ -7230,9 +7230,9 @@
                 <a:solidFill>
                   <a:srgbClr val="6B6560"/>
                 </a:solidFill>
-                <a:latin typeface="AT Aero" pitchFamily="34" charset="0"/>
-                <a:ea typeface="AT Aero" pitchFamily="34" charset="-122"/>
-                <a:cs typeface="AT Aero" pitchFamily="34" charset="-120"/>
+                <a:latin typeface="Bookman ITC Std" pitchFamily="34" charset="0"/>
+                <a:ea typeface="Bookman ITC Std" pitchFamily="34" charset="-122"/>
+                <a:cs typeface="Bookman ITC Std" pitchFamily="34" charset="-120"/>
               </a:rPr>
               <a:t>The 2026 Semiconductor Ecosystem | Slide 03</a:t>
             </a:r>
@@ -7294,9 +7294,9 @@
                 <a:solidFill>
                   <a:srgbClr val="9E7D84"/>
                 </a:solidFill>
-                <a:latin typeface="AT Aero" pitchFamily="34" charset="0"/>
-                <a:ea typeface="AT Aero" pitchFamily="34" charset="-122"/>
-                <a:cs typeface="AT Aero" pitchFamily="34" charset="-120"/>
+                <a:latin typeface="Bookman ITC Std" pitchFamily="34" charset="0"/>
+                <a:ea typeface="Bookman ITC Std" pitchFamily="34" charset="-122"/>
+                <a:cs typeface="Bookman ITC Std" pitchFamily="34" charset="-120"/>
               </a:rPr>
               <a:t>Key Message: Pure JIT is obsolete; the new standard is a hybrid approach that prioritizes resilience for high-value nodes.</a:t>
             </a:r>
@@ -7397,9 +7397,9 @@
                 <a:solidFill>
                   <a:srgbClr val="6B6560"/>
                 </a:solidFill>
-                <a:latin typeface="AT Aero" pitchFamily="34" charset="0"/>
-                <a:ea typeface="AT Aero" pitchFamily="34" charset="-122"/>
-                <a:cs typeface="AT Aero" pitchFamily="34" charset="-120"/>
+                <a:latin typeface="Bookman ITC Std" pitchFamily="34" charset="0"/>
+                <a:ea typeface="Bookman ITC Std" pitchFamily="34" charset="-122"/>
+                <a:cs typeface="Bookman ITC Std" pitchFamily="34" charset="-120"/>
               </a:rPr>
               <a:t>Used for standardized legacy passive elements and commoditized logic chips. Minimizes capital lock-up and inventory holding costs while keeping storage footprint low.</a:t>
             </a:r>
@@ -7500,9 +7500,9 @@
                 <a:solidFill>
                   <a:srgbClr val="6B6560"/>
                 </a:solidFill>
-                <a:latin typeface="AT Aero" pitchFamily="34" charset="0"/>
-                <a:ea typeface="AT Aero" pitchFamily="34" charset="-122"/>
-                <a:cs typeface="AT Aero" pitchFamily="34" charset="-120"/>
+                <a:latin typeface="Bookman ITC Std" pitchFamily="34" charset="0"/>
+                <a:ea typeface="Bookman ITC Std" pitchFamily="34" charset="-122"/>
+                <a:cs typeface="Bookman ITC Std" pitchFamily="34" charset="-120"/>
               </a:rPr>
               <a:t>Maintaining 3 to 6 months of safety stock for sole-sourced, high-margin microcomponents (HBM, custom GPUs) to guarantee manufacturing continuity.</a:t>
             </a:r>
@@ -7571,9 +7571,9 @@
                 <a:solidFill>
                   <a:srgbClr val="B84A2F"/>
                 </a:solidFill>
-                <a:latin typeface="AT Aero" pitchFamily="34" charset="0"/>
-                <a:ea typeface="AT Aero" pitchFamily="34" charset="-122"/>
-                <a:cs typeface="AT Aero" pitchFamily="34" charset="-120"/>
+                <a:latin typeface="Bookman ITC Std" pitchFamily="34" charset="0"/>
+                <a:ea typeface="Bookman ITC Std" pitchFamily="34" charset="-122"/>
+                <a:cs typeface="Bookman ITC Std" pitchFamily="34" charset="-120"/>
               </a:rPr>
               <a:t>PART 1: PROCUREMENT OF SEMICONDUCTORS</a:t>
             </a:r>
@@ -7649,9 +7649,9 @@
                 <a:solidFill>
                   <a:srgbClr val="6B6560"/>
                 </a:solidFill>
-                <a:latin typeface="AT Aero" pitchFamily="34" charset="0"/>
-                <a:ea typeface="AT Aero" pitchFamily="34" charset="-122"/>
-                <a:cs typeface="AT Aero" pitchFamily="34" charset="-120"/>
+                <a:latin typeface="Bookman ITC Std" pitchFamily="34" charset="0"/>
+                <a:ea typeface="Bookman ITC Std" pitchFamily="34" charset="-122"/>
+                <a:cs typeface="Bookman ITC Std" pitchFamily="34" charset="-120"/>
               </a:rPr>
               <a:t>The 2026 Semiconductor Ecosystem | Slide 04</a:t>
             </a:r>
@@ -7713,9 +7713,9 @@
                 <a:solidFill>
                   <a:srgbClr val="768C7C"/>
                 </a:solidFill>
-                <a:latin typeface="AT Aero" pitchFamily="34" charset="0"/>
-                <a:ea typeface="AT Aero" pitchFamily="34" charset="-122"/>
-                <a:cs typeface="AT Aero" pitchFamily="34" charset="-120"/>
+                <a:latin typeface="Bookman ITC Std" pitchFamily="34" charset="0"/>
+                <a:ea typeface="Bookman ITC Std" pitchFamily="34" charset="-122"/>
+                <a:cs typeface="Bookman ITC Std" pitchFamily="34" charset="-120"/>
               </a:rPr>
               <a:t>Key Message: Data opacity and reactive risk management are the primary enemies of a resilient procurement strategy.</a:t>
             </a:r>
@@ -7753,9 +7753,9 @@
                 <a:solidFill>
                   <a:srgbClr val="6B6560"/>
                 </a:solidFill>
-                <a:latin typeface="AT Aero" pitchFamily="34" charset="0"/>
-                <a:ea typeface="AT Aero" pitchFamily="34" charset="-122"/>
-                <a:cs typeface="AT Aero" pitchFamily="34" charset="-120"/>
+                <a:latin typeface="Bookman ITC Std" pitchFamily="34" charset="0"/>
+                <a:ea typeface="Bookman ITC Std" pitchFamily="34" charset="-122"/>
+                <a:cs typeface="Bookman ITC Std" pitchFamily="34" charset="-120"/>
               </a:rPr>
               <a:t>- Category Management Sourcing: Slicing procurement into precise technology nodes (Leading-edge sub-7nm vs Legacy nodes).</a:t>
             </a:r>
@@ -7778,9 +7778,9 @@
                 <a:solidFill>
                   <a:srgbClr val="6B6560"/>
                 </a:solidFill>
-                <a:latin typeface="AT Aero" pitchFamily="34" charset="0"/>
-                <a:ea typeface="AT Aero" pitchFamily="34" charset="-122"/>
-                <a:cs typeface="AT Aero" pitchFamily="34" charset="-120"/>
+                <a:latin typeface="Bookman ITC Std" pitchFamily="34" charset="0"/>
+                <a:ea typeface="Bookman ITC Std" pitchFamily="34" charset="-122"/>
+                <a:cs typeface="Bookman ITC Std" pitchFamily="34" charset="-120"/>
               </a:rPr>
               <a:t>- Leading-edge Sourcing: Focuses on deep co-development partnerships, engineering collaboration, and long-term volume commitments.</a:t>
             </a:r>
@@ -7803,9 +7803,9 @@
                 <a:solidFill>
                   <a:srgbClr val="6B6560"/>
                 </a:solidFill>
-                <a:latin typeface="AT Aero" pitchFamily="34" charset="0"/>
-                <a:ea typeface="AT Aero" pitchFamily="34" charset="-122"/>
-                <a:cs typeface="AT Aero" pitchFamily="34" charset="-120"/>
+                <a:latin typeface="Bookman ITC Std" pitchFamily="34" charset="0"/>
+                <a:ea typeface="Bookman ITC Std" pitchFamily="34" charset="-122"/>
+                <a:cs typeface="Bookman ITC Std" pitchFamily="34" charset="-120"/>
               </a:rPr>
               <a:t>- Legacy Sourcing: Emphasizes multi-sourcing, second-sourcing qualification, and legacy lifecycle management to offset obsolescence.</a:t>
             </a:r>
@@ -7867,9 +7867,9 @@
                 <a:solidFill>
                   <a:srgbClr val="6B6560"/>
                 </a:solidFill>
-                <a:latin typeface="AT Aero" pitchFamily="34" charset="0"/>
-                <a:ea typeface="AT Aero" pitchFamily="34" charset="-122"/>
-                <a:cs typeface="AT Aero" pitchFamily="34" charset="-120"/>
+                <a:latin typeface="Bookman ITC Std" pitchFamily="34" charset="0"/>
+                <a:ea typeface="Bookman ITC Std" pitchFamily="34" charset="-122"/>
+                <a:cs typeface="Bookman ITC Std" pitchFamily="34" charset="-120"/>
               </a:rPr>
               <a:t>Leading-Edge Nodes</a:t>
             </a:r>
@@ -7890,9 +7890,9 @@
                 <a:solidFill>
                   <a:srgbClr val="6B6560"/>
                 </a:solidFill>
-                <a:latin typeface="AT Aero" pitchFamily="34" charset="0"/>
-                <a:ea typeface="AT Aero" pitchFamily="34" charset="-122"/>
-                <a:cs typeface="AT Aero" pitchFamily="34" charset="-120"/>
+                <a:latin typeface="Bookman ITC Std" pitchFamily="34" charset="0"/>
+                <a:ea typeface="Bookman ITC Std" pitchFamily="34" charset="-122"/>
+                <a:cs typeface="Bookman ITC Std" pitchFamily="34" charset="-120"/>
               </a:rPr>
               <a:t>Focus: Deep alliances, R&amp;D partnerships, capacity reservations.</a:t>
             </a:r>
@@ -7954,9 +7954,9 @@
                 <a:solidFill>
                   <a:srgbClr val="6B6560"/>
                 </a:solidFill>
-                <a:latin typeface="AT Aero" pitchFamily="34" charset="0"/>
-                <a:ea typeface="AT Aero" pitchFamily="34" charset="-122"/>
-                <a:cs typeface="AT Aero" pitchFamily="34" charset="-120"/>
+                <a:latin typeface="Bookman ITC Std" pitchFamily="34" charset="0"/>
+                <a:ea typeface="Bookman ITC Std" pitchFamily="34" charset="-122"/>
+                <a:cs typeface="Bookman ITC Std" pitchFamily="34" charset="-120"/>
               </a:rPr>
               <a:t>Legacy Nodes</a:t>
             </a:r>
@@ -7977,9 +7977,9 @@
                 <a:solidFill>
                   <a:srgbClr val="6B6560"/>
                 </a:solidFill>
-                <a:latin typeface="AT Aero" pitchFamily="34" charset="0"/>
-                <a:ea typeface="AT Aero" pitchFamily="34" charset="-122"/>
-                <a:cs typeface="AT Aero" pitchFamily="34" charset="-120"/>
+                <a:latin typeface="Bookman ITC Std" pitchFamily="34" charset="0"/>
+                <a:ea typeface="Bookman ITC Std" pitchFamily="34" charset="-122"/>
+                <a:cs typeface="Bookman ITC Std" pitchFamily="34" charset="-120"/>
               </a:rPr>
               <a:t>Focus: Multi-sourcing, distributor networks, life-cycle tracking.</a:t>
             </a:r>
@@ -8048,9 +8048,9 @@
                 <a:solidFill>
                   <a:srgbClr val="B84A2F"/>
                 </a:solidFill>
-                <a:latin typeface="AT Aero" pitchFamily="34" charset="0"/>
-                <a:ea typeface="AT Aero" pitchFamily="34" charset="-122"/>
-                <a:cs typeface="AT Aero" pitchFamily="34" charset="-120"/>
+                <a:latin typeface="Bookman ITC Std" pitchFamily="34" charset="0"/>
+                <a:ea typeface="Bookman ITC Std" pitchFamily="34" charset="-122"/>
+                <a:cs typeface="Bookman ITC Std" pitchFamily="34" charset="-120"/>
               </a:rPr>
               <a:t>PART 1: PROCUREMENT OF SEMICONDUCTORS</a:t>
             </a:r>
@@ -8126,9 +8126,9 @@
                 <a:solidFill>
                   <a:srgbClr val="6B6560"/>
                 </a:solidFill>
-                <a:latin typeface="AT Aero" pitchFamily="34" charset="0"/>
-                <a:ea typeface="AT Aero" pitchFamily="34" charset="-122"/>
-                <a:cs typeface="AT Aero" pitchFamily="34" charset="-120"/>
+                <a:latin typeface="Bookman ITC Std" pitchFamily="34" charset="0"/>
+                <a:ea typeface="Bookman ITC Std" pitchFamily="34" charset="-122"/>
+                <a:cs typeface="Bookman ITC Std" pitchFamily="34" charset="-120"/>
               </a:rPr>
               <a:t>The 2026 Semiconductor Ecosystem | Slide 05</a:t>
             </a:r>
@@ -8190,9 +8190,9 @@
                 <a:solidFill>
                   <a:srgbClr val="B84A2F"/>
                 </a:solidFill>
-                <a:latin typeface="AT Aero" pitchFamily="34" charset="0"/>
-                <a:ea typeface="AT Aero" pitchFamily="34" charset="-122"/>
-                <a:cs typeface="AT Aero" pitchFamily="34" charset="-120"/>
+                <a:latin typeface="Bookman ITC Std" pitchFamily="34" charset="0"/>
+                <a:ea typeface="Bookman ITC Std" pitchFamily="34" charset="-122"/>
+                <a:cs typeface="Bookman ITC Std" pitchFamily="34" charset="-120"/>
               </a:rPr>
               <a:t>Key Message: AI-driven "Business Intelligence Cockpits" are essential for predicting shortages 6-12 months in advance.</a:t>
             </a:r>
@@ -8293,9 +8293,9 @@
                 <a:solidFill>
                   <a:srgbClr val="6B6560"/>
                 </a:solidFill>
-                <a:latin typeface="AT Aero" pitchFamily="34" charset="0"/>
-                <a:ea typeface="AT Aero" pitchFamily="34" charset="-122"/>
-                <a:cs typeface="AT Aero" pitchFamily="34" charset="-120"/>
+                <a:latin typeface="Bookman ITC Std" pitchFamily="34" charset="0"/>
+                <a:ea typeface="Bookman ITC Std" pitchFamily="34" charset="-122"/>
+                <a:cs typeface="Bookman ITC Std" pitchFamily="34" charset="-120"/>
               </a:rPr>
               <a:t>Securing fab slots requires upfront reservation fees and take-or-pay clauses in Long-Term Agreements (LTAs) to lock down volume.</a:t>
             </a:r>
@@ -8396,9 +8396,9 @@
                 <a:solidFill>
                   <a:srgbClr val="6B6560"/>
                 </a:solidFill>
-                <a:latin typeface="AT Aero" pitchFamily="34" charset="0"/>
-                <a:ea typeface="AT Aero" pitchFamily="34" charset="-122"/>
-                <a:cs typeface="AT Aero" pitchFamily="34" charset="-120"/>
+                <a:latin typeface="Bookman ITC Std" pitchFamily="34" charset="0"/>
+                <a:ea typeface="Bookman ITC Std" pitchFamily="34" charset="-122"/>
+                <a:cs typeface="Bookman ITC Std" pitchFamily="34" charset="-120"/>
               </a:rPr>
               <a:t>Decoupling supply links from high-risk locations, redirecting procurement to allied geopolitical nodes with guaranteed supply lines.</a:t>
             </a:r>
@@ -8460,9 +8460,9 @@
                 <a:solidFill>
                   <a:srgbClr val="6B6560"/>
                 </a:solidFill>
-                <a:latin typeface="AT Aero" pitchFamily="34" charset="0"/>
-                <a:ea typeface="AT Aero" pitchFamily="34" charset="-122"/>
-                <a:cs typeface="AT Aero" pitchFamily="34" charset="-120"/>
+                <a:latin typeface="Bookman ITC Std" pitchFamily="34" charset="0"/>
+                <a:ea typeface="Bookman ITC Std" pitchFamily="34" charset="-122"/>
+                <a:cs typeface="Bookman ITC Std" pitchFamily="34" charset="-120"/>
               </a:rPr>
               <a:t>AI integration automatically tracks tier-2 chemical and substrate suppliers to detect factory closures or export blocks before they ripple into final fab allocations.</a:t>
             </a:r>
@@ -8531,9 +8531,9 @@
                 <a:solidFill>
                   <a:srgbClr val="B84A2F"/>
                 </a:solidFill>
-                <a:latin typeface="AT Aero" pitchFamily="34" charset="0"/>
-                <a:ea typeface="AT Aero" pitchFamily="34" charset="-122"/>
-                <a:cs typeface="AT Aero" pitchFamily="34" charset="-120"/>
+                <a:latin typeface="Bookman ITC Std" pitchFamily="34" charset="0"/>
+                <a:ea typeface="Bookman ITC Std" pitchFamily="34" charset="-122"/>
+                <a:cs typeface="Bookman ITC Std" pitchFamily="34" charset="-120"/>
               </a:rPr>
               <a:t>PART 2: THE GLOBAL SUPPLY CHAIN OF SEMICONDUCTORS</a:t>
             </a:r>
@@ -8609,9 +8609,9 @@
                 <a:solidFill>
                   <a:srgbClr val="6B6560"/>
                 </a:solidFill>
-                <a:latin typeface="AT Aero" pitchFamily="34" charset="0"/>
-                <a:ea typeface="AT Aero" pitchFamily="34" charset="-122"/>
-                <a:cs typeface="AT Aero" pitchFamily="34" charset="-120"/>
+                <a:latin typeface="Bookman ITC Std" pitchFamily="34" charset="0"/>
+                <a:ea typeface="Bookman ITC Std" pitchFamily="34" charset="-122"/>
+                <a:cs typeface="Bookman ITC Std" pitchFamily="34" charset="-120"/>
               </a:rPr>
               <a:t>The 2026 Semiconductor Ecosystem | Slide 06</a:t>
             </a:r>
@@ -8673,9 +8673,9 @@
                 <a:solidFill>
                   <a:srgbClr val="B84A2F"/>
                 </a:solidFill>
-                <a:latin typeface="AT Aero" pitchFamily="34" charset="0"/>
-                <a:ea typeface="AT Aero" pitchFamily="34" charset="-122"/>
-                <a:cs typeface="AT Aero" pitchFamily="34" charset="-120"/>
+                <a:latin typeface="Bookman ITC Std" pitchFamily="34" charset="0"/>
+                <a:ea typeface="Bookman ITC Std" pitchFamily="34" charset="-122"/>
+                <a:cs typeface="Bookman ITC Std" pitchFamily="34" charset="-120"/>
               </a:rPr>
               <a:t>Key Message: A single chip may cross international borders over 70 times, making it the most geographically dispersed value chain in history.</a:t>
             </a:r>
@@ -8712,9 +8712,9 @@
                 <a:solidFill>
                   <a:srgbClr val="768C7C"/>
                 </a:solidFill>
-                <a:latin typeface="AT Aero" pitchFamily="34" charset="0"/>
-                <a:ea typeface="AT Aero" pitchFamily="34" charset="-122"/>
-                <a:cs typeface="AT Aero" pitchFamily="34" charset="-120"/>
+                <a:latin typeface="Bookman ITC Std" pitchFamily="34" charset="0"/>
+                <a:ea typeface="Bookman ITC Std" pitchFamily="34" charset="-122"/>
+                <a:cs typeface="Bookman ITC Std" pitchFamily="34" charset="-120"/>
               </a:rPr>
               <a:t>THE SILICON JOURNEY</a:t>
             </a:r>
@@ -8815,9 +8815,9 @@
                 <a:solidFill>
                   <a:srgbClr val="1A1714"/>
                 </a:solidFill>
-                <a:latin typeface="AT Aero" pitchFamily="34" charset="0"/>
-                <a:ea typeface="AT Aero" pitchFamily="34" charset="-122"/>
-                <a:cs typeface="AT Aero" pitchFamily="34" charset="-120"/>
+                <a:latin typeface="Bookman ITC Std" pitchFamily="34" charset="0"/>
+                <a:ea typeface="Bookman ITC Std" pitchFamily="34" charset="-122"/>
+                <a:cs typeface="Bookman ITC Std" pitchFamily="34" charset="-120"/>
               </a:rPr>
               <a:t>US Design</a:t>
             </a:r>
@@ -8854,9 +8854,9 @@
                 <a:solidFill>
                   <a:srgbClr val="6B6560"/>
                 </a:solidFill>
-                <a:latin typeface="AT Aero" pitchFamily="34" charset="0"/>
-                <a:ea typeface="AT Aero" pitchFamily="34" charset="-122"/>
-                <a:cs typeface="AT Aero" pitchFamily="34" charset="-120"/>
+                <a:latin typeface="Bookman ITC Std" pitchFamily="34" charset="0"/>
+                <a:ea typeface="Bookman ITC Std" pitchFamily="34" charset="-122"/>
+                <a:cs typeface="Bookman ITC Std" pitchFamily="34" charset="-120"/>
               </a:rPr>
               <a:t>Design &amp; EDA Tools</a:t>
             </a:r>
@@ -8957,9 +8957,9 @@
                 <a:solidFill>
                   <a:srgbClr val="1A1714"/>
                 </a:solidFill>
-                <a:latin typeface="AT Aero" pitchFamily="34" charset="0"/>
-                <a:ea typeface="AT Aero" pitchFamily="34" charset="-122"/>
-                <a:cs typeface="AT Aero" pitchFamily="34" charset="-120"/>
+                <a:latin typeface="Bookman ITC Std" pitchFamily="34" charset="0"/>
+                <a:ea typeface="Bookman ITC Std" pitchFamily="34" charset="-122"/>
+                <a:cs typeface="Bookman ITC Std" pitchFamily="34" charset="-120"/>
               </a:rPr>
               <a:t>Dutch SME</a:t>
             </a:r>
@@ -8996,9 +8996,9 @@
                 <a:solidFill>
                   <a:srgbClr val="6B6560"/>
                 </a:solidFill>
-                <a:latin typeface="AT Aero" pitchFamily="34" charset="0"/>
-                <a:ea typeface="AT Aero" pitchFamily="34" charset="-122"/>
-                <a:cs typeface="AT Aero" pitchFamily="34" charset="-120"/>
+                <a:latin typeface="Bookman ITC Std" pitchFamily="34" charset="0"/>
+                <a:ea typeface="Bookman ITC Std" pitchFamily="34" charset="-122"/>
+                <a:cs typeface="Bookman ITC Std" pitchFamily="34" charset="-120"/>
               </a:rPr>
               <a:t>ASML EUV Optics</a:t>
             </a:r>
@@ -9099,9 +9099,9 @@
                 <a:solidFill>
                   <a:srgbClr val="1A1714"/>
                 </a:solidFill>
-                <a:latin typeface="AT Aero" pitchFamily="34" charset="0"/>
-                <a:ea typeface="AT Aero" pitchFamily="34" charset="-122"/>
-                <a:cs typeface="AT Aero" pitchFamily="34" charset="-120"/>
+                <a:latin typeface="Bookman ITC Std" pitchFamily="34" charset="0"/>
+                <a:ea typeface="Bookman ITC Std" pitchFamily="34" charset="-122"/>
+                <a:cs typeface="Bookman ITC Std" pitchFamily="34" charset="-120"/>
               </a:rPr>
               <a:t>Taiwan Fab</a:t>
             </a:r>
@@ -9138,9 +9138,9 @@
                 <a:solidFill>
                   <a:srgbClr val="6B6560"/>
                 </a:solidFill>
-                <a:latin typeface="AT Aero" pitchFamily="34" charset="0"/>
-                <a:ea typeface="AT Aero" pitchFamily="34" charset="-122"/>
-                <a:cs typeface="AT Aero" pitchFamily="34" charset="-120"/>
+                <a:latin typeface="Bookman ITC Std" pitchFamily="34" charset="0"/>
+                <a:ea typeface="Bookman ITC Std" pitchFamily="34" charset="-122"/>
+                <a:cs typeface="Bookman ITC Std" pitchFamily="34" charset="-120"/>
               </a:rPr>
               <a:t>TSMC Printing</a:t>
             </a:r>
@@ -9241,9 +9241,9 @@
                 <a:solidFill>
                   <a:srgbClr val="1A1714"/>
                 </a:solidFill>
-                <a:latin typeface="AT Aero" pitchFamily="34" charset="0"/>
-                <a:ea typeface="AT Aero" pitchFamily="34" charset="-122"/>
-                <a:cs typeface="AT Aero" pitchFamily="34" charset="-120"/>
+                <a:latin typeface="Bookman ITC Std" pitchFamily="34" charset="0"/>
+                <a:ea typeface="Bookman ITC Std" pitchFamily="34" charset="-122"/>
+                <a:cs typeface="Bookman ITC Std" pitchFamily="34" charset="-120"/>
               </a:rPr>
               <a:t>Japan Material</a:t>
             </a:r>
@@ -9280,9 +9280,9 @@
                 <a:solidFill>
                   <a:srgbClr val="6B6560"/>
                 </a:solidFill>
-                <a:latin typeface="AT Aero" pitchFamily="34" charset="0"/>
-                <a:ea typeface="AT Aero" pitchFamily="34" charset="-122"/>
-                <a:cs typeface="AT Aero" pitchFamily="34" charset="-120"/>
+                <a:latin typeface="Bookman ITC Std" pitchFamily="34" charset="0"/>
+                <a:ea typeface="Bookman ITC Std" pitchFamily="34" charset="-122"/>
+                <a:cs typeface="Bookman ITC Std" pitchFamily="34" charset="-120"/>
               </a:rPr>
               <a:t>Wafers &amp; Photoresist</a:t>
             </a:r>
@@ -9383,9 +9383,9 @@
                 <a:solidFill>
                   <a:srgbClr val="1A1714"/>
                 </a:solidFill>
-                <a:latin typeface="AT Aero" pitchFamily="34" charset="0"/>
-                <a:ea typeface="AT Aero" pitchFamily="34" charset="-122"/>
-                <a:cs typeface="AT Aero" pitchFamily="34" charset="-120"/>
+                <a:latin typeface="Bookman ITC Std" pitchFamily="34" charset="0"/>
+                <a:ea typeface="Bookman ITC Std" pitchFamily="34" charset="-122"/>
+                <a:cs typeface="Bookman ITC Std" pitchFamily="34" charset="-120"/>
               </a:rPr>
               <a:t>SE Asia Pack</a:t>
             </a:r>
@@ -9422,9 +9422,9 @@
                 <a:solidFill>
                   <a:srgbClr val="6B6560"/>
                 </a:solidFill>
-                <a:latin typeface="AT Aero" pitchFamily="34" charset="0"/>
-                <a:ea typeface="AT Aero" pitchFamily="34" charset="-122"/>
-                <a:cs typeface="AT Aero" pitchFamily="34" charset="-120"/>
+                <a:latin typeface="Bookman ITC Std" pitchFamily="34" charset="0"/>
+                <a:ea typeface="Bookman ITC Std" pitchFamily="34" charset="-122"/>
+                <a:cs typeface="Bookman ITC Std" pitchFamily="34" charset="-120"/>
               </a:rPr>
               <a:t>OSAT Assembly</a:t>
             </a:r>
@@ -9493,9 +9493,9 @@
                 <a:solidFill>
                   <a:srgbClr val="B84A2F"/>
                 </a:solidFill>
-                <a:latin typeface="AT Aero" pitchFamily="34" charset="0"/>
-                <a:ea typeface="AT Aero" pitchFamily="34" charset="-122"/>
-                <a:cs typeface="AT Aero" pitchFamily="34" charset="-120"/>
+                <a:latin typeface="Bookman ITC Std" pitchFamily="34" charset="0"/>
+                <a:ea typeface="Bookman ITC Std" pitchFamily="34" charset="-122"/>
+                <a:cs typeface="Bookman ITC Std" pitchFamily="34" charset="-120"/>
               </a:rPr>
               <a:t>PART 2: THE GLOBAL SUPPLY CHAIN OF SEMICONDUCTORS</a:t>
             </a:r>
@@ -9571,9 +9571,9 @@
                 <a:solidFill>
                   <a:srgbClr val="6B6560"/>
                 </a:solidFill>
-                <a:latin typeface="AT Aero" pitchFamily="34" charset="0"/>
-                <a:ea typeface="AT Aero" pitchFamily="34" charset="-122"/>
-                <a:cs typeface="AT Aero" pitchFamily="34" charset="-120"/>
+                <a:latin typeface="Bookman ITC Std" pitchFamily="34" charset="0"/>
+                <a:ea typeface="Bookman ITC Std" pitchFamily="34" charset="-122"/>
+                <a:cs typeface="Bookman ITC Std" pitchFamily="34" charset="-120"/>
               </a:rPr>
               <a:t>The 2026 Semiconductor Ecosystem | Slide 07</a:t>
             </a:r>
@@ -9635,9 +9635,9 @@
                 <a:solidFill>
                   <a:srgbClr val="9E7D84"/>
                 </a:solidFill>
-                <a:latin typeface="AT Aero" pitchFamily="34" charset="0"/>
-                <a:ea typeface="AT Aero" pitchFamily="34" charset="-122"/>
-                <a:cs typeface="AT Aero" pitchFamily="34" charset="-120"/>
+                <a:latin typeface="Bookman ITC Std" pitchFamily="34" charset="0"/>
+                <a:ea typeface="Bookman ITC Std" pitchFamily="34" charset="-122"/>
+                <a:cs typeface="Bookman ITC Std" pitchFamily="34" charset="-120"/>
               </a:rPr>
               <a:t>Key Message: Value is highly concentrated in specialized clusters: U.S. (Design), Europe (Equipment), and East Asia (Manufacturing).</a:t>
             </a:r>
@@ -9675,9 +9675,9 @@
                 <a:solidFill>
                   <a:srgbClr val="6B6560"/>
                 </a:solidFill>
-                <a:latin typeface="AT Aero" pitchFamily="34" charset="0"/>
-                <a:ea typeface="AT Aero" pitchFamily="34" charset="-122"/>
-                <a:cs typeface="AT Aero" pitchFamily="34" charset="-120"/>
+                <a:latin typeface="Bookman ITC Std" pitchFamily="34" charset="0"/>
+                <a:ea typeface="Bookman ITC Std" pitchFamily="34" charset="-122"/>
+                <a:cs typeface="Bookman ITC Std" pitchFamily="34" charset="-120"/>
               </a:rPr>
               <a:t>- Design &amp; EDA (United States): Dominance in core processor blueprints and layout compiler systems (NVIDIA, Apple, Qualcomm).</a:t>
             </a:r>
@@ -9700,9 +9700,9 @@
                 <a:solidFill>
                   <a:srgbClr val="6B6560"/>
                 </a:solidFill>
-                <a:latin typeface="AT Aero" pitchFamily="34" charset="0"/>
-                <a:ea typeface="AT Aero" pitchFamily="34" charset="-122"/>
-                <a:cs typeface="AT Aero" pitchFamily="34" charset="-120"/>
+                <a:latin typeface="Bookman ITC Std" pitchFamily="34" charset="0"/>
+                <a:ea typeface="Bookman ITC Std" pitchFamily="34" charset="-122"/>
+                <a:cs typeface="Bookman ITC Std" pitchFamily="34" charset="-120"/>
               </a:rPr>
               <a:t>- SME Equipment (Europe): Monopoly on Extreme Ultraviolet tools (ASML) required to etch sub-7nm circuit nodes.</a:t>
             </a:r>
@@ -9725,9 +9725,9 @@
                 <a:solidFill>
                   <a:srgbClr val="6B6560"/>
                 </a:solidFill>
-                <a:latin typeface="AT Aero" pitchFamily="34" charset="0"/>
-                <a:ea typeface="AT Aero" pitchFamily="34" charset="-122"/>
-                <a:cs typeface="AT Aero" pitchFamily="34" charset="-120"/>
+                <a:latin typeface="Bookman ITC Std" pitchFamily="34" charset="0"/>
+                <a:ea typeface="Bookman ITC Std" pitchFamily="34" charset="-122"/>
+                <a:cs typeface="Bookman ITC Std" pitchFamily="34" charset="-120"/>
               </a:rPr>
               <a:t>- Wafer Fabrication (East Asia): TSMC (Taiwan) and Samsung (Korea) form the production base for global advanced nodes.</a:t>
             </a:r>
@@ -9789,9 +9789,9 @@
                 <a:solidFill>
                   <a:srgbClr val="6B6560"/>
                 </a:solidFill>
-                <a:latin typeface="AT Aero" pitchFamily="34" charset="0"/>
-                <a:ea typeface="AT Aero" pitchFamily="34" charset="-122"/>
-                <a:cs typeface="AT Aero" pitchFamily="34" charset="-120"/>
+                <a:latin typeface="Bookman ITC Std" pitchFamily="34" charset="0"/>
+                <a:ea typeface="Bookman ITC Std" pitchFamily="34" charset="-122"/>
+                <a:cs typeface="Bookman ITC Std" pitchFamily="34" charset="-120"/>
               </a:rPr>
               <a:t>USA: Design IP</a:t>
             </a:r>
@@ -9812,9 +9812,9 @@
                 <a:solidFill>
                   <a:srgbClr val="6B6560"/>
                 </a:solidFill>
-                <a:latin typeface="AT Aero" pitchFamily="34" charset="0"/>
-                <a:ea typeface="AT Aero" pitchFamily="34" charset="-122"/>
-                <a:cs typeface="AT Aero" pitchFamily="34" charset="-120"/>
+                <a:latin typeface="Bookman ITC Std" pitchFamily="34" charset="0"/>
+                <a:ea typeface="Bookman ITC Std" pitchFamily="34" charset="-122"/>
+                <a:cs typeface="Bookman ITC Std" pitchFamily="34" charset="-120"/>
               </a:rPr>
               <a:t>80%+ market share in advanced EDA software tools.</a:t>
             </a:r>
@@ -9876,9 +9876,9 @@
                 <a:solidFill>
                   <a:srgbClr val="6B6560"/>
                 </a:solidFill>
-                <a:latin typeface="AT Aero" pitchFamily="34" charset="0"/>
-                <a:ea typeface="AT Aero" pitchFamily="34" charset="-122"/>
-                <a:cs typeface="AT Aero" pitchFamily="34" charset="-120"/>
+                <a:latin typeface="Bookman ITC Std" pitchFamily="34" charset="0"/>
+                <a:ea typeface="Bookman ITC Std" pitchFamily="34" charset="-122"/>
+                <a:cs typeface="Bookman ITC Std" pitchFamily="34" charset="-120"/>
               </a:rPr>
               <a:t>ASML (EU): Lithography</a:t>
             </a:r>
@@ -9899,9 +9899,9 @@
                 <a:solidFill>
                   <a:srgbClr val="6B6560"/>
                 </a:solidFill>
-                <a:latin typeface="AT Aero" pitchFamily="34" charset="0"/>
-                <a:ea typeface="AT Aero" pitchFamily="34" charset="-122"/>
-                <a:cs typeface="AT Aero" pitchFamily="34" charset="-120"/>
+                <a:latin typeface="Bookman ITC Std" pitchFamily="34" charset="0"/>
+                <a:ea typeface="Bookman ITC Std" pitchFamily="34" charset="-122"/>
+                <a:cs typeface="Bookman ITC Std" pitchFamily="34" charset="-120"/>
               </a:rPr>
               <a:t>100% monopsony on EUV printing technology.</a:t>
             </a:r>
@@ -9970,9 +9970,9 @@
                 <a:solidFill>
                   <a:srgbClr val="B84A2F"/>
                 </a:solidFill>
-                <a:latin typeface="AT Aero" pitchFamily="34" charset="0"/>
-                <a:ea typeface="AT Aero" pitchFamily="34" charset="-122"/>
-                <a:cs typeface="AT Aero" pitchFamily="34" charset="-120"/>
+                <a:latin typeface="Bookman ITC Std" pitchFamily="34" charset="0"/>
+                <a:ea typeface="Bookman ITC Std" pitchFamily="34" charset="-122"/>
+                <a:cs typeface="Bookman ITC Std" pitchFamily="34" charset="-120"/>
               </a:rPr>
               <a:t>PART 2: THE GLOBAL SUPPLY CHAIN OF SEMICONDUCTORS</a:t>
             </a:r>
@@ -10048,9 +10048,9 @@
                 <a:solidFill>
                   <a:srgbClr val="6B6560"/>
                 </a:solidFill>
-                <a:latin typeface="AT Aero" pitchFamily="34" charset="0"/>
-                <a:ea typeface="AT Aero" pitchFamily="34" charset="-122"/>
-                <a:cs typeface="AT Aero" pitchFamily="34" charset="-120"/>
+                <a:latin typeface="Bookman ITC Std" pitchFamily="34" charset="0"/>
+                <a:ea typeface="Bookman ITC Std" pitchFamily="34" charset="-122"/>
+                <a:cs typeface="Bookman ITC Std" pitchFamily="34" charset="-120"/>
               </a:rPr>
               <a:t>The 2026 Semiconductor Ecosystem | Slide 08</a:t>
             </a:r>
@@ -10112,9 +10112,9 @@
                 <a:solidFill>
                   <a:srgbClr val="768C7C"/>
                 </a:solidFill>
-                <a:latin typeface="AT Aero" pitchFamily="34" charset="0"/>
-                <a:ea typeface="AT Aero" pitchFamily="34" charset="-122"/>
-                <a:cs typeface="AT Aero" pitchFamily="34" charset="-120"/>
+                <a:latin typeface="Bookman ITC Std" pitchFamily="34" charset="0"/>
+                <a:ea typeface="Bookman ITC Std" pitchFamily="34" charset="-122"/>
+                <a:cs typeface="Bookman ITC Std" pitchFamily="34" charset="-120"/>
               </a:rPr>
               <a:t>Key Message: Advanced packaging (CoWoS, 3D Stacking) is the new primary growth limiter for the AI industry.</a:t>
             </a:r>
@@ -10215,9 +10215,9 @@
                 <a:solidFill>
                   <a:srgbClr val="6B6560"/>
                 </a:solidFill>
-                <a:latin typeface="AT Aero" pitchFamily="34" charset="0"/>
-                <a:ea typeface="AT Aero" pitchFamily="34" charset="-122"/>
-                <a:cs typeface="AT Aero" pitchFamily="34" charset="-120"/>
+                <a:latin typeface="Bookman ITC Std" pitchFamily="34" charset="0"/>
+                <a:ea typeface="Bookman ITC Std" pitchFamily="34" charset="-122"/>
+                <a:cs typeface="Bookman ITC Std" pitchFamily="34" charset="-120"/>
               </a:rPr>
               <a:t>The race for the 2nm and 1.4nm nodes continues to demand immense capital investments for wafer fabrication lines.</a:t>
             </a:r>
@@ -10318,9 +10318,9 @@
                 <a:solidFill>
                   <a:srgbClr val="6B6560"/>
                 </a:solidFill>
-                <a:latin typeface="AT Aero" pitchFamily="34" charset="0"/>
-                <a:ea typeface="AT Aero" pitchFamily="34" charset="-122"/>
-                <a:cs typeface="AT Aero" pitchFamily="34" charset="-120"/>
+                <a:latin typeface="Bookman ITC Std" pitchFamily="34" charset="0"/>
+                <a:ea typeface="Bookman ITC Std" pitchFamily="34" charset="-122"/>
+                <a:cs typeface="Bookman ITC Std" pitchFamily="34" charset="-120"/>
               </a:rPr>
               <a:t>Integrating multiple logic dies and High Bandwidth Memory (HBM) via CoWoS interposers is more constrained than wafer printing.</a:t>
             </a:r>
@@ -10382,9 +10382,9 @@
                 <a:solidFill>
                   <a:srgbClr val="6B6560"/>
                 </a:solidFill>
-                <a:latin typeface="AT Aero" pitchFamily="34" charset="0"/>
-                <a:ea typeface="AT Aero" pitchFamily="34" charset="-122"/>
-                <a:cs typeface="AT Aero" pitchFamily="34" charset="-120"/>
+                <a:latin typeface="Bookman ITC Std" pitchFamily="34" charset="0"/>
+                <a:ea typeface="Bookman ITC Std" pitchFamily="34" charset="-122"/>
+                <a:cs typeface="Bookman ITC Std" pitchFamily="34" charset="-120"/>
               </a:rPr>
               <a:t>Logistics bottleneck: Reaching target AI yields depends heavily on advanced back-end capacity, not just front-end print nodes.</a:t>
             </a:r>
@@ -10453,9 +10453,9 @@
                 <a:solidFill>
                   <a:srgbClr val="B84A2F"/>
                 </a:solidFill>
-                <a:latin typeface="AT Aero" pitchFamily="34" charset="0"/>
-                <a:ea typeface="AT Aero" pitchFamily="34" charset="-122"/>
-                <a:cs typeface="AT Aero" pitchFamily="34" charset="-120"/>
+                <a:latin typeface="Bookman ITC Std" pitchFamily="34" charset="0"/>
+                <a:ea typeface="Bookman ITC Std" pitchFamily="34" charset="-122"/>
+                <a:cs typeface="Bookman ITC Std" pitchFamily="34" charset="-120"/>
               </a:rPr>
               <a:t>PART 2: THE GLOBAL SUPPLY CHAIN OF SEMICONDUCTORS</a:t>
             </a:r>
@@ -10531,9 +10531,9 @@
                 <a:solidFill>
                   <a:srgbClr val="6B6560"/>
                 </a:solidFill>
-                <a:latin typeface="AT Aero" pitchFamily="34" charset="0"/>
-                <a:ea typeface="AT Aero" pitchFamily="34" charset="-122"/>
-                <a:cs typeface="AT Aero" pitchFamily="34" charset="-120"/>
+                <a:latin typeface="Bookman ITC Std" pitchFamily="34" charset="0"/>
+                <a:ea typeface="Bookman ITC Std" pitchFamily="34" charset="-122"/>
+                <a:cs typeface="Bookman ITC Std" pitchFamily="34" charset="-120"/>
               </a:rPr>
               <a:t>The 2026 Semiconductor Ecosystem | Slide 09</a:t>
             </a:r>
@@ -10595,9 +10595,9 @@
                 <a:solidFill>
                   <a:srgbClr val="B84A2F"/>
                 </a:solidFill>
-                <a:latin typeface="AT Aero" pitchFamily="34" charset="0"/>
-                <a:ea typeface="AT Aero" pitchFamily="34" charset="-122"/>
-                <a:cs typeface="AT Aero" pitchFamily="34" charset="-120"/>
+                <a:latin typeface="Bookman ITC Std" pitchFamily="34" charset="0"/>
+                <a:ea typeface="Bookman ITC Std" pitchFamily="34" charset="-122"/>
+                <a:cs typeface="Bookman ITC Std" pitchFamily="34" charset="-120"/>
               </a:rPr>
               <a:t>Key Message: Geopolitics has created a "Multi-Polar" silicon world, where export controls and subsidies drive regionalization.</a:t>
             </a:r>
@@ -10635,9 +10635,9 @@
                 <a:solidFill>
                   <a:srgbClr val="6B6560"/>
                 </a:solidFill>
-                <a:latin typeface="AT Aero" pitchFamily="34" charset="0"/>
-                <a:ea typeface="AT Aero" pitchFamily="34" charset="-122"/>
-                <a:cs typeface="AT Aero" pitchFamily="34" charset="-120"/>
+                <a:latin typeface="Bookman ITC Std" pitchFamily="34" charset="0"/>
+                <a:ea typeface="Bookman ITC Std" pitchFamily="34" charset="-122"/>
+                <a:cs typeface="Bookman ITC Std" pitchFamily="34" charset="-120"/>
               </a:rPr>
               <a:t>- The US CHIPS Act ($52B): Funding the domestic establishment of advanced logic fabs to balance East Asian concentration.</a:t>
             </a:r>
@@ -10660,9 +10660,9 @@
                 <a:solidFill>
                   <a:srgbClr val="6B6560"/>
                 </a:solidFill>
-                <a:latin typeface="AT Aero" pitchFamily="34" charset="0"/>
-                <a:ea typeface="AT Aero" pitchFamily="34" charset="-122"/>
-                <a:cs typeface="AT Aero" pitchFamily="34" charset="-120"/>
+                <a:latin typeface="Bookman ITC Std" pitchFamily="34" charset="0"/>
+                <a:ea typeface="Bookman ITC Std" pitchFamily="34" charset="-122"/>
+                <a:cs typeface="Bookman ITC Std" pitchFamily="34" charset="-120"/>
               </a:rPr>
               <a:t>- Europe &amp; China Reshoring: Multi-billion dollar state-supported programs targeting semiconductor in-sourcing.</a:t>
             </a:r>
@@ -10685,9 +10685,9 @@
                 <a:solidFill>
                   <a:srgbClr val="6B6560"/>
                 </a:solidFill>
-                <a:latin typeface="AT Aero" pitchFamily="34" charset="0"/>
-                <a:ea typeface="AT Aero" pitchFamily="34" charset="-122"/>
-                <a:cs typeface="AT Aero" pitchFamily="34" charset="-120"/>
+                <a:latin typeface="Bookman ITC Std" pitchFamily="34" charset="0"/>
+                <a:ea typeface="Bookman ITC Std" pitchFamily="34" charset="-122"/>
+                <a:cs typeface="Bookman ITC Std" pitchFamily="34" charset="-120"/>
               </a:rPr>
               <a:t>- Material Chokepoints: Strict export controls placed on critical trace materials like Gallium and Germanium.</a:t>
             </a:r>
@@ -10749,9 +10749,9 @@
                 <a:solidFill>
                   <a:srgbClr val="B84A2F"/>
                 </a:solidFill>
-                <a:latin typeface="AT Aero" pitchFamily="34" charset="0"/>
-                <a:ea typeface="AT Aero" pitchFamily="34" charset="-122"/>
-                <a:cs typeface="AT Aero" pitchFamily="34" charset="-120"/>
+                <a:latin typeface="Bookman ITC Std" pitchFamily="34" charset="0"/>
+                <a:ea typeface="Bookman ITC Std" pitchFamily="34" charset="-122"/>
+                <a:cs typeface="Bookman ITC Std" pitchFamily="34" charset="-120"/>
               </a:rPr>
               <a:t>CRITICAL CHOKEPOINT</a:t>
             </a:r>
@@ -10844,9 +10844,9 @@
                 <a:solidFill>
                   <a:srgbClr val="6B6560"/>
                 </a:solidFill>
-                <a:latin typeface="AT Aero" pitchFamily="34" charset="0"/>
-                <a:ea typeface="AT Aero" pitchFamily="34" charset="-122"/>
-                <a:cs typeface="AT Aero" pitchFamily="34" charset="-120"/>
+                <a:latin typeface="Bookman ITC Std" pitchFamily="34" charset="0"/>
+                <a:ea typeface="Bookman ITC Std" pitchFamily="34" charset="-122"/>
+                <a:cs typeface="Bookman ITC Std" pitchFamily="34" charset="-120"/>
               </a:rPr>
               <a:t>Strict raw material export control levers</a:t>
             </a:r>

</xml_diff>

<commit_message>
Update typography to exclusively use VVDS Fifties variants
</commit_message>
<xml_diff>
--- a/output/semiconductor-ecosystem-2026.pptx
+++ b/output/semiconductor-ecosystem-2026.pptx
@@ -2419,9 +2419,9 @@
                 <a:solidFill>
                   <a:srgbClr val="1A1714"/>
                 </a:solidFill>
-                <a:latin typeface="PP Mondwest" pitchFamily="34" charset="0"/>
-                <a:ea typeface="PP Mondwest" pitchFamily="34" charset="-122"/>
-                <a:cs typeface="PP Mondwest" pitchFamily="34" charset="-120"/>
+                <a:latin typeface="VVDS Fifties Exp SBold" pitchFamily="34" charset="0"/>
+                <a:ea typeface="VVDS Fifties Exp SBold" pitchFamily="34" charset="-122"/>
+                <a:cs typeface="VVDS Fifties Exp SBold" pitchFamily="34" charset="-120"/>
               </a:rPr>
               <a:t>The 2026 Semiconductor Ecosystem</a:t>
             </a:r>
@@ -2458,9 +2458,9 @@
                 <a:solidFill>
                   <a:srgbClr val="6B6560"/>
                 </a:solidFill>
-                <a:latin typeface="Bookman ITC Std" pitchFamily="34" charset="0"/>
-                <a:ea typeface="Bookman ITC Std" pitchFamily="34" charset="-122"/>
-                <a:cs typeface="Bookman ITC Std" pitchFamily="34" charset="-120"/>
+                <a:latin typeface="VVDS Fifties SCond Reg" pitchFamily="34" charset="0"/>
+                <a:ea typeface="VVDS Fifties SCond Reg" pitchFamily="34" charset="-122"/>
+                <a:cs typeface="VVDS Fifties SCond Reg" pitchFamily="34" charset="-120"/>
               </a:rPr>
               <a:t>A Strategic Briefing on Procurement, Global Supply Chains, and End-User Verticals</a:t>
             </a:r>
@@ -2517,9 +2517,9 @@
                 <a:solidFill>
                   <a:srgbClr val="6B6560"/>
                 </a:solidFill>
-                <a:latin typeface="Bookman ITC Std" pitchFamily="34" charset="0"/>
-                <a:ea typeface="Bookman ITC Std" pitchFamily="34" charset="-122"/>
-                <a:cs typeface="Bookman ITC Std" pitchFamily="34" charset="-120"/>
+                <a:latin typeface="VVDS Fifties Exp Reg" pitchFamily="34" charset="0"/>
+                <a:ea typeface="VVDS Fifties Exp Reg" pitchFamily="34" charset="-122"/>
+                <a:cs typeface="VVDS Fifties Exp Reg" pitchFamily="34" charset="-120"/>
               </a:rPr>
               <a:t>Presenter: Phyoe Sat Paing</a:t>
             </a:r>
@@ -2534,9 +2534,9 @@
                 <a:solidFill>
                   <a:srgbClr val="6B6560"/>
                 </a:solidFill>
-                <a:latin typeface="Bookman ITC Std" pitchFamily="34" charset="0"/>
-                <a:ea typeface="Bookman ITC Std" pitchFamily="34" charset="-122"/>
-                <a:cs typeface="Bookman ITC Std" pitchFamily="34" charset="-120"/>
+                <a:latin typeface="VVDS Fifties Exp Reg" pitchFamily="34" charset="0"/>
+                <a:ea typeface="VVDS Fifties Exp Reg" pitchFamily="34" charset="-122"/>
+                <a:cs typeface="VVDS Fifties Exp Reg" pitchFamily="34" charset="-120"/>
               </a:rPr>
               <a:t>Boardroom Strategic Briefing</a:t>
             </a:r>
@@ -2605,9 +2605,9 @@
                 <a:solidFill>
                   <a:srgbClr val="B84A2F"/>
                 </a:solidFill>
-                <a:latin typeface="Bookman ITC Std" pitchFamily="34" charset="0"/>
-                <a:ea typeface="Bookman ITC Std" pitchFamily="34" charset="-122"/>
-                <a:cs typeface="Bookman ITC Std" pitchFamily="34" charset="-120"/>
+                <a:latin typeface="VVDS Fifties Exp Reg" pitchFamily="34" charset="0"/>
+                <a:ea typeface="VVDS Fifties Exp Reg" pitchFamily="34" charset="-122"/>
+                <a:cs typeface="VVDS Fifties Exp Reg" pitchFamily="34" charset="-120"/>
               </a:rPr>
               <a:t>PART 2: THE GLOBAL SUPPLY CHAIN OF SEMICONDUCTORS</a:t>
             </a:r>
@@ -2644,9 +2644,9 @@
                 <a:solidFill>
                   <a:srgbClr val="1A1714"/>
                 </a:solidFill>
-                <a:latin typeface="PP Mondwest" pitchFamily="34" charset="0"/>
-                <a:ea typeface="PP Mondwest" pitchFamily="34" charset="-122"/>
-                <a:cs typeface="PP Mondwest" pitchFamily="34" charset="-120"/>
+                <a:latin typeface="VVDS Fifties Exp SBold" pitchFamily="34" charset="0"/>
+                <a:ea typeface="VVDS Fifties Exp SBold" pitchFamily="34" charset="-122"/>
+                <a:cs typeface="VVDS Fifties Exp SBold" pitchFamily="34" charset="-120"/>
               </a:rPr>
               <a:t>Supply Chain Resilience: Digital &amp; Circular</a:t>
             </a:r>
@@ -2683,9 +2683,9 @@
                 <a:solidFill>
                   <a:srgbClr val="6B6560"/>
                 </a:solidFill>
-                <a:latin typeface="Bookman ITC Std" pitchFamily="34" charset="0"/>
-                <a:ea typeface="Bookman ITC Std" pitchFamily="34" charset="-122"/>
-                <a:cs typeface="Bookman ITC Std" pitchFamily="34" charset="-120"/>
+                <a:latin typeface="VVDS Fifties Exp Reg" pitchFamily="34" charset="0"/>
+                <a:ea typeface="VVDS Fifties Exp Reg" pitchFamily="34" charset="-122"/>
+                <a:cs typeface="VVDS Fifties Exp Reg" pitchFamily="34" charset="-120"/>
               </a:rPr>
               <a:t>The 2026 Semiconductor Ecosystem | Slide 10</a:t>
             </a:r>
@@ -2747,9 +2747,9 @@
                 <a:solidFill>
                   <a:srgbClr val="B84A2F"/>
                 </a:solidFill>
-                <a:latin typeface="Bookman ITC Std" pitchFamily="34" charset="0"/>
-                <a:ea typeface="Bookman ITC Std" pitchFamily="34" charset="-122"/>
-                <a:cs typeface="Bookman ITC Std" pitchFamily="34" charset="-120"/>
+                <a:latin typeface="VVDS Fifties SCond Reg" pitchFamily="34" charset="0"/>
+                <a:ea typeface="VVDS Fifties SCond Reg" pitchFamily="34" charset="-122"/>
+                <a:cs typeface="VVDS Fifties SCond Reg" pitchFamily="34" charset="-120"/>
               </a:rPr>
               <a:t>Key Message: The response? Circular and Autonomous Supply Chains. We are using AI to 'self-heal' the supply chain.</a:t>
             </a:r>
@@ -2811,9 +2811,9 @@
                 <a:solidFill>
                   <a:srgbClr val="B84A2F"/>
                 </a:solidFill>
-                <a:latin typeface="PP Mondwest" pitchFamily="34" charset="0"/>
-                <a:ea typeface="PP Mondwest" pitchFamily="34" charset="-122"/>
-                <a:cs typeface="PP Mondwest" pitchFamily="34" charset="-120"/>
+                <a:latin typeface="VVDS Fifties SExp Reg" pitchFamily="34" charset="0"/>
+                <a:ea typeface="VVDS Fifties SExp Reg" pitchFamily="34" charset="-122"/>
+                <a:cs typeface="VVDS Fifties SExp Reg" pitchFamily="34" charset="-120"/>
               </a:rPr>
               <a:t>Deep Supply Mapping &amp; AI</a:t>
             </a:r>
@@ -2850,9 +2850,9 @@
                 <a:solidFill>
                   <a:srgbClr val="6B6560"/>
                 </a:solidFill>
-                <a:latin typeface="Bookman ITC Std" pitchFamily="34" charset="0"/>
-                <a:ea typeface="Bookman ITC Std" pitchFamily="34" charset="-122"/>
-                <a:cs typeface="Bookman ITC Std" pitchFamily="34" charset="-120"/>
+                <a:latin typeface="VVDS Fifties SCond Reg" pitchFamily="34" charset="0"/>
+                <a:ea typeface="VVDS Fifties SCond Reg" pitchFamily="34" charset="-122"/>
+                <a:cs typeface="VVDS Fifties SCond Reg" pitchFamily="34" charset="-120"/>
               </a:rPr>
               <a:t>Automatically re-routing orders when a port closes or a factory goes down. Mapping up to Tier-4 and Tier-5 suppliers.</a:t>
             </a:r>
@@ -2914,9 +2914,9 @@
                 <a:solidFill>
                   <a:srgbClr val="768C7C"/>
                 </a:solidFill>
-                <a:latin typeface="PP Mondwest" pitchFamily="34" charset="0"/>
-                <a:ea typeface="PP Mondwest" pitchFamily="34" charset="-122"/>
-                <a:cs typeface="PP Mondwest" pitchFamily="34" charset="-120"/>
+                <a:latin typeface="VVDS Fifties SExp Reg" pitchFamily="34" charset="0"/>
+                <a:ea typeface="VVDS Fifties SExp Reg" pitchFamily="34" charset="-122"/>
+                <a:cs typeface="VVDS Fifties SExp Reg" pitchFamily="34" charset="-120"/>
               </a:rPr>
               <a:t>Circular Reclamation</a:t>
             </a:r>
@@ -2953,9 +2953,9 @@
                 <a:solidFill>
                   <a:srgbClr val="6B6560"/>
                 </a:solidFill>
-                <a:latin typeface="Bookman ITC Std" pitchFamily="34" charset="0"/>
-                <a:ea typeface="Bookman ITC Std" pitchFamily="34" charset="-122"/>
-                <a:cs typeface="Bookman ITC Std" pitchFamily="34" charset="-120"/>
+                <a:latin typeface="VVDS Fifties SCond Reg" pitchFamily="34" charset="0"/>
+                <a:ea typeface="VVDS Fifties SCond Reg" pitchFamily="34" charset="-122"/>
+                <a:cs typeface="VVDS Fifties SCond Reg" pitchFamily="34" charset="-120"/>
               </a:rPr>
               <a:t>Mining the 'urban mine'—recovering rare earth elements from old electronics to reduce dependency on volatile mining regions.</a:t>
             </a:r>
@@ -3017,9 +3017,9 @@
                 <a:solidFill>
                   <a:srgbClr val="6B6560"/>
                 </a:solidFill>
-                <a:latin typeface="Bookman ITC Std" pitchFamily="34" charset="0"/>
-                <a:ea typeface="Bookman ITC Std" pitchFamily="34" charset="-122"/>
-                <a:cs typeface="Bookman ITC Std" pitchFamily="34" charset="-120"/>
+                <a:latin typeface="VVDS Fifties SCond Reg" pitchFamily="34" charset="0"/>
+                <a:ea typeface="VVDS Fifties SCond Reg" pitchFamily="34" charset="-122"/>
+                <a:cs typeface="VVDS Fifties SCond Reg" pitchFamily="34" charset="-120"/>
               </a:rPr>
               <a:t>Autonomous logistics systems automatically scan trade flows to reroute containers before bottleneck events cause line shutdowns.</a:t>
             </a:r>
@@ -3088,9 +3088,9 @@
                 <a:solidFill>
                   <a:srgbClr val="B84A2F"/>
                 </a:solidFill>
-                <a:latin typeface="Bookman ITC Std" pitchFamily="34" charset="0"/>
-                <a:ea typeface="Bookman ITC Std" pitchFamily="34" charset="-122"/>
-                <a:cs typeface="Bookman ITC Std" pitchFamily="34" charset="-120"/>
+                <a:latin typeface="VVDS Fifties Exp Reg" pitchFamily="34" charset="0"/>
+                <a:ea typeface="VVDS Fifties Exp Reg" pitchFamily="34" charset="-122"/>
+                <a:cs typeface="VVDS Fifties Exp Reg" pitchFamily="34" charset="-120"/>
               </a:rPr>
               <a:t>PART 3: END-USER INDUSTRIES &amp; APPLICATION ECOSYSTEM</a:t>
             </a:r>
@@ -3127,9 +3127,9 @@
                 <a:solidFill>
                   <a:srgbClr val="1A1714"/>
                 </a:solidFill>
-                <a:latin typeface="PP Mondwest" pitchFamily="34" charset="0"/>
-                <a:ea typeface="PP Mondwest" pitchFamily="34" charset="-122"/>
-                <a:cs typeface="PP Mondwest" pitchFamily="34" charset="-120"/>
+                <a:latin typeface="VVDS Fifties Exp SBold" pitchFamily="34" charset="0"/>
+                <a:ea typeface="VVDS Fifties Exp SBold" pitchFamily="34" charset="-122"/>
+                <a:cs typeface="VVDS Fifties Exp SBold" pitchFamily="34" charset="-120"/>
               </a:rPr>
               <a:t>The Ubiquity of Silicon: Powering the Modern World</a:t>
             </a:r>
@@ -3166,9 +3166,9 @@
                 <a:solidFill>
                   <a:srgbClr val="6B6560"/>
                 </a:solidFill>
-                <a:latin typeface="Bookman ITC Std" pitchFamily="34" charset="0"/>
-                <a:ea typeface="Bookman ITC Std" pitchFamily="34" charset="-122"/>
-                <a:cs typeface="Bookman ITC Std" pitchFamily="34" charset="-120"/>
+                <a:latin typeface="VVDS Fifties Exp Reg" pitchFamily="34" charset="0"/>
+                <a:ea typeface="VVDS Fifties Exp Reg" pitchFamily="34" charset="-122"/>
+                <a:cs typeface="VVDS Fifties Exp Reg" pitchFamily="34" charset="-120"/>
               </a:rPr>
               <a:t>The 2026 Semiconductor Ecosystem | Slide 11</a:t>
             </a:r>
@@ -3230,9 +3230,9 @@
                 <a:solidFill>
                   <a:srgbClr val="9E7D84"/>
                 </a:solidFill>
-                <a:latin typeface="Bookman ITC Std" pitchFamily="34" charset="0"/>
-                <a:ea typeface="Bookman ITC Std" pitchFamily="34" charset="-122"/>
-                <a:cs typeface="Bookman ITC Std" pitchFamily="34" charset="-120"/>
+                <a:latin typeface="VVDS Fifties SCond Reg" pitchFamily="34" charset="0"/>
+                <a:ea typeface="VVDS Fifties SCond Reg" pitchFamily="34" charset="-122"/>
+                <a:cs typeface="VVDS Fifties SCond Reg" pitchFamily="34" charset="-120"/>
               </a:rPr>
               <a:t>Key Message: Semiconductors are the "nerve system" of the global economy; no modern industry can function without them.</a:t>
             </a:r>
@@ -3270,9 +3270,9 @@
                 <a:solidFill>
                   <a:srgbClr val="6B6560"/>
                 </a:solidFill>
-                <a:latin typeface="Bookman ITC Std" pitchFamily="34" charset="0"/>
-                <a:ea typeface="Bookman ITC Std" pitchFamily="34" charset="-122"/>
-                <a:cs typeface="Bookman ITC Std" pitchFamily="34" charset="-120"/>
+                <a:latin typeface="VVDS Fifties SCond Reg" pitchFamily="34" charset="0"/>
+                <a:ea typeface="VVDS Fifties SCond Reg" pitchFamily="34" charset="-122"/>
+                <a:cs typeface="VVDS Fifties SCond Reg" pitchFamily="34" charset="-120"/>
               </a:rPr>
               <a:t>- Central Nerve System: Microchips control the storage, routing, and processing of every piece of data globally.</a:t>
             </a:r>
@@ -3295,9 +3295,9 @@
                 <a:solidFill>
                   <a:srgbClr val="6B6560"/>
                 </a:solidFill>
-                <a:latin typeface="Bookman ITC Std" pitchFamily="34" charset="0"/>
-                <a:ea typeface="Bookman ITC Std" pitchFamily="34" charset="-122"/>
-                <a:cs typeface="Bookman ITC Std" pitchFamily="34" charset="-120"/>
+                <a:latin typeface="VVDS Fifties SCond Reg" pitchFamily="34" charset="0"/>
+                <a:ea typeface="VVDS Fifties SCond Reg" pitchFamily="34" charset="-122"/>
+                <a:cs typeface="VVDS Fifties SCond Reg" pitchFamily="34" charset="-120"/>
               </a:rPr>
               <a:t>- Silicon Intensity Metric: The total value of silicon content per product is the primary metric of industrial scaling.</a:t>
             </a:r>
@@ -3320,9 +3320,9 @@
                 <a:solidFill>
                   <a:srgbClr val="6B6560"/>
                 </a:solidFill>
-                <a:latin typeface="Bookman ITC Std" pitchFamily="34" charset="0"/>
-                <a:ea typeface="Bookman ITC Std" pitchFamily="34" charset="-122"/>
-                <a:cs typeface="Bookman ITC Std" pitchFamily="34" charset="-120"/>
+                <a:latin typeface="VVDS Fifties SCond Reg" pitchFamily="34" charset="0"/>
+                <a:ea typeface="VVDS Fifties SCond Reg" pitchFamily="34" charset="-122"/>
+                <a:cs typeface="VVDS Fifties SCond Reg" pitchFamily="34" charset="-120"/>
               </a:rPr>
               <a:t>- Ubiquitous Integration: Foundational logic layers power smart municipal grids, medical machinery, and neural processors.</a:t>
             </a:r>
@@ -3384,9 +3384,9 @@
                 <a:solidFill>
                   <a:srgbClr val="9E7D84"/>
                 </a:solidFill>
-                <a:latin typeface="Bookman ITC Std" pitchFamily="34" charset="0"/>
-                <a:ea typeface="Bookman ITC Std" pitchFamily="34" charset="-122"/>
-                <a:cs typeface="Bookman ITC Std" pitchFamily="34" charset="-120"/>
+                <a:latin typeface="VVDS Fifties Exp Reg" pitchFamily="34" charset="0"/>
+                <a:ea typeface="VVDS Fifties Exp Reg" pitchFamily="34" charset="-122"/>
+                <a:cs typeface="VVDS Fifties Exp Reg" pitchFamily="34" charset="-120"/>
               </a:rPr>
               <a:t>KEY METRIC</a:t>
             </a:r>
@@ -3423,9 +3423,9 @@
                 <a:solidFill>
                   <a:srgbClr val="1A1714"/>
                 </a:solidFill>
-                <a:latin typeface="PP Mondwest" pitchFamily="34" charset="0"/>
-                <a:ea typeface="PP Mondwest" pitchFamily="34" charset="-122"/>
-                <a:cs typeface="PP Mondwest" pitchFamily="34" charset="-120"/>
+                <a:latin typeface="VVDS Fifties Exp SBold" pitchFamily="34" charset="0"/>
+                <a:ea typeface="VVDS Fifties Exp SBold" pitchFamily="34" charset="-122"/>
+                <a:cs typeface="VVDS Fifties Exp SBold" pitchFamily="34" charset="-120"/>
               </a:rPr>
               <a:t>Silicon</a:t>
             </a:r>
@@ -3440,9 +3440,9 @@
                 <a:solidFill>
                   <a:srgbClr val="1A1714"/>
                 </a:solidFill>
-                <a:latin typeface="PP Mondwest" pitchFamily="34" charset="0"/>
-                <a:ea typeface="PP Mondwest" pitchFamily="34" charset="-122"/>
-                <a:cs typeface="PP Mondwest" pitchFamily="34" charset="-120"/>
+                <a:latin typeface="VVDS Fifties Exp SBold" pitchFamily="34" charset="0"/>
+                <a:ea typeface="VVDS Fifties Exp SBold" pitchFamily="34" charset="-122"/>
+                <a:cs typeface="VVDS Fifties Exp SBold" pitchFamily="34" charset="-120"/>
               </a:rPr>
               <a:t>Intensity</a:t>
             </a:r>
@@ -3479,9 +3479,9 @@
                 <a:solidFill>
                   <a:srgbClr val="6B6560"/>
                 </a:solidFill>
-                <a:latin typeface="Bookman ITC Std" pitchFamily="34" charset="0"/>
-                <a:ea typeface="Bookman ITC Std" pitchFamily="34" charset="-122"/>
-                <a:cs typeface="Bookman ITC Std" pitchFamily="34" charset="-120"/>
+                <a:latin typeface="VVDS Fifties SCond Reg" pitchFamily="34" charset="0"/>
+                <a:ea typeface="VVDS Fifties SCond Reg" pitchFamily="34" charset="-122"/>
+                <a:cs typeface="VVDS Fifties SCond Reg" pitchFamily="34" charset="-120"/>
               </a:rPr>
               <a:t>Primary industrial competitiveness index</a:t>
             </a:r>
@@ -3550,9 +3550,9 @@
                 <a:solidFill>
                   <a:srgbClr val="B84A2F"/>
                 </a:solidFill>
-                <a:latin typeface="Bookman ITC Std" pitchFamily="34" charset="0"/>
-                <a:ea typeface="Bookman ITC Std" pitchFamily="34" charset="-122"/>
-                <a:cs typeface="Bookman ITC Std" pitchFamily="34" charset="-120"/>
+                <a:latin typeface="VVDS Fifties Exp Reg" pitchFamily="34" charset="0"/>
+                <a:ea typeface="VVDS Fifties Exp Reg" pitchFamily="34" charset="-122"/>
+                <a:cs typeface="VVDS Fifties Exp Reg" pitchFamily="34" charset="-120"/>
               </a:rPr>
               <a:t>PART 3: END-USER INDUSTRIES &amp; APPLICATION ECOSYSTEM</a:t>
             </a:r>
@@ -3589,9 +3589,9 @@
                 <a:solidFill>
                   <a:srgbClr val="1A1714"/>
                 </a:solidFill>
-                <a:latin typeface="PP Mondwest" pitchFamily="34" charset="0"/>
-                <a:ea typeface="PP Mondwest" pitchFamily="34" charset="-122"/>
-                <a:cs typeface="PP Mondwest" pitchFamily="34" charset="-120"/>
+                <a:latin typeface="VVDS Fifties Exp SBold" pitchFamily="34" charset="0"/>
+                <a:ea typeface="VVDS Fifties Exp SBold" pitchFamily="34" charset="-122"/>
+                <a:cs typeface="VVDS Fifties Exp SBold" pitchFamily="34" charset="-120"/>
               </a:rPr>
               <a:t>Executive Summary: The Demand Landscape in 2026</a:t>
             </a:r>
@@ -3628,9 +3628,9 @@
                 <a:solidFill>
                   <a:srgbClr val="6B6560"/>
                 </a:solidFill>
-                <a:latin typeface="Bookman ITC Std" pitchFamily="34" charset="0"/>
-                <a:ea typeface="Bookman ITC Std" pitchFamily="34" charset="-122"/>
-                <a:cs typeface="Bookman ITC Std" pitchFamily="34" charset="-120"/>
+                <a:latin typeface="VVDS Fifties Exp Reg" pitchFamily="34" charset="0"/>
+                <a:ea typeface="VVDS Fifties Exp Reg" pitchFamily="34" charset="-122"/>
+                <a:cs typeface="VVDS Fifties Exp Reg" pitchFamily="34" charset="-120"/>
               </a:rPr>
               <a:t>The 2026 Semiconductor Ecosystem | Slide 12</a:t>
             </a:r>
@@ -3692,9 +3692,9 @@
                 <a:solidFill>
                   <a:srgbClr val="B84A2F"/>
                 </a:solidFill>
-                <a:latin typeface="Bookman ITC Std" pitchFamily="34" charset="0"/>
-                <a:ea typeface="Bookman ITC Std" pitchFamily="34" charset="-122"/>
-                <a:cs typeface="Bookman ITC Std" pitchFamily="34" charset="-120"/>
+                <a:latin typeface="VVDS Fifties SCond Reg" pitchFamily="34" charset="0"/>
+                <a:ea typeface="VVDS Fifties SCond Reg" pitchFamily="34" charset="-122"/>
+                <a:cs typeface="VVDS Fifties SCond Reg" pitchFamily="34" charset="-120"/>
               </a:rPr>
               <a:t>Key Message: Demand is shifting from traditional computing toward AI infrastructure, Automotive, and Industrial Automation.</a:t>
             </a:r>
@@ -3756,9 +3756,9 @@
                 <a:solidFill>
                   <a:srgbClr val="B84A2F"/>
                 </a:solidFill>
-                <a:latin typeface="PP Mondwest" pitchFamily="34" charset="0"/>
-                <a:ea typeface="PP Mondwest" pitchFamily="34" charset="-122"/>
-                <a:cs typeface="PP Mondwest" pitchFamily="34" charset="-120"/>
+                <a:latin typeface="VVDS Fifties SExp Reg" pitchFamily="34" charset="0"/>
+                <a:ea typeface="VVDS Fifties SExp Reg" pitchFamily="34" charset="-122"/>
+                <a:cs typeface="VVDS Fifties SExp Reg" pitchFamily="34" charset="-120"/>
               </a:rPr>
               <a:t>AI Datacenters</a:t>
             </a:r>
@@ -3795,9 +3795,9 @@
                 <a:solidFill>
                   <a:srgbClr val="6B6560"/>
                 </a:solidFill>
-                <a:latin typeface="Bookman ITC Std" pitchFamily="34" charset="0"/>
-                <a:ea typeface="Bookman ITC Std" pitchFamily="34" charset="-122"/>
-                <a:cs typeface="Bookman ITC Std" pitchFamily="34" charset="-120"/>
+                <a:latin typeface="VVDS Fifties SCond Reg" pitchFamily="34" charset="0"/>
+                <a:ea typeface="VVDS Fifties SCond Reg" pitchFamily="34" charset="-122"/>
+                <a:cs typeface="VVDS Fifties SCond Reg" pitchFamily="34" charset="-120"/>
               </a:rPr>
               <a:t>Nearly 50% of semiconductor industry growth and revenue is driven by high-performance AI accelerators.</a:t>
             </a:r>
@@ -3859,9 +3859,9 @@
                 <a:solidFill>
                   <a:srgbClr val="9E7D84"/>
                 </a:solidFill>
-                <a:latin typeface="PP Mondwest" pitchFamily="34" charset="0"/>
-                <a:ea typeface="PP Mondwest" pitchFamily="34" charset="-122"/>
-                <a:cs typeface="PP Mondwest" pitchFamily="34" charset="-120"/>
+                <a:latin typeface="VVDS Fifties SExp Reg" pitchFamily="34" charset="0"/>
+                <a:ea typeface="VVDS Fifties SExp Reg" pitchFamily="34" charset="-122"/>
+                <a:cs typeface="VVDS Fifties SExp Reg" pitchFamily="34" charset="-120"/>
               </a:rPr>
               <a:t>Automotive</a:t>
             </a:r>
@@ -3898,9 +3898,9 @@
                 <a:solidFill>
                   <a:srgbClr val="6B6560"/>
                 </a:solidFill>
-                <a:latin typeface="Bookman ITC Std" pitchFamily="34" charset="0"/>
-                <a:ea typeface="Bookman ITC Std" pitchFamily="34" charset="-122"/>
-                <a:cs typeface="Bookman ITC Std" pitchFamily="34" charset="-120"/>
+                <a:latin typeface="VVDS Fifties SCond Reg" pitchFamily="34" charset="0"/>
+                <a:ea typeface="VVDS Fifties SCond Reg" pitchFamily="34" charset="-122"/>
+                <a:cs typeface="VVDS Fifties SCond Reg" pitchFamily="34" charset="-120"/>
               </a:rPr>
               <a:t>The fastest growing volume segment, requiring massive numbers of legacy control nodes and SiC power chips.</a:t>
             </a:r>
@@ -3962,9 +3962,9 @@
                 <a:solidFill>
                   <a:srgbClr val="768C7C"/>
                 </a:solidFill>
-                <a:latin typeface="PP Mondwest" pitchFamily="34" charset="0"/>
-                <a:ea typeface="PP Mondwest" pitchFamily="34" charset="-122"/>
-                <a:cs typeface="PP Mondwest" pitchFamily="34" charset="-120"/>
+                <a:latin typeface="VVDS Fifties SExp Reg" pitchFamily="34" charset="0"/>
+                <a:ea typeface="VVDS Fifties SExp Reg" pitchFamily="34" charset="-122"/>
+                <a:cs typeface="VVDS Fifties SExp Reg" pitchFamily="34" charset="-120"/>
               </a:rPr>
               <a:t>Smartphones &amp; PCs</a:t>
             </a:r>
@@ -4001,9 +4001,9 @@
                 <a:solidFill>
                   <a:srgbClr val="6B6560"/>
                 </a:solidFill>
-                <a:latin typeface="Bookman ITC Std" pitchFamily="34" charset="0"/>
-                <a:ea typeface="Bookman ITC Std" pitchFamily="34" charset="-122"/>
-                <a:cs typeface="Bookman ITC Std" pitchFamily="34" charset="-120"/>
+                <a:latin typeface="VVDS Fifties SCond Reg" pitchFamily="34" charset="0"/>
+                <a:ea typeface="VVDS Fifties SCond Reg" pitchFamily="34" charset="-122"/>
+                <a:cs typeface="VVDS Fifties SCond Reg" pitchFamily="34" charset="-120"/>
               </a:rPr>
               <a:t>Traditional core segments face volume saturation, driving consolidation and focus on specialized edge accelerators.</a:t>
             </a:r>
@@ -4072,9 +4072,9 @@
                 <a:solidFill>
                   <a:srgbClr val="B84A2F"/>
                 </a:solidFill>
-                <a:latin typeface="Bookman ITC Std" pitchFamily="34" charset="0"/>
-                <a:ea typeface="Bookman ITC Std" pitchFamily="34" charset="-122"/>
-                <a:cs typeface="Bookman ITC Std" pitchFamily="34" charset="-120"/>
+                <a:latin typeface="VVDS Fifties Exp Reg" pitchFamily="34" charset="0"/>
+                <a:ea typeface="VVDS Fifties Exp Reg" pitchFamily="34" charset="-122"/>
+                <a:cs typeface="VVDS Fifties Exp Reg" pitchFamily="34" charset="-120"/>
               </a:rPr>
               <a:t>PART 3: END-USER INDUSTRIES &amp; APPLICATION ECOSYSTEM</a:t>
             </a:r>
@@ -4111,9 +4111,9 @@
                 <a:solidFill>
                   <a:srgbClr val="1A1714"/>
                 </a:solidFill>
-                <a:latin typeface="PP Mondwest" pitchFamily="34" charset="0"/>
-                <a:ea typeface="PP Mondwest" pitchFamily="34" charset="-122"/>
-                <a:cs typeface="PP Mondwest" pitchFamily="34" charset="-120"/>
+                <a:latin typeface="VVDS Fifties Exp SBold" pitchFamily="34" charset="0"/>
+                <a:ea typeface="VVDS Fifties Exp SBold" pitchFamily="34" charset="-122"/>
+                <a:cs typeface="VVDS Fifties Exp SBold" pitchFamily="34" charset="-120"/>
               </a:rPr>
               <a:t>AI &amp; Data Centers: The Generative Revolution</a:t>
             </a:r>
@@ -4150,9 +4150,9 @@
                 <a:solidFill>
                   <a:srgbClr val="6B6560"/>
                 </a:solidFill>
-                <a:latin typeface="Bookman ITC Std" pitchFamily="34" charset="0"/>
-                <a:ea typeface="Bookman ITC Std" pitchFamily="34" charset="-122"/>
-                <a:cs typeface="Bookman ITC Std" pitchFamily="34" charset="-120"/>
+                <a:latin typeface="VVDS Fifties Exp Reg" pitchFamily="34" charset="0"/>
+                <a:ea typeface="VVDS Fifties Exp Reg" pitchFamily="34" charset="-122"/>
+                <a:cs typeface="VVDS Fifties Exp Reg" pitchFamily="34" charset="-120"/>
               </a:rPr>
               <a:t>The 2026 Semiconductor Ecosystem | Slide 13</a:t>
             </a:r>
@@ -4214,9 +4214,9 @@
                 <a:solidFill>
                   <a:srgbClr val="768C7C"/>
                 </a:solidFill>
-                <a:latin typeface="Bookman ITC Std" pitchFamily="34" charset="0"/>
-                <a:ea typeface="Bookman ITC Std" pitchFamily="34" charset="-122"/>
-                <a:cs typeface="Bookman ITC Std" pitchFamily="34" charset="-120"/>
+                <a:latin typeface="VVDS Fifties SCond Reg" pitchFamily="34" charset="0"/>
+                <a:ea typeface="VVDS Fifties SCond Reg" pitchFamily="34" charset="-122"/>
+                <a:cs typeface="VVDS Fifties SCond Reg" pitchFamily="34" charset="-120"/>
               </a:rPr>
               <a:t>Key Message: Data centers have evolved into "Intelligence Engines," consuming the highest-value silicon ever produced.</a:t>
             </a:r>
@@ -4254,9 +4254,9 @@
                 <a:solidFill>
                   <a:srgbClr val="6B6560"/>
                 </a:solidFill>
-                <a:latin typeface="Bookman ITC Std" pitchFamily="34" charset="0"/>
-                <a:ea typeface="Bookman ITC Std" pitchFamily="34" charset="-122"/>
-                <a:cs typeface="Bookman ITC Std" pitchFamily="34" charset="-120"/>
+                <a:latin typeface="VVDS Fifties SCond Reg" pitchFamily="34" charset="0"/>
+                <a:ea typeface="VVDS Fifties SCond Reg" pitchFamily="34" charset="-122"/>
+                <a:cs typeface="VVDS Fifties SCond Reg" pitchFamily="34" charset="-120"/>
               </a:rPr>
               <a:t>- Accelerator Market ($500B): Generative models and neural computing demand massive scaling of TPU and GPU nodes.</a:t>
             </a:r>
@@ -4279,9 +4279,9 @@
                 <a:solidFill>
                   <a:srgbClr val="6B6560"/>
                 </a:solidFill>
-                <a:latin typeface="Bookman ITC Std" pitchFamily="34" charset="0"/>
-                <a:ea typeface="Bookman ITC Std" pitchFamily="34" charset="-122"/>
-                <a:cs typeface="Bookman ITC Std" pitchFamily="34" charset="-120"/>
+                <a:latin typeface="VVDS Fifties SCond Reg" pitchFamily="34" charset="0"/>
+                <a:ea typeface="VVDS Fifties SCond Reg" pitchFamily="34" charset="-122"/>
+                <a:cs typeface="VVDS Fifties SCond Reg" pitchFamily="34" charset="-120"/>
               </a:rPr>
               <a:t>- Sub-3nm Node Sourcing: The primary consumers of the most advanced wafer print architectures globally.</a:t>
             </a:r>
@@ -4304,9 +4304,9 @@
                 <a:solidFill>
                   <a:srgbClr val="6B6560"/>
                 </a:solidFill>
-                <a:latin typeface="Bookman ITC Std" pitchFamily="34" charset="0"/>
-                <a:ea typeface="Bookman ITC Std" pitchFamily="34" charset="-122"/>
-                <a:cs typeface="Bookman ITC Std" pitchFamily="34" charset="-120"/>
+                <a:latin typeface="VVDS Fifties SCond Reg" pitchFamily="34" charset="0"/>
+                <a:ea typeface="VVDS Fifties SCond Reg" pitchFamily="34" charset="-122"/>
+                <a:cs typeface="VVDS Fifties SCond Reg" pitchFamily="34" charset="-120"/>
               </a:rPr>
               <a:t>- Memory &amp; Interconnect: Demands extreme density of High Bandwidth Memory (HBM) and customized routing interconnect silicon.</a:t>
             </a:r>
@@ -4368,9 +4368,9 @@
                 <a:solidFill>
                   <a:srgbClr val="768C7C"/>
                 </a:solidFill>
-                <a:latin typeface="Bookman ITC Std" pitchFamily="34" charset="0"/>
-                <a:ea typeface="Bookman ITC Std" pitchFamily="34" charset="-122"/>
-                <a:cs typeface="Bookman ITC Std" pitchFamily="34" charset="-120"/>
+                <a:latin typeface="VVDS Fifties Exp Reg" pitchFamily="34" charset="0"/>
+                <a:ea typeface="VVDS Fifties Exp Reg" pitchFamily="34" charset="-122"/>
+                <a:cs typeface="VVDS Fifties Exp Reg" pitchFamily="34" charset="-120"/>
               </a:rPr>
               <a:t>ANALYST PROJECT</a:t>
             </a:r>
@@ -4407,9 +4407,9 @@
                 <a:solidFill>
                   <a:srgbClr val="1A1714"/>
                 </a:solidFill>
-                <a:latin typeface="PP Mondwest" pitchFamily="34" charset="0"/>
-                <a:ea typeface="PP Mondwest" pitchFamily="34" charset="-122"/>
-                <a:cs typeface="PP Mondwest" pitchFamily="34" charset="-120"/>
+                <a:latin typeface="VVDS Fifties Exp SBold" pitchFamily="34" charset="0"/>
+                <a:ea typeface="VVDS Fifties Exp SBold" pitchFamily="34" charset="-122"/>
+                <a:cs typeface="VVDS Fifties Exp SBold" pitchFamily="34" charset="-120"/>
               </a:rPr>
               <a:t>$500B</a:t>
             </a:r>
@@ -4446,9 +4446,9 @@
                 <a:solidFill>
                   <a:srgbClr val="6B6560"/>
                 </a:solidFill>
-                <a:latin typeface="Bookman ITC Std" pitchFamily="34" charset="0"/>
-                <a:ea typeface="Bookman ITC Std" pitchFamily="34" charset="-122"/>
-                <a:cs typeface="Bookman ITC Std" pitchFamily="34" charset="-120"/>
+                <a:latin typeface="VVDS Fifties SCond Reg" pitchFamily="34" charset="0"/>
+                <a:ea typeface="VVDS Fifties SCond Reg" pitchFamily="34" charset="-122"/>
+                <a:cs typeface="VVDS Fifties SCond Reg" pitchFamily="34" charset="-120"/>
               </a:rPr>
               <a:t>AI Accelerator market size by 2026</a:t>
             </a:r>
@@ -4517,9 +4517,9 @@
                 <a:solidFill>
                   <a:srgbClr val="B84A2F"/>
                 </a:solidFill>
-                <a:latin typeface="Bookman ITC Std" pitchFamily="34" charset="0"/>
-                <a:ea typeface="Bookman ITC Std" pitchFamily="34" charset="-122"/>
-                <a:cs typeface="Bookman ITC Std" pitchFamily="34" charset="-120"/>
+                <a:latin typeface="VVDS Fifties Exp Reg" pitchFamily="34" charset="0"/>
+                <a:ea typeface="VVDS Fifties Exp Reg" pitchFamily="34" charset="-122"/>
+                <a:cs typeface="VVDS Fifties Exp Reg" pitchFamily="34" charset="-120"/>
               </a:rPr>
               <a:t>PART 3: END-USER INDUSTRIES &amp; APPLICATION ECOSYSTEM</a:t>
             </a:r>
@@ -4556,9 +4556,9 @@
                 <a:solidFill>
                   <a:srgbClr val="1A1714"/>
                 </a:solidFill>
-                <a:latin typeface="PP Mondwest" pitchFamily="34" charset="0"/>
-                <a:ea typeface="PP Mondwest" pitchFamily="34" charset="-122"/>
-                <a:cs typeface="PP Mondwest" pitchFamily="34" charset="-120"/>
+                <a:latin typeface="VVDS Fifties Exp SBold" pitchFamily="34" charset="0"/>
+                <a:ea typeface="VVDS Fifties Exp SBold" pitchFamily="34" charset="-122"/>
+                <a:cs typeface="VVDS Fifties Exp SBold" pitchFamily="34" charset="-120"/>
               </a:rPr>
               <a:t>Automotive: The "Smartphone on Wheels"</a:t>
             </a:r>
@@ -4595,9 +4595,9 @@
                 <a:solidFill>
                   <a:srgbClr val="6B6560"/>
                 </a:solidFill>
-                <a:latin typeface="Bookman ITC Std" pitchFamily="34" charset="0"/>
-                <a:ea typeface="Bookman ITC Std" pitchFamily="34" charset="-122"/>
-                <a:cs typeface="Bookman ITC Std" pitchFamily="34" charset="-120"/>
+                <a:latin typeface="VVDS Fifties Exp Reg" pitchFamily="34" charset="0"/>
+                <a:ea typeface="VVDS Fifties Exp Reg" pitchFamily="34" charset="-122"/>
+                <a:cs typeface="VVDS Fifties Exp Reg" pitchFamily="34" charset="-120"/>
               </a:rPr>
               <a:t>The 2026 Semiconductor Ecosystem | Slide 14</a:t>
             </a:r>
@@ -4659,9 +4659,9 @@
                 <a:solidFill>
                   <a:srgbClr val="B84A2F"/>
                 </a:solidFill>
-                <a:latin typeface="Bookman ITC Std" pitchFamily="34" charset="0"/>
-                <a:ea typeface="Bookman ITC Std" pitchFamily="34" charset="-122"/>
-                <a:cs typeface="Bookman ITC Std" pitchFamily="34" charset="-120"/>
+                <a:latin typeface="VVDS Fifties SCond Reg" pitchFamily="34" charset="0"/>
+                <a:ea typeface="VVDS Fifties SCond Reg" pitchFamily="34" charset="-122"/>
+                <a:cs typeface="VVDS Fifties SCond Reg" pitchFamily="34" charset="-120"/>
               </a:rPr>
               <a:t>Key Message: The transition to EVs and ADAS is doubling semiconductor content per vehicle, reaching over $1,000 per unit.</a:t>
             </a:r>
@@ -4699,9 +4699,9 @@
                 <a:solidFill>
                   <a:srgbClr val="6B6560"/>
                 </a:solidFill>
-                <a:latin typeface="Bookman ITC Std" pitchFamily="34" charset="0"/>
-                <a:ea typeface="Bookman ITC Std" pitchFamily="34" charset="-122"/>
-                <a:cs typeface="Bookman ITC Std" pitchFamily="34" charset="-120"/>
+                <a:latin typeface="VVDS Fifties SCond Reg" pitchFamily="34" charset="0"/>
+                <a:ea typeface="VVDS Fifties SCond Reg" pitchFamily="34" charset="-122"/>
+                <a:cs typeface="VVDS Fifties SCond Reg" pitchFamily="34" charset="-120"/>
               </a:rPr>
               <a:t>- Silicon Carbide (SiC) Power: Drives high-efficiency power switches in high-voltage EV battery platforms.</a:t>
             </a:r>
@@ -4724,9 +4724,9 @@
                 <a:solidFill>
                   <a:srgbClr val="6B6560"/>
                 </a:solidFill>
-                <a:latin typeface="Bookman ITC Std" pitchFamily="34" charset="0"/>
-                <a:ea typeface="Bookman ITC Std" pitchFamily="34" charset="-122"/>
-                <a:cs typeface="Bookman ITC Std" pitchFamily="34" charset="-120"/>
+                <a:latin typeface="VVDS Fifties SCond Reg" pitchFamily="34" charset="0"/>
+                <a:ea typeface="VVDS Fifties SCond Reg" pitchFamily="34" charset="-122"/>
+                <a:cs typeface="VVDS Fifties SCond Reg" pitchFamily="34" charset="-120"/>
               </a:rPr>
               <a:t>- ADAS Autonomous Compute: Self-driving capabilities demand heavy on-board computational units for sensor fusion.</a:t>
             </a:r>
@@ -4749,9 +4749,9 @@
                 <a:solidFill>
                   <a:srgbClr val="6B6560"/>
                 </a:solidFill>
-                <a:latin typeface="Bookman ITC Std" pitchFamily="34" charset="0"/>
-                <a:ea typeface="Bookman ITC Std" pitchFamily="34" charset="-122"/>
-                <a:cs typeface="Bookman ITC Std" pitchFamily="34" charset="-120"/>
+                <a:latin typeface="VVDS Fifties SCond Reg" pitchFamily="34" charset="0"/>
+                <a:ea typeface="VVDS Fifties SCond Reg" pitchFamily="34" charset="-122"/>
+                <a:cs typeface="VVDS Fifties SCond Reg" pitchFamily="34" charset="-120"/>
               </a:rPr>
               <a:t>- Sensor Arrays Sourcing: Vehicles integrate multiple LiDAR, radar, and camera chip sets for 360-degree coverage.</a:t>
             </a:r>
@@ -4813,9 +4813,9 @@
                 <a:solidFill>
                   <a:srgbClr val="B84A2F"/>
                 </a:solidFill>
-                <a:latin typeface="Bookman ITC Std" pitchFamily="34" charset="0"/>
-                <a:ea typeface="Bookman ITC Std" pitchFamily="34" charset="-122"/>
-                <a:cs typeface="Bookman ITC Std" pitchFamily="34" charset="-120"/>
+                <a:latin typeface="VVDS Fifties Exp Reg" pitchFamily="34" charset="0"/>
+                <a:ea typeface="VVDS Fifties Exp Reg" pitchFamily="34" charset="-122"/>
+                <a:cs typeface="VVDS Fifties Exp Reg" pitchFamily="34" charset="-120"/>
               </a:rPr>
               <a:t>ESTIMATE</a:t>
             </a:r>
@@ -4852,9 +4852,9 @@
                 <a:solidFill>
                   <a:srgbClr val="1A1714"/>
                 </a:solidFill>
-                <a:latin typeface="PP Mondwest" pitchFamily="34" charset="0"/>
-                <a:ea typeface="PP Mondwest" pitchFamily="34" charset="-122"/>
-                <a:cs typeface="PP Mondwest" pitchFamily="34" charset="-120"/>
+                <a:latin typeface="VVDS Fifties Exp SBold" pitchFamily="34" charset="0"/>
+                <a:ea typeface="VVDS Fifties Exp SBold" pitchFamily="34" charset="-122"/>
+                <a:cs typeface="VVDS Fifties Exp SBold" pitchFamily="34" charset="-120"/>
               </a:rPr>
               <a:t>$1,000+</a:t>
             </a:r>
@@ -4891,9 +4891,9 @@
                 <a:solidFill>
                   <a:srgbClr val="6B6560"/>
                 </a:solidFill>
-                <a:latin typeface="Bookman ITC Std" pitchFamily="34" charset="0"/>
-                <a:ea typeface="Bookman ITC Std" pitchFamily="34" charset="-122"/>
-                <a:cs typeface="Bookman ITC Std" pitchFamily="34" charset="-120"/>
+                <a:latin typeface="VVDS Fifties SCond Reg" pitchFamily="34" charset="0"/>
+                <a:ea typeface="VVDS Fifties SCond Reg" pitchFamily="34" charset="-122"/>
+                <a:cs typeface="VVDS Fifties SCond Reg" pitchFamily="34" charset="-120"/>
               </a:rPr>
               <a:t>Silicon value content per EV unit</a:t>
             </a:r>
@@ -4962,9 +4962,9 @@
                 <a:solidFill>
                   <a:srgbClr val="B84A2F"/>
                 </a:solidFill>
-                <a:latin typeface="Bookman ITC Std" pitchFamily="34" charset="0"/>
-                <a:ea typeface="Bookman ITC Std" pitchFamily="34" charset="-122"/>
-                <a:cs typeface="Bookman ITC Std" pitchFamily="34" charset="-120"/>
+                <a:latin typeface="VVDS Fifties Exp Reg" pitchFamily="34" charset="0"/>
+                <a:ea typeface="VVDS Fifties Exp Reg" pitchFamily="34" charset="-122"/>
+                <a:cs typeface="VVDS Fifties Exp Reg" pitchFamily="34" charset="-120"/>
               </a:rPr>
               <a:t>PART 3: END-USER INDUSTRIES &amp; APPLICATION ECOSYSTEM</a:t>
             </a:r>
@@ -5001,9 +5001,9 @@
                 <a:solidFill>
                   <a:srgbClr val="1A1714"/>
                 </a:solidFill>
-                <a:latin typeface="PP Mondwest" pitchFamily="34" charset="0"/>
-                <a:ea typeface="PP Mondwest" pitchFamily="34" charset="-122"/>
-                <a:cs typeface="PP Mondwest" pitchFamily="34" charset="-120"/>
+                <a:latin typeface="VVDS Fifties Exp SBold" pitchFamily="34" charset="0"/>
+                <a:ea typeface="VVDS Fifties Exp SBold" pitchFamily="34" charset="-122"/>
+                <a:cs typeface="VVDS Fifties Exp SBold" pitchFamily="34" charset="-120"/>
               </a:rPr>
               <a:t>Industrial, IoT &amp; Healthcare: Intelligence at the Edge</a:t>
             </a:r>
@@ -5040,9 +5040,9 @@
                 <a:solidFill>
                   <a:srgbClr val="6B6560"/>
                 </a:solidFill>
-                <a:latin typeface="Bookman ITC Std" pitchFamily="34" charset="0"/>
-                <a:ea typeface="Bookman ITC Std" pitchFamily="34" charset="-122"/>
-                <a:cs typeface="Bookman ITC Std" pitchFamily="34" charset="-120"/>
+                <a:latin typeface="VVDS Fifties Exp Reg" pitchFamily="34" charset="0"/>
+                <a:ea typeface="VVDS Fifties Exp Reg" pitchFamily="34" charset="-122"/>
+                <a:cs typeface="VVDS Fifties Exp Reg" pitchFamily="34" charset="-120"/>
               </a:rPr>
               <a:t>The 2026 Semiconductor Ecosystem | Slide 15</a:t>
             </a:r>
@@ -5104,9 +5104,9 @@
                 <a:solidFill>
                   <a:srgbClr val="9E7D84"/>
                 </a:solidFill>
-                <a:latin typeface="Bookman ITC Std" pitchFamily="34" charset="0"/>
-                <a:ea typeface="Bookman ITC Std" pitchFamily="34" charset="-122"/>
-                <a:cs typeface="Bookman ITC Std" pitchFamily="34" charset="-120"/>
+                <a:latin typeface="VVDS Fifties SCond Reg" pitchFamily="34" charset="0"/>
+                <a:ea typeface="VVDS Fifties SCond Reg" pitchFamily="34" charset="-122"/>
+                <a:cs typeface="VVDS Fifties SCond Reg" pitchFamily="34" charset="-120"/>
               </a:rPr>
               <a:t>Key Message: Edge AI is transforming manufacturing and healthcare, prioritizing long-lifecycle, high-reliability silicon.</a:t>
             </a:r>
@@ -5168,9 +5168,9 @@
                 <a:solidFill>
                   <a:srgbClr val="9E7D84"/>
                 </a:solidFill>
-                <a:latin typeface="PP Mondwest" pitchFamily="34" charset="0"/>
-                <a:ea typeface="PP Mondwest" pitchFamily="34" charset="-122"/>
-                <a:cs typeface="PP Mondwest" pitchFamily="34" charset="-120"/>
+                <a:latin typeface="VVDS Fifties SExp Reg" pitchFamily="34" charset="0"/>
+                <a:ea typeface="VVDS Fifties SExp Reg" pitchFamily="34" charset="-122"/>
+                <a:cs typeface="VVDS Fifties SExp Reg" pitchFamily="34" charset="-120"/>
               </a:rPr>
               <a:t>Industry 4.0 Edge Analytics</a:t>
             </a:r>
@@ -5207,9 +5207,9 @@
                 <a:solidFill>
                   <a:srgbClr val="6B6560"/>
                 </a:solidFill>
-                <a:latin typeface="Bookman ITC Std" pitchFamily="34" charset="0"/>
-                <a:ea typeface="Bookman ITC Std" pitchFamily="34" charset="-122"/>
-                <a:cs typeface="Bookman ITC Std" pitchFamily="34" charset="-120"/>
+                <a:latin typeface="VVDS Fifties SCond Reg" pitchFamily="34" charset="0"/>
+                <a:ea typeface="VVDS Fifties SCond Reg" pitchFamily="34" charset="-122"/>
+                <a:cs typeface="VVDS Fifties SCond Reg" pitchFamily="34" charset="-120"/>
               </a:rPr>
               <a:t>Factory floor nodes execute real-time local algorithms for predictive maintenance and machine vision controls, utilizing highly rugged legacy processes.</a:t>
             </a:r>
@@ -5271,9 +5271,9 @@
                 <a:solidFill>
                   <a:srgbClr val="768C7C"/>
                 </a:solidFill>
-                <a:latin typeface="PP Mondwest" pitchFamily="34" charset="0"/>
-                <a:ea typeface="PP Mondwest" pitchFamily="34" charset="-122"/>
-                <a:cs typeface="PP Mondwest" pitchFamily="34" charset="-120"/>
+                <a:latin typeface="VVDS Fifties SExp Reg" pitchFamily="34" charset="0"/>
+                <a:ea typeface="VVDS Fifties SExp Reg" pitchFamily="34" charset="-122"/>
+                <a:cs typeface="VVDS Fifties SExp Reg" pitchFamily="34" charset="-120"/>
               </a:rPr>
               <a:t>Healthcare Personalized Sourcing</a:t>
             </a:r>
@@ -5310,9 +5310,9 @@
                 <a:solidFill>
                   <a:srgbClr val="6B6560"/>
                 </a:solidFill>
-                <a:latin typeface="Bookman ITC Std" pitchFamily="34" charset="0"/>
-                <a:ea typeface="Bookman ITC Std" pitchFamily="34" charset="-122"/>
-                <a:cs typeface="Bookman ITC Std" pitchFamily="34" charset="-120"/>
+                <a:latin typeface="VVDS Fifties SCond Reg" pitchFamily="34" charset="0"/>
+                <a:ea typeface="VVDS Fifties SCond Reg" pitchFamily="34" charset="-122"/>
+                <a:cs typeface="VVDS Fifties SCond Reg" pitchFamily="34" charset="-120"/>
               </a:rPr>
               <a:t>Semiconductors enable smart wearable diagnostics, active health implants, and personalized diagnostics. Requires extreme reliability certifications.</a:t>
             </a:r>
@@ -5381,9 +5381,9 @@
                 <a:solidFill>
                   <a:srgbClr val="B84A2F"/>
                 </a:solidFill>
-                <a:latin typeface="Bookman ITC Std" pitchFamily="34" charset="0"/>
-                <a:ea typeface="Bookman ITC Std" pitchFamily="34" charset="-122"/>
-                <a:cs typeface="Bookman ITC Std" pitchFamily="34" charset="-120"/>
+                <a:latin typeface="VVDS Fifties Exp Reg" pitchFamily="34" charset="0"/>
+                <a:ea typeface="VVDS Fifties Exp Reg" pitchFamily="34" charset="-122"/>
+                <a:cs typeface="VVDS Fifties Exp Reg" pitchFamily="34" charset="-120"/>
               </a:rPr>
               <a:t>PART 3: END-USER INDUSTRIES &amp; APPLICATION ECOSYSTEM</a:t>
             </a:r>
@@ -5420,9 +5420,9 @@
                 <a:solidFill>
                   <a:srgbClr val="1A1714"/>
                 </a:solidFill>
-                <a:latin typeface="PP Mondwest" pitchFamily="34" charset="0"/>
-                <a:ea typeface="PP Mondwest" pitchFamily="34" charset="-122"/>
-                <a:cs typeface="PP Mondwest" pitchFamily="34" charset="-120"/>
+                <a:latin typeface="VVDS Fifties Exp SBold" pitchFamily="34" charset="0"/>
+                <a:ea typeface="VVDS Fifties Exp SBold" pitchFamily="34" charset="-122"/>
+                <a:cs typeface="VVDS Fifties Exp SBold" pitchFamily="34" charset="-120"/>
               </a:rPr>
               <a:t>Consumer Electronics &amp; Emerging Frontiers</a:t>
             </a:r>
@@ -5459,9 +5459,9 @@
                 <a:solidFill>
                   <a:srgbClr val="6B6560"/>
                 </a:solidFill>
-                <a:latin typeface="Bookman ITC Std" pitchFamily="34" charset="0"/>
-                <a:ea typeface="Bookman ITC Std" pitchFamily="34" charset="-122"/>
-                <a:cs typeface="Bookman ITC Std" pitchFamily="34" charset="-120"/>
+                <a:latin typeface="VVDS Fifties Exp Reg" pitchFamily="34" charset="0"/>
+                <a:ea typeface="VVDS Fifties Exp Reg" pitchFamily="34" charset="-122"/>
+                <a:cs typeface="VVDS Fifties Exp Reg" pitchFamily="34" charset="-120"/>
               </a:rPr>
               <a:t>The 2026 Semiconductor Ecosystem | Slide 16</a:t>
             </a:r>
@@ -5523,9 +5523,9 @@
                 <a:solidFill>
                   <a:srgbClr val="768C7C"/>
                 </a:solidFill>
-                <a:latin typeface="Bookman ITC Std" pitchFamily="34" charset="0"/>
-                <a:ea typeface="Bookman ITC Std" pitchFamily="34" charset="-122"/>
-                <a:cs typeface="Bookman ITC Std" pitchFamily="34" charset="-120"/>
+                <a:latin typeface="VVDS Fifties SCond Reg" pitchFamily="34" charset="0"/>
+                <a:ea typeface="VVDS Fifties SCond Reg" pitchFamily="34" charset="-122"/>
+                <a:cs typeface="VVDS Fifties SCond Reg" pitchFamily="34" charset="-120"/>
               </a:rPr>
               <a:t>Key Message: While traditional consumer tech matures, frontiers like Quantum, 6G, and Neuromorphic computing define the 2030 roadmap.</a:t>
             </a:r>
@@ -5563,9 +5563,9 @@
                 <a:solidFill>
                   <a:srgbClr val="6B6560"/>
                 </a:solidFill>
-                <a:latin typeface="Bookman ITC Std" pitchFamily="34" charset="0"/>
-                <a:ea typeface="Bookman ITC Std" pitchFamily="34" charset="-122"/>
-                <a:cs typeface="Bookman ITC Std" pitchFamily="34" charset="-120"/>
+                <a:latin typeface="VVDS Fifties SCond Reg" pitchFamily="34" charset="0"/>
+                <a:ea typeface="VVDS Fifties SCond Reg" pitchFamily="34" charset="-122"/>
+                <a:cs typeface="VVDS Fifties SCond Reg" pitchFamily="34" charset="-120"/>
               </a:rPr>
               <a:t>- On-Device NPU Logic: Integrating Neural Processing Units (NPUs) into laptops and mobile phones to enable local AI execution.</a:t>
             </a:r>
@@ -5588,9 +5588,9 @@
                 <a:solidFill>
                   <a:srgbClr val="6B6560"/>
                 </a:solidFill>
-                <a:latin typeface="Bookman ITC Std" pitchFamily="34" charset="0"/>
-                <a:ea typeface="Bookman ITC Std" pitchFamily="34" charset="-122"/>
-                <a:cs typeface="Bookman ITC Std" pitchFamily="34" charset="-120"/>
+                <a:latin typeface="VVDS Fifties SCond Reg" pitchFamily="34" charset="0"/>
+                <a:ea typeface="VVDS Fifties SCond Reg" pitchFamily="34" charset="-122"/>
+                <a:cs typeface="VVDS Fifties SCond Reg" pitchFamily="34" charset="-120"/>
               </a:rPr>
               <a:t>- Neuromorphic Computing: Researching brain-inspired architectures targeting extreme computing power efficiency.</a:t>
             </a:r>
@@ -5613,9 +5613,9 @@
                 <a:solidFill>
                   <a:srgbClr val="6B6560"/>
                 </a:solidFill>
-                <a:latin typeface="Bookman ITC Std" pitchFamily="34" charset="0"/>
-                <a:ea typeface="Bookman ITC Std" pitchFamily="34" charset="-122"/>
-                <a:cs typeface="Bookman ITC Std" pitchFamily="34" charset="-120"/>
+                <a:latin typeface="VVDS Fifties SCond Reg" pitchFamily="34" charset="0"/>
+                <a:ea typeface="VVDS Fifties SCond Reg" pitchFamily="34" charset="-122"/>
+                <a:cs typeface="VVDS Fifties SCond Reg" pitchFamily="34" charset="-120"/>
               </a:rPr>
               <a:t>- Next-Gen Frontiers: Developing quantum structures and 6G communications hardware blocks.</a:t>
             </a:r>
@@ -5677,9 +5677,9 @@
                 <a:solidFill>
                   <a:srgbClr val="768C7C"/>
                 </a:solidFill>
-                <a:latin typeface="Bookman ITC Std" pitchFamily="34" charset="0"/>
-                <a:ea typeface="Bookman ITC Std" pitchFamily="34" charset="-122"/>
-                <a:cs typeface="Bookman ITC Std" pitchFamily="34" charset="-120"/>
+                <a:latin typeface="VVDS Fifties Exp Reg" pitchFamily="34" charset="0"/>
+                <a:ea typeface="VVDS Fifties Exp Reg" pitchFamily="34" charset="-122"/>
+                <a:cs typeface="VVDS Fifties Exp Reg" pitchFamily="34" charset="-120"/>
               </a:rPr>
               <a:t>NPU CORES</a:t>
             </a:r>
@@ -5716,9 +5716,9 @@
                 <a:solidFill>
                   <a:srgbClr val="1A1714"/>
                 </a:solidFill>
-                <a:latin typeface="PP Mondwest" pitchFamily="34" charset="0"/>
-                <a:ea typeface="PP Mondwest" pitchFamily="34" charset="-122"/>
-                <a:cs typeface="PP Mondwest" pitchFamily="34" charset="-120"/>
+                <a:latin typeface="VVDS Fifties Exp SBold" pitchFamily="34" charset="0"/>
+                <a:ea typeface="VVDS Fifties Exp SBold" pitchFamily="34" charset="-122"/>
+                <a:cs typeface="VVDS Fifties Exp SBold" pitchFamily="34" charset="-120"/>
               </a:rPr>
               <a:t>Client AI</a:t>
             </a:r>
@@ -5755,9 +5755,9 @@
                 <a:solidFill>
                   <a:srgbClr val="6B6560"/>
                 </a:solidFill>
-                <a:latin typeface="Bookman ITC Std" pitchFamily="34" charset="0"/>
-                <a:ea typeface="Bookman ITC Std" pitchFamily="34" charset="-122"/>
-                <a:cs typeface="Bookman ITC Std" pitchFamily="34" charset="-120"/>
+                <a:latin typeface="VVDS Fifties SCond Reg" pitchFamily="34" charset="0"/>
+                <a:ea typeface="VVDS Fifties SCond Reg" pitchFamily="34" charset="-122"/>
+                <a:cs typeface="VVDS Fifties SCond Reg" pitchFamily="34" charset="-120"/>
               </a:rPr>
               <a:t>Standard hardware in 2026 client electronics (laptops, phones)</a:t>
             </a:r>
@@ -5826,9 +5826,9 @@
                 <a:solidFill>
                   <a:srgbClr val="B84A2F"/>
                 </a:solidFill>
-                <a:latin typeface="Bookman ITC Std" pitchFamily="34" charset="0"/>
-                <a:ea typeface="Bookman ITC Std" pitchFamily="34" charset="-122"/>
-                <a:cs typeface="Bookman ITC Std" pitchFamily="34" charset="-120"/>
+                <a:latin typeface="VVDS Fifties Exp Reg" pitchFamily="34" charset="0"/>
+                <a:ea typeface="VVDS Fifties Exp Reg" pitchFamily="34" charset="-122"/>
+                <a:cs typeface="VVDS Fifties Exp Reg" pitchFamily="34" charset="-120"/>
               </a:rPr>
               <a:t>SUMMARY &amp; ROADMAP</a:t>
             </a:r>
@@ -5865,9 +5865,9 @@
                 <a:solidFill>
                   <a:srgbClr val="1A1714"/>
                 </a:solidFill>
-                <a:latin typeface="PP Mondwest" pitchFamily="34" charset="0"/>
-                <a:ea typeface="PP Mondwest" pitchFamily="34" charset="-122"/>
-                <a:cs typeface="PP Mondwest" pitchFamily="34" charset="-120"/>
+                <a:latin typeface="VVDS Fifties Exp SBold" pitchFamily="34" charset="0"/>
+                <a:ea typeface="VVDS Fifties Exp SBold" pitchFamily="34" charset="-122"/>
+                <a:cs typeface="VVDS Fifties Exp SBold" pitchFamily="34" charset="-120"/>
               </a:rPr>
               <a:t>Conclusion: A Silicon-Dependent Civilization</a:t>
             </a:r>
@@ -5904,9 +5904,9 @@
                 <a:solidFill>
                   <a:srgbClr val="6B6560"/>
                 </a:solidFill>
-                <a:latin typeface="Bookman ITC Std" pitchFamily="34" charset="0"/>
-                <a:ea typeface="Bookman ITC Std" pitchFamily="34" charset="-122"/>
-                <a:cs typeface="Bookman ITC Std" pitchFamily="34" charset="-120"/>
+                <a:latin typeface="VVDS Fifties Exp Reg" pitchFamily="34" charset="0"/>
+                <a:ea typeface="VVDS Fifties Exp Reg" pitchFamily="34" charset="-122"/>
+                <a:cs typeface="VVDS Fifties Exp Reg" pitchFamily="34" charset="-120"/>
               </a:rPr>
               <a:t>The 2026 Semiconductor Ecosystem | Slide 17</a:t>
             </a:r>
@@ -5968,9 +5968,9 @@
                 <a:solidFill>
                   <a:srgbClr val="B84A2F"/>
                 </a:solidFill>
-                <a:latin typeface="Bookman ITC Std" pitchFamily="34" charset="0"/>
-                <a:ea typeface="Bookman ITC Std" pitchFamily="34" charset="-122"/>
-                <a:cs typeface="Bookman ITC Std" pitchFamily="34" charset="-120"/>
+                <a:latin typeface="VVDS Fifties SCond Reg" pitchFamily="34" charset="0"/>
+                <a:ea typeface="VVDS Fifties SCond Reg" pitchFamily="34" charset="-122"/>
+                <a:cs typeface="VVDS Fifties SCond Reg" pitchFamily="34" charset="-120"/>
               </a:rPr>
               <a:t>Key Message: We have reached a point of "Total Silicon Dependency." The path to a $2 trillion industry is certain.</a:t>
             </a:r>
@@ -6007,9 +6007,9 @@
                 <a:solidFill>
                   <a:srgbClr val="6B6560"/>
                 </a:solidFill>
-                <a:latin typeface="Bookman ITC Std" pitchFamily="34" charset="0"/>
-                <a:ea typeface="Bookman ITC Std" pitchFamily="34" charset="-122"/>
-                <a:cs typeface="Bookman ITC Std" pitchFamily="34" charset="-120"/>
+                <a:latin typeface="VVDS Fifties SCond Reg" pitchFamily="34" charset="0"/>
+                <a:ea typeface="VVDS Fifties SCond Reg" pitchFamily="34" charset="-122"/>
+                <a:cs typeface="VVDS Fifties SCond Reg" pitchFamily="34" charset="-120"/>
               </a:rPr>
               <a:t>Mastery of the semiconductor ecosystem is mastery of the future. The "Chip Wars" aren't just about manufacturing; they are about who can best harness silicon to transform their industries.</a:t>
             </a:r>
@@ -6046,9 +6046,9 @@
                 <a:solidFill>
                   <a:srgbClr val="1A1714"/>
                 </a:solidFill>
-                <a:latin typeface="Bookman ITC Std" pitchFamily="34" charset="0"/>
-                <a:ea typeface="Bookman ITC Std" pitchFamily="34" charset="-122"/>
-                <a:cs typeface="Bookman ITC Std" pitchFamily="34" charset="-120"/>
+                <a:latin typeface="VVDS Fifties Exp Reg" pitchFamily="34" charset="0"/>
+                <a:ea typeface="VVDS Fifties Exp Reg" pitchFamily="34" charset="-122"/>
+                <a:cs typeface="VVDS Fifties Exp Reg" pitchFamily="34" charset="-120"/>
               </a:rPr>
               <a:t>KEY TAKEAWAYS SUMMARY</a:t>
             </a:r>
@@ -6110,9 +6110,9 @@
                 <a:solidFill>
                   <a:srgbClr val="B84A2F"/>
                 </a:solidFill>
-                <a:latin typeface="PP Mondwest" pitchFamily="34" charset="0"/>
-                <a:ea typeface="PP Mondwest" pitchFamily="34" charset="-122"/>
-                <a:cs typeface="PP Mondwest" pitchFamily="34" charset="-120"/>
+                <a:latin typeface="VVDS Fifties SExp Reg" pitchFamily="34" charset="0"/>
+                <a:ea typeface="VVDS Fifties SExp Reg" pitchFamily="34" charset="-122"/>
+                <a:cs typeface="VVDS Fifties SExp Reg" pitchFamily="34" charset="-120"/>
               </a:rPr>
               <a:t>Procurement</a:t>
             </a:r>
@@ -6149,9 +6149,9 @@
                 <a:solidFill>
                   <a:srgbClr val="6B6560"/>
                 </a:solidFill>
-                <a:latin typeface="Bookman ITC Std" pitchFamily="34" charset="0"/>
-                <a:ea typeface="Bookman ITC Std" pitchFamily="34" charset="-122"/>
-                <a:cs typeface="Bookman ITC Std" pitchFamily="34" charset="-120"/>
+                <a:latin typeface="VVDS Fifties SCond Reg" pitchFamily="34" charset="0"/>
+                <a:ea typeface="VVDS Fifties SCond Reg" pitchFamily="34" charset="-122"/>
+                <a:cs typeface="VVDS Fifties SCond Reg" pitchFamily="34" charset="-120"/>
               </a:rPr>
               <a:t>Shift from JIT to Strategic Hybrid; resilience is the new ROI.</a:t>
             </a:r>
@@ -6213,9 +6213,9 @@
                 <a:solidFill>
                   <a:srgbClr val="9E7D84"/>
                 </a:solidFill>
-                <a:latin typeface="PP Mondwest" pitchFamily="34" charset="0"/>
-                <a:ea typeface="PP Mondwest" pitchFamily="34" charset="-122"/>
-                <a:cs typeface="PP Mondwest" pitchFamily="34" charset="-120"/>
+                <a:latin typeface="VVDS Fifties SExp Reg" pitchFamily="34" charset="0"/>
+                <a:ea typeface="VVDS Fifties SExp Reg" pitchFamily="34" charset="-122"/>
+                <a:cs typeface="VVDS Fifties SExp Reg" pitchFamily="34" charset="-120"/>
               </a:rPr>
               <a:t>Supply Chain</a:t>
             </a:r>
@@ -6252,9 +6252,9 @@
                 <a:solidFill>
                   <a:srgbClr val="6B6560"/>
                 </a:solidFill>
-                <a:latin typeface="Bookman ITC Std" pitchFamily="34" charset="0"/>
-                <a:ea typeface="Bookman ITC Std" pitchFamily="34" charset="-122"/>
-                <a:cs typeface="Bookman ITC Std" pitchFamily="34" charset="-120"/>
+                <a:latin typeface="VVDS Fifties SCond Reg" pitchFamily="34" charset="0"/>
+                <a:ea typeface="VVDS Fifties SCond Reg" pitchFamily="34" charset="-122"/>
+                <a:cs typeface="VVDS Fifties SCond Reg" pitchFamily="34" charset="-120"/>
               </a:rPr>
               <a:t>Chokepoints in Advanced Packaging and SME are the new strategic risks.</a:t>
             </a:r>
@@ -6316,9 +6316,9 @@
                 <a:solidFill>
                   <a:srgbClr val="768C7C"/>
                 </a:solidFill>
-                <a:latin typeface="PP Mondwest" pitchFamily="34" charset="0"/>
-                <a:ea typeface="PP Mondwest" pitchFamily="34" charset="-122"/>
-                <a:cs typeface="PP Mondwest" pitchFamily="34" charset="-120"/>
+                <a:latin typeface="VVDS Fifties SExp Reg" pitchFamily="34" charset="0"/>
+                <a:ea typeface="VVDS Fifties SExp Reg" pitchFamily="34" charset="-122"/>
+                <a:cs typeface="VVDS Fifties SExp Reg" pitchFamily="34" charset="-120"/>
               </a:rPr>
               <a:t>Industries</a:t>
             </a:r>
@@ -6355,9 +6355,9 @@
                 <a:solidFill>
                   <a:srgbClr val="6B6560"/>
                 </a:solidFill>
-                <a:latin typeface="Bookman ITC Std" pitchFamily="34" charset="0"/>
-                <a:ea typeface="Bookman ITC Std" pitchFamily="34" charset="-122"/>
-                <a:cs typeface="Bookman ITC Std" pitchFamily="34" charset="-120"/>
+                <a:latin typeface="VVDS Fifties SCond Reg" pitchFamily="34" charset="0"/>
+                <a:ea typeface="VVDS Fifties SCond Reg" pitchFamily="34" charset="-122"/>
+                <a:cs typeface="VVDS Fifties SCond Reg" pitchFamily="34" charset="-120"/>
               </a:rPr>
               <a:t>AI is the Value King; Automotive is the Volume King.</a:t>
             </a:r>
@@ -6426,9 +6426,9 @@
                 <a:solidFill>
                   <a:srgbClr val="B84A2F"/>
                 </a:solidFill>
-                <a:latin typeface="Bookman ITC Std" pitchFamily="34" charset="0"/>
-                <a:ea typeface="Bookman ITC Std" pitchFamily="34" charset="-122"/>
-                <a:cs typeface="Bookman ITC Std" pitchFamily="34" charset="-120"/>
+                <a:latin typeface="VVDS Fifties Exp Reg" pitchFamily="34" charset="0"/>
+                <a:ea typeface="VVDS Fifties Exp Reg" pitchFamily="34" charset="-122"/>
+                <a:cs typeface="VVDS Fifties Exp Reg" pitchFamily="34" charset="-120"/>
               </a:rPr>
               <a:t>THE END</a:t>
             </a:r>
@@ -6465,9 +6465,9 @@
                 <a:solidFill>
                   <a:srgbClr val="1A1714"/>
                 </a:solidFill>
-                <a:latin typeface="PP Mondwest" pitchFamily="34" charset="0"/>
-                <a:ea typeface="PP Mondwest" pitchFamily="34" charset="-122"/>
-                <a:cs typeface="PP Mondwest" pitchFamily="34" charset="-120"/>
+                <a:latin typeface="VVDS Fifties Exp SBold" pitchFamily="34" charset="0"/>
+                <a:ea typeface="VVDS Fifties Exp SBold" pitchFamily="34" charset="-122"/>
+                <a:cs typeface="VVDS Fifties Exp SBold" pitchFamily="34" charset="-120"/>
               </a:rPr>
               <a:t>Thank You</a:t>
             </a:r>
@@ -6504,9 +6504,9 @@
                 <a:solidFill>
                   <a:srgbClr val="6B6560"/>
                 </a:solidFill>
-                <a:latin typeface="Bookman ITC Std" pitchFamily="34" charset="0"/>
-                <a:ea typeface="Bookman ITC Std" pitchFamily="34" charset="-122"/>
-                <a:cs typeface="Bookman ITC Std" pitchFamily="34" charset="-120"/>
+                <a:latin typeface="VVDS Fifties SCond Reg" pitchFamily="34" charset="0"/>
+                <a:ea typeface="VVDS Fifties SCond Reg" pitchFamily="34" charset="-122"/>
+                <a:cs typeface="VVDS Fifties SCond Reg" pitchFamily="34" charset="-120"/>
               </a:rPr>
               <a:t>Mastery of the semiconductor ecosystem is mastery of the future.</a:t>
             </a:r>
@@ -6563,9 +6563,9 @@
                 <a:solidFill>
                   <a:srgbClr val="6B6560"/>
                 </a:solidFill>
-                <a:latin typeface="Bookman ITC Std" pitchFamily="34" charset="0"/>
-                <a:ea typeface="Bookman ITC Std" pitchFamily="34" charset="-122"/>
-                <a:cs typeface="Bookman ITC Std" pitchFamily="34" charset="-120"/>
+                <a:latin typeface="VVDS Fifties Exp Reg" pitchFamily="34" charset="0"/>
+                <a:ea typeface="VVDS Fifties Exp Reg" pitchFamily="34" charset="-122"/>
+                <a:cs typeface="VVDS Fifties Exp Reg" pitchFamily="34" charset="-120"/>
               </a:rPr>
               <a:t>Presenter: Phyoe Sat Paing</a:t>
             </a:r>
@@ -6580,9 +6580,9 @@
                 <a:solidFill>
                   <a:srgbClr val="6B6560"/>
                 </a:solidFill>
-                <a:latin typeface="Bookman ITC Std" pitchFamily="34" charset="0"/>
-                <a:ea typeface="Bookman ITC Std" pitchFamily="34" charset="-122"/>
-                <a:cs typeface="Bookman ITC Std" pitchFamily="34" charset="-120"/>
+                <a:latin typeface="VVDS Fifties Exp Reg" pitchFamily="34" charset="0"/>
+                <a:ea typeface="VVDS Fifties Exp Reg" pitchFamily="34" charset="-122"/>
+                <a:cs typeface="VVDS Fifties Exp Reg" pitchFamily="34" charset="-120"/>
               </a:rPr>
               <a:t>Boardroom Strategic Briefing</a:t>
             </a:r>
@@ -6619,9 +6619,9 @@
                 <a:solidFill>
                   <a:srgbClr val="6B6560"/>
                 </a:solidFill>
-                <a:latin typeface="Bookman ITC Std" pitchFamily="34" charset="0"/>
-                <a:ea typeface="Bookman ITC Std" pitchFamily="34" charset="-122"/>
-                <a:cs typeface="Bookman ITC Std" pitchFamily="34" charset="-120"/>
+                <a:latin typeface="VVDS Fifties Exp Reg" pitchFamily="34" charset="0"/>
+                <a:ea typeface="VVDS Fifties Exp Reg" pitchFamily="34" charset="-122"/>
+                <a:cs typeface="VVDS Fifties Exp Reg" pitchFamily="34" charset="-120"/>
               </a:rPr>
               <a:t>The 2026 Semiconductor Ecosystem | Slide 18</a:t>
             </a:r>
@@ -6690,9 +6690,9 @@
                 <a:solidFill>
                   <a:srgbClr val="B84A2F"/>
                 </a:solidFill>
-                <a:latin typeface="Bookman ITC Std" pitchFamily="34" charset="0"/>
-                <a:ea typeface="Bookman ITC Std" pitchFamily="34" charset="-122"/>
-                <a:cs typeface="Bookman ITC Std" pitchFamily="34" charset="-120"/>
+                <a:latin typeface="VVDS Fifties Exp Reg" pitchFamily="34" charset="0"/>
+                <a:ea typeface="VVDS Fifties Exp Reg" pitchFamily="34" charset="-122"/>
+                <a:cs typeface="VVDS Fifties Exp Reg" pitchFamily="34" charset="-120"/>
               </a:rPr>
               <a:t>PART 1: PROCUREMENT OF SEMICONDUCTORS</a:t>
             </a:r>
@@ -6729,9 +6729,9 @@
                 <a:solidFill>
                   <a:srgbClr val="1A1714"/>
                 </a:solidFill>
-                <a:latin typeface="PP Mondwest" pitchFamily="34" charset="0"/>
-                <a:ea typeface="PP Mondwest" pitchFamily="34" charset="-122"/>
-                <a:cs typeface="PP Mondwest" pitchFamily="34" charset="-120"/>
+                <a:latin typeface="VVDS Fifties Exp SBold" pitchFamily="34" charset="0"/>
+                <a:ea typeface="VVDS Fifties Exp SBold" pitchFamily="34" charset="-122"/>
+                <a:cs typeface="VVDS Fifties Exp SBold" pitchFamily="34" charset="-120"/>
               </a:rPr>
               <a:t>Executive Summary: The Procurement Paradox</a:t>
             </a:r>
@@ -6768,9 +6768,9 @@
                 <a:solidFill>
                   <a:srgbClr val="6B6560"/>
                 </a:solidFill>
-                <a:latin typeface="Bookman ITC Std" pitchFamily="34" charset="0"/>
-                <a:ea typeface="Bookman ITC Std" pitchFamily="34" charset="-122"/>
-                <a:cs typeface="Bookman ITC Std" pitchFamily="34" charset="-120"/>
+                <a:latin typeface="VVDS Fifties Exp Reg" pitchFamily="34" charset="0"/>
+                <a:ea typeface="VVDS Fifties Exp Reg" pitchFamily="34" charset="-122"/>
+                <a:cs typeface="VVDS Fifties Exp Reg" pitchFamily="34" charset="-120"/>
               </a:rPr>
               <a:t>The 2026 Semiconductor Ecosystem | Slide 02</a:t>
             </a:r>
@@ -6832,9 +6832,9 @@
                 <a:solidFill>
                   <a:srgbClr val="B84A2F"/>
                 </a:solidFill>
-                <a:latin typeface="Bookman ITC Std" pitchFamily="34" charset="0"/>
-                <a:ea typeface="Bookman ITC Std" pitchFamily="34" charset="-122"/>
-                <a:cs typeface="Bookman ITC Std" pitchFamily="34" charset="-120"/>
+                <a:latin typeface="VVDS Fifties SCond Reg" pitchFamily="34" charset="0"/>
+                <a:ea typeface="VVDS Fifties SCond Reg" pitchFamily="34" charset="-122"/>
+                <a:cs typeface="VVDS Fifties SCond Reg" pitchFamily="34" charset="-120"/>
               </a:rPr>
               <a:t>Key Message: Navigating a $1.3 trillion market requires balancing unprecedented growth with systemic supply chain fragility.</a:t>
             </a:r>
@@ -6872,9 +6872,9 @@
                 <a:solidFill>
                   <a:srgbClr val="6B6560"/>
                 </a:solidFill>
-                <a:latin typeface="Bookman ITC Std" pitchFamily="34" charset="0"/>
-                <a:ea typeface="Bookman ITC Std" pitchFamily="34" charset="-122"/>
-                <a:cs typeface="Bookman ITC Std" pitchFamily="34" charset="-120"/>
+                <a:latin typeface="VVDS Fifties SCond Reg" pitchFamily="34" charset="0"/>
+                <a:ea typeface="VVDS Fifties SCond Reg" pitchFamily="34" charset="-122"/>
+                <a:cs typeface="VVDS Fifties SCond Reg" pitchFamily="34" charset="-120"/>
               </a:rPr>
               <a:t>- Record-High Valuations: Growth is driven by explosive global demand for AI systems and electric vehicle power logic.</a:t>
             </a:r>
@@ -6897,9 +6897,9 @@
                 <a:solidFill>
                   <a:srgbClr val="6B6560"/>
                 </a:solidFill>
-                <a:latin typeface="Bookman ITC Std" pitchFamily="34" charset="0"/>
-                <a:ea typeface="Bookman ITC Std" pitchFamily="34" charset="-122"/>
-                <a:cs typeface="Bookman ITC Std" pitchFamily="34" charset="-120"/>
+                <a:latin typeface="VVDS Fifties SCond Reg" pitchFamily="34" charset="0"/>
+                <a:ea typeface="VVDS Fifties SCond Reg" pitchFamily="34" charset="-122"/>
+                <a:cs typeface="VVDS Fifties SCond Reg" pitchFamily="34" charset="-120"/>
               </a:rPr>
               <a:t>- Systemic Fragility: Leading-edge fabs operate near maximum capacity, leaving the industry vulnerable to minor material delays.</a:t>
             </a:r>
@@ -6922,9 +6922,9 @@
                 <a:solidFill>
                   <a:srgbClr val="6B6560"/>
                 </a:solidFill>
-                <a:latin typeface="Bookman ITC Std" pitchFamily="34" charset="0"/>
-                <a:ea typeface="Bookman ITC Std" pitchFamily="34" charset="-122"/>
-                <a:cs typeface="Bookman ITC Std" pitchFamily="34" charset="-120"/>
+                <a:latin typeface="VVDS Fifties SCond Reg" pitchFamily="34" charset="0"/>
+                <a:ea typeface="VVDS Fifties SCond Reg" pitchFamily="34" charset="-122"/>
+                <a:cs typeface="VVDS Fifties SCond Reg" pitchFamily="34" charset="-120"/>
               </a:rPr>
               <a:t>- Strategic Pivot: Sourcing HBM (High Bandwidth Memory) and advanced logic requires a shift from transactional purchasing to capacity reservation models.</a:t>
             </a:r>
@@ -6986,9 +6986,9 @@
                 <a:solidFill>
                   <a:srgbClr val="B84A2F"/>
                 </a:solidFill>
-                <a:latin typeface="Bookman ITC Std" pitchFamily="34" charset="0"/>
-                <a:ea typeface="Bookman ITC Std" pitchFamily="34" charset="-122"/>
-                <a:cs typeface="Bookman ITC Std" pitchFamily="34" charset="-120"/>
+                <a:latin typeface="VVDS Fifties Exp Reg" pitchFamily="34" charset="0"/>
+                <a:ea typeface="VVDS Fifties Exp Reg" pitchFamily="34" charset="-122"/>
+                <a:cs typeface="VVDS Fifties Exp Reg" pitchFamily="34" charset="-120"/>
               </a:rPr>
               <a:t>ESTIMATE</a:t>
             </a:r>
@@ -7025,9 +7025,9 @@
                 <a:solidFill>
                   <a:srgbClr val="1A1714"/>
                 </a:solidFill>
-                <a:latin typeface="PP Mondwest" pitchFamily="34" charset="0"/>
-                <a:ea typeface="PP Mondwest" pitchFamily="34" charset="-122"/>
-                <a:cs typeface="PP Mondwest" pitchFamily="34" charset="-120"/>
+                <a:latin typeface="VVDS Fifties Exp SBold" pitchFamily="34" charset="0"/>
+                <a:ea typeface="VVDS Fifties Exp SBold" pitchFamily="34" charset="-122"/>
+                <a:cs typeface="VVDS Fifties Exp SBold" pitchFamily="34" charset="-120"/>
               </a:rPr>
               <a:t>$1.3T</a:t>
             </a:r>
@@ -7064,9 +7064,9 @@
                 <a:solidFill>
                   <a:srgbClr val="6B6560"/>
                 </a:solidFill>
-                <a:latin typeface="Bookman ITC Std" pitchFamily="34" charset="0"/>
-                <a:ea typeface="Bookman ITC Std" pitchFamily="34" charset="-122"/>
-                <a:cs typeface="Bookman ITC Std" pitchFamily="34" charset="-120"/>
+                <a:latin typeface="VVDS Fifties Exp Reg" pitchFamily="34" charset="0"/>
+                <a:ea typeface="VVDS Fifties Exp Reg" pitchFamily="34" charset="-122"/>
+                <a:cs typeface="VVDS Fifties Exp Reg" pitchFamily="34" charset="-120"/>
               </a:rPr>
               <a:t>Global Market Value</a:t>
             </a:r>
@@ -7081,9 +7081,9 @@
                 <a:solidFill>
                   <a:srgbClr val="6B6560"/>
                 </a:solidFill>
-                <a:latin typeface="Bookman ITC Std" pitchFamily="34" charset="0"/>
-                <a:ea typeface="Bookman ITC Std" pitchFamily="34" charset="-122"/>
-                <a:cs typeface="Bookman ITC Std" pitchFamily="34" charset="-120"/>
+                <a:latin typeface="VVDS Fifties Exp Reg" pitchFamily="34" charset="0"/>
+                <a:ea typeface="VVDS Fifties Exp Reg" pitchFamily="34" charset="-122"/>
+                <a:cs typeface="VVDS Fifties Exp Reg" pitchFamily="34" charset="-120"/>
               </a:rPr>
               <a:t>Analyst consensus 2026</a:t>
             </a:r>
@@ -7152,9 +7152,9 @@
                 <a:solidFill>
                   <a:srgbClr val="B84A2F"/>
                 </a:solidFill>
-                <a:latin typeface="Bookman ITC Std" pitchFamily="34" charset="0"/>
-                <a:ea typeface="Bookman ITC Std" pitchFamily="34" charset="-122"/>
-                <a:cs typeface="Bookman ITC Std" pitchFamily="34" charset="-120"/>
+                <a:latin typeface="VVDS Fifties Exp Reg" pitchFamily="34" charset="0"/>
+                <a:ea typeface="VVDS Fifties Exp Reg" pitchFamily="34" charset="-122"/>
+                <a:cs typeface="VVDS Fifties Exp Reg" pitchFamily="34" charset="-120"/>
               </a:rPr>
               <a:t>PART 1: PROCUREMENT OF SEMICONDUCTORS</a:t>
             </a:r>
@@ -7191,9 +7191,9 @@
                 <a:solidFill>
                   <a:srgbClr val="1A1714"/>
                 </a:solidFill>
-                <a:latin typeface="PP Mondwest" pitchFamily="34" charset="0"/>
-                <a:ea typeface="PP Mondwest" pitchFamily="34" charset="-122"/>
-                <a:cs typeface="PP Mondwest" pitchFamily="34" charset="-120"/>
+                <a:latin typeface="VVDS Fifties Exp SBold" pitchFamily="34" charset="0"/>
+                <a:ea typeface="VVDS Fifties Exp SBold" pitchFamily="34" charset="-122"/>
+                <a:cs typeface="VVDS Fifties Exp SBold" pitchFamily="34" charset="-120"/>
               </a:rPr>
               <a:t>Evolution of Procurement: The Strategic Hybrid Model</a:t>
             </a:r>
@@ -7230,9 +7230,9 @@
                 <a:solidFill>
                   <a:srgbClr val="6B6560"/>
                 </a:solidFill>
-                <a:latin typeface="Bookman ITC Std" pitchFamily="34" charset="0"/>
-                <a:ea typeface="Bookman ITC Std" pitchFamily="34" charset="-122"/>
-                <a:cs typeface="Bookman ITC Std" pitchFamily="34" charset="-120"/>
+                <a:latin typeface="VVDS Fifties Exp Reg" pitchFamily="34" charset="0"/>
+                <a:ea typeface="VVDS Fifties Exp Reg" pitchFamily="34" charset="-122"/>
+                <a:cs typeface="VVDS Fifties Exp Reg" pitchFamily="34" charset="-120"/>
               </a:rPr>
               <a:t>The 2026 Semiconductor Ecosystem | Slide 03</a:t>
             </a:r>
@@ -7294,9 +7294,9 @@
                 <a:solidFill>
                   <a:srgbClr val="9E7D84"/>
                 </a:solidFill>
-                <a:latin typeface="Bookman ITC Std" pitchFamily="34" charset="0"/>
-                <a:ea typeface="Bookman ITC Std" pitchFamily="34" charset="-122"/>
-                <a:cs typeface="Bookman ITC Std" pitchFamily="34" charset="-120"/>
+                <a:latin typeface="VVDS Fifties SCond Reg" pitchFamily="34" charset="0"/>
+                <a:ea typeface="VVDS Fifties SCond Reg" pitchFamily="34" charset="-122"/>
+                <a:cs typeface="VVDS Fifties SCond Reg" pitchFamily="34" charset="-120"/>
               </a:rPr>
               <a:t>Key Message: Pure JIT is obsolete; the new standard is a hybrid approach that prioritizes resilience for high-value nodes.</a:t>
             </a:r>
@@ -7358,9 +7358,9 @@
                 <a:solidFill>
                   <a:srgbClr val="B84A2F"/>
                 </a:solidFill>
-                <a:latin typeface="PP Mondwest" pitchFamily="34" charset="0"/>
-                <a:ea typeface="PP Mondwest" pitchFamily="34" charset="-122"/>
-                <a:cs typeface="PP Mondwest" pitchFamily="34" charset="-120"/>
+                <a:latin typeface="VVDS Fifties SExp Reg" pitchFamily="34" charset="0"/>
+                <a:ea typeface="VVDS Fifties SExp Reg" pitchFamily="34" charset="-122"/>
+                <a:cs typeface="VVDS Fifties SExp Reg" pitchFamily="34" charset="-120"/>
               </a:rPr>
               <a:t>Lean JIT (Commoditized Nodes)</a:t>
             </a:r>
@@ -7397,9 +7397,9 @@
                 <a:solidFill>
                   <a:srgbClr val="6B6560"/>
                 </a:solidFill>
-                <a:latin typeface="Bookman ITC Std" pitchFamily="34" charset="0"/>
-                <a:ea typeface="Bookman ITC Std" pitchFamily="34" charset="-122"/>
-                <a:cs typeface="Bookman ITC Std" pitchFamily="34" charset="-120"/>
+                <a:latin typeface="VVDS Fifties SCond Reg" pitchFamily="34" charset="0"/>
+                <a:ea typeface="VVDS Fifties SCond Reg" pitchFamily="34" charset="-122"/>
+                <a:cs typeface="VVDS Fifties SCond Reg" pitchFamily="34" charset="-120"/>
               </a:rPr>
               <a:t>Used for standardized legacy passive elements and commoditized logic chips. Minimizes capital lock-up and inventory holding costs while keeping storage footprint low.</a:t>
             </a:r>
@@ -7461,9 +7461,9 @@
                 <a:solidFill>
                   <a:srgbClr val="9E7D84"/>
                 </a:solidFill>
-                <a:latin typeface="PP Mondwest" pitchFamily="34" charset="0"/>
-                <a:ea typeface="PP Mondwest" pitchFamily="34" charset="-122"/>
-                <a:cs typeface="PP Mondwest" pitchFamily="34" charset="-120"/>
+                <a:latin typeface="VVDS Fifties SExp Reg" pitchFamily="34" charset="0"/>
+                <a:ea typeface="VVDS Fifties SExp Reg" pitchFamily="34" charset="-122"/>
+                <a:cs typeface="VVDS Fifties SExp Reg" pitchFamily="34" charset="-120"/>
               </a:rPr>
               <a:t>Strategic Buffers (Critical Nodes)</a:t>
             </a:r>
@@ -7500,9 +7500,9 @@
                 <a:solidFill>
                   <a:srgbClr val="6B6560"/>
                 </a:solidFill>
-                <a:latin typeface="Bookman ITC Std" pitchFamily="34" charset="0"/>
-                <a:ea typeface="Bookman ITC Std" pitchFamily="34" charset="-122"/>
-                <a:cs typeface="Bookman ITC Std" pitchFamily="34" charset="-120"/>
+                <a:latin typeface="VVDS Fifties SCond Reg" pitchFamily="34" charset="0"/>
+                <a:ea typeface="VVDS Fifties SCond Reg" pitchFamily="34" charset="-122"/>
+                <a:cs typeface="VVDS Fifties SCond Reg" pitchFamily="34" charset="-120"/>
               </a:rPr>
               <a:t>Maintaining 3 to 6 months of safety stock for sole-sourced, high-margin microcomponents (HBM, custom GPUs) to guarantee manufacturing continuity.</a:t>
             </a:r>
@@ -7571,9 +7571,9 @@
                 <a:solidFill>
                   <a:srgbClr val="B84A2F"/>
                 </a:solidFill>
-                <a:latin typeface="Bookman ITC Std" pitchFamily="34" charset="0"/>
-                <a:ea typeface="Bookman ITC Std" pitchFamily="34" charset="-122"/>
-                <a:cs typeface="Bookman ITC Std" pitchFamily="34" charset="-120"/>
+                <a:latin typeface="VVDS Fifties Exp Reg" pitchFamily="34" charset="0"/>
+                <a:ea typeface="VVDS Fifties Exp Reg" pitchFamily="34" charset="-122"/>
+                <a:cs typeface="VVDS Fifties Exp Reg" pitchFamily="34" charset="-120"/>
               </a:rPr>
               <a:t>PART 1: PROCUREMENT OF SEMICONDUCTORS</a:t>
             </a:r>
@@ -7610,9 +7610,9 @@
                 <a:solidFill>
                   <a:srgbClr val="1A1714"/>
                 </a:solidFill>
-                <a:latin typeface="PP Mondwest" pitchFamily="34" charset="0"/>
-                <a:ea typeface="PP Mondwest" pitchFamily="34" charset="-122"/>
-                <a:cs typeface="PP Mondwest" pitchFamily="34" charset="-120"/>
+                <a:latin typeface="VVDS Fifties Exp SBold" pitchFamily="34" charset="0"/>
+                <a:ea typeface="VVDS Fifties Exp SBold" pitchFamily="34" charset="-122"/>
+                <a:cs typeface="VVDS Fifties Exp SBold" pitchFamily="34" charset="-120"/>
               </a:rPr>
               <a:t>Key Procurement Challenges &amp; Strategic Sourcing</a:t>
             </a:r>
@@ -7649,9 +7649,9 @@
                 <a:solidFill>
                   <a:srgbClr val="6B6560"/>
                 </a:solidFill>
-                <a:latin typeface="Bookman ITC Std" pitchFamily="34" charset="0"/>
-                <a:ea typeface="Bookman ITC Std" pitchFamily="34" charset="-122"/>
-                <a:cs typeface="Bookman ITC Std" pitchFamily="34" charset="-120"/>
+                <a:latin typeface="VVDS Fifties Exp Reg" pitchFamily="34" charset="0"/>
+                <a:ea typeface="VVDS Fifties Exp Reg" pitchFamily="34" charset="-122"/>
+                <a:cs typeface="VVDS Fifties Exp Reg" pitchFamily="34" charset="-120"/>
               </a:rPr>
               <a:t>The 2026 Semiconductor Ecosystem | Slide 04</a:t>
             </a:r>
@@ -7713,9 +7713,9 @@
                 <a:solidFill>
                   <a:srgbClr val="768C7C"/>
                 </a:solidFill>
-                <a:latin typeface="Bookman ITC Std" pitchFamily="34" charset="0"/>
-                <a:ea typeface="Bookman ITC Std" pitchFamily="34" charset="-122"/>
-                <a:cs typeface="Bookman ITC Std" pitchFamily="34" charset="-120"/>
+                <a:latin typeface="VVDS Fifties SCond Reg" pitchFamily="34" charset="0"/>
+                <a:ea typeface="VVDS Fifties SCond Reg" pitchFamily="34" charset="-122"/>
+                <a:cs typeface="VVDS Fifties SCond Reg" pitchFamily="34" charset="-120"/>
               </a:rPr>
               <a:t>Key Message: Data opacity and reactive risk management are the primary enemies of a resilient procurement strategy.</a:t>
             </a:r>
@@ -7753,9 +7753,9 @@
                 <a:solidFill>
                   <a:srgbClr val="6B6560"/>
                 </a:solidFill>
-                <a:latin typeface="Bookman ITC Std" pitchFamily="34" charset="0"/>
-                <a:ea typeface="Bookman ITC Std" pitchFamily="34" charset="-122"/>
-                <a:cs typeface="Bookman ITC Std" pitchFamily="34" charset="-120"/>
+                <a:latin typeface="VVDS Fifties SCond Reg" pitchFamily="34" charset="0"/>
+                <a:ea typeface="VVDS Fifties SCond Reg" pitchFamily="34" charset="-122"/>
+                <a:cs typeface="VVDS Fifties SCond Reg" pitchFamily="34" charset="-120"/>
               </a:rPr>
               <a:t>- Category Management Sourcing: Slicing procurement into precise technology nodes (Leading-edge sub-7nm vs Legacy nodes).</a:t>
             </a:r>
@@ -7778,9 +7778,9 @@
                 <a:solidFill>
                   <a:srgbClr val="6B6560"/>
                 </a:solidFill>
-                <a:latin typeface="Bookman ITC Std" pitchFamily="34" charset="0"/>
-                <a:ea typeface="Bookman ITC Std" pitchFamily="34" charset="-122"/>
-                <a:cs typeface="Bookman ITC Std" pitchFamily="34" charset="-120"/>
+                <a:latin typeface="VVDS Fifties SCond Reg" pitchFamily="34" charset="0"/>
+                <a:ea typeface="VVDS Fifties SCond Reg" pitchFamily="34" charset="-122"/>
+                <a:cs typeface="VVDS Fifties SCond Reg" pitchFamily="34" charset="-120"/>
               </a:rPr>
               <a:t>- Leading-edge Sourcing: Focuses on deep co-development partnerships, engineering collaboration, and long-term volume commitments.</a:t>
             </a:r>
@@ -7803,9 +7803,9 @@
                 <a:solidFill>
                   <a:srgbClr val="6B6560"/>
                 </a:solidFill>
-                <a:latin typeface="Bookman ITC Std" pitchFamily="34" charset="0"/>
-                <a:ea typeface="Bookman ITC Std" pitchFamily="34" charset="-122"/>
-                <a:cs typeface="Bookman ITC Std" pitchFamily="34" charset="-120"/>
+                <a:latin typeface="VVDS Fifties SCond Reg" pitchFamily="34" charset="0"/>
+                <a:ea typeface="VVDS Fifties SCond Reg" pitchFamily="34" charset="-122"/>
+                <a:cs typeface="VVDS Fifties SCond Reg" pitchFamily="34" charset="-120"/>
               </a:rPr>
               <a:t>- Legacy Sourcing: Emphasizes multi-sourcing, second-sourcing qualification, and legacy lifecycle management to offset obsolescence.</a:t>
             </a:r>
@@ -7867,9 +7867,9 @@
                 <a:solidFill>
                   <a:srgbClr val="6B6560"/>
                 </a:solidFill>
-                <a:latin typeface="Bookman ITC Std" pitchFamily="34" charset="0"/>
-                <a:ea typeface="Bookman ITC Std" pitchFamily="34" charset="-122"/>
-                <a:cs typeface="Bookman ITC Std" pitchFamily="34" charset="-120"/>
+                <a:latin typeface="VVDS Fifties SCond Reg" pitchFamily="34" charset="0"/>
+                <a:ea typeface="VVDS Fifties SCond Reg" pitchFamily="34" charset="-122"/>
+                <a:cs typeface="VVDS Fifties SCond Reg" pitchFamily="34" charset="-120"/>
               </a:rPr>
               <a:t>Leading-Edge Nodes</a:t>
             </a:r>
@@ -7890,9 +7890,9 @@
                 <a:solidFill>
                   <a:srgbClr val="6B6560"/>
                 </a:solidFill>
-                <a:latin typeface="Bookman ITC Std" pitchFamily="34" charset="0"/>
-                <a:ea typeface="Bookman ITC Std" pitchFamily="34" charset="-122"/>
-                <a:cs typeface="Bookman ITC Std" pitchFamily="34" charset="-120"/>
+                <a:latin typeface="VVDS Fifties SCond Reg" pitchFamily="34" charset="0"/>
+                <a:ea typeface="VVDS Fifties SCond Reg" pitchFamily="34" charset="-122"/>
+                <a:cs typeface="VVDS Fifties SCond Reg" pitchFamily="34" charset="-120"/>
               </a:rPr>
               <a:t>Focus: Deep alliances, R&amp;D partnerships, capacity reservations.</a:t>
             </a:r>
@@ -7954,9 +7954,9 @@
                 <a:solidFill>
                   <a:srgbClr val="6B6560"/>
                 </a:solidFill>
-                <a:latin typeface="Bookman ITC Std" pitchFamily="34" charset="0"/>
-                <a:ea typeface="Bookman ITC Std" pitchFamily="34" charset="-122"/>
-                <a:cs typeface="Bookman ITC Std" pitchFamily="34" charset="-120"/>
+                <a:latin typeface="VVDS Fifties SCond Reg" pitchFamily="34" charset="0"/>
+                <a:ea typeface="VVDS Fifties SCond Reg" pitchFamily="34" charset="-122"/>
+                <a:cs typeface="VVDS Fifties SCond Reg" pitchFamily="34" charset="-120"/>
               </a:rPr>
               <a:t>Legacy Nodes</a:t>
             </a:r>
@@ -7977,9 +7977,9 @@
                 <a:solidFill>
                   <a:srgbClr val="6B6560"/>
                 </a:solidFill>
-                <a:latin typeface="Bookman ITC Std" pitchFamily="34" charset="0"/>
-                <a:ea typeface="Bookman ITC Std" pitchFamily="34" charset="-122"/>
-                <a:cs typeface="Bookman ITC Std" pitchFamily="34" charset="-120"/>
+                <a:latin typeface="VVDS Fifties SCond Reg" pitchFamily="34" charset="0"/>
+                <a:ea typeface="VVDS Fifties SCond Reg" pitchFamily="34" charset="-122"/>
+                <a:cs typeface="VVDS Fifties SCond Reg" pitchFamily="34" charset="-120"/>
               </a:rPr>
               <a:t>Focus: Multi-sourcing, distributor networks, life-cycle tracking.</a:t>
             </a:r>
@@ -8048,9 +8048,9 @@
                 <a:solidFill>
                   <a:srgbClr val="B84A2F"/>
                 </a:solidFill>
-                <a:latin typeface="Bookman ITC Std" pitchFamily="34" charset="0"/>
-                <a:ea typeface="Bookman ITC Std" pitchFamily="34" charset="-122"/>
-                <a:cs typeface="Bookman ITC Std" pitchFamily="34" charset="-120"/>
+                <a:latin typeface="VVDS Fifties Exp Reg" pitchFamily="34" charset="0"/>
+                <a:ea typeface="VVDS Fifties Exp Reg" pitchFamily="34" charset="-122"/>
+                <a:cs typeface="VVDS Fifties Exp Reg" pitchFamily="34" charset="-120"/>
               </a:rPr>
               <a:t>PART 1: PROCUREMENT OF SEMICONDUCTORS</a:t>
             </a:r>
@@ -8087,9 +8087,9 @@
                 <a:solidFill>
                   <a:srgbClr val="1A1714"/>
                 </a:solidFill>
-                <a:latin typeface="PP Mondwest" pitchFamily="34" charset="0"/>
-                <a:ea typeface="PP Mondwest" pitchFamily="34" charset="-122"/>
-                <a:cs typeface="PP Mondwest" pitchFamily="34" charset="-120"/>
+                <a:latin typeface="VVDS Fifties Exp SBold" pitchFamily="34" charset="0"/>
+                <a:ea typeface="VVDS Fifties Exp SBold" pitchFamily="34" charset="-122"/>
+                <a:cs typeface="VVDS Fifties Exp SBold" pitchFamily="34" charset="-120"/>
               </a:rPr>
               <a:t>Digitalization &amp; Resilience in Procurement</a:t>
             </a:r>
@@ -8126,9 +8126,9 @@
                 <a:solidFill>
                   <a:srgbClr val="6B6560"/>
                 </a:solidFill>
-                <a:latin typeface="Bookman ITC Std" pitchFamily="34" charset="0"/>
-                <a:ea typeface="Bookman ITC Std" pitchFamily="34" charset="-122"/>
-                <a:cs typeface="Bookman ITC Std" pitchFamily="34" charset="-120"/>
+                <a:latin typeface="VVDS Fifties Exp Reg" pitchFamily="34" charset="0"/>
+                <a:ea typeface="VVDS Fifties Exp Reg" pitchFamily="34" charset="-122"/>
+                <a:cs typeface="VVDS Fifties Exp Reg" pitchFamily="34" charset="-120"/>
               </a:rPr>
               <a:t>The 2026 Semiconductor Ecosystem | Slide 05</a:t>
             </a:r>
@@ -8190,9 +8190,9 @@
                 <a:solidFill>
                   <a:srgbClr val="B84A2F"/>
                 </a:solidFill>
-                <a:latin typeface="Bookman ITC Std" pitchFamily="34" charset="0"/>
-                <a:ea typeface="Bookman ITC Std" pitchFamily="34" charset="-122"/>
-                <a:cs typeface="Bookman ITC Std" pitchFamily="34" charset="-120"/>
+                <a:latin typeface="VVDS Fifties SCond Reg" pitchFamily="34" charset="0"/>
+                <a:ea typeface="VVDS Fifties SCond Reg" pitchFamily="34" charset="-122"/>
+                <a:cs typeface="VVDS Fifties SCond Reg" pitchFamily="34" charset="-120"/>
               </a:rPr>
               <a:t>Key Message: AI-driven "Business Intelligence Cockpits" are essential for predicting shortages 6-12 months in advance.</a:t>
             </a:r>
@@ -8254,9 +8254,9 @@
                 <a:solidFill>
                   <a:srgbClr val="B84A2F"/>
                 </a:solidFill>
-                <a:latin typeface="PP Mondwest" pitchFamily="34" charset="0"/>
-                <a:ea typeface="PP Mondwest" pitchFamily="34" charset="-122"/>
-                <a:cs typeface="PP Mondwest" pitchFamily="34" charset="-120"/>
+                <a:latin typeface="VVDS Fifties SExp Reg" pitchFamily="34" charset="0"/>
+                <a:ea typeface="VVDS Fifties SExp Reg" pitchFamily="34" charset="-122"/>
+                <a:cs typeface="VVDS Fifties SExp Reg" pitchFamily="34" charset="-120"/>
               </a:rPr>
               <a:t>LTA &amp; Reservation Fees</a:t>
             </a:r>
@@ -8293,9 +8293,9 @@
                 <a:solidFill>
                   <a:srgbClr val="6B6560"/>
                 </a:solidFill>
-                <a:latin typeface="Bookman ITC Std" pitchFamily="34" charset="0"/>
-                <a:ea typeface="Bookman ITC Std" pitchFamily="34" charset="-122"/>
-                <a:cs typeface="Bookman ITC Std" pitchFamily="34" charset="-120"/>
+                <a:latin typeface="VVDS Fifties SCond Reg" pitchFamily="34" charset="0"/>
+                <a:ea typeface="VVDS Fifties SCond Reg" pitchFamily="34" charset="-122"/>
+                <a:cs typeface="VVDS Fifties SCond Reg" pitchFamily="34" charset="-120"/>
               </a:rPr>
               <a:t>Securing fab slots requires upfront reservation fees and take-or-pay clauses in Long-Term Agreements (LTAs) to lock down volume.</a:t>
             </a:r>
@@ -8357,9 +8357,9 @@
                 <a:solidFill>
                   <a:srgbClr val="768C7C"/>
                 </a:solidFill>
-                <a:latin typeface="PP Mondwest" pitchFamily="34" charset="0"/>
-                <a:ea typeface="PP Mondwest" pitchFamily="34" charset="-122"/>
-                <a:cs typeface="PP Mondwest" pitchFamily="34" charset="-120"/>
+                <a:latin typeface="VVDS Fifties SExp Reg" pitchFamily="34" charset="0"/>
+                <a:ea typeface="VVDS Fifties SExp Reg" pitchFamily="34" charset="-122"/>
+                <a:cs typeface="VVDS Fifties SExp Reg" pitchFamily="34" charset="-120"/>
               </a:rPr>
               <a:t>Friend-Shoring Sourcing</a:t>
             </a:r>
@@ -8396,9 +8396,9 @@
                 <a:solidFill>
                   <a:srgbClr val="6B6560"/>
                 </a:solidFill>
-                <a:latin typeface="Bookman ITC Std" pitchFamily="34" charset="0"/>
-                <a:ea typeface="Bookman ITC Std" pitchFamily="34" charset="-122"/>
-                <a:cs typeface="Bookman ITC Std" pitchFamily="34" charset="-120"/>
+                <a:latin typeface="VVDS Fifties SCond Reg" pitchFamily="34" charset="0"/>
+                <a:ea typeface="VVDS Fifties SCond Reg" pitchFamily="34" charset="-122"/>
+                <a:cs typeface="VVDS Fifties SCond Reg" pitchFamily="34" charset="-120"/>
               </a:rPr>
               <a:t>Decoupling supply links from high-risk locations, redirecting procurement to allied geopolitical nodes with guaranteed supply lines.</a:t>
             </a:r>
@@ -8460,9 +8460,9 @@
                 <a:solidFill>
                   <a:srgbClr val="6B6560"/>
                 </a:solidFill>
-                <a:latin typeface="Bookman ITC Std" pitchFamily="34" charset="0"/>
-                <a:ea typeface="Bookman ITC Std" pitchFamily="34" charset="-122"/>
-                <a:cs typeface="Bookman ITC Std" pitchFamily="34" charset="-120"/>
+                <a:latin typeface="VVDS Fifties SCond Reg" pitchFamily="34" charset="0"/>
+                <a:ea typeface="VVDS Fifties SCond Reg" pitchFamily="34" charset="-122"/>
+                <a:cs typeface="VVDS Fifties SCond Reg" pitchFamily="34" charset="-120"/>
               </a:rPr>
               <a:t>AI integration automatically tracks tier-2 chemical and substrate suppliers to detect factory closures or export blocks before they ripple into final fab allocations.</a:t>
             </a:r>
@@ -8531,9 +8531,9 @@
                 <a:solidFill>
                   <a:srgbClr val="B84A2F"/>
                 </a:solidFill>
-                <a:latin typeface="Bookman ITC Std" pitchFamily="34" charset="0"/>
-                <a:ea typeface="Bookman ITC Std" pitchFamily="34" charset="-122"/>
-                <a:cs typeface="Bookman ITC Std" pitchFamily="34" charset="-120"/>
+                <a:latin typeface="VVDS Fifties Exp Reg" pitchFamily="34" charset="0"/>
+                <a:ea typeface="VVDS Fifties Exp Reg" pitchFamily="34" charset="-122"/>
+                <a:cs typeface="VVDS Fifties Exp Reg" pitchFamily="34" charset="-120"/>
               </a:rPr>
               <a:t>PART 2: THE GLOBAL SUPPLY CHAIN OF SEMICONDUCTORS</a:t>
             </a:r>
@@ -8570,9 +8570,9 @@
                 <a:solidFill>
                   <a:srgbClr val="1A1714"/>
                 </a:solidFill>
-                <a:latin typeface="PP Mondwest" pitchFamily="34" charset="0"/>
-                <a:ea typeface="PP Mondwest" pitchFamily="34" charset="-122"/>
-                <a:cs typeface="PP Mondwest" pitchFamily="34" charset="-120"/>
+                <a:latin typeface="VVDS Fifties Exp SBold" pitchFamily="34" charset="0"/>
+                <a:ea typeface="VVDS Fifties Exp SBold" pitchFamily="34" charset="-122"/>
+                <a:cs typeface="VVDS Fifties Exp SBold" pitchFamily="34" charset="-120"/>
               </a:rPr>
               <a:t>The Global Supply Chain: A Web of Complexity</a:t>
             </a:r>
@@ -8609,9 +8609,9 @@
                 <a:solidFill>
                   <a:srgbClr val="6B6560"/>
                 </a:solidFill>
-                <a:latin typeface="Bookman ITC Std" pitchFamily="34" charset="0"/>
-                <a:ea typeface="Bookman ITC Std" pitchFamily="34" charset="-122"/>
-                <a:cs typeface="Bookman ITC Std" pitchFamily="34" charset="-120"/>
+                <a:latin typeface="VVDS Fifties Exp Reg" pitchFamily="34" charset="0"/>
+                <a:ea typeface="VVDS Fifties Exp Reg" pitchFamily="34" charset="-122"/>
+                <a:cs typeface="VVDS Fifties Exp Reg" pitchFamily="34" charset="-120"/>
               </a:rPr>
               <a:t>The 2026 Semiconductor Ecosystem | Slide 06</a:t>
             </a:r>
@@ -8673,9 +8673,9 @@
                 <a:solidFill>
                   <a:srgbClr val="B84A2F"/>
                 </a:solidFill>
-                <a:latin typeface="Bookman ITC Std" pitchFamily="34" charset="0"/>
-                <a:ea typeface="Bookman ITC Std" pitchFamily="34" charset="-122"/>
-                <a:cs typeface="Bookman ITC Std" pitchFamily="34" charset="-120"/>
+                <a:latin typeface="VVDS Fifties SCond Reg" pitchFamily="34" charset="0"/>
+                <a:ea typeface="VVDS Fifties SCond Reg" pitchFamily="34" charset="-122"/>
+                <a:cs typeface="VVDS Fifties SCond Reg" pitchFamily="34" charset="-120"/>
               </a:rPr>
               <a:t>Key Message: A single chip may cross international borders over 70 times, making it the most geographically dispersed value chain in history.</a:t>
             </a:r>
@@ -8712,9 +8712,9 @@
                 <a:solidFill>
                   <a:srgbClr val="768C7C"/>
                 </a:solidFill>
-                <a:latin typeface="Bookman ITC Std" pitchFamily="34" charset="0"/>
-                <a:ea typeface="Bookman ITC Std" pitchFamily="34" charset="-122"/>
-                <a:cs typeface="Bookman ITC Std" pitchFamily="34" charset="-120"/>
+                <a:latin typeface="VVDS Fifties SCond Reg" pitchFamily="34" charset="0"/>
+                <a:ea typeface="VVDS Fifties SCond Reg" pitchFamily="34" charset="-122"/>
+                <a:cs typeface="VVDS Fifties SCond Reg" pitchFamily="34" charset="-120"/>
               </a:rPr>
               <a:t>THE SILICON JOURNEY</a:t>
             </a:r>
@@ -8776,9 +8776,9 @@
                 <a:solidFill>
                   <a:srgbClr val="B84A2F"/>
                 </a:solidFill>
-                <a:latin typeface="PP Mondwest" pitchFamily="34" charset="0"/>
-                <a:ea typeface="PP Mondwest" pitchFamily="34" charset="-122"/>
-                <a:cs typeface="PP Mondwest" pitchFamily="34" charset="-120"/>
+                <a:latin typeface="VVDS Fifties Exp SBold" pitchFamily="34" charset="0"/>
+                <a:ea typeface="VVDS Fifties Exp SBold" pitchFamily="34" charset="-122"/>
+                <a:cs typeface="VVDS Fifties Exp SBold" pitchFamily="34" charset="-120"/>
               </a:rPr>
               <a:t>1</a:t>
             </a:r>
@@ -8815,9 +8815,9 @@
                 <a:solidFill>
                   <a:srgbClr val="1A1714"/>
                 </a:solidFill>
-                <a:latin typeface="Bookman ITC Std" pitchFamily="34" charset="0"/>
-                <a:ea typeface="Bookman ITC Std" pitchFamily="34" charset="-122"/>
-                <a:cs typeface="Bookman ITC Std" pitchFamily="34" charset="-120"/>
+                <a:latin typeface="VVDS Fifties SCond Reg" pitchFamily="34" charset="0"/>
+                <a:ea typeface="VVDS Fifties SCond Reg" pitchFamily="34" charset="-122"/>
+                <a:cs typeface="VVDS Fifties SCond Reg" pitchFamily="34" charset="-120"/>
               </a:rPr>
               <a:t>US Design</a:t>
             </a:r>
@@ -8854,9 +8854,9 @@
                 <a:solidFill>
                   <a:srgbClr val="6B6560"/>
                 </a:solidFill>
-                <a:latin typeface="Bookman ITC Std" pitchFamily="34" charset="0"/>
-                <a:ea typeface="Bookman ITC Std" pitchFamily="34" charset="-122"/>
-                <a:cs typeface="Bookman ITC Std" pitchFamily="34" charset="-120"/>
+                <a:latin typeface="VVDS Fifties Exp Reg" pitchFamily="34" charset="0"/>
+                <a:ea typeface="VVDS Fifties Exp Reg" pitchFamily="34" charset="-122"/>
+                <a:cs typeface="VVDS Fifties Exp Reg" pitchFamily="34" charset="-120"/>
               </a:rPr>
               <a:t>Design &amp; EDA Tools</a:t>
             </a:r>
@@ -8918,9 +8918,9 @@
                 <a:solidFill>
                   <a:srgbClr val="B84A2F"/>
                 </a:solidFill>
-                <a:latin typeface="PP Mondwest" pitchFamily="34" charset="0"/>
-                <a:ea typeface="PP Mondwest" pitchFamily="34" charset="-122"/>
-                <a:cs typeface="PP Mondwest" pitchFamily="34" charset="-120"/>
+                <a:latin typeface="VVDS Fifties Exp SBold" pitchFamily="34" charset="0"/>
+                <a:ea typeface="VVDS Fifties Exp SBold" pitchFamily="34" charset="-122"/>
+                <a:cs typeface="VVDS Fifties Exp SBold" pitchFamily="34" charset="-120"/>
               </a:rPr>
               <a:t>2</a:t>
             </a:r>
@@ -8957,9 +8957,9 @@
                 <a:solidFill>
                   <a:srgbClr val="1A1714"/>
                 </a:solidFill>
-                <a:latin typeface="Bookman ITC Std" pitchFamily="34" charset="0"/>
-                <a:ea typeface="Bookman ITC Std" pitchFamily="34" charset="-122"/>
-                <a:cs typeface="Bookman ITC Std" pitchFamily="34" charset="-120"/>
+                <a:latin typeface="VVDS Fifties SCond Reg" pitchFamily="34" charset="0"/>
+                <a:ea typeface="VVDS Fifties SCond Reg" pitchFamily="34" charset="-122"/>
+                <a:cs typeface="VVDS Fifties SCond Reg" pitchFamily="34" charset="-120"/>
               </a:rPr>
               <a:t>Dutch SME</a:t>
             </a:r>
@@ -8996,9 +8996,9 @@
                 <a:solidFill>
                   <a:srgbClr val="6B6560"/>
                 </a:solidFill>
-                <a:latin typeface="Bookman ITC Std" pitchFamily="34" charset="0"/>
-                <a:ea typeface="Bookman ITC Std" pitchFamily="34" charset="-122"/>
-                <a:cs typeface="Bookman ITC Std" pitchFamily="34" charset="-120"/>
+                <a:latin typeface="VVDS Fifties Exp Reg" pitchFamily="34" charset="0"/>
+                <a:ea typeface="VVDS Fifties Exp Reg" pitchFamily="34" charset="-122"/>
+                <a:cs typeface="VVDS Fifties Exp Reg" pitchFamily="34" charset="-120"/>
               </a:rPr>
               <a:t>ASML EUV Optics</a:t>
             </a:r>
@@ -9060,9 +9060,9 @@
                 <a:solidFill>
                   <a:srgbClr val="B84A2F"/>
                 </a:solidFill>
-                <a:latin typeface="PP Mondwest" pitchFamily="34" charset="0"/>
-                <a:ea typeface="PP Mondwest" pitchFamily="34" charset="-122"/>
-                <a:cs typeface="PP Mondwest" pitchFamily="34" charset="-120"/>
+                <a:latin typeface="VVDS Fifties Exp SBold" pitchFamily="34" charset="0"/>
+                <a:ea typeface="VVDS Fifties Exp SBold" pitchFamily="34" charset="-122"/>
+                <a:cs typeface="VVDS Fifties Exp SBold" pitchFamily="34" charset="-120"/>
               </a:rPr>
               <a:t>3</a:t>
             </a:r>
@@ -9099,9 +9099,9 @@
                 <a:solidFill>
                   <a:srgbClr val="1A1714"/>
                 </a:solidFill>
-                <a:latin typeface="Bookman ITC Std" pitchFamily="34" charset="0"/>
-                <a:ea typeface="Bookman ITC Std" pitchFamily="34" charset="-122"/>
-                <a:cs typeface="Bookman ITC Std" pitchFamily="34" charset="-120"/>
+                <a:latin typeface="VVDS Fifties SCond Reg" pitchFamily="34" charset="0"/>
+                <a:ea typeface="VVDS Fifties SCond Reg" pitchFamily="34" charset="-122"/>
+                <a:cs typeface="VVDS Fifties SCond Reg" pitchFamily="34" charset="-120"/>
               </a:rPr>
               <a:t>Taiwan Fab</a:t>
             </a:r>
@@ -9138,9 +9138,9 @@
                 <a:solidFill>
                   <a:srgbClr val="6B6560"/>
                 </a:solidFill>
-                <a:latin typeface="Bookman ITC Std" pitchFamily="34" charset="0"/>
-                <a:ea typeface="Bookman ITC Std" pitchFamily="34" charset="-122"/>
-                <a:cs typeface="Bookman ITC Std" pitchFamily="34" charset="-120"/>
+                <a:latin typeface="VVDS Fifties Exp Reg" pitchFamily="34" charset="0"/>
+                <a:ea typeface="VVDS Fifties Exp Reg" pitchFamily="34" charset="-122"/>
+                <a:cs typeface="VVDS Fifties Exp Reg" pitchFamily="34" charset="-120"/>
               </a:rPr>
               <a:t>TSMC Printing</a:t>
             </a:r>
@@ -9202,9 +9202,9 @@
                 <a:solidFill>
                   <a:srgbClr val="B84A2F"/>
                 </a:solidFill>
-                <a:latin typeface="PP Mondwest" pitchFamily="34" charset="0"/>
-                <a:ea typeface="PP Mondwest" pitchFamily="34" charset="-122"/>
-                <a:cs typeface="PP Mondwest" pitchFamily="34" charset="-120"/>
+                <a:latin typeface="VVDS Fifties Exp SBold" pitchFamily="34" charset="0"/>
+                <a:ea typeface="VVDS Fifties Exp SBold" pitchFamily="34" charset="-122"/>
+                <a:cs typeface="VVDS Fifties Exp SBold" pitchFamily="34" charset="-120"/>
               </a:rPr>
               <a:t>4</a:t>
             </a:r>
@@ -9241,9 +9241,9 @@
                 <a:solidFill>
                   <a:srgbClr val="1A1714"/>
                 </a:solidFill>
-                <a:latin typeface="Bookman ITC Std" pitchFamily="34" charset="0"/>
-                <a:ea typeface="Bookman ITC Std" pitchFamily="34" charset="-122"/>
-                <a:cs typeface="Bookman ITC Std" pitchFamily="34" charset="-120"/>
+                <a:latin typeface="VVDS Fifties SCond Reg" pitchFamily="34" charset="0"/>
+                <a:ea typeface="VVDS Fifties SCond Reg" pitchFamily="34" charset="-122"/>
+                <a:cs typeface="VVDS Fifties SCond Reg" pitchFamily="34" charset="-120"/>
               </a:rPr>
               <a:t>Japan Material</a:t>
             </a:r>
@@ -9280,9 +9280,9 @@
                 <a:solidFill>
                   <a:srgbClr val="6B6560"/>
                 </a:solidFill>
-                <a:latin typeface="Bookman ITC Std" pitchFamily="34" charset="0"/>
-                <a:ea typeface="Bookman ITC Std" pitchFamily="34" charset="-122"/>
-                <a:cs typeface="Bookman ITC Std" pitchFamily="34" charset="-120"/>
+                <a:latin typeface="VVDS Fifties Exp Reg" pitchFamily="34" charset="0"/>
+                <a:ea typeface="VVDS Fifties Exp Reg" pitchFamily="34" charset="-122"/>
+                <a:cs typeface="VVDS Fifties Exp Reg" pitchFamily="34" charset="-120"/>
               </a:rPr>
               <a:t>Wafers &amp; Photoresist</a:t>
             </a:r>
@@ -9344,9 +9344,9 @@
                 <a:solidFill>
                   <a:srgbClr val="B84A2F"/>
                 </a:solidFill>
-                <a:latin typeface="PP Mondwest" pitchFamily="34" charset="0"/>
-                <a:ea typeface="PP Mondwest" pitchFamily="34" charset="-122"/>
-                <a:cs typeface="PP Mondwest" pitchFamily="34" charset="-120"/>
+                <a:latin typeface="VVDS Fifties Exp SBold" pitchFamily="34" charset="0"/>
+                <a:ea typeface="VVDS Fifties Exp SBold" pitchFamily="34" charset="-122"/>
+                <a:cs typeface="VVDS Fifties Exp SBold" pitchFamily="34" charset="-120"/>
               </a:rPr>
               <a:t>5</a:t>
             </a:r>
@@ -9383,9 +9383,9 @@
                 <a:solidFill>
                   <a:srgbClr val="1A1714"/>
                 </a:solidFill>
-                <a:latin typeface="Bookman ITC Std" pitchFamily="34" charset="0"/>
-                <a:ea typeface="Bookman ITC Std" pitchFamily="34" charset="-122"/>
-                <a:cs typeface="Bookman ITC Std" pitchFamily="34" charset="-120"/>
+                <a:latin typeface="VVDS Fifties SCond Reg" pitchFamily="34" charset="0"/>
+                <a:ea typeface="VVDS Fifties SCond Reg" pitchFamily="34" charset="-122"/>
+                <a:cs typeface="VVDS Fifties SCond Reg" pitchFamily="34" charset="-120"/>
               </a:rPr>
               <a:t>SE Asia Pack</a:t>
             </a:r>
@@ -9422,9 +9422,9 @@
                 <a:solidFill>
                   <a:srgbClr val="6B6560"/>
                 </a:solidFill>
-                <a:latin typeface="Bookman ITC Std" pitchFamily="34" charset="0"/>
-                <a:ea typeface="Bookman ITC Std" pitchFamily="34" charset="-122"/>
-                <a:cs typeface="Bookman ITC Std" pitchFamily="34" charset="-120"/>
+                <a:latin typeface="VVDS Fifties Exp Reg" pitchFamily="34" charset="0"/>
+                <a:ea typeface="VVDS Fifties Exp Reg" pitchFamily="34" charset="-122"/>
+                <a:cs typeface="VVDS Fifties Exp Reg" pitchFamily="34" charset="-120"/>
               </a:rPr>
               <a:t>OSAT Assembly</a:t>
             </a:r>
@@ -9493,9 +9493,9 @@
                 <a:solidFill>
                   <a:srgbClr val="B84A2F"/>
                 </a:solidFill>
-                <a:latin typeface="Bookman ITC Std" pitchFamily="34" charset="0"/>
-                <a:ea typeface="Bookman ITC Std" pitchFamily="34" charset="-122"/>
-                <a:cs typeface="Bookman ITC Std" pitchFamily="34" charset="-120"/>
+                <a:latin typeface="VVDS Fifties Exp Reg" pitchFamily="34" charset="0"/>
+                <a:ea typeface="VVDS Fifties Exp Reg" pitchFamily="34" charset="-122"/>
+                <a:cs typeface="VVDS Fifties Exp Reg" pitchFamily="34" charset="-120"/>
               </a:rPr>
               <a:t>PART 2: THE GLOBAL SUPPLY CHAIN OF SEMICONDUCTORS</a:t>
             </a:r>
@@ -9532,9 +9532,9 @@
                 <a:solidFill>
                   <a:srgbClr val="1A1714"/>
                 </a:solidFill>
-                <a:latin typeface="PP Mondwest" pitchFamily="34" charset="0"/>
-                <a:ea typeface="PP Mondwest" pitchFamily="34" charset="-122"/>
-                <a:cs typeface="PP Mondwest" pitchFamily="34" charset="-120"/>
+                <a:latin typeface="VVDS Fifties Exp SBold" pitchFamily="34" charset="0"/>
+                <a:ea typeface="VVDS Fifties Exp SBold" pitchFamily="34" charset="-122"/>
+                <a:cs typeface="VVDS Fifties Exp SBold" pitchFamily="34" charset="-120"/>
               </a:rPr>
               <a:t>Architecture of the Global Value Chain (GVC)</a:t>
             </a:r>
@@ -9571,9 +9571,9 @@
                 <a:solidFill>
                   <a:srgbClr val="6B6560"/>
                 </a:solidFill>
-                <a:latin typeface="Bookman ITC Std" pitchFamily="34" charset="0"/>
-                <a:ea typeface="Bookman ITC Std" pitchFamily="34" charset="-122"/>
-                <a:cs typeface="Bookman ITC Std" pitchFamily="34" charset="-120"/>
+                <a:latin typeface="VVDS Fifties Exp Reg" pitchFamily="34" charset="0"/>
+                <a:ea typeface="VVDS Fifties Exp Reg" pitchFamily="34" charset="-122"/>
+                <a:cs typeface="VVDS Fifties Exp Reg" pitchFamily="34" charset="-120"/>
               </a:rPr>
               <a:t>The 2026 Semiconductor Ecosystem | Slide 07</a:t>
             </a:r>
@@ -9635,9 +9635,9 @@
                 <a:solidFill>
                   <a:srgbClr val="9E7D84"/>
                 </a:solidFill>
-                <a:latin typeface="Bookman ITC Std" pitchFamily="34" charset="0"/>
-                <a:ea typeface="Bookman ITC Std" pitchFamily="34" charset="-122"/>
-                <a:cs typeface="Bookman ITC Std" pitchFamily="34" charset="-120"/>
+                <a:latin typeface="VVDS Fifties SCond Reg" pitchFamily="34" charset="0"/>
+                <a:ea typeface="VVDS Fifties SCond Reg" pitchFamily="34" charset="-122"/>
+                <a:cs typeface="VVDS Fifties SCond Reg" pitchFamily="34" charset="-120"/>
               </a:rPr>
               <a:t>Key Message: Value is highly concentrated in specialized clusters: U.S. (Design), Europe (Equipment), and East Asia (Manufacturing).</a:t>
             </a:r>
@@ -9675,9 +9675,9 @@
                 <a:solidFill>
                   <a:srgbClr val="6B6560"/>
                 </a:solidFill>
-                <a:latin typeface="Bookman ITC Std" pitchFamily="34" charset="0"/>
-                <a:ea typeface="Bookman ITC Std" pitchFamily="34" charset="-122"/>
-                <a:cs typeface="Bookman ITC Std" pitchFamily="34" charset="-120"/>
+                <a:latin typeface="VVDS Fifties SCond Reg" pitchFamily="34" charset="0"/>
+                <a:ea typeface="VVDS Fifties SCond Reg" pitchFamily="34" charset="-122"/>
+                <a:cs typeface="VVDS Fifties SCond Reg" pitchFamily="34" charset="-120"/>
               </a:rPr>
               <a:t>- Design &amp; EDA (United States): Dominance in core processor blueprints and layout compiler systems (NVIDIA, Apple, Qualcomm).</a:t>
             </a:r>
@@ -9700,9 +9700,9 @@
                 <a:solidFill>
                   <a:srgbClr val="6B6560"/>
                 </a:solidFill>
-                <a:latin typeface="Bookman ITC Std" pitchFamily="34" charset="0"/>
-                <a:ea typeface="Bookman ITC Std" pitchFamily="34" charset="-122"/>
-                <a:cs typeface="Bookman ITC Std" pitchFamily="34" charset="-120"/>
+                <a:latin typeface="VVDS Fifties SCond Reg" pitchFamily="34" charset="0"/>
+                <a:ea typeface="VVDS Fifties SCond Reg" pitchFamily="34" charset="-122"/>
+                <a:cs typeface="VVDS Fifties SCond Reg" pitchFamily="34" charset="-120"/>
               </a:rPr>
               <a:t>- SME Equipment (Europe): Monopoly on Extreme Ultraviolet tools (ASML) required to etch sub-7nm circuit nodes.</a:t>
             </a:r>
@@ -9725,9 +9725,9 @@
                 <a:solidFill>
                   <a:srgbClr val="6B6560"/>
                 </a:solidFill>
-                <a:latin typeface="Bookman ITC Std" pitchFamily="34" charset="0"/>
-                <a:ea typeface="Bookman ITC Std" pitchFamily="34" charset="-122"/>
-                <a:cs typeface="Bookman ITC Std" pitchFamily="34" charset="-120"/>
+                <a:latin typeface="VVDS Fifties SCond Reg" pitchFamily="34" charset="0"/>
+                <a:ea typeface="VVDS Fifties SCond Reg" pitchFamily="34" charset="-122"/>
+                <a:cs typeface="VVDS Fifties SCond Reg" pitchFamily="34" charset="-120"/>
               </a:rPr>
               <a:t>- Wafer Fabrication (East Asia): TSMC (Taiwan) and Samsung (Korea) form the production base for global advanced nodes.</a:t>
             </a:r>
@@ -9789,9 +9789,9 @@
                 <a:solidFill>
                   <a:srgbClr val="6B6560"/>
                 </a:solidFill>
-                <a:latin typeface="Bookman ITC Std" pitchFamily="34" charset="0"/>
-                <a:ea typeface="Bookman ITC Std" pitchFamily="34" charset="-122"/>
-                <a:cs typeface="Bookman ITC Std" pitchFamily="34" charset="-120"/>
+                <a:latin typeface="VVDS Fifties SCond Reg" pitchFamily="34" charset="0"/>
+                <a:ea typeface="VVDS Fifties SCond Reg" pitchFamily="34" charset="-122"/>
+                <a:cs typeface="VVDS Fifties SCond Reg" pitchFamily="34" charset="-120"/>
               </a:rPr>
               <a:t>USA: Design IP</a:t>
             </a:r>
@@ -9812,9 +9812,9 @@
                 <a:solidFill>
                   <a:srgbClr val="6B6560"/>
                 </a:solidFill>
-                <a:latin typeface="Bookman ITC Std" pitchFamily="34" charset="0"/>
-                <a:ea typeface="Bookman ITC Std" pitchFamily="34" charset="-122"/>
-                <a:cs typeface="Bookman ITC Std" pitchFamily="34" charset="-120"/>
+                <a:latin typeface="VVDS Fifties SCond Reg" pitchFamily="34" charset="0"/>
+                <a:ea typeface="VVDS Fifties SCond Reg" pitchFamily="34" charset="-122"/>
+                <a:cs typeface="VVDS Fifties SCond Reg" pitchFamily="34" charset="-120"/>
               </a:rPr>
               <a:t>80%+ market share in advanced EDA software tools.</a:t>
             </a:r>
@@ -9876,9 +9876,9 @@
                 <a:solidFill>
                   <a:srgbClr val="6B6560"/>
                 </a:solidFill>
-                <a:latin typeface="Bookman ITC Std" pitchFamily="34" charset="0"/>
-                <a:ea typeface="Bookman ITC Std" pitchFamily="34" charset="-122"/>
-                <a:cs typeface="Bookman ITC Std" pitchFamily="34" charset="-120"/>
+                <a:latin typeface="VVDS Fifties SCond Reg" pitchFamily="34" charset="0"/>
+                <a:ea typeface="VVDS Fifties SCond Reg" pitchFamily="34" charset="-122"/>
+                <a:cs typeface="VVDS Fifties SCond Reg" pitchFamily="34" charset="-120"/>
               </a:rPr>
               <a:t>ASML (EU): Lithography</a:t>
             </a:r>
@@ -9899,9 +9899,9 @@
                 <a:solidFill>
                   <a:srgbClr val="6B6560"/>
                 </a:solidFill>
-                <a:latin typeface="Bookman ITC Std" pitchFamily="34" charset="0"/>
-                <a:ea typeface="Bookman ITC Std" pitchFamily="34" charset="-122"/>
-                <a:cs typeface="Bookman ITC Std" pitchFamily="34" charset="-120"/>
+                <a:latin typeface="VVDS Fifties SCond Reg" pitchFamily="34" charset="0"/>
+                <a:ea typeface="VVDS Fifties SCond Reg" pitchFamily="34" charset="-122"/>
+                <a:cs typeface="VVDS Fifties SCond Reg" pitchFamily="34" charset="-120"/>
               </a:rPr>
               <a:t>100% monopsony on EUV printing technology.</a:t>
             </a:r>
@@ -9970,9 +9970,9 @@
                 <a:solidFill>
                   <a:srgbClr val="B84A2F"/>
                 </a:solidFill>
-                <a:latin typeface="Bookman ITC Std" pitchFamily="34" charset="0"/>
-                <a:ea typeface="Bookman ITC Std" pitchFamily="34" charset="-122"/>
-                <a:cs typeface="Bookman ITC Std" pitchFamily="34" charset="-120"/>
+                <a:latin typeface="VVDS Fifties Exp Reg" pitchFamily="34" charset="0"/>
+                <a:ea typeface="VVDS Fifties Exp Reg" pitchFamily="34" charset="-122"/>
+                <a:cs typeface="VVDS Fifties Exp Reg" pitchFamily="34" charset="-120"/>
               </a:rPr>
               <a:t>PART 2: THE GLOBAL SUPPLY CHAIN OF SEMICONDUCTORS</a:t>
             </a:r>
@@ -10009,9 +10009,9 @@
                 <a:solidFill>
                   <a:srgbClr val="1A1714"/>
                 </a:solidFill>
-                <a:latin typeface="PP Mondwest" pitchFamily="34" charset="0"/>
-                <a:ea typeface="PP Mondwest" pitchFamily="34" charset="-122"/>
-                <a:cs typeface="PP Mondwest" pitchFamily="34" charset="-120"/>
+                <a:latin typeface="VVDS Fifties Exp SBold" pitchFamily="34" charset="0"/>
+                <a:ea typeface="VVDS Fifties Exp SBold" pitchFamily="34" charset="-122"/>
+                <a:cs typeface="VVDS Fifties Exp SBold" pitchFamily="34" charset="-120"/>
               </a:rPr>
               <a:t>Front-End &amp; Back-End Bottlenecks</a:t>
             </a:r>
@@ -10048,9 +10048,9 @@
                 <a:solidFill>
                   <a:srgbClr val="6B6560"/>
                 </a:solidFill>
-                <a:latin typeface="Bookman ITC Std" pitchFamily="34" charset="0"/>
-                <a:ea typeface="Bookman ITC Std" pitchFamily="34" charset="-122"/>
-                <a:cs typeface="Bookman ITC Std" pitchFamily="34" charset="-120"/>
+                <a:latin typeface="VVDS Fifties Exp Reg" pitchFamily="34" charset="0"/>
+                <a:ea typeface="VVDS Fifties Exp Reg" pitchFamily="34" charset="-122"/>
+                <a:cs typeface="VVDS Fifties Exp Reg" pitchFamily="34" charset="-120"/>
               </a:rPr>
               <a:t>The 2026 Semiconductor Ecosystem | Slide 08</a:t>
             </a:r>
@@ -10112,9 +10112,9 @@
                 <a:solidFill>
                   <a:srgbClr val="768C7C"/>
                 </a:solidFill>
-                <a:latin typeface="Bookman ITC Std" pitchFamily="34" charset="0"/>
-                <a:ea typeface="Bookman ITC Std" pitchFamily="34" charset="-122"/>
-                <a:cs typeface="Bookman ITC Std" pitchFamily="34" charset="-120"/>
+                <a:latin typeface="VVDS Fifties SCond Reg" pitchFamily="34" charset="0"/>
+                <a:ea typeface="VVDS Fifties SCond Reg" pitchFamily="34" charset="-122"/>
+                <a:cs typeface="VVDS Fifties SCond Reg" pitchFamily="34" charset="-120"/>
               </a:rPr>
               <a:t>Key Message: Advanced packaging (CoWoS, 3D Stacking) is the new primary growth limiter for the AI industry.</a:t>
             </a:r>
@@ -10176,9 +10176,9 @@
                 <a:solidFill>
                   <a:srgbClr val="B84A2F"/>
                 </a:solidFill>
-                <a:latin typeface="PP Mondwest" pitchFamily="34" charset="0"/>
-                <a:ea typeface="PP Mondwest" pitchFamily="34" charset="-122"/>
-                <a:cs typeface="PP Mondwest" pitchFamily="34" charset="-120"/>
+                <a:latin typeface="VVDS Fifties SExp Reg" pitchFamily="34" charset="0"/>
+                <a:ea typeface="VVDS Fifties SExp Reg" pitchFamily="34" charset="-122"/>
+                <a:cs typeface="VVDS Fifties SExp Reg" pitchFamily="34" charset="-120"/>
               </a:rPr>
               <a:t>Front-End: Node Scaling</a:t>
             </a:r>
@@ -10215,9 +10215,9 @@
                 <a:solidFill>
                   <a:srgbClr val="6B6560"/>
                 </a:solidFill>
-                <a:latin typeface="Bookman ITC Std" pitchFamily="34" charset="0"/>
-                <a:ea typeface="Bookman ITC Std" pitchFamily="34" charset="-122"/>
-                <a:cs typeface="Bookman ITC Std" pitchFamily="34" charset="-120"/>
+                <a:latin typeface="VVDS Fifties SCond Reg" pitchFamily="34" charset="0"/>
+                <a:ea typeface="VVDS Fifties SCond Reg" pitchFamily="34" charset="-122"/>
+                <a:cs typeface="VVDS Fifties SCond Reg" pitchFamily="34" charset="-120"/>
               </a:rPr>
               <a:t>The race for the 2nm and 1.4nm nodes continues to demand immense capital investments for wafer fabrication lines.</a:t>
             </a:r>
@@ -10279,9 +10279,9 @@
                 <a:solidFill>
                   <a:srgbClr val="768C7C"/>
                 </a:solidFill>
-                <a:latin typeface="PP Mondwest" pitchFamily="34" charset="0"/>
-                <a:ea typeface="PP Mondwest" pitchFamily="34" charset="-122"/>
-                <a:cs typeface="PP Mondwest" pitchFamily="34" charset="-120"/>
+                <a:latin typeface="VVDS Fifties SExp Reg" pitchFamily="34" charset="0"/>
+                <a:ea typeface="VVDS Fifties SExp Reg" pitchFamily="34" charset="-122"/>
+                <a:cs typeface="VVDS Fifties SExp Reg" pitchFamily="34" charset="-120"/>
               </a:rPr>
               <a:t>Back-End: Advanced Packaging Chokepoint</a:t>
             </a:r>
@@ -10318,9 +10318,9 @@
                 <a:solidFill>
                   <a:srgbClr val="6B6560"/>
                 </a:solidFill>
-                <a:latin typeface="Bookman ITC Std" pitchFamily="34" charset="0"/>
-                <a:ea typeface="Bookman ITC Std" pitchFamily="34" charset="-122"/>
-                <a:cs typeface="Bookman ITC Std" pitchFamily="34" charset="-120"/>
+                <a:latin typeface="VVDS Fifties SCond Reg" pitchFamily="34" charset="0"/>
+                <a:ea typeface="VVDS Fifties SCond Reg" pitchFamily="34" charset="-122"/>
+                <a:cs typeface="VVDS Fifties SCond Reg" pitchFamily="34" charset="-120"/>
               </a:rPr>
               <a:t>Integrating multiple logic dies and High Bandwidth Memory (HBM) via CoWoS interposers is more constrained than wafer printing.</a:t>
             </a:r>
@@ -10382,9 +10382,9 @@
                 <a:solidFill>
                   <a:srgbClr val="6B6560"/>
                 </a:solidFill>
-                <a:latin typeface="Bookman ITC Std" pitchFamily="34" charset="0"/>
-                <a:ea typeface="Bookman ITC Std" pitchFamily="34" charset="-122"/>
-                <a:cs typeface="Bookman ITC Std" pitchFamily="34" charset="-120"/>
+                <a:latin typeface="VVDS Fifties SCond Reg" pitchFamily="34" charset="0"/>
+                <a:ea typeface="VVDS Fifties SCond Reg" pitchFamily="34" charset="-122"/>
+                <a:cs typeface="VVDS Fifties SCond Reg" pitchFamily="34" charset="-120"/>
               </a:rPr>
               <a:t>Logistics bottleneck: Reaching target AI yields depends heavily on advanced back-end capacity, not just front-end print nodes.</a:t>
             </a:r>
@@ -10453,9 +10453,9 @@
                 <a:solidFill>
                   <a:srgbClr val="B84A2F"/>
                 </a:solidFill>
-                <a:latin typeface="Bookman ITC Std" pitchFamily="34" charset="0"/>
-                <a:ea typeface="Bookman ITC Std" pitchFamily="34" charset="-122"/>
-                <a:cs typeface="Bookman ITC Std" pitchFamily="34" charset="-120"/>
+                <a:latin typeface="VVDS Fifties Exp Reg" pitchFamily="34" charset="0"/>
+                <a:ea typeface="VVDS Fifties Exp Reg" pitchFamily="34" charset="-122"/>
+                <a:cs typeface="VVDS Fifties Exp Reg" pitchFamily="34" charset="-120"/>
               </a:rPr>
               <a:t>PART 2: THE GLOBAL SUPPLY CHAIN OF SEMICONDUCTORS</a:t>
             </a:r>
@@ -10492,9 +10492,9 @@
                 <a:solidFill>
                   <a:srgbClr val="1A1714"/>
                 </a:solidFill>
-                <a:latin typeface="PP Mondwest" pitchFamily="34" charset="0"/>
-                <a:ea typeface="PP Mondwest" pitchFamily="34" charset="-122"/>
-                <a:cs typeface="PP Mondwest" pitchFamily="34" charset="-120"/>
+                <a:latin typeface="VVDS Fifties Exp SBold" pitchFamily="34" charset="0"/>
+                <a:ea typeface="VVDS Fifties Exp SBold" pitchFamily="34" charset="-122"/>
+                <a:cs typeface="VVDS Fifties Exp SBold" pitchFamily="34" charset="-120"/>
               </a:rPr>
               <a:t>SME, Materials &amp; Geopolitical Fragmentation</a:t>
             </a:r>
@@ -10531,9 +10531,9 @@
                 <a:solidFill>
                   <a:srgbClr val="6B6560"/>
                 </a:solidFill>
-                <a:latin typeface="Bookman ITC Std" pitchFamily="34" charset="0"/>
-                <a:ea typeface="Bookman ITC Std" pitchFamily="34" charset="-122"/>
-                <a:cs typeface="Bookman ITC Std" pitchFamily="34" charset="-120"/>
+                <a:latin typeface="VVDS Fifties Exp Reg" pitchFamily="34" charset="0"/>
+                <a:ea typeface="VVDS Fifties Exp Reg" pitchFamily="34" charset="-122"/>
+                <a:cs typeface="VVDS Fifties Exp Reg" pitchFamily="34" charset="-120"/>
               </a:rPr>
               <a:t>The 2026 Semiconductor Ecosystem | Slide 09</a:t>
             </a:r>
@@ -10595,9 +10595,9 @@
                 <a:solidFill>
                   <a:srgbClr val="B84A2F"/>
                 </a:solidFill>
-                <a:latin typeface="Bookman ITC Std" pitchFamily="34" charset="0"/>
-                <a:ea typeface="Bookman ITC Std" pitchFamily="34" charset="-122"/>
-                <a:cs typeface="Bookman ITC Std" pitchFamily="34" charset="-120"/>
+                <a:latin typeface="VVDS Fifties SCond Reg" pitchFamily="34" charset="0"/>
+                <a:ea typeface="VVDS Fifties SCond Reg" pitchFamily="34" charset="-122"/>
+                <a:cs typeface="VVDS Fifties SCond Reg" pitchFamily="34" charset="-120"/>
               </a:rPr>
               <a:t>Key Message: Geopolitics has created a "Multi-Polar" silicon world, where export controls and subsidies drive regionalization.</a:t>
             </a:r>
@@ -10635,9 +10635,9 @@
                 <a:solidFill>
                   <a:srgbClr val="6B6560"/>
                 </a:solidFill>
-                <a:latin typeface="Bookman ITC Std" pitchFamily="34" charset="0"/>
-                <a:ea typeface="Bookman ITC Std" pitchFamily="34" charset="-122"/>
-                <a:cs typeface="Bookman ITC Std" pitchFamily="34" charset="-120"/>
+                <a:latin typeface="VVDS Fifties SCond Reg" pitchFamily="34" charset="0"/>
+                <a:ea typeface="VVDS Fifties SCond Reg" pitchFamily="34" charset="-122"/>
+                <a:cs typeface="VVDS Fifties SCond Reg" pitchFamily="34" charset="-120"/>
               </a:rPr>
               <a:t>- The US CHIPS Act ($52B): Funding the domestic establishment of advanced logic fabs to balance East Asian concentration.</a:t>
             </a:r>
@@ -10660,9 +10660,9 @@
                 <a:solidFill>
                   <a:srgbClr val="6B6560"/>
                 </a:solidFill>
-                <a:latin typeface="Bookman ITC Std" pitchFamily="34" charset="0"/>
-                <a:ea typeface="Bookman ITC Std" pitchFamily="34" charset="-122"/>
-                <a:cs typeface="Bookman ITC Std" pitchFamily="34" charset="-120"/>
+                <a:latin typeface="VVDS Fifties SCond Reg" pitchFamily="34" charset="0"/>
+                <a:ea typeface="VVDS Fifties SCond Reg" pitchFamily="34" charset="-122"/>
+                <a:cs typeface="VVDS Fifties SCond Reg" pitchFamily="34" charset="-120"/>
               </a:rPr>
               <a:t>- Europe &amp; China Reshoring: Multi-billion dollar state-supported programs targeting semiconductor in-sourcing.</a:t>
             </a:r>
@@ -10685,9 +10685,9 @@
                 <a:solidFill>
                   <a:srgbClr val="6B6560"/>
                 </a:solidFill>
-                <a:latin typeface="Bookman ITC Std" pitchFamily="34" charset="0"/>
-                <a:ea typeface="Bookman ITC Std" pitchFamily="34" charset="-122"/>
-                <a:cs typeface="Bookman ITC Std" pitchFamily="34" charset="-120"/>
+                <a:latin typeface="VVDS Fifties SCond Reg" pitchFamily="34" charset="0"/>
+                <a:ea typeface="VVDS Fifties SCond Reg" pitchFamily="34" charset="-122"/>
+                <a:cs typeface="VVDS Fifties SCond Reg" pitchFamily="34" charset="-120"/>
               </a:rPr>
               <a:t>- Material Chokepoints: Strict export controls placed on critical trace materials like Gallium and Germanium.</a:t>
             </a:r>
@@ -10749,9 +10749,9 @@
                 <a:solidFill>
                   <a:srgbClr val="B84A2F"/>
                 </a:solidFill>
-                <a:latin typeface="Bookman ITC Std" pitchFamily="34" charset="0"/>
-                <a:ea typeface="Bookman ITC Std" pitchFamily="34" charset="-122"/>
-                <a:cs typeface="Bookman ITC Std" pitchFamily="34" charset="-120"/>
+                <a:latin typeface="VVDS Fifties Exp Reg" pitchFamily="34" charset="0"/>
+                <a:ea typeface="VVDS Fifties Exp Reg" pitchFamily="34" charset="-122"/>
+                <a:cs typeface="VVDS Fifties Exp Reg" pitchFamily="34" charset="-120"/>
               </a:rPr>
               <a:t>CRITICAL CHOKEPOINT</a:t>
             </a:r>
@@ -10788,9 +10788,9 @@
                 <a:solidFill>
                   <a:srgbClr val="1A1714"/>
                 </a:solidFill>
-                <a:latin typeface="PP Mondwest" pitchFamily="34" charset="0"/>
-                <a:ea typeface="PP Mondwest" pitchFamily="34" charset="-122"/>
-                <a:cs typeface="PP Mondwest" pitchFamily="34" charset="-120"/>
+                <a:latin typeface="VVDS Fifties Exp SBold" pitchFamily="34" charset="0"/>
+                <a:ea typeface="VVDS Fifties Exp SBold" pitchFamily="34" charset="-122"/>
+                <a:cs typeface="VVDS Fifties Exp SBold" pitchFamily="34" charset="-120"/>
               </a:rPr>
               <a:t>Gallium &amp;</a:t>
             </a:r>
@@ -10805,9 +10805,9 @@
                 <a:solidFill>
                   <a:srgbClr val="1A1714"/>
                 </a:solidFill>
-                <a:latin typeface="PP Mondwest" pitchFamily="34" charset="0"/>
-                <a:ea typeface="PP Mondwest" pitchFamily="34" charset="-122"/>
-                <a:cs typeface="PP Mondwest" pitchFamily="34" charset="-120"/>
+                <a:latin typeface="VVDS Fifties Exp SBold" pitchFamily="34" charset="0"/>
+                <a:ea typeface="VVDS Fifties Exp SBold" pitchFamily="34" charset="-122"/>
+                <a:cs typeface="VVDS Fifties Exp SBold" pitchFamily="34" charset="-120"/>
               </a:rPr>
               <a:t>Germanium</a:t>
             </a:r>
@@ -10844,9 +10844,9 @@
                 <a:solidFill>
                   <a:srgbClr val="6B6560"/>
                 </a:solidFill>
-                <a:latin typeface="Bookman ITC Std" pitchFamily="34" charset="0"/>
-                <a:ea typeface="Bookman ITC Std" pitchFamily="34" charset="-122"/>
-                <a:cs typeface="Bookman ITC Std" pitchFamily="34" charset="-120"/>
+                <a:latin typeface="VVDS Fifties SCond Reg" pitchFamily="34" charset="0"/>
+                <a:ea typeface="VVDS Fifties SCond Reg" pitchFamily="34" charset="-122"/>
+                <a:cs typeface="VVDS Fifties SCond Reg" pitchFamily="34" charset="-120"/>
               </a:rPr>
               <a:t>Strict raw material export control levers</a:t>
             </a:r>

</xml_diff>

<commit_message>
Restore PP Mondwest for headings, keeping VVDS Fifties for body and buttons
</commit_message>
<xml_diff>
--- a/output/semiconductor-ecosystem-2026.pptx
+++ b/output/semiconductor-ecosystem-2026.pptx
@@ -2419,9 +2419,9 @@
                 <a:solidFill>
                   <a:srgbClr val="1A1714"/>
                 </a:solidFill>
-                <a:latin typeface="VVDS Fifties Exp SBold" pitchFamily="34" charset="0"/>
-                <a:ea typeface="VVDS Fifties Exp SBold" pitchFamily="34" charset="-122"/>
-                <a:cs typeface="VVDS Fifties Exp SBold" pitchFamily="34" charset="-120"/>
+                <a:latin typeface="PP Mondwest" pitchFamily="34" charset="0"/>
+                <a:ea typeface="PP Mondwest" pitchFamily="34" charset="-122"/>
+                <a:cs typeface="PP Mondwest" pitchFamily="34" charset="-120"/>
               </a:rPr>
               <a:t>The 2026 Semiconductor Ecosystem</a:t>
             </a:r>
@@ -2644,9 +2644,9 @@
                 <a:solidFill>
                   <a:srgbClr val="1A1714"/>
                 </a:solidFill>
-                <a:latin typeface="VVDS Fifties Exp SBold" pitchFamily="34" charset="0"/>
-                <a:ea typeface="VVDS Fifties Exp SBold" pitchFamily="34" charset="-122"/>
-                <a:cs typeface="VVDS Fifties Exp SBold" pitchFamily="34" charset="-120"/>
+                <a:latin typeface="PP Mondwest" pitchFamily="34" charset="0"/>
+                <a:ea typeface="PP Mondwest" pitchFamily="34" charset="-122"/>
+                <a:cs typeface="PP Mondwest" pitchFamily="34" charset="-120"/>
               </a:rPr>
               <a:t>Supply Chain Resilience: Digital &amp; Circular</a:t>
             </a:r>
@@ -2811,9 +2811,9 @@
                 <a:solidFill>
                   <a:srgbClr val="B84A2F"/>
                 </a:solidFill>
-                <a:latin typeface="VVDS Fifties SExp Reg" pitchFamily="34" charset="0"/>
-                <a:ea typeface="VVDS Fifties SExp Reg" pitchFamily="34" charset="-122"/>
-                <a:cs typeface="VVDS Fifties SExp Reg" pitchFamily="34" charset="-120"/>
+                <a:latin typeface="PP Mondwest" pitchFamily="34" charset="0"/>
+                <a:ea typeface="PP Mondwest" pitchFamily="34" charset="-122"/>
+                <a:cs typeface="PP Mondwest" pitchFamily="34" charset="-120"/>
               </a:rPr>
               <a:t>Deep Supply Mapping &amp; AI</a:t>
             </a:r>
@@ -2914,9 +2914,9 @@
                 <a:solidFill>
                   <a:srgbClr val="768C7C"/>
                 </a:solidFill>
-                <a:latin typeface="VVDS Fifties SExp Reg" pitchFamily="34" charset="0"/>
-                <a:ea typeface="VVDS Fifties SExp Reg" pitchFamily="34" charset="-122"/>
-                <a:cs typeface="VVDS Fifties SExp Reg" pitchFamily="34" charset="-120"/>
+                <a:latin typeface="PP Mondwest" pitchFamily="34" charset="0"/>
+                <a:ea typeface="PP Mondwest" pitchFamily="34" charset="-122"/>
+                <a:cs typeface="PP Mondwest" pitchFamily="34" charset="-120"/>
               </a:rPr>
               <a:t>Circular Reclamation</a:t>
             </a:r>
@@ -3127,9 +3127,9 @@
                 <a:solidFill>
                   <a:srgbClr val="1A1714"/>
                 </a:solidFill>
-                <a:latin typeface="VVDS Fifties Exp SBold" pitchFamily="34" charset="0"/>
-                <a:ea typeface="VVDS Fifties Exp SBold" pitchFamily="34" charset="-122"/>
-                <a:cs typeface="VVDS Fifties Exp SBold" pitchFamily="34" charset="-120"/>
+                <a:latin typeface="PP Mondwest" pitchFamily="34" charset="0"/>
+                <a:ea typeface="PP Mondwest" pitchFamily="34" charset="-122"/>
+                <a:cs typeface="PP Mondwest" pitchFamily="34" charset="-120"/>
               </a:rPr>
               <a:t>The Ubiquity of Silicon: Powering the Modern World</a:t>
             </a:r>
@@ -3423,9 +3423,9 @@
                 <a:solidFill>
                   <a:srgbClr val="1A1714"/>
                 </a:solidFill>
-                <a:latin typeface="VVDS Fifties Exp SBold" pitchFamily="34" charset="0"/>
-                <a:ea typeface="VVDS Fifties Exp SBold" pitchFamily="34" charset="-122"/>
-                <a:cs typeface="VVDS Fifties Exp SBold" pitchFamily="34" charset="-120"/>
+                <a:latin typeface="PP Mondwest" pitchFamily="34" charset="0"/>
+                <a:ea typeface="PP Mondwest" pitchFamily="34" charset="-122"/>
+                <a:cs typeface="PP Mondwest" pitchFamily="34" charset="-120"/>
               </a:rPr>
               <a:t>Silicon</a:t>
             </a:r>
@@ -3440,9 +3440,9 @@
                 <a:solidFill>
                   <a:srgbClr val="1A1714"/>
                 </a:solidFill>
-                <a:latin typeface="VVDS Fifties Exp SBold" pitchFamily="34" charset="0"/>
-                <a:ea typeface="VVDS Fifties Exp SBold" pitchFamily="34" charset="-122"/>
-                <a:cs typeface="VVDS Fifties Exp SBold" pitchFamily="34" charset="-120"/>
+                <a:latin typeface="PP Mondwest" pitchFamily="34" charset="0"/>
+                <a:ea typeface="PP Mondwest" pitchFamily="34" charset="-122"/>
+                <a:cs typeface="PP Mondwest" pitchFamily="34" charset="-120"/>
               </a:rPr>
               <a:t>Intensity</a:t>
             </a:r>
@@ -3589,9 +3589,9 @@
                 <a:solidFill>
                   <a:srgbClr val="1A1714"/>
                 </a:solidFill>
-                <a:latin typeface="VVDS Fifties Exp SBold" pitchFamily="34" charset="0"/>
-                <a:ea typeface="VVDS Fifties Exp SBold" pitchFamily="34" charset="-122"/>
-                <a:cs typeface="VVDS Fifties Exp SBold" pitchFamily="34" charset="-120"/>
+                <a:latin typeface="PP Mondwest" pitchFamily="34" charset="0"/>
+                <a:ea typeface="PP Mondwest" pitchFamily="34" charset="-122"/>
+                <a:cs typeface="PP Mondwest" pitchFamily="34" charset="-120"/>
               </a:rPr>
               <a:t>Executive Summary: The Demand Landscape in 2026</a:t>
             </a:r>
@@ -3756,9 +3756,9 @@
                 <a:solidFill>
                   <a:srgbClr val="B84A2F"/>
                 </a:solidFill>
-                <a:latin typeface="VVDS Fifties SExp Reg" pitchFamily="34" charset="0"/>
-                <a:ea typeface="VVDS Fifties SExp Reg" pitchFamily="34" charset="-122"/>
-                <a:cs typeface="VVDS Fifties SExp Reg" pitchFamily="34" charset="-120"/>
+                <a:latin typeface="PP Mondwest" pitchFamily="34" charset="0"/>
+                <a:ea typeface="PP Mondwest" pitchFamily="34" charset="-122"/>
+                <a:cs typeface="PP Mondwest" pitchFamily="34" charset="-120"/>
               </a:rPr>
               <a:t>AI Datacenters</a:t>
             </a:r>
@@ -3859,9 +3859,9 @@
                 <a:solidFill>
                   <a:srgbClr val="9E7D84"/>
                 </a:solidFill>
-                <a:latin typeface="VVDS Fifties SExp Reg" pitchFamily="34" charset="0"/>
-                <a:ea typeface="VVDS Fifties SExp Reg" pitchFamily="34" charset="-122"/>
-                <a:cs typeface="VVDS Fifties SExp Reg" pitchFamily="34" charset="-120"/>
+                <a:latin typeface="PP Mondwest" pitchFamily="34" charset="0"/>
+                <a:ea typeface="PP Mondwest" pitchFamily="34" charset="-122"/>
+                <a:cs typeface="PP Mondwest" pitchFamily="34" charset="-120"/>
               </a:rPr>
               <a:t>Automotive</a:t>
             </a:r>
@@ -3962,9 +3962,9 @@
                 <a:solidFill>
                   <a:srgbClr val="768C7C"/>
                 </a:solidFill>
-                <a:latin typeface="VVDS Fifties SExp Reg" pitchFamily="34" charset="0"/>
-                <a:ea typeface="VVDS Fifties SExp Reg" pitchFamily="34" charset="-122"/>
-                <a:cs typeface="VVDS Fifties SExp Reg" pitchFamily="34" charset="-120"/>
+                <a:latin typeface="PP Mondwest" pitchFamily="34" charset="0"/>
+                <a:ea typeface="PP Mondwest" pitchFamily="34" charset="-122"/>
+                <a:cs typeface="PP Mondwest" pitchFamily="34" charset="-120"/>
               </a:rPr>
               <a:t>Smartphones &amp; PCs</a:t>
             </a:r>
@@ -4111,9 +4111,9 @@
                 <a:solidFill>
                   <a:srgbClr val="1A1714"/>
                 </a:solidFill>
-                <a:latin typeface="VVDS Fifties Exp SBold" pitchFamily="34" charset="0"/>
-                <a:ea typeface="VVDS Fifties Exp SBold" pitchFamily="34" charset="-122"/>
-                <a:cs typeface="VVDS Fifties Exp SBold" pitchFamily="34" charset="-120"/>
+                <a:latin typeface="PP Mondwest" pitchFamily="34" charset="0"/>
+                <a:ea typeface="PP Mondwest" pitchFamily="34" charset="-122"/>
+                <a:cs typeface="PP Mondwest" pitchFamily="34" charset="-120"/>
               </a:rPr>
               <a:t>AI &amp; Data Centers: The Generative Revolution</a:t>
             </a:r>
@@ -4407,9 +4407,9 @@
                 <a:solidFill>
                   <a:srgbClr val="1A1714"/>
                 </a:solidFill>
-                <a:latin typeface="VVDS Fifties Exp SBold" pitchFamily="34" charset="0"/>
-                <a:ea typeface="VVDS Fifties Exp SBold" pitchFamily="34" charset="-122"/>
-                <a:cs typeface="VVDS Fifties Exp SBold" pitchFamily="34" charset="-120"/>
+                <a:latin typeface="PP Mondwest" pitchFamily="34" charset="0"/>
+                <a:ea typeface="PP Mondwest" pitchFamily="34" charset="-122"/>
+                <a:cs typeface="PP Mondwest" pitchFamily="34" charset="-120"/>
               </a:rPr>
               <a:t>$500B</a:t>
             </a:r>
@@ -4556,9 +4556,9 @@
                 <a:solidFill>
                   <a:srgbClr val="1A1714"/>
                 </a:solidFill>
-                <a:latin typeface="VVDS Fifties Exp SBold" pitchFamily="34" charset="0"/>
-                <a:ea typeface="VVDS Fifties Exp SBold" pitchFamily="34" charset="-122"/>
-                <a:cs typeface="VVDS Fifties Exp SBold" pitchFamily="34" charset="-120"/>
+                <a:latin typeface="PP Mondwest" pitchFamily="34" charset="0"/>
+                <a:ea typeface="PP Mondwest" pitchFamily="34" charset="-122"/>
+                <a:cs typeface="PP Mondwest" pitchFamily="34" charset="-120"/>
               </a:rPr>
               <a:t>Automotive: The "Smartphone on Wheels"</a:t>
             </a:r>
@@ -4852,9 +4852,9 @@
                 <a:solidFill>
                   <a:srgbClr val="1A1714"/>
                 </a:solidFill>
-                <a:latin typeface="VVDS Fifties Exp SBold" pitchFamily="34" charset="0"/>
-                <a:ea typeface="VVDS Fifties Exp SBold" pitchFamily="34" charset="-122"/>
-                <a:cs typeface="VVDS Fifties Exp SBold" pitchFamily="34" charset="-120"/>
+                <a:latin typeface="PP Mondwest" pitchFamily="34" charset="0"/>
+                <a:ea typeface="PP Mondwest" pitchFamily="34" charset="-122"/>
+                <a:cs typeface="PP Mondwest" pitchFamily="34" charset="-120"/>
               </a:rPr>
               <a:t>$1,000+</a:t>
             </a:r>
@@ -5001,9 +5001,9 @@
                 <a:solidFill>
                   <a:srgbClr val="1A1714"/>
                 </a:solidFill>
-                <a:latin typeface="VVDS Fifties Exp SBold" pitchFamily="34" charset="0"/>
-                <a:ea typeface="VVDS Fifties Exp SBold" pitchFamily="34" charset="-122"/>
-                <a:cs typeface="VVDS Fifties Exp SBold" pitchFamily="34" charset="-120"/>
+                <a:latin typeface="PP Mondwest" pitchFamily="34" charset="0"/>
+                <a:ea typeface="PP Mondwest" pitchFamily="34" charset="-122"/>
+                <a:cs typeface="PP Mondwest" pitchFamily="34" charset="-120"/>
               </a:rPr>
               <a:t>Industrial, IoT &amp; Healthcare: Intelligence at the Edge</a:t>
             </a:r>
@@ -5168,9 +5168,9 @@
                 <a:solidFill>
                   <a:srgbClr val="9E7D84"/>
                 </a:solidFill>
-                <a:latin typeface="VVDS Fifties SExp Reg" pitchFamily="34" charset="0"/>
-                <a:ea typeface="VVDS Fifties SExp Reg" pitchFamily="34" charset="-122"/>
-                <a:cs typeface="VVDS Fifties SExp Reg" pitchFamily="34" charset="-120"/>
+                <a:latin typeface="PP Mondwest" pitchFamily="34" charset="0"/>
+                <a:ea typeface="PP Mondwest" pitchFamily="34" charset="-122"/>
+                <a:cs typeface="PP Mondwest" pitchFamily="34" charset="-120"/>
               </a:rPr>
               <a:t>Industry 4.0 Edge Analytics</a:t>
             </a:r>
@@ -5271,9 +5271,9 @@
                 <a:solidFill>
                   <a:srgbClr val="768C7C"/>
                 </a:solidFill>
-                <a:latin typeface="VVDS Fifties SExp Reg" pitchFamily="34" charset="0"/>
-                <a:ea typeface="VVDS Fifties SExp Reg" pitchFamily="34" charset="-122"/>
-                <a:cs typeface="VVDS Fifties SExp Reg" pitchFamily="34" charset="-120"/>
+                <a:latin typeface="PP Mondwest" pitchFamily="34" charset="0"/>
+                <a:ea typeface="PP Mondwest" pitchFamily="34" charset="-122"/>
+                <a:cs typeface="PP Mondwest" pitchFamily="34" charset="-120"/>
               </a:rPr>
               <a:t>Healthcare Personalized Sourcing</a:t>
             </a:r>
@@ -5420,9 +5420,9 @@
                 <a:solidFill>
                   <a:srgbClr val="1A1714"/>
                 </a:solidFill>
-                <a:latin typeface="VVDS Fifties Exp SBold" pitchFamily="34" charset="0"/>
-                <a:ea typeface="VVDS Fifties Exp SBold" pitchFamily="34" charset="-122"/>
-                <a:cs typeface="VVDS Fifties Exp SBold" pitchFamily="34" charset="-120"/>
+                <a:latin typeface="PP Mondwest" pitchFamily="34" charset="0"/>
+                <a:ea typeface="PP Mondwest" pitchFamily="34" charset="-122"/>
+                <a:cs typeface="PP Mondwest" pitchFamily="34" charset="-120"/>
               </a:rPr>
               <a:t>Consumer Electronics &amp; Emerging Frontiers</a:t>
             </a:r>
@@ -5716,9 +5716,9 @@
                 <a:solidFill>
                   <a:srgbClr val="1A1714"/>
                 </a:solidFill>
-                <a:latin typeface="VVDS Fifties Exp SBold" pitchFamily="34" charset="0"/>
-                <a:ea typeface="VVDS Fifties Exp SBold" pitchFamily="34" charset="-122"/>
-                <a:cs typeface="VVDS Fifties Exp SBold" pitchFamily="34" charset="-120"/>
+                <a:latin typeface="PP Mondwest" pitchFamily="34" charset="0"/>
+                <a:ea typeface="PP Mondwest" pitchFamily="34" charset="-122"/>
+                <a:cs typeface="PP Mondwest" pitchFamily="34" charset="-120"/>
               </a:rPr>
               <a:t>Client AI</a:t>
             </a:r>
@@ -5865,9 +5865,9 @@
                 <a:solidFill>
                   <a:srgbClr val="1A1714"/>
                 </a:solidFill>
-                <a:latin typeface="VVDS Fifties Exp SBold" pitchFamily="34" charset="0"/>
-                <a:ea typeface="VVDS Fifties Exp SBold" pitchFamily="34" charset="-122"/>
-                <a:cs typeface="VVDS Fifties Exp SBold" pitchFamily="34" charset="-120"/>
+                <a:latin typeface="PP Mondwest" pitchFamily="34" charset="0"/>
+                <a:ea typeface="PP Mondwest" pitchFamily="34" charset="-122"/>
+                <a:cs typeface="PP Mondwest" pitchFamily="34" charset="-120"/>
               </a:rPr>
               <a:t>Conclusion: A Silicon-Dependent Civilization</a:t>
             </a:r>
@@ -6110,9 +6110,9 @@
                 <a:solidFill>
                   <a:srgbClr val="B84A2F"/>
                 </a:solidFill>
-                <a:latin typeface="VVDS Fifties SExp Reg" pitchFamily="34" charset="0"/>
-                <a:ea typeface="VVDS Fifties SExp Reg" pitchFamily="34" charset="-122"/>
-                <a:cs typeface="VVDS Fifties SExp Reg" pitchFamily="34" charset="-120"/>
+                <a:latin typeface="PP Mondwest" pitchFamily="34" charset="0"/>
+                <a:ea typeface="PP Mondwest" pitchFamily="34" charset="-122"/>
+                <a:cs typeface="PP Mondwest" pitchFamily="34" charset="-120"/>
               </a:rPr>
               <a:t>Procurement</a:t>
             </a:r>
@@ -6213,9 +6213,9 @@
                 <a:solidFill>
                   <a:srgbClr val="9E7D84"/>
                 </a:solidFill>
-                <a:latin typeface="VVDS Fifties SExp Reg" pitchFamily="34" charset="0"/>
-                <a:ea typeface="VVDS Fifties SExp Reg" pitchFamily="34" charset="-122"/>
-                <a:cs typeface="VVDS Fifties SExp Reg" pitchFamily="34" charset="-120"/>
+                <a:latin typeface="PP Mondwest" pitchFamily="34" charset="0"/>
+                <a:ea typeface="PP Mondwest" pitchFamily="34" charset="-122"/>
+                <a:cs typeface="PP Mondwest" pitchFamily="34" charset="-120"/>
               </a:rPr>
               <a:t>Supply Chain</a:t>
             </a:r>
@@ -6316,9 +6316,9 @@
                 <a:solidFill>
                   <a:srgbClr val="768C7C"/>
                 </a:solidFill>
-                <a:latin typeface="VVDS Fifties SExp Reg" pitchFamily="34" charset="0"/>
-                <a:ea typeface="VVDS Fifties SExp Reg" pitchFamily="34" charset="-122"/>
-                <a:cs typeface="VVDS Fifties SExp Reg" pitchFamily="34" charset="-120"/>
+                <a:latin typeface="PP Mondwest" pitchFamily="34" charset="0"/>
+                <a:ea typeface="PP Mondwest" pitchFamily="34" charset="-122"/>
+                <a:cs typeface="PP Mondwest" pitchFamily="34" charset="-120"/>
               </a:rPr>
               <a:t>Industries</a:t>
             </a:r>
@@ -6465,9 +6465,9 @@
                 <a:solidFill>
                   <a:srgbClr val="1A1714"/>
                 </a:solidFill>
-                <a:latin typeface="VVDS Fifties Exp SBold" pitchFamily="34" charset="0"/>
-                <a:ea typeface="VVDS Fifties Exp SBold" pitchFamily="34" charset="-122"/>
-                <a:cs typeface="VVDS Fifties Exp SBold" pitchFamily="34" charset="-120"/>
+                <a:latin typeface="PP Mondwest" pitchFamily="34" charset="0"/>
+                <a:ea typeface="PP Mondwest" pitchFamily="34" charset="-122"/>
+                <a:cs typeface="PP Mondwest" pitchFamily="34" charset="-120"/>
               </a:rPr>
               <a:t>Thank You</a:t>
             </a:r>
@@ -6729,9 +6729,9 @@
                 <a:solidFill>
                   <a:srgbClr val="1A1714"/>
                 </a:solidFill>
-                <a:latin typeface="VVDS Fifties Exp SBold" pitchFamily="34" charset="0"/>
-                <a:ea typeface="VVDS Fifties Exp SBold" pitchFamily="34" charset="-122"/>
-                <a:cs typeface="VVDS Fifties Exp SBold" pitchFamily="34" charset="-120"/>
+                <a:latin typeface="PP Mondwest" pitchFamily="34" charset="0"/>
+                <a:ea typeface="PP Mondwest" pitchFamily="34" charset="-122"/>
+                <a:cs typeface="PP Mondwest" pitchFamily="34" charset="-120"/>
               </a:rPr>
               <a:t>Executive Summary: The Procurement Paradox</a:t>
             </a:r>
@@ -7025,9 +7025,9 @@
                 <a:solidFill>
                   <a:srgbClr val="1A1714"/>
                 </a:solidFill>
-                <a:latin typeface="VVDS Fifties Exp SBold" pitchFamily="34" charset="0"/>
-                <a:ea typeface="VVDS Fifties Exp SBold" pitchFamily="34" charset="-122"/>
-                <a:cs typeface="VVDS Fifties Exp SBold" pitchFamily="34" charset="-120"/>
+                <a:latin typeface="PP Mondwest" pitchFamily="34" charset="0"/>
+                <a:ea typeface="PP Mondwest" pitchFamily="34" charset="-122"/>
+                <a:cs typeface="PP Mondwest" pitchFamily="34" charset="-120"/>
               </a:rPr>
               <a:t>$1.3T</a:t>
             </a:r>
@@ -7191,9 +7191,9 @@
                 <a:solidFill>
                   <a:srgbClr val="1A1714"/>
                 </a:solidFill>
-                <a:latin typeface="VVDS Fifties Exp SBold" pitchFamily="34" charset="0"/>
-                <a:ea typeface="VVDS Fifties Exp SBold" pitchFamily="34" charset="-122"/>
-                <a:cs typeface="VVDS Fifties Exp SBold" pitchFamily="34" charset="-120"/>
+                <a:latin typeface="PP Mondwest" pitchFamily="34" charset="0"/>
+                <a:ea typeface="PP Mondwest" pitchFamily="34" charset="-122"/>
+                <a:cs typeface="PP Mondwest" pitchFamily="34" charset="-120"/>
               </a:rPr>
               <a:t>Evolution of Procurement: The Strategic Hybrid Model</a:t>
             </a:r>
@@ -7358,9 +7358,9 @@
                 <a:solidFill>
                   <a:srgbClr val="B84A2F"/>
                 </a:solidFill>
-                <a:latin typeface="VVDS Fifties SExp Reg" pitchFamily="34" charset="0"/>
-                <a:ea typeface="VVDS Fifties SExp Reg" pitchFamily="34" charset="-122"/>
-                <a:cs typeface="VVDS Fifties SExp Reg" pitchFamily="34" charset="-120"/>
+                <a:latin typeface="PP Mondwest" pitchFamily="34" charset="0"/>
+                <a:ea typeface="PP Mondwest" pitchFamily="34" charset="-122"/>
+                <a:cs typeface="PP Mondwest" pitchFamily="34" charset="-120"/>
               </a:rPr>
               <a:t>Lean JIT (Commoditized Nodes)</a:t>
             </a:r>
@@ -7461,9 +7461,9 @@
                 <a:solidFill>
                   <a:srgbClr val="9E7D84"/>
                 </a:solidFill>
-                <a:latin typeface="VVDS Fifties SExp Reg" pitchFamily="34" charset="0"/>
-                <a:ea typeface="VVDS Fifties SExp Reg" pitchFamily="34" charset="-122"/>
-                <a:cs typeface="VVDS Fifties SExp Reg" pitchFamily="34" charset="-120"/>
+                <a:latin typeface="PP Mondwest" pitchFamily="34" charset="0"/>
+                <a:ea typeface="PP Mondwest" pitchFamily="34" charset="-122"/>
+                <a:cs typeface="PP Mondwest" pitchFamily="34" charset="-120"/>
               </a:rPr>
               <a:t>Strategic Buffers (Critical Nodes)</a:t>
             </a:r>
@@ -7610,9 +7610,9 @@
                 <a:solidFill>
                   <a:srgbClr val="1A1714"/>
                 </a:solidFill>
-                <a:latin typeface="VVDS Fifties Exp SBold" pitchFamily="34" charset="0"/>
-                <a:ea typeface="VVDS Fifties Exp SBold" pitchFamily="34" charset="-122"/>
-                <a:cs typeface="VVDS Fifties Exp SBold" pitchFamily="34" charset="-120"/>
+                <a:latin typeface="PP Mondwest" pitchFamily="34" charset="0"/>
+                <a:ea typeface="PP Mondwest" pitchFamily="34" charset="-122"/>
+                <a:cs typeface="PP Mondwest" pitchFamily="34" charset="-120"/>
               </a:rPr>
               <a:t>Key Procurement Challenges &amp; Strategic Sourcing</a:t>
             </a:r>
@@ -8087,9 +8087,9 @@
                 <a:solidFill>
                   <a:srgbClr val="1A1714"/>
                 </a:solidFill>
-                <a:latin typeface="VVDS Fifties Exp SBold" pitchFamily="34" charset="0"/>
-                <a:ea typeface="VVDS Fifties Exp SBold" pitchFamily="34" charset="-122"/>
-                <a:cs typeface="VVDS Fifties Exp SBold" pitchFamily="34" charset="-120"/>
+                <a:latin typeface="PP Mondwest" pitchFamily="34" charset="0"/>
+                <a:ea typeface="PP Mondwest" pitchFamily="34" charset="-122"/>
+                <a:cs typeface="PP Mondwest" pitchFamily="34" charset="-120"/>
               </a:rPr>
               <a:t>Digitalization &amp; Resilience in Procurement</a:t>
             </a:r>
@@ -8254,9 +8254,9 @@
                 <a:solidFill>
                   <a:srgbClr val="B84A2F"/>
                 </a:solidFill>
-                <a:latin typeface="VVDS Fifties SExp Reg" pitchFamily="34" charset="0"/>
-                <a:ea typeface="VVDS Fifties SExp Reg" pitchFamily="34" charset="-122"/>
-                <a:cs typeface="VVDS Fifties SExp Reg" pitchFamily="34" charset="-120"/>
+                <a:latin typeface="PP Mondwest" pitchFamily="34" charset="0"/>
+                <a:ea typeface="PP Mondwest" pitchFamily="34" charset="-122"/>
+                <a:cs typeface="PP Mondwest" pitchFamily="34" charset="-120"/>
               </a:rPr>
               <a:t>LTA &amp; Reservation Fees</a:t>
             </a:r>
@@ -8357,9 +8357,9 @@
                 <a:solidFill>
                   <a:srgbClr val="768C7C"/>
                 </a:solidFill>
-                <a:latin typeface="VVDS Fifties SExp Reg" pitchFamily="34" charset="0"/>
-                <a:ea typeface="VVDS Fifties SExp Reg" pitchFamily="34" charset="-122"/>
-                <a:cs typeface="VVDS Fifties SExp Reg" pitchFamily="34" charset="-120"/>
+                <a:latin typeface="PP Mondwest" pitchFamily="34" charset="0"/>
+                <a:ea typeface="PP Mondwest" pitchFamily="34" charset="-122"/>
+                <a:cs typeface="PP Mondwest" pitchFamily="34" charset="-120"/>
               </a:rPr>
               <a:t>Friend-Shoring Sourcing</a:t>
             </a:r>
@@ -8570,9 +8570,9 @@
                 <a:solidFill>
                   <a:srgbClr val="1A1714"/>
                 </a:solidFill>
-                <a:latin typeface="VVDS Fifties Exp SBold" pitchFamily="34" charset="0"/>
-                <a:ea typeface="VVDS Fifties Exp SBold" pitchFamily="34" charset="-122"/>
-                <a:cs typeface="VVDS Fifties Exp SBold" pitchFamily="34" charset="-120"/>
+                <a:latin typeface="PP Mondwest" pitchFamily="34" charset="0"/>
+                <a:ea typeface="PP Mondwest" pitchFamily="34" charset="-122"/>
+                <a:cs typeface="PP Mondwest" pitchFamily="34" charset="-120"/>
               </a:rPr>
               <a:t>The Global Supply Chain: A Web of Complexity</a:t>
             </a:r>
@@ -8776,9 +8776,9 @@
                 <a:solidFill>
                   <a:srgbClr val="B84A2F"/>
                 </a:solidFill>
-                <a:latin typeface="VVDS Fifties Exp SBold" pitchFamily="34" charset="0"/>
-                <a:ea typeface="VVDS Fifties Exp SBold" pitchFamily="34" charset="-122"/>
-                <a:cs typeface="VVDS Fifties Exp SBold" pitchFamily="34" charset="-120"/>
+                <a:latin typeface="PP Mondwest" pitchFamily="34" charset="0"/>
+                <a:ea typeface="PP Mondwest" pitchFamily="34" charset="-122"/>
+                <a:cs typeface="PP Mondwest" pitchFamily="34" charset="-120"/>
               </a:rPr>
               <a:t>1</a:t>
             </a:r>
@@ -8918,9 +8918,9 @@
                 <a:solidFill>
                   <a:srgbClr val="B84A2F"/>
                 </a:solidFill>
-                <a:latin typeface="VVDS Fifties Exp SBold" pitchFamily="34" charset="0"/>
-                <a:ea typeface="VVDS Fifties Exp SBold" pitchFamily="34" charset="-122"/>
-                <a:cs typeface="VVDS Fifties Exp SBold" pitchFamily="34" charset="-120"/>
+                <a:latin typeface="PP Mondwest" pitchFamily="34" charset="0"/>
+                <a:ea typeface="PP Mondwest" pitchFamily="34" charset="-122"/>
+                <a:cs typeface="PP Mondwest" pitchFamily="34" charset="-120"/>
               </a:rPr>
               <a:t>2</a:t>
             </a:r>
@@ -9060,9 +9060,9 @@
                 <a:solidFill>
                   <a:srgbClr val="B84A2F"/>
                 </a:solidFill>
-                <a:latin typeface="VVDS Fifties Exp SBold" pitchFamily="34" charset="0"/>
-                <a:ea typeface="VVDS Fifties Exp SBold" pitchFamily="34" charset="-122"/>
-                <a:cs typeface="VVDS Fifties Exp SBold" pitchFamily="34" charset="-120"/>
+                <a:latin typeface="PP Mondwest" pitchFamily="34" charset="0"/>
+                <a:ea typeface="PP Mondwest" pitchFamily="34" charset="-122"/>
+                <a:cs typeface="PP Mondwest" pitchFamily="34" charset="-120"/>
               </a:rPr>
               <a:t>3</a:t>
             </a:r>
@@ -9202,9 +9202,9 @@
                 <a:solidFill>
                   <a:srgbClr val="B84A2F"/>
                 </a:solidFill>
-                <a:latin typeface="VVDS Fifties Exp SBold" pitchFamily="34" charset="0"/>
-                <a:ea typeface="VVDS Fifties Exp SBold" pitchFamily="34" charset="-122"/>
-                <a:cs typeface="VVDS Fifties Exp SBold" pitchFamily="34" charset="-120"/>
+                <a:latin typeface="PP Mondwest" pitchFamily="34" charset="0"/>
+                <a:ea typeface="PP Mondwest" pitchFamily="34" charset="-122"/>
+                <a:cs typeface="PP Mondwest" pitchFamily="34" charset="-120"/>
               </a:rPr>
               <a:t>4</a:t>
             </a:r>
@@ -9344,9 +9344,9 @@
                 <a:solidFill>
                   <a:srgbClr val="B84A2F"/>
                 </a:solidFill>
-                <a:latin typeface="VVDS Fifties Exp SBold" pitchFamily="34" charset="0"/>
-                <a:ea typeface="VVDS Fifties Exp SBold" pitchFamily="34" charset="-122"/>
-                <a:cs typeface="VVDS Fifties Exp SBold" pitchFamily="34" charset="-120"/>
+                <a:latin typeface="PP Mondwest" pitchFamily="34" charset="0"/>
+                <a:ea typeface="PP Mondwest" pitchFamily="34" charset="-122"/>
+                <a:cs typeface="PP Mondwest" pitchFamily="34" charset="-120"/>
               </a:rPr>
               <a:t>5</a:t>
             </a:r>
@@ -9532,9 +9532,9 @@
                 <a:solidFill>
                   <a:srgbClr val="1A1714"/>
                 </a:solidFill>
-                <a:latin typeface="VVDS Fifties Exp SBold" pitchFamily="34" charset="0"/>
-                <a:ea typeface="VVDS Fifties Exp SBold" pitchFamily="34" charset="-122"/>
-                <a:cs typeface="VVDS Fifties Exp SBold" pitchFamily="34" charset="-120"/>
+                <a:latin typeface="PP Mondwest" pitchFamily="34" charset="0"/>
+                <a:ea typeface="PP Mondwest" pitchFamily="34" charset="-122"/>
+                <a:cs typeface="PP Mondwest" pitchFamily="34" charset="-120"/>
               </a:rPr>
               <a:t>Architecture of the Global Value Chain (GVC)</a:t>
             </a:r>
@@ -10009,9 +10009,9 @@
                 <a:solidFill>
                   <a:srgbClr val="1A1714"/>
                 </a:solidFill>
-                <a:latin typeface="VVDS Fifties Exp SBold" pitchFamily="34" charset="0"/>
-                <a:ea typeface="VVDS Fifties Exp SBold" pitchFamily="34" charset="-122"/>
-                <a:cs typeface="VVDS Fifties Exp SBold" pitchFamily="34" charset="-120"/>
+                <a:latin typeface="PP Mondwest" pitchFamily="34" charset="0"/>
+                <a:ea typeface="PP Mondwest" pitchFamily="34" charset="-122"/>
+                <a:cs typeface="PP Mondwest" pitchFamily="34" charset="-120"/>
               </a:rPr>
               <a:t>Front-End &amp; Back-End Bottlenecks</a:t>
             </a:r>
@@ -10176,9 +10176,9 @@
                 <a:solidFill>
                   <a:srgbClr val="B84A2F"/>
                 </a:solidFill>
-                <a:latin typeface="VVDS Fifties SExp Reg" pitchFamily="34" charset="0"/>
-                <a:ea typeface="VVDS Fifties SExp Reg" pitchFamily="34" charset="-122"/>
-                <a:cs typeface="VVDS Fifties SExp Reg" pitchFamily="34" charset="-120"/>
+                <a:latin typeface="PP Mondwest" pitchFamily="34" charset="0"/>
+                <a:ea typeface="PP Mondwest" pitchFamily="34" charset="-122"/>
+                <a:cs typeface="PP Mondwest" pitchFamily="34" charset="-120"/>
               </a:rPr>
               <a:t>Front-End: Node Scaling</a:t>
             </a:r>
@@ -10279,9 +10279,9 @@
                 <a:solidFill>
                   <a:srgbClr val="768C7C"/>
                 </a:solidFill>
-                <a:latin typeface="VVDS Fifties SExp Reg" pitchFamily="34" charset="0"/>
-                <a:ea typeface="VVDS Fifties SExp Reg" pitchFamily="34" charset="-122"/>
-                <a:cs typeface="VVDS Fifties SExp Reg" pitchFamily="34" charset="-120"/>
+                <a:latin typeface="PP Mondwest" pitchFamily="34" charset="0"/>
+                <a:ea typeface="PP Mondwest" pitchFamily="34" charset="-122"/>
+                <a:cs typeface="PP Mondwest" pitchFamily="34" charset="-120"/>
               </a:rPr>
               <a:t>Back-End: Advanced Packaging Chokepoint</a:t>
             </a:r>
@@ -10492,9 +10492,9 @@
                 <a:solidFill>
                   <a:srgbClr val="1A1714"/>
                 </a:solidFill>
-                <a:latin typeface="VVDS Fifties Exp SBold" pitchFamily="34" charset="0"/>
-                <a:ea typeface="VVDS Fifties Exp SBold" pitchFamily="34" charset="-122"/>
-                <a:cs typeface="VVDS Fifties Exp SBold" pitchFamily="34" charset="-120"/>
+                <a:latin typeface="PP Mondwest" pitchFamily="34" charset="0"/>
+                <a:ea typeface="PP Mondwest" pitchFamily="34" charset="-122"/>
+                <a:cs typeface="PP Mondwest" pitchFamily="34" charset="-120"/>
               </a:rPr>
               <a:t>SME, Materials &amp; Geopolitical Fragmentation</a:t>
             </a:r>
@@ -10788,9 +10788,9 @@
                 <a:solidFill>
                   <a:srgbClr val="1A1714"/>
                 </a:solidFill>
-                <a:latin typeface="VVDS Fifties Exp SBold" pitchFamily="34" charset="0"/>
-                <a:ea typeface="VVDS Fifties Exp SBold" pitchFamily="34" charset="-122"/>
-                <a:cs typeface="VVDS Fifties Exp SBold" pitchFamily="34" charset="-120"/>
+                <a:latin typeface="PP Mondwest" pitchFamily="34" charset="0"/>
+                <a:ea typeface="PP Mondwest" pitchFamily="34" charset="-122"/>
+                <a:cs typeface="PP Mondwest" pitchFamily="34" charset="-120"/>
               </a:rPr>
               <a:t>Gallium &amp;</a:t>
             </a:r>
@@ -10805,9 +10805,9 @@
                 <a:solidFill>
                   <a:srgbClr val="1A1714"/>
                 </a:solidFill>
-                <a:latin typeface="VVDS Fifties Exp SBold" pitchFamily="34" charset="0"/>
-                <a:ea typeface="VVDS Fifties Exp SBold" pitchFamily="34" charset="-122"/>
-                <a:cs typeface="VVDS Fifties Exp SBold" pitchFamily="34" charset="-120"/>
+                <a:latin typeface="PP Mondwest" pitchFamily="34" charset="0"/>
+                <a:ea typeface="PP Mondwest" pitchFamily="34" charset="-122"/>
+                <a:cs typeface="PP Mondwest" pitchFamily="34" charset="-120"/>
               </a:rPr>
               <a:t>Germanium</a:t>
             </a:r>

</xml_diff>

<commit_message>
Replace VVDS Fifties with Aeonik, setting buttons to VVDS Fifties-SExp SBold
</commit_message>
<xml_diff>
--- a/output/semiconductor-ecosystem-2026.pptx
+++ b/output/semiconductor-ecosystem-2026.pptx
@@ -2458,9 +2458,9 @@
                 <a:solidFill>
                   <a:srgbClr val="6B6560"/>
                 </a:solidFill>
-                <a:latin typeface="VVDS Fifties SCond Reg" pitchFamily="34" charset="0"/>
-                <a:ea typeface="VVDS Fifties SCond Reg" pitchFamily="34" charset="-122"/>
-                <a:cs typeface="VVDS Fifties SCond Reg" pitchFamily="34" charset="-120"/>
+                <a:latin typeface="Aeonik" pitchFamily="34" charset="0"/>
+                <a:ea typeface="Aeonik" pitchFamily="34" charset="-122"/>
+                <a:cs typeface="Aeonik" pitchFamily="34" charset="-120"/>
               </a:rPr>
               <a:t>A Strategic Briefing on Procurement, Global Supply Chains, and End-User Verticals</a:t>
             </a:r>
@@ -2517,9 +2517,9 @@
                 <a:solidFill>
                   <a:srgbClr val="6B6560"/>
                 </a:solidFill>
-                <a:latin typeface="VVDS Fifties Exp Reg" pitchFamily="34" charset="0"/>
-                <a:ea typeface="VVDS Fifties Exp Reg" pitchFamily="34" charset="-122"/>
-                <a:cs typeface="VVDS Fifties Exp Reg" pitchFamily="34" charset="-120"/>
+                <a:latin typeface="Aeonik" pitchFamily="34" charset="0"/>
+                <a:ea typeface="Aeonik" pitchFamily="34" charset="-122"/>
+                <a:cs typeface="Aeonik" pitchFamily="34" charset="-120"/>
               </a:rPr>
               <a:t>Presenter: Phyoe Sat Paing</a:t>
             </a:r>
@@ -2534,9 +2534,9 @@
                 <a:solidFill>
                   <a:srgbClr val="6B6560"/>
                 </a:solidFill>
-                <a:latin typeface="VVDS Fifties Exp Reg" pitchFamily="34" charset="0"/>
-                <a:ea typeface="VVDS Fifties Exp Reg" pitchFamily="34" charset="-122"/>
-                <a:cs typeface="VVDS Fifties Exp Reg" pitchFamily="34" charset="-120"/>
+                <a:latin typeface="Aeonik" pitchFamily="34" charset="0"/>
+                <a:ea typeface="Aeonik" pitchFamily="34" charset="-122"/>
+                <a:cs typeface="Aeonik" pitchFamily="34" charset="-120"/>
               </a:rPr>
               <a:t>Boardroom Strategic Briefing</a:t>
             </a:r>
@@ -2605,9 +2605,9 @@
                 <a:solidFill>
                   <a:srgbClr val="B84A2F"/>
                 </a:solidFill>
-                <a:latin typeface="VVDS Fifties Exp Reg" pitchFamily="34" charset="0"/>
-                <a:ea typeface="VVDS Fifties Exp Reg" pitchFamily="34" charset="-122"/>
-                <a:cs typeface="VVDS Fifties Exp Reg" pitchFamily="34" charset="-120"/>
+                <a:latin typeface="Aeonik" pitchFamily="34" charset="0"/>
+                <a:ea typeface="Aeonik" pitchFamily="34" charset="-122"/>
+                <a:cs typeface="Aeonik" pitchFamily="34" charset="-120"/>
               </a:rPr>
               <a:t>PART 2: THE GLOBAL SUPPLY CHAIN OF SEMICONDUCTORS</a:t>
             </a:r>
@@ -2683,9 +2683,9 @@
                 <a:solidFill>
                   <a:srgbClr val="6B6560"/>
                 </a:solidFill>
-                <a:latin typeface="VVDS Fifties Exp Reg" pitchFamily="34" charset="0"/>
-                <a:ea typeface="VVDS Fifties Exp Reg" pitchFamily="34" charset="-122"/>
-                <a:cs typeface="VVDS Fifties Exp Reg" pitchFamily="34" charset="-120"/>
+                <a:latin typeface="Aeonik" pitchFamily="34" charset="0"/>
+                <a:ea typeface="Aeonik" pitchFamily="34" charset="-122"/>
+                <a:cs typeface="Aeonik" pitchFamily="34" charset="-120"/>
               </a:rPr>
               <a:t>The 2026 Semiconductor Ecosystem | Slide 10</a:t>
             </a:r>
@@ -2747,9 +2747,9 @@
                 <a:solidFill>
                   <a:srgbClr val="B84A2F"/>
                 </a:solidFill>
-                <a:latin typeface="VVDS Fifties SCond Reg" pitchFamily="34" charset="0"/>
-                <a:ea typeface="VVDS Fifties SCond Reg" pitchFamily="34" charset="-122"/>
-                <a:cs typeface="VVDS Fifties SCond Reg" pitchFamily="34" charset="-120"/>
+                <a:latin typeface="Aeonik" pitchFamily="34" charset="0"/>
+                <a:ea typeface="Aeonik" pitchFamily="34" charset="-122"/>
+                <a:cs typeface="Aeonik" pitchFamily="34" charset="-120"/>
               </a:rPr>
               <a:t>Key Message: The response? Circular and Autonomous Supply Chains. We are using AI to 'self-heal' the supply chain.</a:t>
             </a:r>
@@ -2850,9 +2850,9 @@
                 <a:solidFill>
                   <a:srgbClr val="6B6560"/>
                 </a:solidFill>
-                <a:latin typeface="VVDS Fifties SCond Reg" pitchFamily="34" charset="0"/>
-                <a:ea typeface="VVDS Fifties SCond Reg" pitchFamily="34" charset="-122"/>
-                <a:cs typeface="VVDS Fifties SCond Reg" pitchFamily="34" charset="-120"/>
+                <a:latin typeface="Aeonik" pitchFamily="34" charset="0"/>
+                <a:ea typeface="Aeonik" pitchFamily="34" charset="-122"/>
+                <a:cs typeface="Aeonik" pitchFamily="34" charset="-120"/>
               </a:rPr>
               <a:t>Automatically re-routing orders when a port closes or a factory goes down. Mapping up to Tier-4 and Tier-5 suppliers.</a:t>
             </a:r>
@@ -2953,9 +2953,9 @@
                 <a:solidFill>
                   <a:srgbClr val="6B6560"/>
                 </a:solidFill>
-                <a:latin typeface="VVDS Fifties SCond Reg" pitchFamily="34" charset="0"/>
-                <a:ea typeface="VVDS Fifties SCond Reg" pitchFamily="34" charset="-122"/>
-                <a:cs typeface="VVDS Fifties SCond Reg" pitchFamily="34" charset="-120"/>
+                <a:latin typeface="Aeonik" pitchFamily="34" charset="0"/>
+                <a:ea typeface="Aeonik" pitchFamily="34" charset="-122"/>
+                <a:cs typeface="Aeonik" pitchFamily="34" charset="-120"/>
               </a:rPr>
               <a:t>Mining the 'urban mine'—recovering rare earth elements from old electronics to reduce dependency on volatile mining regions.</a:t>
             </a:r>
@@ -3017,9 +3017,9 @@
                 <a:solidFill>
                   <a:srgbClr val="6B6560"/>
                 </a:solidFill>
-                <a:latin typeface="VVDS Fifties SCond Reg" pitchFamily="34" charset="0"/>
-                <a:ea typeface="VVDS Fifties SCond Reg" pitchFamily="34" charset="-122"/>
-                <a:cs typeface="VVDS Fifties SCond Reg" pitchFamily="34" charset="-120"/>
+                <a:latin typeface="Aeonik" pitchFamily="34" charset="0"/>
+                <a:ea typeface="Aeonik" pitchFamily="34" charset="-122"/>
+                <a:cs typeface="Aeonik" pitchFamily="34" charset="-120"/>
               </a:rPr>
               <a:t>Autonomous logistics systems automatically scan trade flows to reroute containers before bottleneck events cause line shutdowns.</a:t>
             </a:r>
@@ -3088,9 +3088,9 @@
                 <a:solidFill>
                   <a:srgbClr val="B84A2F"/>
                 </a:solidFill>
-                <a:latin typeface="VVDS Fifties Exp Reg" pitchFamily="34" charset="0"/>
-                <a:ea typeface="VVDS Fifties Exp Reg" pitchFamily="34" charset="-122"/>
-                <a:cs typeface="VVDS Fifties Exp Reg" pitchFamily="34" charset="-120"/>
+                <a:latin typeface="Aeonik" pitchFamily="34" charset="0"/>
+                <a:ea typeface="Aeonik" pitchFamily="34" charset="-122"/>
+                <a:cs typeface="Aeonik" pitchFamily="34" charset="-120"/>
               </a:rPr>
               <a:t>PART 3: END-USER INDUSTRIES &amp; APPLICATION ECOSYSTEM</a:t>
             </a:r>
@@ -3166,9 +3166,9 @@
                 <a:solidFill>
                   <a:srgbClr val="6B6560"/>
                 </a:solidFill>
-                <a:latin typeface="VVDS Fifties Exp Reg" pitchFamily="34" charset="0"/>
-                <a:ea typeface="VVDS Fifties Exp Reg" pitchFamily="34" charset="-122"/>
-                <a:cs typeface="VVDS Fifties Exp Reg" pitchFamily="34" charset="-120"/>
+                <a:latin typeface="Aeonik" pitchFamily="34" charset="0"/>
+                <a:ea typeface="Aeonik" pitchFamily="34" charset="-122"/>
+                <a:cs typeface="Aeonik" pitchFamily="34" charset="-120"/>
               </a:rPr>
               <a:t>The 2026 Semiconductor Ecosystem | Slide 11</a:t>
             </a:r>
@@ -3230,9 +3230,9 @@
                 <a:solidFill>
                   <a:srgbClr val="9E7D84"/>
                 </a:solidFill>
-                <a:latin typeface="VVDS Fifties SCond Reg" pitchFamily="34" charset="0"/>
-                <a:ea typeface="VVDS Fifties SCond Reg" pitchFamily="34" charset="-122"/>
-                <a:cs typeface="VVDS Fifties SCond Reg" pitchFamily="34" charset="-120"/>
+                <a:latin typeface="Aeonik" pitchFamily="34" charset="0"/>
+                <a:ea typeface="Aeonik" pitchFamily="34" charset="-122"/>
+                <a:cs typeface="Aeonik" pitchFamily="34" charset="-120"/>
               </a:rPr>
               <a:t>Key Message: Semiconductors are the "nerve system" of the global economy; no modern industry can function without them.</a:t>
             </a:r>
@@ -3270,9 +3270,9 @@
                 <a:solidFill>
                   <a:srgbClr val="6B6560"/>
                 </a:solidFill>
-                <a:latin typeface="VVDS Fifties SCond Reg" pitchFamily="34" charset="0"/>
-                <a:ea typeface="VVDS Fifties SCond Reg" pitchFamily="34" charset="-122"/>
-                <a:cs typeface="VVDS Fifties SCond Reg" pitchFamily="34" charset="-120"/>
+                <a:latin typeface="Aeonik" pitchFamily="34" charset="0"/>
+                <a:ea typeface="Aeonik" pitchFamily="34" charset="-122"/>
+                <a:cs typeface="Aeonik" pitchFamily="34" charset="-120"/>
               </a:rPr>
               <a:t>- Central Nerve System: Microchips control the storage, routing, and processing of every piece of data globally.</a:t>
             </a:r>
@@ -3295,9 +3295,9 @@
                 <a:solidFill>
                   <a:srgbClr val="6B6560"/>
                 </a:solidFill>
-                <a:latin typeface="VVDS Fifties SCond Reg" pitchFamily="34" charset="0"/>
-                <a:ea typeface="VVDS Fifties SCond Reg" pitchFamily="34" charset="-122"/>
-                <a:cs typeface="VVDS Fifties SCond Reg" pitchFamily="34" charset="-120"/>
+                <a:latin typeface="Aeonik" pitchFamily="34" charset="0"/>
+                <a:ea typeface="Aeonik" pitchFamily="34" charset="-122"/>
+                <a:cs typeface="Aeonik" pitchFamily="34" charset="-120"/>
               </a:rPr>
               <a:t>- Silicon Intensity Metric: The total value of silicon content per product is the primary metric of industrial scaling.</a:t>
             </a:r>
@@ -3320,9 +3320,9 @@
                 <a:solidFill>
                   <a:srgbClr val="6B6560"/>
                 </a:solidFill>
-                <a:latin typeface="VVDS Fifties SCond Reg" pitchFamily="34" charset="0"/>
-                <a:ea typeface="VVDS Fifties SCond Reg" pitchFamily="34" charset="-122"/>
-                <a:cs typeface="VVDS Fifties SCond Reg" pitchFamily="34" charset="-120"/>
+                <a:latin typeface="Aeonik" pitchFamily="34" charset="0"/>
+                <a:ea typeface="Aeonik" pitchFamily="34" charset="-122"/>
+                <a:cs typeface="Aeonik" pitchFamily="34" charset="-120"/>
               </a:rPr>
               <a:t>- Ubiquitous Integration: Foundational logic layers power smart municipal grids, medical machinery, and neural processors.</a:t>
             </a:r>
@@ -3384,9 +3384,9 @@
                 <a:solidFill>
                   <a:srgbClr val="9E7D84"/>
                 </a:solidFill>
-                <a:latin typeface="VVDS Fifties Exp Reg" pitchFamily="34" charset="0"/>
-                <a:ea typeface="VVDS Fifties Exp Reg" pitchFamily="34" charset="-122"/>
-                <a:cs typeface="VVDS Fifties Exp Reg" pitchFamily="34" charset="-120"/>
+                <a:latin typeface="Aeonik" pitchFamily="34" charset="0"/>
+                <a:ea typeface="Aeonik" pitchFamily="34" charset="-122"/>
+                <a:cs typeface="Aeonik" pitchFamily="34" charset="-120"/>
               </a:rPr>
               <a:t>KEY METRIC</a:t>
             </a:r>
@@ -3479,9 +3479,9 @@
                 <a:solidFill>
                   <a:srgbClr val="6B6560"/>
                 </a:solidFill>
-                <a:latin typeface="VVDS Fifties SCond Reg" pitchFamily="34" charset="0"/>
-                <a:ea typeface="VVDS Fifties SCond Reg" pitchFamily="34" charset="-122"/>
-                <a:cs typeface="VVDS Fifties SCond Reg" pitchFamily="34" charset="-120"/>
+                <a:latin typeface="Aeonik" pitchFamily="34" charset="0"/>
+                <a:ea typeface="Aeonik" pitchFamily="34" charset="-122"/>
+                <a:cs typeface="Aeonik" pitchFamily="34" charset="-120"/>
               </a:rPr>
               <a:t>Primary industrial competitiveness index</a:t>
             </a:r>
@@ -3550,9 +3550,9 @@
                 <a:solidFill>
                   <a:srgbClr val="B84A2F"/>
                 </a:solidFill>
-                <a:latin typeface="VVDS Fifties Exp Reg" pitchFamily="34" charset="0"/>
-                <a:ea typeface="VVDS Fifties Exp Reg" pitchFamily="34" charset="-122"/>
-                <a:cs typeface="VVDS Fifties Exp Reg" pitchFamily="34" charset="-120"/>
+                <a:latin typeface="Aeonik" pitchFamily="34" charset="0"/>
+                <a:ea typeface="Aeonik" pitchFamily="34" charset="-122"/>
+                <a:cs typeface="Aeonik" pitchFamily="34" charset="-120"/>
               </a:rPr>
               <a:t>PART 3: END-USER INDUSTRIES &amp; APPLICATION ECOSYSTEM</a:t>
             </a:r>
@@ -3628,9 +3628,9 @@
                 <a:solidFill>
                   <a:srgbClr val="6B6560"/>
                 </a:solidFill>
-                <a:latin typeface="VVDS Fifties Exp Reg" pitchFamily="34" charset="0"/>
-                <a:ea typeface="VVDS Fifties Exp Reg" pitchFamily="34" charset="-122"/>
-                <a:cs typeface="VVDS Fifties Exp Reg" pitchFamily="34" charset="-120"/>
+                <a:latin typeface="Aeonik" pitchFamily="34" charset="0"/>
+                <a:ea typeface="Aeonik" pitchFamily="34" charset="-122"/>
+                <a:cs typeface="Aeonik" pitchFamily="34" charset="-120"/>
               </a:rPr>
               <a:t>The 2026 Semiconductor Ecosystem | Slide 12</a:t>
             </a:r>
@@ -3692,9 +3692,9 @@
                 <a:solidFill>
                   <a:srgbClr val="B84A2F"/>
                 </a:solidFill>
-                <a:latin typeface="VVDS Fifties SCond Reg" pitchFamily="34" charset="0"/>
-                <a:ea typeface="VVDS Fifties SCond Reg" pitchFamily="34" charset="-122"/>
-                <a:cs typeface="VVDS Fifties SCond Reg" pitchFamily="34" charset="-120"/>
+                <a:latin typeface="Aeonik" pitchFamily="34" charset="0"/>
+                <a:ea typeface="Aeonik" pitchFamily="34" charset="-122"/>
+                <a:cs typeface="Aeonik" pitchFamily="34" charset="-120"/>
               </a:rPr>
               <a:t>Key Message: Demand is shifting from traditional computing toward AI infrastructure, Automotive, and Industrial Automation.</a:t>
             </a:r>
@@ -3795,9 +3795,9 @@
                 <a:solidFill>
                   <a:srgbClr val="6B6560"/>
                 </a:solidFill>
-                <a:latin typeface="VVDS Fifties SCond Reg" pitchFamily="34" charset="0"/>
-                <a:ea typeface="VVDS Fifties SCond Reg" pitchFamily="34" charset="-122"/>
-                <a:cs typeface="VVDS Fifties SCond Reg" pitchFamily="34" charset="-120"/>
+                <a:latin typeface="Aeonik" pitchFamily="34" charset="0"/>
+                <a:ea typeface="Aeonik" pitchFamily="34" charset="-122"/>
+                <a:cs typeface="Aeonik" pitchFamily="34" charset="-120"/>
               </a:rPr>
               <a:t>Nearly 50% of semiconductor industry growth and revenue is driven by high-performance AI accelerators.</a:t>
             </a:r>
@@ -3898,9 +3898,9 @@
                 <a:solidFill>
                   <a:srgbClr val="6B6560"/>
                 </a:solidFill>
-                <a:latin typeface="VVDS Fifties SCond Reg" pitchFamily="34" charset="0"/>
-                <a:ea typeface="VVDS Fifties SCond Reg" pitchFamily="34" charset="-122"/>
-                <a:cs typeface="VVDS Fifties SCond Reg" pitchFamily="34" charset="-120"/>
+                <a:latin typeface="Aeonik" pitchFamily="34" charset="0"/>
+                <a:ea typeface="Aeonik" pitchFamily="34" charset="-122"/>
+                <a:cs typeface="Aeonik" pitchFamily="34" charset="-120"/>
               </a:rPr>
               <a:t>The fastest growing volume segment, requiring massive numbers of legacy control nodes and SiC power chips.</a:t>
             </a:r>
@@ -4001,9 +4001,9 @@
                 <a:solidFill>
                   <a:srgbClr val="6B6560"/>
                 </a:solidFill>
-                <a:latin typeface="VVDS Fifties SCond Reg" pitchFamily="34" charset="0"/>
-                <a:ea typeface="VVDS Fifties SCond Reg" pitchFamily="34" charset="-122"/>
-                <a:cs typeface="VVDS Fifties SCond Reg" pitchFamily="34" charset="-120"/>
+                <a:latin typeface="Aeonik" pitchFamily="34" charset="0"/>
+                <a:ea typeface="Aeonik" pitchFamily="34" charset="-122"/>
+                <a:cs typeface="Aeonik" pitchFamily="34" charset="-120"/>
               </a:rPr>
               <a:t>Traditional core segments face volume saturation, driving consolidation and focus on specialized edge accelerators.</a:t>
             </a:r>
@@ -4072,9 +4072,9 @@
                 <a:solidFill>
                   <a:srgbClr val="B84A2F"/>
                 </a:solidFill>
-                <a:latin typeface="VVDS Fifties Exp Reg" pitchFamily="34" charset="0"/>
-                <a:ea typeface="VVDS Fifties Exp Reg" pitchFamily="34" charset="-122"/>
-                <a:cs typeface="VVDS Fifties Exp Reg" pitchFamily="34" charset="-120"/>
+                <a:latin typeface="Aeonik" pitchFamily="34" charset="0"/>
+                <a:ea typeface="Aeonik" pitchFamily="34" charset="-122"/>
+                <a:cs typeface="Aeonik" pitchFamily="34" charset="-120"/>
               </a:rPr>
               <a:t>PART 3: END-USER INDUSTRIES &amp; APPLICATION ECOSYSTEM</a:t>
             </a:r>
@@ -4150,9 +4150,9 @@
                 <a:solidFill>
                   <a:srgbClr val="6B6560"/>
                 </a:solidFill>
-                <a:latin typeface="VVDS Fifties Exp Reg" pitchFamily="34" charset="0"/>
-                <a:ea typeface="VVDS Fifties Exp Reg" pitchFamily="34" charset="-122"/>
-                <a:cs typeface="VVDS Fifties Exp Reg" pitchFamily="34" charset="-120"/>
+                <a:latin typeface="Aeonik" pitchFamily="34" charset="0"/>
+                <a:ea typeface="Aeonik" pitchFamily="34" charset="-122"/>
+                <a:cs typeface="Aeonik" pitchFamily="34" charset="-120"/>
               </a:rPr>
               <a:t>The 2026 Semiconductor Ecosystem | Slide 13</a:t>
             </a:r>
@@ -4214,9 +4214,9 @@
                 <a:solidFill>
                   <a:srgbClr val="768C7C"/>
                 </a:solidFill>
-                <a:latin typeface="VVDS Fifties SCond Reg" pitchFamily="34" charset="0"/>
-                <a:ea typeface="VVDS Fifties SCond Reg" pitchFamily="34" charset="-122"/>
-                <a:cs typeface="VVDS Fifties SCond Reg" pitchFamily="34" charset="-120"/>
+                <a:latin typeface="Aeonik" pitchFamily="34" charset="0"/>
+                <a:ea typeface="Aeonik" pitchFamily="34" charset="-122"/>
+                <a:cs typeface="Aeonik" pitchFamily="34" charset="-120"/>
               </a:rPr>
               <a:t>Key Message: Data centers have evolved into "Intelligence Engines," consuming the highest-value silicon ever produced.</a:t>
             </a:r>
@@ -4254,9 +4254,9 @@
                 <a:solidFill>
                   <a:srgbClr val="6B6560"/>
                 </a:solidFill>
-                <a:latin typeface="VVDS Fifties SCond Reg" pitchFamily="34" charset="0"/>
-                <a:ea typeface="VVDS Fifties SCond Reg" pitchFamily="34" charset="-122"/>
-                <a:cs typeface="VVDS Fifties SCond Reg" pitchFamily="34" charset="-120"/>
+                <a:latin typeface="Aeonik" pitchFamily="34" charset="0"/>
+                <a:ea typeface="Aeonik" pitchFamily="34" charset="-122"/>
+                <a:cs typeface="Aeonik" pitchFamily="34" charset="-120"/>
               </a:rPr>
               <a:t>- Accelerator Market ($500B): Generative models and neural computing demand massive scaling of TPU and GPU nodes.</a:t>
             </a:r>
@@ -4279,9 +4279,9 @@
                 <a:solidFill>
                   <a:srgbClr val="6B6560"/>
                 </a:solidFill>
-                <a:latin typeface="VVDS Fifties SCond Reg" pitchFamily="34" charset="0"/>
-                <a:ea typeface="VVDS Fifties SCond Reg" pitchFamily="34" charset="-122"/>
-                <a:cs typeface="VVDS Fifties SCond Reg" pitchFamily="34" charset="-120"/>
+                <a:latin typeface="Aeonik" pitchFamily="34" charset="0"/>
+                <a:ea typeface="Aeonik" pitchFamily="34" charset="-122"/>
+                <a:cs typeface="Aeonik" pitchFamily="34" charset="-120"/>
               </a:rPr>
               <a:t>- Sub-3nm Node Sourcing: The primary consumers of the most advanced wafer print architectures globally.</a:t>
             </a:r>
@@ -4304,9 +4304,9 @@
                 <a:solidFill>
                   <a:srgbClr val="6B6560"/>
                 </a:solidFill>
-                <a:latin typeface="VVDS Fifties SCond Reg" pitchFamily="34" charset="0"/>
-                <a:ea typeface="VVDS Fifties SCond Reg" pitchFamily="34" charset="-122"/>
-                <a:cs typeface="VVDS Fifties SCond Reg" pitchFamily="34" charset="-120"/>
+                <a:latin typeface="Aeonik" pitchFamily="34" charset="0"/>
+                <a:ea typeface="Aeonik" pitchFamily="34" charset="-122"/>
+                <a:cs typeface="Aeonik" pitchFamily="34" charset="-120"/>
               </a:rPr>
               <a:t>- Memory &amp; Interconnect: Demands extreme density of High Bandwidth Memory (HBM) and customized routing interconnect silicon.</a:t>
             </a:r>
@@ -4368,9 +4368,9 @@
                 <a:solidFill>
                   <a:srgbClr val="768C7C"/>
                 </a:solidFill>
-                <a:latin typeface="VVDS Fifties Exp Reg" pitchFamily="34" charset="0"/>
-                <a:ea typeface="VVDS Fifties Exp Reg" pitchFamily="34" charset="-122"/>
-                <a:cs typeface="VVDS Fifties Exp Reg" pitchFamily="34" charset="-120"/>
+                <a:latin typeface="Aeonik" pitchFamily="34" charset="0"/>
+                <a:ea typeface="Aeonik" pitchFamily="34" charset="-122"/>
+                <a:cs typeface="Aeonik" pitchFamily="34" charset="-120"/>
               </a:rPr>
               <a:t>ANALYST PROJECT</a:t>
             </a:r>
@@ -4446,9 +4446,9 @@
                 <a:solidFill>
                   <a:srgbClr val="6B6560"/>
                 </a:solidFill>
-                <a:latin typeface="VVDS Fifties SCond Reg" pitchFamily="34" charset="0"/>
-                <a:ea typeface="VVDS Fifties SCond Reg" pitchFamily="34" charset="-122"/>
-                <a:cs typeface="VVDS Fifties SCond Reg" pitchFamily="34" charset="-120"/>
+                <a:latin typeface="Aeonik" pitchFamily="34" charset="0"/>
+                <a:ea typeface="Aeonik" pitchFamily="34" charset="-122"/>
+                <a:cs typeface="Aeonik" pitchFamily="34" charset="-120"/>
               </a:rPr>
               <a:t>AI Accelerator market size by 2026</a:t>
             </a:r>
@@ -4517,9 +4517,9 @@
                 <a:solidFill>
                   <a:srgbClr val="B84A2F"/>
                 </a:solidFill>
-                <a:latin typeface="VVDS Fifties Exp Reg" pitchFamily="34" charset="0"/>
-                <a:ea typeface="VVDS Fifties Exp Reg" pitchFamily="34" charset="-122"/>
-                <a:cs typeface="VVDS Fifties Exp Reg" pitchFamily="34" charset="-120"/>
+                <a:latin typeface="Aeonik" pitchFamily="34" charset="0"/>
+                <a:ea typeface="Aeonik" pitchFamily="34" charset="-122"/>
+                <a:cs typeface="Aeonik" pitchFamily="34" charset="-120"/>
               </a:rPr>
               <a:t>PART 3: END-USER INDUSTRIES &amp; APPLICATION ECOSYSTEM</a:t>
             </a:r>
@@ -4595,9 +4595,9 @@
                 <a:solidFill>
                   <a:srgbClr val="6B6560"/>
                 </a:solidFill>
-                <a:latin typeface="VVDS Fifties Exp Reg" pitchFamily="34" charset="0"/>
-                <a:ea typeface="VVDS Fifties Exp Reg" pitchFamily="34" charset="-122"/>
-                <a:cs typeface="VVDS Fifties Exp Reg" pitchFamily="34" charset="-120"/>
+                <a:latin typeface="Aeonik" pitchFamily="34" charset="0"/>
+                <a:ea typeface="Aeonik" pitchFamily="34" charset="-122"/>
+                <a:cs typeface="Aeonik" pitchFamily="34" charset="-120"/>
               </a:rPr>
               <a:t>The 2026 Semiconductor Ecosystem | Slide 14</a:t>
             </a:r>
@@ -4659,9 +4659,9 @@
                 <a:solidFill>
                   <a:srgbClr val="B84A2F"/>
                 </a:solidFill>
-                <a:latin typeface="VVDS Fifties SCond Reg" pitchFamily="34" charset="0"/>
-                <a:ea typeface="VVDS Fifties SCond Reg" pitchFamily="34" charset="-122"/>
-                <a:cs typeface="VVDS Fifties SCond Reg" pitchFamily="34" charset="-120"/>
+                <a:latin typeface="Aeonik" pitchFamily="34" charset="0"/>
+                <a:ea typeface="Aeonik" pitchFamily="34" charset="-122"/>
+                <a:cs typeface="Aeonik" pitchFamily="34" charset="-120"/>
               </a:rPr>
               <a:t>Key Message: The transition to EVs and ADAS is doubling semiconductor content per vehicle, reaching over $1,000 per unit.</a:t>
             </a:r>
@@ -4699,9 +4699,9 @@
                 <a:solidFill>
                   <a:srgbClr val="6B6560"/>
                 </a:solidFill>
-                <a:latin typeface="VVDS Fifties SCond Reg" pitchFamily="34" charset="0"/>
-                <a:ea typeface="VVDS Fifties SCond Reg" pitchFamily="34" charset="-122"/>
-                <a:cs typeface="VVDS Fifties SCond Reg" pitchFamily="34" charset="-120"/>
+                <a:latin typeface="Aeonik" pitchFamily="34" charset="0"/>
+                <a:ea typeface="Aeonik" pitchFamily="34" charset="-122"/>
+                <a:cs typeface="Aeonik" pitchFamily="34" charset="-120"/>
               </a:rPr>
               <a:t>- Silicon Carbide (SiC) Power: Drives high-efficiency power switches in high-voltage EV battery platforms.</a:t>
             </a:r>
@@ -4724,9 +4724,9 @@
                 <a:solidFill>
                   <a:srgbClr val="6B6560"/>
                 </a:solidFill>
-                <a:latin typeface="VVDS Fifties SCond Reg" pitchFamily="34" charset="0"/>
-                <a:ea typeface="VVDS Fifties SCond Reg" pitchFamily="34" charset="-122"/>
-                <a:cs typeface="VVDS Fifties SCond Reg" pitchFamily="34" charset="-120"/>
+                <a:latin typeface="Aeonik" pitchFamily="34" charset="0"/>
+                <a:ea typeface="Aeonik" pitchFamily="34" charset="-122"/>
+                <a:cs typeface="Aeonik" pitchFamily="34" charset="-120"/>
               </a:rPr>
               <a:t>- ADAS Autonomous Compute: Self-driving capabilities demand heavy on-board computational units for sensor fusion.</a:t>
             </a:r>
@@ -4749,9 +4749,9 @@
                 <a:solidFill>
                   <a:srgbClr val="6B6560"/>
                 </a:solidFill>
-                <a:latin typeface="VVDS Fifties SCond Reg" pitchFamily="34" charset="0"/>
-                <a:ea typeface="VVDS Fifties SCond Reg" pitchFamily="34" charset="-122"/>
-                <a:cs typeface="VVDS Fifties SCond Reg" pitchFamily="34" charset="-120"/>
+                <a:latin typeface="Aeonik" pitchFamily="34" charset="0"/>
+                <a:ea typeface="Aeonik" pitchFamily="34" charset="-122"/>
+                <a:cs typeface="Aeonik" pitchFamily="34" charset="-120"/>
               </a:rPr>
               <a:t>- Sensor Arrays Sourcing: Vehicles integrate multiple LiDAR, radar, and camera chip sets for 360-degree coverage.</a:t>
             </a:r>
@@ -4813,9 +4813,9 @@
                 <a:solidFill>
                   <a:srgbClr val="B84A2F"/>
                 </a:solidFill>
-                <a:latin typeface="VVDS Fifties Exp Reg" pitchFamily="34" charset="0"/>
-                <a:ea typeface="VVDS Fifties Exp Reg" pitchFamily="34" charset="-122"/>
-                <a:cs typeface="VVDS Fifties Exp Reg" pitchFamily="34" charset="-120"/>
+                <a:latin typeface="Aeonik" pitchFamily="34" charset="0"/>
+                <a:ea typeface="Aeonik" pitchFamily="34" charset="-122"/>
+                <a:cs typeface="Aeonik" pitchFamily="34" charset="-120"/>
               </a:rPr>
               <a:t>ESTIMATE</a:t>
             </a:r>
@@ -4891,9 +4891,9 @@
                 <a:solidFill>
                   <a:srgbClr val="6B6560"/>
                 </a:solidFill>
-                <a:latin typeface="VVDS Fifties SCond Reg" pitchFamily="34" charset="0"/>
-                <a:ea typeface="VVDS Fifties SCond Reg" pitchFamily="34" charset="-122"/>
-                <a:cs typeface="VVDS Fifties SCond Reg" pitchFamily="34" charset="-120"/>
+                <a:latin typeface="Aeonik" pitchFamily="34" charset="0"/>
+                <a:ea typeface="Aeonik" pitchFamily="34" charset="-122"/>
+                <a:cs typeface="Aeonik" pitchFamily="34" charset="-120"/>
               </a:rPr>
               <a:t>Silicon value content per EV unit</a:t>
             </a:r>
@@ -4962,9 +4962,9 @@
                 <a:solidFill>
                   <a:srgbClr val="B84A2F"/>
                 </a:solidFill>
-                <a:latin typeface="VVDS Fifties Exp Reg" pitchFamily="34" charset="0"/>
-                <a:ea typeface="VVDS Fifties Exp Reg" pitchFamily="34" charset="-122"/>
-                <a:cs typeface="VVDS Fifties Exp Reg" pitchFamily="34" charset="-120"/>
+                <a:latin typeface="Aeonik" pitchFamily="34" charset="0"/>
+                <a:ea typeface="Aeonik" pitchFamily="34" charset="-122"/>
+                <a:cs typeface="Aeonik" pitchFamily="34" charset="-120"/>
               </a:rPr>
               <a:t>PART 3: END-USER INDUSTRIES &amp; APPLICATION ECOSYSTEM</a:t>
             </a:r>
@@ -5040,9 +5040,9 @@
                 <a:solidFill>
                   <a:srgbClr val="6B6560"/>
                 </a:solidFill>
-                <a:latin typeface="VVDS Fifties Exp Reg" pitchFamily="34" charset="0"/>
-                <a:ea typeface="VVDS Fifties Exp Reg" pitchFamily="34" charset="-122"/>
-                <a:cs typeface="VVDS Fifties Exp Reg" pitchFamily="34" charset="-120"/>
+                <a:latin typeface="Aeonik" pitchFamily="34" charset="0"/>
+                <a:ea typeface="Aeonik" pitchFamily="34" charset="-122"/>
+                <a:cs typeface="Aeonik" pitchFamily="34" charset="-120"/>
               </a:rPr>
               <a:t>The 2026 Semiconductor Ecosystem | Slide 15</a:t>
             </a:r>
@@ -5104,9 +5104,9 @@
                 <a:solidFill>
                   <a:srgbClr val="9E7D84"/>
                 </a:solidFill>
-                <a:latin typeface="VVDS Fifties SCond Reg" pitchFamily="34" charset="0"/>
-                <a:ea typeface="VVDS Fifties SCond Reg" pitchFamily="34" charset="-122"/>
-                <a:cs typeface="VVDS Fifties SCond Reg" pitchFamily="34" charset="-120"/>
+                <a:latin typeface="Aeonik" pitchFamily="34" charset="0"/>
+                <a:ea typeface="Aeonik" pitchFamily="34" charset="-122"/>
+                <a:cs typeface="Aeonik" pitchFamily="34" charset="-120"/>
               </a:rPr>
               <a:t>Key Message: Edge AI is transforming manufacturing and healthcare, prioritizing long-lifecycle, high-reliability silicon.</a:t>
             </a:r>
@@ -5207,9 +5207,9 @@
                 <a:solidFill>
                   <a:srgbClr val="6B6560"/>
                 </a:solidFill>
-                <a:latin typeface="VVDS Fifties SCond Reg" pitchFamily="34" charset="0"/>
-                <a:ea typeface="VVDS Fifties SCond Reg" pitchFamily="34" charset="-122"/>
-                <a:cs typeface="VVDS Fifties SCond Reg" pitchFamily="34" charset="-120"/>
+                <a:latin typeface="Aeonik" pitchFamily="34" charset="0"/>
+                <a:ea typeface="Aeonik" pitchFamily="34" charset="-122"/>
+                <a:cs typeface="Aeonik" pitchFamily="34" charset="-120"/>
               </a:rPr>
               <a:t>Factory floor nodes execute real-time local algorithms for predictive maintenance and machine vision controls, utilizing highly rugged legacy processes.</a:t>
             </a:r>
@@ -5310,9 +5310,9 @@
                 <a:solidFill>
                   <a:srgbClr val="6B6560"/>
                 </a:solidFill>
-                <a:latin typeface="VVDS Fifties SCond Reg" pitchFamily="34" charset="0"/>
-                <a:ea typeface="VVDS Fifties SCond Reg" pitchFamily="34" charset="-122"/>
-                <a:cs typeface="VVDS Fifties SCond Reg" pitchFamily="34" charset="-120"/>
+                <a:latin typeface="Aeonik" pitchFamily="34" charset="0"/>
+                <a:ea typeface="Aeonik" pitchFamily="34" charset="-122"/>
+                <a:cs typeface="Aeonik" pitchFamily="34" charset="-120"/>
               </a:rPr>
               <a:t>Semiconductors enable smart wearable diagnostics, active health implants, and personalized diagnostics. Requires extreme reliability certifications.</a:t>
             </a:r>
@@ -5381,9 +5381,9 @@
                 <a:solidFill>
                   <a:srgbClr val="B84A2F"/>
                 </a:solidFill>
-                <a:latin typeface="VVDS Fifties Exp Reg" pitchFamily="34" charset="0"/>
-                <a:ea typeface="VVDS Fifties Exp Reg" pitchFamily="34" charset="-122"/>
-                <a:cs typeface="VVDS Fifties Exp Reg" pitchFamily="34" charset="-120"/>
+                <a:latin typeface="Aeonik" pitchFamily="34" charset="0"/>
+                <a:ea typeface="Aeonik" pitchFamily="34" charset="-122"/>
+                <a:cs typeface="Aeonik" pitchFamily="34" charset="-120"/>
               </a:rPr>
               <a:t>PART 3: END-USER INDUSTRIES &amp; APPLICATION ECOSYSTEM</a:t>
             </a:r>
@@ -5459,9 +5459,9 @@
                 <a:solidFill>
                   <a:srgbClr val="6B6560"/>
                 </a:solidFill>
-                <a:latin typeface="VVDS Fifties Exp Reg" pitchFamily="34" charset="0"/>
-                <a:ea typeface="VVDS Fifties Exp Reg" pitchFamily="34" charset="-122"/>
-                <a:cs typeface="VVDS Fifties Exp Reg" pitchFamily="34" charset="-120"/>
+                <a:latin typeface="Aeonik" pitchFamily="34" charset="0"/>
+                <a:ea typeface="Aeonik" pitchFamily="34" charset="-122"/>
+                <a:cs typeface="Aeonik" pitchFamily="34" charset="-120"/>
               </a:rPr>
               <a:t>The 2026 Semiconductor Ecosystem | Slide 16</a:t>
             </a:r>
@@ -5523,9 +5523,9 @@
                 <a:solidFill>
                   <a:srgbClr val="768C7C"/>
                 </a:solidFill>
-                <a:latin typeface="VVDS Fifties SCond Reg" pitchFamily="34" charset="0"/>
-                <a:ea typeface="VVDS Fifties SCond Reg" pitchFamily="34" charset="-122"/>
-                <a:cs typeface="VVDS Fifties SCond Reg" pitchFamily="34" charset="-120"/>
+                <a:latin typeface="Aeonik" pitchFamily="34" charset="0"/>
+                <a:ea typeface="Aeonik" pitchFamily="34" charset="-122"/>
+                <a:cs typeface="Aeonik" pitchFamily="34" charset="-120"/>
               </a:rPr>
               <a:t>Key Message: While traditional consumer tech matures, frontiers like Quantum, 6G, and Neuromorphic computing define the 2030 roadmap.</a:t>
             </a:r>
@@ -5563,9 +5563,9 @@
                 <a:solidFill>
                   <a:srgbClr val="6B6560"/>
                 </a:solidFill>
-                <a:latin typeface="VVDS Fifties SCond Reg" pitchFamily="34" charset="0"/>
-                <a:ea typeface="VVDS Fifties SCond Reg" pitchFamily="34" charset="-122"/>
-                <a:cs typeface="VVDS Fifties SCond Reg" pitchFamily="34" charset="-120"/>
+                <a:latin typeface="Aeonik" pitchFamily="34" charset="0"/>
+                <a:ea typeface="Aeonik" pitchFamily="34" charset="-122"/>
+                <a:cs typeface="Aeonik" pitchFamily="34" charset="-120"/>
               </a:rPr>
               <a:t>- On-Device NPU Logic: Integrating Neural Processing Units (NPUs) into laptops and mobile phones to enable local AI execution.</a:t>
             </a:r>
@@ -5588,9 +5588,9 @@
                 <a:solidFill>
                   <a:srgbClr val="6B6560"/>
                 </a:solidFill>
-                <a:latin typeface="VVDS Fifties SCond Reg" pitchFamily="34" charset="0"/>
-                <a:ea typeface="VVDS Fifties SCond Reg" pitchFamily="34" charset="-122"/>
-                <a:cs typeface="VVDS Fifties SCond Reg" pitchFamily="34" charset="-120"/>
+                <a:latin typeface="Aeonik" pitchFamily="34" charset="0"/>
+                <a:ea typeface="Aeonik" pitchFamily="34" charset="-122"/>
+                <a:cs typeface="Aeonik" pitchFamily="34" charset="-120"/>
               </a:rPr>
               <a:t>- Neuromorphic Computing: Researching brain-inspired architectures targeting extreme computing power efficiency.</a:t>
             </a:r>
@@ -5613,9 +5613,9 @@
                 <a:solidFill>
                   <a:srgbClr val="6B6560"/>
                 </a:solidFill>
-                <a:latin typeface="VVDS Fifties SCond Reg" pitchFamily="34" charset="0"/>
-                <a:ea typeface="VVDS Fifties SCond Reg" pitchFamily="34" charset="-122"/>
-                <a:cs typeface="VVDS Fifties SCond Reg" pitchFamily="34" charset="-120"/>
+                <a:latin typeface="Aeonik" pitchFamily="34" charset="0"/>
+                <a:ea typeface="Aeonik" pitchFamily="34" charset="-122"/>
+                <a:cs typeface="Aeonik" pitchFamily="34" charset="-120"/>
               </a:rPr>
               <a:t>- Next-Gen Frontiers: Developing quantum structures and 6G communications hardware blocks.</a:t>
             </a:r>
@@ -5677,9 +5677,9 @@
                 <a:solidFill>
                   <a:srgbClr val="768C7C"/>
                 </a:solidFill>
-                <a:latin typeface="VVDS Fifties Exp Reg" pitchFamily="34" charset="0"/>
-                <a:ea typeface="VVDS Fifties Exp Reg" pitchFamily="34" charset="-122"/>
-                <a:cs typeface="VVDS Fifties Exp Reg" pitchFamily="34" charset="-120"/>
+                <a:latin typeface="Aeonik" pitchFamily="34" charset="0"/>
+                <a:ea typeface="Aeonik" pitchFamily="34" charset="-122"/>
+                <a:cs typeface="Aeonik" pitchFamily="34" charset="-120"/>
               </a:rPr>
               <a:t>NPU CORES</a:t>
             </a:r>
@@ -5755,9 +5755,9 @@
                 <a:solidFill>
                   <a:srgbClr val="6B6560"/>
                 </a:solidFill>
-                <a:latin typeface="VVDS Fifties SCond Reg" pitchFamily="34" charset="0"/>
-                <a:ea typeface="VVDS Fifties SCond Reg" pitchFamily="34" charset="-122"/>
-                <a:cs typeface="VVDS Fifties SCond Reg" pitchFamily="34" charset="-120"/>
+                <a:latin typeface="Aeonik" pitchFamily="34" charset="0"/>
+                <a:ea typeface="Aeonik" pitchFamily="34" charset="-122"/>
+                <a:cs typeface="Aeonik" pitchFamily="34" charset="-120"/>
               </a:rPr>
               <a:t>Standard hardware in 2026 client electronics (laptops, phones)</a:t>
             </a:r>
@@ -5826,9 +5826,9 @@
                 <a:solidFill>
                   <a:srgbClr val="B84A2F"/>
                 </a:solidFill>
-                <a:latin typeface="VVDS Fifties Exp Reg" pitchFamily="34" charset="0"/>
-                <a:ea typeface="VVDS Fifties Exp Reg" pitchFamily="34" charset="-122"/>
-                <a:cs typeface="VVDS Fifties Exp Reg" pitchFamily="34" charset="-120"/>
+                <a:latin typeface="Aeonik" pitchFamily="34" charset="0"/>
+                <a:ea typeface="Aeonik" pitchFamily="34" charset="-122"/>
+                <a:cs typeface="Aeonik" pitchFamily="34" charset="-120"/>
               </a:rPr>
               <a:t>SUMMARY &amp; ROADMAP</a:t>
             </a:r>
@@ -5904,9 +5904,9 @@
                 <a:solidFill>
                   <a:srgbClr val="6B6560"/>
                 </a:solidFill>
-                <a:latin typeface="VVDS Fifties Exp Reg" pitchFamily="34" charset="0"/>
-                <a:ea typeface="VVDS Fifties Exp Reg" pitchFamily="34" charset="-122"/>
-                <a:cs typeface="VVDS Fifties Exp Reg" pitchFamily="34" charset="-120"/>
+                <a:latin typeface="Aeonik" pitchFamily="34" charset="0"/>
+                <a:ea typeface="Aeonik" pitchFamily="34" charset="-122"/>
+                <a:cs typeface="Aeonik" pitchFamily="34" charset="-120"/>
               </a:rPr>
               <a:t>The 2026 Semiconductor Ecosystem | Slide 17</a:t>
             </a:r>
@@ -5968,9 +5968,9 @@
                 <a:solidFill>
                   <a:srgbClr val="B84A2F"/>
                 </a:solidFill>
-                <a:latin typeface="VVDS Fifties SCond Reg" pitchFamily="34" charset="0"/>
-                <a:ea typeface="VVDS Fifties SCond Reg" pitchFamily="34" charset="-122"/>
-                <a:cs typeface="VVDS Fifties SCond Reg" pitchFamily="34" charset="-120"/>
+                <a:latin typeface="Aeonik" pitchFamily="34" charset="0"/>
+                <a:ea typeface="Aeonik" pitchFamily="34" charset="-122"/>
+                <a:cs typeface="Aeonik" pitchFamily="34" charset="-120"/>
               </a:rPr>
               <a:t>Key Message: We have reached a point of "Total Silicon Dependency." The path to a $2 trillion industry is certain.</a:t>
             </a:r>
@@ -6007,9 +6007,9 @@
                 <a:solidFill>
                   <a:srgbClr val="6B6560"/>
                 </a:solidFill>
-                <a:latin typeface="VVDS Fifties SCond Reg" pitchFamily="34" charset="0"/>
-                <a:ea typeface="VVDS Fifties SCond Reg" pitchFamily="34" charset="-122"/>
-                <a:cs typeface="VVDS Fifties SCond Reg" pitchFamily="34" charset="-120"/>
+                <a:latin typeface="Aeonik" pitchFamily="34" charset="0"/>
+                <a:ea typeface="Aeonik" pitchFamily="34" charset="-122"/>
+                <a:cs typeface="Aeonik" pitchFamily="34" charset="-120"/>
               </a:rPr>
               <a:t>Mastery of the semiconductor ecosystem is mastery of the future. The "Chip Wars" aren't just about manufacturing; they are about who can best harness silicon to transform their industries.</a:t>
             </a:r>
@@ -6046,9 +6046,9 @@
                 <a:solidFill>
                   <a:srgbClr val="1A1714"/>
                 </a:solidFill>
-                <a:latin typeface="VVDS Fifties Exp Reg" pitchFamily="34" charset="0"/>
-                <a:ea typeface="VVDS Fifties Exp Reg" pitchFamily="34" charset="-122"/>
-                <a:cs typeface="VVDS Fifties Exp Reg" pitchFamily="34" charset="-120"/>
+                <a:latin typeface="Aeonik" pitchFamily="34" charset="0"/>
+                <a:ea typeface="Aeonik" pitchFamily="34" charset="-122"/>
+                <a:cs typeface="Aeonik" pitchFamily="34" charset="-120"/>
               </a:rPr>
               <a:t>KEY TAKEAWAYS SUMMARY</a:t>
             </a:r>
@@ -6149,9 +6149,9 @@
                 <a:solidFill>
                   <a:srgbClr val="6B6560"/>
                 </a:solidFill>
-                <a:latin typeface="VVDS Fifties SCond Reg" pitchFamily="34" charset="0"/>
-                <a:ea typeface="VVDS Fifties SCond Reg" pitchFamily="34" charset="-122"/>
-                <a:cs typeface="VVDS Fifties SCond Reg" pitchFamily="34" charset="-120"/>
+                <a:latin typeface="Aeonik" pitchFamily="34" charset="0"/>
+                <a:ea typeface="Aeonik" pitchFamily="34" charset="-122"/>
+                <a:cs typeface="Aeonik" pitchFamily="34" charset="-120"/>
               </a:rPr>
               <a:t>Shift from JIT to Strategic Hybrid; resilience is the new ROI.</a:t>
             </a:r>
@@ -6252,9 +6252,9 @@
                 <a:solidFill>
                   <a:srgbClr val="6B6560"/>
                 </a:solidFill>
-                <a:latin typeface="VVDS Fifties SCond Reg" pitchFamily="34" charset="0"/>
-                <a:ea typeface="VVDS Fifties SCond Reg" pitchFamily="34" charset="-122"/>
-                <a:cs typeface="VVDS Fifties SCond Reg" pitchFamily="34" charset="-120"/>
+                <a:latin typeface="Aeonik" pitchFamily="34" charset="0"/>
+                <a:ea typeface="Aeonik" pitchFamily="34" charset="-122"/>
+                <a:cs typeface="Aeonik" pitchFamily="34" charset="-120"/>
               </a:rPr>
               <a:t>Chokepoints in Advanced Packaging and SME are the new strategic risks.</a:t>
             </a:r>
@@ -6355,9 +6355,9 @@
                 <a:solidFill>
                   <a:srgbClr val="6B6560"/>
                 </a:solidFill>
-                <a:latin typeface="VVDS Fifties SCond Reg" pitchFamily="34" charset="0"/>
-                <a:ea typeface="VVDS Fifties SCond Reg" pitchFamily="34" charset="-122"/>
-                <a:cs typeface="VVDS Fifties SCond Reg" pitchFamily="34" charset="-120"/>
+                <a:latin typeface="Aeonik" pitchFamily="34" charset="0"/>
+                <a:ea typeface="Aeonik" pitchFamily="34" charset="-122"/>
+                <a:cs typeface="Aeonik" pitchFamily="34" charset="-120"/>
               </a:rPr>
               <a:t>AI is the Value King; Automotive is the Volume King.</a:t>
             </a:r>
@@ -6426,9 +6426,9 @@
                 <a:solidFill>
                   <a:srgbClr val="B84A2F"/>
                 </a:solidFill>
-                <a:latin typeface="VVDS Fifties Exp Reg" pitchFamily="34" charset="0"/>
-                <a:ea typeface="VVDS Fifties Exp Reg" pitchFamily="34" charset="-122"/>
-                <a:cs typeface="VVDS Fifties Exp Reg" pitchFamily="34" charset="-120"/>
+                <a:latin typeface="Aeonik" pitchFamily="34" charset="0"/>
+                <a:ea typeface="Aeonik" pitchFamily="34" charset="-122"/>
+                <a:cs typeface="Aeonik" pitchFamily="34" charset="-120"/>
               </a:rPr>
               <a:t>THE END</a:t>
             </a:r>
@@ -6504,9 +6504,9 @@
                 <a:solidFill>
                   <a:srgbClr val="6B6560"/>
                 </a:solidFill>
-                <a:latin typeface="VVDS Fifties SCond Reg" pitchFamily="34" charset="0"/>
-                <a:ea typeface="VVDS Fifties SCond Reg" pitchFamily="34" charset="-122"/>
-                <a:cs typeface="VVDS Fifties SCond Reg" pitchFamily="34" charset="-120"/>
+                <a:latin typeface="Aeonik" pitchFamily="34" charset="0"/>
+                <a:ea typeface="Aeonik" pitchFamily="34" charset="-122"/>
+                <a:cs typeface="Aeonik" pitchFamily="34" charset="-120"/>
               </a:rPr>
               <a:t>Mastery of the semiconductor ecosystem is mastery of the future.</a:t>
             </a:r>
@@ -6563,9 +6563,9 @@
                 <a:solidFill>
                   <a:srgbClr val="6B6560"/>
                 </a:solidFill>
-                <a:latin typeface="VVDS Fifties Exp Reg" pitchFamily="34" charset="0"/>
-                <a:ea typeface="VVDS Fifties Exp Reg" pitchFamily="34" charset="-122"/>
-                <a:cs typeface="VVDS Fifties Exp Reg" pitchFamily="34" charset="-120"/>
+                <a:latin typeface="Aeonik" pitchFamily="34" charset="0"/>
+                <a:ea typeface="Aeonik" pitchFamily="34" charset="-122"/>
+                <a:cs typeface="Aeonik" pitchFamily="34" charset="-120"/>
               </a:rPr>
               <a:t>Presenter: Phyoe Sat Paing</a:t>
             </a:r>
@@ -6580,9 +6580,9 @@
                 <a:solidFill>
                   <a:srgbClr val="6B6560"/>
                 </a:solidFill>
-                <a:latin typeface="VVDS Fifties Exp Reg" pitchFamily="34" charset="0"/>
-                <a:ea typeface="VVDS Fifties Exp Reg" pitchFamily="34" charset="-122"/>
-                <a:cs typeface="VVDS Fifties Exp Reg" pitchFamily="34" charset="-120"/>
+                <a:latin typeface="Aeonik" pitchFamily="34" charset="0"/>
+                <a:ea typeface="Aeonik" pitchFamily="34" charset="-122"/>
+                <a:cs typeface="Aeonik" pitchFamily="34" charset="-120"/>
               </a:rPr>
               <a:t>Boardroom Strategic Briefing</a:t>
             </a:r>
@@ -6619,9 +6619,9 @@
                 <a:solidFill>
                   <a:srgbClr val="6B6560"/>
                 </a:solidFill>
-                <a:latin typeface="VVDS Fifties Exp Reg" pitchFamily="34" charset="0"/>
-                <a:ea typeface="VVDS Fifties Exp Reg" pitchFamily="34" charset="-122"/>
-                <a:cs typeface="VVDS Fifties Exp Reg" pitchFamily="34" charset="-120"/>
+                <a:latin typeface="Aeonik" pitchFamily="34" charset="0"/>
+                <a:ea typeface="Aeonik" pitchFamily="34" charset="-122"/>
+                <a:cs typeface="Aeonik" pitchFamily="34" charset="-120"/>
               </a:rPr>
               <a:t>The 2026 Semiconductor Ecosystem | Slide 18</a:t>
             </a:r>
@@ -6690,9 +6690,9 @@
                 <a:solidFill>
                   <a:srgbClr val="B84A2F"/>
                 </a:solidFill>
-                <a:latin typeface="VVDS Fifties Exp Reg" pitchFamily="34" charset="0"/>
-                <a:ea typeface="VVDS Fifties Exp Reg" pitchFamily="34" charset="-122"/>
-                <a:cs typeface="VVDS Fifties Exp Reg" pitchFamily="34" charset="-120"/>
+                <a:latin typeface="Aeonik" pitchFamily="34" charset="0"/>
+                <a:ea typeface="Aeonik" pitchFamily="34" charset="-122"/>
+                <a:cs typeface="Aeonik" pitchFamily="34" charset="-120"/>
               </a:rPr>
               <a:t>PART 1: PROCUREMENT OF SEMICONDUCTORS</a:t>
             </a:r>
@@ -6768,9 +6768,9 @@
                 <a:solidFill>
                   <a:srgbClr val="6B6560"/>
                 </a:solidFill>
-                <a:latin typeface="VVDS Fifties Exp Reg" pitchFamily="34" charset="0"/>
-                <a:ea typeface="VVDS Fifties Exp Reg" pitchFamily="34" charset="-122"/>
-                <a:cs typeface="VVDS Fifties Exp Reg" pitchFamily="34" charset="-120"/>
+                <a:latin typeface="Aeonik" pitchFamily="34" charset="0"/>
+                <a:ea typeface="Aeonik" pitchFamily="34" charset="-122"/>
+                <a:cs typeface="Aeonik" pitchFamily="34" charset="-120"/>
               </a:rPr>
               <a:t>The 2026 Semiconductor Ecosystem | Slide 02</a:t>
             </a:r>
@@ -6832,9 +6832,9 @@
                 <a:solidFill>
                   <a:srgbClr val="B84A2F"/>
                 </a:solidFill>
-                <a:latin typeface="VVDS Fifties SCond Reg" pitchFamily="34" charset="0"/>
-                <a:ea typeface="VVDS Fifties SCond Reg" pitchFamily="34" charset="-122"/>
-                <a:cs typeface="VVDS Fifties SCond Reg" pitchFamily="34" charset="-120"/>
+                <a:latin typeface="Aeonik" pitchFamily="34" charset="0"/>
+                <a:ea typeface="Aeonik" pitchFamily="34" charset="-122"/>
+                <a:cs typeface="Aeonik" pitchFamily="34" charset="-120"/>
               </a:rPr>
               <a:t>Key Message: Navigating a $1.3 trillion market requires balancing unprecedented growth with systemic supply chain fragility.</a:t>
             </a:r>
@@ -6872,9 +6872,9 @@
                 <a:solidFill>
                   <a:srgbClr val="6B6560"/>
                 </a:solidFill>
-                <a:latin typeface="VVDS Fifties SCond Reg" pitchFamily="34" charset="0"/>
-                <a:ea typeface="VVDS Fifties SCond Reg" pitchFamily="34" charset="-122"/>
-                <a:cs typeface="VVDS Fifties SCond Reg" pitchFamily="34" charset="-120"/>
+                <a:latin typeface="Aeonik" pitchFamily="34" charset="0"/>
+                <a:ea typeface="Aeonik" pitchFamily="34" charset="-122"/>
+                <a:cs typeface="Aeonik" pitchFamily="34" charset="-120"/>
               </a:rPr>
               <a:t>- Record-High Valuations: Growth is driven by explosive global demand for AI systems and electric vehicle power logic.</a:t>
             </a:r>
@@ -6897,9 +6897,9 @@
                 <a:solidFill>
                   <a:srgbClr val="6B6560"/>
                 </a:solidFill>
-                <a:latin typeface="VVDS Fifties SCond Reg" pitchFamily="34" charset="0"/>
-                <a:ea typeface="VVDS Fifties SCond Reg" pitchFamily="34" charset="-122"/>
-                <a:cs typeface="VVDS Fifties SCond Reg" pitchFamily="34" charset="-120"/>
+                <a:latin typeface="Aeonik" pitchFamily="34" charset="0"/>
+                <a:ea typeface="Aeonik" pitchFamily="34" charset="-122"/>
+                <a:cs typeface="Aeonik" pitchFamily="34" charset="-120"/>
               </a:rPr>
               <a:t>- Systemic Fragility: Leading-edge fabs operate near maximum capacity, leaving the industry vulnerable to minor material delays.</a:t>
             </a:r>
@@ -6922,9 +6922,9 @@
                 <a:solidFill>
                   <a:srgbClr val="6B6560"/>
                 </a:solidFill>
-                <a:latin typeface="VVDS Fifties SCond Reg" pitchFamily="34" charset="0"/>
-                <a:ea typeface="VVDS Fifties SCond Reg" pitchFamily="34" charset="-122"/>
-                <a:cs typeface="VVDS Fifties SCond Reg" pitchFamily="34" charset="-120"/>
+                <a:latin typeface="Aeonik" pitchFamily="34" charset="0"/>
+                <a:ea typeface="Aeonik" pitchFamily="34" charset="-122"/>
+                <a:cs typeface="Aeonik" pitchFamily="34" charset="-120"/>
               </a:rPr>
               <a:t>- Strategic Pivot: Sourcing HBM (High Bandwidth Memory) and advanced logic requires a shift from transactional purchasing to capacity reservation models.</a:t>
             </a:r>
@@ -6986,9 +6986,9 @@
                 <a:solidFill>
                   <a:srgbClr val="B84A2F"/>
                 </a:solidFill>
-                <a:latin typeface="VVDS Fifties Exp Reg" pitchFamily="34" charset="0"/>
-                <a:ea typeface="VVDS Fifties Exp Reg" pitchFamily="34" charset="-122"/>
-                <a:cs typeface="VVDS Fifties Exp Reg" pitchFamily="34" charset="-120"/>
+                <a:latin typeface="Aeonik" pitchFamily="34" charset="0"/>
+                <a:ea typeface="Aeonik" pitchFamily="34" charset="-122"/>
+                <a:cs typeface="Aeonik" pitchFamily="34" charset="-120"/>
               </a:rPr>
               <a:t>ESTIMATE</a:t>
             </a:r>
@@ -7064,9 +7064,9 @@
                 <a:solidFill>
                   <a:srgbClr val="6B6560"/>
                 </a:solidFill>
-                <a:latin typeface="VVDS Fifties Exp Reg" pitchFamily="34" charset="0"/>
-                <a:ea typeface="VVDS Fifties Exp Reg" pitchFamily="34" charset="-122"/>
-                <a:cs typeface="VVDS Fifties Exp Reg" pitchFamily="34" charset="-120"/>
+                <a:latin typeface="Aeonik" pitchFamily="34" charset="0"/>
+                <a:ea typeface="Aeonik" pitchFamily="34" charset="-122"/>
+                <a:cs typeface="Aeonik" pitchFamily="34" charset="-120"/>
               </a:rPr>
               <a:t>Global Market Value</a:t>
             </a:r>
@@ -7081,9 +7081,9 @@
                 <a:solidFill>
                   <a:srgbClr val="6B6560"/>
                 </a:solidFill>
-                <a:latin typeface="VVDS Fifties Exp Reg" pitchFamily="34" charset="0"/>
-                <a:ea typeface="VVDS Fifties Exp Reg" pitchFamily="34" charset="-122"/>
-                <a:cs typeface="VVDS Fifties Exp Reg" pitchFamily="34" charset="-120"/>
+                <a:latin typeface="Aeonik" pitchFamily="34" charset="0"/>
+                <a:ea typeface="Aeonik" pitchFamily="34" charset="-122"/>
+                <a:cs typeface="Aeonik" pitchFamily="34" charset="-120"/>
               </a:rPr>
               <a:t>Analyst consensus 2026</a:t>
             </a:r>
@@ -7152,9 +7152,9 @@
                 <a:solidFill>
                   <a:srgbClr val="B84A2F"/>
                 </a:solidFill>
-                <a:latin typeface="VVDS Fifties Exp Reg" pitchFamily="34" charset="0"/>
-                <a:ea typeface="VVDS Fifties Exp Reg" pitchFamily="34" charset="-122"/>
-                <a:cs typeface="VVDS Fifties Exp Reg" pitchFamily="34" charset="-120"/>
+                <a:latin typeface="Aeonik" pitchFamily="34" charset="0"/>
+                <a:ea typeface="Aeonik" pitchFamily="34" charset="-122"/>
+                <a:cs typeface="Aeonik" pitchFamily="34" charset="-120"/>
               </a:rPr>
               <a:t>PART 1: PROCUREMENT OF SEMICONDUCTORS</a:t>
             </a:r>
@@ -7230,9 +7230,9 @@
                 <a:solidFill>
                   <a:srgbClr val="6B6560"/>
                 </a:solidFill>
-                <a:latin typeface="VVDS Fifties Exp Reg" pitchFamily="34" charset="0"/>
-                <a:ea typeface="VVDS Fifties Exp Reg" pitchFamily="34" charset="-122"/>
-                <a:cs typeface="VVDS Fifties Exp Reg" pitchFamily="34" charset="-120"/>
+                <a:latin typeface="Aeonik" pitchFamily="34" charset="0"/>
+                <a:ea typeface="Aeonik" pitchFamily="34" charset="-122"/>
+                <a:cs typeface="Aeonik" pitchFamily="34" charset="-120"/>
               </a:rPr>
               <a:t>The 2026 Semiconductor Ecosystem | Slide 03</a:t>
             </a:r>
@@ -7294,9 +7294,9 @@
                 <a:solidFill>
                   <a:srgbClr val="9E7D84"/>
                 </a:solidFill>
-                <a:latin typeface="VVDS Fifties SCond Reg" pitchFamily="34" charset="0"/>
-                <a:ea typeface="VVDS Fifties SCond Reg" pitchFamily="34" charset="-122"/>
-                <a:cs typeface="VVDS Fifties SCond Reg" pitchFamily="34" charset="-120"/>
+                <a:latin typeface="Aeonik" pitchFamily="34" charset="0"/>
+                <a:ea typeface="Aeonik" pitchFamily="34" charset="-122"/>
+                <a:cs typeface="Aeonik" pitchFamily="34" charset="-120"/>
               </a:rPr>
               <a:t>Key Message: Pure JIT is obsolete; the new standard is a hybrid approach that prioritizes resilience for high-value nodes.</a:t>
             </a:r>
@@ -7397,9 +7397,9 @@
                 <a:solidFill>
                   <a:srgbClr val="6B6560"/>
                 </a:solidFill>
-                <a:latin typeface="VVDS Fifties SCond Reg" pitchFamily="34" charset="0"/>
-                <a:ea typeface="VVDS Fifties SCond Reg" pitchFamily="34" charset="-122"/>
-                <a:cs typeface="VVDS Fifties SCond Reg" pitchFamily="34" charset="-120"/>
+                <a:latin typeface="Aeonik" pitchFamily="34" charset="0"/>
+                <a:ea typeface="Aeonik" pitchFamily="34" charset="-122"/>
+                <a:cs typeface="Aeonik" pitchFamily="34" charset="-120"/>
               </a:rPr>
               <a:t>Used for standardized legacy passive elements and commoditized logic chips. Minimizes capital lock-up and inventory holding costs while keeping storage footprint low.</a:t>
             </a:r>
@@ -7500,9 +7500,9 @@
                 <a:solidFill>
                   <a:srgbClr val="6B6560"/>
                 </a:solidFill>
-                <a:latin typeface="VVDS Fifties SCond Reg" pitchFamily="34" charset="0"/>
-                <a:ea typeface="VVDS Fifties SCond Reg" pitchFamily="34" charset="-122"/>
-                <a:cs typeface="VVDS Fifties SCond Reg" pitchFamily="34" charset="-120"/>
+                <a:latin typeface="Aeonik" pitchFamily="34" charset="0"/>
+                <a:ea typeface="Aeonik" pitchFamily="34" charset="-122"/>
+                <a:cs typeface="Aeonik" pitchFamily="34" charset="-120"/>
               </a:rPr>
               <a:t>Maintaining 3 to 6 months of safety stock for sole-sourced, high-margin microcomponents (HBM, custom GPUs) to guarantee manufacturing continuity.</a:t>
             </a:r>
@@ -7571,9 +7571,9 @@
                 <a:solidFill>
                   <a:srgbClr val="B84A2F"/>
                 </a:solidFill>
-                <a:latin typeface="VVDS Fifties Exp Reg" pitchFamily="34" charset="0"/>
-                <a:ea typeface="VVDS Fifties Exp Reg" pitchFamily="34" charset="-122"/>
-                <a:cs typeface="VVDS Fifties Exp Reg" pitchFamily="34" charset="-120"/>
+                <a:latin typeface="Aeonik" pitchFamily="34" charset="0"/>
+                <a:ea typeface="Aeonik" pitchFamily="34" charset="-122"/>
+                <a:cs typeface="Aeonik" pitchFamily="34" charset="-120"/>
               </a:rPr>
               <a:t>PART 1: PROCUREMENT OF SEMICONDUCTORS</a:t>
             </a:r>
@@ -7649,9 +7649,9 @@
                 <a:solidFill>
                   <a:srgbClr val="6B6560"/>
                 </a:solidFill>
-                <a:latin typeface="VVDS Fifties Exp Reg" pitchFamily="34" charset="0"/>
-                <a:ea typeface="VVDS Fifties Exp Reg" pitchFamily="34" charset="-122"/>
-                <a:cs typeface="VVDS Fifties Exp Reg" pitchFamily="34" charset="-120"/>
+                <a:latin typeface="Aeonik" pitchFamily="34" charset="0"/>
+                <a:ea typeface="Aeonik" pitchFamily="34" charset="-122"/>
+                <a:cs typeface="Aeonik" pitchFamily="34" charset="-120"/>
               </a:rPr>
               <a:t>The 2026 Semiconductor Ecosystem | Slide 04</a:t>
             </a:r>
@@ -7713,9 +7713,9 @@
                 <a:solidFill>
                   <a:srgbClr val="768C7C"/>
                 </a:solidFill>
-                <a:latin typeface="VVDS Fifties SCond Reg" pitchFamily="34" charset="0"/>
-                <a:ea typeface="VVDS Fifties SCond Reg" pitchFamily="34" charset="-122"/>
-                <a:cs typeface="VVDS Fifties SCond Reg" pitchFamily="34" charset="-120"/>
+                <a:latin typeface="Aeonik" pitchFamily="34" charset="0"/>
+                <a:ea typeface="Aeonik" pitchFamily="34" charset="-122"/>
+                <a:cs typeface="Aeonik" pitchFamily="34" charset="-120"/>
               </a:rPr>
               <a:t>Key Message: Data opacity and reactive risk management are the primary enemies of a resilient procurement strategy.</a:t>
             </a:r>
@@ -7753,9 +7753,9 @@
                 <a:solidFill>
                   <a:srgbClr val="6B6560"/>
                 </a:solidFill>
-                <a:latin typeface="VVDS Fifties SCond Reg" pitchFamily="34" charset="0"/>
-                <a:ea typeface="VVDS Fifties SCond Reg" pitchFamily="34" charset="-122"/>
-                <a:cs typeface="VVDS Fifties SCond Reg" pitchFamily="34" charset="-120"/>
+                <a:latin typeface="Aeonik" pitchFamily="34" charset="0"/>
+                <a:ea typeface="Aeonik" pitchFamily="34" charset="-122"/>
+                <a:cs typeface="Aeonik" pitchFamily="34" charset="-120"/>
               </a:rPr>
               <a:t>- Category Management Sourcing: Slicing procurement into precise technology nodes (Leading-edge sub-7nm vs Legacy nodes).</a:t>
             </a:r>
@@ -7778,9 +7778,9 @@
                 <a:solidFill>
                   <a:srgbClr val="6B6560"/>
                 </a:solidFill>
-                <a:latin typeface="VVDS Fifties SCond Reg" pitchFamily="34" charset="0"/>
-                <a:ea typeface="VVDS Fifties SCond Reg" pitchFamily="34" charset="-122"/>
-                <a:cs typeface="VVDS Fifties SCond Reg" pitchFamily="34" charset="-120"/>
+                <a:latin typeface="Aeonik" pitchFamily="34" charset="0"/>
+                <a:ea typeface="Aeonik" pitchFamily="34" charset="-122"/>
+                <a:cs typeface="Aeonik" pitchFamily="34" charset="-120"/>
               </a:rPr>
               <a:t>- Leading-edge Sourcing: Focuses on deep co-development partnerships, engineering collaboration, and long-term volume commitments.</a:t>
             </a:r>
@@ -7803,9 +7803,9 @@
                 <a:solidFill>
                   <a:srgbClr val="6B6560"/>
                 </a:solidFill>
-                <a:latin typeface="VVDS Fifties SCond Reg" pitchFamily="34" charset="0"/>
-                <a:ea typeface="VVDS Fifties SCond Reg" pitchFamily="34" charset="-122"/>
-                <a:cs typeface="VVDS Fifties SCond Reg" pitchFamily="34" charset="-120"/>
+                <a:latin typeface="Aeonik" pitchFamily="34" charset="0"/>
+                <a:ea typeface="Aeonik" pitchFamily="34" charset="-122"/>
+                <a:cs typeface="Aeonik" pitchFamily="34" charset="-120"/>
               </a:rPr>
               <a:t>- Legacy Sourcing: Emphasizes multi-sourcing, second-sourcing qualification, and legacy lifecycle management to offset obsolescence.</a:t>
             </a:r>
@@ -7867,9 +7867,9 @@
                 <a:solidFill>
                   <a:srgbClr val="6B6560"/>
                 </a:solidFill>
-                <a:latin typeface="VVDS Fifties SCond Reg" pitchFamily="34" charset="0"/>
-                <a:ea typeface="VVDS Fifties SCond Reg" pitchFamily="34" charset="-122"/>
-                <a:cs typeface="VVDS Fifties SCond Reg" pitchFamily="34" charset="-120"/>
+                <a:latin typeface="Aeonik" pitchFamily="34" charset="0"/>
+                <a:ea typeface="Aeonik" pitchFamily="34" charset="-122"/>
+                <a:cs typeface="Aeonik" pitchFamily="34" charset="-120"/>
               </a:rPr>
               <a:t>Leading-Edge Nodes</a:t>
             </a:r>
@@ -7890,9 +7890,9 @@
                 <a:solidFill>
                   <a:srgbClr val="6B6560"/>
                 </a:solidFill>
-                <a:latin typeface="VVDS Fifties SCond Reg" pitchFamily="34" charset="0"/>
-                <a:ea typeface="VVDS Fifties SCond Reg" pitchFamily="34" charset="-122"/>
-                <a:cs typeface="VVDS Fifties SCond Reg" pitchFamily="34" charset="-120"/>
+                <a:latin typeface="Aeonik" pitchFamily="34" charset="0"/>
+                <a:ea typeface="Aeonik" pitchFamily="34" charset="-122"/>
+                <a:cs typeface="Aeonik" pitchFamily="34" charset="-120"/>
               </a:rPr>
               <a:t>Focus: Deep alliances, R&amp;D partnerships, capacity reservations.</a:t>
             </a:r>
@@ -7954,9 +7954,9 @@
                 <a:solidFill>
                   <a:srgbClr val="6B6560"/>
                 </a:solidFill>
-                <a:latin typeface="VVDS Fifties SCond Reg" pitchFamily="34" charset="0"/>
-                <a:ea typeface="VVDS Fifties SCond Reg" pitchFamily="34" charset="-122"/>
-                <a:cs typeface="VVDS Fifties SCond Reg" pitchFamily="34" charset="-120"/>
+                <a:latin typeface="Aeonik" pitchFamily="34" charset="0"/>
+                <a:ea typeface="Aeonik" pitchFamily="34" charset="-122"/>
+                <a:cs typeface="Aeonik" pitchFamily="34" charset="-120"/>
               </a:rPr>
               <a:t>Legacy Nodes</a:t>
             </a:r>
@@ -7977,9 +7977,9 @@
                 <a:solidFill>
                   <a:srgbClr val="6B6560"/>
                 </a:solidFill>
-                <a:latin typeface="VVDS Fifties SCond Reg" pitchFamily="34" charset="0"/>
-                <a:ea typeface="VVDS Fifties SCond Reg" pitchFamily="34" charset="-122"/>
-                <a:cs typeface="VVDS Fifties SCond Reg" pitchFamily="34" charset="-120"/>
+                <a:latin typeface="Aeonik" pitchFamily="34" charset="0"/>
+                <a:ea typeface="Aeonik" pitchFamily="34" charset="-122"/>
+                <a:cs typeface="Aeonik" pitchFamily="34" charset="-120"/>
               </a:rPr>
               <a:t>Focus: Multi-sourcing, distributor networks, life-cycle tracking.</a:t>
             </a:r>
@@ -8048,9 +8048,9 @@
                 <a:solidFill>
                   <a:srgbClr val="B84A2F"/>
                 </a:solidFill>
-                <a:latin typeface="VVDS Fifties Exp Reg" pitchFamily="34" charset="0"/>
-                <a:ea typeface="VVDS Fifties Exp Reg" pitchFamily="34" charset="-122"/>
-                <a:cs typeface="VVDS Fifties Exp Reg" pitchFamily="34" charset="-120"/>
+                <a:latin typeface="Aeonik" pitchFamily="34" charset="0"/>
+                <a:ea typeface="Aeonik" pitchFamily="34" charset="-122"/>
+                <a:cs typeface="Aeonik" pitchFamily="34" charset="-120"/>
               </a:rPr>
               <a:t>PART 1: PROCUREMENT OF SEMICONDUCTORS</a:t>
             </a:r>
@@ -8126,9 +8126,9 @@
                 <a:solidFill>
                   <a:srgbClr val="6B6560"/>
                 </a:solidFill>
-                <a:latin typeface="VVDS Fifties Exp Reg" pitchFamily="34" charset="0"/>
-                <a:ea typeface="VVDS Fifties Exp Reg" pitchFamily="34" charset="-122"/>
-                <a:cs typeface="VVDS Fifties Exp Reg" pitchFamily="34" charset="-120"/>
+                <a:latin typeface="Aeonik" pitchFamily="34" charset="0"/>
+                <a:ea typeface="Aeonik" pitchFamily="34" charset="-122"/>
+                <a:cs typeface="Aeonik" pitchFamily="34" charset="-120"/>
               </a:rPr>
               <a:t>The 2026 Semiconductor Ecosystem | Slide 05</a:t>
             </a:r>
@@ -8190,9 +8190,9 @@
                 <a:solidFill>
                   <a:srgbClr val="B84A2F"/>
                 </a:solidFill>
-                <a:latin typeface="VVDS Fifties SCond Reg" pitchFamily="34" charset="0"/>
-                <a:ea typeface="VVDS Fifties SCond Reg" pitchFamily="34" charset="-122"/>
-                <a:cs typeface="VVDS Fifties SCond Reg" pitchFamily="34" charset="-120"/>
+                <a:latin typeface="Aeonik" pitchFamily="34" charset="0"/>
+                <a:ea typeface="Aeonik" pitchFamily="34" charset="-122"/>
+                <a:cs typeface="Aeonik" pitchFamily="34" charset="-120"/>
               </a:rPr>
               <a:t>Key Message: AI-driven "Business Intelligence Cockpits" are essential for predicting shortages 6-12 months in advance.</a:t>
             </a:r>
@@ -8293,9 +8293,9 @@
                 <a:solidFill>
                   <a:srgbClr val="6B6560"/>
                 </a:solidFill>
-                <a:latin typeface="VVDS Fifties SCond Reg" pitchFamily="34" charset="0"/>
-                <a:ea typeface="VVDS Fifties SCond Reg" pitchFamily="34" charset="-122"/>
-                <a:cs typeface="VVDS Fifties SCond Reg" pitchFamily="34" charset="-120"/>
+                <a:latin typeface="Aeonik" pitchFamily="34" charset="0"/>
+                <a:ea typeface="Aeonik" pitchFamily="34" charset="-122"/>
+                <a:cs typeface="Aeonik" pitchFamily="34" charset="-120"/>
               </a:rPr>
               <a:t>Securing fab slots requires upfront reservation fees and take-or-pay clauses in Long-Term Agreements (LTAs) to lock down volume.</a:t>
             </a:r>
@@ -8396,9 +8396,9 @@
                 <a:solidFill>
                   <a:srgbClr val="6B6560"/>
                 </a:solidFill>
-                <a:latin typeface="VVDS Fifties SCond Reg" pitchFamily="34" charset="0"/>
-                <a:ea typeface="VVDS Fifties SCond Reg" pitchFamily="34" charset="-122"/>
-                <a:cs typeface="VVDS Fifties SCond Reg" pitchFamily="34" charset="-120"/>
+                <a:latin typeface="Aeonik" pitchFamily="34" charset="0"/>
+                <a:ea typeface="Aeonik" pitchFamily="34" charset="-122"/>
+                <a:cs typeface="Aeonik" pitchFamily="34" charset="-120"/>
               </a:rPr>
               <a:t>Decoupling supply links from high-risk locations, redirecting procurement to allied geopolitical nodes with guaranteed supply lines.</a:t>
             </a:r>
@@ -8460,9 +8460,9 @@
                 <a:solidFill>
                   <a:srgbClr val="6B6560"/>
                 </a:solidFill>
-                <a:latin typeface="VVDS Fifties SCond Reg" pitchFamily="34" charset="0"/>
-                <a:ea typeface="VVDS Fifties SCond Reg" pitchFamily="34" charset="-122"/>
-                <a:cs typeface="VVDS Fifties SCond Reg" pitchFamily="34" charset="-120"/>
+                <a:latin typeface="Aeonik" pitchFamily="34" charset="0"/>
+                <a:ea typeface="Aeonik" pitchFamily="34" charset="-122"/>
+                <a:cs typeface="Aeonik" pitchFamily="34" charset="-120"/>
               </a:rPr>
               <a:t>AI integration automatically tracks tier-2 chemical and substrate suppliers to detect factory closures or export blocks before they ripple into final fab allocations.</a:t>
             </a:r>
@@ -8531,9 +8531,9 @@
                 <a:solidFill>
                   <a:srgbClr val="B84A2F"/>
                 </a:solidFill>
-                <a:latin typeface="VVDS Fifties Exp Reg" pitchFamily="34" charset="0"/>
-                <a:ea typeface="VVDS Fifties Exp Reg" pitchFamily="34" charset="-122"/>
-                <a:cs typeface="VVDS Fifties Exp Reg" pitchFamily="34" charset="-120"/>
+                <a:latin typeface="Aeonik" pitchFamily="34" charset="0"/>
+                <a:ea typeface="Aeonik" pitchFamily="34" charset="-122"/>
+                <a:cs typeface="Aeonik" pitchFamily="34" charset="-120"/>
               </a:rPr>
               <a:t>PART 2: THE GLOBAL SUPPLY CHAIN OF SEMICONDUCTORS</a:t>
             </a:r>
@@ -8609,9 +8609,9 @@
                 <a:solidFill>
                   <a:srgbClr val="6B6560"/>
                 </a:solidFill>
-                <a:latin typeface="VVDS Fifties Exp Reg" pitchFamily="34" charset="0"/>
-                <a:ea typeface="VVDS Fifties Exp Reg" pitchFamily="34" charset="-122"/>
-                <a:cs typeface="VVDS Fifties Exp Reg" pitchFamily="34" charset="-120"/>
+                <a:latin typeface="Aeonik" pitchFamily="34" charset="0"/>
+                <a:ea typeface="Aeonik" pitchFamily="34" charset="-122"/>
+                <a:cs typeface="Aeonik" pitchFamily="34" charset="-120"/>
               </a:rPr>
               <a:t>The 2026 Semiconductor Ecosystem | Slide 06</a:t>
             </a:r>
@@ -8673,9 +8673,9 @@
                 <a:solidFill>
                   <a:srgbClr val="B84A2F"/>
                 </a:solidFill>
-                <a:latin typeface="VVDS Fifties SCond Reg" pitchFamily="34" charset="0"/>
-                <a:ea typeface="VVDS Fifties SCond Reg" pitchFamily="34" charset="-122"/>
-                <a:cs typeface="VVDS Fifties SCond Reg" pitchFamily="34" charset="-120"/>
+                <a:latin typeface="Aeonik" pitchFamily="34" charset="0"/>
+                <a:ea typeface="Aeonik" pitchFamily="34" charset="-122"/>
+                <a:cs typeface="Aeonik" pitchFamily="34" charset="-120"/>
               </a:rPr>
               <a:t>Key Message: A single chip may cross international borders over 70 times, making it the most geographically dispersed value chain in history.</a:t>
             </a:r>
@@ -8712,9 +8712,9 @@
                 <a:solidFill>
                   <a:srgbClr val="768C7C"/>
                 </a:solidFill>
-                <a:latin typeface="VVDS Fifties SCond Reg" pitchFamily="34" charset="0"/>
-                <a:ea typeface="VVDS Fifties SCond Reg" pitchFamily="34" charset="-122"/>
-                <a:cs typeface="VVDS Fifties SCond Reg" pitchFamily="34" charset="-120"/>
+                <a:latin typeface="Aeonik" pitchFamily="34" charset="0"/>
+                <a:ea typeface="Aeonik" pitchFamily="34" charset="-122"/>
+                <a:cs typeface="Aeonik" pitchFamily="34" charset="-120"/>
               </a:rPr>
               <a:t>THE SILICON JOURNEY</a:t>
             </a:r>
@@ -8815,9 +8815,9 @@
                 <a:solidFill>
                   <a:srgbClr val="1A1714"/>
                 </a:solidFill>
-                <a:latin typeface="VVDS Fifties SCond Reg" pitchFamily="34" charset="0"/>
-                <a:ea typeface="VVDS Fifties SCond Reg" pitchFamily="34" charset="-122"/>
-                <a:cs typeface="VVDS Fifties SCond Reg" pitchFamily="34" charset="-120"/>
+                <a:latin typeface="Aeonik" pitchFamily="34" charset="0"/>
+                <a:ea typeface="Aeonik" pitchFamily="34" charset="-122"/>
+                <a:cs typeface="Aeonik" pitchFamily="34" charset="-120"/>
               </a:rPr>
               <a:t>US Design</a:t>
             </a:r>
@@ -8854,9 +8854,9 @@
                 <a:solidFill>
                   <a:srgbClr val="6B6560"/>
                 </a:solidFill>
-                <a:latin typeface="VVDS Fifties Exp Reg" pitchFamily="34" charset="0"/>
-                <a:ea typeface="VVDS Fifties Exp Reg" pitchFamily="34" charset="-122"/>
-                <a:cs typeface="VVDS Fifties Exp Reg" pitchFamily="34" charset="-120"/>
+                <a:latin typeface="Aeonik" pitchFamily="34" charset="0"/>
+                <a:ea typeface="Aeonik" pitchFamily="34" charset="-122"/>
+                <a:cs typeface="Aeonik" pitchFamily="34" charset="-120"/>
               </a:rPr>
               <a:t>Design &amp; EDA Tools</a:t>
             </a:r>
@@ -8957,9 +8957,9 @@
                 <a:solidFill>
                   <a:srgbClr val="1A1714"/>
                 </a:solidFill>
-                <a:latin typeface="VVDS Fifties SCond Reg" pitchFamily="34" charset="0"/>
-                <a:ea typeface="VVDS Fifties SCond Reg" pitchFamily="34" charset="-122"/>
-                <a:cs typeface="VVDS Fifties SCond Reg" pitchFamily="34" charset="-120"/>
+                <a:latin typeface="Aeonik" pitchFamily="34" charset="0"/>
+                <a:ea typeface="Aeonik" pitchFamily="34" charset="-122"/>
+                <a:cs typeface="Aeonik" pitchFamily="34" charset="-120"/>
               </a:rPr>
               <a:t>Dutch SME</a:t>
             </a:r>
@@ -8996,9 +8996,9 @@
                 <a:solidFill>
                   <a:srgbClr val="6B6560"/>
                 </a:solidFill>
-                <a:latin typeface="VVDS Fifties Exp Reg" pitchFamily="34" charset="0"/>
-                <a:ea typeface="VVDS Fifties Exp Reg" pitchFamily="34" charset="-122"/>
-                <a:cs typeface="VVDS Fifties Exp Reg" pitchFamily="34" charset="-120"/>
+                <a:latin typeface="Aeonik" pitchFamily="34" charset="0"/>
+                <a:ea typeface="Aeonik" pitchFamily="34" charset="-122"/>
+                <a:cs typeface="Aeonik" pitchFamily="34" charset="-120"/>
               </a:rPr>
               <a:t>ASML EUV Optics</a:t>
             </a:r>
@@ -9099,9 +9099,9 @@
                 <a:solidFill>
                   <a:srgbClr val="1A1714"/>
                 </a:solidFill>
-                <a:latin typeface="VVDS Fifties SCond Reg" pitchFamily="34" charset="0"/>
-                <a:ea typeface="VVDS Fifties SCond Reg" pitchFamily="34" charset="-122"/>
-                <a:cs typeface="VVDS Fifties SCond Reg" pitchFamily="34" charset="-120"/>
+                <a:latin typeface="Aeonik" pitchFamily="34" charset="0"/>
+                <a:ea typeface="Aeonik" pitchFamily="34" charset="-122"/>
+                <a:cs typeface="Aeonik" pitchFamily="34" charset="-120"/>
               </a:rPr>
               <a:t>Taiwan Fab</a:t>
             </a:r>
@@ -9138,9 +9138,9 @@
                 <a:solidFill>
                   <a:srgbClr val="6B6560"/>
                 </a:solidFill>
-                <a:latin typeface="VVDS Fifties Exp Reg" pitchFamily="34" charset="0"/>
-                <a:ea typeface="VVDS Fifties Exp Reg" pitchFamily="34" charset="-122"/>
-                <a:cs typeface="VVDS Fifties Exp Reg" pitchFamily="34" charset="-120"/>
+                <a:latin typeface="Aeonik" pitchFamily="34" charset="0"/>
+                <a:ea typeface="Aeonik" pitchFamily="34" charset="-122"/>
+                <a:cs typeface="Aeonik" pitchFamily="34" charset="-120"/>
               </a:rPr>
               <a:t>TSMC Printing</a:t>
             </a:r>
@@ -9241,9 +9241,9 @@
                 <a:solidFill>
                   <a:srgbClr val="1A1714"/>
                 </a:solidFill>
-                <a:latin typeface="VVDS Fifties SCond Reg" pitchFamily="34" charset="0"/>
-                <a:ea typeface="VVDS Fifties SCond Reg" pitchFamily="34" charset="-122"/>
-                <a:cs typeface="VVDS Fifties SCond Reg" pitchFamily="34" charset="-120"/>
+                <a:latin typeface="Aeonik" pitchFamily="34" charset="0"/>
+                <a:ea typeface="Aeonik" pitchFamily="34" charset="-122"/>
+                <a:cs typeface="Aeonik" pitchFamily="34" charset="-120"/>
               </a:rPr>
               <a:t>Japan Material</a:t>
             </a:r>
@@ -9280,9 +9280,9 @@
                 <a:solidFill>
                   <a:srgbClr val="6B6560"/>
                 </a:solidFill>
-                <a:latin typeface="VVDS Fifties Exp Reg" pitchFamily="34" charset="0"/>
-                <a:ea typeface="VVDS Fifties Exp Reg" pitchFamily="34" charset="-122"/>
-                <a:cs typeface="VVDS Fifties Exp Reg" pitchFamily="34" charset="-120"/>
+                <a:latin typeface="Aeonik" pitchFamily="34" charset="0"/>
+                <a:ea typeface="Aeonik" pitchFamily="34" charset="-122"/>
+                <a:cs typeface="Aeonik" pitchFamily="34" charset="-120"/>
               </a:rPr>
               <a:t>Wafers &amp; Photoresist</a:t>
             </a:r>
@@ -9383,9 +9383,9 @@
                 <a:solidFill>
                   <a:srgbClr val="1A1714"/>
                 </a:solidFill>
-                <a:latin typeface="VVDS Fifties SCond Reg" pitchFamily="34" charset="0"/>
-                <a:ea typeface="VVDS Fifties SCond Reg" pitchFamily="34" charset="-122"/>
-                <a:cs typeface="VVDS Fifties SCond Reg" pitchFamily="34" charset="-120"/>
+                <a:latin typeface="Aeonik" pitchFamily="34" charset="0"/>
+                <a:ea typeface="Aeonik" pitchFamily="34" charset="-122"/>
+                <a:cs typeface="Aeonik" pitchFamily="34" charset="-120"/>
               </a:rPr>
               <a:t>SE Asia Pack</a:t>
             </a:r>
@@ -9422,9 +9422,9 @@
                 <a:solidFill>
                   <a:srgbClr val="6B6560"/>
                 </a:solidFill>
-                <a:latin typeface="VVDS Fifties Exp Reg" pitchFamily="34" charset="0"/>
-                <a:ea typeface="VVDS Fifties Exp Reg" pitchFamily="34" charset="-122"/>
-                <a:cs typeface="VVDS Fifties Exp Reg" pitchFamily="34" charset="-120"/>
+                <a:latin typeface="Aeonik" pitchFamily="34" charset="0"/>
+                <a:ea typeface="Aeonik" pitchFamily="34" charset="-122"/>
+                <a:cs typeface="Aeonik" pitchFamily="34" charset="-120"/>
               </a:rPr>
               <a:t>OSAT Assembly</a:t>
             </a:r>
@@ -9493,9 +9493,9 @@
                 <a:solidFill>
                   <a:srgbClr val="B84A2F"/>
                 </a:solidFill>
-                <a:latin typeface="VVDS Fifties Exp Reg" pitchFamily="34" charset="0"/>
-                <a:ea typeface="VVDS Fifties Exp Reg" pitchFamily="34" charset="-122"/>
-                <a:cs typeface="VVDS Fifties Exp Reg" pitchFamily="34" charset="-120"/>
+                <a:latin typeface="Aeonik" pitchFamily="34" charset="0"/>
+                <a:ea typeface="Aeonik" pitchFamily="34" charset="-122"/>
+                <a:cs typeface="Aeonik" pitchFamily="34" charset="-120"/>
               </a:rPr>
               <a:t>PART 2: THE GLOBAL SUPPLY CHAIN OF SEMICONDUCTORS</a:t>
             </a:r>
@@ -9571,9 +9571,9 @@
                 <a:solidFill>
                   <a:srgbClr val="6B6560"/>
                 </a:solidFill>
-                <a:latin typeface="VVDS Fifties Exp Reg" pitchFamily="34" charset="0"/>
-                <a:ea typeface="VVDS Fifties Exp Reg" pitchFamily="34" charset="-122"/>
-                <a:cs typeface="VVDS Fifties Exp Reg" pitchFamily="34" charset="-120"/>
+                <a:latin typeface="Aeonik" pitchFamily="34" charset="0"/>
+                <a:ea typeface="Aeonik" pitchFamily="34" charset="-122"/>
+                <a:cs typeface="Aeonik" pitchFamily="34" charset="-120"/>
               </a:rPr>
               <a:t>The 2026 Semiconductor Ecosystem | Slide 07</a:t>
             </a:r>
@@ -9635,9 +9635,9 @@
                 <a:solidFill>
                   <a:srgbClr val="9E7D84"/>
                 </a:solidFill>
-                <a:latin typeface="VVDS Fifties SCond Reg" pitchFamily="34" charset="0"/>
-                <a:ea typeface="VVDS Fifties SCond Reg" pitchFamily="34" charset="-122"/>
-                <a:cs typeface="VVDS Fifties SCond Reg" pitchFamily="34" charset="-120"/>
+                <a:latin typeface="Aeonik" pitchFamily="34" charset="0"/>
+                <a:ea typeface="Aeonik" pitchFamily="34" charset="-122"/>
+                <a:cs typeface="Aeonik" pitchFamily="34" charset="-120"/>
               </a:rPr>
               <a:t>Key Message: Value is highly concentrated in specialized clusters: U.S. (Design), Europe (Equipment), and East Asia (Manufacturing).</a:t>
             </a:r>
@@ -9675,9 +9675,9 @@
                 <a:solidFill>
                   <a:srgbClr val="6B6560"/>
                 </a:solidFill>
-                <a:latin typeface="VVDS Fifties SCond Reg" pitchFamily="34" charset="0"/>
-                <a:ea typeface="VVDS Fifties SCond Reg" pitchFamily="34" charset="-122"/>
-                <a:cs typeface="VVDS Fifties SCond Reg" pitchFamily="34" charset="-120"/>
+                <a:latin typeface="Aeonik" pitchFamily="34" charset="0"/>
+                <a:ea typeface="Aeonik" pitchFamily="34" charset="-122"/>
+                <a:cs typeface="Aeonik" pitchFamily="34" charset="-120"/>
               </a:rPr>
               <a:t>- Design &amp; EDA (United States): Dominance in core processor blueprints and layout compiler systems (NVIDIA, Apple, Qualcomm).</a:t>
             </a:r>
@@ -9700,9 +9700,9 @@
                 <a:solidFill>
                   <a:srgbClr val="6B6560"/>
                 </a:solidFill>
-                <a:latin typeface="VVDS Fifties SCond Reg" pitchFamily="34" charset="0"/>
-                <a:ea typeface="VVDS Fifties SCond Reg" pitchFamily="34" charset="-122"/>
-                <a:cs typeface="VVDS Fifties SCond Reg" pitchFamily="34" charset="-120"/>
+                <a:latin typeface="Aeonik" pitchFamily="34" charset="0"/>
+                <a:ea typeface="Aeonik" pitchFamily="34" charset="-122"/>
+                <a:cs typeface="Aeonik" pitchFamily="34" charset="-120"/>
               </a:rPr>
               <a:t>- SME Equipment (Europe): Monopoly on Extreme Ultraviolet tools (ASML) required to etch sub-7nm circuit nodes.</a:t>
             </a:r>
@@ -9725,9 +9725,9 @@
                 <a:solidFill>
                   <a:srgbClr val="6B6560"/>
                 </a:solidFill>
-                <a:latin typeface="VVDS Fifties SCond Reg" pitchFamily="34" charset="0"/>
-                <a:ea typeface="VVDS Fifties SCond Reg" pitchFamily="34" charset="-122"/>
-                <a:cs typeface="VVDS Fifties SCond Reg" pitchFamily="34" charset="-120"/>
+                <a:latin typeface="Aeonik" pitchFamily="34" charset="0"/>
+                <a:ea typeface="Aeonik" pitchFamily="34" charset="-122"/>
+                <a:cs typeface="Aeonik" pitchFamily="34" charset="-120"/>
               </a:rPr>
               <a:t>- Wafer Fabrication (East Asia): TSMC (Taiwan) and Samsung (Korea) form the production base for global advanced nodes.</a:t>
             </a:r>
@@ -9789,9 +9789,9 @@
                 <a:solidFill>
                   <a:srgbClr val="6B6560"/>
                 </a:solidFill>
-                <a:latin typeface="VVDS Fifties SCond Reg" pitchFamily="34" charset="0"/>
-                <a:ea typeface="VVDS Fifties SCond Reg" pitchFamily="34" charset="-122"/>
-                <a:cs typeface="VVDS Fifties SCond Reg" pitchFamily="34" charset="-120"/>
+                <a:latin typeface="Aeonik" pitchFamily="34" charset="0"/>
+                <a:ea typeface="Aeonik" pitchFamily="34" charset="-122"/>
+                <a:cs typeface="Aeonik" pitchFamily="34" charset="-120"/>
               </a:rPr>
               <a:t>USA: Design IP</a:t>
             </a:r>
@@ -9812,9 +9812,9 @@
                 <a:solidFill>
                   <a:srgbClr val="6B6560"/>
                 </a:solidFill>
-                <a:latin typeface="VVDS Fifties SCond Reg" pitchFamily="34" charset="0"/>
-                <a:ea typeface="VVDS Fifties SCond Reg" pitchFamily="34" charset="-122"/>
-                <a:cs typeface="VVDS Fifties SCond Reg" pitchFamily="34" charset="-120"/>
+                <a:latin typeface="Aeonik" pitchFamily="34" charset="0"/>
+                <a:ea typeface="Aeonik" pitchFamily="34" charset="-122"/>
+                <a:cs typeface="Aeonik" pitchFamily="34" charset="-120"/>
               </a:rPr>
               <a:t>80%+ market share in advanced EDA software tools.</a:t>
             </a:r>
@@ -9876,9 +9876,9 @@
                 <a:solidFill>
                   <a:srgbClr val="6B6560"/>
                 </a:solidFill>
-                <a:latin typeface="VVDS Fifties SCond Reg" pitchFamily="34" charset="0"/>
-                <a:ea typeface="VVDS Fifties SCond Reg" pitchFamily="34" charset="-122"/>
-                <a:cs typeface="VVDS Fifties SCond Reg" pitchFamily="34" charset="-120"/>
+                <a:latin typeface="Aeonik" pitchFamily="34" charset="0"/>
+                <a:ea typeface="Aeonik" pitchFamily="34" charset="-122"/>
+                <a:cs typeface="Aeonik" pitchFamily="34" charset="-120"/>
               </a:rPr>
               <a:t>ASML (EU): Lithography</a:t>
             </a:r>
@@ -9899,9 +9899,9 @@
                 <a:solidFill>
                   <a:srgbClr val="6B6560"/>
                 </a:solidFill>
-                <a:latin typeface="VVDS Fifties SCond Reg" pitchFamily="34" charset="0"/>
-                <a:ea typeface="VVDS Fifties SCond Reg" pitchFamily="34" charset="-122"/>
-                <a:cs typeface="VVDS Fifties SCond Reg" pitchFamily="34" charset="-120"/>
+                <a:latin typeface="Aeonik" pitchFamily="34" charset="0"/>
+                <a:ea typeface="Aeonik" pitchFamily="34" charset="-122"/>
+                <a:cs typeface="Aeonik" pitchFamily="34" charset="-120"/>
               </a:rPr>
               <a:t>100% monopsony on EUV printing technology.</a:t>
             </a:r>
@@ -9970,9 +9970,9 @@
                 <a:solidFill>
                   <a:srgbClr val="B84A2F"/>
                 </a:solidFill>
-                <a:latin typeface="VVDS Fifties Exp Reg" pitchFamily="34" charset="0"/>
-                <a:ea typeface="VVDS Fifties Exp Reg" pitchFamily="34" charset="-122"/>
-                <a:cs typeface="VVDS Fifties Exp Reg" pitchFamily="34" charset="-120"/>
+                <a:latin typeface="Aeonik" pitchFamily="34" charset="0"/>
+                <a:ea typeface="Aeonik" pitchFamily="34" charset="-122"/>
+                <a:cs typeface="Aeonik" pitchFamily="34" charset="-120"/>
               </a:rPr>
               <a:t>PART 2: THE GLOBAL SUPPLY CHAIN OF SEMICONDUCTORS</a:t>
             </a:r>
@@ -10048,9 +10048,9 @@
                 <a:solidFill>
                   <a:srgbClr val="6B6560"/>
                 </a:solidFill>
-                <a:latin typeface="VVDS Fifties Exp Reg" pitchFamily="34" charset="0"/>
-                <a:ea typeface="VVDS Fifties Exp Reg" pitchFamily="34" charset="-122"/>
-                <a:cs typeface="VVDS Fifties Exp Reg" pitchFamily="34" charset="-120"/>
+                <a:latin typeface="Aeonik" pitchFamily="34" charset="0"/>
+                <a:ea typeface="Aeonik" pitchFamily="34" charset="-122"/>
+                <a:cs typeface="Aeonik" pitchFamily="34" charset="-120"/>
               </a:rPr>
               <a:t>The 2026 Semiconductor Ecosystem | Slide 08</a:t>
             </a:r>
@@ -10112,9 +10112,9 @@
                 <a:solidFill>
                   <a:srgbClr val="768C7C"/>
                 </a:solidFill>
-                <a:latin typeface="VVDS Fifties SCond Reg" pitchFamily="34" charset="0"/>
-                <a:ea typeface="VVDS Fifties SCond Reg" pitchFamily="34" charset="-122"/>
-                <a:cs typeface="VVDS Fifties SCond Reg" pitchFamily="34" charset="-120"/>
+                <a:latin typeface="Aeonik" pitchFamily="34" charset="0"/>
+                <a:ea typeface="Aeonik" pitchFamily="34" charset="-122"/>
+                <a:cs typeface="Aeonik" pitchFamily="34" charset="-120"/>
               </a:rPr>
               <a:t>Key Message: Advanced packaging (CoWoS, 3D Stacking) is the new primary growth limiter for the AI industry.</a:t>
             </a:r>
@@ -10215,9 +10215,9 @@
                 <a:solidFill>
                   <a:srgbClr val="6B6560"/>
                 </a:solidFill>
-                <a:latin typeface="VVDS Fifties SCond Reg" pitchFamily="34" charset="0"/>
-                <a:ea typeface="VVDS Fifties SCond Reg" pitchFamily="34" charset="-122"/>
-                <a:cs typeface="VVDS Fifties SCond Reg" pitchFamily="34" charset="-120"/>
+                <a:latin typeface="Aeonik" pitchFamily="34" charset="0"/>
+                <a:ea typeface="Aeonik" pitchFamily="34" charset="-122"/>
+                <a:cs typeface="Aeonik" pitchFamily="34" charset="-120"/>
               </a:rPr>
               <a:t>The race for the 2nm and 1.4nm nodes continues to demand immense capital investments for wafer fabrication lines.</a:t>
             </a:r>
@@ -10318,9 +10318,9 @@
                 <a:solidFill>
                   <a:srgbClr val="6B6560"/>
                 </a:solidFill>
-                <a:latin typeface="VVDS Fifties SCond Reg" pitchFamily="34" charset="0"/>
-                <a:ea typeface="VVDS Fifties SCond Reg" pitchFamily="34" charset="-122"/>
-                <a:cs typeface="VVDS Fifties SCond Reg" pitchFamily="34" charset="-120"/>
+                <a:latin typeface="Aeonik" pitchFamily="34" charset="0"/>
+                <a:ea typeface="Aeonik" pitchFamily="34" charset="-122"/>
+                <a:cs typeface="Aeonik" pitchFamily="34" charset="-120"/>
               </a:rPr>
               <a:t>Integrating multiple logic dies and High Bandwidth Memory (HBM) via CoWoS interposers is more constrained than wafer printing.</a:t>
             </a:r>
@@ -10382,9 +10382,9 @@
                 <a:solidFill>
                   <a:srgbClr val="6B6560"/>
                 </a:solidFill>
-                <a:latin typeface="VVDS Fifties SCond Reg" pitchFamily="34" charset="0"/>
-                <a:ea typeface="VVDS Fifties SCond Reg" pitchFamily="34" charset="-122"/>
-                <a:cs typeface="VVDS Fifties SCond Reg" pitchFamily="34" charset="-120"/>
+                <a:latin typeface="Aeonik" pitchFamily="34" charset="0"/>
+                <a:ea typeface="Aeonik" pitchFamily="34" charset="-122"/>
+                <a:cs typeface="Aeonik" pitchFamily="34" charset="-120"/>
               </a:rPr>
               <a:t>Logistics bottleneck: Reaching target AI yields depends heavily on advanced back-end capacity, not just front-end print nodes.</a:t>
             </a:r>
@@ -10453,9 +10453,9 @@
                 <a:solidFill>
                   <a:srgbClr val="B84A2F"/>
                 </a:solidFill>
-                <a:latin typeface="VVDS Fifties Exp Reg" pitchFamily="34" charset="0"/>
-                <a:ea typeface="VVDS Fifties Exp Reg" pitchFamily="34" charset="-122"/>
-                <a:cs typeface="VVDS Fifties Exp Reg" pitchFamily="34" charset="-120"/>
+                <a:latin typeface="Aeonik" pitchFamily="34" charset="0"/>
+                <a:ea typeface="Aeonik" pitchFamily="34" charset="-122"/>
+                <a:cs typeface="Aeonik" pitchFamily="34" charset="-120"/>
               </a:rPr>
               <a:t>PART 2: THE GLOBAL SUPPLY CHAIN OF SEMICONDUCTORS</a:t>
             </a:r>
@@ -10531,9 +10531,9 @@
                 <a:solidFill>
                   <a:srgbClr val="6B6560"/>
                 </a:solidFill>
-                <a:latin typeface="VVDS Fifties Exp Reg" pitchFamily="34" charset="0"/>
-                <a:ea typeface="VVDS Fifties Exp Reg" pitchFamily="34" charset="-122"/>
-                <a:cs typeface="VVDS Fifties Exp Reg" pitchFamily="34" charset="-120"/>
+                <a:latin typeface="Aeonik" pitchFamily="34" charset="0"/>
+                <a:ea typeface="Aeonik" pitchFamily="34" charset="-122"/>
+                <a:cs typeface="Aeonik" pitchFamily="34" charset="-120"/>
               </a:rPr>
               <a:t>The 2026 Semiconductor Ecosystem | Slide 09</a:t>
             </a:r>
@@ -10595,9 +10595,9 @@
                 <a:solidFill>
                   <a:srgbClr val="B84A2F"/>
                 </a:solidFill>
-                <a:latin typeface="VVDS Fifties SCond Reg" pitchFamily="34" charset="0"/>
-                <a:ea typeface="VVDS Fifties SCond Reg" pitchFamily="34" charset="-122"/>
-                <a:cs typeface="VVDS Fifties SCond Reg" pitchFamily="34" charset="-120"/>
+                <a:latin typeface="Aeonik" pitchFamily="34" charset="0"/>
+                <a:ea typeface="Aeonik" pitchFamily="34" charset="-122"/>
+                <a:cs typeface="Aeonik" pitchFamily="34" charset="-120"/>
               </a:rPr>
               <a:t>Key Message: Geopolitics has created a "Multi-Polar" silicon world, where export controls and subsidies drive regionalization.</a:t>
             </a:r>
@@ -10635,9 +10635,9 @@
                 <a:solidFill>
                   <a:srgbClr val="6B6560"/>
                 </a:solidFill>
-                <a:latin typeface="VVDS Fifties SCond Reg" pitchFamily="34" charset="0"/>
-                <a:ea typeface="VVDS Fifties SCond Reg" pitchFamily="34" charset="-122"/>
-                <a:cs typeface="VVDS Fifties SCond Reg" pitchFamily="34" charset="-120"/>
+                <a:latin typeface="Aeonik" pitchFamily="34" charset="0"/>
+                <a:ea typeface="Aeonik" pitchFamily="34" charset="-122"/>
+                <a:cs typeface="Aeonik" pitchFamily="34" charset="-120"/>
               </a:rPr>
               <a:t>- The US CHIPS Act ($52B): Funding the domestic establishment of advanced logic fabs to balance East Asian concentration.</a:t>
             </a:r>
@@ -10660,9 +10660,9 @@
                 <a:solidFill>
                   <a:srgbClr val="6B6560"/>
                 </a:solidFill>
-                <a:latin typeface="VVDS Fifties SCond Reg" pitchFamily="34" charset="0"/>
-                <a:ea typeface="VVDS Fifties SCond Reg" pitchFamily="34" charset="-122"/>
-                <a:cs typeface="VVDS Fifties SCond Reg" pitchFamily="34" charset="-120"/>
+                <a:latin typeface="Aeonik" pitchFamily="34" charset="0"/>
+                <a:ea typeface="Aeonik" pitchFamily="34" charset="-122"/>
+                <a:cs typeface="Aeonik" pitchFamily="34" charset="-120"/>
               </a:rPr>
               <a:t>- Europe &amp; China Reshoring: Multi-billion dollar state-supported programs targeting semiconductor in-sourcing.</a:t>
             </a:r>
@@ -10685,9 +10685,9 @@
                 <a:solidFill>
                   <a:srgbClr val="6B6560"/>
                 </a:solidFill>
-                <a:latin typeface="VVDS Fifties SCond Reg" pitchFamily="34" charset="0"/>
-                <a:ea typeface="VVDS Fifties SCond Reg" pitchFamily="34" charset="-122"/>
-                <a:cs typeface="VVDS Fifties SCond Reg" pitchFamily="34" charset="-120"/>
+                <a:latin typeface="Aeonik" pitchFamily="34" charset="0"/>
+                <a:ea typeface="Aeonik" pitchFamily="34" charset="-122"/>
+                <a:cs typeface="Aeonik" pitchFamily="34" charset="-120"/>
               </a:rPr>
               <a:t>- Material Chokepoints: Strict export controls placed on critical trace materials like Gallium and Germanium.</a:t>
             </a:r>
@@ -10749,9 +10749,9 @@
                 <a:solidFill>
                   <a:srgbClr val="B84A2F"/>
                 </a:solidFill>
-                <a:latin typeface="VVDS Fifties Exp Reg" pitchFamily="34" charset="0"/>
-                <a:ea typeface="VVDS Fifties Exp Reg" pitchFamily="34" charset="-122"/>
-                <a:cs typeface="VVDS Fifties Exp Reg" pitchFamily="34" charset="-120"/>
+                <a:latin typeface="Aeonik" pitchFamily="34" charset="0"/>
+                <a:ea typeface="Aeonik" pitchFamily="34" charset="-122"/>
+                <a:cs typeface="Aeonik" pitchFamily="34" charset="-120"/>
               </a:rPr>
               <a:t>CRITICAL CHOKEPOINT</a:t>
             </a:r>
@@ -10844,9 +10844,9 @@
                 <a:solidFill>
                   <a:srgbClr val="6B6560"/>
                 </a:solidFill>
-                <a:latin typeface="VVDS Fifties SCond Reg" pitchFamily="34" charset="0"/>
-                <a:ea typeface="VVDS Fifties SCond Reg" pitchFamily="34" charset="-122"/>
-                <a:cs typeface="VVDS Fifties SCond Reg" pitchFamily="34" charset="-120"/>
+                <a:latin typeface="Aeonik" pitchFamily="34" charset="0"/>
+                <a:ea typeface="Aeonik" pitchFamily="34" charset="-122"/>
+                <a:cs typeface="Aeonik" pitchFamily="34" charset="-120"/>
               </a:rPr>
               <a:t>Strict raw material export control levers</a:t>
             </a:r>

</xml_diff>

<commit_message>
Remove Key Message prefix and set Key Message font to Bookman ITC Std
</commit_message>
<xml_diff>
--- a/output/semiconductor-ecosystem-2026.pptx
+++ b/output/semiconductor-ecosystem-2026.pptx
@@ -2747,11 +2747,11 @@
                 <a:solidFill>
                   <a:srgbClr val="B84A2F"/>
                 </a:solidFill>
-                <a:latin typeface="Aeonik" pitchFamily="34" charset="0"/>
-                <a:ea typeface="Aeonik" pitchFamily="34" charset="-122"/>
-                <a:cs typeface="Aeonik" pitchFamily="34" charset="-120"/>
-              </a:rPr>
-              <a:t>Key Message: The response? Circular and Autonomous Supply Chains. We are using AI to 'self-heal' the supply chain.</a:t>
+                <a:latin typeface="Bookman ITC Std" pitchFamily="34" charset="0"/>
+                <a:ea typeface="Bookman ITC Std" pitchFamily="34" charset="-122"/>
+                <a:cs typeface="Bookman ITC Std" pitchFamily="34" charset="-120"/>
+              </a:rPr>
+              <a:t>The response? Circular and Autonomous Supply Chains. We are using AI to 'self-heal' the supply chain.</a:t>
             </a:r>
             <a:endParaRPr lang="en-US" sz="1800" dirty="0"/>
           </a:p>
@@ -3230,11 +3230,11 @@
                 <a:solidFill>
                   <a:srgbClr val="9E7D84"/>
                 </a:solidFill>
-                <a:latin typeface="Aeonik" pitchFamily="34" charset="0"/>
-                <a:ea typeface="Aeonik" pitchFamily="34" charset="-122"/>
-                <a:cs typeface="Aeonik" pitchFamily="34" charset="-120"/>
-              </a:rPr>
-              <a:t>Key Message: Semiconductors are the "nerve system" of the global economy; no modern industry can function without them.</a:t>
+                <a:latin typeface="Bookman ITC Std" pitchFamily="34" charset="0"/>
+                <a:ea typeface="Bookman ITC Std" pitchFamily="34" charset="-122"/>
+                <a:cs typeface="Bookman ITC Std" pitchFamily="34" charset="-120"/>
+              </a:rPr>
+              <a:t>Semiconductors are the "nerve system" of the global economy; no modern industry can function without them.</a:t>
             </a:r>
             <a:endParaRPr lang="en-US" sz="1800" dirty="0"/>
           </a:p>
@@ -3692,11 +3692,11 @@
                 <a:solidFill>
                   <a:srgbClr val="B84A2F"/>
                 </a:solidFill>
-                <a:latin typeface="Aeonik" pitchFamily="34" charset="0"/>
-                <a:ea typeface="Aeonik" pitchFamily="34" charset="-122"/>
-                <a:cs typeface="Aeonik" pitchFamily="34" charset="-120"/>
-              </a:rPr>
-              <a:t>Key Message: Demand is shifting from traditional computing toward AI infrastructure, Automotive, and Industrial Automation.</a:t>
+                <a:latin typeface="Bookman ITC Std" pitchFamily="34" charset="0"/>
+                <a:ea typeface="Bookman ITC Std" pitchFamily="34" charset="-122"/>
+                <a:cs typeface="Bookman ITC Std" pitchFamily="34" charset="-120"/>
+              </a:rPr>
+              <a:t>Demand is shifting from traditional computing toward AI infrastructure, Automotive, and Industrial Automation.</a:t>
             </a:r>
             <a:endParaRPr lang="en-US" sz="1800" dirty="0"/>
           </a:p>
@@ -4214,11 +4214,11 @@
                 <a:solidFill>
                   <a:srgbClr val="768C7C"/>
                 </a:solidFill>
-                <a:latin typeface="Aeonik" pitchFamily="34" charset="0"/>
-                <a:ea typeface="Aeonik" pitchFamily="34" charset="-122"/>
-                <a:cs typeface="Aeonik" pitchFamily="34" charset="-120"/>
-              </a:rPr>
-              <a:t>Key Message: Data centers have evolved into "Intelligence Engines," consuming the highest-value silicon ever produced.</a:t>
+                <a:latin typeface="Bookman ITC Std" pitchFamily="34" charset="0"/>
+                <a:ea typeface="Bookman ITC Std" pitchFamily="34" charset="-122"/>
+                <a:cs typeface="Bookman ITC Std" pitchFamily="34" charset="-120"/>
+              </a:rPr>
+              <a:t>Data centers have evolved into "Intelligence Engines," consuming the highest-value silicon ever produced.</a:t>
             </a:r>
             <a:endParaRPr lang="en-US" sz="1800" dirty="0"/>
           </a:p>
@@ -4659,11 +4659,11 @@
                 <a:solidFill>
                   <a:srgbClr val="B84A2F"/>
                 </a:solidFill>
-                <a:latin typeface="Aeonik" pitchFamily="34" charset="0"/>
-                <a:ea typeface="Aeonik" pitchFamily="34" charset="-122"/>
-                <a:cs typeface="Aeonik" pitchFamily="34" charset="-120"/>
-              </a:rPr>
-              <a:t>Key Message: The transition to EVs and ADAS is doubling semiconductor content per vehicle, reaching over $1,000 per unit.</a:t>
+                <a:latin typeface="Bookman ITC Std" pitchFamily="34" charset="0"/>
+                <a:ea typeface="Bookman ITC Std" pitchFamily="34" charset="-122"/>
+                <a:cs typeface="Bookman ITC Std" pitchFamily="34" charset="-120"/>
+              </a:rPr>
+              <a:t>The transition to EVs and ADAS is doubling semiconductor content per vehicle, reaching over $1,000 per unit.</a:t>
             </a:r>
             <a:endParaRPr lang="en-US" sz="1800" dirty="0"/>
           </a:p>
@@ -5104,11 +5104,11 @@
                 <a:solidFill>
                   <a:srgbClr val="9E7D84"/>
                 </a:solidFill>
-                <a:latin typeface="Aeonik" pitchFamily="34" charset="0"/>
-                <a:ea typeface="Aeonik" pitchFamily="34" charset="-122"/>
-                <a:cs typeface="Aeonik" pitchFamily="34" charset="-120"/>
-              </a:rPr>
-              <a:t>Key Message: Edge AI is transforming manufacturing and healthcare, prioritizing long-lifecycle, high-reliability silicon.</a:t>
+                <a:latin typeface="Bookman ITC Std" pitchFamily="34" charset="0"/>
+                <a:ea typeface="Bookman ITC Std" pitchFamily="34" charset="-122"/>
+                <a:cs typeface="Bookman ITC Std" pitchFamily="34" charset="-120"/>
+              </a:rPr>
+              <a:t>Edge AI is transforming manufacturing and healthcare, prioritizing long-lifecycle, high-reliability silicon.</a:t>
             </a:r>
             <a:endParaRPr lang="en-US" sz="1800" dirty="0"/>
           </a:p>
@@ -5523,11 +5523,11 @@
                 <a:solidFill>
                   <a:srgbClr val="768C7C"/>
                 </a:solidFill>
-                <a:latin typeface="Aeonik" pitchFamily="34" charset="0"/>
-                <a:ea typeface="Aeonik" pitchFamily="34" charset="-122"/>
-                <a:cs typeface="Aeonik" pitchFamily="34" charset="-120"/>
-              </a:rPr>
-              <a:t>Key Message: While traditional consumer tech matures, frontiers like Quantum, 6G, and Neuromorphic computing define the 2030 roadmap.</a:t>
+                <a:latin typeface="Bookman ITC Std" pitchFamily="34" charset="0"/>
+                <a:ea typeface="Bookman ITC Std" pitchFamily="34" charset="-122"/>
+                <a:cs typeface="Bookman ITC Std" pitchFamily="34" charset="-120"/>
+              </a:rPr>
+              <a:t>While traditional consumer tech matures, frontiers like Quantum, 6G, and Neuromorphic computing define the 2030 roadmap.</a:t>
             </a:r>
             <a:endParaRPr lang="en-US" sz="1800" dirty="0"/>
           </a:p>
@@ -5968,11 +5968,11 @@
                 <a:solidFill>
                   <a:srgbClr val="B84A2F"/>
                 </a:solidFill>
-                <a:latin typeface="Aeonik" pitchFamily="34" charset="0"/>
-                <a:ea typeface="Aeonik" pitchFamily="34" charset="-122"/>
-                <a:cs typeface="Aeonik" pitchFamily="34" charset="-120"/>
-              </a:rPr>
-              <a:t>Key Message: We have reached a point of "Total Silicon Dependency." The path to a $2 trillion industry is certain.</a:t>
+                <a:latin typeface="Bookman ITC Std" pitchFamily="34" charset="0"/>
+                <a:ea typeface="Bookman ITC Std" pitchFamily="34" charset="-122"/>
+                <a:cs typeface="Bookman ITC Std" pitchFamily="34" charset="-120"/>
+              </a:rPr>
+              <a:t>We have reached a point of "Total Silicon Dependency." The path to a $2 trillion industry is certain.</a:t>
             </a:r>
             <a:endParaRPr lang="en-US" sz="1800" dirty="0"/>
           </a:p>
@@ -6832,11 +6832,11 @@
                 <a:solidFill>
                   <a:srgbClr val="B84A2F"/>
                 </a:solidFill>
-                <a:latin typeface="Aeonik" pitchFamily="34" charset="0"/>
-                <a:ea typeface="Aeonik" pitchFamily="34" charset="-122"/>
-                <a:cs typeface="Aeonik" pitchFamily="34" charset="-120"/>
-              </a:rPr>
-              <a:t>Key Message: Navigating a $1.3 trillion market requires balancing unprecedented growth with systemic supply chain fragility.</a:t>
+                <a:latin typeface="Bookman ITC Std" pitchFamily="34" charset="0"/>
+                <a:ea typeface="Bookman ITC Std" pitchFamily="34" charset="-122"/>
+                <a:cs typeface="Bookman ITC Std" pitchFamily="34" charset="-120"/>
+              </a:rPr>
+              <a:t>Navigating a $1.3 trillion market requires balancing unprecedented growth with systemic supply chain fragility.</a:t>
             </a:r>
             <a:endParaRPr lang="en-US" sz="1800" dirty="0"/>
           </a:p>
@@ -7294,11 +7294,11 @@
                 <a:solidFill>
                   <a:srgbClr val="9E7D84"/>
                 </a:solidFill>
-                <a:latin typeface="Aeonik" pitchFamily="34" charset="0"/>
-                <a:ea typeface="Aeonik" pitchFamily="34" charset="-122"/>
-                <a:cs typeface="Aeonik" pitchFamily="34" charset="-120"/>
-              </a:rPr>
-              <a:t>Key Message: Pure JIT is obsolete; the new standard is a hybrid approach that prioritizes resilience for high-value nodes.</a:t>
+                <a:latin typeface="Bookman ITC Std" pitchFamily="34" charset="0"/>
+                <a:ea typeface="Bookman ITC Std" pitchFamily="34" charset="-122"/>
+                <a:cs typeface="Bookman ITC Std" pitchFamily="34" charset="-120"/>
+              </a:rPr>
+              <a:t>Pure JIT is obsolete; the new standard is a hybrid approach that prioritizes resilience for high-value nodes.</a:t>
             </a:r>
             <a:endParaRPr lang="en-US" sz="1800" dirty="0"/>
           </a:p>
@@ -7713,11 +7713,11 @@
                 <a:solidFill>
                   <a:srgbClr val="768C7C"/>
                 </a:solidFill>
-                <a:latin typeface="Aeonik" pitchFamily="34" charset="0"/>
-                <a:ea typeface="Aeonik" pitchFamily="34" charset="-122"/>
-                <a:cs typeface="Aeonik" pitchFamily="34" charset="-120"/>
-              </a:rPr>
-              <a:t>Key Message: Data opacity and reactive risk management are the primary enemies of a resilient procurement strategy.</a:t>
+                <a:latin typeface="Bookman ITC Std" pitchFamily="34" charset="0"/>
+                <a:ea typeface="Bookman ITC Std" pitchFamily="34" charset="-122"/>
+                <a:cs typeface="Bookman ITC Std" pitchFamily="34" charset="-120"/>
+              </a:rPr>
+              <a:t>Data opacity and reactive risk management are the primary enemies of a resilient procurement strategy.</a:t>
             </a:r>
             <a:endParaRPr lang="en-US" sz="1800" dirty="0"/>
           </a:p>
@@ -8190,11 +8190,11 @@
                 <a:solidFill>
                   <a:srgbClr val="B84A2F"/>
                 </a:solidFill>
-                <a:latin typeface="Aeonik" pitchFamily="34" charset="0"/>
-                <a:ea typeface="Aeonik" pitchFamily="34" charset="-122"/>
-                <a:cs typeface="Aeonik" pitchFamily="34" charset="-120"/>
-              </a:rPr>
-              <a:t>Key Message: AI-driven "Business Intelligence Cockpits" are essential for predicting shortages 6-12 months in advance.</a:t>
+                <a:latin typeface="Bookman ITC Std" pitchFamily="34" charset="0"/>
+                <a:ea typeface="Bookman ITC Std" pitchFamily="34" charset="-122"/>
+                <a:cs typeface="Bookman ITC Std" pitchFamily="34" charset="-120"/>
+              </a:rPr>
+              <a:t>AI-driven "Business Intelligence Cockpits" are essential for predicting shortages 6-12 months in advance.</a:t>
             </a:r>
             <a:endParaRPr lang="en-US" sz="1800" dirty="0"/>
           </a:p>
@@ -8673,11 +8673,11 @@
                 <a:solidFill>
                   <a:srgbClr val="B84A2F"/>
                 </a:solidFill>
-                <a:latin typeface="Aeonik" pitchFamily="34" charset="0"/>
-                <a:ea typeface="Aeonik" pitchFamily="34" charset="-122"/>
-                <a:cs typeface="Aeonik" pitchFamily="34" charset="-120"/>
-              </a:rPr>
-              <a:t>Key Message: A single chip may cross international borders over 70 times, making it the most geographically dispersed value chain in history.</a:t>
+                <a:latin typeface="Bookman ITC Std" pitchFamily="34" charset="0"/>
+                <a:ea typeface="Bookman ITC Std" pitchFamily="34" charset="-122"/>
+                <a:cs typeface="Bookman ITC Std" pitchFamily="34" charset="-120"/>
+              </a:rPr>
+              <a:t>A single chip may cross international borders over 70 times, making it the most geographically dispersed value chain in history.</a:t>
             </a:r>
             <a:endParaRPr lang="en-US" sz="1800" dirty="0"/>
           </a:p>
@@ -9635,11 +9635,11 @@
                 <a:solidFill>
                   <a:srgbClr val="9E7D84"/>
                 </a:solidFill>
-                <a:latin typeface="Aeonik" pitchFamily="34" charset="0"/>
-                <a:ea typeface="Aeonik" pitchFamily="34" charset="-122"/>
-                <a:cs typeface="Aeonik" pitchFamily="34" charset="-120"/>
-              </a:rPr>
-              <a:t>Key Message: Value is highly concentrated in specialized clusters: U.S. (Design), Europe (Equipment), and East Asia (Manufacturing).</a:t>
+                <a:latin typeface="Bookman ITC Std" pitchFamily="34" charset="0"/>
+                <a:ea typeface="Bookman ITC Std" pitchFamily="34" charset="-122"/>
+                <a:cs typeface="Bookman ITC Std" pitchFamily="34" charset="-120"/>
+              </a:rPr>
+              <a:t>Value is highly concentrated in specialized clusters: U.S. (Design), Europe (Equipment), and East Asia (Manufacturing).</a:t>
             </a:r>
             <a:endParaRPr lang="en-US" sz="1800" dirty="0"/>
           </a:p>
@@ -10112,11 +10112,11 @@
                 <a:solidFill>
                   <a:srgbClr val="768C7C"/>
                 </a:solidFill>
-                <a:latin typeface="Aeonik" pitchFamily="34" charset="0"/>
-                <a:ea typeface="Aeonik" pitchFamily="34" charset="-122"/>
-                <a:cs typeface="Aeonik" pitchFamily="34" charset="-120"/>
-              </a:rPr>
-              <a:t>Key Message: Advanced packaging (CoWoS, 3D Stacking) is the new primary growth limiter for the AI industry.</a:t>
+                <a:latin typeface="Bookman ITC Std" pitchFamily="34" charset="0"/>
+                <a:ea typeface="Bookman ITC Std" pitchFamily="34" charset="-122"/>
+                <a:cs typeface="Bookman ITC Std" pitchFamily="34" charset="-120"/>
+              </a:rPr>
+              <a:t>Advanced packaging (CoWoS, 3D Stacking) is the new primary growth limiter for the AI industry.</a:t>
             </a:r>
             <a:endParaRPr lang="en-US" sz="1800" dirty="0"/>
           </a:p>
@@ -10595,11 +10595,11 @@
                 <a:solidFill>
                   <a:srgbClr val="B84A2F"/>
                 </a:solidFill>
-                <a:latin typeface="Aeonik" pitchFamily="34" charset="0"/>
-                <a:ea typeface="Aeonik" pitchFamily="34" charset="-122"/>
-                <a:cs typeface="Aeonik" pitchFamily="34" charset="-120"/>
-              </a:rPr>
-              <a:t>Key Message: Geopolitics has created a "Multi-Polar" silicon world, where export controls and subsidies drive regionalization.</a:t>
+                <a:latin typeface="Bookman ITC Std" pitchFamily="34" charset="0"/>
+                <a:ea typeface="Bookman ITC Std" pitchFamily="34" charset="-122"/>
+                <a:cs typeface="Bookman ITC Std" pitchFamily="34" charset="-120"/>
+              </a:rPr>
+              <a:t>Geopolitics has created a "Multi-Polar" silicon world, where export controls and subsidies drive regionalization.</a:t>
             </a:r>
             <a:endParaRPr lang="en-US" sz="1800" dirty="0"/>
           </a:p>

</xml_diff>

<commit_message>
Integrate Critical Raw Materials infographic on Slide 19 and 12 Reference links on Slide 20
</commit_message>
<xml_diff>
--- a/output/semiconductor-ecosystem-2026.pptx
+++ b/output/semiconductor-ecosystem-2026.pptx
@@ -5922,8 +5922,8 @@
         </p:nvSpPr>
         <p:spPr>
           <a:xfrm>
-            <a:off x="548640" y="1280160"/>
-            <a:ext cx="10972800" cy="822960"/>
+            <a:off x="548640" y="1188720"/>
+            <a:ext cx="5486400" cy="822960"/>
           </a:xfrm>
           <a:prstGeom prst="rect">
             <a:avLst/>
@@ -5947,24 +5947,24 @@
         </p:nvSpPr>
         <p:spPr>
           <a:xfrm>
-            <a:off x="731520" y="1325880"/>
-            <a:ext cx="10607040" cy="731520"/>
-          </a:xfrm>
-          <a:prstGeom prst="rect">
-            <a:avLst/>
-          </a:prstGeom>
-          <a:noFill/>
-          <a:ln/>
-        </p:spPr>
-        <p:txBody>
-          <a:bodyPr wrap="square" rtlCol="0" anchor="ctr"/>
-          <a:lstStyle/>
-          <a:p>
-            <a:pPr indent="0" marL="0">
-              <a:buNone/>
-            </a:pPr>
-            <a:r>
-              <a:rPr lang="en-US" sz="1800" b="1" i="1" dirty="0">
+            <a:off x="731520" y="1234440"/>
+            <a:ext cx="5120640" cy="731520"/>
+          </a:xfrm>
+          <a:prstGeom prst="rect">
+            <a:avLst/>
+          </a:prstGeom>
+          <a:noFill/>
+          <a:ln/>
+        </p:spPr>
+        <p:txBody>
+          <a:bodyPr wrap="square" rtlCol="0" anchor="ctr"/>
+          <a:lstStyle/>
+          <a:p>
+            <a:pPr indent="0" marL="0">
+              <a:buNone/>
+            </a:pPr>
+            <a:r>
+              <a:rPr lang="en-US" sz="1400" b="1" i="1" dirty="0">
                 <a:solidFill>
                   <a:srgbClr val="B84A2F"/>
                 </a:solidFill>
@@ -5974,7 +5974,7 @@
               </a:rPr>
               <a:t>We have reached a point of "Total Silicon Dependency." The path to a $2 trillion industry is certain.</a:t>
             </a:r>
-            <a:endParaRPr lang="en-US" sz="1800" dirty="0"/>
+            <a:endParaRPr lang="en-US" sz="1400" dirty="0"/>
           </a:p>
         </p:txBody>
       </p:sp>
@@ -5986,24 +5986,24 @@
         </p:nvSpPr>
         <p:spPr>
           <a:xfrm>
-            <a:off x="548640" y="2194560"/>
-            <a:ext cx="10972800" cy="731520"/>
-          </a:xfrm>
-          <a:prstGeom prst="rect">
-            <a:avLst/>
-          </a:prstGeom>
-          <a:noFill/>
-          <a:ln/>
-        </p:spPr>
-        <p:txBody>
-          <a:bodyPr wrap="square" rtlCol="0" anchor="ctr"/>
-          <a:lstStyle/>
-          <a:p>
-            <a:pPr indent="0" marL="0">
-              <a:buNone/>
-            </a:pPr>
-            <a:r>
-              <a:rPr lang="en-US" sz="1800" dirty="0">
+            <a:off x="548640" y="2103120"/>
+            <a:ext cx="5486400" cy="914400"/>
+          </a:xfrm>
+          <a:prstGeom prst="rect">
+            <a:avLst/>
+          </a:prstGeom>
+          <a:noFill/>
+          <a:ln/>
+        </p:spPr>
+        <p:txBody>
+          <a:bodyPr wrap="square" rtlCol="0" anchor="ctr"/>
+          <a:lstStyle/>
+          <a:p>
+            <a:pPr indent="0" marL="0">
+              <a:buNone/>
+            </a:pPr>
+            <a:r>
+              <a:rPr lang="en-US" sz="1400" dirty="0">
                 <a:solidFill>
                   <a:srgbClr val="6B6560"/>
                 </a:solidFill>
@@ -6013,7 +6013,7 @@
               </a:rPr>
               <a:t>Mastery of the semiconductor ecosystem is mastery of the future. The "Chip Wars" aren't just about manufacturing; they are about who can best harness silicon to transform their industries.</a:t>
             </a:r>
-            <a:endParaRPr lang="en-US" sz="1800" dirty="0"/>
+            <a:endParaRPr lang="en-US" sz="1400" dirty="0"/>
           </a:p>
         </p:txBody>
       </p:sp>
@@ -6025,24 +6025,24 @@
         </p:nvSpPr>
         <p:spPr>
           <a:xfrm>
-            <a:off x="548640" y="3017520"/>
-            <a:ext cx="10972800" cy="274320"/>
-          </a:xfrm>
-          <a:prstGeom prst="rect">
-            <a:avLst/>
-          </a:prstGeom>
-          <a:noFill/>
-          <a:ln/>
-        </p:spPr>
-        <p:txBody>
-          <a:bodyPr wrap="square" rtlCol="0" anchor="ctr"/>
-          <a:lstStyle/>
-          <a:p>
-            <a:pPr indent="0" marL="0">
-              <a:buNone/>
-            </a:pPr>
-            <a:r>
-              <a:rPr lang="en-US" sz="1200" b="1" spc="100" kern="0" dirty="0">
+            <a:off x="548640" y="3108960"/>
+            <a:ext cx="5486400" cy="274320"/>
+          </a:xfrm>
+          <a:prstGeom prst="rect">
+            <a:avLst/>
+          </a:prstGeom>
+          <a:noFill/>
+          <a:ln/>
+        </p:spPr>
+        <p:txBody>
+          <a:bodyPr wrap="square" rtlCol="0" anchor="ctr"/>
+          <a:lstStyle/>
+          <a:p>
+            <a:pPr indent="0" marL="0">
+              <a:buNone/>
+            </a:pPr>
+            <a:r>
+              <a:rPr lang="en-US" sz="1000" b="1" spc="100" kern="0" dirty="0">
                 <a:solidFill>
                   <a:srgbClr val="1A1714"/>
                 </a:solidFill>
@@ -6052,7 +6052,7 @@
               </a:rPr>
               <a:t>KEY TAKEAWAYS SUMMARY</a:t>
             </a:r>
-            <a:endParaRPr lang="en-US" sz="1200" dirty="0"/>
+            <a:endParaRPr lang="en-US" sz="1000" dirty="0"/>
           </a:p>
         </p:txBody>
       </p:sp>
@@ -6064,8 +6064,8 @@
         </p:nvSpPr>
         <p:spPr>
           <a:xfrm>
-            <a:off x="548640" y="3383280"/>
-            <a:ext cx="3291840" cy="2743200"/>
+            <a:off x="548640" y="3474720"/>
+            <a:ext cx="5486400" cy="731520"/>
           </a:xfrm>
           <a:prstGeom prst="rect">
             <a:avLst/>
@@ -6089,34 +6089,34 @@
         </p:nvSpPr>
         <p:spPr>
           <a:xfrm>
-            <a:off x="822960" y="3566160"/>
-            <a:ext cx="2743200" cy="365760"/>
-          </a:xfrm>
-          <a:prstGeom prst="rect">
-            <a:avLst/>
-          </a:prstGeom>
-          <a:noFill/>
-          <a:ln/>
-        </p:spPr>
-        <p:txBody>
-          <a:bodyPr wrap="square" rtlCol="0" anchor="ctr"/>
-          <a:lstStyle/>
-          <a:p>
-            <a:pPr indent="0" marL="0">
-              <a:buNone/>
-            </a:pPr>
-            <a:r>
-              <a:rPr lang="en-US" sz="2000" b="1" dirty="0">
+            <a:off x="731520" y="3566160"/>
+            <a:ext cx="5120640" cy="228600"/>
+          </a:xfrm>
+          <a:prstGeom prst="rect">
+            <a:avLst/>
+          </a:prstGeom>
+          <a:noFill/>
+          <a:ln/>
+        </p:spPr>
+        <p:txBody>
+          <a:bodyPr wrap="square" rtlCol="0" anchor="ctr"/>
+          <a:lstStyle/>
+          <a:p>
+            <a:pPr indent="0" marL="0">
+              <a:buNone/>
+            </a:pPr>
+            <a:r>
+              <a:rPr lang="en-US" sz="1300" b="1" dirty="0">
                 <a:solidFill>
                   <a:srgbClr val="B84A2F"/>
                 </a:solidFill>
-                <a:latin typeface="PP Mondwest" pitchFamily="34" charset="0"/>
-                <a:ea typeface="PP Mondwest" pitchFamily="34" charset="-122"/>
-                <a:cs typeface="PP Mondwest" pitchFamily="34" charset="-120"/>
+                <a:latin typeface="Aeonik" pitchFamily="34" charset="0"/>
+                <a:ea typeface="Aeonik" pitchFamily="34" charset="-122"/>
+                <a:cs typeface="Aeonik" pitchFamily="34" charset="-120"/>
               </a:rPr>
               <a:t>Procurement</a:t>
             </a:r>
-            <a:endParaRPr lang="en-US" sz="2000" dirty="0"/>
+            <a:endParaRPr lang="en-US" sz="1300" dirty="0"/>
           </a:p>
         </p:txBody>
       </p:sp>
@@ -6128,24 +6128,24 @@
         </p:nvSpPr>
         <p:spPr>
           <a:xfrm>
-            <a:off x="822960" y="4023360"/>
-            <a:ext cx="2743200" cy="1920240"/>
-          </a:xfrm>
-          <a:prstGeom prst="rect">
-            <a:avLst/>
-          </a:prstGeom>
-          <a:noFill/>
-          <a:ln/>
-        </p:spPr>
-        <p:txBody>
-          <a:bodyPr wrap="square" rtlCol="0" anchor="ctr"/>
-          <a:lstStyle/>
-          <a:p>
-            <a:pPr indent="0" marL="0">
-              <a:buNone/>
-            </a:pPr>
-            <a:r>
-              <a:rPr lang="en-US" sz="1800" dirty="0">
+            <a:off x="731520" y="3794760"/>
+            <a:ext cx="5120640" cy="365760"/>
+          </a:xfrm>
+          <a:prstGeom prst="rect">
+            <a:avLst/>
+          </a:prstGeom>
+          <a:noFill/>
+          <a:ln/>
+        </p:spPr>
+        <p:txBody>
+          <a:bodyPr wrap="square" rtlCol="0" anchor="ctr"/>
+          <a:lstStyle/>
+          <a:p>
+            <a:pPr indent="0" marL="0">
+              <a:buNone/>
+            </a:pPr>
+            <a:r>
+              <a:rPr lang="en-US" sz="1100" dirty="0">
                 <a:solidFill>
                   <a:srgbClr val="6B6560"/>
                 </a:solidFill>
@@ -6155,7 +6155,7 @@
               </a:rPr>
               <a:t>Shift from JIT to Strategic Hybrid; resilience is the new ROI.</a:t>
             </a:r>
-            <a:endParaRPr lang="en-US" sz="1800" dirty="0"/>
+            <a:endParaRPr lang="en-US" sz="1100" dirty="0"/>
           </a:p>
         </p:txBody>
       </p:sp>
@@ -6167,8 +6167,8 @@
         </p:nvSpPr>
         <p:spPr>
           <a:xfrm>
-            <a:off x="4389120" y="3383280"/>
-            <a:ext cx="3291840" cy="2743200"/>
+            <a:off x="548640" y="4343400"/>
+            <a:ext cx="5486400" cy="731520"/>
           </a:xfrm>
           <a:prstGeom prst="rect">
             <a:avLst/>
@@ -6192,34 +6192,34 @@
         </p:nvSpPr>
         <p:spPr>
           <a:xfrm>
-            <a:off x="4663440" y="3566160"/>
-            <a:ext cx="2743200" cy="365760"/>
-          </a:xfrm>
-          <a:prstGeom prst="rect">
-            <a:avLst/>
-          </a:prstGeom>
-          <a:noFill/>
-          <a:ln/>
-        </p:spPr>
-        <p:txBody>
-          <a:bodyPr wrap="square" rtlCol="0" anchor="ctr"/>
-          <a:lstStyle/>
-          <a:p>
-            <a:pPr indent="0" marL="0">
-              <a:buNone/>
-            </a:pPr>
-            <a:r>
-              <a:rPr lang="en-US" sz="2000" b="1" dirty="0">
+            <a:off x="731520" y="4434840"/>
+            <a:ext cx="5120640" cy="228600"/>
+          </a:xfrm>
+          <a:prstGeom prst="rect">
+            <a:avLst/>
+          </a:prstGeom>
+          <a:noFill/>
+          <a:ln/>
+        </p:spPr>
+        <p:txBody>
+          <a:bodyPr wrap="square" rtlCol="0" anchor="ctr"/>
+          <a:lstStyle/>
+          <a:p>
+            <a:pPr indent="0" marL="0">
+              <a:buNone/>
+            </a:pPr>
+            <a:r>
+              <a:rPr lang="en-US" sz="1300" b="1" dirty="0">
                 <a:solidFill>
                   <a:srgbClr val="9E7D84"/>
                 </a:solidFill>
-                <a:latin typeface="PP Mondwest" pitchFamily="34" charset="0"/>
-                <a:ea typeface="PP Mondwest" pitchFamily="34" charset="-122"/>
-                <a:cs typeface="PP Mondwest" pitchFamily="34" charset="-120"/>
+                <a:latin typeface="Aeonik" pitchFamily="34" charset="0"/>
+                <a:ea typeface="Aeonik" pitchFamily="34" charset="-122"/>
+                <a:cs typeface="Aeonik" pitchFamily="34" charset="-120"/>
               </a:rPr>
               <a:t>Supply Chain</a:t>
             </a:r>
-            <a:endParaRPr lang="en-US" sz="2000" dirty="0"/>
+            <a:endParaRPr lang="en-US" sz="1300" dirty="0"/>
           </a:p>
         </p:txBody>
       </p:sp>
@@ -6231,24 +6231,24 @@
         </p:nvSpPr>
         <p:spPr>
           <a:xfrm>
-            <a:off x="4663440" y="4023360"/>
-            <a:ext cx="2743200" cy="1920240"/>
-          </a:xfrm>
-          <a:prstGeom prst="rect">
-            <a:avLst/>
-          </a:prstGeom>
-          <a:noFill/>
-          <a:ln/>
-        </p:spPr>
-        <p:txBody>
-          <a:bodyPr wrap="square" rtlCol="0" anchor="ctr"/>
-          <a:lstStyle/>
-          <a:p>
-            <a:pPr indent="0" marL="0">
-              <a:buNone/>
-            </a:pPr>
-            <a:r>
-              <a:rPr lang="en-US" sz="1800" dirty="0">
+            <a:off x="731520" y="4663440"/>
+            <a:ext cx="5120640" cy="365760"/>
+          </a:xfrm>
+          <a:prstGeom prst="rect">
+            <a:avLst/>
+          </a:prstGeom>
+          <a:noFill/>
+          <a:ln/>
+        </p:spPr>
+        <p:txBody>
+          <a:bodyPr wrap="square" rtlCol="0" anchor="ctr"/>
+          <a:lstStyle/>
+          <a:p>
+            <a:pPr indent="0" marL="0">
+              <a:buNone/>
+            </a:pPr>
+            <a:r>
+              <a:rPr lang="en-US" sz="1100" dirty="0">
                 <a:solidFill>
                   <a:srgbClr val="6B6560"/>
                 </a:solidFill>
@@ -6258,7 +6258,7 @@
               </a:rPr>
               <a:t>Chokepoints in Advanced Packaging and SME are the new strategic risks.</a:t>
             </a:r>
-            <a:endParaRPr lang="en-US" sz="1800" dirty="0"/>
+            <a:endParaRPr lang="en-US" sz="1100" dirty="0"/>
           </a:p>
         </p:txBody>
       </p:sp>
@@ -6270,8 +6270,8 @@
         </p:nvSpPr>
         <p:spPr>
           <a:xfrm>
-            <a:off x="8229600" y="3383280"/>
-            <a:ext cx="3291840" cy="2743200"/>
+            <a:off x="548640" y="5212080"/>
+            <a:ext cx="5486400" cy="731520"/>
           </a:xfrm>
           <a:prstGeom prst="rect">
             <a:avLst/>
@@ -6295,34 +6295,34 @@
         </p:nvSpPr>
         <p:spPr>
           <a:xfrm>
-            <a:off x="8503920" y="3566160"/>
-            <a:ext cx="2743200" cy="365760"/>
-          </a:xfrm>
-          <a:prstGeom prst="rect">
-            <a:avLst/>
-          </a:prstGeom>
-          <a:noFill/>
-          <a:ln/>
-        </p:spPr>
-        <p:txBody>
-          <a:bodyPr wrap="square" rtlCol="0" anchor="ctr"/>
-          <a:lstStyle/>
-          <a:p>
-            <a:pPr indent="0" marL="0">
-              <a:buNone/>
-            </a:pPr>
-            <a:r>
-              <a:rPr lang="en-US" sz="2000" b="1" dirty="0">
+            <a:off x="731520" y="5303520"/>
+            <a:ext cx="5120640" cy="228600"/>
+          </a:xfrm>
+          <a:prstGeom prst="rect">
+            <a:avLst/>
+          </a:prstGeom>
+          <a:noFill/>
+          <a:ln/>
+        </p:spPr>
+        <p:txBody>
+          <a:bodyPr wrap="square" rtlCol="0" anchor="ctr"/>
+          <a:lstStyle/>
+          <a:p>
+            <a:pPr indent="0" marL="0">
+              <a:buNone/>
+            </a:pPr>
+            <a:r>
+              <a:rPr lang="en-US" sz="1300" b="1" dirty="0">
                 <a:solidFill>
                   <a:srgbClr val="768C7C"/>
                 </a:solidFill>
-                <a:latin typeface="PP Mondwest" pitchFamily="34" charset="0"/>
-                <a:ea typeface="PP Mondwest" pitchFamily="34" charset="-122"/>
-                <a:cs typeface="PP Mondwest" pitchFamily="34" charset="-120"/>
+                <a:latin typeface="Aeonik" pitchFamily="34" charset="0"/>
+                <a:ea typeface="Aeonik" pitchFamily="34" charset="-122"/>
+                <a:cs typeface="Aeonik" pitchFamily="34" charset="-120"/>
               </a:rPr>
               <a:t>Industries</a:t>
             </a:r>
-            <a:endParaRPr lang="en-US" sz="2000" dirty="0"/>
+            <a:endParaRPr lang="en-US" sz="1300" dirty="0"/>
           </a:p>
         </p:txBody>
       </p:sp>
@@ -6334,24 +6334,24 @@
         </p:nvSpPr>
         <p:spPr>
           <a:xfrm>
-            <a:off x="8503920" y="4023360"/>
-            <a:ext cx="2743200" cy="1920240"/>
-          </a:xfrm>
-          <a:prstGeom prst="rect">
-            <a:avLst/>
-          </a:prstGeom>
-          <a:noFill/>
-          <a:ln/>
-        </p:spPr>
-        <p:txBody>
-          <a:bodyPr wrap="square" rtlCol="0" anchor="ctr"/>
-          <a:lstStyle/>
-          <a:p>
-            <a:pPr indent="0" marL="0">
-              <a:buNone/>
-            </a:pPr>
-            <a:r>
-              <a:rPr lang="en-US" sz="1800" dirty="0">
+            <a:off x="731520" y="5532120"/>
+            <a:ext cx="5120640" cy="365760"/>
+          </a:xfrm>
+          <a:prstGeom prst="rect">
+            <a:avLst/>
+          </a:prstGeom>
+          <a:noFill/>
+          <a:ln/>
+        </p:spPr>
+        <p:txBody>
+          <a:bodyPr wrap="square" rtlCol="0" anchor="ctr"/>
+          <a:lstStyle/>
+          <a:p>
+            <a:pPr indent="0" marL="0">
+              <a:buNone/>
+            </a:pPr>
+            <a:r>
+              <a:rPr lang="en-US" sz="1100" dirty="0">
                 <a:solidFill>
                   <a:srgbClr val="6B6560"/>
                 </a:solidFill>
@@ -6361,10 +6361,59 @@
               </a:rPr>
               <a:t>AI is the Value King; Automotive is the Volume King.</a:t>
             </a:r>
-            <a:endParaRPr lang="en-US" sz="1800" dirty="0"/>
-          </a:p>
-        </p:txBody>
-      </p:sp>
+            <a:endParaRPr lang="en-US" sz="1100" dirty="0"/>
+          </a:p>
+        </p:txBody>
+      </p:sp>
+      <p:sp>
+        <p:nvSpPr>
+          <p:cNvPr id="19" name="Shape 16"/>
+          <p:cNvSpPr/>
+          <p:nvPr/>
+        </p:nvSpPr>
+        <p:spPr>
+          <a:xfrm>
+            <a:off x="6309360" y="1188720"/>
+            <a:ext cx="5394960" cy="4937760"/>
+          </a:xfrm>
+          <a:prstGeom prst="rect">
+            <a:avLst/>
+          </a:prstGeom>
+          <a:solidFill>
+            <a:srgbClr val="FFFDF8"/>
+          </a:solidFill>
+          <a:ln w="12700">
+            <a:solidFill>
+              <a:srgbClr val="E0D9D0"/>
+            </a:solidFill>
+            <a:prstDash val="solid"/>
+          </a:ln>
+        </p:spPr>
+      </p:sp>
+      <p:pic>
+        <p:nvPicPr>
+          <p:cNvPr id="20" name="Image 0" descr="critical_materials.png">    </p:cNvPr>
+          <p:cNvPicPr>
+            <a:picLocks noChangeAspect="1"/>
+          </p:cNvPicPr>
+          <p:nvPr/>
+        </p:nvPicPr>
+        <p:blipFill>
+          <a:blip r:embed="rId1"/>
+          <a:stretch>
+            <a:fillRect/>
+          </a:stretch>
+        </p:blipFill>
+        <p:spPr>
+          <a:xfrm>
+            <a:off x="6400800" y="1280160"/>
+            <a:ext cx="5212080" cy="4754880"/>
+          </a:xfrm>
+          <a:prstGeom prst="rect">
+            <a:avLst/>
+          </a:prstGeom>
+        </p:spPr>
+      </p:pic>
     </p:spTree>
   </p:cSld>
   <p:clrMapOvr>
@@ -6405,8 +6454,8 @@
         </p:nvSpPr>
         <p:spPr>
           <a:xfrm>
-            <a:off x="731520" y="1371600"/>
-            <a:ext cx="10515600" cy="365760"/>
+            <a:off x="731520" y="1645920"/>
+            <a:ext cx="4572000" cy="365760"/>
           </a:xfrm>
           <a:prstGeom prst="rect">
             <a:avLst/>
@@ -6444,8 +6493,8 @@
         </p:nvSpPr>
         <p:spPr>
           <a:xfrm>
-            <a:off x="731520" y="1828800"/>
-            <a:ext cx="10515600" cy="1097280"/>
+            <a:off x="731520" y="2103120"/>
+            <a:ext cx="4572000" cy="1097280"/>
           </a:xfrm>
           <a:prstGeom prst="rect">
             <a:avLst/>
@@ -6483,8 +6532,8 @@
         </p:nvSpPr>
         <p:spPr>
           <a:xfrm>
-            <a:off x="731520" y="3017520"/>
-            <a:ext cx="10515600" cy="731520"/>
+            <a:off x="731520" y="3291840"/>
+            <a:ext cx="4572000" cy="731520"/>
           </a:xfrm>
           <a:prstGeom prst="rect">
             <a:avLst/>
@@ -6522,8 +6571,8 @@
         </p:nvSpPr>
         <p:spPr>
           <a:xfrm>
-            <a:off x="731520" y="3840480"/>
-            <a:ext cx="4572000" cy="36576"/>
+            <a:off x="731520" y="4114800"/>
+            <a:ext cx="3657600" cy="36576"/>
           </a:xfrm>
           <a:prstGeom prst="rect">
             <a:avLst/>
@@ -6542,7 +6591,7 @@
         </p:nvSpPr>
         <p:spPr>
           <a:xfrm>
-            <a:off x="731520" y="4206240"/>
+            <a:off x="731520" y="4389120"/>
             <a:ext cx="4572000" cy="731520"/>
           </a:xfrm>
           <a:prstGeom prst="rect">
@@ -6592,7 +6641,481 @@
       </p:sp>
       <p:sp>
         <p:nvSpPr>
-          <p:cNvPr id="8" name="Text 5"/>
+          <p:cNvPr id="8" name="Shape 5"/>
+          <p:cNvSpPr/>
+          <p:nvPr/>
+        </p:nvSpPr>
+        <p:spPr>
+          <a:xfrm>
+            <a:off x="5852160" y="1188720"/>
+            <a:ext cx="5760720" cy="4937760"/>
+          </a:xfrm>
+          <a:prstGeom prst="rect">
+            <a:avLst/>
+          </a:prstGeom>
+          <a:solidFill>
+            <a:srgbClr val="FFFDF8"/>
+          </a:solidFill>
+          <a:ln w="12700">
+            <a:solidFill>
+              <a:srgbClr val="E0D9D0"/>
+            </a:solidFill>
+            <a:prstDash val="solid"/>
+          </a:ln>
+        </p:spPr>
+      </p:sp>
+      <p:sp>
+        <p:nvSpPr>
+          <p:cNvPr id="9" name="Text 6"/>
+          <p:cNvSpPr/>
+          <p:nvPr/>
+        </p:nvSpPr>
+        <p:spPr>
+          <a:xfrm>
+            <a:off x="6035040" y="1371600"/>
+            <a:ext cx="5394960" cy="365760"/>
+          </a:xfrm>
+          <a:prstGeom prst="rect">
+            <a:avLst/>
+          </a:prstGeom>
+          <a:noFill/>
+          <a:ln/>
+        </p:spPr>
+        <p:txBody>
+          <a:bodyPr wrap="square" rtlCol="0" anchor="ctr"/>
+          <a:lstStyle/>
+          <a:p>
+            <a:pPr indent="0" marL="0">
+              <a:buNone/>
+            </a:pPr>
+            <a:r>
+              <a:rPr lang="en-US" sz="2000" b="1" dirty="0">
+                <a:solidFill>
+                  <a:srgbClr val="B84A2F"/>
+                </a:solidFill>
+                <a:latin typeface="PP Mondwest" pitchFamily="34" charset="0"/>
+                <a:ea typeface="PP Mondwest" pitchFamily="34" charset="-122"/>
+                <a:cs typeface="PP Mondwest" pitchFamily="34" charset="-120"/>
+              </a:rPr>
+              <a:t>References</a:t>
+            </a:r>
+            <a:endParaRPr lang="en-US" sz="2000" dirty="0"/>
+          </a:p>
+        </p:txBody>
+      </p:sp>
+      <p:sp>
+        <p:nvSpPr>
+          <p:cNvPr id="10" name="Text 7"/>
+          <p:cNvSpPr/>
+          <p:nvPr/>
+        </p:nvSpPr>
+        <p:spPr>
+          <a:xfrm>
+            <a:off x="6035040" y="1828800"/>
+            <a:ext cx="2651760" cy="4023360"/>
+          </a:xfrm>
+          <a:prstGeom prst="rect">
+            <a:avLst/>
+          </a:prstGeom>
+          <a:noFill/>
+          <a:ln/>
+        </p:spPr>
+        <p:txBody>
+          <a:bodyPr wrap="square" rtlCol="0" anchor="ctr"/>
+          <a:lstStyle/>
+          <a:p>
+            <a:pPr indent="0" marL="0">
+              <a:buNone/>
+            </a:pPr>
+            <a:r>
+              <a:rPr lang="en-US" sz="850" b="1" dirty="0">
+                <a:solidFill>
+                  <a:srgbClr val="1A1714"/>
+                </a:solidFill>
+                <a:latin typeface="Aeonik" pitchFamily="34" charset="0"/>
+                <a:ea typeface="Aeonik" pitchFamily="34" charset="-122"/>
+                <a:cs typeface="Aeonik" pitchFamily="34" charset="-120"/>
+              </a:rPr>
+              <a:t>1. Gartner: Revenue Forecast
+</a:t>
+            </a:r>
+            <a:pPr indent="0" marL="0">
+              <a:buNone/>
+            </a:pPr>
+            <a:r>
+              <a:rPr lang="en-US" sz="800" dirty="0">
+                <a:solidFill>
+                  <a:srgbClr val="B84A2F"/>
+                </a:solidFill>
+                <a:latin typeface="Aeonik" pitchFamily="34" charset="0"/>
+                <a:ea typeface="Aeonik" pitchFamily="34" charset="-122"/>
+                <a:cs typeface="Aeonik" pitchFamily="34" charset="-120"/>
+              </a:rPr>
+              <a:t>https://www.gartner.com/en/newsroom/press-releases/...
+</a:t>
+            </a:r>
+            <a:pPr indent="0" marL="0">
+              <a:buNone/>
+            </a:pPr>
+            <a:r>
+              <a:rPr lang="en-US" sz="850" b="1" dirty="0">
+                <a:solidFill>
+                  <a:srgbClr val="1A1714"/>
+                </a:solidFill>
+                <a:latin typeface="Aeonik" pitchFamily="34" charset="0"/>
+                <a:ea typeface="Aeonik" pitchFamily="34" charset="-122"/>
+                <a:cs typeface="Aeonik" pitchFamily="34" charset="-120"/>
+              </a:rPr>
+              <a:t>2. Phihong: JIT vs JIC Sourcing
+</a:t>
+            </a:r>
+            <a:pPr indent="0" marL="0">
+              <a:buNone/>
+            </a:pPr>
+            <a:r>
+              <a:rPr lang="en-US" sz="800" dirty="0">
+                <a:solidFill>
+                  <a:srgbClr val="B84A2F"/>
+                </a:solidFill>
+                <a:latin typeface="Aeonik" pitchFamily="34" charset="0"/>
+                <a:ea typeface="Aeonik" pitchFamily="34" charset="-122"/>
+                <a:cs typeface="Aeonik" pitchFamily="34" charset="-120"/>
+              </a:rPr>
+              <a:t>https://www.phihong.com/just-in-time-vs-just-in-case...
+</a:t>
+            </a:r>
+            <a:pPr indent="0" marL="0">
+              <a:buNone/>
+            </a:pPr>
+            <a:r>
+              <a:rPr lang="en-US" sz="850" b="1" dirty="0">
+                <a:solidFill>
+                  <a:srgbClr val="1A1714"/>
+                </a:solidFill>
+                <a:latin typeface="Aeonik" pitchFamily="34" charset="0"/>
+                <a:ea typeface="Aeonik" pitchFamily="34" charset="-122"/>
+                <a:cs typeface="Aeonik" pitchFamily="34" charset="-120"/>
+              </a:rPr>
+              <a:t>3. Maria O.: Supply Chain Continuity
+</a:t>
+            </a:r>
+            <a:pPr indent="0" marL="0">
+              <a:buNone/>
+            </a:pPr>
+            <a:r>
+              <a:rPr lang="en-US" sz="800" dirty="0">
+                <a:solidFill>
+                  <a:srgbClr val="B84A2F"/>
+                </a:solidFill>
+                <a:latin typeface="Aeonik" pitchFamily="34" charset="0"/>
+                <a:ea typeface="Aeonik" pitchFamily="34" charset="-122"/>
+                <a:cs typeface="Aeonik" pitchFamily="34" charset="-120"/>
+              </a:rPr>
+              <a:t>https://www.linkedin.com/posts/pmochoamc...
+</a:t>
+            </a:r>
+            <a:pPr indent="0" marL="0">
+              <a:buNone/>
+            </a:pPr>
+            <a:r>
+              <a:rPr lang="en-US" sz="850" b="1" dirty="0">
+                <a:solidFill>
+                  <a:srgbClr val="1A1714"/>
+                </a:solidFill>
+                <a:latin typeface="Aeonik" pitchFamily="34" charset="0"/>
+                <a:ea typeface="Aeonik" pitchFamily="34" charset="-122"/>
+                <a:cs typeface="Aeonik" pitchFamily="34" charset="-120"/>
+              </a:rPr>
+              <a:t>4. Porsche: Semiconductor Superiority
+</a:t>
+            </a:r>
+            <a:pPr indent="0" marL="0">
+              <a:buNone/>
+            </a:pPr>
+            <a:r>
+              <a:rPr lang="en-US" sz="800" dirty="0">
+                <a:solidFill>
+                  <a:srgbClr val="B84A2F"/>
+                </a:solidFill>
+                <a:latin typeface="Aeonik" pitchFamily="34" charset="0"/>
+                <a:ea typeface="Aeonik" pitchFamily="34" charset="-122"/>
+                <a:cs typeface="Aeonik" pitchFamily="34" charset="-120"/>
+              </a:rPr>
+              <a:t>https://www.porsche-consulting.com/sites/...
+</a:t>
+            </a:r>
+            <a:pPr indent="0" marL="0">
+              <a:buNone/>
+            </a:pPr>
+            <a:r>
+              <a:rPr lang="en-US" sz="850" b="1" dirty="0">
+                <a:solidFill>
+                  <a:srgbClr val="1A1714"/>
+                </a:solidFill>
+                <a:latin typeface="Aeonik" pitchFamily="34" charset="0"/>
+                <a:ea typeface="Aeonik" pitchFamily="34" charset="-122"/>
+                <a:cs typeface="Aeonik" pitchFamily="34" charset="-120"/>
+              </a:rPr>
+              <a:t>5. CSET: Semiconductor Supply Chain
+</a:t>
+            </a:r>
+            <a:pPr indent="0" marL="0">
+              <a:buNone/>
+            </a:pPr>
+            <a:r>
+              <a:rPr lang="en-US" sz="800" dirty="0">
+                <a:solidFill>
+                  <a:srgbClr val="B84A2F"/>
+                </a:solidFill>
+                <a:latin typeface="Aeonik" pitchFamily="34" charset="0"/>
+                <a:ea typeface="Aeonik" pitchFamily="34" charset="-122"/>
+                <a:cs typeface="Aeonik" pitchFamily="34" charset="-120"/>
+              </a:rPr>
+              <a:t>https://cset.georgetown.edu/publication/...
+</a:t>
+            </a:r>
+            <a:pPr indent="0" marL="0">
+              <a:buNone/>
+            </a:pPr>
+            <a:r>
+              <a:rPr lang="en-US" sz="850" b="1" dirty="0">
+                <a:solidFill>
+                  <a:srgbClr val="1A1714"/>
+                </a:solidFill>
+                <a:latin typeface="Aeonik" pitchFamily="34" charset="0"/>
+                <a:ea typeface="Aeonik" pitchFamily="34" charset="-122"/>
+                <a:cs typeface="Aeonik" pitchFamily="34" charset="-120"/>
+              </a:rPr>
+              <a:t>6. CSIS: Mineral Demands for Resilient
+</a:t>
+            </a:r>
+            <a:pPr indent="0" marL="0">
+              <a:buNone/>
+            </a:pPr>
+            <a:r>
+              <a:rPr lang="en-US" sz="800" dirty="0">
+                <a:solidFill>
+                  <a:srgbClr val="B84A2F"/>
+                </a:solidFill>
+                <a:latin typeface="Aeonik" pitchFamily="34" charset="0"/>
+                <a:ea typeface="Aeonik" pitchFamily="34" charset="-122"/>
+                <a:cs typeface="Aeonik" pitchFamily="34" charset="-120"/>
+              </a:rPr>
+              <a:t>https://www.csis.org/analysis/mineral-demands...
+</a:t>
+            </a:r>
+            <a:endParaRPr lang="en-US" sz="850" dirty="0"/>
+          </a:p>
+        </p:txBody>
+      </p:sp>
+      <p:sp>
+        <p:nvSpPr>
+          <p:cNvPr id="11" name="Text 8"/>
+          <p:cNvSpPr/>
+          <p:nvPr/>
+        </p:nvSpPr>
+        <p:spPr>
+          <a:xfrm>
+            <a:off x="8778240" y="1828800"/>
+            <a:ext cx="2651760" cy="4023360"/>
+          </a:xfrm>
+          <a:prstGeom prst="rect">
+            <a:avLst/>
+          </a:prstGeom>
+          <a:noFill/>
+          <a:ln/>
+        </p:spPr>
+        <p:txBody>
+          <a:bodyPr wrap="square" rtlCol="0" anchor="ctr"/>
+          <a:lstStyle/>
+          <a:p>
+            <a:pPr indent="0" marL="0">
+              <a:buNone/>
+            </a:pPr>
+            <a:r>
+              <a:rPr lang="en-US" sz="850" b="1" dirty="0">
+                <a:solidFill>
+                  <a:srgbClr val="1A1714"/>
+                </a:solidFill>
+                <a:latin typeface="Aeonik" pitchFamily="34" charset="0"/>
+                <a:ea typeface="Aeonik" pitchFamily="34" charset="-122"/>
+                <a:cs typeface="Aeonik" pitchFamily="34" charset="-120"/>
+              </a:rPr>
+              <a:t>7. SIA: Emerging Resilience
+</a:t>
+            </a:r>
+            <a:pPr indent="0" marL="0">
+              <a:buNone/>
+            </a:pPr>
+            <a:r>
+              <a:rPr lang="en-US" sz="800" dirty="0">
+                <a:solidFill>
+                  <a:srgbClr val="B84A2F"/>
+                </a:solidFill>
+                <a:latin typeface="Aeonik" pitchFamily="34" charset="0"/>
+                <a:ea typeface="Aeonik" pitchFamily="34" charset="-122"/>
+                <a:cs typeface="Aeonik" pitchFamily="34" charset="-120"/>
+              </a:rPr>
+              <a:t>https://www.semiconductors.org/emerging-resilience...
+</a:t>
+            </a:r>
+            <a:pPr indent="0" marL="0">
+              <a:buNone/>
+            </a:pPr>
+            <a:r>
+              <a:rPr lang="en-US" sz="850" b="1" dirty="0">
+                <a:solidFill>
+                  <a:srgbClr val="1A1714"/>
+                </a:solidFill>
+                <a:latin typeface="Aeonik" pitchFamily="34" charset="0"/>
+                <a:ea typeface="Aeonik" pitchFamily="34" charset="-122"/>
+                <a:cs typeface="Aeonik" pitchFamily="34" charset="-120"/>
+              </a:rPr>
+              <a:t>8. A. Masood: Semiconductors in 2026
+</a:t>
+            </a:r>
+            <a:pPr indent="0" marL="0">
+              <a:buNone/>
+            </a:pPr>
+            <a:r>
+              <a:rPr lang="en-US" sz="800" dirty="0">
+                <a:solidFill>
+                  <a:srgbClr val="B84A2F"/>
+                </a:solidFill>
+                <a:latin typeface="Aeonik" pitchFamily="34" charset="0"/>
+                <a:ea typeface="Aeonik" pitchFamily="34" charset="-122"/>
+                <a:cs typeface="Aeonik" pitchFamily="34" charset="-120"/>
+              </a:rPr>
+              <a:t>https://medium.com/@adnanmasood/semiconductors...
+</a:t>
+            </a:r>
+            <a:pPr indent="0" marL="0">
+              <a:buNone/>
+            </a:pPr>
+            <a:r>
+              <a:rPr lang="en-US" sz="850" b="1" dirty="0">
+                <a:solidFill>
+                  <a:srgbClr val="1A1714"/>
+                </a:solidFill>
+                <a:latin typeface="Aeonik" pitchFamily="34" charset="0"/>
+                <a:ea typeface="Aeonik" pitchFamily="34" charset="-122"/>
+                <a:cs typeface="Aeonik" pitchFamily="34" charset="-120"/>
+              </a:rPr>
+              <a:t>9. OECD: Mapping the Value Chain
+</a:t>
+            </a:r>
+            <a:pPr indent="0" marL="0">
+              <a:buNone/>
+            </a:pPr>
+            <a:r>
+              <a:rPr lang="en-US" sz="800" dirty="0">
+                <a:solidFill>
+                  <a:srgbClr val="B84A2F"/>
+                </a:solidFill>
+                <a:latin typeface="Aeonik" pitchFamily="34" charset="0"/>
+                <a:ea typeface="Aeonik" pitchFamily="34" charset="-122"/>
+                <a:cs typeface="Aeonik" pitchFamily="34" charset="-120"/>
+              </a:rPr>
+              <a:t>https://www.oecd.org/content/dam/oecd/en/...
+</a:t>
+            </a:r>
+            <a:pPr indent="0" marL="0">
+              <a:buNone/>
+            </a:pPr>
+            <a:r>
+              <a:rPr lang="en-US" sz="850" b="1" dirty="0">
+                <a:solidFill>
+                  <a:srgbClr val="1A1714"/>
+                </a:solidFill>
+                <a:latin typeface="Aeonik" pitchFamily="34" charset="0"/>
+                <a:ea typeface="Aeonik" pitchFamily="34" charset="-122"/>
+                <a:cs typeface="Aeonik" pitchFamily="34" charset="-120"/>
+              </a:rPr>
+              <a:t>10. Deloitte: 2026 Industry Outlook
+</a:t>
+            </a:r>
+            <a:pPr indent="0" marL="0">
+              <a:buNone/>
+            </a:pPr>
+            <a:r>
+              <a:rPr lang="en-US" sz="800" dirty="0">
+                <a:solidFill>
+                  <a:srgbClr val="B84A2F"/>
+                </a:solidFill>
+                <a:latin typeface="Aeonik" pitchFamily="34" charset="0"/>
+                <a:ea typeface="Aeonik" pitchFamily="34" charset="-122"/>
+                <a:cs typeface="Aeonik" pitchFamily="34" charset="-120"/>
+              </a:rPr>
+              <a:t>https://www.deloitte.com/us/en/insights/...
+</a:t>
+            </a:r>
+            <a:pPr indent="0" marL="0">
+              <a:buNone/>
+            </a:pPr>
+            <a:r>
+              <a:rPr lang="en-US" sz="850" b="1" dirty="0">
+                <a:solidFill>
+                  <a:srgbClr val="1A1714"/>
+                </a:solidFill>
+                <a:latin typeface="Aeonik" pitchFamily="34" charset="0"/>
+                <a:ea typeface="Aeonik" pitchFamily="34" charset="-122"/>
+                <a:cs typeface="Aeonik" pitchFamily="34" charset="-120"/>
+              </a:rPr>
+              <a:t>11. GM Insights: Aerospace Market Size
+</a:t>
+            </a:r>
+            <a:pPr indent="0" marL="0">
+              <a:buNone/>
+            </a:pPr>
+            <a:r>
+              <a:rPr lang="en-US" sz="800" dirty="0">
+                <a:solidFill>
+                  <a:srgbClr val="B84A2F"/>
+                </a:solidFill>
+                <a:latin typeface="Aeonik" pitchFamily="34" charset="0"/>
+                <a:ea typeface="Aeonik" pitchFamily="34" charset="-122"/>
+                <a:cs typeface="Aeonik" pitchFamily="34" charset="-120"/>
+              </a:rPr>
+              <a:t>https://www.gminsights.com/industry-analysis/...
+</a:t>
+            </a:r>
+            <a:pPr indent="0" marL="0">
+              <a:buNone/>
+            </a:pPr>
+            <a:r>
+              <a:rPr lang="en-US" sz="850" b="1" dirty="0">
+                <a:solidFill>
+                  <a:srgbClr val="1A1714"/>
+                </a:solidFill>
+                <a:latin typeface="Aeonik" pitchFamily="34" charset="0"/>
+                <a:ea typeface="Aeonik" pitchFamily="34" charset="-122"/>
+                <a:cs typeface="Aeonik" pitchFamily="34" charset="-120"/>
+              </a:rPr>
+              <a:t>12. Edge Silica: AI &amp; EVs Trends
+</a:t>
+            </a:r>
+            <a:pPr indent="0" marL="0">
+              <a:buNone/>
+            </a:pPr>
+            <a:r>
+              <a:rPr lang="en-US" sz="800" dirty="0">
+                <a:solidFill>
+                  <a:srgbClr val="B84A2F"/>
+                </a:solidFill>
+                <a:latin typeface="Aeonik" pitchFamily="34" charset="0"/>
+                <a:ea typeface="Aeonik" pitchFamily="34" charset="-122"/>
+                <a:cs typeface="Aeonik" pitchFamily="34" charset="-120"/>
+              </a:rPr>
+              <a:t>https://www.linkedin.com/posts/edgesilica...
+</a:t>
+            </a:r>
+            <a:endParaRPr lang="en-US" sz="850" dirty="0"/>
+          </a:p>
+        </p:txBody>
+      </p:sp>
+      <p:sp>
+        <p:nvSpPr>
+          <p:cNvPr id="12" name="Text 9"/>
           <p:cNvSpPr/>
           <p:nvPr/>
         </p:nvSpPr>

</xml_diff>

<commit_message>
feat: complete academic content expansion and vocabulary corrections
</commit_message>
<xml_diff>
--- a/output/semiconductor-ecosystem-2026.pptx
+++ b/output/semiconductor-ecosystem-2026.pptx
@@ -2392,13 +2392,77 @@
       </p:grpSpPr>
       <p:sp>
         <p:nvSpPr>
-          <p:cNvPr id="3" name="Text 0"/>
-          <p:cNvSpPr/>
-          <p:nvPr/>
-        </p:nvSpPr>
-        <p:spPr>
-          <a:xfrm>
-            <a:off x="731520" y="2011680"/>
+          <p:cNvPr id="3" name="Shape 0"/>
+          <p:cNvSpPr/>
+          <p:nvPr/>
+        </p:nvSpPr>
+        <p:spPr>
+          <a:xfrm>
+            <a:off x="731520" y="1371600"/>
+            <a:ext cx="3474720" cy="365760"/>
+          </a:xfrm>
+          <a:prstGeom prst="rect">
+            <a:avLst/>
+          </a:prstGeom>
+          <a:solidFill>
+            <a:srgbClr val="FFFDF8"/>
+          </a:solidFill>
+          <a:ln w="12700">
+            <a:solidFill>
+              <a:srgbClr val="B84A2F"/>
+            </a:solidFill>
+            <a:prstDash val="solid"/>
+          </a:ln>
+        </p:spPr>
+      </p:sp>
+      <p:sp>
+        <p:nvSpPr>
+          <p:cNvPr id="4" name="Text 1"/>
+          <p:cNvSpPr/>
+          <p:nvPr/>
+        </p:nvSpPr>
+        <p:spPr>
+          <a:xfrm>
+            <a:off x="822960" y="1417320"/>
+            <a:ext cx="3291840" cy="274320"/>
+          </a:xfrm>
+          <a:prstGeom prst="rect">
+            <a:avLst/>
+          </a:prstGeom>
+          <a:noFill/>
+          <a:ln/>
+        </p:spPr>
+        <p:txBody>
+          <a:bodyPr wrap="square" rtlCol="0" anchor="ctr"/>
+          <a:lstStyle/>
+          <a:p>
+            <a:pPr indent="0" marL="0">
+              <a:buNone/>
+            </a:pPr>
+            <a:r>
+              <a:rPr lang="en-US" sz="1000" b="1" spc="150" kern="0" dirty="0">
+                <a:solidFill>
+                  <a:srgbClr val="B84A2F"/>
+                </a:solidFill>
+                <a:latin typeface="Aeonik" pitchFamily="34" charset="0"/>
+                <a:ea typeface="Aeonik" pitchFamily="34" charset="-122"/>
+                <a:cs typeface="Aeonik" pitchFamily="34" charset="-120"/>
+              </a:rPr>
+              <a:t>CONSOLIDATED REMEDIAL BRIEFING</a:t>
+            </a:r>
+            <a:endParaRPr lang="en-US" sz="1000" dirty="0"/>
+          </a:p>
+        </p:txBody>
+      </p:sp>
+      <p:sp>
+        <p:nvSpPr>
+          <p:cNvPr id="5" name="Text 2"/>
+          <p:cNvSpPr/>
+          <p:nvPr/>
+        </p:nvSpPr>
+        <p:spPr>
+          <a:xfrm>
+            <a:off x="731520" y="1920240"/>
             <a:ext cx="10515600" cy="1097280"/>
           </a:xfrm>
           <a:prstGeom prst="rect">
@@ -2431,13 +2495,13 @@
       </p:sp>
       <p:sp>
         <p:nvSpPr>
-          <p:cNvPr id="4" name="Text 1"/>
-          <p:cNvSpPr/>
-          <p:nvPr/>
-        </p:nvSpPr>
-        <p:spPr>
-          <a:xfrm>
-            <a:off x="731520" y="3200400"/>
+          <p:cNvPr id="6" name="Text 3"/>
+          <p:cNvSpPr/>
+          <p:nvPr/>
+        </p:nvSpPr>
+        <p:spPr>
+          <a:xfrm>
+            <a:off x="731520" y="3017520"/>
             <a:ext cx="10515600" cy="731520"/>
           </a:xfrm>
           <a:prstGeom prst="rect">
@@ -2462,7 +2526,7 @@
                 <a:ea typeface="Aeonik" pitchFamily="34" charset="-122"/>
                 <a:cs typeface="Aeonik" pitchFamily="34" charset="-120"/>
               </a:rPr>
-              <a:t>A Strategic Briefing on Procurement, Global Supply Chains, and End-User Verticals</a:t>
+              <a:t>A Comprehensive Analysis of Sourcing Strategies, Supply Chain Architecture, and Global End-User Industries</a:t>
             </a:r>
             <a:endParaRPr lang="en-US" sz="2000" dirty="0"/>
           </a:p>
@@ -2470,13 +2534,13 @@
       </p:sp>
       <p:sp>
         <p:nvSpPr>
-          <p:cNvPr id="5" name="Shape 2"/>
-          <p:cNvSpPr/>
-          <p:nvPr/>
-        </p:nvSpPr>
-        <p:spPr>
-          <a:xfrm>
-            <a:off x="731520" y="4023360"/>
+          <p:cNvPr id="7" name="Shape 4"/>
+          <p:cNvSpPr/>
+          <p:nvPr/>
+        </p:nvSpPr>
+        <p:spPr>
+          <a:xfrm>
+            <a:off x="731520" y="3931920"/>
             <a:ext cx="4572000" cy="36576"/>
           </a:xfrm>
           <a:prstGeom prst="rect">
@@ -2490,30 +2554,30 @@
       </p:sp>
       <p:sp>
         <p:nvSpPr>
-          <p:cNvPr id="6" name="Text 3"/>
-          <p:cNvSpPr/>
-          <p:nvPr/>
-        </p:nvSpPr>
-        <p:spPr>
-          <a:xfrm>
-            <a:off x="731520" y="4389120"/>
-            <a:ext cx="4572000" cy="731520"/>
-          </a:xfrm>
-          <a:prstGeom prst="rect">
-            <a:avLst/>
-          </a:prstGeom>
-          <a:noFill/>
-          <a:ln/>
-        </p:spPr>
-        <p:txBody>
-          <a:bodyPr wrap="square" rtlCol="0" anchor="ctr"/>
-          <a:lstStyle/>
-          <a:p>
-            <a:pPr indent="0" marL="0">
-              <a:buNone/>
-            </a:pPr>
-            <a:r>
-              <a:rPr lang="en-US" sz="1400" dirty="0">
+          <p:cNvPr id="8" name="Text 5"/>
+          <p:cNvSpPr/>
+          <p:nvPr/>
+        </p:nvSpPr>
+        <p:spPr>
+          <a:xfrm>
+            <a:off x="731520" y="4297680"/>
+            <a:ext cx="7315200" cy="1371600"/>
+          </a:xfrm>
+          <a:prstGeom prst="rect">
+            <a:avLst/>
+          </a:prstGeom>
+          <a:noFill/>
+          <a:ln/>
+        </p:spPr>
+        <p:txBody>
+          <a:bodyPr wrap="square" rtlCol="0" anchor="ctr"/>
+          <a:lstStyle/>
+          <a:p>
+            <a:pPr indent="0" marL="0">
+              <a:buNone/>
+            </a:pPr>
+            <a:r>
+              <a:rPr lang="en-US" sz="1200" dirty="0">
                 <a:solidFill>
                   <a:srgbClr val="6B6560"/>
                 </a:solidFill>
@@ -2521,16 +2585,28 @@
                 <a:ea typeface="Aeonik" pitchFamily="34" charset="-122"/>
                 <a:cs typeface="Aeonik" pitchFamily="34" charset="-120"/>
               </a:rPr>
-              <a:t>Presenter: Phyoe Sat Paing</a:t>
-            </a:r>
-            <a:endParaRPr lang="en-US" sz="1400" dirty="0"/>
-          </a:p>
-          <a:p>
-            <a:pPr indent="0" marL="0">
-              <a:buNone/>
-            </a:pPr>
-            <a:r>
-              <a:rPr lang="en-US" sz="1400" dirty="0">
+              <a:t>Presenter: </a:t>
+            </a:r>
+            <a:pPr indent="0" marL="0">
+              <a:buNone/>
+            </a:pPr>
+            <a:r>
+              <a:rPr lang="en-US" sz="1200" b="1" dirty="0">
+                <a:solidFill>
+                  <a:srgbClr val="1A1714"/>
+                </a:solidFill>
+                <a:latin typeface="Aeonik" pitchFamily="34" charset="0"/>
+                <a:ea typeface="Aeonik" pitchFamily="34" charset="-122"/>
+                <a:cs typeface="Aeonik" pitchFamily="34" charset="-120"/>
+              </a:rPr>
+              <a:t>Phyoe Sat Paing (ID: 6821711420061)
+</a:t>
+            </a:r>
+            <a:pPr indent="0" marL="0">
+              <a:buNone/>
+            </a:pPr>
+            <a:r>
+              <a:rPr lang="en-US" sz="1200" dirty="0">
                 <a:solidFill>
                   <a:srgbClr val="6B6560"/>
                 </a:solidFill>
@@ -2538,9 +2614,52 @@
                 <a:ea typeface="Aeonik" pitchFamily="34" charset="-122"/>
                 <a:cs typeface="Aeonik" pitchFamily="34" charset="-120"/>
               </a:rPr>
-              <a:t>Boardroom Strategic Briefing</a:t>
-            </a:r>
-            <a:endParaRPr lang="en-US" sz="1400" dirty="0"/>
+              <a:t>Course: </a:t>
+            </a:r>
+            <a:pPr indent="0" marL="0">
+              <a:buNone/>
+            </a:pPr>
+            <a:r>
+              <a:rPr lang="en-US" sz="1200" b="1" dirty="0">
+                <a:solidFill>
+                  <a:srgbClr val="1A1714"/>
+                </a:solidFill>
+                <a:latin typeface="Aeonik" pitchFamily="34" charset="0"/>
+                <a:ea typeface="Aeonik" pitchFamily="34" charset="-122"/>
+                <a:cs typeface="Aeonik" pitchFamily="34" charset="-120"/>
+              </a:rPr>
+              <a:t>501105, logistics and supply chain management
+</a:t>
+            </a:r>
+            <a:pPr indent="0" marL="0">
+              <a:buNone/>
+            </a:pPr>
+            <a:r>
+              <a:rPr lang="en-US" sz="1200" dirty="0">
+                <a:solidFill>
+                  <a:srgbClr val="6B6560"/>
+                </a:solidFill>
+                <a:latin typeface="Aeonik" pitchFamily="34" charset="0"/>
+                <a:ea typeface="Aeonik" pitchFamily="34" charset="-122"/>
+                <a:cs typeface="Aeonik" pitchFamily="34" charset="-120"/>
+              </a:rPr>
+              <a:t>Date: </a:t>
+            </a:r>
+            <a:pPr indent="0" marL="0">
+              <a:buNone/>
+            </a:pPr>
+            <a:r>
+              <a:rPr lang="en-US" sz="1200" b="1" dirty="0">
+                <a:solidFill>
+                  <a:srgbClr val="1A1714"/>
+                </a:solidFill>
+                <a:latin typeface="Aeonik" pitchFamily="34" charset="0"/>
+                <a:ea typeface="Aeonik" pitchFamily="34" charset="-122"/>
+                <a:cs typeface="Aeonik" pitchFamily="34" charset="-120"/>
+              </a:rPr>
+              <a:t>June 2026</a:t>
+            </a:r>
+            <a:endParaRPr lang="en-US" sz="1200" dirty="0"/>
           </a:p>
         </p:txBody>
       </p:sp>
@@ -2933,23 +3052,23 @@
         <p:spPr>
           <a:xfrm>
             <a:off x="6583680" y="3291840"/>
-            <a:ext cx="4663440" cy="1371600"/>
-          </a:xfrm>
-          <a:prstGeom prst="rect">
-            <a:avLst/>
-          </a:prstGeom>
-          <a:noFill/>
-          <a:ln/>
-        </p:spPr>
-        <p:txBody>
-          <a:bodyPr wrap="square" rtlCol="0" anchor="ctr"/>
-          <a:lstStyle/>
-          <a:p>
-            <a:pPr indent="0" marL="0">
-              <a:buNone/>
-            </a:pPr>
-            <a:r>
-              <a:rPr lang="en-US" sz="1800" dirty="0">
+            <a:ext cx="4663440" cy="1554480"/>
+          </a:xfrm>
+          <a:prstGeom prst="rect">
+            <a:avLst/>
+          </a:prstGeom>
+          <a:noFill/>
+          <a:ln/>
+        </p:spPr>
+        <p:txBody>
+          <a:bodyPr wrap="square" rtlCol="0" anchor="ctr"/>
+          <a:lstStyle/>
+          <a:p>
+            <a:pPr indent="0" marL="0">
+              <a:buNone/>
+            </a:pPr>
+            <a:r>
+              <a:rPr lang="en-US" sz="1500" dirty="0">
                 <a:solidFill>
                   <a:srgbClr val="6B6560"/>
                 </a:solidFill>
@@ -2957,9 +3076,9 @@
                 <a:ea typeface="Aeonik" pitchFamily="34" charset="-122"/>
                 <a:cs typeface="Aeonik" pitchFamily="34" charset="-120"/>
               </a:rPr>
-              <a:t>Mining the 'urban mine'—recovering rare earth elements from old electronics to reduce dependency on volatile mining regions.</a:t>
-            </a:r>
-            <a:endParaRPr lang="en-US" sz="1800" dirty="0"/>
+              <a:t>Transitioning to industrial e-waste harvesting to extract high-purity minerals. Recovering up to 99% of Copper, 98% of Gold, and 95% of Silicon substrates from decommissioned hardware to buffer raw mining volatility.</a:t>
+            </a:r>
+            <a:endParaRPr lang="en-US" sz="1500" dirty="0"/>
           </a:p>
         </p:txBody>
       </p:sp>
@@ -3092,7 +3211,7 @@
                 <a:ea typeface="Aeonik" pitchFamily="34" charset="-122"/>
                 <a:cs typeface="Aeonik" pitchFamily="34" charset="-120"/>
               </a:rPr>
-              <a:t>PART 3: END-USER INDUSTRIES &amp; APPLICATION ECOSYSTEM</a:t>
+              <a:t>PART 3: DOWNSTREAM END-USER INDUSTRIES &amp; APPLICATION ECOSYSTEM</a:t>
             </a:r>
             <a:endParaRPr lang="en-US" sz="1200" dirty="0"/>
           </a:p>
@@ -3363,8 +3482,8 @@
         </p:nvSpPr>
         <p:spPr>
           <a:xfrm>
-            <a:off x="7680960" y="2011680"/>
-            <a:ext cx="3840480" cy="365760"/>
+            <a:off x="7863840" y="1645920"/>
+            <a:ext cx="3474720" cy="548640"/>
           </a:xfrm>
           <a:prstGeom prst="rect">
             <a:avLst/>
@@ -3380,7 +3499,7 @@
               <a:buNone/>
             </a:pPr>
             <a:r>
-              <a:rPr lang="en-US" sz="1200" b="1" dirty="0">
+              <a:rPr lang="en-US" sz="1500" b="1" dirty="0">
                 <a:solidFill>
                   <a:srgbClr val="9E7D84"/>
                 </a:solidFill>
@@ -3388,9 +3507,9 @@
                 <a:ea typeface="Aeonik" pitchFamily="34" charset="-122"/>
                 <a:cs typeface="Aeonik" pitchFamily="34" charset="-120"/>
               </a:rPr>
-              <a:t>KEY METRIC</a:t>
-            </a:r>
-            <a:endParaRPr lang="en-US" sz="1200" dirty="0"/>
+              <a:t>SILICON INTENSITY INDEX</a:t>
+            </a:r>
+            <a:endParaRPr lang="en-US" sz="1500" dirty="0"/>
           </a:p>
         </p:txBody>
       </p:sp>
@@ -3402,80 +3521,81 @@
         </p:nvSpPr>
         <p:spPr>
           <a:xfrm>
-            <a:off x="7680960" y="2560320"/>
-            <a:ext cx="3840480" cy="1097280"/>
-          </a:xfrm>
-          <a:prstGeom prst="rect">
-            <a:avLst/>
-          </a:prstGeom>
-          <a:noFill/>
-          <a:ln/>
-        </p:spPr>
-        <p:txBody>
-          <a:bodyPr wrap="square" rtlCol="0" anchor="ctr"/>
-          <a:lstStyle/>
-          <a:p>
-            <a:pPr algn="ctr" indent="0" marL="0">
-              <a:buNone/>
-            </a:pPr>
-            <a:r>
-              <a:rPr lang="en-US" sz="3600" b="1" dirty="0">
+            <a:off x="7863840" y="2377440"/>
+            <a:ext cx="3474720" cy="3291840"/>
+          </a:xfrm>
+          <a:prstGeom prst="rect">
+            <a:avLst/>
+          </a:prstGeom>
+          <a:noFill/>
+          <a:ln/>
+        </p:spPr>
+        <p:txBody>
+          <a:bodyPr wrap="square" rtlCol="0" anchor="ctr"/>
+          <a:lstStyle/>
+          <a:p>
+            <a:pPr algn="l" indent="0" marL="0">
+              <a:buNone/>
+            </a:pPr>
+            <a:r>
+              <a:rPr lang="en-US" sz="1300" dirty="0">
+                <a:solidFill>
+                  <a:srgbClr val="6B6560"/>
+                </a:solidFill>
+                <a:latin typeface="Aeonik" pitchFamily="34" charset="0"/>
+                <a:ea typeface="Aeonik" pitchFamily="34" charset="-122"/>
+                <a:cs typeface="Aeonik" pitchFamily="34" charset="-120"/>
+              </a:rPr>
+              <a:t>Defined as </a:t>
+            </a:r>
+            <a:pPr algn="l" indent="0" marL="0">
+              <a:buNone/>
+            </a:pPr>
+            <a:r>
+              <a:rPr lang="en-US" sz="1300" b="1" dirty="0">
                 <a:solidFill>
                   <a:srgbClr val="1A1714"/>
                 </a:solidFill>
-                <a:latin typeface="PP Mondwest" pitchFamily="34" charset="0"/>
-                <a:ea typeface="PP Mondwest" pitchFamily="34" charset="-122"/>
-                <a:cs typeface="PP Mondwest" pitchFamily="34" charset="-120"/>
-              </a:rPr>
-              <a:t>Silicon</a:t>
-            </a:r>
-            <a:endParaRPr lang="en-US" sz="3600" dirty="0"/>
-          </a:p>
-          <a:p>
-            <a:pPr algn="ctr" indent="0" marL="0">
-              <a:buNone/>
-            </a:pPr>
-            <a:r>
-              <a:rPr lang="en-US" sz="3600" b="1" dirty="0">
+                <a:latin typeface="Aeonik" pitchFamily="34" charset="0"/>
+                <a:ea typeface="Aeonik" pitchFamily="34" charset="-122"/>
+                <a:cs typeface="Aeonik" pitchFamily="34" charset="-120"/>
+              </a:rPr>
+              <a:t>the total monetary value of silicon content embedded per finished product unit</a:t>
+            </a:r>
+            <a:pPr algn="l" indent="0" marL="0">
+              <a:buNone/>
+            </a:pPr>
+            <a:r>
+              <a:rPr lang="en-US" sz="1300" dirty="0">
+                <a:solidFill>
+                  <a:srgbClr val="6B6560"/>
+                </a:solidFill>
+                <a:latin typeface="Aeonik" pitchFamily="34" charset="0"/>
+                <a:ea typeface="Aeonik" pitchFamily="34" charset="-122"/>
+                <a:cs typeface="Aeonik" pitchFamily="34" charset="-120"/>
+              </a:rPr>
+              <a:t>. This index is the primary metric tracking how deeply semiconductors add value to downstream hardware.
+</a:t>
+            </a:r>
+            <a:pPr algn="l" indent="0" marL="0">
+              <a:buNone/>
+            </a:pPr>
+            <a:r>
+              <a:rPr lang="en-US" sz="1100" b="1" dirty="0">
                 <a:solidFill>
                   <a:srgbClr val="1A1714"/>
                 </a:solidFill>
-                <a:latin typeface="PP Mondwest" pitchFamily="34" charset="0"/>
-                <a:ea typeface="PP Mondwest" pitchFamily="34" charset="-122"/>
-                <a:cs typeface="PP Mondwest" pitchFamily="34" charset="-120"/>
-              </a:rPr>
-              <a:t>Intensity</a:t>
-            </a:r>
-            <a:endParaRPr lang="en-US" sz="3600" dirty="0"/>
-          </a:p>
-        </p:txBody>
-      </p:sp>
-      <p:sp>
-        <p:nvSpPr>
-          <p:cNvPr id="12" name="Text 9"/>
-          <p:cNvSpPr/>
-          <p:nvPr/>
-        </p:nvSpPr>
-        <p:spPr>
-          <a:xfrm>
-            <a:off x="7680960" y="3840480"/>
-            <a:ext cx="3840480" cy="731520"/>
-          </a:xfrm>
-          <a:prstGeom prst="rect">
-            <a:avLst/>
-          </a:prstGeom>
-          <a:noFill/>
-          <a:ln/>
-        </p:spPr>
-        <p:txBody>
-          <a:bodyPr wrap="square" rtlCol="0" anchor="ctr"/>
-          <a:lstStyle/>
-          <a:p>
-            <a:pPr algn="ctr" indent="0" marL="0">
-              <a:buNone/>
-            </a:pPr>
-            <a:r>
-              <a:rPr lang="en-US" sz="1500" dirty="0">
+                <a:latin typeface="Aeonik" pitchFamily="34" charset="0"/>
+                <a:ea typeface="Aeonik" pitchFamily="34" charset="-122"/>
+                <a:cs typeface="Aeonik" pitchFamily="34" charset="-120"/>
+              </a:rPr>
+              <a:t>Value Metric: </a:t>
+            </a:r>
+            <a:pPr algn="l" indent="0" marL="0">
+              <a:buNone/>
+            </a:pPr>
+            <a:r>
+              <a:rPr lang="en-US" sz="1100" i="1" dirty="0">
                 <a:solidFill>
                   <a:srgbClr val="6B6560"/>
                 </a:solidFill>
@@ -3483,9 +3603,9 @@
                 <a:ea typeface="Aeonik" pitchFamily="34" charset="-122"/>
                 <a:cs typeface="Aeonik" pitchFamily="34" charset="-120"/>
               </a:rPr>
-              <a:t>Primary industrial competitiveness index</a:t>
-            </a:r>
-            <a:endParaRPr lang="en-US" sz="1500" dirty="0"/>
+              <a:t>Measures semiconductor reliance across all downstream products.</a:t>
+            </a:r>
+            <a:endParaRPr lang="en-US" sz="1300" dirty="0"/>
           </a:p>
         </p:txBody>
       </p:sp>
@@ -3554,7 +3674,7 @@
                 <a:ea typeface="Aeonik" pitchFamily="34" charset="-122"/>
                 <a:cs typeface="Aeonik" pitchFamily="34" charset="-120"/>
               </a:rPr>
-              <a:t>PART 3: END-USER INDUSTRIES &amp; APPLICATION ECOSYSTEM</a:t>
+              <a:t>PART 3: DOWNSTREAM END-USER INDUSTRIES &amp; APPLICATION ECOSYSTEM</a:t>
             </a:r>
             <a:endParaRPr lang="en-US" sz="1200" dirty="0"/>
           </a:p>
@@ -3704,14 +3824,131 @@
       </p:sp>
       <p:sp>
         <p:nvSpPr>
-          <p:cNvPr id="8" name="Shape 5"/>
+          <p:cNvPr id="8" name="Text 5"/>
+          <p:cNvSpPr/>
+          <p:nvPr/>
+        </p:nvSpPr>
+        <p:spPr>
+          <a:xfrm>
+            <a:off x="731520" y="2194560"/>
+            <a:ext cx="2286000" cy="274320"/>
+          </a:xfrm>
+          <a:prstGeom prst="rect">
+            <a:avLst/>
+          </a:prstGeom>
+          <a:noFill/>
+          <a:ln/>
+        </p:spPr>
+        <p:txBody>
+          <a:bodyPr wrap="square" rtlCol="0" anchor="ctr"/>
+          <a:lstStyle/>
+          <a:p>
+            <a:pPr indent="0" marL="0">
+              <a:buNone/>
+            </a:pPr>
+            <a:r>
+              <a:rPr lang="en-US" sz="1000" b="1" dirty="0">
+                <a:solidFill>
+                  <a:srgbClr val="6B6560"/>
+                </a:solidFill>
+                <a:latin typeface="Aeonik" pitchFamily="34" charset="0"/>
+                <a:ea typeface="Aeonik" pitchFamily="34" charset="-122"/>
+                <a:cs typeface="Aeonik" pitchFamily="34" charset="-120"/>
+              </a:rPr>
+              <a:t>INDUSTRY SEGMENT</a:t>
+            </a:r>
+            <a:endParaRPr lang="en-US" sz="1000" dirty="0"/>
+          </a:p>
+        </p:txBody>
+      </p:sp>
+      <p:sp>
+        <p:nvSpPr>
+          <p:cNvPr id="9" name="Text 6"/>
+          <p:cNvSpPr/>
+          <p:nvPr/>
+        </p:nvSpPr>
+        <p:spPr>
+          <a:xfrm>
+            <a:off x="3200400" y="2194560"/>
+            <a:ext cx="3200400" cy="274320"/>
+          </a:xfrm>
+          <a:prstGeom prst="rect">
+            <a:avLst/>
+          </a:prstGeom>
+          <a:noFill/>
+          <a:ln/>
+        </p:spPr>
+        <p:txBody>
+          <a:bodyPr wrap="square" rtlCol="0" anchor="ctr"/>
+          <a:lstStyle/>
+          <a:p>
+            <a:pPr indent="0" marL="0">
+              <a:buNone/>
+            </a:pPr>
+            <a:r>
+              <a:rPr lang="en-US" sz="1000" b="1" dirty="0">
+                <a:solidFill>
+                  <a:srgbClr val="6B6560"/>
+                </a:solidFill>
+                <a:latin typeface="Aeonik" pitchFamily="34" charset="0"/>
+                <a:ea typeface="Aeonik" pitchFamily="34" charset="-122"/>
+                <a:cs typeface="Aeonik" pitchFamily="34" charset="-120"/>
+              </a:rPr>
+              <a:t>GROWTH SPEED &amp; STATUS</a:t>
+            </a:r>
+            <a:endParaRPr lang="en-US" sz="1000" dirty="0"/>
+          </a:p>
+        </p:txBody>
+      </p:sp>
+      <p:sp>
+        <p:nvSpPr>
+          <p:cNvPr id="10" name="Text 7"/>
+          <p:cNvSpPr/>
+          <p:nvPr/>
+        </p:nvSpPr>
+        <p:spPr>
+          <a:xfrm>
+            <a:off x="6583680" y="2194560"/>
+            <a:ext cx="4754880" cy="274320"/>
+          </a:xfrm>
+          <a:prstGeom prst="rect">
+            <a:avLst/>
+          </a:prstGeom>
+          <a:noFill/>
+          <a:ln/>
+        </p:spPr>
+        <p:txBody>
+          <a:bodyPr wrap="square" rtlCol="0" anchor="ctr"/>
+          <a:lstStyle/>
+          <a:p>
+            <a:pPr indent="0" marL="0">
+              <a:buNone/>
+            </a:pPr>
+            <a:r>
+              <a:rPr lang="en-US" sz="1000" b="1" dirty="0">
+                <a:solidFill>
+                  <a:srgbClr val="6B6560"/>
+                </a:solidFill>
+                <a:latin typeface="Aeonik" pitchFamily="34" charset="0"/>
+                <a:ea typeface="Aeonik" pitchFamily="34" charset="-122"/>
+                <a:cs typeface="Aeonik" pitchFamily="34" charset="-120"/>
+              </a:rPr>
+              <a:t>SOURCING &amp; TECHNOLOGY FOCUS</a:t>
+            </a:r>
+            <a:endParaRPr lang="en-US" sz="1000" dirty="0"/>
+          </a:p>
+        </p:txBody>
+      </p:sp>
+      <p:sp>
+        <p:nvSpPr>
+          <p:cNvPr id="11" name="Shape 8"/>
           <p:cNvSpPr/>
           <p:nvPr/>
         </p:nvSpPr>
         <p:spPr>
           <a:xfrm>
             <a:off x="548640" y="2560320"/>
-            <a:ext cx="3291840" cy="3474720"/>
+            <a:ext cx="10972800" cy="1005840"/>
           </a:xfrm>
           <a:prstGeom prst="rect">
             <a:avLst/>
@@ -3729,69 +3966,83 @@
       </p:sp>
       <p:sp>
         <p:nvSpPr>
-          <p:cNvPr id="9" name="Text 6"/>
-          <p:cNvSpPr/>
-          <p:nvPr/>
-        </p:nvSpPr>
-        <p:spPr>
-          <a:xfrm>
-            <a:off x="822960" y="2834640"/>
-            <a:ext cx="2743200" cy="457200"/>
-          </a:xfrm>
-          <a:prstGeom prst="rect">
-            <a:avLst/>
-          </a:prstGeom>
-          <a:noFill/>
-          <a:ln/>
-        </p:spPr>
-        <p:txBody>
-          <a:bodyPr wrap="square" rtlCol="0" anchor="ctr"/>
-          <a:lstStyle/>
-          <a:p>
-            <a:pPr indent="0" marL="0">
-              <a:buNone/>
-            </a:pPr>
-            <a:r>
-              <a:rPr lang="en-US" sz="2000" b="1" dirty="0">
+          <p:cNvPr id="12" name="Text 9"/>
+          <p:cNvSpPr/>
+          <p:nvPr/>
+        </p:nvSpPr>
+        <p:spPr>
+          <a:xfrm>
+            <a:off x="731520" y="2834640"/>
+            <a:ext cx="2286000" cy="457200"/>
+          </a:xfrm>
+          <a:prstGeom prst="rect">
+            <a:avLst/>
+          </a:prstGeom>
+          <a:noFill/>
+          <a:ln/>
+        </p:spPr>
+        <p:txBody>
+          <a:bodyPr wrap="square" rtlCol="0" anchor="ctr"/>
+          <a:lstStyle/>
+          <a:p>
+            <a:pPr indent="0" marL="0">
+              <a:buNone/>
+            </a:pPr>
+            <a:r>
+              <a:rPr lang="en-US" sz="1600" b="1" dirty="0">
                 <a:solidFill>
                   <a:srgbClr val="B84A2F"/>
                 </a:solidFill>
-                <a:latin typeface="PP Mondwest" pitchFamily="34" charset="0"/>
-                <a:ea typeface="PP Mondwest" pitchFamily="34" charset="-122"/>
-                <a:cs typeface="PP Mondwest" pitchFamily="34" charset="-120"/>
+                <a:latin typeface="Aeonik" pitchFamily="34" charset="0"/>
+                <a:ea typeface="Aeonik" pitchFamily="34" charset="-122"/>
+                <a:cs typeface="Aeonik" pitchFamily="34" charset="-120"/>
               </a:rPr>
               <a:t>AI Datacenters</a:t>
             </a:r>
-            <a:endParaRPr lang="en-US" sz="2000" dirty="0"/>
-          </a:p>
-        </p:txBody>
-      </p:sp>
-      <p:sp>
-        <p:nvSpPr>
-          <p:cNvPr id="10" name="Text 7"/>
-          <p:cNvSpPr/>
-          <p:nvPr/>
-        </p:nvSpPr>
-        <p:spPr>
-          <a:xfrm>
-            <a:off x="822960" y="3474720"/>
-            <a:ext cx="2743200" cy="2286000"/>
-          </a:xfrm>
-          <a:prstGeom prst="rect">
-            <a:avLst/>
-          </a:prstGeom>
-          <a:noFill/>
-          <a:ln/>
-        </p:spPr>
-        <p:txBody>
-          <a:bodyPr wrap="square" rtlCol="0" anchor="ctr"/>
-          <a:lstStyle/>
-          <a:p>
-            <a:pPr indent="0" marL="0">
-              <a:buNone/>
-            </a:pPr>
-            <a:r>
-              <a:rPr lang="en-US" sz="1800" dirty="0">
+            <a:endParaRPr lang="en-US" sz="1600" dirty="0"/>
+          </a:p>
+        </p:txBody>
+      </p:sp>
+      <p:sp>
+        <p:nvSpPr>
+          <p:cNvPr id="13" name="Text 10"/>
+          <p:cNvSpPr/>
+          <p:nvPr/>
+        </p:nvSpPr>
+        <p:spPr>
+          <a:xfrm>
+            <a:off x="3200400" y="2834640"/>
+            <a:ext cx="3017520" cy="457200"/>
+          </a:xfrm>
+          <a:prstGeom prst="rect">
+            <a:avLst/>
+          </a:prstGeom>
+          <a:noFill/>
+          <a:ln/>
+        </p:spPr>
+        <p:txBody>
+          <a:bodyPr wrap="square" rtlCol="0" anchor="ctr"/>
+          <a:lstStyle/>
+          <a:p>
+            <a:pPr indent="0" marL="0">
+              <a:buNone/>
+            </a:pPr>
+            <a:r>
+              <a:rPr lang="en-US" sz="1300" b="1" dirty="0">
+                <a:solidFill>
+                  <a:srgbClr val="1A1714"/>
+                </a:solidFill>
+                <a:latin typeface="Aeonik" pitchFamily="34" charset="0"/>
+                <a:ea typeface="Aeonik" pitchFamily="34" charset="-122"/>
+                <a:cs typeface="Aeonik" pitchFamily="34" charset="-120"/>
+              </a:rPr>
+              <a:t>50% CAGR</a:t>
+            </a:r>
+            <a:pPr indent="0" marL="0">
+              <a:buNone/>
+            </a:pPr>
+            <a:r>
+              <a:rPr lang="en-US" sz="1300" dirty="0">
                 <a:solidFill>
                   <a:srgbClr val="6B6560"/>
                 </a:solidFill>
@@ -3799,22 +4050,61 @@
                 <a:ea typeface="Aeonik" pitchFamily="34" charset="-122"/>
                 <a:cs typeface="Aeonik" pitchFamily="34" charset="-120"/>
               </a:rPr>
-              <a:t>Nearly 50% of semiconductor industry growth and revenue is driven by high-performance AI accelerators.</a:t>
-            </a:r>
-            <a:endParaRPr lang="en-US" sz="1800" dirty="0"/>
-          </a:p>
-        </p:txBody>
-      </p:sp>
-      <p:sp>
-        <p:nvSpPr>
-          <p:cNvPr id="11" name="Shape 8"/>
-          <p:cNvSpPr/>
-          <p:nvPr/>
-        </p:nvSpPr>
-        <p:spPr>
-          <a:xfrm>
-            <a:off x="4389120" y="2560320"/>
-            <a:ext cx="3291840" cy="3474720"/>
+              <a:t> (Exponential Value Growth)</a:t>
+            </a:r>
+            <a:endParaRPr lang="en-US" sz="1300" dirty="0"/>
+          </a:p>
+        </p:txBody>
+      </p:sp>
+      <p:sp>
+        <p:nvSpPr>
+          <p:cNvPr id="14" name="Text 11"/>
+          <p:cNvSpPr/>
+          <p:nvPr/>
+        </p:nvSpPr>
+        <p:spPr>
+          <a:xfrm>
+            <a:off x="6583680" y="2743200"/>
+            <a:ext cx="4754880" cy="640080"/>
+          </a:xfrm>
+          <a:prstGeom prst="rect">
+            <a:avLst/>
+          </a:prstGeom>
+          <a:noFill/>
+          <a:ln/>
+        </p:spPr>
+        <p:txBody>
+          <a:bodyPr wrap="square" rtlCol="0" anchor="ctr"/>
+          <a:lstStyle/>
+          <a:p>
+            <a:pPr indent="0" marL="0">
+              <a:buNone/>
+            </a:pPr>
+            <a:r>
+              <a:rPr lang="en-US" sz="1300" dirty="0">
+                <a:solidFill>
+                  <a:srgbClr val="6B6560"/>
+                </a:solidFill>
+                <a:latin typeface="Aeonik" pitchFamily="34" charset="0"/>
+                <a:ea typeface="Aeonik" pitchFamily="34" charset="-122"/>
+                <a:cs typeface="Aeonik" pitchFamily="34" charset="-120"/>
+              </a:rPr>
+              <a:t>GPUs, HBM (High Bandwidth Memory), advanced optical links, sub-3nm allocations.</a:t>
+            </a:r>
+            <a:endParaRPr lang="en-US" sz="1300" dirty="0"/>
+          </a:p>
+        </p:txBody>
+      </p:sp>
+      <p:sp>
+        <p:nvSpPr>
+          <p:cNvPr id="15" name="Shape 12"/>
+          <p:cNvSpPr/>
+          <p:nvPr/>
+        </p:nvSpPr>
+        <p:spPr>
+          <a:xfrm>
+            <a:off x="548640" y="3749040"/>
+            <a:ext cx="10972800" cy="1005840"/>
           </a:xfrm>
           <a:prstGeom prst="rect">
             <a:avLst/>
@@ -3832,69 +4122,83 @@
       </p:sp>
       <p:sp>
         <p:nvSpPr>
-          <p:cNvPr id="12" name="Text 9"/>
-          <p:cNvSpPr/>
-          <p:nvPr/>
-        </p:nvSpPr>
-        <p:spPr>
-          <a:xfrm>
-            <a:off x="4663440" y="2834640"/>
-            <a:ext cx="2743200" cy="457200"/>
-          </a:xfrm>
-          <a:prstGeom prst="rect">
-            <a:avLst/>
-          </a:prstGeom>
-          <a:noFill/>
-          <a:ln/>
-        </p:spPr>
-        <p:txBody>
-          <a:bodyPr wrap="square" rtlCol="0" anchor="ctr"/>
-          <a:lstStyle/>
-          <a:p>
-            <a:pPr indent="0" marL="0">
-              <a:buNone/>
-            </a:pPr>
-            <a:r>
-              <a:rPr lang="en-US" sz="2000" b="1" dirty="0">
+          <p:cNvPr id="16" name="Text 13"/>
+          <p:cNvSpPr/>
+          <p:nvPr/>
+        </p:nvSpPr>
+        <p:spPr>
+          <a:xfrm>
+            <a:off x="731520" y="4023360"/>
+            <a:ext cx="2286000" cy="457200"/>
+          </a:xfrm>
+          <a:prstGeom prst="rect">
+            <a:avLst/>
+          </a:prstGeom>
+          <a:noFill/>
+          <a:ln/>
+        </p:spPr>
+        <p:txBody>
+          <a:bodyPr wrap="square" rtlCol="0" anchor="ctr"/>
+          <a:lstStyle/>
+          <a:p>
+            <a:pPr indent="0" marL="0">
+              <a:buNone/>
+            </a:pPr>
+            <a:r>
+              <a:rPr lang="en-US" sz="1600" b="1" dirty="0">
                 <a:solidFill>
                   <a:srgbClr val="9E7D84"/>
                 </a:solidFill>
-                <a:latin typeface="PP Mondwest" pitchFamily="34" charset="0"/>
-                <a:ea typeface="PP Mondwest" pitchFamily="34" charset="-122"/>
-                <a:cs typeface="PP Mondwest" pitchFamily="34" charset="-120"/>
+                <a:latin typeface="Aeonik" pitchFamily="34" charset="0"/>
+                <a:ea typeface="Aeonik" pitchFamily="34" charset="-122"/>
+                <a:cs typeface="Aeonik" pitchFamily="34" charset="-120"/>
               </a:rPr>
               <a:t>Automotive</a:t>
             </a:r>
-            <a:endParaRPr lang="en-US" sz="2000" dirty="0"/>
-          </a:p>
-        </p:txBody>
-      </p:sp>
-      <p:sp>
-        <p:nvSpPr>
-          <p:cNvPr id="13" name="Text 10"/>
-          <p:cNvSpPr/>
-          <p:nvPr/>
-        </p:nvSpPr>
-        <p:spPr>
-          <a:xfrm>
-            <a:off x="4663440" y="3474720"/>
-            <a:ext cx="2743200" cy="2286000"/>
-          </a:xfrm>
-          <a:prstGeom prst="rect">
-            <a:avLst/>
-          </a:prstGeom>
-          <a:noFill/>
-          <a:ln/>
-        </p:spPr>
-        <p:txBody>
-          <a:bodyPr wrap="square" rtlCol="0" anchor="ctr"/>
-          <a:lstStyle/>
-          <a:p>
-            <a:pPr indent="0" marL="0">
-              <a:buNone/>
-            </a:pPr>
-            <a:r>
-              <a:rPr lang="en-US" sz="1800" dirty="0">
+            <a:endParaRPr lang="en-US" sz="1600" dirty="0"/>
+          </a:p>
+        </p:txBody>
+      </p:sp>
+      <p:sp>
+        <p:nvSpPr>
+          <p:cNvPr id="17" name="Text 14"/>
+          <p:cNvSpPr/>
+          <p:nvPr/>
+        </p:nvSpPr>
+        <p:spPr>
+          <a:xfrm>
+            <a:off x="3200400" y="4023360"/>
+            <a:ext cx="3017520" cy="457200"/>
+          </a:xfrm>
+          <a:prstGeom prst="rect">
+            <a:avLst/>
+          </a:prstGeom>
+          <a:noFill/>
+          <a:ln/>
+        </p:spPr>
+        <p:txBody>
+          <a:bodyPr wrap="square" rtlCol="0" anchor="ctr"/>
+          <a:lstStyle/>
+          <a:p>
+            <a:pPr indent="0" marL="0">
+              <a:buNone/>
+            </a:pPr>
+            <a:r>
+              <a:rPr lang="en-US" sz="1300" b="1" dirty="0">
+                <a:solidFill>
+                  <a:srgbClr val="1A1714"/>
+                </a:solidFill>
+                <a:latin typeface="Aeonik" pitchFamily="34" charset="0"/>
+                <a:ea typeface="Aeonik" pitchFamily="34" charset="-122"/>
+                <a:cs typeface="Aeonik" pitchFamily="34" charset="-120"/>
+              </a:rPr>
+              <a:t>Fastest Volume Growth</a:t>
+            </a:r>
+            <a:pPr indent="0" marL="0">
+              <a:buNone/>
+            </a:pPr>
+            <a:r>
+              <a:rPr lang="en-US" sz="1300" dirty="0">
                 <a:solidFill>
                   <a:srgbClr val="6B6560"/>
                 </a:solidFill>
@@ -3902,22 +4206,61 @@
                 <a:ea typeface="Aeonik" pitchFamily="34" charset="-122"/>
                 <a:cs typeface="Aeonik" pitchFamily="34" charset="-120"/>
               </a:rPr>
-              <a:t>The fastest growing volume segment, requiring massive numbers of legacy control nodes and SiC power chips.</a:t>
-            </a:r>
-            <a:endParaRPr lang="en-US" sz="1800" dirty="0"/>
-          </a:p>
-        </p:txBody>
-      </p:sp>
-      <p:sp>
-        <p:nvSpPr>
-          <p:cNvPr id="14" name="Shape 11"/>
-          <p:cNvSpPr/>
-          <p:nvPr/>
-        </p:nvSpPr>
-        <p:spPr>
-          <a:xfrm>
-            <a:off x="8229600" y="2560320"/>
-            <a:ext cx="3291840" cy="3474720"/>
+              <a:t> (High Intensity scaling)</a:t>
+            </a:r>
+            <a:endParaRPr lang="en-US" sz="1300" dirty="0"/>
+          </a:p>
+        </p:txBody>
+      </p:sp>
+      <p:sp>
+        <p:nvSpPr>
+          <p:cNvPr id="18" name="Text 15"/>
+          <p:cNvSpPr/>
+          <p:nvPr/>
+        </p:nvSpPr>
+        <p:spPr>
+          <a:xfrm>
+            <a:off x="6583680" y="3931920"/>
+            <a:ext cx="4754880" cy="640080"/>
+          </a:xfrm>
+          <a:prstGeom prst="rect">
+            <a:avLst/>
+          </a:prstGeom>
+          <a:noFill/>
+          <a:ln/>
+        </p:spPr>
+        <p:txBody>
+          <a:bodyPr wrap="square" rtlCol="0" anchor="ctr"/>
+          <a:lstStyle/>
+          <a:p>
+            <a:pPr indent="0" marL="0">
+              <a:buNone/>
+            </a:pPr>
+            <a:r>
+              <a:rPr lang="en-US" sz="1300" dirty="0">
+                <a:solidFill>
+                  <a:srgbClr val="6B6560"/>
+                </a:solidFill>
+                <a:latin typeface="Aeonik" pitchFamily="34" charset="0"/>
+                <a:ea typeface="Aeonik" pitchFamily="34" charset="-122"/>
+                <a:cs typeface="Aeonik" pitchFamily="34" charset="-120"/>
+              </a:rPr>
+              <a:t>ADAS logic, Lidar, Silicon Carbide (SiC) power logic, 28nm+ legacy microcontrollers.</a:t>
+            </a:r>
+            <a:endParaRPr lang="en-US" sz="1300" dirty="0"/>
+          </a:p>
+        </p:txBody>
+      </p:sp>
+      <p:sp>
+        <p:nvSpPr>
+          <p:cNvPr id="19" name="Shape 16"/>
+          <p:cNvSpPr/>
+          <p:nvPr/>
+        </p:nvSpPr>
+        <p:spPr>
+          <a:xfrm>
+            <a:off x="548640" y="4937760"/>
+            <a:ext cx="10972800" cy="1005840"/>
           </a:xfrm>
           <a:prstGeom prst="rect">
             <a:avLst/>
@@ -3935,69 +4278,83 @@
       </p:sp>
       <p:sp>
         <p:nvSpPr>
-          <p:cNvPr id="15" name="Text 12"/>
-          <p:cNvSpPr/>
-          <p:nvPr/>
-        </p:nvSpPr>
-        <p:spPr>
-          <a:xfrm>
-            <a:off x="8503920" y="2834640"/>
-            <a:ext cx="2743200" cy="457200"/>
-          </a:xfrm>
-          <a:prstGeom prst="rect">
-            <a:avLst/>
-          </a:prstGeom>
-          <a:noFill/>
-          <a:ln/>
-        </p:spPr>
-        <p:txBody>
-          <a:bodyPr wrap="square" rtlCol="0" anchor="ctr"/>
-          <a:lstStyle/>
-          <a:p>
-            <a:pPr indent="0" marL="0">
-              <a:buNone/>
-            </a:pPr>
-            <a:r>
-              <a:rPr lang="en-US" sz="2000" b="1" dirty="0">
+          <p:cNvPr id="20" name="Text 17"/>
+          <p:cNvSpPr/>
+          <p:nvPr/>
+        </p:nvSpPr>
+        <p:spPr>
+          <a:xfrm>
+            <a:off x="731520" y="5212080"/>
+            <a:ext cx="2286000" cy="457200"/>
+          </a:xfrm>
+          <a:prstGeom prst="rect">
+            <a:avLst/>
+          </a:prstGeom>
+          <a:noFill/>
+          <a:ln/>
+        </p:spPr>
+        <p:txBody>
+          <a:bodyPr wrap="square" rtlCol="0" anchor="ctr"/>
+          <a:lstStyle/>
+          <a:p>
+            <a:pPr indent="0" marL="0">
+              <a:buNone/>
+            </a:pPr>
+            <a:r>
+              <a:rPr lang="en-US" sz="1600" b="1" dirty="0">
                 <a:solidFill>
                   <a:srgbClr val="768C7C"/>
                 </a:solidFill>
-                <a:latin typeface="PP Mondwest" pitchFamily="34" charset="0"/>
-                <a:ea typeface="PP Mondwest" pitchFamily="34" charset="-122"/>
-                <a:cs typeface="PP Mondwest" pitchFamily="34" charset="-120"/>
+                <a:latin typeface="Aeonik" pitchFamily="34" charset="0"/>
+                <a:ea typeface="Aeonik" pitchFamily="34" charset="-122"/>
+                <a:cs typeface="Aeonik" pitchFamily="34" charset="-120"/>
               </a:rPr>
               <a:t>Smartphones &amp; PCs</a:t>
             </a:r>
-            <a:endParaRPr lang="en-US" sz="2000" dirty="0"/>
-          </a:p>
-        </p:txBody>
-      </p:sp>
-      <p:sp>
-        <p:nvSpPr>
-          <p:cNvPr id="16" name="Text 13"/>
-          <p:cNvSpPr/>
-          <p:nvPr/>
-        </p:nvSpPr>
-        <p:spPr>
-          <a:xfrm>
-            <a:off x="8503920" y="3474720"/>
-            <a:ext cx="2743200" cy="2286000"/>
-          </a:xfrm>
-          <a:prstGeom prst="rect">
-            <a:avLst/>
-          </a:prstGeom>
-          <a:noFill/>
-          <a:ln/>
-        </p:spPr>
-        <p:txBody>
-          <a:bodyPr wrap="square" rtlCol="0" anchor="ctr"/>
-          <a:lstStyle/>
-          <a:p>
-            <a:pPr indent="0" marL="0">
-              <a:buNone/>
-            </a:pPr>
-            <a:r>
-              <a:rPr lang="en-US" sz="1800" dirty="0">
+            <a:endParaRPr lang="en-US" sz="1600" dirty="0"/>
+          </a:p>
+        </p:txBody>
+      </p:sp>
+      <p:sp>
+        <p:nvSpPr>
+          <p:cNvPr id="21" name="Text 18"/>
+          <p:cNvSpPr/>
+          <p:nvPr/>
+        </p:nvSpPr>
+        <p:spPr>
+          <a:xfrm>
+            <a:off x="3200400" y="5212080"/>
+            <a:ext cx="3017520" cy="457200"/>
+          </a:xfrm>
+          <a:prstGeom prst="rect">
+            <a:avLst/>
+          </a:prstGeom>
+          <a:noFill/>
+          <a:ln/>
+        </p:spPr>
+        <p:txBody>
+          <a:bodyPr wrap="square" rtlCol="0" anchor="ctr"/>
+          <a:lstStyle/>
+          <a:p>
+            <a:pPr indent="0" marL="0">
+              <a:buNone/>
+            </a:pPr>
+            <a:r>
+              <a:rPr lang="en-US" sz="1300" b="1" dirty="0">
+                <a:solidFill>
+                  <a:srgbClr val="1A1714"/>
+                </a:solidFill>
+                <a:latin typeface="Aeonik" pitchFamily="34" charset="0"/>
+                <a:ea typeface="Aeonik" pitchFamily="34" charset="-122"/>
+                <a:cs typeface="Aeonik" pitchFamily="34" charset="-120"/>
+              </a:rPr>
+              <a:t>Volume Saturation</a:t>
+            </a:r>
+            <a:pPr indent="0" marL="0">
+              <a:buNone/>
+            </a:pPr>
+            <a:r>
+              <a:rPr lang="en-US" sz="1300" dirty="0">
                 <a:solidFill>
                   <a:srgbClr val="6B6560"/>
                 </a:solidFill>
@@ -4005,9 +4362,48 @@
                 <a:ea typeface="Aeonik" pitchFamily="34" charset="-122"/>
                 <a:cs typeface="Aeonik" pitchFamily="34" charset="-120"/>
               </a:rPr>
-              <a:t>Traditional core segments face volume saturation, driving consolidation and focus on specialized edge accelerators.</a:t>
-            </a:r>
-            <a:endParaRPr lang="en-US" sz="1800" dirty="0"/>
+              <a:t> (Flat/Steady volume growth)</a:t>
+            </a:r>
+            <a:endParaRPr lang="en-US" sz="1300" dirty="0"/>
+          </a:p>
+        </p:txBody>
+      </p:sp>
+      <p:sp>
+        <p:nvSpPr>
+          <p:cNvPr id="22" name="Text 19"/>
+          <p:cNvSpPr/>
+          <p:nvPr/>
+        </p:nvSpPr>
+        <p:spPr>
+          <a:xfrm>
+            <a:off x="6583680" y="5120640"/>
+            <a:ext cx="4754880" cy="640080"/>
+          </a:xfrm>
+          <a:prstGeom prst="rect">
+            <a:avLst/>
+          </a:prstGeom>
+          <a:noFill/>
+          <a:ln/>
+        </p:spPr>
+        <p:txBody>
+          <a:bodyPr wrap="square" rtlCol="0" anchor="ctr"/>
+          <a:lstStyle/>
+          <a:p>
+            <a:pPr indent="0" marL="0">
+              <a:buNone/>
+            </a:pPr>
+            <a:r>
+              <a:rPr lang="en-US" sz="1300" dirty="0">
+                <a:solidFill>
+                  <a:srgbClr val="6B6560"/>
+                </a:solidFill>
+                <a:latin typeface="Aeonik" pitchFamily="34" charset="0"/>
+                <a:ea typeface="Aeonik" pitchFamily="34" charset="-122"/>
+                <a:cs typeface="Aeonik" pitchFamily="34" charset="-120"/>
+              </a:rPr>
+              <a:t>Edge-AI acceleration NPUs, standard application processors, memory, sensor logic.</a:t>
+            </a:r>
+            <a:endParaRPr lang="en-US" sz="1300" dirty="0"/>
           </a:p>
         </p:txBody>
       </p:sp>
@@ -4076,7 +4472,7 @@
                 <a:ea typeface="Aeonik" pitchFamily="34" charset="-122"/>
                 <a:cs typeface="Aeonik" pitchFamily="34" charset="-120"/>
               </a:rPr>
-              <a:t>PART 3: END-USER INDUSTRIES &amp; APPLICATION ECOSYSTEM</a:t>
+              <a:t>PART 3: DOWNSTREAM END-USER INDUSTRIES &amp; APPLICATION ECOSYSTEM</a:t>
             </a:r>
             <a:endParaRPr lang="en-US" sz="1200" dirty="0"/>
           </a:p>
@@ -4258,7 +4654,7 @@
                 <a:ea typeface="Aeonik" pitchFamily="34" charset="-122"/>
                 <a:cs typeface="Aeonik" pitchFamily="34" charset="-120"/>
               </a:rPr>
-              <a:t>- Accelerator Market ($500B): Generative models and neural computing demand massive scaling of TPU and GPU nodes.</a:t>
+              <a:t>- Accelerator Market ($500B+): Generative models and neural computing demand massive scaling of TPU and GPU nodes.</a:t>
             </a:r>
             <a:endParaRPr lang="en-US" sz="1800" dirty="0"/>
           </a:p>
@@ -4372,7 +4768,7 @@
                 <a:ea typeface="Aeonik" pitchFamily="34" charset="-122"/>
                 <a:cs typeface="Aeonik" pitchFamily="34" charset="-120"/>
               </a:rPr>
-              <a:t>ANALYST PROJECT</a:t>
+              <a:t>CONSENSUS FORECAST</a:t>
             </a:r>
             <a:endParaRPr lang="en-US" sz="1200" dirty="0"/>
           </a:p>
@@ -4411,7 +4807,7 @@
                 <a:ea typeface="PP Mondwest" pitchFamily="34" charset="-122"/>
                 <a:cs typeface="PP Mondwest" pitchFamily="34" charset="-120"/>
               </a:rPr>
-              <a:t>$500B</a:t>
+              <a:t>$500B+</a:t>
             </a:r>
             <a:endParaRPr lang="en-US" sz="5400" dirty="0"/>
           </a:p>
@@ -4425,8 +4821,8 @@
         </p:nvSpPr>
         <p:spPr>
           <a:xfrm>
-            <a:off x="7680960" y="3840480"/>
-            <a:ext cx="3840480" cy="731520"/>
+            <a:off x="7772400" y="3840480"/>
+            <a:ext cx="3657600" cy="731520"/>
           </a:xfrm>
           <a:prstGeom prst="rect">
             <a:avLst/>
@@ -4442,7 +4838,7 @@
               <a:buNone/>
             </a:pPr>
             <a:r>
-              <a:rPr lang="en-US" sz="1500" dirty="0">
+              <a:rPr lang="en-US" sz="1400" b="1" dirty="0">
                 <a:solidFill>
                   <a:srgbClr val="6B6560"/>
                 </a:solidFill>
@@ -4450,9 +4846,9 @@
                 <a:ea typeface="Aeonik" pitchFamily="34" charset="-122"/>
                 <a:cs typeface="Aeonik" pitchFamily="34" charset="-120"/>
               </a:rPr>
-              <a:t>AI Accelerator market size by 2026</a:t>
-            </a:r>
-            <a:endParaRPr lang="en-US" sz="1500" dirty="0"/>
+              <a:t>AI Accelerator Market Projected Size by 2026</a:t>
+            </a:r>
+            <a:endParaRPr lang="en-US" sz="1400" dirty="0"/>
           </a:p>
         </p:txBody>
       </p:sp>
@@ -4521,7 +4917,7 @@
                 <a:ea typeface="Aeonik" pitchFamily="34" charset="-122"/>
                 <a:cs typeface="Aeonik" pitchFamily="34" charset="-120"/>
               </a:rPr>
-              <a:t>PART 3: END-USER INDUSTRIES &amp; APPLICATION ECOSYSTEM</a:t>
+              <a:t>PART 3: DOWNSTREAM END-USER INDUSTRIES &amp; APPLICATION ECOSYSTEM</a:t>
             </a:r>
             <a:endParaRPr lang="en-US" sz="1200" dirty="0"/>
           </a:p>
@@ -4817,7 +5213,7 @@
                 <a:ea typeface="Aeonik" pitchFamily="34" charset="-122"/>
                 <a:cs typeface="Aeonik" pitchFamily="34" charset="-120"/>
               </a:rPr>
-              <a:t>ESTIMATE</a:t>
+              <a:t>EV CONTENT GROWTH</a:t>
             </a:r>
             <a:endParaRPr lang="en-US" sz="1200" dirty="0"/>
           </a:p>
@@ -4870,8 +5266,8 @@
         </p:nvSpPr>
         <p:spPr>
           <a:xfrm>
-            <a:off x="7680960" y="3840480"/>
-            <a:ext cx="3840480" cy="731520"/>
+            <a:off x="7772400" y="3840480"/>
+            <a:ext cx="3657600" cy="731520"/>
           </a:xfrm>
           <a:prstGeom prst="rect">
             <a:avLst/>
@@ -4887,7 +5283,7 @@
               <a:buNone/>
             </a:pPr>
             <a:r>
-              <a:rPr lang="en-US" sz="1500" dirty="0">
+              <a:rPr lang="en-US" sz="1400" b="1" dirty="0">
                 <a:solidFill>
                   <a:srgbClr val="6B6560"/>
                 </a:solidFill>
@@ -4895,9 +5291,9 @@
                 <a:ea typeface="Aeonik" pitchFamily="34" charset="-122"/>
                 <a:cs typeface="Aeonik" pitchFamily="34" charset="-120"/>
               </a:rPr>
-              <a:t>Silicon value content per EV unit</a:t>
-            </a:r>
-            <a:endParaRPr lang="en-US" sz="1500" dirty="0"/>
+              <a:t>$1,000+ semiconductor content per EV unit</a:t>
+            </a:r>
+            <a:endParaRPr lang="en-US" sz="1400" dirty="0"/>
           </a:p>
         </p:txBody>
       </p:sp>
@@ -4966,7 +5362,7 @@
                 <a:ea typeface="Aeonik" pitchFamily="34" charset="-122"/>
                 <a:cs typeface="Aeonik" pitchFamily="34" charset="-120"/>
               </a:rPr>
-              <a:t>PART 3: END-USER INDUSTRIES &amp; APPLICATION ECOSYSTEM</a:t>
+              <a:t>PART 3: DOWNSTREAM END-USER INDUSTRIES &amp; APPLICATION ECOSYSTEM</a:t>
             </a:r>
             <a:endParaRPr lang="en-US" sz="1200" dirty="0"/>
           </a:p>
@@ -5385,7 +5781,7 @@
                 <a:ea typeface="Aeonik" pitchFamily="34" charset="-122"/>
                 <a:cs typeface="Aeonik" pitchFamily="34" charset="-120"/>
               </a:rPr>
-              <a:t>PART 3: END-USER INDUSTRIES &amp; APPLICATION ECOSYSTEM</a:t>
+              <a:t>PART 3: DOWNSTREAM END-USER INDUSTRIES &amp; APPLICATION ECOSYSTEM</a:t>
             </a:r>
             <a:endParaRPr lang="en-US" sz="1200" dirty="0"/>
           </a:p>
@@ -6320,7 +6716,7 @@
                 <a:ea typeface="Aeonik" pitchFamily="34" charset="-122"/>
                 <a:cs typeface="Aeonik" pitchFamily="34" charset="-120"/>
               </a:rPr>
-              <a:t>Industries</a:t>
+              <a:t>Downstream End-User Industries</a:t>
             </a:r>
             <a:endParaRPr lang="en-US" sz="1300" dirty="0"/>
           </a:p>
@@ -6592,23 +6988,23 @@
         <p:spPr>
           <a:xfrm>
             <a:off x="731520" y="4389120"/>
-            <a:ext cx="4572000" cy="731520"/>
-          </a:xfrm>
-          <a:prstGeom prst="rect">
-            <a:avLst/>
-          </a:prstGeom>
-          <a:noFill/>
-          <a:ln/>
-        </p:spPr>
-        <p:txBody>
-          <a:bodyPr wrap="square" rtlCol="0" anchor="ctr"/>
-          <a:lstStyle/>
-          <a:p>
-            <a:pPr indent="0" marL="0">
-              <a:buNone/>
-            </a:pPr>
-            <a:r>
-              <a:rPr lang="en-US" sz="1400" dirty="0">
+            <a:ext cx="4572000" cy="1097280"/>
+          </a:xfrm>
+          <a:prstGeom prst="rect">
+            <a:avLst/>
+          </a:prstGeom>
+          <a:noFill/>
+          <a:ln/>
+        </p:spPr>
+        <p:txBody>
+          <a:bodyPr wrap="square" rtlCol="0" anchor="ctr"/>
+          <a:lstStyle/>
+          <a:p>
+            <a:pPr indent="0" marL="0">
+              <a:buNone/>
+            </a:pPr>
+            <a:r>
+              <a:rPr lang="en-US" sz="1200" dirty="0">
                 <a:solidFill>
                   <a:srgbClr val="6B6560"/>
                 </a:solidFill>
@@ -6616,16 +7012,16 @@
                 <a:ea typeface="Aeonik" pitchFamily="34" charset="-122"/>
                 <a:cs typeface="Aeonik" pitchFamily="34" charset="-120"/>
               </a:rPr>
-              <a:t>Presenter: Phyoe Sat Paing</a:t>
-            </a:r>
-            <a:endParaRPr lang="en-US" sz="1400" dirty="0"/>
-          </a:p>
-          <a:p>
-            <a:pPr indent="0" marL="0">
-              <a:buNone/>
-            </a:pPr>
-            <a:r>
-              <a:rPr lang="en-US" sz="1400" dirty="0">
+              <a:t>Presenter: Phyoe Sat Paing (ID: 6821711420061)</a:t>
+            </a:r>
+            <a:endParaRPr lang="en-US" sz="1200" dirty="0"/>
+          </a:p>
+          <a:p>
+            <a:pPr indent="0" marL="0">
+              <a:buNone/>
+            </a:pPr>
+            <a:r>
+              <a:rPr lang="en-US" sz="1200" dirty="0">
                 <a:solidFill>
                   <a:srgbClr val="6B6560"/>
                 </a:solidFill>
@@ -6633,9 +7029,26 @@
                 <a:ea typeface="Aeonik" pitchFamily="34" charset="-122"/>
                 <a:cs typeface="Aeonik" pitchFamily="34" charset="-120"/>
               </a:rPr>
-              <a:t>Boardroom Strategic Briefing</a:t>
-            </a:r>
-            <a:endParaRPr lang="en-US" sz="1400" dirty="0"/>
+              <a:t>Course: 501105, logistics and supply chain management</a:t>
+            </a:r>
+            <a:endParaRPr lang="en-US" sz="1200" dirty="0"/>
+          </a:p>
+          <a:p>
+            <a:pPr indent="0" marL="0">
+              <a:buNone/>
+            </a:pPr>
+            <a:r>
+              <a:rPr lang="en-US" sz="1200" dirty="0">
+                <a:solidFill>
+                  <a:srgbClr val="6B6560"/>
+                </a:solidFill>
+                <a:latin typeface="Aeonik" pitchFamily="34" charset="0"/>
+                <a:ea typeface="Aeonik" pitchFamily="34" charset="-122"/>
+                <a:cs typeface="Aeonik" pitchFamily="34" charset="-120"/>
+              </a:rPr>
+              <a:t>Date: June 2026</a:t>
+            </a:r>
+            <a:endParaRPr lang="en-US" sz="1200" dirty="0"/>
           </a:p>
         </p:txBody>
       </p:sp>
@@ -7391,7 +7804,7 @@
               <a:buChar char="•"/>
             </a:pPr>
             <a:r>
-              <a:rPr lang="en-US" sz="1800" dirty="0">
+              <a:rPr lang="en-US" sz="1600" dirty="0">
                 <a:solidFill>
                   <a:srgbClr val="6B6560"/>
                 </a:solidFill>
@@ -7401,14 +7814,14 @@
               </a:rPr>
               <a:t>- Record-High Valuations: Growth is driven by explosive global demand for AI systems and electric vehicle power logic.</a:t>
             </a:r>
-            <a:endParaRPr lang="en-US" sz="1800" dirty="0"/>
+            <a:endParaRPr lang="en-US" sz="1600" dirty="0"/>
           </a:p>
           <a:p>
             <a:pPr marL="342900" indent="-342900">
               <a:buSzPct val="100000"/>
               <a:buChar char="•"/>
             </a:pPr>
-            <a:endParaRPr lang="en-US" sz="1800" dirty="0"/>
+            <a:endParaRPr lang="en-US" sz="1600" dirty="0"/>
           </a:p>
           <a:p>
             <a:pPr marL="342900" indent="-342900">
@@ -7416,7 +7829,7 @@
               <a:buChar char="•"/>
             </a:pPr>
             <a:r>
-              <a:rPr lang="en-US" sz="1800" dirty="0">
+              <a:rPr lang="en-US" sz="1600" dirty="0">
                 <a:solidFill>
                   <a:srgbClr val="6B6560"/>
                 </a:solidFill>
@@ -7424,16 +7837,16 @@
                 <a:ea typeface="Aeonik" pitchFamily="34" charset="-122"/>
                 <a:cs typeface="Aeonik" pitchFamily="34" charset="-120"/>
               </a:rPr>
-              <a:t>- Systemic Fragility: Leading-edge fabs operate near maximum capacity, leaving the industry vulnerable to minor material delays.</a:t>
-            </a:r>
-            <a:endParaRPr lang="en-US" sz="1800" dirty="0"/>
+              <a:t>- Systemic Fragility &amp; Node Allocation: Leading-edge fabrication is a massive chokepoint where global availability of advanced computing rests entirely on sub-3nm allocations. The concentration of Extreme Ultraviolet (EUV) lithography capacity leaves the industry vulnerable to minor material delays.</a:t>
+            </a:r>
+            <a:endParaRPr lang="en-US" sz="1600" dirty="0"/>
           </a:p>
           <a:p>
             <a:pPr marL="342900" indent="-342900">
               <a:buSzPct val="100000"/>
               <a:buChar char="•"/>
             </a:pPr>
-            <a:endParaRPr lang="en-US" sz="1800" dirty="0"/>
+            <a:endParaRPr lang="en-US" sz="1600" dirty="0"/>
           </a:p>
           <a:p>
             <a:pPr marL="342900" indent="-342900">
@@ -7441,7 +7854,7 @@
               <a:buChar char="•"/>
             </a:pPr>
             <a:r>
-              <a:rPr lang="en-US" sz="1800" dirty="0">
+              <a:rPr lang="en-US" sz="1600" dirty="0">
                 <a:solidFill>
                   <a:srgbClr val="6B6560"/>
                 </a:solidFill>
@@ -7451,7 +7864,7 @@
               </a:rPr>
               <a:t>- Strategic Pivot: Sourcing HBM (High Bandwidth Memory) and advanced logic requires a shift from transactional purchasing to capacity reservation models.</a:t>
             </a:r>
-            <a:endParaRPr lang="en-US" sz="1800" dirty="0"/>
+            <a:endParaRPr lang="en-US" sz="1600" dirty="0"/>
           </a:p>
         </p:txBody>
       </p:sp>
@@ -7899,24 +8312,24 @@
         </p:nvSpPr>
         <p:spPr>
           <a:xfrm>
-            <a:off x="822960" y="3474720"/>
-            <a:ext cx="4663440" cy="2194560"/>
-          </a:xfrm>
-          <a:prstGeom prst="rect">
-            <a:avLst/>
-          </a:prstGeom>
-          <a:noFill/>
-          <a:ln/>
-        </p:spPr>
-        <p:txBody>
-          <a:bodyPr wrap="square" rtlCol="0" anchor="ctr"/>
-          <a:lstStyle/>
-          <a:p>
-            <a:pPr indent="0" marL="0">
-              <a:buNone/>
-            </a:pPr>
-            <a:r>
-              <a:rPr lang="en-US" sz="1800" dirty="0">
+            <a:off x="822960" y="3383280"/>
+            <a:ext cx="4663440" cy="2377440"/>
+          </a:xfrm>
+          <a:prstGeom prst="rect">
+            <a:avLst/>
+          </a:prstGeom>
+          <a:noFill/>
+          <a:ln/>
+        </p:spPr>
+        <p:txBody>
+          <a:bodyPr wrap="square" rtlCol="0" anchor="ctr"/>
+          <a:lstStyle/>
+          <a:p>
+            <a:pPr indent="0" marL="0">
+              <a:buNone/>
+            </a:pPr>
+            <a:r>
+              <a:rPr lang="en-US" sz="1500" dirty="0">
                 <a:solidFill>
                   <a:srgbClr val="6B6560"/>
                 </a:solidFill>
@@ -7924,9 +8337,9 @@
                 <a:ea typeface="Aeonik" pitchFamily="34" charset="-122"/>
                 <a:cs typeface="Aeonik" pitchFamily="34" charset="-120"/>
               </a:rPr>
-              <a:t>Used for standardized legacy passive elements and commoditized logic chips. Minimizes capital lock-up and inventory holding costs while keeping storage footprint low.</a:t>
-            </a:r>
-            <a:endParaRPr lang="en-US" sz="1800" dirty="0"/>
+              <a:t>Used for standardized legacy passive elements and commoditized logic chips. Minimizes capital lock-up and inventory holding costs. However, global supply shocks exposed severe operational risks in pure JIT models, including zero safety buffers, sudden factory halts, supplier insolvency, and shipping delays.</a:t>
+            </a:r>
+            <a:endParaRPr lang="en-US" sz="1500" dirty="0"/>
           </a:p>
         </p:txBody>
       </p:sp>
@@ -8002,24 +8415,24 @@
         </p:nvSpPr>
         <p:spPr>
           <a:xfrm>
-            <a:off x="6583680" y="3474720"/>
-            <a:ext cx="4663440" cy="2194560"/>
-          </a:xfrm>
-          <a:prstGeom prst="rect">
-            <a:avLst/>
-          </a:prstGeom>
-          <a:noFill/>
-          <a:ln/>
-        </p:spPr>
-        <p:txBody>
-          <a:bodyPr wrap="square" rtlCol="0" anchor="ctr"/>
-          <a:lstStyle/>
-          <a:p>
-            <a:pPr indent="0" marL="0">
-              <a:buNone/>
-            </a:pPr>
-            <a:r>
-              <a:rPr lang="en-US" sz="1800" dirty="0">
+            <a:off x="6583680" y="3383280"/>
+            <a:ext cx="4663440" cy="2377440"/>
+          </a:xfrm>
+          <a:prstGeom prst="rect">
+            <a:avLst/>
+          </a:prstGeom>
+          <a:noFill/>
+          <a:ln/>
+        </p:spPr>
+        <p:txBody>
+          <a:bodyPr wrap="square" rtlCol="0" anchor="ctr"/>
+          <a:lstStyle/>
+          <a:p>
+            <a:pPr indent="0" marL="0">
+              <a:buNone/>
+            </a:pPr>
+            <a:r>
+              <a:rPr lang="en-US" sz="1500" dirty="0">
                 <a:solidFill>
                   <a:srgbClr val="6B6560"/>
                 </a:solidFill>
@@ -8029,7 +8442,7 @@
               </a:rPr>
               <a:t>Maintaining 3 to 6 months of safety stock for sole-sourced, high-margin microcomponents (HBM, custom GPUs) to guarantee manufacturing continuity.</a:t>
             </a:r>
-            <a:endParaRPr lang="en-US" sz="1800" dirty="0"/>
+            <a:endParaRPr lang="en-US" sz="1500" dirty="0"/>
           </a:p>
         </p:txBody>
       </p:sp>
@@ -8369,24 +8782,63 @@
         </p:nvSpPr>
         <p:spPr>
           <a:xfrm>
-            <a:off x="7863840" y="1554480"/>
-            <a:ext cx="3474720" cy="1737360"/>
-          </a:xfrm>
-          <a:prstGeom prst="rect">
-            <a:avLst/>
-          </a:prstGeom>
-          <a:noFill/>
-          <a:ln/>
-        </p:spPr>
-        <p:txBody>
-          <a:bodyPr wrap="square" rtlCol="0" anchor="ctr"/>
-          <a:lstStyle/>
-          <a:p>
-            <a:pPr indent="0" marL="0">
-              <a:buNone/>
-            </a:pPr>
-            <a:r>
-              <a:rPr lang="en-US" sz="1600" dirty="0">
+            <a:off x="7863840" y="1463040"/>
+            <a:ext cx="3474720" cy="274320"/>
+          </a:xfrm>
+          <a:prstGeom prst="rect">
+            <a:avLst/>
+          </a:prstGeom>
+          <a:noFill/>
+          <a:ln/>
+        </p:spPr>
+        <p:txBody>
+          <a:bodyPr wrap="square" rtlCol="0" anchor="ctr"/>
+          <a:lstStyle/>
+          <a:p>
+            <a:pPr indent="0" marL="0">
+              <a:buNone/>
+            </a:pPr>
+            <a:r>
+              <a:rPr lang="en-US" sz="1200" b="1" dirty="0">
+                <a:solidFill>
+                  <a:srgbClr val="768C7C"/>
+                </a:solidFill>
+                <a:latin typeface="Aeonik" pitchFamily="34" charset="0"/>
+                <a:ea typeface="Aeonik" pitchFamily="34" charset="-122"/>
+                <a:cs typeface="Aeonik" pitchFamily="34" charset="-120"/>
+              </a:rPr>
+              <a:t>LEADING-EDGE NODES (SUB-7NM)</a:t>
+            </a:r>
+            <a:endParaRPr lang="en-US" sz="1200" dirty="0"/>
+          </a:p>
+        </p:txBody>
+      </p:sp>
+      <p:sp>
+        <p:nvSpPr>
+          <p:cNvPr id="11" name="Text 8"/>
+          <p:cNvSpPr/>
+          <p:nvPr/>
+        </p:nvSpPr>
+        <p:spPr>
+          <a:xfrm>
+            <a:off x="7863840" y="1783080"/>
+            <a:ext cx="3474720" cy="1600200"/>
+          </a:xfrm>
+          <a:prstGeom prst="rect">
+            <a:avLst/>
+          </a:prstGeom>
+          <a:noFill/>
+          <a:ln/>
+        </p:spPr>
+        <p:txBody>
+          <a:bodyPr wrap="square" rtlCol="0" anchor="ctr"/>
+          <a:lstStyle/>
+          <a:p>
+            <a:pPr indent="0" marL="0">
+              <a:buNone/>
+            </a:pPr>
+            <a:r>
+              <a:rPr lang="en-US" sz="1300" dirty="0">
                 <a:solidFill>
                   <a:srgbClr val="6B6560"/>
                 </a:solidFill>
@@ -8394,38 +8846,15 @@
                 <a:ea typeface="Aeonik" pitchFamily="34" charset="-122"/>
                 <a:cs typeface="Aeonik" pitchFamily="34" charset="-120"/>
               </a:rPr>
-              <a:t>Leading-Edge Nodes</a:t>
-            </a:r>
-            <a:endParaRPr lang="en-US" sz="1600" dirty="0"/>
-          </a:p>
-          <a:p>
-            <a:pPr indent="0" marL="0">
-              <a:buNone/>
-            </a:pPr>
-            <a:endParaRPr lang="en-US" sz="1600" dirty="0"/>
-          </a:p>
-          <a:p>
-            <a:pPr indent="0" marL="0">
-              <a:buNone/>
-            </a:pPr>
-            <a:r>
-              <a:rPr lang="en-US" sz="1600" dirty="0">
-                <a:solidFill>
-                  <a:srgbClr val="6B6560"/>
-                </a:solidFill>
-                <a:latin typeface="Aeonik" pitchFamily="34" charset="0"/>
-                <a:ea typeface="Aeonik" pitchFamily="34" charset="-122"/>
-                <a:cs typeface="Aeonik" pitchFamily="34" charset="-120"/>
-              </a:rPr>
-              <a:t>Focus: Deep alliances, R&amp;D partnerships, capacity reservations.</a:t>
-            </a:r>
-            <a:endParaRPr lang="en-US" sz="1600" dirty="0"/>
-          </a:p>
-        </p:txBody>
-      </p:sp>
-      <p:sp>
-        <p:nvSpPr>
-          <p:cNvPr id="11" name="Shape 8"/>
+              <a:t>Focus: Secure allocation in sub-7nm alliances, multi-billion capacity reservation fees (LTAs), and joint R&amp;D partnerships.</a:t>
+            </a:r>
+            <a:endParaRPr lang="en-US" sz="1300" dirty="0"/>
+          </a:p>
+        </p:txBody>
+      </p:sp>
+      <p:sp>
+        <p:nvSpPr>
+          <p:cNvPr id="12" name="Shape 9"/>
           <p:cNvSpPr/>
           <p:nvPr/>
         </p:nvSpPr>
@@ -8450,30 +8879,69 @@
       </p:sp>
       <p:sp>
         <p:nvSpPr>
-          <p:cNvPr id="12" name="Text 9"/>
-          <p:cNvSpPr/>
-          <p:nvPr/>
-        </p:nvSpPr>
-        <p:spPr>
-          <a:xfrm>
-            <a:off x="7863840" y="4023360"/>
-            <a:ext cx="3474720" cy="1737360"/>
-          </a:xfrm>
-          <a:prstGeom prst="rect">
-            <a:avLst/>
-          </a:prstGeom>
-          <a:noFill/>
-          <a:ln/>
-        </p:spPr>
-        <p:txBody>
-          <a:bodyPr wrap="square" rtlCol="0" anchor="ctr"/>
-          <a:lstStyle/>
-          <a:p>
-            <a:pPr indent="0" marL="0">
-              <a:buNone/>
-            </a:pPr>
-            <a:r>
-              <a:rPr lang="en-US" sz="1600" dirty="0">
+          <p:cNvPr id="13" name="Text 10"/>
+          <p:cNvSpPr/>
+          <p:nvPr/>
+        </p:nvSpPr>
+        <p:spPr>
+          <a:xfrm>
+            <a:off x="7863840" y="3931920"/>
+            <a:ext cx="3474720" cy="274320"/>
+          </a:xfrm>
+          <a:prstGeom prst="rect">
+            <a:avLst/>
+          </a:prstGeom>
+          <a:noFill/>
+          <a:ln/>
+        </p:spPr>
+        <p:txBody>
+          <a:bodyPr wrap="square" rtlCol="0" anchor="ctr"/>
+          <a:lstStyle/>
+          <a:p>
+            <a:pPr indent="0" marL="0">
+              <a:buNone/>
+            </a:pPr>
+            <a:r>
+              <a:rPr lang="en-US" sz="1200" b="1" dirty="0">
+                <a:solidFill>
+                  <a:srgbClr val="B08E66"/>
+                </a:solidFill>
+                <a:latin typeface="Aeonik" pitchFamily="34" charset="0"/>
+                <a:ea typeface="Aeonik" pitchFamily="34" charset="-122"/>
+                <a:cs typeface="Aeonik" pitchFamily="34" charset="-120"/>
+              </a:rPr>
+              <a:t>LEGACY NODES (28NM+)</a:t>
+            </a:r>
+            <a:endParaRPr lang="en-US" sz="1200" dirty="0"/>
+          </a:p>
+        </p:txBody>
+      </p:sp>
+      <p:sp>
+        <p:nvSpPr>
+          <p:cNvPr id="14" name="Text 11"/>
+          <p:cNvSpPr/>
+          <p:nvPr/>
+        </p:nvSpPr>
+        <p:spPr>
+          <a:xfrm>
+            <a:off x="7863840" y="4251960"/>
+            <a:ext cx="3474720" cy="1600200"/>
+          </a:xfrm>
+          <a:prstGeom prst="rect">
+            <a:avLst/>
+          </a:prstGeom>
+          <a:noFill/>
+          <a:ln/>
+        </p:spPr>
+        <p:txBody>
+          <a:bodyPr wrap="square" rtlCol="0" anchor="ctr"/>
+          <a:lstStyle/>
+          <a:p>
+            <a:pPr indent="0" marL="0">
+              <a:buNone/>
+            </a:pPr>
+            <a:r>
+              <a:rPr lang="en-US" sz="1300" dirty="0">
                 <a:solidFill>
                   <a:srgbClr val="6B6560"/>
                 </a:solidFill>
@@ -8481,32 +8949,9 @@
                 <a:ea typeface="Aeonik" pitchFamily="34" charset="-122"/>
                 <a:cs typeface="Aeonik" pitchFamily="34" charset="-120"/>
               </a:rPr>
-              <a:t>Legacy Nodes</a:t>
-            </a:r>
-            <a:endParaRPr lang="en-US" sz="1600" dirty="0"/>
-          </a:p>
-          <a:p>
-            <a:pPr indent="0" marL="0">
-              <a:buNone/>
-            </a:pPr>
-            <a:endParaRPr lang="en-US" sz="1600" dirty="0"/>
-          </a:p>
-          <a:p>
-            <a:pPr indent="0" marL="0">
-              <a:buNone/>
-            </a:pPr>
-            <a:r>
-              <a:rPr lang="en-US" sz="1600" dirty="0">
-                <a:solidFill>
-                  <a:srgbClr val="6B6560"/>
-                </a:solidFill>
-                <a:latin typeface="Aeonik" pitchFamily="34" charset="0"/>
-                <a:ea typeface="Aeonik" pitchFamily="34" charset="-122"/>
-                <a:cs typeface="Aeonik" pitchFamily="34" charset="-120"/>
-              </a:rPr>
-              <a:t>Focus: Multi-sourcing, distributor networks, life-cycle tracking.</a:t>
-            </a:r>
-            <a:endParaRPr lang="en-US" sz="1600" dirty="0"/>
+              <a:t>Focus: Broad multi-sourcing, alternate distributor qualification, spot buy strategies, and lifecycle obsolescence tracking.</a:t>
+            </a:r>
+            <a:endParaRPr lang="en-US" sz="1300" dirty="0"/>
           </a:p>
         </p:txBody>
       </p:sp>
@@ -8962,24 +9407,38 @@
         </p:nvSpPr>
         <p:spPr>
           <a:xfrm>
-            <a:off x="731520" y="5303520"/>
-            <a:ext cx="10607040" cy="640080"/>
-          </a:xfrm>
-          <a:prstGeom prst="rect">
-            <a:avLst/>
-          </a:prstGeom>
-          <a:noFill/>
-          <a:ln/>
-        </p:spPr>
-        <p:txBody>
-          <a:bodyPr wrap="square" rtlCol="0" anchor="ctr"/>
-          <a:lstStyle/>
-          <a:p>
-            <a:pPr indent="0" marL="0">
-              <a:buNone/>
-            </a:pPr>
-            <a:r>
-              <a:rPr lang="en-US" sz="1500" dirty="0">
+            <a:off x="731520" y="5257800"/>
+            <a:ext cx="10607040" cy="731520"/>
+          </a:xfrm>
+          <a:prstGeom prst="rect">
+            <a:avLst/>
+          </a:prstGeom>
+          <a:noFill/>
+          <a:ln/>
+        </p:spPr>
+        <p:txBody>
+          <a:bodyPr wrap="square" rtlCol="0" anchor="ctr"/>
+          <a:lstStyle/>
+          <a:p>
+            <a:pPr indent="0" marL="0">
+              <a:buNone/>
+            </a:pPr>
+            <a:r>
+              <a:rPr lang="en-US" sz="1300" b="1" dirty="0">
+                <a:solidFill>
+                  <a:srgbClr val="1A1714"/>
+                </a:solidFill>
+                <a:latin typeface="Aeonik" pitchFamily="34" charset="0"/>
+                <a:ea typeface="Aeonik" pitchFamily="34" charset="-122"/>
+                <a:cs typeface="Aeonik" pitchFamily="34" charset="-120"/>
+              </a:rPr>
+              <a:t>AI Business Intelligence Cockpits: </a:t>
+            </a:r>
+            <a:pPr indent="0" marL="0">
+              <a:buNone/>
+            </a:pPr>
+            <a:r>
+              <a:rPr lang="en-US" sz="1300" dirty="0">
                 <a:solidFill>
                   <a:srgbClr val="6B6560"/>
                 </a:solidFill>
@@ -8987,9 +9446,9 @@
                 <a:ea typeface="Aeonik" pitchFamily="34" charset="-122"/>
                 <a:cs typeface="Aeonik" pitchFamily="34" charset="-120"/>
               </a:rPr>
-              <a:t>AI integration automatically tracks tier-2 chemical and substrate suppliers to detect factory closures or export blocks before they ripple into final fab allocations.</a:t>
-            </a:r>
-            <a:endParaRPr lang="en-US" sz="1500" dirty="0"/>
+              <a:t>Advanced analytics systems parse unstructured global feeds—including weather logs, border congestion, and raw chemical shortages—to build a multi-tier dependency map, tracking Tier-2/3 volatility and supplier insolvency risks before they disrupt Tier-1 deliveries.</a:t>
+            </a:r>
+            <a:endParaRPr lang="en-US" sz="1300" dirty="0"/>
           </a:p>
         </p:txBody>
       </p:sp>
@@ -10291,24 +10750,63 @@
         </p:nvSpPr>
         <p:spPr>
           <a:xfrm>
-            <a:off x="7863840" y="1554480"/>
-            <a:ext cx="3474720" cy="1737360"/>
-          </a:xfrm>
-          <a:prstGeom prst="rect">
-            <a:avLst/>
-          </a:prstGeom>
-          <a:noFill/>
-          <a:ln/>
-        </p:spPr>
-        <p:txBody>
-          <a:bodyPr wrap="square" rtlCol="0" anchor="ctr"/>
-          <a:lstStyle/>
-          <a:p>
-            <a:pPr indent="0" marL="0">
-              <a:buNone/>
-            </a:pPr>
-            <a:r>
-              <a:rPr lang="en-US" sz="1600" dirty="0">
+            <a:off x="7863840" y="1463040"/>
+            <a:ext cx="3474720" cy="274320"/>
+          </a:xfrm>
+          <a:prstGeom prst="rect">
+            <a:avLst/>
+          </a:prstGeom>
+          <a:noFill/>
+          <a:ln/>
+        </p:spPr>
+        <p:txBody>
+          <a:bodyPr wrap="square" rtlCol="0" anchor="ctr"/>
+          <a:lstStyle/>
+          <a:p>
+            <a:pPr indent="0" marL="0">
+              <a:buNone/>
+            </a:pPr>
+            <a:r>
+              <a:rPr lang="en-US" sz="1200" b="1" dirty="0">
+                <a:solidFill>
+                  <a:srgbClr val="B84A2F"/>
+                </a:solidFill>
+                <a:latin typeface="Aeonik" pitchFamily="34" charset="0"/>
+                <a:ea typeface="Aeonik" pitchFamily="34" charset="-122"/>
+                <a:cs typeface="Aeonik" pitchFamily="34" charset="-120"/>
+              </a:rPr>
+              <a:t>USA: DESIGN IP</a:t>
+            </a:r>
+            <a:endParaRPr lang="en-US" sz="1200" dirty="0"/>
+          </a:p>
+        </p:txBody>
+      </p:sp>
+      <p:sp>
+        <p:nvSpPr>
+          <p:cNvPr id="11" name="Text 8"/>
+          <p:cNvSpPr/>
+          <p:nvPr/>
+        </p:nvSpPr>
+        <p:spPr>
+          <a:xfrm>
+            <a:off x="7863840" y="1783080"/>
+            <a:ext cx="3474720" cy="1600200"/>
+          </a:xfrm>
+          <a:prstGeom prst="rect">
+            <a:avLst/>
+          </a:prstGeom>
+          <a:noFill/>
+          <a:ln/>
+        </p:spPr>
+        <p:txBody>
+          <a:bodyPr wrap="square" rtlCol="0" anchor="ctr"/>
+          <a:lstStyle/>
+          <a:p>
+            <a:pPr indent="0" marL="0">
+              <a:buNone/>
+            </a:pPr>
+            <a:r>
+              <a:rPr lang="en-US" sz="1300" dirty="0">
                 <a:solidFill>
                   <a:srgbClr val="6B6560"/>
                 </a:solidFill>
@@ -10316,22 +10814,27 @@
                 <a:ea typeface="Aeonik" pitchFamily="34" charset="-122"/>
                 <a:cs typeface="Aeonik" pitchFamily="34" charset="-120"/>
               </a:rPr>
-              <a:t>USA: Design IP</a:t>
-            </a:r>
-            <a:endParaRPr lang="en-US" sz="1600" dirty="0"/>
-          </a:p>
-          <a:p>
-            <a:pPr indent="0" marL="0">
-              <a:buNone/>
-            </a:pPr>
-            <a:endParaRPr lang="en-US" sz="1600" dirty="0"/>
-          </a:p>
-          <a:p>
-            <a:pPr indent="0" marL="0">
-              <a:buNone/>
-            </a:pPr>
-            <a:r>
-              <a:rPr lang="en-US" sz="1600" dirty="0">
+              <a:t>Market Leader: U.S. design firms capture the majority of global chip value, controlling </a:t>
+            </a:r>
+            <a:pPr indent="0" marL="0">
+              <a:buNone/>
+            </a:pPr>
+            <a:r>
+              <a:rPr lang="en-US" sz="1300" b="1" dirty="0">
+                <a:solidFill>
+                  <a:srgbClr val="1A1714"/>
+                </a:solidFill>
+                <a:latin typeface="Aeonik" pitchFamily="34" charset="0"/>
+                <a:ea typeface="Aeonik" pitchFamily="34" charset="-122"/>
+                <a:cs typeface="Aeonik" pitchFamily="34" charset="-120"/>
+              </a:rPr>
+              <a:t>80%+ of the Electronic Design Automation (EDA)</a:t>
+            </a:r>
+            <a:pPr indent="0" marL="0">
+              <a:buNone/>
+            </a:pPr>
+            <a:r>
+              <a:rPr lang="en-US" sz="1300" dirty="0">
                 <a:solidFill>
                   <a:srgbClr val="6B6560"/>
                 </a:solidFill>
@@ -10339,15 +10842,15 @@
                 <a:ea typeface="Aeonik" pitchFamily="34" charset="-122"/>
                 <a:cs typeface="Aeonik" pitchFamily="34" charset="-120"/>
               </a:rPr>
-              <a:t>80%+ market share in advanced EDA software tools.</a:t>
-            </a:r>
-            <a:endParaRPr lang="en-US" sz="1600" dirty="0"/>
-          </a:p>
-        </p:txBody>
-      </p:sp>
-      <p:sp>
-        <p:nvSpPr>
-          <p:cNvPr id="11" name="Shape 8"/>
+              <a:t> software market and holding core IP for high-end CPU/GPU microarchitectures.</a:t>
+            </a:r>
+            <a:endParaRPr lang="en-US" sz="1300" dirty="0"/>
+          </a:p>
+        </p:txBody>
+      </p:sp>
+      <p:sp>
+        <p:nvSpPr>
+          <p:cNvPr id="12" name="Shape 9"/>
           <p:cNvSpPr/>
           <p:nvPr/>
         </p:nvSpPr>
@@ -10372,30 +10875,69 @@
       </p:sp>
       <p:sp>
         <p:nvSpPr>
-          <p:cNvPr id="12" name="Text 9"/>
-          <p:cNvSpPr/>
-          <p:nvPr/>
-        </p:nvSpPr>
-        <p:spPr>
-          <a:xfrm>
-            <a:off x="7863840" y="4023360"/>
-            <a:ext cx="3474720" cy="1737360"/>
-          </a:xfrm>
-          <a:prstGeom prst="rect">
-            <a:avLst/>
-          </a:prstGeom>
-          <a:noFill/>
-          <a:ln/>
-        </p:spPr>
-        <p:txBody>
-          <a:bodyPr wrap="square" rtlCol="0" anchor="ctr"/>
-          <a:lstStyle/>
-          <a:p>
-            <a:pPr indent="0" marL="0">
-              <a:buNone/>
-            </a:pPr>
-            <a:r>
-              <a:rPr lang="en-US" sz="1600" dirty="0">
+          <p:cNvPr id="13" name="Text 10"/>
+          <p:cNvSpPr/>
+          <p:nvPr/>
+        </p:nvSpPr>
+        <p:spPr>
+          <a:xfrm>
+            <a:off x="7863840" y="3931920"/>
+            <a:ext cx="3474720" cy="274320"/>
+          </a:xfrm>
+          <a:prstGeom prst="rect">
+            <a:avLst/>
+          </a:prstGeom>
+          <a:noFill/>
+          <a:ln/>
+        </p:spPr>
+        <p:txBody>
+          <a:bodyPr wrap="square" rtlCol="0" anchor="ctr"/>
+          <a:lstStyle/>
+          <a:p>
+            <a:pPr indent="0" marL="0">
+              <a:buNone/>
+            </a:pPr>
+            <a:r>
+              <a:rPr lang="en-US" sz="1200" b="1" dirty="0">
+                <a:solidFill>
+                  <a:srgbClr val="9E7D84"/>
+                </a:solidFill>
+                <a:latin typeface="Aeonik" pitchFamily="34" charset="0"/>
+                <a:ea typeface="Aeonik" pitchFamily="34" charset="-122"/>
+                <a:cs typeface="Aeonik" pitchFamily="34" charset="-120"/>
+              </a:rPr>
+              <a:t>ASML (EU): LITHOGRAPHY</a:t>
+            </a:r>
+            <a:endParaRPr lang="en-US" sz="1200" dirty="0"/>
+          </a:p>
+        </p:txBody>
+      </p:sp>
+      <p:sp>
+        <p:nvSpPr>
+          <p:cNvPr id="14" name="Text 11"/>
+          <p:cNvSpPr/>
+          <p:nvPr/>
+        </p:nvSpPr>
+        <p:spPr>
+          <a:xfrm>
+            <a:off x="7863840" y="4251960"/>
+            <a:ext cx="3474720" cy="1600200"/>
+          </a:xfrm>
+          <a:prstGeom prst="rect">
+            <a:avLst/>
+          </a:prstGeom>
+          <a:noFill/>
+          <a:ln/>
+        </p:spPr>
+        <p:txBody>
+          <a:bodyPr wrap="square" rtlCol="0" anchor="ctr"/>
+          <a:lstStyle/>
+          <a:p>
+            <a:pPr indent="0" marL="0">
+              <a:buNone/>
+            </a:pPr>
+            <a:r>
+              <a:rPr lang="en-US" sz="1300" dirty="0">
                 <a:solidFill>
                   <a:srgbClr val="6B6560"/>
                 </a:solidFill>
@@ -10403,22 +10945,27 @@
                 <a:ea typeface="Aeonik" pitchFamily="34" charset="-122"/>
                 <a:cs typeface="Aeonik" pitchFamily="34" charset="-120"/>
               </a:rPr>
-              <a:t>ASML (EU): Lithography</a:t>
-            </a:r>
-            <a:endParaRPr lang="en-US" sz="1600" dirty="0"/>
-          </a:p>
-          <a:p>
-            <a:pPr indent="0" marL="0">
-              <a:buNone/>
-            </a:pPr>
-            <a:endParaRPr lang="en-US" sz="1600" dirty="0"/>
-          </a:p>
-          <a:p>
-            <a:pPr indent="0" marL="0">
-              <a:buNone/>
-            </a:pPr>
-            <a:r>
-              <a:rPr lang="en-US" sz="1600" dirty="0">
+              <a:t>Critical Enabler: European-based ASML holds a </a:t>
+            </a:r>
+            <a:pPr indent="0" marL="0">
+              <a:buNone/>
+            </a:pPr>
+            <a:r>
+              <a:rPr lang="en-US" sz="1300" b="1" dirty="0">
+                <a:solidFill>
+                  <a:srgbClr val="1A1714"/>
+                </a:solidFill>
+                <a:latin typeface="Aeonik" pitchFamily="34" charset="0"/>
+                <a:ea typeface="Aeonik" pitchFamily="34" charset="-122"/>
+                <a:cs typeface="Aeonik" pitchFamily="34" charset="-120"/>
+              </a:rPr>
+              <a:t>100% EUV (Extreme Ultraviolet) Monopsony</a:t>
+            </a:r>
+            <a:pPr indent="0" marL="0">
+              <a:buNone/>
+            </a:pPr>
+            <a:r>
+              <a:rPr lang="en-US" sz="1300" dirty="0">
                 <a:solidFill>
                   <a:srgbClr val="6B6560"/>
                 </a:solidFill>
@@ -10426,9 +10973,9 @@
                 <a:ea typeface="Aeonik" pitchFamily="34" charset="-122"/>
                 <a:cs typeface="Aeonik" pitchFamily="34" charset="-120"/>
               </a:rPr>
-              <a:t>100% monopsony on EUV printing technology.</a:t>
-            </a:r>
-            <a:endParaRPr lang="en-US" sz="1600" dirty="0"/>
+              <a:t> for high-end printing scanners, making it the sole hardware gatekeeper for sub-7nm node fabrication.</a:t>
+            </a:r>
+            <a:endParaRPr lang="en-US" sz="1300" dirty="0"/>
           </a:p>
         </p:txBody>
       </p:sp>
@@ -10806,7 +11353,7 @@
                 <a:ea typeface="PP Mondwest" pitchFamily="34" charset="-122"/>
                 <a:cs typeface="PP Mondwest" pitchFamily="34" charset="-120"/>
               </a:rPr>
-              <a:t>Back-End: Advanced Packaging Chokepoint</a:t>
+              <a:t>Back-End: CoWoS &amp; HBM Integration</a:t>
             </a:r>
             <a:endParaRPr lang="en-US" sz="2000" dirty="0"/>
           </a:p>
@@ -10837,7 +11384,7 @@
               <a:buNone/>
             </a:pPr>
             <a:r>
-              <a:rPr lang="en-US" sz="1800" dirty="0">
+              <a:rPr lang="en-US" sz="1600" dirty="0">
                 <a:solidFill>
                   <a:srgbClr val="6B6560"/>
                 </a:solidFill>
@@ -10845,9 +11392,9 @@
                 <a:ea typeface="Aeonik" pitchFamily="34" charset="-122"/>
                 <a:cs typeface="Aeonik" pitchFamily="34" charset="-120"/>
               </a:rPr>
-              <a:t>Integrating multiple logic dies and High Bandwidth Memory (HBM) via CoWoS interposers is more constrained than wafer printing.</a:t>
-            </a:r>
-            <a:endParaRPr lang="en-US" sz="1800" dirty="0"/>
+              <a:t>Stacking logic dies and High Bandwidth Memory (HBM) via Chip-on-Wafer-on-Substrate (CoWoS) formats has surpassed wafer printing as the primary supply chain bottleneck.</a:t>
+            </a:r>
+            <a:endParaRPr lang="en-US" sz="1600" dirty="0"/>
           </a:p>
         </p:txBody>
       </p:sp>
@@ -10884,24 +11431,38 @@
         </p:nvSpPr>
         <p:spPr>
           <a:xfrm>
-            <a:off x="731520" y="5303520"/>
-            <a:ext cx="10607040" cy="640080"/>
-          </a:xfrm>
-          <a:prstGeom prst="rect">
-            <a:avLst/>
-          </a:prstGeom>
-          <a:noFill/>
-          <a:ln/>
-        </p:spPr>
-        <p:txBody>
-          <a:bodyPr wrap="square" rtlCol="0" anchor="ctr"/>
-          <a:lstStyle/>
-          <a:p>
-            <a:pPr indent="0" marL="0">
-              <a:buNone/>
-            </a:pPr>
-            <a:r>
-              <a:rPr lang="en-US" sz="1500" dirty="0">
+            <a:off x="731520" y="5257800"/>
+            <a:ext cx="10607040" cy="731520"/>
+          </a:xfrm>
+          <a:prstGeom prst="rect">
+            <a:avLst/>
+          </a:prstGeom>
+          <a:noFill/>
+          <a:ln/>
+        </p:spPr>
+        <p:txBody>
+          <a:bodyPr wrap="square" rtlCol="0" anchor="ctr"/>
+          <a:lstStyle/>
+          <a:p>
+            <a:pPr indent="0" marL="0">
+              <a:buNone/>
+            </a:pPr>
+            <a:r>
+              <a:rPr lang="en-US" sz="1300" b="1" dirty="0">
+                <a:solidFill>
+                  <a:srgbClr val="1A1714"/>
+                </a:solidFill>
+                <a:latin typeface="Aeonik" pitchFamily="34" charset="0"/>
+                <a:ea typeface="Aeonik" pitchFamily="34" charset="-122"/>
+                <a:cs typeface="Aeonik" pitchFamily="34" charset="-120"/>
+              </a:rPr>
+              <a:t>Logistics bottleneck: </a:t>
+            </a:r>
+            <a:pPr indent="0" marL="0">
+              <a:buNone/>
+            </a:pPr>
+            <a:r>
+              <a:rPr lang="en-US" sz="1300" dirty="0">
                 <a:solidFill>
                   <a:srgbClr val="6B6560"/>
                 </a:solidFill>
@@ -10909,9 +11470,9 @@
                 <a:ea typeface="Aeonik" pitchFamily="34" charset="-122"/>
                 <a:cs typeface="Aeonik" pitchFamily="34" charset="-120"/>
               </a:rPr>
-              <a:t>Logistics bottleneck: Reaching target AI yields depends heavily on advanced back-end capacity, not just front-end print nodes.</a:t>
-            </a:r>
-            <a:endParaRPr lang="en-US" sz="1500" dirty="0"/>
+              <a:t>Yield limitations are no longer dominated by front-end node lithography, but by the capacity limits of advanced back-end CoWoS and 3D stacking processes.</a:t>
+            </a:r>
+            <a:endParaRPr lang="en-US" sz="1300" dirty="0"/>
           </a:p>
         </p:txBody>
       </p:sp>
@@ -11251,8 +11812,8 @@
         </p:nvSpPr>
         <p:spPr>
           <a:xfrm>
-            <a:off x="7680960" y="2011680"/>
-            <a:ext cx="3840480" cy="365760"/>
+            <a:off x="7863840" y="1645920"/>
+            <a:ext cx="3474720" cy="548640"/>
           </a:xfrm>
           <a:prstGeom prst="rect">
             <a:avLst/>
@@ -11268,7 +11829,7 @@
               <a:buNone/>
             </a:pPr>
             <a:r>
-              <a:rPr lang="en-US" sz="1200" b="1" dirty="0">
+              <a:rPr lang="en-US" sz="1400" b="1" dirty="0">
                 <a:solidFill>
                   <a:srgbClr val="B84A2F"/>
                 </a:solidFill>
@@ -11276,9 +11837,9 @@
                 <a:ea typeface="Aeonik" pitchFamily="34" charset="-122"/>
                 <a:cs typeface="Aeonik" pitchFamily="34" charset="-120"/>
               </a:rPr>
-              <a:t>CRITICAL CHOKEPOINT</a:t>
-            </a:r>
-            <a:endParaRPr lang="en-US" sz="1200" dirty="0"/>
+              <a:t>GALLIUM &amp; GERMANIUM EXPORT RESTRICTIONS</a:t>
+            </a:r>
+            <a:endParaRPr lang="en-US" sz="1400" dirty="0"/>
           </a:p>
         </p:txBody>
       </p:sp>
@@ -11290,80 +11851,80 @@
         </p:nvSpPr>
         <p:spPr>
           <a:xfrm>
-            <a:off x="7680960" y="2560320"/>
-            <a:ext cx="3840480" cy="1097280"/>
-          </a:xfrm>
-          <a:prstGeom prst="rect">
-            <a:avLst/>
-          </a:prstGeom>
-          <a:noFill/>
-          <a:ln/>
-        </p:spPr>
-        <p:txBody>
-          <a:bodyPr wrap="square" rtlCol="0" anchor="ctr"/>
-          <a:lstStyle/>
-          <a:p>
-            <a:pPr algn="ctr" indent="0" marL="0">
-              <a:buNone/>
-            </a:pPr>
-            <a:r>
-              <a:rPr lang="en-US" sz="3600" b="1" dirty="0">
+            <a:off x="7863840" y="2377440"/>
+            <a:ext cx="3474720" cy="3291840"/>
+          </a:xfrm>
+          <a:prstGeom prst="rect">
+            <a:avLst/>
+          </a:prstGeom>
+          <a:noFill/>
+          <a:ln/>
+        </p:spPr>
+        <p:txBody>
+          <a:bodyPr wrap="square" rtlCol="0" anchor="ctr"/>
+          <a:lstStyle/>
+          <a:p>
+            <a:pPr algn="l" indent="0" marL="0">
+              <a:buNone/>
+            </a:pPr>
+            <a:r>
+              <a:rPr lang="en-US" sz="1300" dirty="0">
+                <a:solidFill>
+                  <a:srgbClr val="6B6560"/>
+                </a:solidFill>
+                <a:latin typeface="Aeonik" pitchFamily="34" charset="0"/>
+                <a:ea typeface="Aeonik" pitchFamily="34" charset="-122"/>
+                <a:cs typeface="Aeonik" pitchFamily="34" charset="-120"/>
+              </a:rPr>
+              <a:t>China controls </a:t>
+            </a:r>
+            <a:pPr algn="l" indent="0" marL="0">
+              <a:buNone/>
+            </a:pPr>
+            <a:r>
+              <a:rPr lang="en-US" sz="1300" b="1" dirty="0">
                 <a:solidFill>
                   <a:srgbClr val="1A1714"/>
                 </a:solidFill>
-                <a:latin typeface="PP Mondwest" pitchFamily="34" charset="0"/>
-                <a:ea typeface="PP Mondwest" pitchFamily="34" charset="-122"/>
-                <a:cs typeface="PP Mondwest" pitchFamily="34" charset="-120"/>
-              </a:rPr>
-              <a:t>Gallium &amp;</a:t>
-            </a:r>
-            <a:endParaRPr lang="en-US" sz="3600" dirty="0"/>
-          </a:p>
-          <a:p>
-            <a:pPr algn="ctr" indent="0" marL="0">
-              <a:buNone/>
-            </a:pPr>
-            <a:r>
-              <a:rPr lang="en-US" sz="3600" b="1" dirty="0">
+                <a:latin typeface="Aeonik" pitchFamily="34" charset="0"/>
+                <a:ea typeface="Aeonik" pitchFamily="34" charset="-122"/>
+                <a:cs typeface="Aeonik" pitchFamily="34" charset="-120"/>
+              </a:rPr>
+              <a:t>90%+ of Gallium</a:t>
+            </a:r>
+            <a:pPr algn="l" indent="0" marL="0">
+              <a:buNone/>
+            </a:pPr>
+            <a:r>
+              <a:rPr lang="en-US" sz="1300" dirty="0">
+                <a:solidFill>
+                  <a:srgbClr val="6B6560"/>
+                </a:solidFill>
+                <a:latin typeface="Aeonik" pitchFamily="34" charset="0"/>
+                <a:ea typeface="Aeonik" pitchFamily="34" charset="-122"/>
+                <a:cs typeface="Aeonik" pitchFamily="34" charset="-120"/>
+              </a:rPr>
+              <a:t> and </a:t>
+            </a:r>
+            <a:pPr algn="l" indent="0" marL="0">
+              <a:buNone/>
+            </a:pPr>
+            <a:r>
+              <a:rPr lang="en-US" sz="1300" b="1" dirty="0">
                 <a:solidFill>
                   <a:srgbClr val="1A1714"/>
                 </a:solidFill>
-                <a:latin typeface="PP Mondwest" pitchFamily="34" charset="0"/>
-                <a:ea typeface="PP Mondwest" pitchFamily="34" charset="-122"/>
-                <a:cs typeface="PP Mondwest" pitchFamily="34" charset="-120"/>
-              </a:rPr>
-              <a:t>Germanium</a:t>
-            </a:r>
-            <a:endParaRPr lang="en-US" sz="3600" dirty="0"/>
-          </a:p>
-        </p:txBody>
-      </p:sp>
-      <p:sp>
-        <p:nvSpPr>
-          <p:cNvPr id="12" name="Text 9"/>
-          <p:cNvSpPr/>
-          <p:nvPr/>
-        </p:nvSpPr>
-        <p:spPr>
-          <a:xfrm>
-            <a:off x="7680960" y="3840480"/>
-            <a:ext cx="3840480" cy="731520"/>
-          </a:xfrm>
-          <a:prstGeom prst="rect">
-            <a:avLst/>
-          </a:prstGeom>
-          <a:noFill/>
-          <a:ln/>
-        </p:spPr>
-        <p:txBody>
-          <a:bodyPr wrap="square" rtlCol="0" anchor="ctr"/>
-          <a:lstStyle/>
-          <a:p>
-            <a:pPr algn="ctr" indent="0" marL="0">
-              <a:buNone/>
-            </a:pPr>
-            <a:r>
-              <a:rPr lang="en-US" sz="1500" dirty="0">
+                <a:latin typeface="Aeonik" pitchFamily="34" charset="0"/>
+                <a:ea typeface="Aeonik" pitchFamily="34" charset="-122"/>
+                <a:cs typeface="Aeonik" pitchFamily="34" charset="-120"/>
+              </a:rPr>
+              <a:t>60%+ of Germanium</a:t>
+            </a:r>
+            <a:pPr algn="l" indent="0" marL="0">
+              <a:buNone/>
+            </a:pPr>
+            <a:r>
+              <a:rPr lang="en-US" sz="1300" dirty="0">
                 <a:solidFill>
                   <a:srgbClr val="6B6560"/>
                 </a:solidFill>
@@ -11371,9 +11932,38 @@
                 <a:ea typeface="Aeonik" pitchFamily="34" charset="-122"/>
                 <a:cs typeface="Aeonik" pitchFamily="34" charset="-120"/>
               </a:rPr>
-              <a:t>Strict raw material export control levers</a:t>
-            </a:r>
-            <a:endParaRPr lang="en-US" sz="1500" dirty="0"/>
+              <a:t> sourcing. Recent export restrictions require explicit licenses, causing price volatility and sourcing delays for next-generation power electronics and optical systems.
+</a:t>
+            </a:r>
+            <a:pPr algn="l" indent="0" marL="0">
+              <a:buNone/>
+            </a:pPr>
+            <a:r>
+              <a:rPr lang="en-US" sz="1100" b="1" dirty="0">
+                <a:solidFill>
+                  <a:srgbClr val="1A1714"/>
+                </a:solidFill>
+                <a:latin typeface="Aeonik" pitchFamily="34" charset="0"/>
+                <a:ea typeface="Aeonik" pitchFamily="34" charset="-122"/>
+                <a:cs typeface="Aeonik" pitchFamily="34" charset="-120"/>
+              </a:rPr>
+              <a:t>Strategic Risk: </a:t>
+            </a:r>
+            <a:pPr algn="l" indent="0" marL="0">
+              <a:buNone/>
+            </a:pPr>
+            <a:r>
+              <a:rPr lang="en-US" sz="1100" i="1" dirty="0">
+                <a:solidFill>
+                  <a:srgbClr val="6B6560"/>
+                </a:solidFill>
+                <a:latin typeface="Aeonik" pitchFamily="34" charset="0"/>
+                <a:ea typeface="Aeonik" pitchFamily="34" charset="-122"/>
+                <a:cs typeface="Aeonik" pitchFamily="34" charset="-120"/>
+              </a:rPr>
+              <a:t>Material bottlenecks can disrupt entire optoelectronic supply chains.</a:t>
+            </a:r>
+            <a:endParaRPr lang="en-US" sz="1300" dirty="0"/>
           </a:p>
         </p:txBody>
       </p:sp>

</xml_diff>

<commit_message>
feat: update spoken presentation scripts across slides 1-20 in PPTX, PDF and web presenter
</commit_message>
<xml_diff>
--- a/output/semiconductor-ecosystem-2026.pptx
+++ b/output/semiconductor-ecosystem-2026.pptx
@@ -519,7 +519,7 @@
           <a:p>
             <a:r>
               <a:rPr lang="en-US" dirty="0"/>
-              <a:t>Hello everyone. I’m Phyoe Sat Paing, and today we are conducting a deep-dive into the 'nerve system' of our modern civilization: the 2026 Semiconductor Ecosystem. Over the next 20 minutes, we are going to move beyond the headlines of 'chip shortages' and look at the actual structural mechanics of how silicon is procured, how it moves across the globe, and finally, how it is fundamentally rewriting the DNA of every major industry. Whether you are an investor, a procurement lead, or a strategic planner, this briefing is designed to give you the high-ground view of the $1.3 trillion silicon economy.</a:t>
+              <a:t>Good afternoon, Professor. My name is Phyoe Sat Paing, and today I am presenting my consolidated master briefing on the 2026 Semiconductor Ecosystem. This presentation represents an intensive, multi-layered investigation into the critical macroarchitectures of the global chip industry. I have structured this briefing directly around your three core assignment pillars: Sourcing and Procurement, Global Supply Chain Mechanics, and Downstream End-User Industries. Over the next twenty minutes, I will demonstrate how semiconductors have transitioned from basic electronic components into the ultimate instruments of global geopolitical leverage, economic insulation, and corporate competitive advantage. Let us begin with Part One, focusing on the radical evolution of microelectronic procurement.</a:t>
             </a:r>
             <a:endParaRPr lang="en-US" dirty="0"/>
           </a:p>
@@ -607,7 +607,7 @@
           <a:p>
             <a:r>
               <a:rPr lang="en-US" dirty="0"/>
-              <a:t>The response? Circular and Autonomous Supply Chains. We are using AI to 'self-heal' the supply chain—automatically re-routing orders when a port closes or a factory goes down. And we are starting to recycle. We are mining the 'urban mine'—recovering rare earth elements from old electronics to reduce our dependency on volatile mining regions.</a:t>
+              <a:t>To survive this fragmented environment, supply chain architectures are evolving from static, linear models into circular, autonomous networks. First, advanced manufacturers are utilizing deep digital mapping tools to achieve multi-tier visibility. They are tracing their supply structures past their direct partners, all the way down to Tier-4 and Tier-5 chemical facilities that supply raw acids and substrates. Second, the industry is investing heavily in Circular Mineral Reclamation. Rather than relying solely on volatile geopolitical mining nodes, firms are actively recycling electronic waste to reclaim high-purity copper, gold, and recycled silicon substrates. This circular economy integration acts as a critical strategic buffer, shielding foundry operations from raw material shocks while aligning with modern environmental sustainability mandates.</a:t>
             </a:r>
             <a:endParaRPr lang="en-US" dirty="0"/>
           </a:p>
@@ -695,7 +695,7 @@
           <a:p>
             <a:r>
               <a:rPr lang="en-US" dirty="0"/>
-              <a:t>So, where does all this silicon end up? Everywhere. We have reached 'Total Silicon Dependency.' Every industry is now a 'tech industry' because every industry is built on chips.</a:t>
+              <a:t>In 2026, we occupy a civilization of total silicon dependency. Microchips have transcended traditional computing electronics; they have become the fundamental nerve system of the broader global economy. No modern industry can function without a secure pipeline of semiconductors. Today, semiconductors control the storage, lightning-fast routing, and real-time processing of every single piece of global data. Because of this, industrial analysts now track a metric called the Silicon Intensity Index. This measures the total percentage value of silicon content embedded inside a physical product. Whether an enterprise manufactures smart municipal utility grids, high-precision medical machinery, or neural processors, their ability to scale and compete is directly bounded by the processing efficiency of their integrated silicon layers.</a:t>
             </a:r>
             <a:endParaRPr lang="en-US" dirty="0"/>
           </a:p>
@@ -783,7 +783,7 @@
           <a:p>
             <a:r>
               <a:rPr lang="en-US" dirty="0"/>
-              <a:t>The demand landscape is shifting. While PCs and smartphones are maturing, AI Infrastructure and Automotive are exploding. AI and Data Centers now drive nearly half of the industry’s total value. We are in a 'multi-speed' market where the high-end is racing ahead while the low-end stabilizes.</a:t>
+              <a:t>The downstream demand landscape in 2026 is characterized by a stark structural divergence. We are operating in a multi-speed market where traditional core sectors are maturing while new infrastructure segments explode. As broken down on this summary chart, artificial intelligence data centers have become the supreme economic engine of the industry, now capturing nearly 50% of total semiconductor growth and revenue value. Conversely, the automotive sector has emerged as the fastest-growing volume segment. Electric vehicles and advanced driver-assistance systems require massive volumes of both legacy control nodes and silicon carbide power chips. Meanwhile, traditional volume drivers like smartphones and personal computers are facing volume saturation. This saturation is forcing consumer tech hardware developers to consolidate and pivot toward integrating specialized edge accelerators to induce new consumer replacement cycles.</a:t>
             </a:r>
             <a:endParaRPr lang="en-US" dirty="0"/>
           </a:p>
@@ -871,7 +871,7 @@
           <a:p>
             <a:r>
               <a:rPr lang="en-US" dirty="0"/>
-              <a:t>Look at the Data Center. It’s no longer just a place to store files; it’s an 'Intelligence Engine.' We are spending $500 billion a year on AI accelerators. This is the segment that is pushing us to 2nm and beyond. It is the 'Value King' of the semiconductor world.</a:t>
+              <a:t>Let's look closer at the hyper-scale data center market, which has fundamentally evolved from passive data storage hubs into active machine-intelligence engines. The global market for dedicated AI accelerators—encompassing specialized GPUs, TPUs, and neural computing nodes—is scaling toward an annual value of 500 billion dollars. This single sector is the primary consumer of the world's most advanced sub-3nm wafer print architectures globally. The sheer computational density required to train large language models has triggered an unprecedented demand squeeze across adjacent silicon technologies. AI servers don't just require fast processors; they demand ultra-dense configurations of High Bandwidth Memory, which has faced severe market inflation, alongside customized high-speed routing interconnect silicon to manage data transit between massive server clusters.</a:t>
             </a:r>
             <a:endParaRPr lang="en-US" dirty="0"/>
           </a:p>
@@ -959,7 +959,7 @@
           <a:p>
             <a:r>
               <a:rPr lang="en-US" dirty="0"/>
-              <a:t>Then there is the car—the 'Smartphone on Wheels.' An EV in 2026 has over $1,000 worth of chips in it. We are talking about Silicon Carbide for power efficiency and massive SoCs for autonomous driving. The car has become a high-performance computer that just happens to have wheels.</a:t>
+              <a:t>Turning to the automotive sector, vehicles have effectively transformed into high-performance computers on wheels. The compounding transitions toward vehicle electrification and advanced driver-assistance systems, or ADAS, have doubled the total semiconductor bill-of-materials, now exceeding 1,000 dollars in silicon content per vehicle unit. This growth is driven by two main pillars. First, power electronics: electric vehicles rely heavily on Silicon Carbide, or SiC, power switches in high-voltage battery platforms to drive charging efficiency. Second, safety and autonomy. Level 2 and Level 3 autonomous vehicles require massive on-board computational units to handle real-time sensor fusion. A single vehicle now requires a comprehensive sourcing strategy for a massive array of chips, including radar components, ultrasonic modules, LiDAR systems, and high-resolution CMOS camera chipsets.</a:t>
             </a:r>
             <a:endParaRPr lang="en-US" dirty="0"/>
           </a:p>
@@ -1047,7 +1047,7 @@
           <a:p>
             <a:r>
               <a:rPr lang="en-US" dirty="0"/>
-              <a:t>In the Industrial and Healthcare sectors, we are seeing the rise of 'Edge AI.' We aren't sending data to the cloud anymore; we are processing it right there on the factory floor or inside a medical implant. This requires ultra-reliable, long-lifecycle silicon that can survive for fifteen years in harsh environments.</a:t>
+              <a:t>Beyond heavy computing, we see the rise of 'Intelligence at the Edge' across industrial operations and healthcare systems. In the industrial IoT and Industry 4.0 landscape, factory floor nodes are no longer sending raw data back to centralized clouds. Instead, they use low-power edge chips to execute real-time local algorithms for automated machine vision controls and predictive maintenance. In the healthcare sector, specialized semiconductor sourcing has become a cornerstone of personalized medicine. Microchips are enabling highly reliable, long-lifecycle deployments including smart wearable diagnostics, continuous blood-glucose monitors, active health implants, and high-resolution personalized diagnostic imaging equipment. For both industrial and medical applications, silicon reliability and extended availability are prioritized over absolute nanoscale shrinking.</a:t>
             </a:r>
             <a:endParaRPr lang="en-US" dirty="0"/>
           </a:p>
@@ -1135,7 +1135,7 @@
           <a:p>
             <a:r>
               <a:rPr lang="en-US" dirty="0"/>
-              <a:t>And looking at the horizon—Quantum, 6G, and Neuromorphic computing. These aren't science fiction anymore. We are already building the 2030 roadmap. We are designing chips that work like the human brain and networks that make 5G look like dial-up. The innovation cycle is actually accelerating.</a:t>
+              <a:t>As traditional client consumer electronics like laptops and standard mobile handsets reach structural maturity, hardware developers are aggressively pushing architectural boundaries to kickstart new upgrade cycles. In 2026, dedicated On-Device NPU, or Neural Processing Unit, logic has become standard hardware in client electronics. This allows local generative AI execution directly on your handset without relying on cloud servers. Looking further down the horizon toward the 2030 roadmap, the industry is investing heavily in next-generation computing frontiers. This includes intensive R&amp;D into cryogenic quantum structures, sub-terahertz 6G communications hardware blocks, and neuromorphic computing architectures that mimic the organic efficiency of the human brain to bypass traditional physical limits.</a:t>
             </a:r>
             <a:endParaRPr lang="en-US" dirty="0"/>
           </a:p>
@@ -1223,9 +1223,7 @@
           <a:p>
             <a:r>
               <a:rPr lang="en-US" dirty="0"/>
-              <a:t>To conclude, the 2026 ecosystem tells us one thing: Silicon Intensity is the new gold standard. The winners of the next decade won't just be the ones with the best software; they will be the ones who master the procurement, the supply chain, and the application of these chips.
-Before we go, look at this infographic. These are the five materials that keep the lights on. From Gallium in your 5G phone to Neon in the lasers that print the chips, these are the true foundations. Most of these are concentrated in a few regions, which is why the 'Silicon Journey' is as much about geology as it is about geometry.
-The 'Chip Wars' are far from over. In fact, they are just beginning. Mastery of this ecosystem is mastery of the future. Thank you for your time.</a:t>
+              <a:t>In conclusion, our deep-dive analysis of the 2026 semiconductor ecosystem proves that modern society has reached an inflection point of total silicon dependency. The path toward a multi-trillion-dollar global semiconductor industry is practically a certainty as microchips integrate permanently into every facet of global commerce. To summarize our key takeaways across our three assignments: In procurement, corporations must accept that pure JIT is dead; a strategic hybrid framework that treats resilience as the ultimate operational mandate is the new standard. In the global supply chain, we must recognize that back-end advanced packaging and material chokepoints are the new strategic risks. And finally, across downstream industries, while artificial intelligence remains the undisputed king of high-margin value, the automotive sector has solidified its position as the king of volume scaling. Ultimately, mastery of the semiconductor ecosystem is mastery of global industrial strategy. Thank you for your time, and I am now open to your questions and feedback.</a:t>
             </a:r>
             <a:endParaRPr lang="en-US" dirty="0"/>
           </a:p>
@@ -1313,7 +1311,7 @@
           <a:p>
             <a:r>
               <a:rPr lang="en-US" dirty="0"/>
-              <a:t>Thank you everyone for your time. I would now like to open the floor to any questions you may have.</a:t>
+              <a:t>Thank you everyone for your time. I would now like to open the floor to any questions and feedback you may have.</a:t>
             </a:r>
             <a:endParaRPr lang="en-US" dirty="0"/>
           </a:p>
@@ -1401,7 +1399,7 @@
           <a:p>
             <a:r>
               <a:rPr lang="en-US" dirty="0"/>
-              <a:t>We start with the 'Procurement Paradox.' In 2026, we are seeing record-breaking revenue, yet the supply chain has never felt more fragile. Why? Because the 'Just-in-Time' model we spent thirty years perfecting was built for a world of stability—not the world of 'Chip Wars' and AI super-cycles we live in today.</a:t>
+              <a:t>When analyzing semiconductor procurement in 2026, we encounter an operational paradox. On one hand, the market cap is projecting toward a staggering 1.3 trillion dollar valuation, fueled by an insatiable global demand for artificial intelligence accelerators and electric vehicle power logic. Yet, beneath this massive valuation lies extreme systemic fragility. Leading-edge fabs are running at near maximum capacity utilization rates. This means even a minor logistics bottleneck, a localized power grid failure, or a trace material delivery delay can trigger massive downstream factory shutdowns. For advanced logic, availability rests entirely on sub-3nm allocations. Consequently, modern procurement functions have had to pivot away from transactional, short-term purchasing toward long-term capacity reservation models. Securing advanced logic is no longer a matter of price haggling; it is a matter of corporate survival.</a:t>
             </a:r>
             <a:endParaRPr lang="en-US" dirty="0"/>
           </a:p>
@@ -1489,7 +1487,7 @@
           <a:p>
             <a:r>
               <a:rPr lang="en-US" dirty="0"/>
-              <a:t>To survive, elite firms have pivoted to a Strategic Hybrid Model. We aren't just stockpiling everything—that’s expensive and inefficient. Instead, we are using 'Just-in-Case' logic for the high-value nodes: the 3nm processors and the High Bandwidth Memory that power AI. For everything else, we keep it lean. It’s about being surgical with your inventory.</a:t>
+              <a:t>To understand where we are today, we must look at how procurement philosophies have fundamentally shifted. For decades, the global manufacturing sector relied on pure Just-in-Time, or JIT, procurement. JIT was optimized purely for cost efficiency, keeping warehouse inventories near zero to eliminate capital lock-up. However, the semiconductor shortages of recent years exposed a fatal flaw: JIT optimizes for stable efficiency, not operational continuity. Today, pure JIT is obsolete for mission-critical components. The new standard is a Strategic Hybrid Model. As visualized on this slide, we split procurement into two distinct paths. For commoditized, legacy passive components where suppliers are abundant, we still utilize lean JIT dynamics to minimize costs. But for critical, sole-sourced nodes like High Bandwidth Memory or custom GPUs, organizations now maintain 3 to 6 months of strategic buffer stocks as an insurance policy.</a:t>
             </a:r>
             <a:endParaRPr lang="en-US" dirty="0"/>
           </a:p>
@@ -1577,7 +1575,7 @@
           <a:p>
             <a:r>
               <a:rPr lang="en-US" dirty="0"/>
-              <a:t>But you can't be surgical if you're blind. The biggest challenge in 2026 is Data Opacity. Most firms don't know who their Tier-3 or Tier-4 suppliers are. We are solving this through Category Management—segmenting our sourcing by technology node. We treat a 28nm legacy microcontroller for a car window very differently than a 2nm AI accelerator for a data center.</a:t>
+              <a:t>The two primary enemies of a modern procurement executive are data opacity across the multi-tier supplier network and a reactive, 'firefighting' approach to risk mitigation. To solve this, advanced category management requires a sharp segregation of sourcing strategies based on technology nodes. On the left hand of our framework, we have Leading-Edge Nodes, which refers to sub-7nanometer fabrications. Sourcing here requires deep R&amp;D alliances, engineering collaboration, and heavy upfront capital capacity reservations. You are dealing with virtual monopolies like TSMC. On the right side, we have Legacy Nodes—typically 28-nanometer and above. The challenge here isn't technological complexity; it's lifecycle tracking and obsolescence. For legacy chips, procurement must emphasize continuous multi-sourcing and broad distributor network qualification to ensure a single discontinued component doesn't break an entire production line.</a:t>
             </a:r>
             <a:endParaRPr lang="en-US" dirty="0"/>
           </a:p>
@@ -1665,7 +1663,7 @@
           <a:p>
             <a:r>
               <a:rPr lang="en-US" dirty="0"/>
-              <a:t>Finally, look at the digitalization of the 'Buy' side. We are now using Business Intelligence Cockpits that use AI to scan geopolitical signals and weather patterns to predict shortages six months out. We are also seeing a rise in 'Friend-Shoring' and Long-Term Agreements. In 2026, a handshake isn't enough; you need 'take-or-pay' contracts and reservation fees to ensure you aren't left behind in the next allocation cycle.</a:t>
+              <a:t>Building structural resilience into procurement requires a heavy investment in digitalization. Leading enterprises have deployed AI-driven 'Business Intelligence Cockpits'. These systems don't just track your direct tier-1 suppliers; they use predictive algorithms to map deep into your tier-2 and tier-3 chemical and substrate providers. If a specialized quartz mine or a neon purification plant faces an export block or an environmental closure, the AI flags it 6 to 12 months before it manifests as a shortage at the fab level. This predictive window gives companies the time needed to negotiate complex Long-Term Agreements, pay upfront reservation fees, and commit to 'take-or-pay' clauses to secure their wafer allocations. Furthermore, we are seeing a massive trend toward 'Friend-Shoring,' where sourcing paths are deliberately re-routed away from geopolitically unstable regions and into allied economic nodes to insulate operations from trade wars.</a:t>
             </a:r>
             <a:endParaRPr lang="en-US" dirty="0"/>
           </a:p>
@@ -1753,7 +1751,7 @@
           <a:p>
             <a:r>
               <a:rPr lang="en-US" dirty="0"/>
-              <a:t>Now, let's look at the 'Silicon Journey.' A single chip might cross 70 borders before it ever reaches a consumer. This is the most complex logistical web ever built. It’s a masterpiece of efficiency, but it’s also a 'Chokepoint Architecture.'</a:t>
+              <a:t>The semiconductor supply chain is widely recognized as the most complex and geographically dispersed value chain in human history. As illustrated on the geographical flow map on this slide, a single integrated circuit can cross international borders over 70 times before it is finally soldered into an end-user device. This creates an extreme, hyper-specialized international division of labor. The United States serves as the anchor for design intellectual property and Electronic Design Automation software. Europe acts as the provider of advanced lithography equipment. Japan dominates the supply of ultra-pure chemical materials, while Taiwan handles the actual front-end fabrication. Finally, Southeast Asian nations like Malaysia manage the back-end assembly, testing, and packaging. This extreme dependency means that disrupting even a single region impacts the entire global electronics supply pipeline instantly.</a:t>
             </a:r>
             <a:endParaRPr lang="en-US" dirty="0"/>
           </a:p>
@@ -1841,7 +1839,7 @@
           <a:p>
             <a:r>
               <a:rPr lang="en-US" dirty="0"/>
-              <a:t>The value is incredibly concentrated. The U.S. owns the design; the Netherlands owns the lithography equipment; and East Asia—specifically Taiwan and South Korea—owns the fabrication. TSMC isn't just a company; it is a systemic pillar of the global economy. If that pillar shakes, the whole world feels it.</a:t>
+              <a:t>Let's zoom into the extreme market concentrations within this Global Value Chain architecture. Value creation is highly localized into specific structural monopolies. In the United States, companies hold an 80% plus market share in advanced Electronic Design Automation software. Without software tools from firms like NVIDIA, Qualcomm, or Apple, designing a modern microchip is physically impossible. Moving to Europe, we see a near monopoly held by ASML in the Netherlands regarding Extreme Ultraviolet tools required to etch sub-7nm circuit nodes. Every single leading-edge chip on Earth requires an ASML machine. This means front-end wafer fabrication, dominated by TSMC in Taiwan and Samsung in South Korea, is entirely dependent on Western equipment and design blueprints to feed their production bases.</a:t>
             </a:r>
             <a:endParaRPr lang="en-US" dirty="0"/>
           </a:p>
@@ -1929,7 +1927,7 @@
           <a:p>
             <a:r>
               <a:rPr lang="en-US" dirty="0"/>
-              <a:t>The new bottleneck in 2026 isn't just the fab; it's the 'Back-End.' We’ve reached the limits of traditional chip design, so we are now 'stacking' chips using advanced packaging like CoWoS. This is where the AI war is being fought. If you can't get capacity in an advanced packaging facility, it doesn't matter how many wafers you can print.</a:t>
+              <a:t>For many years, the primary focus of semiconductor innovation was front-end node scaling—the relentless race to shrink transistors down to the 2-nanometer and 1.4-nanometer thresholds. While front-end fabrication lines still require monumental capital investments, a structural shift has occurred in 2026. The primary growth bottleneck for the artificial intelligence industry has moved from the front-end to the back-end. Advanced Back-End Packaging, specifically Chip-on-Wafer-on-Substrate or CoWoS, along with 3D stacking, is the new industry chokepoint. To create a modern AI accelerator, you must seamlessly integrate multiple logic dies with surrounding High Bandwidth Memory stacks onto a specialized silicon interposer. Currently, global back-end capacity is severely constrained. Reaching target production yields depends heavily on advanced back-end capacity, not just front-end printing nodes.</a:t>
             </a:r>
             <a:endParaRPr lang="en-US" dirty="0"/>
           </a:p>
@@ -2017,7 +2015,7 @@
           <a:p>
             <a:r>
               <a:rPr lang="en-US" dirty="0"/>
-              <a:t>And we cannot ignore the 'Chip Wars.' Geopolitics is now a primary architect of the supply chain. Between the U.S. CHIPS Act and China’s massive 'In-Sourcing' push, we are moving toward a multi-polar silicon world. Critical materials like Gallium and Germanium are now being used as strategic levers in a global game of chess.</a:t>
+              <a:t>This hyper-concentration has turned the semiconductor supply chain into a prime geopolitical battleground, causing severe fragmentation. We have moved away from a unified global market into a highly regionalized, multi-polar silicon world. Governments are treating chips as assets of national sovereignty. For instance, the United States has deployed the 52 billion dollar CHIPS Act, providing massive financial subsidies to build domestic advanced logic fabs to balance the heavy East Asian concentration. Europe and China are engaged in similar multi-billion dollar state-supported reshoring initiatives. In retaliation, we see material chokepoints being leveraged as economic weapons. Strict export controls have been placed on critical trace materials like Gallium and Germanium. These elements are vital for power electronics and radar systems, and their restriction forces a global scramble for alternative supply loops.</a:t>
             </a:r>
             <a:endParaRPr lang="en-US" dirty="0"/>
           </a:p>

</xml_diff>